<commit_message>
Add Mississauga on-time service data (incl./excl. partner carriers)
Service tab and deck now show the Adj On Time dashboard: September
93.7% including partner carriers / 96.7% excluding, 7-day avg 94.35%,
monthly trend Jan-Sep 2026 vs the 90% target, and the calculated
partner-carrier share of late freight bills.

Co-Authored-By: Claude Opus 5.5 <noreply@anthropic.com>
Claude-Session: https://claude.ai/code/session_01BwRjju3y2wk3wSHFrM9KLe
</commit_message>
<xml_diff>
--- a/presentation/Mississauga_F27_Leadership_Review_Sep29.pptx
+++ b/presentation/Mississauga_F27_Leadership_Review_Sep29.pptx
@@ -125,6 +125,628 @@
 </file>
 
 <file path=ppt/charts/chart1.xml><?xml version="1.0" encoding="utf-8"?>
+<c:chartSpace xmlns:c="http://schemas.openxmlformats.org/drawingml/2006/chart" xmlns:a="http://schemas.openxmlformats.org/drawingml/2006/main" xmlns:r="http://schemas.openxmlformats.org/officeDocument/2006/relationships">
+  <c:date1904 val="0"/>
+  <c:roundedCorners val="1"/>
+  <c:chart>
+    <c:title>
+      <c:tx>
+        <c:rich>
+          <a:bodyPr/>
+          <a:lstStyle/>
+          <a:p>
+            <a:pPr>
+              <a:defRPr sz="1200" b="0" i="0" u="none" strike="noStrike">
+                <a:solidFill>
+                  <a:srgbClr val="111827"/>
+                </a:solidFill>
+                <a:latin typeface="Calibri"/>
+              </a:defRPr>
+            </a:pPr>
+            <a:r>
+              <a:rPr sz="1200" b="0" i="0" u="none" strike="noStrike">
+                <a:solidFill>
+                  <a:srgbClr val="111827"/>
+                </a:solidFill>
+                <a:latin typeface="Calibri"/>
+              </a:rPr>
+              <a:t>Adjusted on-time % by month · 2026</a:t>
+            </a:r>
+          </a:p>
+        </c:rich>
+      </c:tx>
+      <c:layout/>
+      <c:overlay val="0"/>
+    </c:title>
+    <c:autoTitleDeleted val="0"/>
+    <c:plotArea>
+      <c:layout/>
+      <c:barChart>
+        <c:barDir val="col"/>
+        <c:grouping val="clustered"/>
+        <c:varyColors val="0"/>
+        <c:ser>
+          <c:idx val="0"/>
+          <c:order val="0"/>
+          <c:tx>
+            <c:strRef>
+              <c:f>Sheet1!$B$1</c:f>
+              <c:strCache>
+                <c:ptCount val="1"/>
+                <c:pt idx="0">
+                  <c:v>Incl. partner carriers</c:v>
+                </c:pt>
+              </c:strCache>
+            </c:strRef>
+          </c:tx>
+          <c:spPr>
+            <a:solidFill>
+              <a:srgbClr val="7C3AED"/>
+            </a:solidFill>
+            <a:effectLst/>
+          </c:spPr>
+          <c:invertIfNegative val="0"/>
+          <c:dLbls>
+            <c:numFmt formatCode="#,##0" sourceLinked="0"/>
+            <c:txPr>
+              <a:bodyPr/>
+              <a:lstStyle/>
+              <a:p>
+                <a:pPr>
+                  <a:defRPr b="0" i="0" strike="noStrike" sz="1200" u="none">
+                    <a:solidFill>
+                      <a:srgbClr val="000000"/>
+                    </a:solidFill>
+                    <a:latin typeface="Arial"/>
+                  </a:defRPr>
+                </a:pPr>
+              </a:p>
+            </c:txPr>
+            <c:showLegendKey val="0"/>
+            <c:showVal val="0"/>
+            <c:showCatName val="0"/>
+            <c:showSerName val="0"/>
+            <c:showPercent val="0"/>
+            <c:showBubbleSize val="0"/>
+            <c:showLeaderLines val="0"/>
+          </c:dLbls>
+          <c:cat>
+            <c:multiLvlStrRef>
+              <c:f>Sheet1!$A$2:$A$10</c:f>
+              <c:multiLvlStrCache>
+                <c:ptCount val="9"/>
+                <c:lvl>
+                  <c:pt idx="0">
+                    <c:v>Jan</c:v>
+                  </c:pt>
+                  <c:pt idx="1">
+                    <c:v>Feb</c:v>
+                  </c:pt>
+                  <c:pt idx="2">
+                    <c:v>Mar</c:v>
+                  </c:pt>
+                  <c:pt idx="3">
+                    <c:v>Apr</c:v>
+                  </c:pt>
+                  <c:pt idx="4">
+                    <c:v>May</c:v>
+                  </c:pt>
+                  <c:pt idx="5">
+                    <c:v>Jun</c:v>
+                  </c:pt>
+                  <c:pt idx="6">
+                    <c:v>Jul</c:v>
+                  </c:pt>
+                  <c:pt idx="7">
+                    <c:v>Aug</c:v>
+                  </c:pt>
+                  <c:pt idx="8">
+                    <c:v>Sep</c:v>
+                  </c:pt>
+                </c:lvl>
+              </c:multiLvlStrCache>
+            </c:multiLvlStrRef>
+          </c:cat>
+          <c:val>
+            <c:numRef>
+              <c:f>Sheet1!$B$2:$B$10</c:f>
+              <c:numCache>
+                <c:formatCode>General</c:formatCode>
+                <c:ptCount val="9"/>
+                <c:pt idx="0">
+                  <c:v>87.5</c:v>
+                </c:pt>
+                <c:pt idx="1">
+                  <c:v>87.8</c:v>
+                </c:pt>
+                <c:pt idx="2">
+                  <c:v>84.9</c:v>
+                </c:pt>
+                <c:pt idx="3">
+                  <c:v>81.5</c:v>
+                </c:pt>
+                <c:pt idx="4">
+                  <c:v>83.6</c:v>
+                </c:pt>
+                <c:pt idx="5">
+                  <c:v>85.5</c:v>
+                </c:pt>
+                <c:pt idx="6">
+                  <c:v>89.3</c:v>
+                </c:pt>
+                <c:pt idx="7">
+                  <c:v>91.7</c:v>
+                </c:pt>
+                <c:pt idx="8">
+                  <c:v>93.7</c:v>
+                </c:pt>
+              </c:numCache>
+            </c:numRef>
+          </c:val>
+        </c:ser>
+        <c:ser>
+          <c:idx val="1"/>
+          <c:order val="1"/>
+          <c:tx>
+            <c:strRef>
+              <c:f>Sheet1!$C$1</c:f>
+              <c:strCache>
+                <c:ptCount val="1"/>
+                <c:pt idx="0">
+                  <c:v>Excl. partner carriers</c:v>
+                </c:pt>
+              </c:strCache>
+            </c:strRef>
+          </c:tx>
+          <c:spPr>
+            <a:solidFill>
+              <a:srgbClr val="C4B5FD"/>
+            </a:solidFill>
+            <a:effectLst/>
+          </c:spPr>
+          <c:invertIfNegative val="0"/>
+          <c:dLbls>
+            <c:numFmt formatCode="#,##0" sourceLinked="0"/>
+            <c:txPr>
+              <a:bodyPr/>
+              <a:lstStyle/>
+              <a:p>
+                <a:pPr>
+                  <a:defRPr b="0" i="0" strike="noStrike" sz="1200" u="none">
+                    <a:solidFill>
+                      <a:srgbClr val="000000"/>
+                    </a:solidFill>
+                    <a:latin typeface="Arial"/>
+                  </a:defRPr>
+                </a:pPr>
+              </a:p>
+            </c:txPr>
+            <c:showLegendKey val="0"/>
+            <c:showVal val="0"/>
+            <c:showCatName val="0"/>
+            <c:showSerName val="0"/>
+            <c:showPercent val="0"/>
+            <c:showBubbleSize val="0"/>
+            <c:showLeaderLines val="0"/>
+          </c:dLbls>
+          <c:cat>
+            <c:multiLvlStrRef>
+              <c:f>Sheet1!$A$2:$A$10</c:f>
+              <c:multiLvlStrCache>
+                <c:ptCount val="9"/>
+                <c:lvl>
+                  <c:pt idx="0">
+                    <c:v>Jan</c:v>
+                  </c:pt>
+                  <c:pt idx="1">
+                    <c:v>Feb</c:v>
+                  </c:pt>
+                  <c:pt idx="2">
+                    <c:v>Mar</c:v>
+                  </c:pt>
+                  <c:pt idx="3">
+                    <c:v>Apr</c:v>
+                  </c:pt>
+                  <c:pt idx="4">
+                    <c:v>May</c:v>
+                  </c:pt>
+                  <c:pt idx="5">
+                    <c:v>Jun</c:v>
+                  </c:pt>
+                  <c:pt idx="6">
+                    <c:v>Jul</c:v>
+                  </c:pt>
+                  <c:pt idx="7">
+                    <c:v>Aug</c:v>
+                  </c:pt>
+                  <c:pt idx="8">
+                    <c:v>Sep</c:v>
+                  </c:pt>
+                </c:lvl>
+              </c:multiLvlStrCache>
+            </c:multiLvlStrRef>
+          </c:cat>
+          <c:val>
+            <c:numRef>
+              <c:f>Sheet1!$C$2:$C$10</c:f>
+              <c:numCache>
+                <c:formatCode>General</c:formatCode>
+                <c:ptCount val="9"/>
+                <c:pt idx="0">
+                  <c:v>87.5</c:v>
+                </c:pt>
+                <c:pt idx="1">
+                  <c:v>87.9</c:v>
+                </c:pt>
+                <c:pt idx="2">
+                  <c:v>88.4</c:v>
+                </c:pt>
+                <c:pt idx="3">
+                  <c:v>88.8</c:v>
+                </c:pt>
+                <c:pt idx="4">
+                  <c:v>92.1</c:v>
+                </c:pt>
+                <c:pt idx="5">
+                  <c:v>91.8</c:v>
+                </c:pt>
+                <c:pt idx="6">
+                  <c:v>94.4</c:v>
+                </c:pt>
+                <c:pt idx="7">
+                  <c:v>94.7</c:v>
+                </c:pt>
+                <c:pt idx="8">
+                  <c:v>96.7</c:v>
+                </c:pt>
+              </c:numCache>
+            </c:numRef>
+          </c:val>
+        </c:ser>
+        <c:dLbls>
+          <c:numFmt formatCode="#,##0" sourceLinked="0"/>
+          <c:txPr>
+            <a:bodyPr/>
+            <a:lstStyle/>
+            <a:p>
+              <a:pPr>
+                <a:defRPr b="0" i="0" strike="noStrike" sz="1200" u="none">
+                  <a:solidFill>
+                    <a:srgbClr val="000000"/>
+                  </a:solidFill>
+                  <a:latin typeface="Arial"/>
+                </a:defRPr>
+              </a:pPr>
+            </a:p>
+          </c:txPr>
+          <c:showLegendKey val="0"/>
+          <c:showVal val="0"/>
+          <c:showCatName val="0"/>
+          <c:showSerName val="0"/>
+          <c:showPercent val="0"/>
+          <c:showBubbleSize val="0"/>
+          <c:showLeaderLines val="0"/>
+        </c:dLbls>
+        <c:gapWidth val="45"/>
+        <c:overlap val="0"/>
+        <c:axId val="2094734554"/>
+        <c:axId val="2094734552"/>
+        <c:axId val="2094734556"/>
+      </c:barChart>
+      <c:lineChart>
+        <c:varyColors val="0"/>
+        <c:ser>
+          <c:idx val="2"/>
+          <c:order val="2"/>
+          <c:tx>
+            <c:strRef>
+              <c:f>Sheet1!$D$1</c:f>
+              <c:strCache>
+                <c:ptCount val="1"/>
+                <c:pt idx="0">
+                  <c:v>Target 90%</c:v>
+                </c:pt>
+              </c:strCache>
+            </c:strRef>
+          </c:tx>
+          <c:spPr>
+            <a:solidFill>
+              <a:srgbClr val="DC2626"/>
+            </a:solidFill>
+            <a:ln w="19050" cap="flat">
+              <a:solidFill>
+                <a:srgbClr val="DC2626"/>
+              </a:solidFill>
+              <a:prstDash val="solid"/>
+              <a:round/>
+            </a:ln>
+            <a:effectLst/>
+          </c:spPr>
+          <c:invertIfNegative val="0"/>
+          <c:dLbls>
+            <c:numFmt formatCode="#,##0" sourceLinked="0"/>
+            <c:txPr>
+              <a:bodyPr/>
+              <a:lstStyle/>
+              <a:p>
+                <a:pPr>
+                  <a:defRPr b="0" i="0" strike="noStrike" sz="1200" u="none">
+                    <a:solidFill>
+                      <a:srgbClr val="000000"/>
+                    </a:solidFill>
+                    <a:latin typeface="Arial"/>
+                  </a:defRPr>
+                </a:pPr>
+              </a:p>
+            </c:txPr>
+            <c:showLegendKey val="0"/>
+            <c:showVal val="0"/>
+            <c:showCatName val="0"/>
+            <c:showSerName val="0"/>
+            <c:showPercent val="0"/>
+            <c:showBubbleSize val="0"/>
+            <c:showLeaderLines val="0"/>
+          </c:dLbls>
+          <c:marker>
+            <c:symbol val="none"/>
+            <c:size val="6"/>
+            <c:spPr>
+              <a:solidFill>
+                <a:srgbClr val="DC2626"/>
+              </a:solidFill>
+              <a:ln w="9525" cap="flat">
+                <a:solidFill>
+                  <a:srgbClr val="DC2626"/>
+                </a:solidFill>
+                <a:prstDash val="solid"/>
+                <a:round/>
+              </a:ln>
+              <a:effectLst/>
+            </c:spPr>
+          </c:marker>
+          <c:cat>
+            <c:multiLvlStrRef>
+              <c:f>Sheet1!$A$2:$A$10</c:f>
+              <c:multiLvlStrCache>
+                <c:ptCount val="9"/>
+                <c:lvl>
+                  <c:pt idx="0">
+                    <c:v>Jan</c:v>
+                  </c:pt>
+                  <c:pt idx="1">
+                    <c:v>Feb</c:v>
+                  </c:pt>
+                  <c:pt idx="2">
+                    <c:v>Mar</c:v>
+                  </c:pt>
+                  <c:pt idx="3">
+                    <c:v>Apr</c:v>
+                  </c:pt>
+                  <c:pt idx="4">
+                    <c:v>May</c:v>
+                  </c:pt>
+                  <c:pt idx="5">
+                    <c:v>Jun</c:v>
+                  </c:pt>
+                  <c:pt idx="6">
+                    <c:v>Jul</c:v>
+                  </c:pt>
+                  <c:pt idx="7">
+                    <c:v>Aug</c:v>
+                  </c:pt>
+                  <c:pt idx="8">
+                    <c:v>Sep</c:v>
+                  </c:pt>
+                </c:lvl>
+              </c:multiLvlStrCache>
+            </c:multiLvlStrRef>
+          </c:cat>
+          <c:val>
+            <c:numRef>
+              <c:f>Sheet1!$D$2:$D$10</c:f>
+              <c:numCache>
+                <c:formatCode>General</c:formatCode>
+                <c:ptCount val="9"/>
+                <c:pt idx="0">
+                  <c:v>90</c:v>
+                </c:pt>
+                <c:pt idx="1">
+                  <c:v>90</c:v>
+                </c:pt>
+                <c:pt idx="2">
+                  <c:v>90</c:v>
+                </c:pt>
+                <c:pt idx="3">
+                  <c:v>90</c:v>
+                </c:pt>
+                <c:pt idx="4">
+                  <c:v>90</c:v>
+                </c:pt>
+                <c:pt idx="5">
+                  <c:v>90</c:v>
+                </c:pt>
+                <c:pt idx="6">
+                  <c:v>90</c:v>
+                </c:pt>
+                <c:pt idx="7">
+                  <c:v>90</c:v>
+                </c:pt>
+                <c:pt idx="8">
+                  <c:v>90</c:v>
+                </c:pt>
+              </c:numCache>
+            </c:numRef>
+          </c:val>
+          <c:smooth val="0"/>
+        </c:ser>
+        <c:dLbls>
+          <c:numFmt formatCode="#,##0" sourceLinked="0"/>
+          <c:txPr>
+            <a:bodyPr/>
+            <a:lstStyle/>
+            <a:p>
+              <a:pPr>
+                <a:defRPr b="0" i="0" strike="noStrike" sz="1200" u="none">
+                  <a:solidFill>
+                    <a:srgbClr val="000000"/>
+                  </a:solidFill>
+                  <a:latin typeface="Arial"/>
+                </a:defRPr>
+              </a:pPr>
+            </a:p>
+          </c:txPr>
+          <c:showLegendKey val="0"/>
+          <c:showVal val="0"/>
+          <c:showCatName val="0"/>
+          <c:showSerName val="0"/>
+          <c:showPercent val="0"/>
+          <c:showBubbleSize val="0"/>
+          <c:showLeaderLines val="0"/>
+        </c:dLbls>
+        <c:marker val="1"/>
+        <c:axId val="2094734554"/>
+        <c:axId val="2094734552"/>
+        <c:axId val="2094734556"/>
+      </c:lineChart>
+      <c:catAx>
+        <c:axId val="2094734554"/>
+        <c:scaling>
+          <c:orientation val="minMax"/>
+        </c:scaling>
+        <c:delete val="0"/>
+        <c:axPos val="b"/>
+        <c:numFmt formatCode="General" sourceLinked="1"/>
+        <c:majorTickMark val="out"/>
+        <c:minorTickMark val="none"/>
+        <c:tickLblPos val="low"/>
+        <c:spPr>
+          <a:ln w="12700" cap="flat">
+            <a:solidFill>
+              <a:srgbClr val="888888"/>
+            </a:solidFill>
+            <a:prstDash val="solid"/>
+            <a:round/>
+          </a:ln>
+        </c:spPr>
+        <c:txPr>
+          <a:bodyPr/>
+          <a:lstStyle/>
+          <a:p>
+            <a:pPr>
+              <a:defRPr sz="1000" b="0" i="0" u="none" strike="noStrike">
+                <a:solidFill>
+                  <a:srgbClr val="1F2937"/>
+                </a:solidFill>
+                <a:latin typeface="Calibri"/>
+              </a:defRPr>
+            </a:pPr>
+            <a:endParaRPr lang="en-US"/>
+          </a:p>
+        </c:txPr>
+        <c:crossAx val="2094734552"/>
+        <c:crosses val="autoZero"/>
+        <c:auto val="1"/>
+        <c:lblAlgn val="ctr"/>
+        <c:noMultiLvlLbl val="1"/>
+      </c:catAx>
+      <c:valAx>
+        <c:axId val="2094734552"/>
+        <c:scaling>
+          <c:orientation val="minMax"/>
+          <c:max val="100"/>
+          <c:min val="75"/>
+        </c:scaling>
+        <c:delete val="0"/>
+        <c:axPos val="l"/>
+        <c:majorGridlines>
+          <c:spPr>
+            <a:ln w="9525" cap="flat">
+              <a:solidFill>
+                <a:srgbClr val="E5E7EB"/>
+              </a:solidFill>
+              <a:prstDash val="solid"/>
+              <a:round/>
+            </a:ln>
+          </c:spPr>
+        </c:majorGridlines>
+        <c:numFmt formatCode="0&quot;%&quot;" sourceLinked="0"/>
+        <c:majorTickMark val="out"/>
+        <c:minorTickMark val="none"/>
+        <c:tickLblPos val="nextTo"/>
+        <c:spPr>
+          <a:ln w="12700" cap="flat">
+            <a:solidFill>
+              <a:srgbClr val="888888"/>
+            </a:solidFill>
+            <a:prstDash val="solid"/>
+            <a:round/>
+          </a:ln>
+        </c:spPr>
+        <c:txPr>
+          <a:bodyPr/>
+          <a:lstStyle/>
+          <a:p>
+            <a:pPr>
+              <a:defRPr sz="900" b="0" i="0" u="none" strike="noStrike">
+                <a:solidFill>
+                  <a:srgbClr val="6B7280"/>
+                </a:solidFill>
+                <a:latin typeface="Arial"/>
+              </a:defRPr>
+            </a:pPr>
+            <a:endParaRPr lang="en-US"/>
+          </a:p>
+        </c:txPr>
+        <c:crossAx val="2094734554"/>
+        <c:crosses val="autoZero"/>
+        <c:crossBetween val="between"/>
+        <c:majorUnit val="5"/>
+      </c:valAx>
+      <c:spPr>
+        <a:noFill/>
+        <a:ln>
+          <a:noFill/>
+        </a:ln>
+        <a:effectLst/>
+      </c:spPr>
+    </c:plotArea>
+    <c:legend>
+      <c:legendPos val="b"/>
+      <c:overlay val="0"/>
+      <c:txPr>
+        <a:bodyPr/>
+        <a:lstStyle/>
+        <a:p>
+          <a:pPr>
+            <a:defRPr sz="1000">
+              <a:solidFill>
+                <a:srgbClr val="1F2937"/>
+              </a:solidFill>
+              <a:latin typeface="Calibri"/>
+              <a:cs typeface="Calibri"/>
+            </a:defRPr>
+          </a:pPr>
+          <a:endParaRPr lang="en-US"/>
+        </a:p>
+      </c:txPr>
+    </c:legend>
+    <c:plotVisOnly val="1"/>
+    <c:dispBlanksAs val="span"/>
+  </c:chart>
+  <c:spPr>
+    <a:noFill/>
+    <a:ln>
+      <a:noFill/>
+    </a:ln>
+    <a:effectLst/>
+  </c:spPr>
+  <c:externalData r:id="rId1">
+    <c:autoUpdate val="0"/>
+  </c:externalData>
+</c:chartSpace>
+</file>
+
+<file path=ppt/charts/chart2.xml><?xml version="1.0" encoding="utf-8"?>
 <c:chartSpace xmlns:c="http://schemas.openxmlformats.org/drawingml/2006/chart" xmlns:a="http://schemas.openxmlformats.org/drawingml/2006/main" xmlns:r="http://schemas.openxmlformats.org/officeDocument/2006/relationships">
   <c:date1904 val="0"/>
   <c:roundedCorners val="1"/>
@@ -401,7 +1023,7 @@
 </c:chartSpace>
 </file>
 
-<file path=ppt/charts/chart2.xml><?xml version="1.0" encoding="utf-8"?>
+<file path=ppt/charts/chart3.xml><?xml version="1.0" encoding="utf-8"?>
 <c:chartSpace xmlns:c="http://schemas.openxmlformats.org/drawingml/2006/chart" xmlns:a="http://schemas.openxmlformats.org/drawingml/2006/main" xmlns:r="http://schemas.openxmlformats.org/officeDocument/2006/relationships">
   <c:date1904 val="0"/>
   <c:roundedCorners val="1"/>
@@ -732,7 +1354,7 @@
 </c:chartSpace>
 </file>
 
-<file path=ppt/charts/chart3.xml><?xml version="1.0" encoding="utf-8"?>
+<file path=ppt/charts/chart4.xml><?xml version="1.0" encoding="utf-8"?>
 <c:chartSpace xmlns:c="http://schemas.openxmlformats.org/drawingml/2006/chart" xmlns:a="http://schemas.openxmlformats.org/drawingml/2006/main" xmlns:r="http://schemas.openxmlformats.org/officeDocument/2006/relationships">
   <c:date1904 val="0"/>
   <c:roundedCorners val="1"/>
@@ -1085,7 +1707,7 @@
 </c:chartSpace>
 </file>
 
-<file path=ppt/charts/chart4.xml><?xml version="1.0" encoding="utf-8"?>
+<file path=ppt/charts/chart5.xml><?xml version="1.0" encoding="utf-8"?>
 <c:chartSpace xmlns:c="http://schemas.openxmlformats.org/drawingml/2006/chart" xmlns:a="http://schemas.openxmlformats.org/drawingml/2006/main" xmlns:r="http://schemas.openxmlformats.org/officeDocument/2006/relationships">
   <c:date1904 val="0"/>
   <c:roundedCorners val="1"/>
@@ -1438,7 +2060,7 @@
 </c:chartSpace>
 </file>
 
-<file path=ppt/charts/chart5.xml><?xml version="1.0" encoding="utf-8"?>
+<file path=ppt/charts/chart6.xml><?xml version="1.0" encoding="utf-8"?>
 <c:chartSpace xmlns:c="http://schemas.openxmlformats.org/drawingml/2006/chart" xmlns:a="http://schemas.openxmlformats.org/drawingml/2006/main" xmlns:r="http://schemas.openxmlformats.org/officeDocument/2006/relationships">
   <c:date1904 val="0"/>
   <c:roundedCorners val="1"/>
@@ -2254,7 +2876,7 @@
           <a:p>
             <a:r>
               <a:rPr lang="en-US" dirty="0"/>
-              <a:t>Good morning. This is the Mississauga Terminal F27 review, following the same structure Brampton used yesterday: safety, service, SCA, productivity, and the status of the building. Our September month-to-date headlines: we are at 91.1 percent of our SCA hour allowance, cost per unit is down 16.7 percent and units per hour up 26.7 percent on last year, with only 9 overtime hours. Our focus is the gap to the PPH goal.</a:t>
+              <a:t>Good morning. This is the Mississauga Terminal F27 review, following the same structure Brampton used yesterday: safety, service, SCA, productivity, and the status of the building. Our September month-to-date headlines: adjusted on-time service is 93.7 percent, we are at 91.1 percent of our SCA hour allowance, cost per unit is down 16.7 percent and units per hour up 26.7 percent on last year, with only 9 overtime hours. Our focus is the gap to the PPH goal.</a:t>
             </a:r>
             <a:endParaRPr lang="en-US" dirty="0"/>
           </a:p>
@@ -3398,7 +4020,7 @@
           <a:p>
             <a:r>
               <a:rPr lang="en-US" dirty="0"/>
-              <a:t>OTS counts for September month to date are being confirmed; once entered, the unadjusted and adjusted percentages calculate from the freight bill counts. Our focus is driver ownership of the freight bill, every late coded before end of shift, and separating interline and transborder lates, which sit outside terminal control.</a:t>
+              <a:t>Adjusted on-time service for September is 93.7 percent including partner-carrier freight and 96.7 percent excluding it, both above our 90 percent target, and the last seven days averaged 94.35 percent. We show both views because partner carriers, the beyond-interliner freight, are about 13 percent of our volume but roughly 45 percent of our late freight bills, and only about 56 percent of that freight is on time. Every F27 month has been at or above 89 percent and we have been above target since August, up from 81.5 percent in April.</a:t>
             </a:r>
             <a:endParaRPr lang="en-US" dirty="0"/>
           </a:p>
@@ -4423,8 +5045,8 @@
         </p:nvSpPr>
         <p:spPr>
           <a:xfrm>
-            <a:off x="8641080" y="1828800"/>
-            <a:ext cx="1325880" cy="475488"/>
+            <a:off x="8641080" y="1783080"/>
+            <a:ext cx="1325880" cy="457200"/>
           </a:xfrm>
           <a:prstGeom prst="rect">
             <a:avLst/>
@@ -4448,6 +5070,84 @@
                 <a:ea typeface="Calibri" pitchFamily="34" charset="-122"/>
                 <a:cs typeface="Calibri" pitchFamily="34" charset="-120"/>
               </a:rPr>
+              <a:t>93.7%</a:t>
+            </a:r>
+            <a:endParaRPr lang="en-US" sz="2200" dirty="0"/>
+          </a:p>
+        </p:txBody>
+      </p:sp>
+      <p:sp>
+        <p:nvSpPr>
+          <p:cNvPr id="10" name="Text 8"/>
+          <p:cNvSpPr txBox="1"/>
+          <p:nvPr/>
+        </p:nvSpPr>
+        <p:spPr>
+          <a:xfrm>
+            <a:off x="10012680" y="1783080"/>
+            <a:ext cx="1508760" cy="457200"/>
+          </a:xfrm>
+          <a:prstGeom prst="rect">
+            <a:avLst/>
+          </a:prstGeom>
+          <a:noFill/>
+          <a:ln/>
+        </p:spPr>
+        <p:txBody>
+          <a:bodyPr wrap="square" lIns="0" tIns="0" rIns="0" bIns="0" rtlCol="0" anchor="ctr"/>
+          <a:lstStyle/>
+          <a:p>
+            <a:pPr indent="0" marL="0">
+              <a:buNone/>
+            </a:pPr>
+            <a:r>
+              <a:rPr lang="en-US" sz="1150" dirty="0">
+                <a:solidFill>
+                  <a:srgbClr val="D1D5DB"/>
+                </a:solidFill>
+                <a:latin typeface="Calibri" pitchFamily="34" charset="0"/>
+                <a:ea typeface="Calibri" pitchFamily="34" charset="-122"/>
+                <a:cs typeface="Calibri" pitchFamily="34" charset="-120"/>
+              </a:rPr>
+              <a:t>OTS Sept (adj., incl. partners)</a:t>
+            </a:r>
+            <a:endParaRPr lang="en-US" sz="1150" dirty="0"/>
+          </a:p>
+        </p:txBody>
+      </p:sp>
+      <p:sp>
+        <p:nvSpPr>
+          <p:cNvPr id="11" name="Text 9"/>
+          <p:cNvSpPr txBox="1"/>
+          <p:nvPr/>
+        </p:nvSpPr>
+        <p:spPr>
+          <a:xfrm>
+            <a:off x="8641080" y="2286000"/>
+            <a:ext cx="1325880" cy="457200"/>
+          </a:xfrm>
+          <a:prstGeom prst="rect">
+            <a:avLst/>
+          </a:prstGeom>
+          <a:noFill/>
+          <a:ln/>
+        </p:spPr>
+        <p:txBody>
+          <a:bodyPr wrap="square" lIns="0" tIns="0" rIns="0" bIns="0" rtlCol="0" anchor="ctr"/>
+          <a:lstStyle/>
+          <a:p>
+            <a:pPr indent="0" marL="0">
+              <a:buNone/>
+            </a:pPr>
+            <a:r>
+              <a:rPr lang="en-US" sz="2200" b="1" dirty="0">
+                <a:solidFill>
+                  <a:srgbClr val="34D399"/>
+                </a:solidFill>
+                <a:latin typeface="Calibri" pitchFamily="34" charset="0"/>
+                <a:ea typeface="Calibri" pitchFamily="34" charset="-122"/>
+                <a:cs typeface="Calibri" pitchFamily="34" charset="-120"/>
+              </a:rPr>
               <a:t>91.1%</a:t>
             </a:r>
             <a:endParaRPr lang="en-US" sz="2200" dirty="0"/>
@@ -4456,14 +5156,14 @@
       </p:sp>
       <p:sp>
         <p:nvSpPr>
-          <p:cNvPr id="10" name="Text 8"/>
-          <p:cNvSpPr txBox="1"/>
-          <p:nvPr/>
-        </p:nvSpPr>
-        <p:spPr>
-          <a:xfrm>
-            <a:off x="10012680" y="1828800"/>
-            <a:ext cx="1508760" cy="475488"/>
+          <p:cNvPr id="12" name="Text 10"/>
+          <p:cNvSpPr txBox="1"/>
+          <p:nvPr/>
+        </p:nvSpPr>
+        <p:spPr>
+          <a:xfrm>
+            <a:off x="10012680" y="2286000"/>
+            <a:ext cx="1508760" cy="457200"/>
           </a:xfrm>
           <a:prstGeom prst="rect">
             <a:avLst/>
@@ -4479,7 +5179,7 @@
               <a:buNone/>
             </a:pPr>
             <a:r>
-              <a:rPr lang="en-US" sz="1200" dirty="0">
+              <a:rPr lang="en-US" sz="1150" dirty="0">
                 <a:solidFill>
                   <a:srgbClr val="D1D5DB"/>
                 </a:solidFill>
@@ -4489,20 +5189,20 @@
               </a:rPr>
               <a:t>of SCA hour allowance</a:t>
             </a:r>
-            <a:endParaRPr lang="en-US" sz="1200" dirty="0"/>
-          </a:p>
-        </p:txBody>
-      </p:sp>
-      <p:sp>
-        <p:nvSpPr>
-          <p:cNvPr id="11" name="Text 9"/>
-          <p:cNvSpPr txBox="1"/>
-          <p:nvPr/>
-        </p:nvSpPr>
-        <p:spPr>
-          <a:xfrm>
-            <a:off x="8641080" y="2395728"/>
-            <a:ext cx="1325880" cy="475488"/>
+            <a:endParaRPr lang="en-US" sz="1150" dirty="0"/>
+          </a:p>
+        </p:txBody>
+      </p:sp>
+      <p:sp>
+        <p:nvSpPr>
+          <p:cNvPr id="13" name="Text 11"/>
+          <p:cNvSpPr txBox="1"/>
+          <p:nvPr/>
+        </p:nvSpPr>
+        <p:spPr>
+          <a:xfrm>
+            <a:off x="8641080" y="2788920"/>
+            <a:ext cx="1325880" cy="457200"/>
           </a:xfrm>
           <a:prstGeom prst="rect">
             <a:avLst/>
@@ -4534,14 +5234,14 @@
       </p:sp>
       <p:sp>
         <p:nvSpPr>
-          <p:cNvPr id="12" name="Text 10"/>
-          <p:cNvSpPr txBox="1"/>
-          <p:nvPr/>
-        </p:nvSpPr>
-        <p:spPr>
-          <a:xfrm>
-            <a:off x="10012680" y="2395728"/>
-            <a:ext cx="1508760" cy="475488"/>
+          <p:cNvPr id="14" name="Text 12"/>
+          <p:cNvSpPr txBox="1"/>
+          <p:nvPr/>
+        </p:nvSpPr>
+        <p:spPr>
+          <a:xfrm>
+            <a:off x="10012680" y="2788920"/>
+            <a:ext cx="1508760" cy="457200"/>
           </a:xfrm>
           <a:prstGeom prst="rect">
             <a:avLst/>
@@ -4557,7 +5257,7 @@
               <a:buNone/>
             </a:pPr>
             <a:r>
-              <a:rPr lang="en-US" sz="1200" dirty="0">
+              <a:rPr lang="en-US" sz="1150" dirty="0">
                 <a:solidFill>
                   <a:srgbClr val="D1D5DB"/>
                 </a:solidFill>
@@ -4567,20 +5267,20 @@
               </a:rPr>
               <a:t>cost per unit vs F26</a:t>
             </a:r>
-            <a:endParaRPr lang="en-US" sz="1200" dirty="0"/>
-          </a:p>
-        </p:txBody>
-      </p:sp>
-      <p:sp>
-        <p:nvSpPr>
-          <p:cNvPr id="13" name="Text 11"/>
-          <p:cNvSpPr txBox="1"/>
-          <p:nvPr/>
-        </p:nvSpPr>
-        <p:spPr>
-          <a:xfrm>
-            <a:off x="8641080" y="2962656"/>
-            <a:ext cx="1325880" cy="475488"/>
+            <a:endParaRPr lang="en-US" sz="1150" dirty="0"/>
+          </a:p>
+        </p:txBody>
+      </p:sp>
+      <p:sp>
+        <p:nvSpPr>
+          <p:cNvPr id="15" name="Text 13"/>
+          <p:cNvSpPr txBox="1"/>
+          <p:nvPr/>
+        </p:nvSpPr>
+        <p:spPr>
+          <a:xfrm>
+            <a:off x="8641080" y="3291840"/>
+            <a:ext cx="1325880" cy="457200"/>
           </a:xfrm>
           <a:prstGeom prst="rect">
             <a:avLst/>
@@ -4612,14 +5312,14 @@
       </p:sp>
       <p:sp>
         <p:nvSpPr>
-          <p:cNvPr id="14" name="Text 12"/>
-          <p:cNvSpPr txBox="1"/>
-          <p:nvPr/>
-        </p:nvSpPr>
-        <p:spPr>
-          <a:xfrm>
-            <a:off x="10012680" y="2962656"/>
-            <a:ext cx="1508760" cy="475488"/>
+          <p:cNvPr id="16" name="Text 14"/>
+          <p:cNvSpPr txBox="1"/>
+          <p:nvPr/>
+        </p:nvSpPr>
+        <p:spPr>
+          <a:xfrm>
+            <a:off x="10012680" y="3291840"/>
+            <a:ext cx="1508760" cy="457200"/>
           </a:xfrm>
           <a:prstGeom prst="rect">
             <a:avLst/>
@@ -4635,7 +5335,7 @@
               <a:buNone/>
             </a:pPr>
             <a:r>
-              <a:rPr lang="en-US" sz="1200" dirty="0">
+              <a:rPr lang="en-US" sz="1150" dirty="0">
                 <a:solidFill>
                   <a:srgbClr val="D1D5DB"/>
                 </a:solidFill>
@@ -4645,20 +5345,20 @@
               </a:rPr>
               <a:t>units per hour vs F26</a:t>
             </a:r>
-            <a:endParaRPr lang="en-US" sz="1200" dirty="0"/>
-          </a:p>
-        </p:txBody>
-      </p:sp>
-      <p:sp>
-        <p:nvSpPr>
-          <p:cNvPr id="15" name="Text 13"/>
-          <p:cNvSpPr txBox="1"/>
-          <p:nvPr/>
-        </p:nvSpPr>
-        <p:spPr>
-          <a:xfrm>
-            <a:off x="8641080" y="3529584"/>
-            <a:ext cx="1325880" cy="475488"/>
+            <a:endParaRPr lang="en-US" sz="1150" dirty="0"/>
+          </a:p>
+        </p:txBody>
+      </p:sp>
+      <p:sp>
+        <p:nvSpPr>
+          <p:cNvPr id="17" name="Text 15"/>
+          <p:cNvSpPr txBox="1"/>
+          <p:nvPr/>
+        </p:nvSpPr>
+        <p:spPr>
+          <a:xfrm>
+            <a:off x="8641080" y="3794760"/>
+            <a:ext cx="1325880" cy="457200"/>
           </a:xfrm>
           <a:prstGeom prst="rect">
             <a:avLst/>
@@ -4690,14 +5390,14 @@
       </p:sp>
       <p:sp>
         <p:nvSpPr>
-          <p:cNvPr id="16" name="Text 14"/>
-          <p:cNvSpPr txBox="1"/>
-          <p:nvPr/>
-        </p:nvSpPr>
-        <p:spPr>
-          <a:xfrm>
-            <a:off x="10012680" y="3529584"/>
-            <a:ext cx="1508760" cy="475488"/>
+          <p:cNvPr id="18" name="Text 16"/>
+          <p:cNvSpPr txBox="1"/>
+          <p:nvPr/>
+        </p:nvSpPr>
+        <p:spPr>
+          <a:xfrm>
+            <a:off x="10012680" y="3794760"/>
+            <a:ext cx="1508760" cy="457200"/>
           </a:xfrm>
           <a:prstGeom prst="rect">
             <a:avLst/>
@@ -4713,7 +5413,7 @@
               <a:buNone/>
             </a:pPr>
             <a:r>
-              <a:rPr lang="en-US" sz="1200" dirty="0">
+              <a:rPr lang="en-US" sz="1150" dirty="0">
                 <a:solidFill>
                   <a:srgbClr val="D1D5DB"/>
                 </a:solidFill>
@@ -4723,19 +5423,19 @@
               </a:rPr>
               <a:t>overtime MTD</a:t>
             </a:r>
-            <a:endParaRPr lang="en-US" sz="1200" dirty="0"/>
-          </a:p>
-        </p:txBody>
-      </p:sp>
-      <p:sp>
-        <p:nvSpPr>
-          <p:cNvPr id="17" name="Text 15"/>
-          <p:cNvSpPr txBox="1"/>
-          <p:nvPr/>
-        </p:nvSpPr>
-        <p:spPr>
-          <a:xfrm>
-            <a:off x="8641080" y="4206240"/>
+            <a:endParaRPr lang="en-US" sz="1150" dirty="0"/>
+          </a:p>
+        </p:txBody>
+      </p:sp>
+      <p:sp>
+        <p:nvSpPr>
+          <p:cNvPr id="19" name="Text 17"/>
+          <p:cNvSpPr txBox="1"/>
+          <p:nvPr/>
+        </p:nvSpPr>
+        <p:spPr>
+          <a:xfrm>
+            <a:off x="8641080" y="4370832"/>
             <a:ext cx="2834640" cy="274320"/>
           </a:xfrm>
           <a:prstGeom prst="rect">
@@ -4768,14 +5468,14 @@
       </p:sp>
       <p:sp>
         <p:nvSpPr>
-          <p:cNvPr id="18" name="Text 16"/>
-          <p:cNvSpPr txBox="1"/>
-          <p:nvPr/>
-        </p:nvSpPr>
-        <p:spPr>
-          <a:xfrm>
-            <a:off x="8641080" y="4480560"/>
-            <a:ext cx="2834640" cy="502920"/>
+          <p:cNvPr id="20" name="Text 18"/>
+          <p:cNvSpPr txBox="1"/>
+          <p:nvPr/>
+        </p:nvSpPr>
+        <p:spPr>
+          <a:xfrm>
+            <a:off x="8641080" y="4626864"/>
+            <a:ext cx="2834640" cy="457200"/>
           </a:xfrm>
           <a:prstGeom prst="rect">
             <a:avLst/>
@@ -4821,13 +5521,13 @@
       </p:sp>
       <p:sp>
         <p:nvSpPr>
-          <p:cNvPr id="19" name="Text 17"/>
-          <p:cNvSpPr txBox="1"/>
-          <p:nvPr/>
-        </p:nvSpPr>
-        <p:spPr>
-          <a:xfrm>
-            <a:off x="8641080" y="4983480"/>
+          <p:cNvPr id="21" name="Text 19"/>
+          <p:cNvSpPr txBox="1"/>
+          <p:nvPr/>
+        </p:nvSpPr>
+        <p:spPr>
+          <a:xfrm>
+            <a:off x="8641080" y="5084064"/>
             <a:ext cx="2834640" cy="274320"/>
           </a:xfrm>
           <a:prstGeom prst="rect">
@@ -27163,7 +27863,7 @@
                 <a:ea typeface="Calibri" pitchFamily="34" charset="-122"/>
                 <a:cs typeface="Calibri" pitchFamily="34" charset="-120"/>
               </a:rPr>
-              <a:t>Service — On-time service (Sept MTD)</a:t>
+              <a:t>Service — On-time service (adjusted)</a:t>
             </a:r>
             <a:endParaRPr lang="en-US" sz="3000" dirty="0"/>
           </a:p>
@@ -27177,8 +27877,8 @@
         </p:nvSpPr>
         <p:spPr>
           <a:xfrm>
-            <a:off x="548640" y="1371600"/>
-            <a:ext cx="2072030" cy="1188720"/>
+            <a:off x="548640" y="1325880"/>
+            <a:ext cx="2635758" cy="1188720"/>
           </a:xfrm>
           <a:prstGeom prst="roundRect">
             <a:avLst>
@@ -27204,8 +27904,8 @@
         </p:nvSpPr>
         <p:spPr>
           <a:xfrm>
-            <a:off x="731520" y="1508760"/>
-            <a:ext cx="1706270" cy="274320"/>
+            <a:off x="731520" y="1463040"/>
+            <a:ext cx="2269998" cy="274320"/>
           </a:xfrm>
           <a:prstGeom prst="rect">
             <a:avLst/>
@@ -27229,7 +27929,7 @@
                 <a:ea typeface="Calibri" pitchFamily="34" charset="-122"/>
                 <a:cs typeface="Calibri" pitchFamily="34" charset="-120"/>
               </a:rPr>
-              <a:t>Total FB's</a:t>
+              <a:t>Sept · incl. partner carriers</a:t>
             </a:r>
             <a:endParaRPr lang="en-US" sz="1100" dirty="0"/>
           </a:p>
@@ -27243,8 +27943,8 @@
         </p:nvSpPr>
         <p:spPr>
           <a:xfrm>
-            <a:off x="731520" y="1783080"/>
-            <a:ext cx="1706270" cy="320040"/>
+            <a:off x="731520" y="1737360"/>
+            <a:ext cx="2269998" cy="320040"/>
           </a:xfrm>
           <a:prstGeom prst="rect">
             <a:avLst/>
@@ -27260,17 +27960,17 @@
               <a:buNone/>
             </a:pPr>
             <a:r>
-              <a:rPr lang="en-US" sz="2800" b="1" dirty="0">
-                <a:solidFill>
-                  <a:srgbClr val="D97706"/>
-                </a:solidFill>
-                <a:latin typeface="Calibri" pitchFamily="34" charset="0"/>
-                <a:ea typeface="Calibri" pitchFamily="34" charset="-122"/>
-                <a:cs typeface="Calibri" pitchFamily="34" charset="-120"/>
-              </a:rPr>
-              <a:t>TBC</a:t>
-            </a:r>
-            <a:endParaRPr lang="en-US" sz="2800" dirty="0"/>
+              <a:rPr lang="en-US" sz="2600" b="1" dirty="0">
+                <a:solidFill>
+                  <a:srgbClr val="059669"/>
+                </a:solidFill>
+                <a:latin typeface="Calibri" pitchFamily="34" charset="0"/>
+                <a:ea typeface="Calibri" pitchFamily="34" charset="-122"/>
+                <a:cs typeface="Calibri" pitchFamily="34" charset="-120"/>
+              </a:rPr>
+              <a:t>93.7%</a:t>
+            </a:r>
+            <a:endParaRPr lang="en-US" sz="2600" dirty="0"/>
           </a:p>
         </p:txBody>
       </p:sp>
@@ -27282,8 +27982,8 @@
         </p:nvSpPr>
         <p:spPr>
           <a:xfrm>
-            <a:off x="731520" y="2130552"/>
-            <a:ext cx="1706270" cy="292608"/>
+            <a:off x="731520" y="2084832"/>
+            <a:ext cx="2269998" cy="292608"/>
           </a:xfrm>
           <a:prstGeom prst="rect">
             <a:avLst/>
@@ -27307,7 +28007,7 @@
                 <a:ea typeface="Calibri" pitchFamily="34" charset="-122"/>
                 <a:cs typeface="Calibri" pitchFamily="34" charset="-120"/>
               </a:rPr>
-              <a:t>Sept MTD</a:t>
+              <a:t>Sep 1–28 · F27</a:t>
             </a:r>
             <a:endParaRPr lang="en-US" sz="1050" dirty="0"/>
           </a:p>
@@ -27321,8 +28021,8 @@
         </p:nvSpPr>
         <p:spPr>
           <a:xfrm>
-            <a:off x="2803550" y="1371600"/>
-            <a:ext cx="2072030" cy="1188720"/>
+            <a:off x="3367278" y="1325880"/>
+            <a:ext cx="2635758" cy="1188720"/>
           </a:xfrm>
           <a:prstGeom prst="roundRect">
             <a:avLst>
@@ -27348,8 +28048,8 @@
         </p:nvSpPr>
         <p:spPr>
           <a:xfrm>
-            <a:off x="2986430" y="1508760"/>
-            <a:ext cx="1706270" cy="274320"/>
+            <a:off x="3550158" y="1463040"/>
+            <a:ext cx="2269998" cy="274320"/>
           </a:xfrm>
           <a:prstGeom prst="rect">
             <a:avLst/>
@@ -27373,7 +28073,7 @@
                 <a:ea typeface="Calibri" pitchFamily="34" charset="-122"/>
                 <a:cs typeface="Calibri" pitchFamily="34" charset="-120"/>
               </a:rPr>
-              <a:t>On-time FB's</a:t>
+              <a:t>Sept · excl. partner carriers</a:t>
             </a:r>
             <a:endParaRPr lang="en-US" sz="1100" dirty="0"/>
           </a:p>
@@ -27387,8 +28087,8 @@
         </p:nvSpPr>
         <p:spPr>
           <a:xfrm>
-            <a:off x="2986430" y="1783080"/>
-            <a:ext cx="1706270" cy="320040"/>
+            <a:off x="3550158" y="1737360"/>
+            <a:ext cx="2269998" cy="320040"/>
           </a:xfrm>
           <a:prstGeom prst="rect">
             <a:avLst/>
@@ -27404,17 +28104,17 @@
               <a:buNone/>
             </a:pPr>
             <a:r>
-              <a:rPr lang="en-US" sz="2800" b="1" dirty="0">
-                <a:solidFill>
-                  <a:srgbClr val="D97706"/>
-                </a:solidFill>
-                <a:latin typeface="Calibri" pitchFamily="34" charset="0"/>
-                <a:ea typeface="Calibri" pitchFamily="34" charset="-122"/>
-                <a:cs typeface="Calibri" pitchFamily="34" charset="-120"/>
-              </a:rPr>
-              <a:t>TBC</a:t>
-            </a:r>
-            <a:endParaRPr lang="en-US" sz="2800" dirty="0"/>
+              <a:rPr lang="en-US" sz="2600" b="1" dirty="0">
+                <a:solidFill>
+                  <a:srgbClr val="059669"/>
+                </a:solidFill>
+                <a:latin typeface="Calibri" pitchFamily="34" charset="0"/>
+                <a:ea typeface="Calibri" pitchFamily="34" charset="-122"/>
+                <a:cs typeface="Calibri" pitchFamily="34" charset="-120"/>
+              </a:rPr>
+              <a:t>96.7%</a:t>
+            </a:r>
+            <a:endParaRPr lang="en-US" sz="2600" dirty="0"/>
           </a:p>
         </p:txBody>
       </p:sp>
@@ -27426,8 +28126,8 @@
         </p:nvSpPr>
         <p:spPr>
           <a:xfrm>
-            <a:off x="2986430" y="2130552"/>
-            <a:ext cx="1706270" cy="292608"/>
+            <a:off x="3550158" y="2084832"/>
+            <a:ext cx="2269998" cy="292608"/>
           </a:xfrm>
           <a:prstGeom prst="rect">
             <a:avLst/>
@@ -27451,7 +28151,7 @@
                 <a:ea typeface="Calibri" pitchFamily="34" charset="-122"/>
                 <a:cs typeface="Calibri" pitchFamily="34" charset="-120"/>
               </a:rPr>
-              <a:t>Sept MTD</a:t>
+              <a:t>Partner freight excluded</a:t>
             </a:r>
             <a:endParaRPr lang="en-US" sz="1050" dirty="0"/>
           </a:p>
@@ -27465,8 +28165,8 @@
         </p:nvSpPr>
         <p:spPr>
           <a:xfrm>
-            <a:off x="5058461" y="1371600"/>
-            <a:ext cx="2072030" cy="1188720"/>
+            <a:off x="6185916" y="1325880"/>
+            <a:ext cx="2635758" cy="1188720"/>
           </a:xfrm>
           <a:prstGeom prst="roundRect">
             <a:avLst>
@@ -27492,8 +28192,8 @@
         </p:nvSpPr>
         <p:spPr>
           <a:xfrm>
-            <a:off x="5241341" y="1508760"/>
-            <a:ext cx="1706270" cy="274320"/>
+            <a:off x="6368796" y="1463040"/>
+            <a:ext cx="2269998" cy="274320"/>
           </a:xfrm>
           <a:prstGeom prst="rect">
             <a:avLst/>
@@ -27517,7 +28217,7 @@
                 <a:ea typeface="Calibri" pitchFamily="34" charset="-122"/>
                 <a:cs typeface="Calibri" pitchFamily="34" charset="-120"/>
               </a:rPr>
-              <a:t>UNADJ OTS %</a:t>
+              <a:t>Last 7 days · Sep 22–28</a:t>
             </a:r>
             <a:endParaRPr lang="en-US" sz="1100" dirty="0"/>
           </a:p>
@@ -27531,8 +28231,8 @@
         </p:nvSpPr>
         <p:spPr>
           <a:xfrm>
-            <a:off x="5241341" y="1783080"/>
-            <a:ext cx="1706270" cy="320040"/>
+            <a:off x="6368796" y="1737360"/>
+            <a:ext cx="2269998" cy="320040"/>
           </a:xfrm>
           <a:prstGeom prst="rect">
             <a:avLst/>
@@ -27548,17 +28248,17 @@
               <a:buNone/>
             </a:pPr>
             <a:r>
-              <a:rPr lang="en-US" sz="2800" b="1" dirty="0">
-                <a:solidFill>
-                  <a:srgbClr val="D97706"/>
-                </a:solidFill>
-                <a:latin typeface="Calibri" pitchFamily="34" charset="0"/>
-                <a:ea typeface="Calibri" pitchFamily="34" charset="-122"/>
-                <a:cs typeface="Calibri" pitchFamily="34" charset="-120"/>
-              </a:rPr>
-              <a:t>TBC</a:t>
-            </a:r>
-            <a:endParaRPr lang="en-US" sz="2800" dirty="0"/>
+              <a:rPr lang="en-US" sz="2600" b="1" dirty="0">
+                <a:solidFill>
+                  <a:srgbClr val="059669"/>
+                </a:solidFill>
+                <a:latin typeface="Calibri" pitchFamily="34" charset="0"/>
+                <a:ea typeface="Calibri" pitchFamily="34" charset="-122"/>
+                <a:cs typeface="Calibri" pitchFamily="34" charset="-120"/>
+              </a:rPr>
+              <a:t>94.35%</a:t>
+            </a:r>
+            <a:endParaRPr lang="en-US" sz="2600" dirty="0"/>
           </a:p>
         </p:txBody>
       </p:sp>
@@ -27570,8 +28270,8 @@
         </p:nvSpPr>
         <p:spPr>
           <a:xfrm>
-            <a:off x="5241341" y="2130552"/>
-            <a:ext cx="1706270" cy="292608"/>
+            <a:off x="6368796" y="2084832"/>
+            <a:ext cx="2269998" cy="292608"/>
           </a:xfrm>
           <a:prstGeom prst="rect">
             <a:avLst/>
@@ -27595,7 +28295,7 @@
                 <a:ea typeface="Calibri" pitchFamily="34" charset="-122"/>
                 <a:cs typeface="Calibri" pitchFamily="34" charset="-120"/>
               </a:rPr>
-              <a:t>On-time ÷ total FB's</a:t>
+              <a:t>Wk 40: 95.8% incl. · 97.8% excl.</a:t>
             </a:r>
             <a:endParaRPr lang="en-US" sz="1050" dirty="0"/>
           </a:p>
@@ -27609,8 +28309,8 @@
         </p:nvSpPr>
         <p:spPr>
           <a:xfrm>
-            <a:off x="7313371" y="1371600"/>
-            <a:ext cx="2072030" cy="1188720"/>
+            <a:off x="9004554" y="1325880"/>
+            <a:ext cx="2635758" cy="1188720"/>
           </a:xfrm>
           <a:prstGeom prst="roundRect">
             <a:avLst>
@@ -27636,8 +28336,8 @@
         </p:nvSpPr>
         <p:spPr>
           <a:xfrm>
-            <a:off x="7496251" y="1508760"/>
-            <a:ext cx="1706270" cy="274320"/>
+            <a:off x="9187434" y="1463040"/>
+            <a:ext cx="2269998" cy="274320"/>
           </a:xfrm>
           <a:prstGeom prst="rect">
             <a:avLst/>
@@ -27661,7 +28361,7 @@
                 <a:ea typeface="Calibri" pitchFamily="34" charset="-122"/>
                 <a:cs typeface="Calibri" pitchFamily="34" charset="-120"/>
               </a:rPr>
-              <a:t>ADJ OTS %</a:t>
+              <a:t>Target</a:t>
             </a:r>
             <a:endParaRPr lang="en-US" sz="1100" dirty="0"/>
           </a:p>
@@ -27675,8 +28375,8 @@
         </p:nvSpPr>
         <p:spPr>
           <a:xfrm>
-            <a:off x="7496251" y="1783080"/>
-            <a:ext cx="1706270" cy="320040"/>
+            <a:off x="9187434" y="1737360"/>
+            <a:ext cx="2269998" cy="320040"/>
           </a:xfrm>
           <a:prstGeom prst="rect">
             <a:avLst/>
@@ -27692,17 +28392,17 @@
               <a:buNone/>
             </a:pPr>
             <a:r>
-              <a:rPr lang="en-US" sz="2800" b="1" dirty="0">
-                <a:solidFill>
-                  <a:srgbClr val="D97706"/>
-                </a:solidFill>
-                <a:latin typeface="Calibri" pitchFamily="34" charset="0"/>
-                <a:ea typeface="Calibri" pitchFamily="34" charset="-122"/>
-                <a:cs typeface="Calibri" pitchFamily="34" charset="-120"/>
-              </a:rPr>
-              <a:t>TBC</a:t>
-            </a:r>
-            <a:endParaRPr lang="en-US" sz="2800" dirty="0"/>
+              <a:rPr lang="en-US" sz="2600" b="1" dirty="0">
+                <a:solidFill>
+                  <a:srgbClr val="111827"/>
+                </a:solidFill>
+                <a:latin typeface="Calibri" pitchFamily="34" charset="0"/>
+                <a:ea typeface="Calibri" pitchFamily="34" charset="-122"/>
+                <a:cs typeface="Calibri" pitchFamily="34" charset="-120"/>
+              </a:rPr>
+              <a:t>90%</a:t>
+            </a:r>
+            <a:endParaRPr lang="en-US" sz="2600" dirty="0"/>
           </a:p>
         </p:txBody>
       </p:sp>
@@ -27714,8 +28414,8 @@
         </p:nvSpPr>
         <p:spPr>
           <a:xfrm>
-            <a:off x="7496251" y="2130552"/>
-            <a:ext cx="1706270" cy="292608"/>
+            <a:off x="9187434" y="2084832"/>
+            <a:ext cx="2269998" cy="292608"/>
           </a:xfrm>
           <a:prstGeom prst="rect">
             <a:avLst/>
@@ -27739,26 +28439,196 @@
                 <a:ea typeface="Calibri" pitchFamily="34" charset="-122"/>
                 <a:cs typeface="Calibri" pitchFamily="34" charset="-120"/>
               </a:rPr>
-              <a:t>(Total − ADJ lates) ÷ total</a:t>
+              <a:t>80–90% amber · &lt;80% red</a:t>
             </a:r>
             <a:endParaRPr lang="en-US" sz="1050" dirty="0"/>
           </a:p>
         </p:txBody>
       </p:sp>
-      <p:sp>
-        <p:nvSpPr>
-          <p:cNvPr id="20" name="Shape 18"/>
+      <p:graphicFrame>
+        <p:nvGraphicFramePr>
+          <p:cNvPr id="20" name="Chart 0" descr=""/>
+          <p:cNvGraphicFramePr/>
+          <p:nvPr/>
+        </p:nvGraphicFramePr>
+        <p:xfrm>
+          <a:off x="548640" y="2651760"/>
+          <a:ext cx="5943600" cy="2331720"/>
+        </p:xfrm>
+        <a:graphic xmlns:a="http://schemas.openxmlformats.org/drawingml/2006/main">
+          <a:graphicData uri="http://schemas.openxmlformats.org/drawingml/2006/chart">
+            <c:chart xmlns:c="http://schemas.openxmlformats.org/drawingml/2006/chart" r:id="rId1"/>
+          </a:graphicData>
+        </a:graphic>
+      </p:graphicFrame>
+      <p:sp>
+        <p:nvSpPr>
+          <p:cNvPr id="21" name="Text 18"/>
+          <p:cNvSpPr txBox="1"/>
+          <p:nvPr/>
+        </p:nvSpPr>
+        <p:spPr>
+          <a:xfrm>
+            <a:off x="548640" y="4983480"/>
+            <a:ext cx="5943600" cy="219456"/>
+          </a:xfrm>
+          <a:prstGeom prst="rect">
+            <a:avLst/>
+          </a:prstGeom>
+          <a:noFill/>
+          <a:ln/>
+        </p:spPr>
+        <p:txBody>
+          <a:bodyPr wrap="square" lIns="0" tIns="0" rIns="0" bIns="0" rtlCol="0" anchor="ctr"/>
+          <a:lstStyle/>
+          <a:p>
+            <a:pPr algn="ctr" indent="0" marL="0">
+              <a:buNone/>
+            </a:pPr>
+            <a:r>
+              <a:rPr lang="en-US" sz="950" i="1" dirty="0">
+                <a:solidFill>
+                  <a:srgbClr val="6B7280"/>
+                </a:solidFill>
+                <a:latin typeface="Calibri" pitchFamily="34" charset="0"/>
+                <a:ea typeface="Calibri" pitchFamily="34" charset="-122"/>
+                <a:cs typeface="Calibri" pitchFamily="34" charset="-120"/>
+              </a:rPr>
+              <a:t>Jan–Jun = F26 · Jul–Sep = F27 (fiscal year starts Jul 1)</a:t>
+            </a:r>
+            <a:endParaRPr lang="en-US" sz="950" dirty="0"/>
+          </a:p>
+        </p:txBody>
+      </p:sp>
+      <p:sp>
+        <p:nvSpPr>
+          <p:cNvPr id="22" name="Shape 19"/>
           <p:cNvSpPr/>
           <p:nvPr/>
         </p:nvSpPr>
         <p:spPr>
           <a:xfrm>
-            <a:off x="9568282" y="1371600"/>
-            <a:ext cx="2072030" cy="1188720"/>
+            <a:off x="548640" y="5276088"/>
+            <a:ext cx="5943600" cy="731520"/>
           </a:xfrm>
           <a:prstGeom prst="roundRect">
             <a:avLst>
-              <a:gd name="adj" fmla="val 6154"/>
+              <a:gd name="adj" fmla="val 10000"/>
+            </a:avLst>
+          </a:prstGeom>
+          <a:solidFill>
+            <a:srgbClr val="F5F3FF"/>
+          </a:solidFill>
+          <a:ln w="12700">
+            <a:solidFill>
+              <a:srgbClr val="F5F3FF"/>
+            </a:solidFill>
+            <a:prstDash val="solid"/>
+          </a:ln>
+        </p:spPr>
+      </p:sp>
+      <p:sp>
+        <p:nvSpPr>
+          <p:cNvPr id="23" name="Shape 20"/>
+          <p:cNvSpPr/>
+          <p:nvPr/>
+        </p:nvSpPr>
+        <p:spPr>
+          <a:xfrm>
+            <a:off x="731520" y="5404104"/>
+            <a:ext cx="475488" cy="475488"/>
+          </a:xfrm>
+          <a:prstGeom prst="ellipse">
+            <a:avLst/>
+          </a:prstGeom>
+          <a:solidFill>
+            <a:srgbClr val="7C3AED"/>
+          </a:solidFill>
+          <a:ln w="12700">
+            <a:solidFill>
+              <a:srgbClr val="7C3AED"/>
+            </a:solidFill>
+            <a:prstDash val="solid"/>
+          </a:ln>
+        </p:spPr>
+      </p:sp>
+      <p:pic>
+        <p:nvPicPr>
+          <p:cNvPr id="24" name="Image 0" descr="preencoded.png">    </p:cNvPr>
+          <p:cNvPicPr>
+            <a:picLocks noChangeAspect="1"/>
+          </p:cNvPicPr>
+          <p:nvPr/>
+        </p:nvPicPr>
+        <p:blipFill>
+          <a:blip r:embed="rId2"/>
+          <a:stretch>
+            <a:fillRect/>
+          </a:stretch>
+        </p:blipFill>
+        <p:spPr>
+          <a:xfrm>
+            <a:off x="850392" y="5522976"/>
+            <a:ext cx="237744" cy="237744"/>
+          </a:xfrm>
+          <a:prstGeom prst="rect">
+            <a:avLst/>
+          </a:prstGeom>
+        </p:spPr>
+      </p:pic>
+      <p:sp>
+        <p:nvSpPr>
+          <p:cNvPr id="25" name="Text 21"/>
+          <p:cNvSpPr txBox="1"/>
+          <p:nvPr/>
+        </p:nvSpPr>
+        <p:spPr>
+          <a:xfrm>
+            <a:off x="1371600" y="5276088"/>
+            <a:ext cx="4983480" cy="731520"/>
+          </a:xfrm>
+          <a:prstGeom prst="rect">
+            <a:avLst/>
+          </a:prstGeom>
+          <a:noFill/>
+          <a:ln/>
+        </p:spPr>
+        <p:txBody>
+          <a:bodyPr wrap="square" lIns="0" tIns="0" rIns="0" bIns="0" rtlCol="0" anchor="ctr"/>
+          <a:lstStyle/>
+          <a:p>
+            <a:pPr indent="0" marL="0">
+              <a:buNone/>
+            </a:pPr>
+            <a:r>
+              <a:rPr lang="en-US" sz="1300" b="1" dirty="0">
+                <a:solidFill>
+                  <a:srgbClr val="111827"/>
+                </a:solidFill>
+                <a:latin typeface="Calibri" pitchFamily="34" charset="0"/>
+                <a:ea typeface="Calibri" pitchFamily="34" charset="-122"/>
+                <a:cs typeface="Calibri" pitchFamily="34" charset="-120"/>
+              </a:rPr>
+              <a:t>F27: every month ≥89%, above target since August; up from 81.5% in April.</a:t>
+            </a:r>
+            <a:endParaRPr lang="en-US" sz="1300" dirty="0"/>
+          </a:p>
+        </p:txBody>
+      </p:sp>
+      <p:sp>
+        <p:nvSpPr>
+          <p:cNvPr id="26" name="Shape 22"/>
+          <p:cNvSpPr/>
+          <p:nvPr/>
+        </p:nvSpPr>
+        <p:spPr>
+          <a:xfrm>
+            <a:off x="6720840" y="2651760"/>
+            <a:ext cx="4919472" cy="1371600"/>
+          </a:xfrm>
+          <a:prstGeom prst="roundRect">
+            <a:avLst>
+              <a:gd name="adj" fmla="val 5333"/>
             </a:avLst>
           </a:prstGeom>
           <a:solidFill>
@@ -27774,14 +28644,14 @@
       </p:sp>
       <p:sp>
         <p:nvSpPr>
-          <p:cNvPr id="21" name="Text 19"/>
-          <p:cNvSpPr txBox="1"/>
-          <p:nvPr/>
-        </p:nvSpPr>
-        <p:spPr>
-          <a:xfrm>
-            <a:off x="9751162" y="1508760"/>
-            <a:ext cx="1706270" cy="274320"/>
+          <p:cNvPr id="27" name="Text 23"/>
+          <p:cNvSpPr txBox="1"/>
+          <p:nvPr/>
+        </p:nvSpPr>
+        <p:spPr>
+          <a:xfrm>
+            <a:off x="6903720" y="2734056"/>
+            <a:ext cx="4572000" cy="274320"/>
           </a:xfrm>
           <a:prstGeom prst="rect">
             <a:avLst/>
@@ -27797,7 +28667,21 @@
               <a:buNone/>
             </a:pPr>
             <a:r>
-              <a:rPr lang="en-US" sz="1100" b="1" dirty="0">
+              <a:rPr lang="en-US" sz="1300" b="1" dirty="0">
+                <a:solidFill>
+                  <a:srgbClr val="111827"/>
+                </a:solidFill>
+                <a:latin typeface="Calibri" pitchFamily="34" charset="0"/>
+                <a:ea typeface="Calibri" pitchFamily="34" charset="-122"/>
+                <a:cs typeface="Calibri" pitchFamily="34" charset="-120"/>
+              </a:rPr>
+              <a:t>Partner-carrier impact</a:t>
+            </a:r>
+            <a:pPr indent="0" marL="0">
+              <a:buNone/>
+            </a:pPr>
+            <a:r>
+              <a:rPr lang="en-US" sz="1050" dirty="0">
                 <a:solidFill>
                   <a:srgbClr val="6B7280"/>
                 </a:solidFill>
@@ -27805,22 +28689,22 @@
                 <a:ea typeface="Calibri" pitchFamily="34" charset="-122"/>
                 <a:cs typeface="Calibri" pitchFamily="34" charset="-120"/>
               </a:rPr>
-              <a:t>OTS target</a:t>
-            </a:r>
-            <a:endParaRPr lang="en-US" sz="1100" dirty="0"/>
-          </a:p>
-        </p:txBody>
-      </p:sp>
-      <p:sp>
-        <p:nvSpPr>
-          <p:cNvPr id="22" name="Text 20"/>
-          <p:cNvSpPr txBox="1"/>
-          <p:nvPr/>
-        </p:nvSpPr>
-        <p:spPr>
-          <a:xfrm>
-            <a:off x="9751162" y="1783080"/>
-            <a:ext cx="1706270" cy="320040"/>
+              <a:t>  · calculated, Jan–Sep 2026</a:t>
+            </a:r>
+            <a:endParaRPr lang="en-US" sz="1300" dirty="0"/>
+          </a:p>
+        </p:txBody>
+      </p:sp>
+      <p:sp>
+        <p:nvSpPr>
+          <p:cNvPr id="28" name="Text 24"/>
+          <p:cNvSpPr txBox="1"/>
+          <p:nvPr/>
+        </p:nvSpPr>
+        <p:spPr>
+          <a:xfrm>
+            <a:off x="6903720" y="3008376"/>
+            <a:ext cx="4572000" cy="347472"/>
           </a:xfrm>
           <a:prstGeom prst="rect">
             <a:avLst/>
@@ -27836,30 +28720,97 @@
               <a:buNone/>
             </a:pPr>
             <a:r>
-              <a:rPr lang="en-US" sz="2800" b="1" dirty="0">
-                <a:solidFill>
-                  <a:srgbClr val="D97706"/>
-                </a:solidFill>
-                <a:latin typeface="Calibri" pitchFamily="34" charset="0"/>
-                <a:ea typeface="Calibri" pitchFamily="34" charset="-122"/>
-                <a:cs typeface="Calibri" pitchFamily="34" charset="-120"/>
-              </a:rPr>
-              <a:t>TBC</a:t>
-            </a:r>
-            <a:endParaRPr lang="en-US" sz="2800" dirty="0"/>
-          </a:p>
-        </p:txBody>
-      </p:sp>
-      <p:sp>
-        <p:nvSpPr>
-          <p:cNvPr id="23" name="Text 21"/>
-          <p:cNvSpPr txBox="1"/>
-          <p:nvPr/>
-        </p:nvSpPr>
-        <p:spPr>
-          <a:xfrm>
-            <a:off x="9751162" y="2130552"/>
-            <a:ext cx="1706270" cy="292608"/>
+              <a:rPr lang="en-US" sz="1500" b="1" dirty="0">
+                <a:solidFill>
+                  <a:srgbClr val="111827"/>
+                </a:solidFill>
+                <a:latin typeface="Calibri" pitchFamily="34" charset="0"/>
+                <a:ea typeface="Calibri" pitchFamily="34" charset="-122"/>
+                <a:cs typeface="Calibri" pitchFamily="34" charset="-120"/>
+              </a:rPr>
+              <a:t>≈13% of volume</a:t>
+            </a:r>
+            <a:pPr indent="0" marL="0">
+              <a:buNone/>
+            </a:pPr>
+            <a:r>
+              <a:rPr lang="en-US" sz="1300" b="1" dirty="0">
+                <a:solidFill>
+                  <a:srgbClr val="6B7280"/>
+                </a:solidFill>
+                <a:latin typeface="Calibri" pitchFamily="34" charset="0"/>
+                <a:ea typeface="Calibri" pitchFamily="34" charset="-122"/>
+                <a:cs typeface="Calibri" pitchFamily="34" charset="-120"/>
+              </a:rPr>
+              <a:t>  but  </a:t>
+            </a:r>
+            <a:pPr indent="0" marL="0">
+              <a:buNone/>
+            </a:pPr>
+            <a:r>
+              <a:rPr lang="en-US" sz="1500" b="1" dirty="0">
+                <a:solidFill>
+                  <a:srgbClr val="DC2626"/>
+                </a:solidFill>
+                <a:latin typeface="Calibri" pitchFamily="34" charset="0"/>
+                <a:ea typeface="Calibri" pitchFamily="34" charset="-122"/>
+                <a:cs typeface="Calibri" pitchFamily="34" charset="-120"/>
+              </a:rPr>
+              <a:t>≈45% of late FBs</a:t>
+            </a:r>
+            <a:endParaRPr lang="en-US" sz="1500" dirty="0"/>
+          </a:p>
+        </p:txBody>
+      </p:sp>
+      <p:sp>
+        <p:nvSpPr>
+          <p:cNvPr id="29" name="Text 25"/>
+          <p:cNvSpPr txBox="1"/>
+          <p:nvPr/>
+        </p:nvSpPr>
+        <p:spPr>
+          <a:xfrm>
+            <a:off x="6903720" y="3364992"/>
+            <a:ext cx="4572000" cy="365760"/>
+          </a:xfrm>
+          <a:prstGeom prst="rect">
+            <a:avLst/>
+          </a:prstGeom>
+          <a:noFill/>
+          <a:ln/>
+        </p:spPr>
+        <p:txBody>
+          <a:bodyPr wrap="square" lIns="0" tIns="0" rIns="0" bIns="0" rtlCol="0" anchor="t"/>
+          <a:lstStyle/>
+          <a:p>
+            <a:pPr indent="0" marL="0">
+              <a:buNone/>
+            </a:pPr>
+            <a:r>
+              <a:rPr lang="en-US" sz="1050" dirty="0">
+                <a:solidFill>
+                  <a:srgbClr val="1F2937"/>
+                </a:solidFill>
+                <a:latin typeface="Calibri" pitchFamily="34" charset="0"/>
+                <a:ea typeface="Calibri" pitchFamily="34" charset="-122"/>
+                <a:cs typeface="Calibri" pitchFamily="34" charset="-120"/>
+              </a:rPr>
+              <a:t>≈13.0K partner FBs (101.99K − 88.98K); ≈5.74K late (12.65K − 6.91K) → ≈56% on time.</a:t>
+            </a:r>
+            <a:endParaRPr lang="en-US" sz="1050" dirty="0"/>
+          </a:p>
+        </p:txBody>
+      </p:sp>
+      <p:sp>
+        <p:nvSpPr>
+          <p:cNvPr id="30" name="Text 26"/>
+          <p:cNvSpPr txBox="1"/>
+          <p:nvPr/>
+        </p:nvSpPr>
+        <p:spPr>
+          <a:xfrm>
+            <a:off x="6903720" y="3730752"/>
+            <a:ext cx="4572000" cy="228600"/>
           </a:xfrm>
           <a:prstGeom prst="rect">
             <a:avLst/>
@@ -27883,7 +28834,7 @@
                 <a:ea typeface="Calibri" pitchFamily="34" charset="-122"/>
                 <a:cs typeface="Calibri" pitchFamily="34" charset="-120"/>
               </a:rPr>
-              <a:t>Adjusted %</a:t>
+              <a:t>YTD adj. on time: 87.60% incl. vs 92.24% excl. partner carriers.</a:t>
             </a:r>
             <a:endParaRPr lang="en-US" sz="1050" dirty="0"/>
           </a:p>
@@ -27891,2560 +28842,18 @@
       </p:sp>
       <p:sp>
         <p:nvSpPr>
-          <p:cNvPr id="24" name="Text 22"/>
-          <p:cNvSpPr txBox="1"/>
-          <p:nvPr/>
-        </p:nvSpPr>
-        <p:spPr>
-          <a:xfrm>
-            <a:off x="548640" y="2788920"/>
-            <a:ext cx="3840480" cy="347472"/>
-          </a:xfrm>
-          <a:prstGeom prst="rect">
-            <a:avLst/>
-          </a:prstGeom>
-          <a:noFill/>
-          <a:ln/>
-        </p:spPr>
-        <p:txBody>
-          <a:bodyPr wrap="square" lIns="0" tIns="0" rIns="0" bIns="0" rtlCol="0" anchor="ctr"/>
-          <a:lstStyle/>
-          <a:p>
-            <a:pPr indent="0" marL="0">
-              <a:buNone/>
-            </a:pPr>
-            <a:r>
-              <a:rPr lang="en-US" sz="1600" b="1" dirty="0">
-                <a:solidFill>
-                  <a:srgbClr val="111827"/>
-                </a:solidFill>
-                <a:latin typeface="Calibri" pitchFamily="34" charset="0"/>
-                <a:ea typeface="Calibri" pitchFamily="34" charset="-122"/>
-                <a:cs typeface="Calibri" pitchFamily="34" charset="-120"/>
-              </a:rPr>
-              <a:t>Late reason codes</a:t>
-            </a:r>
-            <a:endParaRPr lang="en-US" sz="1600" dirty="0"/>
-          </a:p>
-        </p:txBody>
-      </p:sp>
-      <p:graphicFrame>
-        <p:nvGraphicFramePr>
-          <p:cNvPr id="6" name="Table 0"/>
-          <p:cNvGraphicFramePr>
-            <a:graphicFrameLocks noGrp="1"/>
-          </p:cNvGraphicFramePr>
-          <p:nvPr>
-            <p:extLst>
-              <p:ext uri="{D42A27DB-BD31-4B8C-83A1-F6EECF244321}">
-                <p14:modId xmlns:p14="http://schemas.microsoft.com/office/powerpoint/2010/main" val="1579011935"/>
-              </p:ext>
-            </p:extLst>
-          </p:nvPr>
-        </p:nvGraphicFramePr>
-        <p:xfrm>
-          <a:off x="548640" y="3182112"/>
-          <a:ext cx="3657600" cy="914400"/>
-        </p:xfrm>
-        <a:graphic>
-          <a:graphicData uri="http://schemas.openxmlformats.org/drawingml/2006/table">
-            <a:tbl>
-              <a:tblPr/>
-              <a:tblGrid>
-                <a:gridCol w="1645920"/>
-                <a:gridCol w="914400"/>
-                <a:gridCol w="1097280"/>
-              </a:tblGrid>
-              <a:tr h="246888">
-                <a:tc>
-                  <a:txBody>
-                    <a:bodyPr/>
-                    <a:lstStyle/>
-                    <a:p>
-                      <a:pPr indent="0" marL="0">
-                        <a:buNone/>
-                      </a:pPr>
-                      <a:r>
-                        <a:rPr lang="en-US" sz="1100" b="1" dirty="0">
-                          <a:solidFill>
-                            <a:srgbClr val="FFFFFF"/>
-                          </a:solidFill>
-                          <a:latin typeface="Calibri" pitchFamily="34" charset="0"/>
-                          <a:ea typeface="Calibri" pitchFamily="34" charset="-122"/>
-                          <a:cs typeface="Calibri" pitchFamily="34" charset="-120"/>
-                        </a:rPr>
-                        <a:t>Code</a:t>
-                      </a:r>
-                      <a:endParaRPr lang="en-US" sz="1100" dirty="0">
-                        <a:latin typeface="Calibri" charset="0"/>
-                        <a:ea typeface="Calibri" charset="0"/>
-                        <a:cs typeface="Calibri" charset="0"/>
-                      </a:endParaRPr>
-                    </a:p>
-                  </a:txBody>
-                  <a:tcPr marL="91440" marR="91440" marT="36576" marB="36576" anchor="ctr">
-                    <a:lnL w="9525" cap="flat" cmpd="sng" algn="ctr">
-                      <a:solidFill>
-                        <a:srgbClr val="E5E7EB"/>
-                      </a:solidFill>
-                      <a:prstDash val="solid"/>
-                      <a:round/>
-                      <a:headEnd type="none" w="med" len="med"/>
-                      <a:tailEnd type="none" w="med" len="med"/>
-                    </a:lnL>
-                    <a:lnR w="9525" cap="flat" cmpd="sng" algn="ctr">
-                      <a:solidFill>
-                        <a:srgbClr val="E5E7EB"/>
-                      </a:solidFill>
-                      <a:prstDash val="solid"/>
-                      <a:round/>
-                      <a:headEnd type="none" w="med" len="med"/>
-                      <a:tailEnd type="none" w="med" len="med"/>
-                    </a:lnR>
-                    <a:lnT w="9525" cap="flat" cmpd="sng" algn="ctr">
-                      <a:solidFill>
-                        <a:srgbClr val="E5E7EB"/>
-                      </a:solidFill>
-                      <a:prstDash val="solid"/>
-                      <a:round/>
-                      <a:headEnd type="none" w="med" len="med"/>
-                      <a:tailEnd type="none" w="med" len="med"/>
-                    </a:lnT>
-                    <a:lnB w="9525" cap="flat" cmpd="sng" algn="ctr">
-                      <a:solidFill>
-                        <a:srgbClr val="E5E7EB"/>
-                      </a:solidFill>
-                      <a:prstDash val="solid"/>
-                      <a:round/>
-                      <a:headEnd type="none" w="med" len="med"/>
-                      <a:tailEnd type="none" w="med" len="med"/>
-                    </a:lnB>
-                    <a:solidFill>
-                      <a:srgbClr val="1F2937"/>
-                    </a:solidFill>
-                  </a:tcPr>
-                </a:tc>
-                <a:tc>
-                  <a:txBody>
-                    <a:bodyPr/>
-                    <a:lstStyle/>
-                    <a:p>
-                      <a:pPr algn="r" indent="0" marL="0">
-                        <a:buNone/>
-                      </a:pPr>
-                      <a:r>
-                        <a:rPr lang="en-US" sz="1100" b="1" dirty="0">
-                          <a:solidFill>
-                            <a:srgbClr val="FFFFFF"/>
-                          </a:solidFill>
-                          <a:latin typeface="Calibri" pitchFamily="34" charset="0"/>
-                          <a:ea typeface="Calibri" pitchFamily="34" charset="-122"/>
-                          <a:cs typeface="Calibri" pitchFamily="34" charset="-120"/>
-                        </a:rPr>
-                        <a:t>Count</a:t>
-                      </a:r>
-                      <a:endParaRPr lang="en-US" sz="1100" dirty="0">
-                        <a:latin typeface="Calibri" charset="0"/>
-                        <a:ea typeface="Calibri" charset="0"/>
-                        <a:cs typeface="Calibri" charset="0"/>
-                      </a:endParaRPr>
-                    </a:p>
-                  </a:txBody>
-                  <a:tcPr marL="91440" marR="91440" marT="36576" marB="36576" anchor="ctr">
-                    <a:lnL w="9525" cap="flat" cmpd="sng" algn="ctr">
-                      <a:solidFill>
-                        <a:srgbClr val="E5E7EB"/>
-                      </a:solidFill>
-                      <a:prstDash val="solid"/>
-                      <a:round/>
-                      <a:headEnd type="none" w="med" len="med"/>
-                      <a:tailEnd type="none" w="med" len="med"/>
-                    </a:lnL>
-                    <a:lnR w="9525" cap="flat" cmpd="sng" algn="ctr">
-                      <a:solidFill>
-                        <a:srgbClr val="E5E7EB"/>
-                      </a:solidFill>
-                      <a:prstDash val="solid"/>
-                      <a:round/>
-                      <a:headEnd type="none" w="med" len="med"/>
-                      <a:tailEnd type="none" w="med" len="med"/>
-                    </a:lnR>
-                    <a:lnT w="9525" cap="flat" cmpd="sng" algn="ctr">
-                      <a:solidFill>
-                        <a:srgbClr val="E5E7EB"/>
-                      </a:solidFill>
-                      <a:prstDash val="solid"/>
-                      <a:round/>
-                      <a:headEnd type="none" w="med" len="med"/>
-                      <a:tailEnd type="none" w="med" len="med"/>
-                    </a:lnT>
-                    <a:lnB w="9525" cap="flat" cmpd="sng" algn="ctr">
-                      <a:solidFill>
-                        <a:srgbClr val="E5E7EB"/>
-                      </a:solidFill>
-                      <a:prstDash val="solid"/>
-                      <a:round/>
-                      <a:headEnd type="none" w="med" len="med"/>
-                      <a:tailEnd type="none" w="med" len="med"/>
-                    </a:lnB>
-                    <a:solidFill>
-                      <a:srgbClr val="1F2937"/>
-                    </a:solidFill>
-                  </a:tcPr>
-                </a:tc>
-                <a:tc>
-                  <a:txBody>
-                    <a:bodyPr/>
-                    <a:lstStyle/>
-                    <a:p>
-                      <a:pPr algn="r" indent="0" marL="0">
-                        <a:buNone/>
-                      </a:pPr>
-                      <a:r>
-                        <a:rPr lang="en-US" sz="1100" b="1" dirty="0">
-                          <a:solidFill>
-                            <a:srgbClr val="FFFFFF"/>
-                          </a:solidFill>
-                          <a:latin typeface="Calibri" pitchFamily="34" charset="0"/>
-                          <a:ea typeface="Calibri" pitchFamily="34" charset="-122"/>
-                          <a:cs typeface="Calibri" pitchFamily="34" charset="-120"/>
-                        </a:rPr>
-                        <a:t>% of lates</a:t>
-                      </a:r>
-                      <a:endParaRPr lang="en-US" sz="1100" dirty="0">
-                        <a:latin typeface="Calibri" charset="0"/>
-                        <a:ea typeface="Calibri" charset="0"/>
-                        <a:cs typeface="Calibri" charset="0"/>
-                      </a:endParaRPr>
-                    </a:p>
-                  </a:txBody>
-                  <a:tcPr marL="91440" marR="91440" marT="36576" marB="36576" anchor="ctr">
-                    <a:lnL w="9525" cap="flat" cmpd="sng" algn="ctr">
-                      <a:solidFill>
-                        <a:srgbClr val="E5E7EB"/>
-                      </a:solidFill>
-                      <a:prstDash val="solid"/>
-                      <a:round/>
-                      <a:headEnd type="none" w="med" len="med"/>
-                      <a:tailEnd type="none" w="med" len="med"/>
-                    </a:lnL>
-                    <a:lnR w="9525" cap="flat" cmpd="sng" algn="ctr">
-                      <a:solidFill>
-                        <a:srgbClr val="E5E7EB"/>
-                      </a:solidFill>
-                      <a:prstDash val="solid"/>
-                      <a:round/>
-                      <a:headEnd type="none" w="med" len="med"/>
-                      <a:tailEnd type="none" w="med" len="med"/>
-                    </a:lnR>
-                    <a:lnT w="9525" cap="flat" cmpd="sng" algn="ctr">
-                      <a:solidFill>
-                        <a:srgbClr val="E5E7EB"/>
-                      </a:solidFill>
-                      <a:prstDash val="solid"/>
-                      <a:round/>
-                      <a:headEnd type="none" w="med" len="med"/>
-                      <a:tailEnd type="none" w="med" len="med"/>
-                    </a:lnT>
-                    <a:lnB w="9525" cap="flat" cmpd="sng" algn="ctr">
-                      <a:solidFill>
-                        <a:srgbClr val="E5E7EB"/>
-                      </a:solidFill>
-                      <a:prstDash val="solid"/>
-                      <a:round/>
-                      <a:headEnd type="none" w="med" len="med"/>
-                      <a:tailEnd type="none" w="med" len="med"/>
-                    </a:lnB>
-                    <a:solidFill>
-                      <a:srgbClr val="1F2937"/>
-                    </a:solidFill>
-                  </a:tcPr>
-                </a:tc>
-              </a:tr>
-              <a:tr h="246888">
-                <a:tc>
-                  <a:txBody>
-                    <a:bodyPr/>
-                    <a:lstStyle/>
-                    <a:p>
-                      <a:pPr indent="0" marL="0">
-                        <a:buNone/>
-                      </a:pPr>
-                      <a:r>
-                        <a:rPr lang="en-US" sz="1100" b="1" dirty="0">
-                          <a:solidFill>
-                            <a:srgbClr val="111827"/>
-                          </a:solidFill>
-                          <a:latin typeface="Calibri" pitchFamily="34" charset="0"/>
-                          <a:ea typeface="Calibri" pitchFamily="34" charset="-122"/>
-                          <a:cs typeface="Calibri" pitchFamily="34" charset="-120"/>
-                        </a:rPr>
-                        <a:t>AS</a:t>
-                      </a:r>
-                      <a:endParaRPr lang="en-US" sz="1100" dirty="0">
-                        <a:latin typeface="Calibri" charset="0"/>
-                        <a:ea typeface="Calibri" charset="0"/>
-                        <a:cs typeface="Calibri" charset="0"/>
-                      </a:endParaRPr>
-                    </a:p>
-                  </a:txBody>
-                  <a:tcPr marL="91440" marR="91440" marT="36576" marB="36576" anchor="ctr">
-                    <a:lnL w="9525" cap="flat" cmpd="sng" algn="ctr">
-                      <a:solidFill>
-                        <a:srgbClr val="E5E7EB"/>
-                      </a:solidFill>
-                      <a:prstDash val="solid"/>
-                      <a:round/>
-                      <a:headEnd type="none" w="med" len="med"/>
-                      <a:tailEnd type="none" w="med" len="med"/>
-                    </a:lnL>
-                    <a:lnR w="9525" cap="flat" cmpd="sng" algn="ctr">
-                      <a:solidFill>
-                        <a:srgbClr val="E5E7EB"/>
-                      </a:solidFill>
-                      <a:prstDash val="solid"/>
-                      <a:round/>
-                      <a:headEnd type="none" w="med" len="med"/>
-                      <a:tailEnd type="none" w="med" len="med"/>
-                    </a:lnR>
-                    <a:lnT w="9525" cap="flat" cmpd="sng" algn="ctr">
-                      <a:solidFill>
-                        <a:srgbClr val="E5E7EB"/>
-                      </a:solidFill>
-                      <a:prstDash val="solid"/>
-                      <a:round/>
-                      <a:headEnd type="none" w="med" len="med"/>
-                      <a:tailEnd type="none" w="med" len="med"/>
-                    </a:lnT>
-                    <a:lnB w="9525" cap="flat" cmpd="sng" algn="ctr">
-                      <a:solidFill>
-                        <a:srgbClr val="E5E7EB"/>
-                      </a:solidFill>
-                      <a:prstDash val="solid"/>
-                      <a:round/>
-                      <a:headEnd type="none" w="med" len="med"/>
-                      <a:tailEnd type="none" w="med" len="med"/>
-                    </a:lnB>
-                    <a:solidFill>
-                      <a:srgbClr val="FFFFFF"/>
-                    </a:solidFill>
-                  </a:tcPr>
-                </a:tc>
-                <a:tc>
-                  <a:txBody>
-                    <a:bodyPr/>
-                    <a:lstStyle/>
-                    <a:p>
-                      <a:pPr algn="r" indent="0" marL="0">
-                        <a:buNone/>
-                      </a:pPr>
-                      <a:r>
-                        <a:rPr lang="en-US" sz="1100" b="1" dirty="0">
-                          <a:solidFill>
-                            <a:srgbClr val="D97706"/>
-                          </a:solidFill>
-                          <a:latin typeface="Calibri" pitchFamily="34" charset="0"/>
-                          <a:ea typeface="Calibri" pitchFamily="34" charset="-122"/>
-                          <a:cs typeface="Calibri" pitchFamily="34" charset="-120"/>
-                        </a:rPr>
-                        <a:t>TBC</a:t>
-                      </a:r>
-                      <a:endParaRPr lang="en-US" sz="1100" dirty="0">
-                        <a:latin typeface="Calibri" charset="0"/>
-                        <a:ea typeface="Calibri" charset="0"/>
-                        <a:cs typeface="Calibri" charset="0"/>
-                      </a:endParaRPr>
-                    </a:p>
-                  </a:txBody>
-                  <a:tcPr marL="91440" marR="91440" marT="36576" marB="36576" anchor="ctr">
-                    <a:lnL w="9525" cap="flat" cmpd="sng" algn="ctr">
-                      <a:solidFill>
-                        <a:srgbClr val="E5E7EB"/>
-                      </a:solidFill>
-                      <a:prstDash val="solid"/>
-                      <a:round/>
-                      <a:headEnd type="none" w="med" len="med"/>
-                      <a:tailEnd type="none" w="med" len="med"/>
-                    </a:lnL>
-                    <a:lnR w="9525" cap="flat" cmpd="sng" algn="ctr">
-                      <a:solidFill>
-                        <a:srgbClr val="E5E7EB"/>
-                      </a:solidFill>
-                      <a:prstDash val="solid"/>
-                      <a:round/>
-                      <a:headEnd type="none" w="med" len="med"/>
-                      <a:tailEnd type="none" w="med" len="med"/>
-                    </a:lnR>
-                    <a:lnT w="9525" cap="flat" cmpd="sng" algn="ctr">
-                      <a:solidFill>
-                        <a:srgbClr val="E5E7EB"/>
-                      </a:solidFill>
-                      <a:prstDash val="solid"/>
-                      <a:round/>
-                      <a:headEnd type="none" w="med" len="med"/>
-                      <a:tailEnd type="none" w="med" len="med"/>
-                    </a:lnT>
-                    <a:lnB w="9525" cap="flat" cmpd="sng" algn="ctr">
-                      <a:solidFill>
-                        <a:srgbClr val="E5E7EB"/>
-                      </a:solidFill>
-                      <a:prstDash val="solid"/>
-                      <a:round/>
-                      <a:headEnd type="none" w="med" len="med"/>
-                      <a:tailEnd type="none" w="med" len="med"/>
-                    </a:lnB>
-                    <a:solidFill>
-                      <a:srgbClr val="FFFFFF"/>
-                    </a:solidFill>
-                  </a:tcPr>
-                </a:tc>
-                <a:tc>
-                  <a:txBody>
-                    <a:bodyPr/>
-                    <a:lstStyle/>
-                    <a:p>
-                      <a:pPr algn="r" indent="0" marL="0">
-                        <a:buNone/>
-                      </a:pPr>
-                      <a:r>
-                        <a:rPr lang="en-US" sz="1100" b="1" dirty="0">
-                          <a:solidFill>
-                            <a:srgbClr val="D97706"/>
-                          </a:solidFill>
-                          <a:latin typeface="Calibri" pitchFamily="34" charset="0"/>
-                          <a:ea typeface="Calibri" pitchFamily="34" charset="-122"/>
-                          <a:cs typeface="Calibri" pitchFamily="34" charset="-120"/>
-                        </a:rPr>
-                        <a:t>TBC</a:t>
-                      </a:r>
-                      <a:endParaRPr lang="en-US" sz="1100" dirty="0">
-                        <a:latin typeface="Calibri" charset="0"/>
-                        <a:ea typeface="Calibri" charset="0"/>
-                        <a:cs typeface="Calibri" charset="0"/>
-                      </a:endParaRPr>
-                    </a:p>
-                  </a:txBody>
-                  <a:tcPr marL="91440" marR="91440" marT="36576" marB="36576" anchor="ctr">
-                    <a:lnL w="9525" cap="flat" cmpd="sng" algn="ctr">
-                      <a:solidFill>
-                        <a:srgbClr val="E5E7EB"/>
-                      </a:solidFill>
-                      <a:prstDash val="solid"/>
-                      <a:round/>
-                      <a:headEnd type="none" w="med" len="med"/>
-                      <a:tailEnd type="none" w="med" len="med"/>
-                    </a:lnL>
-                    <a:lnR w="9525" cap="flat" cmpd="sng" algn="ctr">
-                      <a:solidFill>
-                        <a:srgbClr val="E5E7EB"/>
-                      </a:solidFill>
-                      <a:prstDash val="solid"/>
-                      <a:round/>
-                      <a:headEnd type="none" w="med" len="med"/>
-                      <a:tailEnd type="none" w="med" len="med"/>
-                    </a:lnR>
-                    <a:lnT w="9525" cap="flat" cmpd="sng" algn="ctr">
-                      <a:solidFill>
-                        <a:srgbClr val="E5E7EB"/>
-                      </a:solidFill>
-                      <a:prstDash val="solid"/>
-                      <a:round/>
-                      <a:headEnd type="none" w="med" len="med"/>
-                      <a:tailEnd type="none" w="med" len="med"/>
-                    </a:lnT>
-                    <a:lnB w="9525" cap="flat" cmpd="sng" algn="ctr">
-                      <a:solidFill>
-                        <a:srgbClr val="E5E7EB"/>
-                      </a:solidFill>
-                      <a:prstDash val="solid"/>
-                      <a:round/>
-                      <a:headEnd type="none" w="med" len="med"/>
-                      <a:tailEnd type="none" w="med" len="med"/>
-                    </a:lnB>
-                    <a:solidFill>
-                      <a:srgbClr val="FFFFFF"/>
-                    </a:solidFill>
-                  </a:tcPr>
-                </a:tc>
-              </a:tr>
-              <a:tr h="246888">
-                <a:tc>
-                  <a:txBody>
-                    <a:bodyPr/>
-                    <a:lstStyle/>
-                    <a:p>
-                      <a:pPr indent="0" marL="0">
-                        <a:buNone/>
-                      </a:pPr>
-                      <a:r>
-                        <a:rPr lang="en-US" sz="1100" b="1" dirty="0">
-                          <a:solidFill>
-                            <a:srgbClr val="111827"/>
-                          </a:solidFill>
-                          <a:latin typeface="Calibri" pitchFamily="34" charset="0"/>
-                          <a:ea typeface="Calibri" pitchFamily="34" charset="-122"/>
-                          <a:cs typeface="Calibri" pitchFamily="34" charset="-120"/>
-                        </a:rPr>
-                        <a:t>BD</a:t>
-                      </a:r>
-                      <a:endParaRPr lang="en-US" sz="1100" dirty="0">
-                        <a:latin typeface="Calibri" charset="0"/>
-                        <a:ea typeface="Calibri" charset="0"/>
-                        <a:cs typeface="Calibri" charset="0"/>
-                      </a:endParaRPr>
-                    </a:p>
-                  </a:txBody>
-                  <a:tcPr marL="91440" marR="91440" marT="36576" marB="36576" anchor="ctr">
-                    <a:lnL w="9525" cap="flat" cmpd="sng" algn="ctr">
-                      <a:solidFill>
-                        <a:srgbClr val="E5E7EB"/>
-                      </a:solidFill>
-                      <a:prstDash val="solid"/>
-                      <a:round/>
-                      <a:headEnd type="none" w="med" len="med"/>
-                      <a:tailEnd type="none" w="med" len="med"/>
-                    </a:lnL>
-                    <a:lnR w="9525" cap="flat" cmpd="sng" algn="ctr">
-                      <a:solidFill>
-                        <a:srgbClr val="E5E7EB"/>
-                      </a:solidFill>
-                      <a:prstDash val="solid"/>
-                      <a:round/>
-                      <a:headEnd type="none" w="med" len="med"/>
-                      <a:tailEnd type="none" w="med" len="med"/>
-                    </a:lnR>
-                    <a:lnT w="9525" cap="flat" cmpd="sng" algn="ctr">
-                      <a:solidFill>
-                        <a:srgbClr val="E5E7EB"/>
-                      </a:solidFill>
-                      <a:prstDash val="solid"/>
-                      <a:round/>
-                      <a:headEnd type="none" w="med" len="med"/>
-                      <a:tailEnd type="none" w="med" len="med"/>
-                    </a:lnT>
-                    <a:lnB w="9525" cap="flat" cmpd="sng" algn="ctr">
-                      <a:solidFill>
-                        <a:srgbClr val="E5E7EB"/>
-                      </a:solidFill>
-                      <a:prstDash val="solid"/>
-                      <a:round/>
-                      <a:headEnd type="none" w="med" len="med"/>
-                      <a:tailEnd type="none" w="med" len="med"/>
-                    </a:lnB>
-                    <a:solidFill>
-                      <a:srgbClr val="F9FAFB"/>
-                    </a:solidFill>
-                  </a:tcPr>
-                </a:tc>
-                <a:tc>
-                  <a:txBody>
-                    <a:bodyPr/>
-                    <a:lstStyle/>
-                    <a:p>
-                      <a:pPr algn="r" indent="0" marL="0">
-                        <a:buNone/>
-                      </a:pPr>
-                      <a:r>
-                        <a:rPr lang="en-US" sz="1100" b="1" dirty="0">
-                          <a:solidFill>
-                            <a:srgbClr val="D97706"/>
-                          </a:solidFill>
-                          <a:latin typeface="Calibri" pitchFamily="34" charset="0"/>
-                          <a:ea typeface="Calibri" pitchFamily="34" charset="-122"/>
-                          <a:cs typeface="Calibri" pitchFamily="34" charset="-120"/>
-                        </a:rPr>
-                        <a:t>TBC</a:t>
-                      </a:r>
-                      <a:endParaRPr lang="en-US" sz="1100" dirty="0">
-                        <a:latin typeface="Calibri" charset="0"/>
-                        <a:ea typeface="Calibri" charset="0"/>
-                        <a:cs typeface="Calibri" charset="0"/>
-                      </a:endParaRPr>
-                    </a:p>
-                  </a:txBody>
-                  <a:tcPr marL="91440" marR="91440" marT="36576" marB="36576" anchor="ctr">
-                    <a:lnL w="9525" cap="flat" cmpd="sng" algn="ctr">
-                      <a:solidFill>
-                        <a:srgbClr val="E5E7EB"/>
-                      </a:solidFill>
-                      <a:prstDash val="solid"/>
-                      <a:round/>
-                      <a:headEnd type="none" w="med" len="med"/>
-                      <a:tailEnd type="none" w="med" len="med"/>
-                    </a:lnL>
-                    <a:lnR w="9525" cap="flat" cmpd="sng" algn="ctr">
-                      <a:solidFill>
-                        <a:srgbClr val="E5E7EB"/>
-                      </a:solidFill>
-                      <a:prstDash val="solid"/>
-                      <a:round/>
-                      <a:headEnd type="none" w="med" len="med"/>
-                      <a:tailEnd type="none" w="med" len="med"/>
-                    </a:lnR>
-                    <a:lnT w="9525" cap="flat" cmpd="sng" algn="ctr">
-                      <a:solidFill>
-                        <a:srgbClr val="E5E7EB"/>
-                      </a:solidFill>
-                      <a:prstDash val="solid"/>
-                      <a:round/>
-                      <a:headEnd type="none" w="med" len="med"/>
-                      <a:tailEnd type="none" w="med" len="med"/>
-                    </a:lnT>
-                    <a:lnB w="9525" cap="flat" cmpd="sng" algn="ctr">
-                      <a:solidFill>
-                        <a:srgbClr val="E5E7EB"/>
-                      </a:solidFill>
-                      <a:prstDash val="solid"/>
-                      <a:round/>
-                      <a:headEnd type="none" w="med" len="med"/>
-                      <a:tailEnd type="none" w="med" len="med"/>
-                    </a:lnB>
-                    <a:solidFill>
-                      <a:srgbClr val="F9FAFB"/>
-                    </a:solidFill>
-                  </a:tcPr>
-                </a:tc>
-                <a:tc>
-                  <a:txBody>
-                    <a:bodyPr/>
-                    <a:lstStyle/>
-                    <a:p>
-                      <a:pPr algn="r" indent="0" marL="0">
-                        <a:buNone/>
-                      </a:pPr>
-                      <a:r>
-                        <a:rPr lang="en-US" sz="1100" b="1" dirty="0">
-                          <a:solidFill>
-                            <a:srgbClr val="D97706"/>
-                          </a:solidFill>
-                          <a:latin typeface="Calibri" pitchFamily="34" charset="0"/>
-                          <a:ea typeface="Calibri" pitchFamily="34" charset="-122"/>
-                          <a:cs typeface="Calibri" pitchFamily="34" charset="-120"/>
-                        </a:rPr>
-                        <a:t>TBC</a:t>
-                      </a:r>
-                      <a:endParaRPr lang="en-US" sz="1100" dirty="0">
-                        <a:latin typeface="Calibri" charset="0"/>
-                        <a:ea typeface="Calibri" charset="0"/>
-                        <a:cs typeface="Calibri" charset="0"/>
-                      </a:endParaRPr>
-                    </a:p>
-                  </a:txBody>
-                  <a:tcPr marL="91440" marR="91440" marT="36576" marB="36576" anchor="ctr">
-                    <a:lnL w="9525" cap="flat" cmpd="sng" algn="ctr">
-                      <a:solidFill>
-                        <a:srgbClr val="E5E7EB"/>
-                      </a:solidFill>
-                      <a:prstDash val="solid"/>
-                      <a:round/>
-                      <a:headEnd type="none" w="med" len="med"/>
-                      <a:tailEnd type="none" w="med" len="med"/>
-                    </a:lnL>
-                    <a:lnR w="9525" cap="flat" cmpd="sng" algn="ctr">
-                      <a:solidFill>
-                        <a:srgbClr val="E5E7EB"/>
-                      </a:solidFill>
-                      <a:prstDash val="solid"/>
-                      <a:round/>
-                      <a:headEnd type="none" w="med" len="med"/>
-                      <a:tailEnd type="none" w="med" len="med"/>
-                    </a:lnR>
-                    <a:lnT w="9525" cap="flat" cmpd="sng" algn="ctr">
-                      <a:solidFill>
-                        <a:srgbClr val="E5E7EB"/>
-                      </a:solidFill>
-                      <a:prstDash val="solid"/>
-                      <a:round/>
-                      <a:headEnd type="none" w="med" len="med"/>
-                      <a:tailEnd type="none" w="med" len="med"/>
-                    </a:lnT>
-                    <a:lnB w="9525" cap="flat" cmpd="sng" algn="ctr">
-                      <a:solidFill>
-                        <a:srgbClr val="E5E7EB"/>
-                      </a:solidFill>
-                      <a:prstDash val="solid"/>
-                      <a:round/>
-                      <a:headEnd type="none" w="med" len="med"/>
-                      <a:tailEnd type="none" w="med" len="med"/>
-                    </a:lnB>
-                    <a:solidFill>
-                      <a:srgbClr val="F9FAFB"/>
-                    </a:solidFill>
-                  </a:tcPr>
-                </a:tc>
-              </a:tr>
-              <a:tr h="246888">
-                <a:tc>
-                  <a:txBody>
-                    <a:bodyPr/>
-                    <a:lstStyle/>
-                    <a:p>
-                      <a:pPr indent="0" marL="0">
-                        <a:buNone/>
-                      </a:pPr>
-                      <a:r>
-                        <a:rPr lang="en-US" sz="1100" b="1" dirty="0">
-                          <a:solidFill>
-                            <a:srgbClr val="111827"/>
-                          </a:solidFill>
-                          <a:latin typeface="Calibri" pitchFamily="34" charset="0"/>
-                          <a:ea typeface="Calibri" pitchFamily="34" charset="-122"/>
-                          <a:cs typeface="Calibri" pitchFamily="34" charset="-120"/>
-                        </a:rPr>
-                        <a:t>OT</a:t>
-                      </a:r>
-                      <a:endParaRPr lang="en-US" sz="1100" dirty="0">
-                        <a:latin typeface="Calibri" charset="0"/>
-                        <a:ea typeface="Calibri" charset="0"/>
-                        <a:cs typeface="Calibri" charset="0"/>
-                      </a:endParaRPr>
-                    </a:p>
-                  </a:txBody>
-                  <a:tcPr marL="91440" marR="91440" marT="36576" marB="36576" anchor="ctr">
-                    <a:lnL w="9525" cap="flat" cmpd="sng" algn="ctr">
-                      <a:solidFill>
-                        <a:srgbClr val="E5E7EB"/>
-                      </a:solidFill>
-                      <a:prstDash val="solid"/>
-                      <a:round/>
-                      <a:headEnd type="none" w="med" len="med"/>
-                      <a:tailEnd type="none" w="med" len="med"/>
-                    </a:lnL>
-                    <a:lnR w="9525" cap="flat" cmpd="sng" algn="ctr">
-                      <a:solidFill>
-                        <a:srgbClr val="E5E7EB"/>
-                      </a:solidFill>
-                      <a:prstDash val="solid"/>
-                      <a:round/>
-                      <a:headEnd type="none" w="med" len="med"/>
-                      <a:tailEnd type="none" w="med" len="med"/>
-                    </a:lnR>
-                    <a:lnT w="9525" cap="flat" cmpd="sng" algn="ctr">
-                      <a:solidFill>
-                        <a:srgbClr val="E5E7EB"/>
-                      </a:solidFill>
-                      <a:prstDash val="solid"/>
-                      <a:round/>
-                      <a:headEnd type="none" w="med" len="med"/>
-                      <a:tailEnd type="none" w="med" len="med"/>
-                    </a:lnT>
-                    <a:lnB w="9525" cap="flat" cmpd="sng" algn="ctr">
-                      <a:solidFill>
-                        <a:srgbClr val="E5E7EB"/>
-                      </a:solidFill>
-                      <a:prstDash val="solid"/>
-                      <a:round/>
-                      <a:headEnd type="none" w="med" len="med"/>
-                      <a:tailEnd type="none" w="med" len="med"/>
-                    </a:lnB>
-                    <a:solidFill>
-                      <a:srgbClr val="FFFFFF"/>
-                    </a:solidFill>
-                  </a:tcPr>
-                </a:tc>
-                <a:tc>
-                  <a:txBody>
-                    <a:bodyPr/>
-                    <a:lstStyle/>
-                    <a:p>
-                      <a:pPr algn="r" indent="0" marL="0">
-                        <a:buNone/>
-                      </a:pPr>
-                      <a:r>
-                        <a:rPr lang="en-US" sz="1100" b="1" dirty="0">
-                          <a:solidFill>
-                            <a:srgbClr val="D97706"/>
-                          </a:solidFill>
-                          <a:latin typeface="Calibri" pitchFamily="34" charset="0"/>
-                          <a:ea typeface="Calibri" pitchFamily="34" charset="-122"/>
-                          <a:cs typeface="Calibri" pitchFamily="34" charset="-120"/>
-                        </a:rPr>
-                        <a:t>TBC</a:t>
-                      </a:r>
-                      <a:endParaRPr lang="en-US" sz="1100" dirty="0">
-                        <a:latin typeface="Calibri" charset="0"/>
-                        <a:ea typeface="Calibri" charset="0"/>
-                        <a:cs typeface="Calibri" charset="0"/>
-                      </a:endParaRPr>
-                    </a:p>
-                  </a:txBody>
-                  <a:tcPr marL="91440" marR="91440" marT="36576" marB="36576" anchor="ctr">
-                    <a:lnL w="9525" cap="flat" cmpd="sng" algn="ctr">
-                      <a:solidFill>
-                        <a:srgbClr val="E5E7EB"/>
-                      </a:solidFill>
-                      <a:prstDash val="solid"/>
-                      <a:round/>
-                      <a:headEnd type="none" w="med" len="med"/>
-                      <a:tailEnd type="none" w="med" len="med"/>
-                    </a:lnL>
-                    <a:lnR w="9525" cap="flat" cmpd="sng" algn="ctr">
-                      <a:solidFill>
-                        <a:srgbClr val="E5E7EB"/>
-                      </a:solidFill>
-                      <a:prstDash val="solid"/>
-                      <a:round/>
-                      <a:headEnd type="none" w="med" len="med"/>
-                      <a:tailEnd type="none" w="med" len="med"/>
-                    </a:lnR>
-                    <a:lnT w="9525" cap="flat" cmpd="sng" algn="ctr">
-                      <a:solidFill>
-                        <a:srgbClr val="E5E7EB"/>
-                      </a:solidFill>
-                      <a:prstDash val="solid"/>
-                      <a:round/>
-                      <a:headEnd type="none" w="med" len="med"/>
-                      <a:tailEnd type="none" w="med" len="med"/>
-                    </a:lnT>
-                    <a:lnB w="9525" cap="flat" cmpd="sng" algn="ctr">
-                      <a:solidFill>
-                        <a:srgbClr val="E5E7EB"/>
-                      </a:solidFill>
-                      <a:prstDash val="solid"/>
-                      <a:round/>
-                      <a:headEnd type="none" w="med" len="med"/>
-                      <a:tailEnd type="none" w="med" len="med"/>
-                    </a:lnB>
-                    <a:solidFill>
-                      <a:srgbClr val="FFFFFF"/>
-                    </a:solidFill>
-                  </a:tcPr>
-                </a:tc>
-                <a:tc>
-                  <a:txBody>
-                    <a:bodyPr/>
-                    <a:lstStyle/>
-                    <a:p>
-                      <a:pPr algn="r" indent="0" marL="0">
-                        <a:buNone/>
-                      </a:pPr>
-                      <a:r>
-                        <a:rPr lang="en-US" sz="1100" b="1" dirty="0">
-                          <a:solidFill>
-                            <a:srgbClr val="D97706"/>
-                          </a:solidFill>
-                          <a:latin typeface="Calibri" pitchFamily="34" charset="0"/>
-                          <a:ea typeface="Calibri" pitchFamily="34" charset="-122"/>
-                          <a:cs typeface="Calibri" pitchFamily="34" charset="-120"/>
-                        </a:rPr>
-                        <a:t>TBC</a:t>
-                      </a:r>
-                      <a:endParaRPr lang="en-US" sz="1100" dirty="0">
-                        <a:latin typeface="Calibri" charset="0"/>
-                        <a:ea typeface="Calibri" charset="0"/>
-                        <a:cs typeface="Calibri" charset="0"/>
-                      </a:endParaRPr>
-                    </a:p>
-                  </a:txBody>
-                  <a:tcPr marL="91440" marR="91440" marT="36576" marB="36576" anchor="ctr">
-                    <a:lnL w="9525" cap="flat" cmpd="sng" algn="ctr">
-                      <a:solidFill>
-                        <a:srgbClr val="E5E7EB"/>
-                      </a:solidFill>
-                      <a:prstDash val="solid"/>
-                      <a:round/>
-                      <a:headEnd type="none" w="med" len="med"/>
-                      <a:tailEnd type="none" w="med" len="med"/>
-                    </a:lnL>
-                    <a:lnR w="9525" cap="flat" cmpd="sng" algn="ctr">
-                      <a:solidFill>
-                        <a:srgbClr val="E5E7EB"/>
-                      </a:solidFill>
-                      <a:prstDash val="solid"/>
-                      <a:round/>
-                      <a:headEnd type="none" w="med" len="med"/>
-                      <a:tailEnd type="none" w="med" len="med"/>
-                    </a:lnR>
-                    <a:lnT w="9525" cap="flat" cmpd="sng" algn="ctr">
-                      <a:solidFill>
-                        <a:srgbClr val="E5E7EB"/>
-                      </a:solidFill>
-                      <a:prstDash val="solid"/>
-                      <a:round/>
-                      <a:headEnd type="none" w="med" len="med"/>
-                      <a:tailEnd type="none" w="med" len="med"/>
-                    </a:lnT>
-                    <a:lnB w="9525" cap="flat" cmpd="sng" algn="ctr">
-                      <a:solidFill>
-                        <a:srgbClr val="E5E7EB"/>
-                      </a:solidFill>
-                      <a:prstDash val="solid"/>
-                      <a:round/>
-                      <a:headEnd type="none" w="med" len="med"/>
-                      <a:tailEnd type="none" w="med" len="med"/>
-                    </a:lnB>
-                    <a:solidFill>
-                      <a:srgbClr val="FFFFFF"/>
-                    </a:solidFill>
-                  </a:tcPr>
-                </a:tc>
-              </a:tr>
-              <a:tr h="246888">
-                <a:tc>
-                  <a:txBody>
-                    <a:bodyPr/>
-                    <a:lstStyle/>
-                    <a:p>
-                      <a:pPr indent="0" marL="0">
-                        <a:buNone/>
-                      </a:pPr>
-                      <a:r>
-                        <a:rPr lang="en-US" sz="1100" b="1" dirty="0">
-                          <a:solidFill>
-                            <a:srgbClr val="111827"/>
-                          </a:solidFill>
-                          <a:latin typeface="Calibri" pitchFamily="34" charset="0"/>
-                          <a:ea typeface="Calibri" pitchFamily="34" charset="-122"/>
-                          <a:cs typeface="Calibri" pitchFamily="34" charset="-120"/>
-                        </a:rPr>
-                        <a:t>TF</a:t>
-                      </a:r>
-                      <a:endParaRPr lang="en-US" sz="1100" dirty="0">
-                        <a:latin typeface="Calibri" charset="0"/>
-                        <a:ea typeface="Calibri" charset="0"/>
-                        <a:cs typeface="Calibri" charset="0"/>
-                      </a:endParaRPr>
-                    </a:p>
-                  </a:txBody>
-                  <a:tcPr marL="91440" marR="91440" marT="36576" marB="36576" anchor="ctr">
-                    <a:lnL w="9525" cap="flat" cmpd="sng" algn="ctr">
-                      <a:solidFill>
-                        <a:srgbClr val="E5E7EB"/>
-                      </a:solidFill>
-                      <a:prstDash val="solid"/>
-                      <a:round/>
-                      <a:headEnd type="none" w="med" len="med"/>
-                      <a:tailEnd type="none" w="med" len="med"/>
-                    </a:lnL>
-                    <a:lnR w="9525" cap="flat" cmpd="sng" algn="ctr">
-                      <a:solidFill>
-                        <a:srgbClr val="E5E7EB"/>
-                      </a:solidFill>
-                      <a:prstDash val="solid"/>
-                      <a:round/>
-                      <a:headEnd type="none" w="med" len="med"/>
-                      <a:tailEnd type="none" w="med" len="med"/>
-                    </a:lnR>
-                    <a:lnT w="9525" cap="flat" cmpd="sng" algn="ctr">
-                      <a:solidFill>
-                        <a:srgbClr val="E5E7EB"/>
-                      </a:solidFill>
-                      <a:prstDash val="solid"/>
-                      <a:round/>
-                      <a:headEnd type="none" w="med" len="med"/>
-                      <a:tailEnd type="none" w="med" len="med"/>
-                    </a:lnT>
-                    <a:lnB w="9525" cap="flat" cmpd="sng" algn="ctr">
-                      <a:solidFill>
-                        <a:srgbClr val="E5E7EB"/>
-                      </a:solidFill>
-                      <a:prstDash val="solid"/>
-                      <a:round/>
-                      <a:headEnd type="none" w="med" len="med"/>
-                      <a:tailEnd type="none" w="med" len="med"/>
-                    </a:lnB>
-                    <a:solidFill>
-                      <a:srgbClr val="F9FAFB"/>
-                    </a:solidFill>
-                  </a:tcPr>
-                </a:tc>
-                <a:tc>
-                  <a:txBody>
-                    <a:bodyPr/>
-                    <a:lstStyle/>
-                    <a:p>
-                      <a:pPr algn="r" indent="0" marL="0">
-                        <a:buNone/>
-                      </a:pPr>
-                      <a:r>
-                        <a:rPr lang="en-US" sz="1100" b="1" dirty="0">
-                          <a:solidFill>
-                            <a:srgbClr val="D97706"/>
-                          </a:solidFill>
-                          <a:latin typeface="Calibri" pitchFamily="34" charset="0"/>
-                          <a:ea typeface="Calibri" pitchFamily="34" charset="-122"/>
-                          <a:cs typeface="Calibri" pitchFamily="34" charset="-120"/>
-                        </a:rPr>
-                        <a:t>TBC</a:t>
-                      </a:r>
-                      <a:endParaRPr lang="en-US" sz="1100" dirty="0">
-                        <a:latin typeface="Calibri" charset="0"/>
-                        <a:ea typeface="Calibri" charset="0"/>
-                        <a:cs typeface="Calibri" charset="0"/>
-                      </a:endParaRPr>
-                    </a:p>
-                  </a:txBody>
-                  <a:tcPr marL="91440" marR="91440" marT="36576" marB="36576" anchor="ctr">
-                    <a:lnL w="9525" cap="flat" cmpd="sng" algn="ctr">
-                      <a:solidFill>
-                        <a:srgbClr val="E5E7EB"/>
-                      </a:solidFill>
-                      <a:prstDash val="solid"/>
-                      <a:round/>
-                      <a:headEnd type="none" w="med" len="med"/>
-                      <a:tailEnd type="none" w="med" len="med"/>
-                    </a:lnL>
-                    <a:lnR w="9525" cap="flat" cmpd="sng" algn="ctr">
-                      <a:solidFill>
-                        <a:srgbClr val="E5E7EB"/>
-                      </a:solidFill>
-                      <a:prstDash val="solid"/>
-                      <a:round/>
-                      <a:headEnd type="none" w="med" len="med"/>
-                      <a:tailEnd type="none" w="med" len="med"/>
-                    </a:lnR>
-                    <a:lnT w="9525" cap="flat" cmpd="sng" algn="ctr">
-                      <a:solidFill>
-                        <a:srgbClr val="E5E7EB"/>
-                      </a:solidFill>
-                      <a:prstDash val="solid"/>
-                      <a:round/>
-                      <a:headEnd type="none" w="med" len="med"/>
-                      <a:tailEnd type="none" w="med" len="med"/>
-                    </a:lnT>
-                    <a:lnB w="9525" cap="flat" cmpd="sng" algn="ctr">
-                      <a:solidFill>
-                        <a:srgbClr val="E5E7EB"/>
-                      </a:solidFill>
-                      <a:prstDash val="solid"/>
-                      <a:round/>
-                      <a:headEnd type="none" w="med" len="med"/>
-                      <a:tailEnd type="none" w="med" len="med"/>
-                    </a:lnB>
-                    <a:solidFill>
-                      <a:srgbClr val="F9FAFB"/>
-                    </a:solidFill>
-                  </a:tcPr>
-                </a:tc>
-                <a:tc>
-                  <a:txBody>
-                    <a:bodyPr/>
-                    <a:lstStyle/>
-                    <a:p>
-                      <a:pPr algn="r" indent="0" marL="0">
-                        <a:buNone/>
-                      </a:pPr>
-                      <a:r>
-                        <a:rPr lang="en-US" sz="1100" b="1" dirty="0">
-                          <a:solidFill>
-                            <a:srgbClr val="D97706"/>
-                          </a:solidFill>
-                          <a:latin typeface="Calibri" pitchFamily="34" charset="0"/>
-                          <a:ea typeface="Calibri" pitchFamily="34" charset="-122"/>
-                          <a:cs typeface="Calibri" pitchFamily="34" charset="-120"/>
-                        </a:rPr>
-                        <a:t>TBC</a:t>
-                      </a:r>
-                      <a:endParaRPr lang="en-US" sz="1100" dirty="0">
-                        <a:latin typeface="Calibri" charset="0"/>
-                        <a:ea typeface="Calibri" charset="0"/>
-                        <a:cs typeface="Calibri" charset="0"/>
-                      </a:endParaRPr>
-                    </a:p>
-                  </a:txBody>
-                  <a:tcPr marL="91440" marR="91440" marT="36576" marB="36576" anchor="ctr">
-                    <a:lnL w="9525" cap="flat" cmpd="sng" algn="ctr">
-                      <a:solidFill>
-                        <a:srgbClr val="E5E7EB"/>
-                      </a:solidFill>
-                      <a:prstDash val="solid"/>
-                      <a:round/>
-                      <a:headEnd type="none" w="med" len="med"/>
-                      <a:tailEnd type="none" w="med" len="med"/>
-                    </a:lnL>
-                    <a:lnR w="9525" cap="flat" cmpd="sng" algn="ctr">
-                      <a:solidFill>
-                        <a:srgbClr val="E5E7EB"/>
-                      </a:solidFill>
-                      <a:prstDash val="solid"/>
-                      <a:round/>
-                      <a:headEnd type="none" w="med" len="med"/>
-                      <a:tailEnd type="none" w="med" len="med"/>
-                    </a:lnR>
-                    <a:lnT w="9525" cap="flat" cmpd="sng" algn="ctr">
-                      <a:solidFill>
-                        <a:srgbClr val="E5E7EB"/>
-                      </a:solidFill>
-                      <a:prstDash val="solid"/>
-                      <a:round/>
-                      <a:headEnd type="none" w="med" len="med"/>
-                      <a:tailEnd type="none" w="med" len="med"/>
-                    </a:lnT>
-                    <a:lnB w="9525" cap="flat" cmpd="sng" algn="ctr">
-                      <a:solidFill>
-                        <a:srgbClr val="E5E7EB"/>
-                      </a:solidFill>
-                      <a:prstDash val="solid"/>
-                      <a:round/>
-                      <a:headEnd type="none" w="med" len="med"/>
-                      <a:tailEnd type="none" w="med" len="med"/>
-                    </a:lnB>
-                    <a:solidFill>
-                      <a:srgbClr val="F9FAFB"/>
-                    </a:solidFill>
-                  </a:tcPr>
-                </a:tc>
-              </a:tr>
-              <a:tr h="246888">
-                <a:tc>
-                  <a:txBody>
-                    <a:bodyPr/>
-                    <a:lstStyle/>
-                    <a:p>
-                      <a:pPr indent="0" marL="0">
-                        <a:buNone/>
-                      </a:pPr>
-                      <a:r>
-                        <a:rPr lang="en-US" sz="1100" b="1" dirty="0">
-                          <a:solidFill>
-                            <a:srgbClr val="111827"/>
-                          </a:solidFill>
-                          <a:latin typeface="Calibri" pitchFamily="34" charset="0"/>
-                          <a:ea typeface="Calibri" pitchFamily="34" charset="-122"/>
-                          <a:cs typeface="Calibri" pitchFamily="34" charset="-120"/>
-                        </a:rPr>
-                        <a:t>LH</a:t>
-                      </a:r>
-                      <a:endParaRPr lang="en-US" sz="1100" dirty="0">
-                        <a:latin typeface="Calibri" charset="0"/>
-                        <a:ea typeface="Calibri" charset="0"/>
-                        <a:cs typeface="Calibri" charset="0"/>
-                      </a:endParaRPr>
-                    </a:p>
-                  </a:txBody>
-                  <a:tcPr marL="91440" marR="91440" marT="36576" marB="36576" anchor="ctr">
-                    <a:lnL w="9525" cap="flat" cmpd="sng" algn="ctr">
-                      <a:solidFill>
-                        <a:srgbClr val="E5E7EB"/>
-                      </a:solidFill>
-                      <a:prstDash val="solid"/>
-                      <a:round/>
-                      <a:headEnd type="none" w="med" len="med"/>
-                      <a:tailEnd type="none" w="med" len="med"/>
-                    </a:lnL>
-                    <a:lnR w="9525" cap="flat" cmpd="sng" algn="ctr">
-                      <a:solidFill>
-                        <a:srgbClr val="E5E7EB"/>
-                      </a:solidFill>
-                      <a:prstDash val="solid"/>
-                      <a:round/>
-                      <a:headEnd type="none" w="med" len="med"/>
-                      <a:tailEnd type="none" w="med" len="med"/>
-                    </a:lnR>
-                    <a:lnT w="9525" cap="flat" cmpd="sng" algn="ctr">
-                      <a:solidFill>
-                        <a:srgbClr val="E5E7EB"/>
-                      </a:solidFill>
-                      <a:prstDash val="solid"/>
-                      <a:round/>
-                      <a:headEnd type="none" w="med" len="med"/>
-                      <a:tailEnd type="none" w="med" len="med"/>
-                    </a:lnT>
-                    <a:lnB w="9525" cap="flat" cmpd="sng" algn="ctr">
-                      <a:solidFill>
-                        <a:srgbClr val="E5E7EB"/>
-                      </a:solidFill>
-                      <a:prstDash val="solid"/>
-                      <a:round/>
-                      <a:headEnd type="none" w="med" len="med"/>
-                      <a:tailEnd type="none" w="med" len="med"/>
-                    </a:lnB>
-                    <a:solidFill>
-                      <a:srgbClr val="FFFFFF"/>
-                    </a:solidFill>
-                  </a:tcPr>
-                </a:tc>
-                <a:tc>
-                  <a:txBody>
-                    <a:bodyPr/>
-                    <a:lstStyle/>
-                    <a:p>
-                      <a:pPr algn="r" indent="0" marL="0">
-                        <a:buNone/>
-                      </a:pPr>
-                      <a:r>
-                        <a:rPr lang="en-US" sz="1100" b="1" dirty="0">
-                          <a:solidFill>
-                            <a:srgbClr val="D97706"/>
-                          </a:solidFill>
-                          <a:latin typeface="Calibri" pitchFamily="34" charset="0"/>
-                          <a:ea typeface="Calibri" pitchFamily="34" charset="-122"/>
-                          <a:cs typeface="Calibri" pitchFamily="34" charset="-120"/>
-                        </a:rPr>
-                        <a:t>TBC</a:t>
-                      </a:r>
-                      <a:endParaRPr lang="en-US" sz="1100" dirty="0">
-                        <a:latin typeface="Calibri" charset="0"/>
-                        <a:ea typeface="Calibri" charset="0"/>
-                        <a:cs typeface="Calibri" charset="0"/>
-                      </a:endParaRPr>
-                    </a:p>
-                  </a:txBody>
-                  <a:tcPr marL="91440" marR="91440" marT="36576" marB="36576" anchor="ctr">
-                    <a:lnL w="9525" cap="flat" cmpd="sng" algn="ctr">
-                      <a:solidFill>
-                        <a:srgbClr val="E5E7EB"/>
-                      </a:solidFill>
-                      <a:prstDash val="solid"/>
-                      <a:round/>
-                      <a:headEnd type="none" w="med" len="med"/>
-                      <a:tailEnd type="none" w="med" len="med"/>
-                    </a:lnL>
-                    <a:lnR w="9525" cap="flat" cmpd="sng" algn="ctr">
-                      <a:solidFill>
-                        <a:srgbClr val="E5E7EB"/>
-                      </a:solidFill>
-                      <a:prstDash val="solid"/>
-                      <a:round/>
-                      <a:headEnd type="none" w="med" len="med"/>
-                      <a:tailEnd type="none" w="med" len="med"/>
-                    </a:lnR>
-                    <a:lnT w="9525" cap="flat" cmpd="sng" algn="ctr">
-                      <a:solidFill>
-                        <a:srgbClr val="E5E7EB"/>
-                      </a:solidFill>
-                      <a:prstDash val="solid"/>
-                      <a:round/>
-                      <a:headEnd type="none" w="med" len="med"/>
-                      <a:tailEnd type="none" w="med" len="med"/>
-                    </a:lnT>
-                    <a:lnB w="9525" cap="flat" cmpd="sng" algn="ctr">
-                      <a:solidFill>
-                        <a:srgbClr val="E5E7EB"/>
-                      </a:solidFill>
-                      <a:prstDash val="solid"/>
-                      <a:round/>
-                      <a:headEnd type="none" w="med" len="med"/>
-                      <a:tailEnd type="none" w="med" len="med"/>
-                    </a:lnB>
-                    <a:solidFill>
-                      <a:srgbClr val="FFFFFF"/>
-                    </a:solidFill>
-                  </a:tcPr>
-                </a:tc>
-                <a:tc>
-                  <a:txBody>
-                    <a:bodyPr/>
-                    <a:lstStyle/>
-                    <a:p>
-                      <a:pPr algn="r" indent="0" marL="0">
-                        <a:buNone/>
-                      </a:pPr>
-                      <a:r>
-                        <a:rPr lang="en-US" sz="1100" b="1" dirty="0">
-                          <a:solidFill>
-                            <a:srgbClr val="D97706"/>
-                          </a:solidFill>
-                          <a:latin typeface="Calibri" pitchFamily="34" charset="0"/>
-                          <a:ea typeface="Calibri" pitchFamily="34" charset="-122"/>
-                          <a:cs typeface="Calibri" pitchFamily="34" charset="-120"/>
-                        </a:rPr>
-                        <a:t>TBC</a:t>
-                      </a:r>
-                      <a:endParaRPr lang="en-US" sz="1100" dirty="0">
-                        <a:latin typeface="Calibri" charset="0"/>
-                        <a:ea typeface="Calibri" charset="0"/>
-                        <a:cs typeface="Calibri" charset="0"/>
-                      </a:endParaRPr>
-                    </a:p>
-                  </a:txBody>
-                  <a:tcPr marL="91440" marR="91440" marT="36576" marB="36576" anchor="ctr">
-                    <a:lnL w="9525" cap="flat" cmpd="sng" algn="ctr">
-                      <a:solidFill>
-                        <a:srgbClr val="E5E7EB"/>
-                      </a:solidFill>
-                      <a:prstDash val="solid"/>
-                      <a:round/>
-                      <a:headEnd type="none" w="med" len="med"/>
-                      <a:tailEnd type="none" w="med" len="med"/>
-                    </a:lnL>
-                    <a:lnR w="9525" cap="flat" cmpd="sng" algn="ctr">
-                      <a:solidFill>
-                        <a:srgbClr val="E5E7EB"/>
-                      </a:solidFill>
-                      <a:prstDash val="solid"/>
-                      <a:round/>
-                      <a:headEnd type="none" w="med" len="med"/>
-                      <a:tailEnd type="none" w="med" len="med"/>
-                    </a:lnR>
-                    <a:lnT w="9525" cap="flat" cmpd="sng" algn="ctr">
-                      <a:solidFill>
-                        <a:srgbClr val="E5E7EB"/>
-                      </a:solidFill>
-                      <a:prstDash val="solid"/>
-                      <a:round/>
-                      <a:headEnd type="none" w="med" len="med"/>
-                      <a:tailEnd type="none" w="med" len="med"/>
-                    </a:lnT>
-                    <a:lnB w="9525" cap="flat" cmpd="sng" algn="ctr">
-                      <a:solidFill>
-                        <a:srgbClr val="E5E7EB"/>
-                      </a:solidFill>
-                      <a:prstDash val="solid"/>
-                      <a:round/>
-                      <a:headEnd type="none" w="med" len="med"/>
-                      <a:tailEnd type="none" w="med" len="med"/>
-                    </a:lnB>
-                    <a:solidFill>
-                      <a:srgbClr val="FFFFFF"/>
-                    </a:solidFill>
-                  </a:tcPr>
-                </a:tc>
-              </a:tr>
-              <a:tr h="246888">
-                <a:tc>
-                  <a:txBody>
-                    <a:bodyPr/>
-                    <a:lstStyle/>
-                    <a:p>
-                      <a:pPr indent="0" marL="0">
-                        <a:buNone/>
-                      </a:pPr>
-                      <a:r>
-                        <a:rPr lang="en-US" sz="1100" b="1" dirty="0">
-                          <a:solidFill>
-                            <a:srgbClr val="111827"/>
-                          </a:solidFill>
-                          <a:latin typeface="Calibri" pitchFamily="34" charset="0"/>
-                          <a:ea typeface="Calibri" pitchFamily="34" charset="-122"/>
-                          <a:cs typeface="Calibri" pitchFamily="34" charset="-120"/>
-                        </a:rPr>
-                        <a:t>DL</a:t>
-                      </a:r>
-                      <a:endParaRPr lang="en-US" sz="1100" dirty="0">
-                        <a:latin typeface="Calibri" charset="0"/>
-                        <a:ea typeface="Calibri" charset="0"/>
-                        <a:cs typeface="Calibri" charset="0"/>
-                      </a:endParaRPr>
-                    </a:p>
-                  </a:txBody>
-                  <a:tcPr marL="91440" marR="91440" marT="36576" marB="36576" anchor="ctr">
-                    <a:lnL w="9525" cap="flat" cmpd="sng" algn="ctr">
-                      <a:solidFill>
-                        <a:srgbClr val="E5E7EB"/>
-                      </a:solidFill>
-                      <a:prstDash val="solid"/>
-                      <a:round/>
-                      <a:headEnd type="none" w="med" len="med"/>
-                      <a:tailEnd type="none" w="med" len="med"/>
-                    </a:lnL>
-                    <a:lnR w="9525" cap="flat" cmpd="sng" algn="ctr">
-                      <a:solidFill>
-                        <a:srgbClr val="E5E7EB"/>
-                      </a:solidFill>
-                      <a:prstDash val="solid"/>
-                      <a:round/>
-                      <a:headEnd type="none" w="med" len="med"/>
-                      <a:tailEnd type="none" w="med" len="med"/>
-                    </a:lnR>
-                    <a:lnT w="9525" cap="flat" cmpd="sng" algn="ctr">
-                      <a:solidFill>
-                        <a:srgbClr val="E5E7EB"/>
-                      </a:solidFill>
-                      <a:prstDash val="solid"/>
-                      <a:round/>
-                      <a:headEnd type="none" w="med" len="med"/>
-                      <a:tailEnd type="none" w="med" len="med"/>
-                    </a:lnT>
-                    <a:lnB w="9525" cap="flat" cmpd="sng" algn="ctr">
-                      <a:solidFill>
-                        <a:srgbClr val="E5E7EB"/>
-                      </a:solidFill>
-                      <a:prstDash val="solid"/>
-                      <a:round/>
-                      <a:headEnd type="none" w="med" len="med"/>
-                      <a:tailEnd type="none" w="med" len="med"/>
-                    </a:lnB>
-                    <a:solidFill>
-                      <a:srgbClr val="F9FAFB"/>
-                    </a:solidFill>
-                  </a:tcPr>
-                </a:tc>
-                <a:tc>
-                  <a:txBody>
-                    <a:bodyPr/>
-                    <a:lstStyle/>
-                    <a:p>
-                      <a:pPr algn="r" indent="0" marL="0">
-                        <a:buNone/>
-                      </a:pPr>
-                      <a:r>
-                        <a:rPr lang="en-US" sz="1100" b="1" dirty="0">
-                          <a:solidFill>
-                            <a:srgbClr val="D97706"/>
-                          </a:solidFill>
-                          <a:latin typeface="Calibri" pitchFamily="34" charset="0"/>
-                          <a:ea typeface="Calibri" pitchFamily="34" charset="-122"/>
-                          <a:cs typeface="Calibri" pitchFamily="34" charset="-120"/>
-                        </a:rPr>
-                        <a:t>TBC</a:t>
-                      </a:r>
-                      <a:endParaRPr lang="en-US" sz="1100" dirty="0">
-                        <a:latin typeface="Calibri" charset="0"/>
-                        <a:ea typeface="Calibri" charset="0"/>
-                        <a:cs typeface="Calibri" charset="0"/>
-                      </a:endParaRPr>
-                    </a:p>
-                  </a:txBody>
-                  <a:tcPr marL="91440" marR="91440" marT="36576" marB="36576" anchor="ctr">
-                    <a:lnL w="9525" cap="flat" cmpd="sng" algn="ctr">
-                      <a:solidFill>
-                        <a:srgbClr val="E5E7EB"/>
-                      </a:solidFill>
-                      <a:prstDash val="solid"/>
-                      <a:round/>
-                      <a:headEnd type="none" w="med" len="med"/>
-                      <a:tailEnd type="none" w="med" len="med"/>
-                    </a:lnL>
-                    <a:lnR w="9525" cap="flat" cmpd="sng" algn="ctr">
-                      <a:solidFill>
-                        <a:srgbClr val="E5E7EB"/>
-                      </a:solidFill>
-                      <a:prstDash val="solid"/>
-                      <a:round/>
-                      <a:headEnd type="none" w="med" len="med"/>
-                      <a:tailEnd type="none" w="med" len="med"/>
-                    </a:lnR>
-                    <a:lnT w="9525" cap="flat" cmpd="sng" algn="ctr">
-                      <a:solidFill>
-                        <a:srgbClr val="E5E7EB"/>
-                      </a:solidFill>
-                      <a:prstDash val="solid"/>
-                      <a:round/>
-                      <a:headEnd type="none" w="med" len="med"/>
-                      <a:tailEnd type="none" w="med" len="med"/>
-                    </a:lnT>
-                    <a:lnB w="9525" cap="flat" cmpd="sng" algn="ctr">
-                      <a:solidFill>
-                        <a:srgbClr val="E5E7EB"/>
-                      </a:solidFill>
-                      <a:prstDash val="solid"/>
-                      <a:round/>
-                      <a:headEnd type="none" w="med" len="med"/>
-                      <a:tailEnd type="none" w="med" len="med"/>
-                    </a:lnB>
-                    <a:solidFill>
-                      <a:srgbClr val="F9FAFB"/>
-                    </a:solidFill>
-                  </a:tcPr>
-                </a:tc>
-                <a:tc>
-                  <a:txBody>
-                    <a:bodyPr/>
-                    <a:lstStyle/>
-                    <a:p>
-                      <a:pPr algn="r" indent="0" marL="0">
-                        <a:buNone/>
-                      </a:pPr>
-                      <a:r>
-                        <a:rPr lang="en-US" sz="1100" b="1" dirty="0">
-                          <a:solidFill>
-                            <a:srgbClr val="D97706"/>
-                          </a:solidFill>
-                          <a:latin typeface="Calibri" pitchFamily="34" charset="0"/>
-                          <a:ea typeface="Calibri" pitchFamily="34" charset="-122"/>
-                          <a:cs typeface="Calibri" pitchFamily="34" charset="-120"/>
-                        </a:rPr>
-                        <a:t>TBC</a:t>
-                      </a:r>
-                      <a:endParaRPr lang="en-US" sz="1100" dirty="0">
-                        <a:latin typeface="Calibri" charset="0"/>
-                        <a:ea typeface="Calibri" charset="0"/>
-                        <a:cs typeface="Calibri" charset="0"/>
-                      </a:endParaRPr>
-                    </a:p>
-                  </a:txBody>
-                  <a:tcPr marL="91440" marR="91440" marT="36576" marB="36576" anchor="ctr">
-                    <a:lnL w="9525" cap="flat" cmpd="sng" algn="ctr">
-                      <a:solidFill>
-                        <a:srgbClr val="E5E7EB"/>
-                      </a:solidFill>
-                      <a:prstDash val="solid"/>
-                      <a:round/>
-                      <a:headEnd type="none" w="med" len="med"/>
-                      <a:tailEnd type="none" w="med" len="med"/>
-                    </a:lnL>
-                    <a:lnR w="9525" cap="flat" cmpd="sng" algn="ctr">
-                      <a:solidFill>
-                        <a:srgbClr val="E5E7EB"/>
-                      </a:solidFill>
-                      <a:prstDash val="solid"/>
-                      <a:round/>
-                      <a:headEnd type="none" w="med" len="med"/>
-                      <a:tailEnd type="none" w="med" len="med"/>
-                    </a:lnR>
-                    <a:lnT w="9525" cap="flat" cmpd="sng" algn="ctr">
-                      <a:solidFill>
-                        <a:srgbClr val="E5E7EB"/>
-                      </a:solidFill>
-                      <a:prstDash val="solid"/>
-                      <a:round/>
-                      <a:headEnd type="none" w="med" len="med"/>
-                      <a:tailEnd type="none" w="med" len="med"/>
-                    </a:lnT>
-                    <a:lnB w="9525" cap="flat" cmpd="sng" algn="ctr">
-                      <a:solidFill>
-                        <a:srgbClr val="E5E7EB"/>
-                      </a:solidFill>
-                      <a:prstDash val="solid"/>
-                      <a:round/>
-                      <a:headEnd type="none" w="med" len="med"/>
-                      <a:tailEnd type="none" w="med" len="med"/>
-                    </a:lnB>
-                    <a:solidFill>
-                      <a:srgbClr val="F9FAFB"/>
-                    </a:solidFill>
-                  </a:tcPr>
-                </a:tc>
-              </a:tr>
-              <a:tr h="246888">
-                <a:tc>
-                  <a:txBody>
-                    <a:bodyPr/>
-                    <a:lstStyle/>
-                    <a:p>
-                      <a:pPr indent="0" marL="0">
-                        <a:buNone/>
-                      </a:pPr>
-                      <a:r>
-                        <a:rPr lang="en-US" sz="1100" b="1" dirty="0">
-                          <a:solidFill>
-                            <a:srgbClr val="111827"/>
-                          </a:solidFill>
-                          <a:latin typeface="Calibri" pitchFamily="34" charset="0"/>
-                          <a:ea typeface="Calibri" pitchFamily="34" charset="-122"/>
-                          <a:cs typeface="Calibri" pitchFamily="34" charset="-120"/>
-                        </a:rPr>
-                        <a:t>MS</a:t>
-                      </a:r>
-                      <a:endParaRPr lang="en-US" sz="1100" dirty="0">
-                        <a:latin typeface="Calibri" charset="0"/>
-                        <a:ea typeface="Calibri" charset="0"/>
-                        <a:cs typeface="Calibri" charset="0"/>
-                      </a:endParaRPr>
-                    </a:p>
-                  </a:txBody>
-                  <a:tcPr marL="91440" marR="91440" marT="36576" marB="36576" anchor="ctr">
-                    <a:lnL w="9525" cap="flat" cmpd="sng" algn="ctr">
-                      <a:solidFill>
-                        <a:srgbClr val="E5E7EB"/>
-                      </a:solidFill>
-                      <a:prstDash val="solid"/>
-                      <a:round/>
-                      <a:headEnd type="none" w="med" len="med"/>
-                      <a:tailEnd type="none" w="med" len="med"/>
-                    </a:lnL>
-                    <a:lnR w="9525" cap="flat" cmpd="sng" algn="ctr">
-                      <a:solidFill>
-                        <a:srgbClr val="E5E7EB"/>
-                      </a:solidFill>
-                      <a:prstDash val="solid"/>
-                      <a:round/>
-                      <a:headEnd type="none" w="med" len="med"/>
-                      <a:tailEnd type="none" w="med" len="med"/>
-                    </a:lnR>
-                    <a:lnT w="9525" cap="flat" cmpd="sng" algn="ctr">
-                      <a:solidFill>
-                        <a:srgbClr val="E5E7EB"/>
-                      </a:solidFill>
-                      <a:prstDash val="solid"/>
-                      <a:round/>
-                      <a:headEnd type="none" w="med" len="med"/>
-                      <a:tailEnd type="none" w="med" len="med"/>
-                    </a:lnT>
-                    <a:lnB w="9525" cap="flat" cmpd="sng" algn="ctr">
-                      <a:solidFill>
-                        <a:srgbClr val="E5E7EB"/>
-                      </a:solidFill>
-                      <a:prstDash val="solid"/>
-                      <a:round/>
-                      <a:headEnd type="none" w="med" len="med"/>
-                      <a:tailEnd type="none" w="med" len="med"/>
-                    </a:lnB>
-                    <a:solidFill>
-                      <a:srgbClr val="FFFFFF"/>
-                    </a:solidFill>
-                  </a:tcPr>
-                </a:tc>
-                <a:tc>
-                  <a:txBody>
-                    <a:bodyPr/>
-                    <a:lstStyle/>
-                    <a:p>
-                      <a:pPr algn="r" indent="0" marL="0">
-                        <a:buNone/>
-                      </a:pPr>
-                      <a:r>
-                        <a:rPr lang="en-US" sz="1100" b="1" dirty="0">
-                          <a:solidFill>
-                            <a:srgbClr val="D97706"/>
-                          </a:solidFill>
-                          <a:latin typeface="Calibri" pitchFamily="34" charset="0"/>
-                          <a:ea typeface="Calibri" pitchFamily="34" charset="-122"/>
-                          <a:cs typeface="Calibri" pitchFamily="34" charset="-120"/>
-                        </a:rPr>
-                        <a:t>TBC</a:t>
-                      </a:r>
-                      <a:endParaRPr lang="en-US" sz="1100" dirty="0">
-                        <a:latin typeface="Calibri" charset="0"/>
-                        <a:ea typeface="Calibri" charset="0"/>
-                        <a:cs typeface="Calibri" charset="0"/>
-                      </a:endParaRPr>
-                    </a:p>
-                  </a:txBody>
-                  <a:tcPr marL="91440" marR="91440" marT="36576" marB="36576" anchor="ctr">
-                    <a:lnL w="9525" cap="flat" cmpd="sng" algn="ctr">
-                      <a:solidFill>
-                        <a:srgbClr val="E5E7EB"/>
-                      </a:solidFill>
-                      <a:prstDash val="solid"/>
-                      <a:round/>
-                      <a:headEnd type="none" w="med" len="med"/>
-                      <a:tailEnd type="none" w="med" len="med"/>
-                    </a:lnL>
-                    <a:lnR w="9525" cap="flat" cmpd="sng" algn="ctr">
-                      <a:solidFill>
-                        <a:srgbClr val="E5E7EB"/>
-                      </a:solidFill>
-                      <a:prstDash val="solid"/>
-                      <a:round/>
-                      <a:headEnd type="none" w="med" len="med"/>
-                      <a:tailEnd type="none" w="med" len="med"/>
-                    </a:lnR>
-                    <a:lnT w="9525" cap="flat" cmpd="sng" algn="ctr">
-                      <a:solidFill>
-                        <a:srgbClr val="E5E7EB"/>
-                      </a:solidFill>
-                      <a:prstDash val="solid"/>
-                      <a:round/>
-                      <a:headEnd type="none" w="med" len="med"/>
-                      <a:tailEnd type="none" w="med" len="med"/>
-                    </a:lnT>
-                    <a:lnB w="9525" cap="flat" cmpd="sng" algn="ctr">
-                      <a:solidFill>
-                        <a:srgbClr val="E5E7EB"/>
-                      </a:solidFill>
-                      <a:prstDash val="solid"/>
-                      <a:round/>
-                      <a:headEnd type="none" w="med" len="med"/>
-                      <a:tailEnd type="none" w="med" len="med"/>
-                    </a:lnB>
-                    <a:solidFill>
-                      <a:srgbClr val="FFFFFF"/>
-                    </a:solidFill>
-                  </a:tcPr>
-                </a:tc>
-                <a:tc>
-                  <a:txBody>
-                    <a:bodyPr/>
-                    <a:lstStyle/>
-                    <a:p>
-                      <a:pPr algn="r" indent="0" marL="0">
-                        <a:buNone/>
-                      </a:pPr>
-                      <a:r>
-                        <a:rPr lang="en-US" sz="1100" b="1" dirty="0">
-                          <a:solidFill>
-                            <a:srgbClr val="D97706"/>
-                          </a:solidFill>
-                          <a:latin typeface="Calibri" pitchFamily="34" charset="0"/>
-                          <a:ea typeface="Calibri" pitchFamily="34" charset="-122"/>
-                          <a:cs typeface="Calibri" pitchFamily="34" charset="-120"/>
-                        </a:rPr>
-                        <a:t>TBC</a:t>
-                      </a:r>
-                      <a:endParaRPr lang="en-US" sz="1100" dirty="0">
-                        <a:latin typeface="Calibri" charset="0"/>
-                        <a:ea typeface="Calibri" charset="0"/>
-                        <a:cs typeface="Calibri" charset="0"/>
-                      </a:endParaRPr>
-                    </a:p>
-                  </a:txBody>
-                  <a:tcPr marL="91440" marR="91440" marT="36576" marB="36576" anchor="ctr">
-                    <a:lnL w="9525" cap="flat" cmpd="sng" algn="ctr">
-                      <a:solidFill>
-                        <a:srgbClr val="E5E7EB"/>
-                      </a:solidFill>
-                      <a:prstDash val="solid"/>
-                      <a:round/>
-                      <a:headEnd type="none" w="med" len="med"/>
-                      <a:tailEnd type="none" w="med" len="med"/>
-                    </a:lnL>
-                    <a:lnR w="9525" cap="flat" cmpd="sng" algn="ctr">
-                      <a:solidFill>
-                        <a:srgbClr val="E5E7EB"/>
-                      </a:solidFill>
-                      <a:prstDash val="solid"/>
-                      <a:round/>
-                      <a:headEnd type="none" w="med" len="med"/>
-                      <a:tailEnd type="none" w="med" len="med"/>
-                    </a:lnR>
-                    <a:lnT w="9525" cap="flat" cmpd="sng" algn="ctr">
-                      <a:solidFill>
-                        <a:srgbClr val="E5E7EB"/>
-                      </a:solidFill>
-                      <a:prstDash val="solid"/>
-                      <a:round/>
-                      <a:headEnd type="none" w="med" len="med"/>
-                      <a:tailEnd type="none" w="med" len="med"/>
-                    </a:lnT>
-                    <a:lnB w="9525" cap="flat" cmpd="sng" algn="ctr">
-                      <a:solidFill>
-                        <a:srgbClr val="E5E7EB"/>
-                      </a:solidFill>
-                      <a:prstDash val="solid"/>
-                      <a:round/>
-                      <a:headEnd type="none" w="med" len="med"/>
-                      <a:tailEnd type="none" w="med" len="med"/>
-                    </a:lnB>
-                    <a:solidFill>
-                      <a:srgbClr val="FFFFFF"/>
-                    </a:solidFill>
-                  </a:tcPr>
-                </a:tc>
-              </a:tr>
-              <a:tr h="246888">
-                <a:tc>
-                  <a:txBody>
-                    <a:bodyPr/>
-                    <a:lstStyle/>
-                    <a:p>
-                      <a:pPr indent="0" marL="0">
-                        <a:buNone/>
-                      </a:pPr>
-                      <a:r>
-                        <a:rPr lang="en-US" sz="1100" b="1" dirty="0">
-                          <a:solidFill>
-                            <a:srgbClr val="6B7280"/>
-                          </a:solidFill>
-                          <a:latin typeface="Calibri" pitchFamily="34" charset="0"/>
-                          <a:ea typeface="Calibri" pitchFamily="34" charset="-122"/>
-                          <a:cs typeface="Calibri" pitchFamily="34" charset="-120"/>
-                        </a:rPr>
-                        <a:t>IN · agent</a:t>
-                      </a:r>
-                      <a:endParaRPr lang="en-US" sz="1100" dirty="0">
-                        <a:latin typeface="Calibri" charset="0"/>
-                        <a:ea typeface="Calibri" charset="0"/>
-                        <a:cs typeface="Calibri" charset="0"/>
-                      </a:endParaRPr>
-                    </a:p>
-                  </a:txBody>
-                  <a:tcPr marL="91440" marR="91440" marT="36576" marB="36576" anchor="ctr">
-                    <a:lnL w="9525" cap="flat" cmpd="sng" algn="ctr">
-                      <a:solidFill>
-                        <a:srgbClr val="E5E7EB"/>
-                      </a:solidFill>
-                      <a:prstDash val="solid"/>
-                      <a:round/>
-                      <a:headEnd type="none" w="med" len="med"/>
-                      <a:tailEnd type="none" w="med" len="med"/>
-                    </a:lnL>
-                    <a:lnR w="9525" cap="flat" cmpd="sng" algn="ctr">
-                      <a:solidFill>
-                        <a:srgbClr val="E5E7EB"/>
-                      </a:solidFill>
-                      <a:prstDash val="solid"/>
-                      <a:round/>
-                      <a:headEnd type="none" w="med" len="med"/>
-                      <a:tailEnd type="none" w="med" len="med"/>
-                    </a:lnR>
-                    <a:lnT w="9525" cap="flat" cmpd="sng" algn="ctr">
-                      <a:solidFill>
-                        <a:srgbClr val="E5E7EB"/>
-                      </a:solidFill>
-                      <a:prstDash val="solid"/>
-                      <a:round/>
-                      <a:headEnd type="none" w="med" len="med"/>
-                      <a:tailEnd type="none" w="med" len="med"/>
-                    </a:lnT>
-                    <a:lnB w="9525" cap="flat" cmpd="sng" algn="ctr">
-                      <a:solidFill>
-                        <a:srgbClr val="E5E7EB"/>
-                      </a:solidFill>
-                      <a:prstDash val="solid"/>
-                      <a:round/>
-                      <a:headEnd type="none" w="med" len="med"/>
-                      <a:tailEnd type="none" w="med" len="med"/>
-                    </a:lnB>
-                    <a:solidFill>
-                      <a:srgbClr val="F9FAFB"/>
-                    </a:solidFill>
-                  </a:tcPr>
-                </a:tc>
-                <a:tc>
-                  <a:txBody>
-                    <a:bodyPr/>
-                    <a:lstStyle/>
-                    <a:p>
-                      <a:pPr algn="r" indent="0" marL="0">
-                        <a:buNone/>
-                      </a:pPr>
-                      <a:r>
-                        <a:rPr lang="en-US" sz="1100" b="1" dirty="0">
-                          <a:solidFill>
-                            <a:srgbClr val="D97706"/>
-                          </a:solidFill>
-                          <a:latin typeface="Calibri" pitchFamily="34" charset="0"/>
-                          <a:ea typeface="Calibri" pitchFamily="34" charset="-122"/>
-                          <a:cs typeface="Calibri" pitchFamily="34" charset="-120"/>
-                        </a:rPr>
-                        <a:t>TBC</a:t>
-                      </a:r>
-                      <a:endParaRPr lang="en-US" sz="1100" dirty="0">
-                        <a:latin typeface="Calibri" charset="0"/>
-                        <a:ea typeface="Calibri" charset="0"/>
-                        <a:cs typeface="Calibri" charset="0"/>
-                      </a:endParaRPr>
-                    </a:p>
-                  </a:txBody>
-                  <a:tcPr marL="91440" marR="91440" marT="36576" marB="36576" anchor="ctr">
-                    <a:lnL w="9525" cap="flat" cmpd="sng" algn="ctr">
-                      <a:solidFill>
-                        <a:srgbClr val="E5E7EB"/>
-                      </a:solidFill>
-                      <a:prstDash val="solid"/>
-                      <a:round/>
-                      <a:headEnd type="none" w="med" len="med"/>
-                      <a:tailEnd type="none" w="med" len="med"/>
-                    </a:lnL>
-                    <a:lnR w="9525" cap="flat" cmpd="sng" algn="ctr">
-                      <a:solidFill>
-                        <a:srgbClr val="E5E7EB"/>
-                      </a:solidFill>
-                      <a:prstDash val="solid"/>
-                      <a:round/>
-                      <a:headEnd type="none" w="med" len="med"/>
-                      <a:tailEnd type="none" w="med" len="med"/>
-                    </a:lnR>
-                    <a:lnT w="9525" cap="flat" cmpd="sng" algn="ctr">
-                      <a:solidFill>
-                        <a:srgbClr val="E5E7EB"/>
-                      </a:solidFill>
-                      <a:prstDash val="solid"/>
-                      <a:round/>
-                      <a:headEnd type="none" w="med" len="med"/>
-                      <a:tailEnd type="none" w="med" len="med"/>
-                    </a:lnT>
-                    <a:lnB w="9525" cap="flat" cmpd="sng" algn="ctr">
-                      <a:solidFill>
-                        <a:srgbClr val="E5E7EB"/>
-                      </a:solidFill>
-                      <a:prstDash val="solid"/>
-                      <a:round/>
-                      <a:headEnd type="none" w="med" len="med"/>
-                      <a:tailEnd type="none" w="med" len="med"/>
-                    </a:lnB>
-                    <a:solidFill>
-                      <a:srgbClr val="F9FAFB"/>
-                    </a:solidFill>
-                  </a:tcPr>
-                </a:tc>
-                <a:tc>
-                  <a:txBody>
-                    <a:bodyPr/>
-                    <a:lstStyle/>
-                    <a:p>
-                      <a:pPr algn="r" indent="0" marL="0">
-                        <a:buNone/>
-                      </a:pPr>
-                      <a:r>
-                        <a:rPr lang="en-US" sz="1100" b="1" dirty="0">
-                          <a:solidFill>
-                            <a:srgbClr val="D97706"/>
-                          </a:solidFill>
-                          <a:latin typeface="Calibri" pitchFamily="34" charset="0"/>
-                          <a:ea typeface="Calibri" pitchFamily="34" charset="-122"/>
-                          <a:cs typeface="Calibri" pitchFamily="34" charset="-120"/>
-                        </a:rPr>
-                        <a:t>TBC</a:t>
-                      </a:r>
-                      <a:endParaRPr lang="en-US" sz="1100" dirty="0">
-                        <a:latin typeface="Calibri" charset="0"/>
-                        <a:ea typeface="Calibri" charset="0"/>
-                        <a:cs typeface="Calibri" charset="0"/>
-                      </a:endParaRPr>
-                    </a:p>
-                  </a:txBody>
-                  <a:tcPr marL="91440" marR="91440" marT="36576" marB="36576" anchor="ctr">
-                    <a:lnL w="9525" cap="flat" cmpd="sng" algn="ctr">
-                      <a:solidFill>
-                        <a:srgbClr val="E5E7EB"/>
-                      </a:solidFill>
-                      <a:prstDash val="solid"/>
-                      <a:round/>
-                      <a:headEnd type="none" w="med" len="med"/>
-                      <a:tailEnd type="none" w="med" len="med"/>
-                    </a:lnL>
-                    <a:lnR w="9525" cap="flat" cmpd="sng" algn="ctr">
-                      <a:solidFill>
-                        <a:srgbClr val="E5E7EB"/>
-                      </a:solidFill>
-                      <a:prstDash val="solid"/>
-                      <a:round/>
-                      <a:headEnd type="none" w="med" len="med"/>
-                      <a:tailEnd type="none" w="med" len="med"/>
-                    </a:lnR>
-                    <a:lnT w="9525" cap="flat" cmpd="sng" algn="ctr">
-                      <a:solidFill>
-                        <a:srgbClr val="E5E7EB"/>
-                      </a:solidFill>
-                      <a:prstDash val="solid"/>
-                      <a:round/>
-                      <a:headEnd type="none" w="med" len="med"/>
-                      <a:tailEnd type="none" w="med" len="med"/>
-                    </a:lnT>
-                    <a:lnB w="9525" cap="flat" cmpd="sng" algn="ctr">
-                      <a:solidFill>
-                        <a:srgbClr val="E5E7EB"/>
-                      </a:solidFill>
-                      <a:prstDash val="solid"/>
-                      <a:round/>
-                      <a:headEnd type="none" w="med" len="med"/>
-                      <a:tailEnd type="none" w="med" len="med"/>
-                    </a:lnB>
-                    <a:solidFill>
-                      <a:srgbClr val="F9FAFB"/>
-                    </a:solidFill>
-                  </a:tcPr>
-                </a:tc>
-              </a:tr>
-              <a:tr h="246888">
-                <a:tc>
-                  <a:txBody>
-                    <a:bodyPr/>
-                    <a:lstStyle/>
-                    <a:p>
-                      <a:pPr indent="0" marL="0">
-                        <a:buNone/>
-                      </a:pPr>
-                      <a:r>
-                        <a:rPr lang="en-US" sz="1100" b="1" dirty="0">
-                          <a:solidFill>
-                            <a:srgbClr val="6B7280"/>
-                          </a:solidFill>
-                          <a:latin typeface="Calibri" pitchFamily="34" charset="0"/>
-                          <a:ea typeface="Calibri" pitchFamily="34" charset="-122"/>
-                          <a:cs typeface="Calibri" pitchFamily="34" charset="-120"/>
-                        </a:rPr>
-                        <a:t>TB · transborder</a:t>
-                      </a:r>
-                      <a:endParaRPr lang="en-US" sz="1100" dirty="0">
-                        <a:latin typeface="Calibri" charset="0"/>
-                        <a:ea typeface="Calibri" charset="0"/>
-                        <a:cs typeface="Calibri" charset="0"/>
-                      </a:endParaRPr>
-                    </a:p>
-                  </a:txBody>
-                  <a:tcPr marL="91440" marR="91440" marT="36576" marB="36576" anchor="ctr">
-                    <a:lnL w="9525" cap="flat" cmpd="sng" algn="ctr">
-                      <a:solidFill>
-                        <a:srgbClr val="E5E7EB"/>
-                      </a:solidFill>
-                      <a:prstDash val="solid"/>
-                      <a:round/>
-                      <a:headEnd type="none" w="med" len="med"/>
-                      <a:tailEnd type="none" w="med" len="med"/>
-                    </a:lnL>
-                    <a:lnR w="9525" cap="flat" cmpd="sng" algn="ctr">
-                      <a:solidFill>
-                        <a:srgbClr val="E5E7EB"/>
-                      </a:solidFill>
-                      <a:prstDash val="solid"/>
-                      <a:round/>
-                      <a:headEnd type="none" w="med" len="med"/>
-                      <a:tailEnd type="none" w="med" len="med"/>
-                    </a:lnR>
-                    <a:lnT w="9525" cap="flat" cmpd="sng" algn="ctr">
-                      <a:solidFill>
-                        <a:srgbClr val="E5E7EB"/>
-                      </a:solidFill>
-                      <a:prstDash val="solid"/>
-                      <a:round/>
-                      <a:headEnd type="none" w="med" len="med"/>
-                      <a:tailEnd type="none" w="med" len="med"/>
-                    </a:lnT>
-                    <a:lnB w="9525" cap="flat" cmpd="sng" algn="ctr">
-                      <a:solidFill>
-                        <a:srgbClr val="E5E7EB"/>
-                      </a:solidFill>
-                      <a:prstDash val="solid"/>
-                      <a:round/>
-                      <a:headEnd type="none" w="med" len="med"/>
-                      <a:tailEnd type="none" w="med" len="med"/>
-                    </a:lnB>
-                    <a:solidFill>
-                      <a:srgbClr val="FFFFFF"/>
-                    </a:solidFill>
-                  </a:tcPr>
-                </a:tc>
-                <a:tc>
-                  <a:txBody>
-                    <a:bodyPr/>
-                    <a:lstStyle/>
-                    <a:p>
-                      <a:pPr algn="r" indent="0" marL="0">
-                        <a:buNone/>
-                      </a:pPr>
-                      <a:r>
-                        <a:rPr lang="en-US" sz="1100" b="1" dirty="0">
-                          <a:solidFill>
-                            <a:srgbClr val="D97706"/>
-                          </a:solidFill>
-                          <a:latin typeface="Calibri" pitchFamily="34" charset="0"/>
-                          <a:ea typeface="Calibri" pitchFamily="34" charset="-122"/>
-                          <a:cs typeface="Calibri" pitchFamily="34" charset="-120"/>
-                        </a:rPr>
-                        <a:t>TBC</a:t>
-                      </a:r>
-                      <a:endParaRPr lang="en-US" sz="1100" dirty="0">
-                        <a:latin typeface="Calibri" charset="0"/>
-                        <a:ea typeface="Calibri" charset="0"/>
-                        <a:cs typeface="Calibri" charset="0"/>
-                      </a:endParaRPr>
-                    </a:p>
-                  </a:txBody>
-                  <a:tcPr marL="91440" marR="91440" marT="36576" marB="36576" anchor="ctr">
-                    <a:lnL w="9525" cap="flat" cmpd="sng" algn="ctr">
-                      <a:solidFill>
-                        <a:srgbClr val="E5E7EB"/>
-                      </a:solidFill>
-                      <a:prstDash val="solid"/>
-                      <a:round/>
-                      <a:headEnd type="none" w="med" len="med"/>
-                      <a:tailEnd type="none" w="med" len="med"/>
-                    </a:lnL>
-                    <a:lnR w="9525" cap="flat" cmpd="sng" algn="ctr">
-                      <a:solidFill>
-                        <a:srgbClr val="E5E7EB"/>
-                      </a:solidFill>
-                      <a:prstDash val="solid"/>
-                      <a:round/>
-                      <a:headEnd type="none" w="med" len="med"/>
-                      <a:tailEnd type="none" w="med" len="med"/>
-                    </a:lnR>
-                    <a:lnT w="9525" cap="flat" cmpd="sng" algn="ctr">
-                      <a:solidFill>
-                        <a:srgbClr val="E5E7EB"/>
-                      </a:solidFill>
-                      <a:prstDash val="solid"/>
-                      <a:round/>
-                      <a:headEnd type="none" w="med" len="med"/>
-                      <a:tailEnd type="none" w="med" len="med"/>
-                    </a:lnT>
-                    <a:lnB w="9525" cap="flat" cmpd="sng" algn="ctr">
-                      <a:solidFill>
-                        <a:srgbClr val="E5E7EB"/>
-                      </a:solidFill>
-                      <a:prstDash val="solid"/>
-                      <a:round/>
-                      <a:headEnd type="none" w="med" len="med"/>
-                      <a:tailEnd type="none" w="med" len="med"/>
-                    </a:lnB>
-                    <a:solidFill>
-                      <a:srgbClr val="FFFFFF"/>
-                    </a:solidFill>
-                  </a:tcPr>
-                </a:tc>
-                <a:tc>
-                  <a:txBody>
-                    <a:bodyPr/>
-                    <a:lstStyle/>
-                    <a:p>
-                      <a:pPr algn="r" indent="0" marL="0">
-                        <a:buNone/>
-                      </a:pPr>
-                      <a:r>
-                        <a:rPr lang="en-US" sz="1100" b="1" dirty="0">
-                          <a:solidFill>
-                            <a:srgbClr val="D97706"/>
-                          </a:solidFill>
-                          <a:latin typeface="Calibri" pitchFamily="34" charset="0"/>
-                          <a:ea typeface="Calibri" pitchFamily="34" charset="-122"/>
-                          <a:cs typeface="Calibri" pitchFamily="34" charset="-120"/>
-                        </a:rPr>
-                        <a:t>TBC</a:t>
-                      </a:r>
-                      <a:endParaRPr lang="en-US" sz="1100" dirty="0">
-                        <a:latin typeface="Calibri" charset="0"/>
-                        <a:ea typeface="Calibri" charset="0"/>
-                        <a:cs typeface="Calibri" charset="0"/>
-                      </a:endParaRPr>
-                    </a:p>
-                  </a:txBody>
-                  <a:tcPr marL="91440" marR="91440" marT="36576" marB="36576" anchor="ctr">
-                    <a:lnL w="9525" cap="flat" cmpd="sng" algn="ctr">
-                      <a:solidFill>
-                        <a:srgbClr val="E5E7EB"/>
-                      </a:solidFill>
-                      <a:prstDash val="solid"/>
-                      <a:round/>
-                      <a:headEnd type="none" w="med" len="med"/>
-                      <a:tailEnd type="none" w="med" len="med"/>
-                    </a:lnL>
-                    <a:lnR w="9525" cap="flat" cmpd="sng" algn="ctr">
-                      <a:solidFill>
-                        <a:srgbClr val="E5E7EB"/>
-                      </a:solidFill>
-                      <a:prstDash val="solid"/>
-                      <a:round/>
-                      <a:headEnd type="none" w="med" len="med"/>
-                      <a:tailEnd type="none" w="med" len="med"/>
-                    </a:lnR>
-                    <a:lnT w="9525" cap="flat" cmpd="sng" algn="ctr">
-                      <a:solidFill>
-                        <a:srgbClr val="E5E7EB"/>
-                      </a:solidFill>
-                      <a:prstDash val="solid"/>
-                      <a:round/>
-                      <a:headEnd type="none" w="med" len="med"/>
-                      <a:tailEnd type="none" w="med" len="med"/>
-                    </a:lnT>
-                    <a:lnB w="9525" cap="flat" cmpd="sng" algn="ctr">
-                      <a:solidFill>
-                        <a:srgbClr val="E5E7EB"/>
-                      </a:solidFill>
-                      <a:prstDash val="solid"/>
-                      <a:round/>
-                      <a:headEnd type="none" w="med" len="med"/>
-                      <a:tailEnd type="none" w="med" len="med"/>
-                    </a:lnB>
-                    <a:solidFill>
-                      <a:srgbClr val="FFFFFF"/>
-                    </a:solidFill>
-                  </a:tcPr>
-                </a:tc>
-              </a:tr>
-              <a:tr h="246888">
-                <a:tc>
-                  <a:txBody>
-                    <a:bodyPr/>
-                    <a:lstStyle/>
-                    <a:p>
-                      <a:pPr indent="0" marL="0">
-                        <a:buNone/>
-                      </a:pPr>
-                      <a:r>
-                        <a:rPr lang="en-US" sz="1100" b="1" dirty="0">
-                          <a:solidFill>
-                            <a:srgbClr val="111827"/>
-                          </a:solidFill>
-                          <a:latin typeface="Calibri" pitchFamily="34" charset="0"/>
-                          <a:ea typeface="Calibri" pitchFamily="34" charset="-122"/>
-                          <a:cs typeface="Calibri" pitchFamily="34" charset="-120"/>
-                        </a:rPr>
-                        <a:t>OTHER</a:t>
-                      </a:r>
-                      <a:endParaRPr lang="en-US" sz="1100" dirty="0">
-                        <a:latin typeface="Calibri" charset="0"/>
-                        <a:ea typeface="Calibri" charset="0"/>
-                        <a:cs typeface="Calibri" charset="0"/>
-                      </a:endParaRPr>
-                    </a:p>
-                  </a:txBody>
-                  <a:tcPr marL="91440" marR="91440" marT="36576" marB="36576" anchor="ctr">
-                    <a:lnL w="9525" cap="flat" cmpd="sng" algn="ctr">
-                      <a:solidFill>
-                        <a:srgbClr val="E5E7EB"/>
-                      </a:solidFill>
-                      <a:prstDash val="solid"/>
-                      <a:round/>
-                      <a:headEnd type="none" w="med" len="med"/>
-                      <a:tailEnd type="none" w="med" len="med"/>
-                    </a:lnL>
-                    <a:lnR w="9525" cap="flat" cmpd="sng" algn="ctr">
-                      <a:solidFill>
-                        <a:srgbClr val="E5E7EB"/>
-                      </a:solidFill>
-                      <a:prstDash val="solid"/>
-                      <a:round/>
-                      <a:headEnd type="none" w="med" len="med"/>
-                      <a:tailEnd type="none" w="med" len="med"/>
-                    </a:lnR>
-                    <a:lnT w="9525" cap="flat" cmpd="sng" algn="ctr">
-                      <a:solidFill>
-                        <a:srgbClr val="E5E7EB"/>
-                      </a:solidFill>
-                      <a:prstDash val="solid"/>
-                      <a:round/>
-                      <a:headEnd type="none" w="med" len="med"/>
-                      <a:tailEnd type="none" w="med" len="med"/>
-                    </a:lnT>
-                    <a:lnB w="9525" cap="flat" cmpd="sng" algn="ctr">
-                      <a:solidFill>
-                        <a:srgbClr val="E5E7EB"/>
-                      </a:solidFill>
-                      <a:prstDash val="solid"/>
-                      <a:round/>
-                      <a:headEnd type="none" w="med" len="med"/>
-                      <a:tailEnd type="none" w="med" len="med"/>
-                    </a:lnB>
-                    <a:solidFill>
-                      <a:srgbClr val="F9FAFB"/>
-                    </a:solidFill>
-                  </a:tcPr>
-                </a:tc>
-                <a:tc>
-                  <a:txBody>
-                    <a:bodyPr/>
-                    <a:lstStyle/>
-                    <a:p>
-                      <a:pPr algn="r" indent="0" marL="0">
-                        <a:buNone/>
-                      </a:pPr>
-                      <a:r>
-                        <a:rPr lang="en-US" sz="1100" b="1" dirty="0">
-                          <a:solidFill>
-                            <a:srgbClr val="D97706"/>
-                          </a:solidFill>
-                          <a:latin typeface="Calibri" pitchFamily="34" charset="0"/>
-                          <a:ea typeface="Calibri" pitchFamily="34" charset="-122"/>
-                          <a:cs typeface="Calibri" pitchFamily="34" charset="-120"/>
-                        </a:rPr>
-                        <a:t>TBC</a:t>
-                      </a:r>
-                      <a:endParaRPr lang="en-US" sz="1100" dirty="0">
-                        <a:latin typeface="Calibri" charset="0"/>
-                        <a:ea typeface="Calibri" charset="0"/>
-                        <a:cs typeface="Calibri" charset="0"/>
-                      </a:endParaRPr>
-                    </a:p>
-                  </a:txBody>
-                  <a:tcPr marL="91440" marR="91440" marT="36576" marB="36576" anchor="ctr">
-                    <a:lnL w="9525" cap="flat" cmpd="sng" algn="ctr">
-                      <a:solidFill>
-                        <a:srgbClr val="E5E7EB"/>
-                      </a:solidFill>
-                      <a:prstDash val="solid"/>
-                      <a:round/>
-                      <a:headEnd type="none" w="med" len="med"/>
-                      <a:tailEnd type="none" w="med" len="med"/>
-                    </a:lnL>
-                    <a:lnR w="9525" cap="flat" cmpd="sng" algn="ctr">
-                      <a:solidFill>
-                        <a:srgbClr val="E5E7EB"/>
-                      </a:solidFill>
-                      <a:prstDash val="solid"/>
-                      <a:round/>
-                      <a:headEnd type="none" w="med" len="med"/>
-                      <a:tailEnd type="none" w="med" len="med"/>
-                    </a:lnR>
-                    <a:lnT w="9525" cap="flat" cmpd="sng" algn="ctr">
-                      <a:solidFill>
-                        <a:srgbClr val="E5E7EB"/>
-                      </a:solidFill>
-                      <a:prstDash val="solid"/>
-                      <a:round/>
-                      <a:headEnd type="none" w="med" len="med"/>
-                      <a:tailEnd type="none" w="med" len="med"/>
-                    </a:lnT>
-                    <a:lnB w="9525" cap="flat" cmpd="sng" algn="ctr">
-                      <a:solidFill>
-                        <a:srgbClr val="E5E7EB"/>
-                      </a:solidFill>
-                      <a:prstDash val="solid"/>
-                      <a:round/>
-                      <a:headEnd type="none" w="med" len="med"/>
-                      <a:tailEnd type="none" w="med" len="med"/>
-                    </a:lnB>
-                    <a:solidFill>
-                      <a:srgbClr val="F9FAFB"/>
-                    </a:solidFill>
-                  </a:tcPr>
-                </a:tc>
-                <a:tc>
-                  <a:txBody>
-                    <a:bodyPr/>
-                    <a:lstStyle/>
-                    <a:p>
-                      <a:pPr algn="r" indent="0" marL="0">
-                        <a:buNone/>
-                      </a:pPr>
-                      <a:r>
-                        <a:rPr lang="en-US" sz="1100" b="1" dirty="0">
-                          <a:solidFill>
-                            <a:srgbClr val="D97706"/>
-                          </a:solidFill>
-                          <a:latin typeface="Calibri" pitchFamily="34" charset="0"/>
-                          <a:ea typeface="Calibri" pitchFamily="34" charset="-122"/>
-                          <a:cs typeface="Calibri" pitchFamily="34" charset="-120"/>
-                        </a:rPr>
-                        <a:t>TBC</a:t>
-                      </a:r>
-                      <a:endParaRPr lang="en-US" sz="1100" dirty="0">
-                        <a:latin typeface="Calibri" charset="0"/>
-                        <a:ea typeface="Calibri" charset="0"/>
-                        <a:cs typeface="Calibri" charset="0"/>
-                      </a:endParaRPr>
-                    </a:p>
-                  </a:txBody>
-                  <a:tcPr marL="91440" marR="91440" marT="36576" marB="36576" anchor="ctr">
-                    <a:lnL w="9525" cap="flat" cmpd="sng" algn="ctr">
-                      <a:solidFill>
-                        <a:srgbClr val="E5E7EB"/>
-                      </a:solidFill>
-                      <a:prstDash val="solid"/>
-                      <a:round/>
-                      <a:headEnd type="none" w="med" len="med"/>
-                      <a:tailEnd type="none" w="med" len="med"/>
-                    </a:lnL>
-                    <a:lnR w="9525" cap="flat" cmpd="sng" algn="ctr">
-                      <a:solidFill>
-                        <a:srgbClr val="E5E7EB"/>
-                      </a:solidFill>
-                      <a:prstDash val="solid"/>
-                      <a:round/>
-                      <a:headEnd type="none" w="med" len="med"/>
-                      <a:tailEnd type="none" w="med" len="med"/>
-                    </a:lnR>
-                    <a:lnT w="9525" cap="flat" cmpd="sng" algn="ctr">
-                      <a:solidFill>
-                        <a:srgbClr val="E5E7EB"/>
-                      </a:solidFill>
-                      <a:prstDash val="solid"/>
-                      <a:round/>
-                      <a:headEnd type="none" w="med" len="med"/>
-                      <a:tailEnd type="none" w="med" len="med"/>
-                    </a:lnT>
-                    <a:lnB w="9525" cap="flat" cmpd="sng" algn="ctr">
-                      <a:solidFill>
-                        <a:srgbClr val="E5E7EB"/>
-                      </a:solidFill>
-                      <a:prstDash val="solid"/>
-                      <a:round/>
-                      <a:headEnd type="none" w="med" len="med"/>
-                      <a:tailEnd type="none" w="med" len="med"/>
-                    </a:lnB>
-                    <a:solidFill>
-                      <a:srgbClr val="F9FAFB"/>
-                    </a:solidFill>
-                  </a:tcPr>
-                </a:tc>
-              </a:tr>
-              <a:tr h="246888">
-                <a:tc>
-                  <a:txBody>
-                    <a:bodyPr/>
-                    <a:lstStyle/>
-                    <a:p>
-                      <a:pPr indent="0" marL="0">
-                        <a:buNone/>
-                      </a:pPr>
-                      <a:r>
-                        <a:rPr lang="en-US" sz="1100" b="1" dirty="0">
-                          <a:solidFill>
-                            <a:srgbClr val="111827"/>
-                          </a:solidFill>
-                          <a:latin typeface="Calibri" pitchFamily="34" charset="0"/>
-                          <a:ea typeface="Calibri" pitchFamily="34" charset="-122"/>
-                          <a:cs typeface="Calibri" pitchFamily="34" charset="-120"/>
-                        </a:rPr>
-                        <a:t>UNCODED</a:t>
-                      </a:r>
-                      <a:endParaRPr lang="en-US" sz="1100" dirty="0">
-                        <a:latin typeface="Calibri" charset="0"/>
-                        <a:ea typeface="Calibri" charset="0"/>
-                        <a:cs typeface="Calibri" charset="0"/>
-                      </a:endParaRPr>
-                    </a:p>
-                  </a:txBody>
-                  <a:tcPr marL="91440" marR="91440" marT="36576" marB="36576" anchor="ctr">
-                    <a:lnL w="9525" cap="flat" cmpd="sng" algn="ctr">
-                      <a:solidFill>
-                        <a:srgbClr val="E5E7EB"/>
-                      </a:solidFill>
-                      <a:prstDash val="solid"/>
-                      <a:round/>
-                      <a:headEnd type="none" w="med" len="med"/>
-                      <a:tailEnd type="none" w="med" len="med"/>
-                    </a:lnL>
-                    <a:lnR w="9525" cap="flat" cmpd="sng" algn="ctr">
-                      <a:solidFill>
-                        <a:srgbClr val="E5E7EB"/>
-                      </a:solidFill>
-                      <a:prstDash val="solid"/>
-                      <a:round/>
-                      <a:headEnd type="none" w="med" len="med"/>
-                      <a:tailEnd type="none" w="med" len="med"/>
-                    </a:lnR>
-                    <a:lnT w="9525" cap="flat" cmpd="sng" algn="ctr">
-                      <a:solidFill>
-                        <a:srgbClr val="E5E7EB"/>
-                      </a:solidFill>
-                      <a:prstDash val="solid"/>
-                      <a:round/>
-                      <a:headEnd type="none" w="med" len="med"/>
-                      <a:tailEnd type="none" w="med" len="med"/>
-                    </a:lnT>
-                    <a:lnB w="9525" cap="flat" cmpd="sng" algn="ctr">
-                      <a:solidFill>
-                        <a:srgbClr val="E5E7EB"/>
-                      </a:solidFill>
-                      <a:prstDash val="solid"/>
-                      <a:round/>
-                      <a:headEnd type="none" w="med" len="med"/>
-                      <a:tailEnd type="none" w="med" len="med"/>
-                    </a:lnB>
-                    <a:solidFill>
-                      <a:srgbClr val="FFFFFF"/>
-                    </a:solidFill>
-                  </a:tcPr>
-                </a:tc>
-                <a:tc>
-                  <a:txBody>
-                    <a:bodyPr/>
-                    <a:lstStyle/>
-                    <a:p>
-                      <a:pPr algn="r" indent="0" marL="0">
-                        <a:buNone/>
-                      </a:pPr>
-                      <a:r>
-                        <a:rPr lang="en-US" sz="1100" b="1" dirty="0">
-                          <a:solidFill>
-                            <a:srgbClr val="D97706"/>
-                          </a:solidFill>
-                          <a:latin typeface="Calibri" pitchFamily="34" charset="0"/>
-                          <a:ea typeface="Calibri" pitchFamily="34" charset="-122"/>
-                          <a:cs typeface="Calibri" pitchFamily="34" charset="-120"/>
-                        </a:rPr>
-                        <a:t>TBC</a:t>
-                      </a:r>
-                      <a:endParaRPr lang="en-US" sz="1100" dirty="0">
-                        <a:latin typeface="Calibri" charset="0"/>
-                        <a:ea typeface="Calibri" charset="0"/>
-                        <a:cs typeface="Calibri" charset="0"/>
-                      </a:endParaRPr>
-                    </a:p>
-                  </a:txBody>
-                  <a:tcPr marL="91440" marR="91440" marT="36576" marB="36576" anchor="ctr">
-                    <a:lnL w="9525" cap="flat" cmpd="sng" algn="ctr">
-                      <a:solidFill>
-                        <a:srgbClr val="E5E7EB"/>
-                      </a:solidFill>
-                      <a:prstDash val="solid"/>
-                      <a:round/>
-                      <a:headEnd type="none" w="med" len="med"/>
-                      <a:tailEnd type="none" w="med" len="med"/>
-                    </a:lnL>
-                    <a:lnR w="9525" cap="flat" cmpd="sng" algn="ctr">
-                      <a:solidFill>
-                        <a:srgbClr val="E5E7EB"/>
-                      </a:solidFill>
-                      <a:prstDash val="solid"/>
-                      <a:round/>
-                      <a:headEnd type="none" w="med" len="med"/>
-                      <a:tailEnd type="none" w="med" len="med"/>
-                    </a:lnR>
-                    <a:lnT w="9525" cap="flat" cmpd="sng" algn="ctr">
-                      <a:solidFill>
-                        <a:srgbClr val="E5E7EB"/>
-                      </a:solidFill>
-                      <a:prstDash val="solid"/>
-                      <a:round/>
-                      <a:headEnd type="none" w="med" len="med"/>
-                      <a:tailEnd type="none" w="med" len="med"/>
-                    </a:lnT>
-                    <a:lnB w="9525" cap="flat" cmpd="sng" algn="ctr">
-                      <a:solidFill>
-                        <a:srgbClr val="E5E7EB"/>
-                      </a:solidFill>
-                      <a:prstDash val="solid"/>
-                      <a:round/>
-                      <a:headEnd type="none" w="med" len="med"/>
-                      <a:tailEnd type="none" w="med" len="med"/>
-                    </a:lnB>
-                    <a:solidFill>
-                      <a:srgbClr val="FFFFFF"/>
-                    </a:solidFill>
-                  </a:tcPr>
-                </a:tc>
-                <a:tc>
-                  <a:txBody>
-                    <a:bodyPr/>
-                    <a:lstStyle/>
-                    <a:p>
-                      <a:pPr algn="r" indent="0" marL="0">
-                        <a:buNone/>
-                      </a:pPr>
-                      <a:r>
-                        <a:rPr lang="en-US" sz="1100" b="1" dirty="0">
-                          <a:solidFill>
-                            <a:srgbClr val="D97706"/>
-                          </a:solidFill>
-                          <a:latin typeface="Calibri" pitchFamily="34" charset="0"/>
-                          <a:ea typeface="Calibri" pitchFamily="34" charset="-122"/>
-                          <a:cs typeface="Calibri" pitchFamily="34" charset="-120"/>
-                        </a:rPr>
-                        <a:t>TBC</a:t>
-                      </a:r>
-                      <a:endParaRPr lang="en-US" sz="1100" dirty="0">
-                        <a:latin typeface="Calibri" charset="0"/>
-                        <a:ea typeface="Calibri" charset="0"/>
-                        <a:cs typeface="Calibri" charset="0"/>
-                      </a:endParaRPr>
-                    </a:p>
-                  </a:txBody>
-                  <a:tcPr marL="91440" marR="91440" marT="36576" marB="36576" anchor="ctr">
-                    <a:lnL w="9525" cap="flat" cmpd="sng" algn="ctr">
-                      <a:solidFill>
-                        <a:srgbClr val="E5E7EB"/>
-                      </a:solidFill>
-                      <a:prstDash val="solid"/>
-                      <a:round/>
-                      <a:headEnd type="none" w="med" len="med"/>
-                      <a:tailEnd type="none" w="med" len="med"/>
-                    </a:lnL>
-                    <a:lnR w="9525" cap="flat" cmpd="sng" algn="ctr">
-                      <a:solidFill>
-                        <a:srgbClr val="E5E7EB"/>
-                      </a:solidFill>
-                      <a:prstDash val="solid"/>
-                      <a:round/>
-                      <a:headEnd type="none" w="med" len="med"/>
-                      <a:tailEnd type="none" w="med" len="med"/>
-                    </a:lnR>
-                    <a:lnT w="9525" cap="flat" cmpd="sng" algn="ctr">
-                      <a:solidFill>
-                        <a:srgbClr val="E5E7EB"/>
-                      </a:solidFill>
-                      <a:prstDash val="solid"/>
-                      <a:round/>
-                      <a:headEnd type="none" w="med" len="med"/>
-                      <a:tailEnd type="none" w="med" len="med"/>
-                    </a:lnT>
-                    <a:lnB w="9525" cap="flat" cmpd="sng" algn="ctr">
-                      <a:solidFill>
-                        <a:srgbClr val="E5E7EB"/>
-                      </a:solidFill>
-                      <a:prstDash val="solid"/>
-                      <a:round/>
-                      <a:headEnd type="none" w="med" len="med"/>
-                      <a:tailEnd type="none" w="med" len="med"/>
-                    </a:lnB>
-                    <a:solidFill>
-                      <a:srgbClr val="FFFFFF"/>
-                    </a:solidFill>
-                  </a:tcPr>
-                </a:tc>
-              </a:tr>
-            </a:tbl>
-          </a:graphicData>
-        </a:graphic>
-      </p:graphicFrame>
-      <p:sp>
-        <p:nvSpPr>
-          <p:cNvPr id="26" name="Shape 23"/>
+          <p:cNvPr id="31" name="Shape 27"/>
           <p:cNvSpPr/>
           <p:nvPr/>
         </p:nvSpPr>
         <p:spPr>
           <a:xfrm>
-            <a:off x="4572000" y="2788920"/>
-            <a:ext cx="7068312" cy="3429000"/>
+            <a:off x="6720840" y="4133088"/>
+            <a:ext cx="4919472" cy="1874520"/>
           </a:xfrm>
           <a:prstGeom prst="roundRect">
             <a:avLst>
-              <a:gd name="adj" fmla="val 2133"/>
+              <a:gd name="adj" fmla="val 3902"/>
             </a:avLst>
           </a:prstGeom>
           <a:solidFill>
@@ -30460,63 +28869,14 @@
       </p:sp>
       <p:sp>
         <p:nvSpPr>
-          <p:cNvPr id="27" name="Shape 24"/>
-          <p:cNvSpPr/>
-          <p:nvPr/>
-        </p:nvSpPr>
-        <p:spPr>
-          <a:xfrm>
-            <a:off x="4800600" y="2971800"/>
-            <a:ext cx="457200" cy="457200"/>
-          </a:xfrm>
-          <a:prstGeom prst="ellipse">
-            <a:avLst/>
-          </a:prstGeom>
-          <a:solidFill>
-            <a:srgbClr val="EDE9FE"/>
-          </a:solidFill>
-          <a:ln w="12700">
-            <a:solidFill>
-              <a:srgbClr val="EDE9FE"/>
-            </a:solidFill>
-            <a:prstDash val="solid"/>
-          </a:ln>
-        </p:spPr>
-      </p:sp>
-      <p:pic>
-        <p:nvPicPr>
-          <p:cNvPr id="28" name="Image 0" descr="preencoded.png">    </p:cNvPr>
-          <p:cNvPicPr>
-            <a:picLocks noChangeAspect="1"/>
-          </p:cNvPicPr>
-          <p:nvPr/>
-        </p:nvPicPr>
-        <p:blipFill>
-          <a:blip r:embed="rId1"/>
-          <a:stretch>
-            <a:fillRect/>
-          </a:stretch>
-        </p:blipFill>
-        <p:spPr>
-          <a:xfrm>
-            <a:off x="4914900" y="3086100"/>
-            <a:ext cx="228600" cy="228600"/>
-          </a:xfrm>
-          <a:prstGeom prst="rect">
-            <a:avLst/>
-          </a:prstGeom>
-        </p:spPr>
-      </p:pic>
-      <p:sp>
-        <p:nvSpPr>
-          <p:cNvPr id="29" name="Text 25"/>
-          <p:cNvSpPr txBox="1"/>
-          <p:nvPr/>
-        </p:nvSpPr>
-        <p:spPr>
-          <a:xfrm>
-            <a:off x="5394960" y="3017520"/>
-            <a:ext cx="5943600" cy="365760"/>
+          <p:cNvPr id="32" name="Text 28"/>
+          <p:cNvSpPr txBox="1"/>
+          <p:nvPr/>
+        </p:nvSpPr>
+        <p:spPr>
+          <a:xfrm>
+            <a:off x="6903720" y="4215384"/>
+            <a:ext cx="4572000" cy="274320"/>
           </a:xfrm>
           <a:prstGeom prst="rect">
             <a:avLst/>
@@ -30532,7 +28892,7 @@
               <a:buNone/>
             </a:pPr>
             <a:r>
-              <a:rPr lang="en-US" sz="1800" b="1" dirty="0">
+              <a:rPr lang="en-US" sz="1300" b="1" dirty="0">
                 <a:solidFill>
                   <a:srgbClr val="111827"/>
                 </a:solidFill>
@@ -30542,20 +28902,20 @@
               </a:rPr>
               <a:t>What we are doing</a:t>
             </a:r>
-            <a:endParaRPr lang="en-US" sz="1800" dirty="0"/>
-          </a:p>
-        </p:txBody>
-      </p:sp>
-      <p:sp>
-        <p:nvSpPr>
-          <p:cNvPr id="30" name="Text 26"/>
-          <p:cNvSpPr txBox="1"/>
-          <p:nvPr/>
-        </p:nvSpPr>
-        <p:spPr>
-          <a:xfrm>
-            <a:off x="4846320" y="3566160"/>
-            <a:ext cx="6583680" cy="1874520"/>
+            <a:endParaRPr lang="en-US" sz="1300" dirty="0"/>
+          </a:p>
+        </p:txBody>
+      </p:sp>
+      <p:sp>
+        <p:nvSpPr>
+          <p:cNvPr id="33" name="Text 29"/>
+          <p:cNvSpPr txBox="1"/>
+          <p:nvPr/>
+        </p:nvSpPr>
+        <p:spPr>
+          <a:xfrm>
+            <a:off x="6903720" y="4498848"/>
+            <a:ext cx="4572000" cy="1463040"/>
           </a:xfrm>
           <a:prstGeom prst="rect">
             <a:avLst/>
@@ -30569,13 +28929,13 @@
           <a:p>
             <a:pPr marL="203200" indent="-203200">
               <a:spcAft>
-                <a:spcPts val="600"/>
+                <a:spcPts val="300"/>
               </a:spcAft>
               <a:buSzPct val="100000"/>
               <a:buChar char="•"/>
             </a:pPr>
             <a:r>
-              <a:rPr lang="en-US" sz="1300" dirty="0">
+              <a:rPr lang="en-US" sz="1050" dirty="0">
                 <a:solidFill>
                   <a:srgbClr val="1F2937"/>
                 </a:solidFill>
@@ -30585,18 +28945,18 @@
               </a:rPr>
               <a:t>Drivers own the freight bill — ownership of the FB from inbound to delivery.</a:t>
             </a:r>
-            <a:endParaRPr lang="en-US" sz="1300" dirty="0"/>
+            <a:endParaRPr lang="en-US" sz="1050" dirty="0"/>
           </a:p>
           <a:p>
             <a:pPr marL="203200" indent="-203200">
               <a:spcAft>
-                <a:spcPts val="600"/>
+                <a:spcPts val="300"/>
               </a:spcAft>
               <a:buSzPct val="100000"/>
               <a:buChar char="•"/>
             </a:pPr>
             <a:r>
-              <a:rPr lang="en-US" sz="1300" dirty="0">
+              <a:rPr lang="en-US" sz="1050" dirty="0">
                 <a:solidFill>
                   <a:srgbClr val="1F2937"/>
                 </a:solidFill>
@@ -30606,18 +28966,18 @@
               </a:rPr>
               <a:t>Scanning compliance checked every shift (see Scanning slide).</a:t>
             </a:r>
-            <a:endParaRPr lang="en-US" sz="1300" dirty="0"/>
+            <a:endParaRPr lang="en-US" sz="1050" dirty="0"/>
           </a:p>
           <a:p>
             <a:pPr marL="203200" indent="-203200">
               <a:spcAft>
-                <a:spcPts val="600"/>
+                <a:spcPts val="300"/>
               </a:spcAft>
               <a:buSzPct val="100000"/>
               <a:buChar char="•"/>
             </a:pPr>
             <a:r>
-              <a:rPr lang="en-US" sz="1300" dirty="0">
+              <a:rPr lang="en-US" sz="1050" dirty="0">
                 <a:solidFill>
                   <a:srgbClr val="1F2937"/>
                 </a:solidFill>
@@ -30627,18 +28987,18 @@
               </a:rPr>
               <a:t>TF (terminal) and P&amp;D working collectively on hand-offs.</a:t>
             </a:r>
-            <a:endParaRPr lang="en-US" sz="1300" dirty="0"/>
+            <a:endParaRPr lang="en-US" sz="1050" dirty="0"/>
           </a:p>
           <a:p>
             <a:pPr marL="203200" indent="-203200">
               <a:spcAft>
-                <a:spcPts val="600"/>
+                <a:spcPts val="300"/>
               </a:spcAft>
               <a:buSzPct val="100000"/>
               <a:buChar char="•"/>
             </a:pPr>
             <a:r>
-              <a:rPr lang="en-US" sz="1300" dirty="0">
+              <a:rPr lang="en-US" sz="1050" dirty="0">
                 <a:solidFill>
                   <a:srgbClr val="1F2937"/>
                 </a:solidFill>
@@ -30648,18 +29008,18 @@
               </a:rPr>
               <a:t>End-of-shift reporting on afternoons — every late coded before shift end.</a:t>
             </a:r>
-            <a:endParaRPr lang="en-US" sz="1300" dirty="0"/>
+            <a:endParaRPr lang="en-US" sz="1050" dirty="0"/>
           </a:p>
           <a:p>
             <a:pPr marL="203200" indent="-203200">
               <a:spcAft>
-                <a:spcPts val="600"/>
+                <a:spcPts val="300"/>
               </a:spcAft>
               <a:buSzPct val="100000"/>
               <a:buChar char="•"/>
             </a:pPr>
             <a:r>
-              <a:rPr lang="en-US" sz="1300" dirty="0">
+              <a:rPr lang="en-US" sz="1050" dirty="0">
                 <a:solidFill>
                   <a:srgbClr val="1F2937"/>
                 </a:solidFill>
@@ -30669,20 +29029,20 @@
               </a:rPr>
               <a:t>Interline (IN) and transborder (TB) lates reviewed with the interline team — outside terminal control.</a:t>
             </a:r>
-            <a:endParaRPr lang="en-US" sz="1300" dirty="0"/>
-          </a:p>
-        </p:txBody>
-      </p:sp>
-      <p:sp>
-        <p:nvSpPr>
-          <p:cNvPr id="31" name="Text 27"/>
-          <p:cNvSpPr txBox="1"/>
-          <p:nvPr/>
-        </p:nvSpPr>
-        <p:spPr>
-          <a:xfrm>
-            <a:off x="4846320" y="5486400"/>
-            <a:ext cx="6583680" cy="274320"/>
+            <a:endParaRPr lang="en-US" sz="1050" dirty="0"/>
+          </a:p>
+        </p:txBody>
+      </p:sp>
+      <p:sp>
+        <p:nvSpPr>
+          <p:cNvPr id="34" name="Text 30"/>
+          <p:cNvSpPr txBox="1"/>
+          <p:nvPr/>
+        </p:nvSpPr>
+        <p:spPr>
+          <a:xfrm>
+            <a:off x="548640" y="6108192"/>
+            <a:ext cx="11091672" cy="256032"/>
           </a:xfrm>
           <a:prstGeom prst="rect">
             <a:avLst/>
@@ -30698,7 +29058,7 @@
               <a:buNone/>
             </a:pPr>
             <a:r>
-              <a:rPr lang="en-US" sz="1200" b="1" dirty="0">
+              <a:rPr lang="en-US" sz="950" i="1" dirty="0">
                 <a:solidFill>
                   <a:srgbClr val="6B7280"/>
                 </a:solidFill>
@@ -30706,13 +29066,13 @@
                 <a:ea typeface="Calibri" pitchFamily="34" charset="-122"/>
                 <a:cs typeface="Calibri" pitchFamily="34" charset="-120"/>
               </a:rPr>
-              <a:t>UNADJ lates: </a:t>
-            </a:r>
-            <a:pPr indent="0" marL="0">
-              <a:buNone/>
-            </a:pPr>
-            <a:r>
-              <a:rPr lang="en-US" sz="1200" b="1" dirty="0">
+              <a:t>Source: Adj On Time dashboard — Mississauga, calendar 2026 through Sep 28. Partner carriers = "beyond interliner" freight. Late codes by reason: </a:t>
+            </a:r>
+            <a:pPr indent="0" marL="0">
+              <a:buNone/>
+            </a:pPr>
+            <a:r>
+              <a:rPr lang="en-US" sz="950" b="1" i="1" dirty="0">
                 <a:solidFill>
                   <a:srgbClr val="D97706"/>
                 </a:solidFill>
@@ -30722,80 +29082,13 @@
               </a:rPr>
               <a:t>TBC</a:t>
             </a:r>
-            <a:pPr indent="0" marL="0">
-              <a:buNone/>
-            </a:pPr>
-            <a:r>
-              <a:rPr lang="en-US" sz="1200" b="1" dirty="0">
-                <a:solidFill>
-                  <a:srgbClr val="6B7280"/>
-                </a:solidFill>
-                <a:latin typeface="Calibri" pitchFamily="34" charset="0"/>
-                <a:ea typeface="Calibri" pitchFamily="34" charset="-122"/>
-                <a:cs typeface="Calibri" pitchFamily="34" charset="-120"/>
-              </a:rPr>
-              <a:t>     ADJ lates: </a:t>
-            </a:r>
-            <a:pPr indent="0" marL="0">
-              <a:buNone/>
-            </a:pPr>
-            <a:r>
-              <a:rPr lang="en-US" sz="1200" b="1" dirty="0">
-                <a:solidFill>
-                  <a:srgbClr val="D97706"/>
-                </a:solidFill>
-                <a:latin typeface="Calibri" pitchFamily="34" charset="0"/>
-                <a:ea typeface="Calibri" pitchFamily="34" charset="-122"/>
-                <a:cs typeface="Calibri" pitchFamily="34" charset="-120"/>
-              </a:rPr>
-              <a:t>TBC</a:t>
-            </a:r>
-            <a:endParaRPr lang="en-US" sz="1200" dirty="0"/>
-          </a:p>
-        </p:txBody>
-      </p:sp>
-      <p:sp>
-        <p:nvSpPr>
-          <p:cNvPr id="32" name="Text 28"/>
-          <p:cNvSpPr txBox="1"/>
-          <p:nvPr/>
-        </p:nvSpPr>
-        <p:spPr>
-          <a:xfrm>
-            <a:off x="4846320" y="5788152"/>
-            <a:ext cx="6583680" cy="274320"/>
-          </a:xfrm>
-          <a:prstGeom prst="rect">
-            <a:avLst/>
-          </a:prstGeom>
-          <a:noFill/>
-          <a:ln/>
-        </p:spPr>
-        <p:txBody>
-          <a:bodyPr wrap="square" lIns="0" tIns="0" rIns="0" bIns="0" rtlCol="0" anchor="ctr"/>
-          <a:lstStyle/>
-          <a:p>
-            <a:pPr indent="0" marL="0">
-              <a:buNone/>
-            </a:pPr>
-            <a:r>
-              <a:rPr lang="en-US" sz="1100" i="1" dirty="0">
-                <a:solidFill>
-                  <a:srgbClr val="6B7280"/>
-                </a:solidFill>
-                <a:latin typeface="Calibri" pitchFamily="34" charset="0"/>
-                <a:ea typeface="Calibri" pitchFamily="34" charset="-122"/>
-                <a:cs typeface="Calibri" pitchFamily="34" charset="-120"/>
-              </a:rPr>
-              <a:t>IN = agent / beyond carrier · TB = transborder — both outside terminal control.</a:t>
-            </a:r>
-            <a:endParaRPr lang="en-US" sz="1100" dirty="0"/>
-          </a:p>
-        </p:txBody>
-      </p:sp>
-      <p:sp>
-        <p:nvSpPr>
-          <p:cNvPr id="33" name="Text 29"/>
+            <a:endParaRPr lang="en-US" sz="950" dirty="0"/>
+          </a:p>
+        </p:txBody>
+      </p:sp>
+      <p:sp>
+        <p:nvSpPr>
+          <p:cNvPr id="35" name="Text 31"/>
           <p:cNvSpPr txBox="1"/>
           <p:nvPr/>
         </p:nvSpPr>
@@ -30834,7 +29127,7 @@
       </p:sp>
       <p:sp>
         <p:nvSpPr>
-          <p:cNvPr id="34" name="Text 30"/>
+          <p:cNvPr id="36" name="Text 32"/>
           <p:cNvSpPr txBox="1"/>
           <p:nvPr/>
         </p:nvSpPr>

</xml_diff>

<commit_message>
Deck: real Mississauga scanning compliance (Sep 1-28)
Co-Authored-By: Claude Opus 5.5 <noreply@anthropic.com>
Claude-Session: https://claude.ai/code/session_01BwRjju3y2wk3wSHFrM9KLe
</commit_message>
<xml_diff>
--- a/presentation/Mississauga_F27_Leadership_Review_Sep29.pptx
+++ b/presentation/Mississauga_F27_Leadership_Review_Sep29.pptx
@@ -5376,7 +5376,7 @@
           <a:p>
             <a:r>
               <a:rPr lang="en-US" dirty="0"/>
-              <a:t>This is freight bills scanned by trip type for the week of September 6 to 11, against the 98 percent target; the percentages are being confirmed from the scanning report. Compliance is checked every shift so gaps are fixed the same day.</a:t>
+              <a:t>For September 1 to 28, 91.37 percent of freight bills were scanned in and out of the terminal, 90.50 percent were completely scanned, and 90.66 percent of items were scanned. The dashboard shows all three ahead of fiscal year to date, though slightly down on the last period. That still leaves about 4,550 freight bills not scanned this month, and closing that gap also reduces the already-serviced false positives we saw in missed pickups.</a:t>
             </a:r>
             <a:endParaRPr lang="en-US" dirty="0"/>
           </a:p>
@@ -41033,8 +41033,8 @@
         </p:nvSpPr>
         <p:spPr>
           <a:xfrm>
-            <a:off x="548640" y="1261872"/>
-            <a:ext cx="10972800" cy="320040"/>
+            <a:off x="548640" y="1243584"/>
+            <a:ext cx="10972800" cy="274320"/>
           </a:xfrm>
           <a:prstGeom prst="rect">
             <a:avLst/>
@@ -41050,7 +41050,7 @@
               <a:buNone/>
             </a:pPr>
             <a:r>
-              <a:rPr lang="en-US" sz="1500" dirty="0">
+              <a:rPr lang="en-US" sz="1300" dirty="0">
                 <a:solidFill>
                   <a:srgbClr val="6B7280"/>
                 </a:solidFill>
@@ -41058,37 +41058,9 @@
                 <a:ea typeface="Calibri" pitchFamily="34" charset="-122"/>
                 <a:cs typeface="Calibri" pitchFamily="34" charset="-120"/>
               </a:rPr>
-              <a:t>Freight bills scanned  ·  </a:t>
-            </a:r>
-            <a:pPr indent="0" marL="0">
-              <a:buNone/>
-            </a:pPr>
-            <a:r>
-              <a:rPr lang="en-US" sz="1500" b="1" dirty="0">
-                <a:solidFill>
-                  <a:srgbClr val="111827"/>
-                </a:solidFill>
-                <a:latin typeface="Calibri" pitchFamily="34" charset="0"/>
-                <a:ea typeface="Calibri" pitchFamily="34" charset="-122"/>
-                <a:cs typeface="Calibri" pitchFamily="34" charset="-120"/>
-              </a:rPr>
-              <a:t>Sep 6 – Sep 11, 2026</a:t>
-            </a:r>
-            <a:pPr indent="0" marL="0">
-              <a:buNone/>
-            </a:pPr>
-            <a:r>
-              <a:rPr lang="en-US" sz="1500" dirty="0">
-                <a:solidFill>
-                  <a:srgbClr val="6B7280"/>
-                </a:solidFill>
-                <a:latin typeface="Calibri" pitchFamily="34" charset="0"/>
-                <a:ea typeface="Calibri" pitchFamily="34" charset="-122"/>
-                <a:cs typeface="Calibri" pitchFamily="34" charset="-120"/>
-              </a:rPr>
-              <a:t>  ·  Target 98%</a:t>
-            </a:r>
-            <a:endParaRPr lang="en-US" sz="1500" dirty="0"/>
+              <a:t>Scanning efficiency in/out of terminals · Sep 1–28, 2026 (28 days) · all trip types</a:t>
+            </a:r>
+            <a:endParaRPr lang="en-US" sz="1300" dirty="0"/>
           </a:p>
         </p:txBody>
       </p:sp>
@@ -41100,12 +41072,12 @@
         </p:nvSpPr>
         <p:spPr>
           <a:xfrm>
-            <a:off x="548640" y="1783080"/>
-            <a:ext cx="2567178" cy="2971800"/>
+            <a:off x="548640" y="1691640"/>
+            <a:ext cx="3514344" cy="3154680"/>
           </a:xfrm>
           <a:prstGeom prst="roundRect">
             <a:avLst>
-              <a:gd name="adj" fmla="val 2850"/>
+              <a:gd name="adj" fmla="val 2319"/>
             </a:avLst>
           </a:prstGeom>
           <a:solidFill>
@@ -41127,7 +41099,7 @@
         </p:nvSpPr>
         <p:spPr>
           <a:xfrm>
-            <a:off x="777240" y="2011680"/>
+            <a:off x="777240" y="1920240"/>
             <a:ext cx="502920" cy="502920"/>
           </a:xfrm>
           <a:prstGeom prst="ellipse">
@@ -41160,7 +41132,7 @@
         </p:blipFill>
         <p:spPr>
           <a:xfrm>
-            <a:off x="902970" y="2137410"/>
+            <a:off x="902970" y="2045970"/>
             <a:ext cx="251460" cy="251460"/>
           </a:xfrm>
           <a:prstGeom prst="rect">
@@ -41176,8 +41148,8 @@
         </p:nvSpPr>
         <p:spPr>
           <a:xfrm>
-            <a:off x="777240" y="2651760"/>
-            <a:ext cx="2109978" cy="365760"/>
+            <a:off x="1417320" y="1920240"/>
+            <a:ext cx="2462784" cy="502920"/>
           </a:xfrm>
           <a:prstGeom prst="rect">
             <a:avLst/>
@@ -41193,7 +41165,7 @@
               <a:buNone/>
             </a:pPr>
             <a:r>
-              <a:rPr lang="en-US" sz="1600" b="1" dirty="0">
+              <a:rPr lang="en-US" sz="1500" b="1" dirty="0">
                 <a:solidFill>
                   <a:srgbClr val="111827"/>
                 </a:solidFill>
@@ -41201,9 +41173,9 @@
                 <a:ea typeface="Calibri" pitchFamily="34" charset="-122"/>
                 <a:cs typeface="Calibri" pitchFamily="34" charset="-120"/>
               </a:rPr>
-              <a:t>Delivery trips</a:t>
-            </a:r>
-            <a:endParaRPr lang="en-US" sz="1600" dirty="0"/>
+              <a:t>Freight bills scanned</a:t>
+            </a:r>
+            <a:endParaRPr lang="en-US" sz="1500" dirty="0"/>
           </a:p>
         </p:txBody>
       </p:sp>
@@ -41215,8 +41187,8 @@
         </p:nvSpPr>
         <p:spPr>
           <a:xfrm>
-            <a:off x="777240" y="3017520"/>
-            <a:ext cx="2109978" cy="777240"/>
+            <a:off x="777240" y="2560320"/>
+            <a:ext cx="3057144" cy="777240"/>
           </a:xfrm>
           <a:prstGeom prst="rect">
             <a:avLst/>
@@ -41232,17 +41204,17 @@
               <a:buNone/>
             </a:pPr>
             <a:r>
-              <a:rPr lang="en-US" sz="4000" b="1" dirty="0">
-                <a:solidFill>
-                  <a:srgbClr val="D97706"/>
-                </a:solidFill>
-                <a:latin typeface="Calibri" pitchFamily="34" charset="0"/>
-                <a:ea typeface="Calibri" pitchFamily="34" charset="-122"/>
-                <a:cs typeface="Calibri" pitchFamily="34" charset="-120"/>
-              </a:rPr>
-              <a:t>TBC</a:t>
-            </a:r>
-            <a:endParaRPr lang="en-US" sz="4000" dirty="0"/>
+              <a:rPr lang="en-US" sz="4400" b="1" dirty="0">
+                <a:solidFill>
+                  <a:srgbClr val="111827"/>
+                </a:solidFill>
+                <a:latin typeface="Calibri" pitchFamily="34" charset="0"/>
+                <a:ea typeface="Calibri" pitchFamily="34" charset="-122"/>
+                <a:cs typeface="Calibri" pitchFamily="34" charset="-120"/>
+              </a:rPr>
+              <a:t>91.37%</a:t>
+            </a:r>
+            <a:endParaRPr lang="en-US" sz="4400" dirty="0"/>
           </a:p>
         </p:txBody>
       </p:sp>
@@ -41254,8 +41226,8 @@
         </p:nvSpPr>
         <p:spPr>
           <a:xfrm>
-            <a:off x="777240" y="3840480"/>
-            <a:ext cx="2109978" cy="777240"/>
+            <a:off x="777240" y="3337560"/>
+            <a:ext cx="3057144" cy="274320"/>
           </a:xfrm>
           <a:prstGeom prst="rect">
             <a:avLst/>
@@ -41264,7 +41236,7 @@
           <a:ln/>
         </p:spPr>
         <p:txBody>
-          <a:bodyPr wrap="square" lIns="0" tIns="0" rIns="0" bIns="0" rtlCol="0" anchor="t"/>
+          <a:bodyPr wrap="square" lIns="0" tIns="0" rIns="0" bIns="0" rtlCol="0" anchor="ctr"/>
           <a:lstStyle/>
           <a:p>
             <a:pPr indent="0" marL="0">
@@ -41273,75 +41245,13 @@
             <a:r>
               <a:rPr lang="en-US" sz="1200" dirty="0">
                 <a:solidFill>
-                  <a:srgbClr val="6B7280"/>
-                </a:solidFill>
-                <a:latin typeface="Calibri" pitchFamily="34" charset="0"/>
-                <a:ea typeface="Calibri" pitchFamily="34" charset="-122"/>
-                <a:cs typeface="Calibri" pitchFamily="34" charset="-120"/>
-              </a:rPr>
-              <a:t>Target 98%</a:t>
-            </a:r>
-            <a:endParaRPr lang="en-US" sz="1200" dirty="0"/>
-          </a:p>
-          <a:p>
-            <a:pPr indent="0" marL="0">
-              <a:buNone/>
-            </a:pPr>
-            <a:r>
-              <a:rPr lang="en-US" sz="1200" dirty="0">
-                <a:solidFill>
-                  <a:srgbClr val="6B7280"/>
-                </a:solidFill>
-                <a:latin typeface="Calibri" pitchFamily="34" charset="0"/>
-                <a:ea typeface="Calibri" pitchFamily="34" charset="-122"/>
-                <a:cs typeface="Calibri" pitchFamily="34" charset="-120"/>
-              </a:rPr>
-              <a:t>Gap to target: </a:t>
-            </a:r>
-            <a:pPr indent="0" marL="0">
-              <a:buNone/>
-            </a:pPr>
-            <a:r>
-              <a:rPr lang="en-US" sz="1200" b="1" dirty="0">
-                <a:solidFill>
-                  <a:srgbClr val="D97706"/>
-                </a:solidFill>
-                <a:latin typeface="Calibri" pitchFamily="34" charset="0"/>
-                <a:ea typeface="Calibri" pitchFamily="34" charset="-122"/>
-                <a:cs typeface="Calibri" pitchFamily="34" charset="-120"/>
-              </a:rPr>
-              <a:t>TBC</a:t>
-            </a:r>
-            <a:endParaRPr lang="en-US" sz="1200" dirty="0"/>
-          </a:p>
-          <a:p>
-            <a:pPr indent="0" marL="0">
-              <a:buNone/>
-            </a:pPr>
-            <a:r>
-              <a:rPr lang="en-US" sz="1200" dirty="0">
-                <a:solidFill>
-                  <a:srgbClr val="6B7280"/>
-                </a:solidFill>
-                <a:latin typeface="Calibri" pitchFamily="34" charset="0"/>
-                <a:ea typeface="Calibri" pitchFamily="34" charset="-122"/>
-                <a:cs typeface="Calibri" pitchFamily="34" charset="-120"/>
-              </a:rPr>
-              <a:t>Fiscal YTD: </a:t>
-            </a:r>
-            <a:pPr indent="0" marL="0">
-              <a:buNone/>
-            </a:pPr>
-            <a:r>
-              <a:rPr lang="en-US" sz="1200" b="1" dirty="0">
-                <a:solidFill>
-                  <a:srgbClr val="D97706"/>
-                </a:solidFill>
-                <a:latin typeface="Calibri" pitchFamily="34" charset="0"/>
-                <a:ea typeface="Calibri" pitchFamily="34" charset="-122"/>
-                <a:cs typeface="Calibri" pitchFamily="34" charset="-120"/>
-              </a:rPr>
-              <a:t>TBC</a:t>
+                  <a:srgbClr val="1F2937"/>
+                </a:solidFill>
+                <a:latin typeface="Calibri" pitchFamily="34" charset="0"/>
+                <a:ea typeface="Calibri" pitchFamily="34" charset="-122"/>
+                <a:cs typeface="Calibri" pitchFamily="34" charset="-120"/>
+              </a:rPr>
+              <a:t>48.22K of 52.77K FBs</a:t>
             </a:r>
             <a:endParaRPr lang="en-US" sz="1200" dirty="0"/>
           </a:p>
@@ -41355,12 +41265,222 @@
         </p:nvSpPr>
         <p:spPr>
           <a:xfrm>
-            <a:off x="3390138" y="1783080"/>
-            <a:ext cx="2567178" cy="2971800"/>
+            <a:off x="777240" y="3703320"/>
+            <a:ext cx="1600200" cy="329184"/>
           </a:xfrm>
           <a:prstGeom prst="roundRect">
             <a:avLst>
-              <a:gd name="adj" fmla="val 2850"/>
+              <a:gd name="adj" fmla="val 22222"/>
+            </a:avLst>
+          </a:prstGeom>
+          <a:solidFill>
+            <a:srgbClr val="FEE2E2"/>
+          </a:solidFill>
+          <a:ln w="12700">
+            <a:solidFill>
+              <a:srgbClr val="FEE2E2"/>
+            </a:solidFill>
+            <a:prstDash val="solid"/>
+          </a:ln>
+        </p:spPr>
+      </p:sp>
+      <p:sp>
+        <p:nvSpPr>
+          <p:cNvPr id="12" name="Text 9"/>
+          <p:cNvSpPr txBox="1"/>
+          <p:nvPr/>
+        </p:nvSpPr>
+        <p:spPr>
+          <a:xfrm>
+            <a:off x="777240" y="3703320"/>
+            <a:ext cx="1600200" cy="329184"/>
+          </a:xfrm>
+          <a:prstGeom prst="rect">
+            <a:avLst/>
+          </a:prstGeom>
+          <a:noFill/>
+          <a:ln/>
+        </p:spPr>
+        <p:txBody>
+          <a:bodyPr wrap="square" lIns="0" tIns="0" rIns="0" bIns="0" rtlCol="0" anchor="ctr"/>
+          <a:lstStyle/>
+          <a:p>
+            <a:pPr algn="ctr" indent="0" marL="0">
+              <a:buNone/>
+            </a:pPr>
+            <a:r>
+              <a:rPr lang="en-US" sz="1200" b="1" dirty="0">
+                <a:solidFill>
+                  <a:srgbClr val="DC2626"/>
+                </a:solidFill>
+                <a:latin typeface="Calibri" pitchFamily="34" charset="0"/>
+                <a:ea typeface="Calibri" pitchFamily="34" charset="-122"/>
+                <a:cs typeface="Calibri" pitchFamily="34" charset="-120"/>
+              </a:rPr>
+              <a:t>−0.22 pts</a:t>
+            </a:r>
+            <a:endParaRPr lang="en-US" sz="1200" dirty="0"/>
+          </a:p>
+        </p:txBody>
+      </p:sp>
+      <p:sp>
+        <p:nvSpPr>
+          <p:cNvPr id="13" name="Text 10"/>
+          <p:cNvSpPr txBox="1"/>
+          <p:nvPr/>
+        </p:nvSpPr>
+        <p:spPr>
+          <a:xfrm>
+            <a:off x="2468880" y="3703320"/>
+            <a:ext cx="1365504" cy="329184"/>
+          </a:xfrm>
+          <a:prstGeom prst="rect">
+            <a:avLst/>
+          </a:prstGeom>
+          <a:noFill/>
+          <a:ln/>
+        </p:spPr>
+        <p:txBody>
+          <a:bodyPr wrap="square" lIns="0" tIns="0" rIns="0" bIns="0" rtlCol="0" anchor="ctr"/>
+          <a:lstStyle/>
+          <a:p>
+            <a:pPr indent="0" marL="0">
+              <a:buNone/>
+            </a:pPr>
+            <a:r>
+              <a:rPr lang="en-US" sz="1100" dirty="0">
+                <a:solidFill>
+                  <a:srgbClr val="6B7280"/>
+                </a:solidFill>
+                <a:latin typeface="Calibri" pitchFamily="34" charset="0"/>
+                <a:ea typeface="Calibri" pitchFamily="34" charset="-122"/>
+                <a:cs typeface="Calibri" pitchFamily="34" charset="-120"/>
+              </a:rPr>
+              <a:t>vs last time period</a:t>
+            </a:r>
+            <a:endParaRPr lang="en-US" sz="1100" dirty="0"/>
+          </a:p>
+        </p:txBody>
+      </p:sp>
+      <p:sp>
+        <p:nvSpPr>
+          <p:cNvPr id="14" name="Shape 11"/>
+          <p:cNvSpPr/>
+          <p:nvPr/>
+        </p:nvSpPr>
+        <p:spPr>
+          <a:xfrm>
+            <a:off x="777240" y="4123944"/>
+            <a:ext cx="1600200" cy="329184"/>
+          </a:xfrm>
+          <a:prstGeom prst="roundRect">
+            <a:avLst>
+              <a:gd name="adj" fmla="val 22222"/>
+            </a:avLst>
+          </a:prstGeom>
+          <a:solidFill>
+            <a:srgbClr val="D1FAE5"/>
+          </a:solidFill>
+          <a:ln w="12700">
+            <a:solidFill>
+              <a:srgbClr val="D1FAE5"/>
+            </a:solidFill>
+            <a:prstDash val="solid"/>
+          </a:ln>
+        </p:spPr>
+      </p:sp>
+      <p:sp>
+        <p:nvSpPr>
+          <p:cNvPr id="15" name="Text 12"/>
+          <p:cNvSpPr txBox="1"/>
+          <p:nvPr/>
+        </p:nvSpPr>
+        <p:spPr>
+          <a:xfrm>
+            <a:off x="777240" y="4123944"/>
+            <a:ext cx="1600200" cy="329184"/>
+          </a:xfrm>
+          <a:prstGeom prst="rect">
+            <a:avLst/>
+          </a:prstGeom>
+          <a:noFill/>
+          <a:ln/>
+        </p:spPr>
+        <p:txBody>
+          <a:bodyPr wrap="square" lIns="0" tIns="0" rIns="0" bIns="0" rtlCol="0" anchor="ctr"/>
+          <a:lstStyle/>
+          <a:p>
+            <a:pPr algn="ctr" indent="0" marL="0">
+              <a:buNone/>
+            </a:pPr>
+            <a:r>
+              <a:rPr lang="en-US" sz="1200" b="1" dirty="0">
+                <a:solidFill>
+                  <a:srgbClr val="059669"/>
+                </a:solidFill>
+                <a:latin typeface="Calibri" pitchFamily="34" charset="0"/>
+                <a:ea typeface="Calibri" pitchFamily="34" charset="-122"/>
+                <a:cs typeface="Calibri" pitchFamily="34" charset="-120"/>
+              </a:rPr>
+              <a:t>+0.47 pts</a:t>
+            </a:r>
+            <a:endParaRPr lang="en-US" sz="1200" dirty="0"/>
+          </a:p>
+        </p:txBody>
+      </p:sp>
+      <p:sp>
+        <p:nvSpPr>
+          <p:cNvPr id="16" name="Text 13"/>
+          <p:cNvSpPr txBox="1"/>
+          <p:nvPr/>
+        </p:nvSpPr>
+        <p:spPr>
+          <a:xfrm>
+            <a:off x="2468880" y="4123944"/>
+            <a:ext cx="1365504" cy="329184"/>
+          </a:xfrm>
+          <a:prstGeom prst="rect">
+            <a:avLst/>
+          </a:prstGeom>
+          <a:noFill/>
+          <a:ln/>
+        </p:spPr>
+        <p:txBody>
+          <a:bodyPr wrap="square" lIns="0" tIns="0" rIns="0" bIns="0" rtlCol="0" anchor="ctr"/>
+          <a:lstStyle/>
+          <a:p>
+            <a:pPr indent="0" marL="0">
+              <a:buNone/>
+            </a:pPr>
+            <a:r>
+              <a:rPr lang="en-US" sz="1100" dirty="0">
+                <a:solidFill>
+                  <a:srgbClr val="6B7280"/>
+                </a:solidFill>
+                <a:latin typeface="Calibri" pitchFamily="34" charset="0"/>
+                <a:ea typeface="Calibri" pitchFamily="34" charset="-122"/>
+                <a:cs typeface="Calibri" pitchFamily="34" charset="-120"/>
+              </a:rPr>
+              <a:t>vs fiscal YTD (91.55%)</a:t>
+            </a:r>
+            <a:endParaRPr lang="en-US" sz="1100" dirty="0"/>
+          </a:p>
+        </p:txBody>
+      </p:sp>
+      <p:sp>
+        <p:nvSpPr>
+          <p:cNvPr id="17" name="Shape 14"/>
+          <p:cNvSpPr/>
+          <p:nvPr/>
+        </p:nvSpPr>
+        <p:spPr>
+          <a:xfrm>
+            <a:off x="4337304" y="1691640"/>
+            <a:ext cx="3514344" cy="3154680"/>
+          </a:xfrm>
+          <a:prstGeom prst="roundRect">
+            <a:avLst>
+              <a:gd name="adj" fmla="val 2319"/>
             </a:avLst>
           </a:prstGeom>
           <a:solidFill>
@@ -41376,13 +41496,13 @@
       </p:sp>
       <p:sp>
         <p:nvSpPr>
-          <p:cNvPr id="12" name="Shape 9"/>
+          <p:cNvPr id="18" name="Shape 15"/>
           <p:cNvSpPr/>
           <p:nvPr/>
         </p:nvSpPr>
         <p:spPr>
           <a:xfrm>
-            <a:off x="3618738" y="2011680"/>
+            <a:off x="4565904" y="1920240"/>
             <a:ext cx="502920" cy="502920"/>
           </a:xfrm>
           <a:prstGeom prst="ellipse">
@@ -41401,7 +41521,7 @@
       </p:sp>
       <p:pic>
         <p:nvPicPr>
-          <p:cNvPr id="13" name="Image 1" descr="preencoded.png">    </p:cNvPr>
+          <p:cNvPr id="19" name="Image 1" descr="preencoded.png">    </p:cNvPr>
           <p:cNvPicPr>
             <a:picLocks noChangeAspect="1"/>
           </p:cNvPicPr>
@@ -41415,7 +41535,7 @@
         </p:blipFill>
         <p:spPr>
           <a:xfrm>
-            <a:off x="3744468" y="2137410"/>
+            <a:off x="4691634" y="2045970"/>
             <a:ext cx="251460" cy="251460"/>
           </a:xfrm>
           <a:prstGeom prst="rect">
@@ -41425,14 +41545,14 @@
       </p:pic>
       <p:sp>
         <p:nvSpPr>
-          <p:cNvPr id="14" name="Text 10"/>
+          <p:cNvPr id="20" name="Text 16"/>
           <p:cNvSpPr txBox="1"/>
           <p:nvPr/>
         </p:nvSpPr>
         <p:spPr>
           <a:xfrm>
-            <a:off x="3618738" y="2651760"/>
-            <a:ext cx="2109978" cy="365760"/>
+            <a:off x="5205984" y="1920240"/>
+            <a:ext cx="2462784" cy="502920"/>
           </a:xfrm>
           <a:prstGeom prst="rect">
             <a:avLst/>
@@ -41448,7 +41568,7 @@
               <a:buNone/>
             </a:pPr>
             <a:r>
-              <a:rPr lang="en-US" sz="1600" b="1" dirty="0">
+              <a:rPr lang="en-US" sz="1500" b="1" dirty="0">
                 <a:solidFill>
                   <a:srgbClr val="111827"/>
                 </a:solidFill>
@@ -41456,22 +41576,22 @@
                 <a:ea typeface="Calibri" pitchFamily="34" charset="-122"/>
                 <a:cs typeface="Calibri" pitchFamily="34" charset="-120"/>
               </a:rPr>
-              <a:t>Line haul · outbound</a:t>
-            </a:r>
-            <a:endParaRPr lang="en-US" sz="1600" dirty="0"/>
-          </a:p>
-        </p:txBody>
-      </p:sp>
-      <p:sp>
-        <p:nvSpPr>
-          <p:cNvPr id="15" name="Text 11"/>
+              <a:t>Freight bills completely scanned</a:t>
+            </a:r>
+            <a:endParaRPr lang="en-US" sz="1500" dirty="0"/>
+          </a:p>
+        </p:txBody>
+      </p:sp>
+      <p:sp>
+        <p:nvSpPr>
+          <p:cNvPr id="21" name="Text 17"/>
           <p:cNvSpPr txBox="1"/>
           <p:nvPr/>
         </p:nvSpPr>
         <p:spPr>
           <a:xfrm>
-            <a:off x="3618738" y="3017520"/>
-            <a:ext cx="2109978" cy="777240"/>
+            <a:off x="4565904" y="2560320"/>
+            <a:ext cx="3057144" cy="777240"/>
           </a:xfrm>
           <a:prstGeom prst="rect">
             <a:avLst/>
@@ -41487,30 +41607,30 @@
               <a:buNone/>
             </a:pPr>
             <a:r>
-              <a:rPr lang="en-US" sz="4000" b="1" dirty="0">
-                <a:solidFill>
-                  <a:srgbClr val="D97706"/>
-                </a:solidFill>
-                <a:latin typeface="Calibri" pitchFamily="34" charset="0"/>
-                <a:ea typeface="Calibri" pitchFamily="34" charset="-122"/>
-                <a:cs typeface="Calibri" pitchFamily="34" charset="-120"/>
-              </a:rPr>
-              <a:t>TBC</a:t>
-            </a:r>
-            <a:endParaRPr lang="en-US" sz="4000" dirty="0"/>
-          </a:p>
-        </p:txBody>
-      </p:sp>
-      <p:sp>
-        <p:nvSpPr>
-          <p:cNvPr id="16" name="Text 12"/>
+              <a:rPr lang="en-US" sz="4400" b="1" dirty="0">
+                <a:solidFill>
+                  <a:srgbClr val="111827"/>
+                </a:solidFill>
+                <a:latin typeface="Calibri" pitchFamily="34" charset="0"/>
+                <a:ea typeface="Calibri" pitchFamily="34" charset="-122"/>
+                <a:cs typeface="Calibri" pitchFamily="34" charset="-120"/>
+              </a:rPr>
+              <a:t>90.50%</a:t>
+            </a:r>
+            <a:endParaRPr lang="en-US" sz="4400" dirty="0"/>
+          </a:p>
+        </p:txBody>
+      </p:sp>
+      <p:sp>
+        <p:nvSpPr>
+          <p:cNvPr id="22" name="Text 18"/>
           <p:cNvSpPr txBox="1"/>
           <p:nvPr/>
         </p:nvSpPr>
         <p:spPr>
           <a:xfrm>
-            <a:off x="3618738" y="3840480"/>
-            <a:ext cx="2109978" cy="777240"/>
+            <a:off x="4565904" y="3337560"/>
+            <a:ext cx="3057144" cy="274320"/>
           </a:xfrm>
           <a:prstGeom prst="rect">
             <a:avLst/>
@@ -41519,7 +41639,7 @@
           <a:ln/>
         </p:spPr>
         <p:txBody>
-          <a:bodyPr wrap="square" lIns="0" tIns="0" rIns="0" bIns="0" rtlCol="0" anchor="t"/>
+          <a:bodyPr wrap="square" lIns="0" tIns="0" rIns="0" bIns="0" rtlCol="0" anchor="ctr"/>
           <a:lstStyle/>
           <a:p>
             <a:pPr indent="0" marL="0">
@@ -41528,94 +41648,242 @@
             <a:r>
               <a:rPr lang="en-US" sz="1200" dirty="0">
                 <a:solidFill>
-                  <a:srgbClr val="6B7280"/>
-                </a:solidFill>
-                <a:latin typeface="Calibri" pitchFamily="34" charset="0"/>
-                <a:ea typeface="Calibri" pitchFamily="34" charset="-122"/>
-                <a:cs typeface="Calibri" pitchFamily="34" charset="-120"/>
-              </a:rPr>
-              <a:t>Target 98%</a:t>
+                  <a:srgbClr val="1F2937"/>
+                </a:solidFill>
+                <a:latin typeface="Calibri" pitchFamily="34" charset="0"/>
+                <a:ea typeface="Calibri" pitchFamily="34" charset="-122"/>
+                <a:cs typeface="Calibri" pitchFamily="34" charset="-120"/>
+              </a:rPr>
+              <a:t>47.76K of 52.77K FBs</a:t>
             </a:r>
             <a:endParaRPr lang="en-US" sz="1200" dirty="0"/>
           </a:p>
-          <a:p>
-            <a:pPr indent="0" marL="0">
-              <a:buNone/>
-            </a:pPr>
-            <a:r>
-              <a:rPr lang="en-US" sz="1200" dirty="0">
-                <a:solidFill>
-                  <a:srgbClr val="6B7280"/>
-                </a:solidFill>
-                <a:latin typeface="Calibri" pitchFamily="34" charset="0"/>
-                <a:ea typeface="Calibri" pitchFamily="34" charset="-122"/>
-                <a:cs typeface="Calibri" pitchFamily="34" charset="-120"/>
-              </a:rPr>
-              <a:t>Gap to target: </a:t>
-            </a:r>
-            <a:pPr indent="0" marL="0">
-              <a:buNone/>
-            </a:pPr>
-            <a:r>
-              <a:rPr lang="en-US" sz="1200" b="1" dirty="0">
-                <a:solidFill>
-                  <a:srgbClr val="D97706"/>
-                </a:solidFill>
-                <a:latin typeface="Calibri" pitchFamily="34" charset="0"/>
-                <a:ea typeface="Calibri" pitchFamily="34" charset="-122"/>
-                <a:cs typeface="Calibri" pitchFamily="34" charset="-120"/>
-              </a:rPr>
-              <a:t>TBC</a:t>
-            </a:r>
-            <a:endParaRPr lang="en-US" sz="1200" dirty="0"/>
-          </a:p>
-          <a:p>
-            <a:pPr indent="0" marL="0">
-              <a:buNone/>
-            </a:pPr>
-            <a:r>
-              <a:rPr lang="en-US" sz="1200" dirty="0">
-                <a:solidFill>
-                  <a:srgbClr val="6B7280"/>
-                </a:solidFill>
-                <a:latin typeface="Calibri" pitchFamily="34" charset="0"/>
-                <a:ea typeface="Calibri" pitchFamily="34" charset="-122"/>
-                <a:cs typeface="Calibri" pitchFamily="34" charset="-120"/>
-              </a:rPr>
-              <a:t>Fiscal YTD: </a:t>
-            </a:r>
-            <a:pPr indent="0" marL="0">
-              <a:buNone/>
-            </a:pPr>
-            <a:r>
-              <a:rPr lang="en-US" sz="1200" b="1" dirty="0">
-                <a:solidFill>
-                  <a:srgbClr val="D97706"/>
-                </a:solidFill>
-                <a:latin typeface="Calibri" pitchFamily="34" charset="0"/>
-                <a:ea typeface="Calibri" pitchFamily="34" charset="-122"/>
-                <a:cs typeface="Calibri" pitchFamily="34" charset="-120"/>
-              </a:rPr>
-              <a:t>TBC</a:t>
-            </a:r>
-            <a:endParaRPr lang="en-US" sz="1200" dirty="0"/>
-          </a:p>
-        </p:txBody>
-      </p:sp>
-      <p:sp>
-        <p:nvSpPr>
-          <p:cNvPr id="17" name="Shape 13"/>
+        </p:txBody>
+      </p:sp>
+      <p:sp>
+        <p:nvSpPr>
+          <p:cNvPr id="23" name="Shape 19"/>
           <p:cNvSpPr/>
           <p:nvPr/>
         </p:nvSpPr>
         <p:spPr>
           <a:xfrm>
-            <a:off x="6231636" y="1783080"/>
-            <a:ext cx="2567178" cy="2971800"/>
+            <a:off x="4565904" y="3703320"/>
+            <a:ext cx="1600200" cy="329184"/>
           </a:xfrm>
           <a:prstGeom prst="roundRect">
             <a:avLst>
-              <a:gd name="adj" fmla="val 2850"/>
+              <a:gd name="adj" fmla="val 22222"/>
+            </a:avLst>
+          </a:prstGeom>
+          <a:solidFill>
+            <a:srgbClr val="FEE2E2"/>
+          </a:solidFill>
+          <a:ln w="12700">
+            <a:solidFill>
+              <a:srgbClr val="FEE2E2"/>
+            </a:solidFill>
+            <a:prstDash val="solid"/>
+          </a:ln>
+        </p:spPr>
+      </p:sp>
+      <p:sp>
+        <p:nvSpPr>
+          <p:cNvPr id="24" name="Text 20"/>
+          <p:cNvSpPr txBox="1"/>
+          <p:nvPr/>
+        </p:nvSpPr>
+        <p:spPr>
+          <a:xfrm>
+            <a:off x="4565904" y="3703320"/>
+            <a:ext cx="1600200" cy="329184"/>
+          </a:xfrm>
+          <a:prstGeom prst="rect">
+            <a:avLst/>
+          </a:prstGeom>
+          <a:noFill/>
+          <a:ln/>
+        </p:spPr>
+        <p:txBody>
+          <a:bodyPr wrap="square" lIns="0" tIns="0" rIns="0" bIns="0" rtlCol="0" anchor="ctr"/>
+          <a:lstStyle/>
+          <a:p>
+            <a:pPr algn="ctr" indent="0" marL="0">
+              <a:buNone/>
+            </a:pPr>
+            <a:r>
+              <a:rPr lang="en-US" sz="1200" b="1" dirty="0">
+                <a:solidFill>
+                  <a:srgbClr val="DC2626"/>
+                </a:solidFill>
+                <a:latin typeface="Calibri" pitchFamily="34" charset="0"/>
+                <a:ea typeface="Calibri" pitchFamily="34" charset="-122"/>
+                <a:cs typeface="Calibri" pitchFamily="34" charset="-120"/>
+              </a:rPr>
+              <a:t>−0.20 pts</a:t>
+            </a:r>
+            <a:endParaRPr lang="en-US" sz="1200" dirty="0"/>
+          </a:p>
+        </p:txBody>
+      </p:sp>
+      <p:sp>
+        <p:nvSpPr>
+          <p:cNvPr id="25" name="Text 21"/>
+          <p:cNvSpPr txBox="1"/>
+          <p:nvPr/>
+        </p:nvSpPr>
+        <p:spPr>
+          <a:xfrm>
+            <a:off x="6257544" y="3703320"/>
+            <a:ext cx="1365504" cy="329184"/>
+          </a:xfrm>
+          <a:prstGeom prst="rect">
+            <a:avLst/>
+          </a:prstGeom>
+          <a:noFill/>
+          <a:ln/>
+        </p:spPr>
+        <p:txBody>
+          <a:bodyPr wrap="square" lIns="0" tIns="0" rIns="0" bIns="0" rtlCol="0" anchor="ctr"/>
+          <a:lstStyle/>
+          <a:p>
+            <a:pPr indent="0" marL="0">
+              <a:buNone/>
+            </a:pPr>
+            <a:r>
+              <a:rPr lang="en-US" sz="1100" dirty="0">
+                <a:solidFill>
+                  <a:srgbClr val="6B7280"/>
+                </a:solidFill>
+                <a:latin typeface="Calibri" pitchFamily="34" charset="0"/>
+                <a:ea typeface="Calibri" pitchFamily="34" charset="-122"/>
+                <a:cs typeface="Calibri" pitchFamily="34" charset="-120"/>
+              </a:rPr>
+              <a:t>vs last time period</a:t>
+            </a:r>
+            <a:endParaRPr lang="en-US" sz="1100" dirty="0"/>
+          </a:p>
+        </p:txBody>
+      </p:sp>
+      <p:sp>
+        <p:nvSpPr>
+          <p:cNvPr id="26" name="Shape 22"/>
+          <p:cNvSpPr/>
+          <p:nvPr/>
+        </p:nvSpPr>
+        <p:spPr>
+          <a:xfrm>
+            <a:off x="4565904" y="4123944"/>
+            <a:ext cx="1600200" cy="329184"/>
+          </a:xfrm>
+          <a:prstGeom prst="roundRect">
+            <a:avLst>
+              <a:gd name="adj" fmla="val 22222"/>
+            </a:avLst>
+          </a:prstGeom>
+          <a:solidFill>
+            <a:srgbClr val="D1FAE5"/>
+          </a:solidFill>
+          <a:ln w="12700">
+            <a:solidFill>
+              <a:srgbClr val="D1FAE5"/>
+            </a:solidFill>
+            <a:prstDash val="solid"/>
+          </a:ln>
+        </p:spPr>
+      </p:sp>
+      <p:sp>
+        <p:nvSpPr>
+          <p:cNvPr id="27" name="Text 23"/>
+          <p:cNvSpPr txBox="1"/>
+          <p:nvPr/>
+        </p:nvSpPr>
+        <p:spPr>
+          <a:xfrm>
+            <a:off x="4565904" y="4123944"/>
+            <a:ext cx="1600200" cy="329184"/>
+          </a:xfrm>
+          <a:prstGeom prst="rect">
+            <a:avLst/>
+          </a:prstGeom>
+          <a:noFill/>
+          <a:ln/>
+        </p:spPr>
+        <p:txBody>
+          <a:bodyPr wrap="square" lIns="0" tIns="0" rIns="0" bIns="0" rtlCol="0" anchor="ctr"/>
+          <a:lstStyle/>
+          <a:p>
+            <a:pPr algn="ctr" indent="0" marL="0">
+              <a:buNone/>
+            </a:pPr>
+            <a:r>
+              <a:rPr lang="en-US" sz="1200" b="1" dirty="0">
+                <a:solidFill>
+                  <a:srgbClr val="059669"/>
+                </a:solidFill>
+                <a:latin typeface="Calibri" pitchFamily="34" charset="0"/>
+                <a:ea typeface="Calibri" pitchFamily="34" charset="-122"/>
+                <a:cs typeface="Calibri" pitchFamily="34" charset="-120"/>
+              </a:rPr>
+              <a:t>+0.60 pts</a:t>
+            </a:r>
+            <a:endParaRPr lang="en-US" sz="1200" dirty="0"/>
+          </a:p>
+        </p:txBody>
+      </p:sp>
+      <p:sp>
+        <p:nvSpPr>
+          <p:cNvPr id="28" name="Text 24"/>
+          <p:cNvSpPr txBox="1"/>
+          <p:nvPr/>
+        </p:nvSpPr>
+        <p:spPr>
+          <a:xfrm>
+            <a:off x="6257544" y="4123944"/>
+            <a:ext cx="1365504" cy="329184"/>
+          </a:xfrm>
+          <a:prstGeom prst="rect">
+            <a:avLst/>
+          </a:prstGeom>
+          <a:noFill/>
+          <a:ln/>
+        </p:spPr>
+        <p:txBody>
+          <a:bodyPr wrap="square" lIns="0" tIns="0" rIns="0" bIns="0" rtlCol="0" anchor="ctr"/>
+          <a:lstStyle/>
+          <a:p>
+            <a:pPr indent="0" marL="0">
+              <a:buNone/>
+            </a:pPr>
+            <a:r>
+              <a:rPr lang="en-US" sz="1100" dirty="0">
+                <a:solidFill>
+                  <a:srgbClr val="6B7280"/>
+                </a:solidFill>
+                <a:latin typeface="Calibri" pitchFamily="34" charset="0"/>
+                <a:ea typeface="Calibri" pitchFamily="34" charset="-122"/>
+                <a:cs typeface="Calibri" pitchFamily="34" charset="-120"/>
+              </a:rPr>
+              <a:t>vs fiscal YTD (90.54%)</a:t>
+            </a:r>
+            <a:endParaRPr lang="en-US" sz="1100" dirty="0"/>
+          </a:p>
+        </p:txBody>
+      </p:sp>
+      <p:sp>
+        <p:nvSpPr>
+          <p:cNvPr id="29" name="Shape 25"/>
+          <p:cNvSpPr/>
+          <p:nvPr/>
+        </p:nvSpPr>
+        <p:spPr>
+          <a:xfrm>
+            <a:off x="8125968" y="1691640"/>
+            <a:ext cx="3514344" cy="3154680"/>
+          </a:xfrm>
+          <a:prstGeom prst="roundRect">
+            <a:avLst>
+              <a:gd name="adj" fmla="val 2319"/>
             </a:avLst>
           </a:prstGeom>
           <a:solidFill>
@@ -41631,13 +41899,13 @@
       </p:sp>
       <p:sp>
         <p:nvSpPr>
-          <p:cNvPr id="18" name="Shape 14"/>
+          <p:cNvPr id="30" name="Shape 26"/>
           <p:cNvSpPr/>
           <p:nvPr/>
         </p:nvSpPr>
         <p:spPr>
           <a:xfrm>
-            <a:off x="6460236" y="2011680"/>
+            <a:off x="8354568" y="1920240"/>
             <a:ext cx="502920" cy="502920"/>
           </a:xfrm>
           <a:prstGeom prst="ellipse">
@@ -41656,7 +41924,7 @@
       </p:sp>
       <p:pic>
         <p:nvPicPr>
-          <p:cNvPr id="19" name="Image 2" descr="preencoded.png">    </p:cNvPr>
+          <p:cNvPr id="31" name="Image 2" descr="preencoded.png">    </p:cNvPr>
           <p:cNvPicPr>
             <a:picLocks noChangeAspect="1"/>
           </p:cNvPicPr>
@@ -41670,7 +41938,7 @@
         </p:blipFill>
         <p:spPr>
           <a:xfrm>
-            <a:off x="6585966" y="2137410"/>
+            <a:off x="8480298" y="2045970"/>
             <a:ext cx="251460" cy="251460"/>
           </a:xfrm>
           <a:prstGeom prst="rect">
@@ -41680,14 +41948,14 @@
       </p:pic>
       <p:sp>
         <p:nvSpPr>
-          <p:cNvPr id="20" name="Text 15"/>
+          <p:cNvPr id="32" name="Text 27"/>
           <p:cNvSpPr txBox="1"/>
           <p:nvPr/>
         </p:nvSpPr>
         <p:spPr>
           <a:xfrm>
-            <a:off x="6460236" y="2651760"/>
-            <a:ext cx="2109978" cy="365760"/>
+            <a:off x="8994648" y="1920240"/>
+            <a:ext cx="2462784" cy="502920"/>
           </a:xfrm>
           <a:prstGeom prst="rect">
             <a:avLst/>
@@ -41703,7 +41971,7 @@
               <a:buNone/>
             </a:pPr>
             <a:r>
-              <a:rPr lang="en-US" sz="1600" b="1" dirty="0">
+              <a:rPr lang="en-US" sz="1500" b="1" dirty="0">
                 <a:solidFill>
                   <a:srgbClr val="111827"/>
                 </a:solidFill>
@@ -41711,22 +41979,22 @@
                 <a:ea typeface="Calibri" pitchFamily="34" charset="-122"/>
                 <a:cs typeface="Calibri" pitchFamily="34" charset="-120"/>
               </a:rPr>
-              <a:t>Line haul · inbound</a:t>
-            </a:r>
-            <a:endParaRPr lang="en-US" sz="1600" dirty="0"/>
-          </a:p>
-        </p:txBody>
-      </p:sp>
-      <p:sp>
-        <p:nvSpPr>
-          <p:cNvPr id="21" name="Text 16"/>
+              <a:t>Items scanned</a:t>
+            </a:r>
+            <a:endParaRPr lang="en-US" sz="1500" dirty="0"/>
+          </a:p>
+        </p:txBody>
+      </p:sp>
+      <p:sp>
+        <p:nvSpPr>
+          <p:cNvPr id="33" name="Text 28"/>
           <p:cNvSpPr txBox="1"/>
           <p:nvPr/>
         </p:nvSpPr>
         <p:spPr>
           <a:xfrm>
-            <a:off x="6460236" y="3017520"/>
-            <a:ext cx="2109978" cy="777240"/>
+            <a:off x="8354568" y="2560320"/>
+            <a:ext cx="3057144" cy="777240"/>
           </a:xfrm>
           <a:prstGeom prst="rect">
             <a:avLst/>
@@ -41742,30 +42010,30 @@
               <a:buNone/>
             </a:pPr>
             <a:r>
-              <a:rPr lang="en-US" sz="4000" b="1" dirty="0">
-                <a:solidFill>
-                  <a:srgbClr val="D97706"/>
-                </a:solidFill>
-                <a:latin typeface="Calibri" pitchFamily="34" charset="0"/>
-                <a:ea typeface="Calibri" pitchFamily="34" charset="-122"/>
-                <a:cs typeface="Calibri" pitchFamily="34" charset="-120"/>
-              </a:rPr>
-              <a:t>TBC</a:t>
-            </a:r>
-            <a:endParaRPr lang="en-US" sz="4000" dirty="0"/>
-          </a:p>
-        </p:txBody>
-      </p:sp>
-      <p:sp>
-        <p:nvSpPr>
-          <p:cNvPr id="22" name="Text 17"/>
+              <a:rPr lang="en-US" sz="4400" b="1" dirty="0">
+                <a:solidFill>
+                  <a:srgbClr val="111827"/>
+                </a:solidFill>
+                <a:latin typeface="Calibri" pitchFamily="34" charset="0"/>
+                <a:ea typeface="Calibri" pitchFamily="34" charset="-122"/>
+                <a:cs typeface="Calibri" pitchFamily="34" charset="-120"/>
+              </a:rPr>
+              <a:t>90.66%</a:t>
+            </a:r>
+            <a:endParaRPr lang="en-US" sz="4400" dirty="0"/>
+          </a:p>
+        </p:txBody>
+      </p:sp>
+      <p:sp>
+        <p:nvSpPr>
+          <p:cNvPr id="34" name="Text 29"/>
           <p:cNvSpPr txBox="1"/>
           <p:nvPr/>
         </p:nvSpPr>
         <p:spPr>
           <a:xfrm>
-            <a:off x="6460236" y="3840480"/>
-            <a:ext cx="2109978" cy="777240"/>
+            <a:off x="8354568" y="3337560"/>
+            <a:ext cx="3057144" cy="274320"/>
           </a:xfrm>
           <a:prstGeom prst="rect">
             <a:avLst/>
@@ -41774,7 +42042,7 @@
           <a:ln/>
         </p:spPr>
         <p:txBody>
-          <a:bodyPr wrap="square" lIns="0" tIns="0" rIns="0" bIns="0" rtlCol="0" anchor="t"/>
+          <a:bodyPr wrap="square" lIns="0" tIns="0" rIns="0" bIns="0" rtlCol="0" anchor="ctr"/>
           <a:lstStyle/>
           <a:p>
             <a:pPr indent="0" marL="0">
@@ -41783,71 +42051,40 @@
             <a:r>
               <a:rPr lang="en-US" sz="1200" dirty="0">
                 <a:solidFill>
-                  <a:srgbClr val="6B7280"/>
-                </a:solidFill>
-                <a:latin typeface="Calibri" pitchFamily="34" charset="0"/>
-                <a:ea typeface="Calibri" pitchFamily="34" charset="-122"/>
-                <a:cs typeface="Calibri" pitchFamily="34" charset="-120"/>
-              </a:rPr>
-              <a:t>Target 98%</a:t>
+                  <a:srgbClr val="1F2937"/>
+                </a:solidFill>
+                <a:latin typeface="Calibri" pitchFamily="34" charset="0"/>
+                <a:ea typeface="Calibri" pitchFamily="34" charset="-122"/>
+                <a:cs typeface="Calibri" pitchFamily="34" charset="-120"/>
+              </a:rPr>
+              <a:t>73.85K of 81.46K items</a:t>
             </a:r>
             <a:endParaRPr lang="en-US" sz="1200" dirty="0"/>
           </a:p>
-          <a:p>
-            <a:pPr indent="0" marL="0">
-              <a:buNone/>
-            </a:pPr>
-            <a:r>
-              <a:rPr lang="en-US" sz="1200" dirty="0">
-                <a:solidFill>
-                  <a:srgbClr val="6B7280"/>
-                </a:solidFill>
-                <a:latin typeface="Calibri" pitchFamily="34" charset="0"/>
-                <a:ea typeface="Calibri" pitchFamily="34" charset="-122"/>
-                <a:cs typeface="Calibri" pitchFamily="34" charset="-120"/>
-              </a:rPr>
-              <a:t>Gap to target: </a:t>
-            </a:r>
-            <a:pPr indent="0" marL="0">
-              <a:buNone/>
-            </a:pPr>
-            <a:r>
-              <a:rPr lang="en-US" sz="1200" b="1" dirty="0">
-                <a:solidFill>
-                  <a:srgbClr val="D97706"/>
-                </a:solidFill>
-                <a:latin typeface="Calibri" pitchFamily="34" charset="0"/>
-                <a:ea typeface="Calibri" pitchFamily="34" charset="-122"/>
-                <a:cs typeface="Calibri" pitchFamily="34" charset="-120"/>
-              </a:rPr>
-              <a:t>TBC</a:t>
-            </a:r>
-            <a:endParaRPr lang="en-US" sz="1200" dirty="0"/>
-          </a:p>
-        </p:txBody>
-      </p:sp>
-      <p:sp>
-        <p:nvSpPr>
-          <p:cNvPr id="23" name="Shape 18"/>
+        </p:txBody>
+      </p:sp>
+      <p:sp>
+        <p:nvSpPr>
+          <p:cNvPr id="35" name="Shape 30"/>
           <p:cNvSpPr/>
           <p:nvPr/>
         </p:nvSpPr>
         <p:spPr>
           <a:xfrm>
-            <a:off x="9073134" y="1783080"/>
-            <a:ext cx="2567178" cy="2971800"/>
+            <a:off x="8354568" y="3703320"/>
+            <a:ext cx="1600200" cy="329184"/>
           </a:xfrm>
           <a:prstGeom prst="roundRect">
             <a:avLst>
-              <a:gd name="adj" fmla="val 2850"/>
+              <a:gd name="adj" fmla="val 22222"/>
             </a:avLst>
           </a:prstGeom>
           <a:solidFill>
-            <a:srgbClr val="F3F4F6"/>
+            <a:srgbClr val="FEE2E2"/>
           </a:solidFill>
           <a:ln w="12700">
             <a:solidFill>
-              <a:srgbClr val="F3F4F6"/>
+              <a:srgbClr val="FEE2E2"/>
             </a:solidFill>
             <a:prstDash val="solid"/>
           </a:ln>
@@ -41855,63 +42092,119 @@
       </p:sp>
       <p:sp>
         <p:nvSpPr>
-          <p:cNvPr id="24" name="Shape 19"/>
+          <p:cNvPr id="36" name="Text 31"/>
+          <p:cNvSpPr txBox="1"/>
+          <p:nvPr/>
+        </p:nvSpPr>
+        <p:spPr>
+          <a:xfrm>
+            <a:off x="8354568" y="3703320"/>
+            <a:ext cx="1600200" cy="329184"/>
+          </a:xfrm>
+          <a:prstGeom prst="rect">
+            <a:avLst/>
+          </a:prstGeom>
+          <a:noFill/>
+          <a:ln/>
+        </p:spPr>
+        <p:txBody>
+          <a:bodyPr wrap="square" lIns="0" tIns="0" rIns="0" bIns="0" rtlCol="0" anchor="ctr"/>
+          <a:lstStyle/>
+          <a:p>
+            <a:pPr algn="ctr" indent="0" marL="0">
+              <a:buNone/>
+            </a:pPr>
+            <a:r>
+              <a:rPr lang="en-US" sz="1200" b="1" dirty="0">
+                <a:solidFill>
+                  <a:srgbClr val="DC2626"/>
+                </a:solidFill>
+                <a:latin typeface="Calibri" pitchFamily="34" charset="0"/>
+                <a:ea typeface="Calibri" pitchFamily="34" charset="-122"/>
+                <a:cs typeface="Calibri" pitchFamily="34" charset="-120"/>
+              </a:rPr>
+              <a:t>−0.13 pts</a:t>
+            </a:r>
+            <a:endParaRPr lang="en-US" sz="1200" dirty="0"/>
+          </a:p>
+        </p:txBody>
+      </p:sp>
+      <p:sp>
+        <p:nvSpPr>
+          <p:cNvPr id="37" name="Text 32"/>
+          <p:cNvSpPr txBox="1"/>
+          <p:nvPr/>
+        </p:nvSpPr>
+        <p:spPr>
+          <a:xfrm>
+            <a:off x="10046208" y="3703320"/>
+            <a:ext cx="1365504" cy="329184"/>
+          </a:xfrm>
+          <a:prstGeom prst="rect">
+            <a:avLst/>
+          </a:prstGeom>
+          <a:noFill/>
+          <a:ln/>
+        </p:spPr>
+        <p:txBody>
+          <a:bodyPr wrap="square" lIns="0" tIns="0" rIns="0" bIns="0" rtlCol="0" anchor="ctr"/>
+          <a:lstStyle/>
+          <a:p>
+            <a:pPr indent="0" marL="0">
+              <a:buNone/>
+            </a:pPr>
+            <a:r>
+              <a:rPr lang="en-US" sz="1100" dirty="0">
+                <a:solidFill>
+                  <a:srgbClr val="6B7280"/>
+                </a:solidFill>
+                <a:latin typeface="Calibri" pitchFamily="34" charset="0"/>
+                <a:ea typeface="Calibri" pitchFamily="34" charset="-122"/>
+                <a:cs typeface="Calibri" pitchFamily="34" charset="-120"/>
+              </a:rPr>
+              <a:t>vs last time period</a:t>
+            </a:r>
+            <a:endParaRPr lang="en-US" sz="1100" dirty="0"/>
+          </a:p>
+        </p:txBody>
+      </p:sp>
+      <p:sp>
+        <p:nvSpPr>
+          <p:cNvPr id="38" name="Shape 33"/>
           <p:cNvSpPr/>
           <p:nvPr/>
         </p:nvSpPr>
         <p:spPr>
           <a:xfrm>
-            <a:off x="9301734" y="2011680"/>
-            <a:ext cx="502920" cy="502920"/>
-          </a:xfrm>
-          <a:prstGeom prst="ellipse">
-            <a:avLst/>
+            <a:off x="8354568" y="4123944"/>
+            <a:ext cx="1600200" cy="329184"/>
+          </a:xfrm>
+          <a:prstGeom prst="roundRect">
+            <a:avLst>
+              <a:gd name="adj" fmla="val 22222"/>
+            </a:avLst>
           </a:prstGeom>
           <a:solidFill>
-            <a:srgbClr val="EDE9FE"/>
+            <a:srgbClr val="D1FAE5"/>
           </a:solidFill>
           <a:ln w="12700">
             <a:solidFill>
-              <a:srgbClr val="EDE9FE"/>
+              <a:srgbClr val="D1FAE5"/>
             </a:solidFill>
             <a:prstDash val="solid"/>
           </a:ln>
         </p:spPr>
       </p:sp>
-      <p:pic>
-        <p:nvPicPr>
-          <p:cNvPr id="25" name="Image 3" descr="preencoded.png">    </p:cNvPr>
-          <p:cNvPicPr>
-            <a:picLocks noChangeAspect="1"/>
-          </p:cNvPicPr>
-          <p:nvPr/>
-        </p:nvPicPr>
-        <p:blipFill>
-          <a:blip r:embed="rId4"/>
-          <a:stretch>
-            <a:fillRect/>
-          </a:stretch>
-        </p:blipFill>
-        <p:spPr>
-          <a:xfrm>
-            <a:off x="9427464" y="2137410"/>
-            <a:ext cx="251460" cy="251460"/>
-          </a:xfrm>
-          <a:prstGeom prst="rect">
-            <a:avLst/>
-          </a:prstGeom>
-        </p:spPr>
-      </p:pic>
-      <p:sp>
-        <p:nvSpPr>
-          <p:cNvPr id="26" name="Text 20"/>
+      <p:sp>
+        <p:nvSpPr>
+          <p:cNvPr id="39" name="Text 34"/>
           <p:cNvSpPr txBox="1"/>
           <p:nvPr/>
         </p:nvSpPr>
         <p:spPr>
           <a:xfrm>
-            <a:off x="9301734" y="2651760"/>
-            <a:ext cx="2109978" cy="365760"/>
+            <a:off x="8354568" y="4123944"/>
+            <a:ext cx="1600200" cy="329184"/>
           </a:xfrm>
           <a:prstGeom prst="rect">
             <a:avLst/>
@@ -41923,89 +42216,50 @@
           <a:bodyPr wrap="square" lIns="0" tIns="0" rIns="0" bIns="0" rtlCol="0" anchor="ctr"/>
           <a:lstStyle/>
           <a:p>
+            <a:pPr algn="ctr" indent="0" marL="0">
+              <a:buNone/>
+            </a:pPr>
+            <a:r>
+              <a:rPr lang="en-US" sz="1200" b="1" dirty="0">
+                <a:solidFill>
+                  <a:srgbClr val="059669"/>
+                </a:solidFill>
+                <a:latin typeface="Calibri" pitchFamily="34" charset="0"/>
+                <a:ea typeface="Calibri" pitchFamily="34" charset="-122"/>
+                <a:cs typeface="Calibri" pitchFamily="34" charset="-120"/>
+              </a:rPr>
+              <a:t>+1.54 pts</a:t>
+            </a:r>
+            <a:endParaRPr lang="en-US" sz="1200" dirty="0"/>
+          </a:p>
+        </p:txBody>
+      </p:sp>
+      <p:sp>
+        <p:nvSpPr>
+          <p:cNvPr id="40" name="Text 35"/>
+          <p:cNvSpPr txBox="1"/>
+          <p:nvPr/>
+        </p:nvSpPr>
+        <p:spPr>
+          <a:xfrm>
+            <a:off x="10046208" y="4123944"/>
+            <a:ext cx="1365504" cy="329184"/>
+          </a:xfrm>
+          <a:prstGeom prst="rect">
+            <a:avLst/>
+          </a:prstGeom>
+          <a:noFill/>
+          <a:ln/>
+        </p:spPr>
+        <p:txBody>
+          <a:bodyPr wrap="square" lIns="0" tIns="0" rIns="0" bIns="0" rtlCol="0" anchor="ctr"/>
+          <a:lstStyle/>
+          <a:p>
             <a:pPr indent="0" marL="0">
               <a:buNone/>
             </a:pPr>
             <a:r>
-              <a:rPr lang="en-US" sz="1600" b="1" dirty="0">
-                <a:solidFill>
-                  <a:srgbClr val="111827"/>
-                </a:solidFill>
-                <a:latin typeface="Calibri" pitchFamily="34" charset="0"/>
-                <a:ea typeface="Calibri" pitchFamily="34" charset="-122"/>
-                <a:cs typeface="Calibri" pitchFamily="34" charset="-120"/>
-              </a:rPr>
-              <a:t>Pickup trips</a:t>
-            </a:r>
-            <a:endParaRPr lang="en-US" sz="1600" dirty="0"/>
-          </a:p>
-        </p:txBody>
-      </p:sp>
-      <p:sp>
-        <p:nvSpPr>
-          <p:cNvPr id="27" name="Text 21"/>
-          <p:cNvSpPr txBox="1"/>
-          <p:nvPr/>
-        </p:nvSpPr>
-        <p:spPr>
-          <a:xfrm>
-            <a:off x="9301734" y="3017520"/>
-            <a:ext cx="2109978" cy="777240"/>
-          </a:xfrm>
-          <a:prstGeom prst="rect">
-            <a:avLst/>
-          </a:prstGeom>
-          <a:noFill/>
-          <a:ln/>
-        </p:spPr>
-        <p:txBody>
-          <a:bodyPr wrap="square" lIns="0" tIns="0" rIns="0" bIns="0" rtlCol="0" anchor="ctr"/>
-          <a:lstStyle/>
-          <a:p>
-            <a:pPr indent="0" marL="0">
-              <a:buNone/>
-            </a:pPr>
-            <a:r>
-              <a:rPr lang="en-US" sz="4000" b="1" dirty="0">
-                <a:solidFill>
-                  <a:srgbClr val="D97706"/>
-                </a:solidFill>
-                <a:latin typeface="Calibri" pitchFamily="34" charset="0"/>
-                <a:ea typeface="Calibri" pitchFamily="34" charset="-122"/>
-                <a:cs typeface="Calibri" pitchFamily="34" charset="-120"/>
-              </a:rPr>
-              <a:t>TBC</a:t>
-            </a:r>
-            <a:endParaRPr lang="en-US" sz="4000" dirty="0"/>
-          </a:p>
-        </p:txBody>
-      </p:sp>
-      <p:sp>
-        <p:nvSpPr>
-          <p:cNvPr id="28" name="Text 22"/>
-          <p:cNvSpPr txBox="1"/>
-          <p:nvPr/>
-        </p:nvSpPr>
-        <p:spPr>
-          <a:xfrm>
-            <a:off x="9301734" y="3840480"/>
-            <a:ext cx="2109978" cy="777240"/>
-          </a:xfrm>
-          <a:prstGeom prst="rect">
-            <a:avLst/>
-          </a:prstGeom>
-          <a:noFill/>
-          <a:ln/>
-        </p:spPr>
-        <p:txBody>
-          <a:bodyPr wrap="square" lIns="0" tIns="0" rIns="0" bIns="0" rtlCol="0" anchor="t"/>
-          <a:lstStyle/>
-          <a:p>
-            <a:pPr indent="0" marL="0">
-              <a:buNone/>
-            </a:pPr>
-            <a:r>
-              <a:rPr lang="en-US" sz="1200" dirty="0">
+              <a:rPr lang="en-US" sz="1100" dirty="0">
                 <a:solidFill>
                   <a:srgbClr val="6B7280"/>
                 </a:solidFill>
@@ -42013,57 +42267,26 @@
                 <a:ea typeface="Calibri" pitchFamily="34" charset="-122"/>
                 <a:cs typeface="Calibri" pitchFamily="34" charset="-120"/>
               </a:rPr>
-              <a:t>Target 98%</a:t>
-            </a:r>
-            <a:endParaRPr lang="en-US" sz="1200" dirty="0"/>
-          </a:p>
-          <a:p>
-            <a:pPr indent="0" marL="0">
-              <a:buNone/>
-            </a:pPr>
-            <a:r>
-              <a:rPr lang="en-US" sz="1200" dirty="0">
-                <a:solidFill>
-                  <a:srgbClr val="6B7280"/>
-                </a:solidFill>
-                <a:latin typeface="Calibri" pitchFamily="34" charset="0"/>
-                <a:ea typeface="Calibri" pitchFamily="34" charset="-122"/>
-                <a:cs typeface="Calibri" pitchFamily="34" charset="-120"/>
-              </a:rPr>
-              <a:t>Gap to target: </a:t>
-            </a:r>
-            <a:pPr indent="0" marL="0">
-              <a:buNone/>
-            </a:pPr>
-            <a:r>
-              <a:rPr lang="en-US" sz="1200" b="1" dirty="0">
-                <a:solidFill>
-                  <a:srgbClr val="D97706"/>
-                </a:solidFill>
-                <a:latin typeface="Calibri" pitchFamily="34" charset="0"/>
-                <a:ea typeface="Calibri" pitchFamily="34" charset="-122"/>
-                <a:cs typeface="Calibri" pitchFamily="34" charset="-120"/>
-              </a:rPr>
-              <a:t>TBC</a:t>
-            </a:r>
-            <a:endParaRPr lang="en-US" sz="1200" dirty="0"/>
-          </a:p>
-        </p:txBody>
-      </p:sp>
-      <p:sp>
-        <p:nvSpPr>
-          <p:cNvPr id="29" name="Shape 23"/>
+              <a:t>vs fiscal YTD (90.61%)</a:t>
+            </a:r>
+            <a:endParaRPr lang="en-US" sz="1100" dirty="0"/>
+          </a:p>
+        </p:txBody>
+      </p:sp>
+      <p:sp>
+        <p:nvSpPr>
+          <p:cNvPr id="41" name="Shape 36"/>
           <p:cNvSpPr/>
           <p:nvPr/>
         </p:nvSpPr>
         <p:spPr>
           <a:xfrm>
             <a:off x="548640" y="5029200"/>
-            <a:ext cx="11091672" cy="1143000"/>
+            <a:ext cx="11091672" cy="960120"/>
           </a:xfrm>
           <a:prstGeom prst="roundRect">
             <a:avLst>
-              <a:gd name="adj" fmla="val 6400"/>
+              <a:gd name="adj" fmla="val 7619"/>
             </a:avLst>
           </a:prstGeom>
           <a:solidFill>
@@ -42079,14 +42302,14 @@
       </p:sp>
       <p:sp>
         <p:nvSpPr>
-          <p:cNvPr id="30" name="Shape 24"/>
+          <p:cNvPr id="42" name="Shape 37"/>
           <p:cNvSpPr/>
           <p:nvPr/>
         </p:nvSpPr>
         <p:spPr>
           <a:xfrm>
-            <a:off x="777240" y="5303520"/>
-            <a:ext cx="566928" cy="566928"/>
+            <a:off x="777240" y="5239512"/>
+            <a:ext cx="548640" cy="548640"/>
           </a:xfrm>
           <a:prstGeom prst="ellipse">
             <a:avLst/>
@@ -42104,22 +42327,22 @@
       </p:sp>
       <p:pic>
         <p:nvPicPr>
-          <p:cNvPr id="31" name="Image 4" descr="preencoded.png">    </p:cNvPr>
+          <p:cNvPr id="43" name="Image 3" descr="preencoded.png">    </p:cNvPr>
           <p:cNvPicPr>
             <a:picLocks noChangeAspect="1"/>
           </p:cNvPicPr>
           <p:nvPr/>
         </p:nvPicPr>
         <p:blipFill>
-          <a:blip r:embed="rId5"/>
+          <a:blip r:embed="rId4"/>
           <a:stretch>
             <a:fillRect/>
           </a:stretch>
         </p:blipFill>
         <p:spPr>
           <a:xfrm>
-            <a:off x="918972" y="5445252"/>
-            <a:ext cx="283464" cy="283464"/>
+            <a:off x="914400" y="5376672"/>
+            <a:ext cx="274320" cy="274320"/>
           </a:xfrm>
           <a:prstGeom prst="rect">
             <a:avLst/>
@@ -42128,14 +42351,14 @@
       </p:pic>
       <p:sp>
         <p:nvSpPr>
-          <p:cNvPr id="32" name="Text 25"/>
+          <p:cNvPr id="44" name="Text 38"/>
           <p:cNvSpPr txBox="1"/>
           <p:nvPr/>
         </p:nvSpPr>
         <p:spPr>
           <a:xfrm>
-            <a:off x="1554480" y="5138928"/>
-            <a:ext cx="9875520" cy="914400"/>
+            <a:off x="1508760" y="5029200"/>
+            <a:ext cx="9966960" cy="960120"/>
           </a:xfrm>
           <a:prstGeom prst="rect">
             <a:avLst/>
@@ -42148,13 +42371,10 @@
           <a:lstStyle/>
           <a:p>
             <a:pPr indent="0" marL="0">
-              <a:spcAft>
-                <a:spcPts val="400"/>
-              </a:spcAft>
-              <a:buNone/>
-            </a:pPr>
-            <a:r>
-              <a:rPr lang="en-US" sz="1500" b="1" dirty="0">
+              <a:buNone/>
+            </a:pPr>
+            <a:r>
+              <a:rPr lang="en-US" sz="1350" b="1" dirty="0">
                 <a:solidFill>
                   <a:srgbClr val="111827"/>
                 </a:solidFill>
@@ -42162,35 +42382,71 @@
                 <a:ea typeface="Calibri" pitchFamily="34" charset="-122"/>
                 <a:cs typeface="Calibri" pitchFamily="34" charset="-120"/>
               </a:rPr>
-              <a:t>Scanning compliance checked every shift (see Scanning slide).</a:t>
-            </a:r>
-            <a:endParaRPr lang="en-US" sz="1500" dirty="0"/>
+              <a:t>All three scanning measures are ahead of fiscal YTD; ~4.5K freight bills a month still not scanned in/out — closing that gap also cuts 'already serviced' missed-PU false positives.</a:t>
+            </a:r>
+            <a:endParaRPr lang="en-US" sz="1350" dirty="0"/>
           </a:p>
           <a:p>
             <a:pPr indent="0" marL="0">
-              <a:spcAft>
-                <a:spcPts val="400"/>
-              </a:spcAft>
-              <a:buNone/>
-            </a:pPr>
-            <a:r>
-              <a:rPr lang="en-US" sz="1500" dirty="0">
-                <a:solidFill>
-                  <a:srgbClr val="1F2937"/>
-                </a:solidFill>
-                <a:latin typeface="Calibri" pitchFamily="34" charset="0"/>
-                <a:ea typeface="Calibri" pitchFamily="34" charset="-122"/>
-                <a:cs typeface="Calibri" pitchFamily="34" charset="-120"/>
-              </a:rPr>
-              <a:t>Drivers own the freight bill — ownership of the FB from inbound to delivery.</a:t>
-            </a:r>
-            <a:endParaRPr lang="en-US" sz="1500" dirty="0"/>
-          </a:p>
-        </p:txBody>
-      </p:sp>
-      <p:sp>
-        <p:nvSpPr>
-          <p:cNvPr id="33" name="Text 26"/>
+              <a:buNone/>
+            </a:pPr>
+            <a:r>
+              <a:rPr lang="en-US" sz="1000" i="1" dirty="0">
+                <a:solidFill>
+                  <a:srgbClr val="6B7280"/>
+                </a:solidFill>
+                <a:latin typeface="Calibri" pitchFamily="34" charset="0"/>
+                <a:ea typeface="Calibri" pitchFamily="34" charset="-122"/>
+                <a:cs typeface="Calibri" pitchFamily="34" charset="-120"/>
+              </a:rPr>
+              <a:t>Calculated: 52.77K − 48.22K = 4.55K FBs not scanned (Sep 1–28)</a:t>
+            </a:r>
+            <a:endParaRPr lang="en-US" sz="1350" dirty="0"/>
+          </a:p>
+        </p:txBody>
+      </p:sp>
+      <p:sp>
+        <p:nvSpPr>
+          <p:cNvPr id="45" name="Text 39"/>
+          <p:cNvSpPr txBox="1"/>
+          <p:nvPr/>
+        </p:nvSpPr>
+        <p:spPr>
+          <a:xfrm>
+            <a:off x="548640" y="6108192"/>
+            <a:ext cx="11091672" cy="256032"/>
+          </a:xfrm>
+          <a:prstGeom prst="rect">
+            <a:avLst/>
+          </a:prstGeom>
+          <a:noFill/>
+          <a:ln/>
+        </p:spPr>
+        <p:txBody>
+          <a:bodyPr wrap="square" lIns="0" tIns="0" rIns="0" bIns="0" rtlCol="0" anchor="ctr"/>
+          <a:lstStyle/>
+          <a:p>
+            <a:pPr indent="0" marL="0">
+              <a:buNone/>
+            </a:pPr>
+            <a:r>
+              <a:rPr lang="en-US" sz="950" i="1" dirty="0">
+                <a:solidFill>
+                  <a:srgbClr val="6B7280"/>
+                </a:solidFill>
+                <a:latin typeface="Calibri" pitchFamily="34" charset="0"/>
+                <a:ea typeface="Calibri" pitchFamily="34" charset="-122"/>
+                <a:cs typeface="Calibri" pitchFamily="34" charset="-120"/>
+              </a:rPr>
+              <a:t>Source: Compliance Reporting — Scanning Efficiency In/Out of Terminals · D&amp;R Commerce Mississauga · Sep 1–28, 2026 (28 days) · all trip types</a:t>
+            </a:r>
+            <a:endParaRPr lang="en-US" sz="950" dirty="0"/>
+          </a:p>
+        </p:txBody>
+      </p:sp>
+      <p:sp>
+        <p:nvSpPr>
+          <p:cNvPr id="46" name="Text 40"/>
           <p:cNvSpPr txBox="1"/>
           <p:nvPr/>
         </p:nvSpPr>
@@ -42229,7 +42485,7 @@
       </p:sp>
       <p:sp>
         <p:nvSpPr>
-          <p:cNvPr id="34" name="Text 27"/>
+          <p:cNvPr id="47" name="Text 41"/>
           <p:cNvSpPr txBox="1"/>
           <p:nvPr/>
         </p:nvSpPr>

</xml_diff>

<commit_message>
Deck: scanning slide says 'in line with fiscal YTD'
Co-Authored-By: Claude Opus 5.5 <noreply@anthropic.com>
Claude-Session: https://claude.ai/code/session_01BwRjju3y2wk3wSHFrM9KLe
</commit_message>
<xml_diff>
--- a/presentation/Mississauga_F27_Leadership_Review_Sep29.pptx
+++ b/presentation/Mississauga_F27_Leadership_Review_Sep29.pptx
@@ -5376,7 +5376,7 @@
           <a:p>
             <a:r>
               <a:rPr lang="en-US" dirty="0"/>
-              <a:t>For September 1 to 28, 91.37 percent of freight bills were scanned in and out of the terminal, 90.50 percent were completely scanned, and 90.66 percent of items were scanned. The dashboard shows all three ahead of fiscal year to date, though slightly down on the last period. That still leaves about 4,550 freight bills not scanned this month, and closing that gap also reduces the already-serviced false positives we saw in missed pickups.</a:t>
+              <a:t>For September 1 to 28, 91.37 percent of freight bills were scanned in and out of the terminal, 90.50 percent were completely scanned, and 90.66 percent of items were scanned. September is in line with fiscal year to date, at 91.4 against 91.6 percent of freight bills scanned, and slightly down on the last period. That still leaves about 4,550 freight bills not scanned this month, and closing that gap also reduces the already-serviced false positives we saw in missed pickups.</a:t>
             </a:r>
             <a:endParaRPr lang="en-US" dirty="0"/>
           </a:p>
@@ -41226,8 +41226,8 @@
         </p:nvSpPr>
         <p:spPr>
           <a:xfrm>
-            <a:off x="777240" y="3337560"/>
-            <a:ext cx="3057144" cy="274320"/>
+            <a:off x="731520" y="3337560"/>
+            <a:ext cx="3194304" cy="274320"/>
           </a:xfrm>
           <a:prstGeom prst="rect">
             <a:avLst/>
@@ -41243,7 +41243,7 @@
               <a:buNone/>
             </a:pPr>
             <a:r>
-              <a:rPr lang="en-US" sz="1200" dirty="0">
+              <a:rPr lang="en-US" sz="1050" dirty="0">
                 <a:solidFill>
                   <a:srgbClr val="1F2937"/>
                 </a:solidFill>
@@ -41251,9 +41251,9 @@
                 <a:ea typeface="Calibri" pitchFamily="34" charset="-122"/>
                 <a:cs typeface="Calibri" pitchFamily="34" charset="-120"/>
               </a:rPr>
-              <a:t>48.22K of 52.77K FBs</a:t>
-            </a:r>
-            <a:endParaRPr lang="en-US" sz="1200" dirty="0"/>
+              <a:t>48.22K of 52.77K FBs · fiscal YTD 91.55%</a:t>
+            </a:r>
+            <a:endParaRPr lang="en-US" sz="1050" dirty="0"/>
           </a:p>
         </p:txBody>
       </p:sp>
@@ -41461,7 +41461,7 @@
                 <a:ea typeface="Calibri" pitchFamily="34" charset="-122"/>
                 <a:cs typeface="Calibri" pitchFamily="34" charset="-120"/>
               </a:rPr>
-              <a:t>vs fiscal YTD (91.55%)</a:t>
+              <a:t>Fiscal YTD chg (dashboard)</a:t>
             </a:r>
             <a:endParaRPr lang="en-US" sz="1100" dirty="0"/>
           </a:p>
@@ -41629,8 +41629,8 @@
         </p:nvSpPr>
         <p:spPr>
           <a:xfrm>
-            <a:off x="4565904" y="3337560"/>
-            <a:ext cx="3057144" cy="274320"/>
+            <a:off x="4520184" y="3337560"/>
+            <a:ext cx="3194304" cy="274320"/>
           </a:xfrm>
           <a:prstGeom prst="rect">
             <a:avLst/>
@@ -41646,7 +41646,7 @@
               <a:buNone/>
             </a:pPr>
             <a:r>
-              <a:rPr lang="en-US" sz="1200" dirty="0">
+              <a:rPr lang="en-US" sz="1050" dirty="0">
                 <a:solidFill>
                   <a:srgbClr val="1F2937"/>
                 </a:solidFill>
@@ -41654,9 +41654,9 @@
                 <a:ea typeface="Calibri" pitchFamily="34" charset="-122"/>
                 <a:cs typeface="Calibri" pitchFamily="34" charset="-120"/>
               </a:rPr>
-              <a:t>47.76K of 52.77K FBs</a:t>
-            </a:r>
-            <a:endParaRPr lang="en-US" sz="1200" dirty="0"/>
+              <a:t>47.76K of 52.77K FBs · fiscal YTD 90.54%</a:t>
+            </a:r>
+            <a:endParaRPr lang="en-US" sz="1050" dirty="0"/>
           </a:p>
         </p:txBody>
       </p:sp>
@@ -41864,7 +41864,7 @@
                 <a:ea typeface="Calibri" pitchFamily="34" charset="-122"/>
                 <a:cs typeface="Calibri" pitchFamily="34" charset="-120"/>
               </a:rPr>
-              <a:t>vs fiscal YTD (90.54%)</a:t>
+              <a:t>Fiscal YTD chg (dashboard)</a:t>
             </a:r>
             <a:endParaRPr lang="en-US" sz="1100" dirty="0"/>
           </a:p>
@@ -42032,8 +42032,8 @@
         </p:nvSpPr>
         <p:spPr>
           <a:xfrm>
-            <a:off x="8354568" y="3337560"/>
-            <a:ext cx="3057144" cy="274320"/>
+            <a:off x="8308848" y="3337560"/>
+            <a:ext cx="3194304" cy="274320"/>
           </a:xfrm>
           <a:prstGeom prst="rect">
             <a:avLst/>
@@ -42049,7 +42049,7 @@
               <a:buNone/>
             </a:pPr>
             <a:r>
-              <a:rPr lang="en-US" sz="1200" dirty="0">
+              <a:rPr lang="en-US" sz="1050" dirty="0">
                 <a:solidFill>
                   <a:srgbClr val="1F2937"/>
                 </a:solidFill>
@@ -42057,9 +42057,9 @@
                 <a:ea typeface="Calibri" pitchFamily="34" charset="-122"/>
                 <a:cs typeface="Calibri" pitchFamily="34" charset="-120"/>
               </a:rPr>
-              <a:t>73.85K of 81.46K items</a:t>
-            </a:r>
-            <a:endParaRPr lang="en-US" sz="1200" dirty="0"/>
+              <a:t>73.85K of 81.46K items · fiscal YTD 90.61%</a:t>
+            </a:r>
+            <a:endParaRPr lang="en-US" sz="1050" dirty="0"/>
           </a:p>
         </p:txBody>
       </p:sp>
@@ -42267,7 +42267,7 @@
                 <a:ea typeface="Calibri" pitchFamily="34" charset="-122"/>
                 <a:cs typeface="Calibri" pitchFamily="34" charset="-120"/>
               </a:rPr>
-              <a:t>vs fiscal YTD (90.61%)</a:t>
+              <a:t>Fiscal YTD chg (dashboard)</a:t>
             </a:r>
             <a:endParaRPr lang="en-US" sz="1100" dirty="0"/>
           </a:p>
@@ -42382,7 +42382,7 @@
                 <a:ea typeface="Calibri" pitchFamily="34" charset="-122"/>
                 <a:cs typeface="Calibri" pitchFamily="34" charset="-120"/>
               </a:rPr>
-              <a:t>All three scanning measures are ahead of fiscal YTD; ~4.5K freight bills a month still not scanned in/out — closing that gap also cuts 'already serviced' missed-PU false positives.</a:t>
+              <a:t>September is in line with fiscal YTD (91.4% vs 91.6% of freight bills scanned). ≈4.55K freight bills were not scanned in/out Sep 1–28 — closing that gap also cuts 'already serviced' missed-PU false positives.</a:t>
             </a:r>
             <a:endParaRPr lang="en-US" sz="1350" dirty="0"/>
           </a:p>

</xml_diff>

<commit_message>
Deck: cargo claims (T-0502) on savings plan slide; 22 slides
Co-Authored-By: Claude Opus 5.5 <noreply@anthropic.com>
Claude-Session: https://claude.ai/code/session_01BwRjju3y2wk3wSHFrM9KLe
</commit_message>
<xml_diff>
--- a/presentation/Mississauga_F27_Leadership_Review_Sep29.pptx
+++ b/presentation/Mississauga_F27_Leadership_Review_Sep29.pptx
@@ -16207,7 +16207,7 @@
                 <a:ea typeface="Calibri" pitchFamily="34" charset="-122"/>
                 <a:cs typeface="Calibri" pitchFamily="34" charset="-120"/>
               </a:rPr>
-              <a:t>Total reweighs · all selected dates</a:t>
+              <a:t>Total reweighs · all dates</a:t>
             </a:r>
             <a:endParaRPr lang="en-US" sz="1050" dirty="0"/>
           </a:p>
@@ -16285,7 +16285,7 @@
                 <a:ea typeface="Calibri" pitchFamily="34" charset="-122"/>
                 <a:cs typeface="Calibri" pitchFamily="34" charset="-120"/>
               </a:rPr>
-              <a:t>44,283 vs 52K · incl. Mar ramp-up 75.4%</a:t>
+              <a:t>44,283 vs 52K · incl. Mar ramp-up</a:t>
             </a:r>
             <a:endParaRPr lang="en-US" sz="1050" dirty="0"/>
           </a:p>

</xml_diff>

<commit_message>
Deck: Mississauga TRIR on safety and title slides
Co-Authored-By: Claude Opus 5.5 <noreply@anthropic.com>
Claude-Session: https://claude.ai/code/session_01BwRjju3y2wk3wSHFrM9KLe
</commit_message>
<xml_diff>
--- a/presentation/Mississauga_F27_Leadership_Review_Sep29.pptx
+++ b/presentation/Mississauga_F27_Leadership_Review_Sep29.pptx
@@ -5669,7 +5669,7 @@
           <a:p>
             <a:r>
               <a:rPr lang="en-US" dirty="0"/>
-              <a:t>TRIR figures for F27 year to date are being confirmed with OHS and will be filled in before distribution. Every shift starts with a tailgate and forklift inspections, and after any incident we run a specific safety moment. Supervisors and managers correct non-compliance on the spot and record it in their STEP observations, and dock conditions are documented and reviewed at JHSC.</a:t>
+              <a:t>We have had zero recordable incidents in F27 to date, July and August, so our F27 TRIR is 0.00 against 1.21 for F26 and a 12-month average of 1.21, a 100 percent improvement. Every shift starts with a tailgate and forklift inspections, and after any incident we run a specific safety moment. Supervisors and managers correct non-compliance on the spot and record it in their STEP observations, and dock conditions are documented and reviewed at JHSC.</a:t>
             </a:r>
             <a:endParaRPr lang="en-US" dirty="0"/>
           </a:p>
@@ -6856,7 +6856,7 @@
                 <a:ea typeface="Calibri" pitchFamily="34" charset="-122"/>
                 <a:cs typeface="Calibri" pitchFamily="34" charset="-120"/>
               </a:rPr>
-              <a:t>SEPT MTD · AS OF SEP 26</a:t>
+              <a:t>F27 HEADLINES · LATEST</a:t>
             </a:r>
             <a:endParaRPr lang="en-US" sz="1100" dirty="0"/>
           </a:p>
@@ -6870,8 +6870,8 @@
         </p:nvSpPr>
         <p:spPr>
           <a:xfrm>
-            <a:off x="8641080" y="1783080"/>
-            <a:ext cx="1325880" cy="457200"/>
+            <a:off x="8641080" y="1719072"/>
+            <a:ext cx="1325880" cy="438912"/>
           </a:xfrm>
           <a:prstGeom prst="rect">
             <a:avLst/>
@@ -6887,15 +6887,536 @@
               <a:buNone/>
             </a:pPr>
             <a:r>
+              <a:rPr lang="en-US" sz="2100" b="1" dirty="0">
+                <a:solidFill>
+                  <a:srgbClr val="34D399"/>
+                </a:solidFill>
+                <a:latin typeface="Calibri" pitchFamily="34" charset="0"/>
+                <a:ea typeface="Calibri" pitchFamily="34" charset="-122"/>
+                <a:cs typeface="Calibri" pitchFamily="34" charset="-120"/>
+              </a:rPr>
+              <a:t>0.00</a:t>
+            </a:r>
+            <a:endParaRPr lang="en-US" sz="2100" dirty="0"/>
+          </a:p>
+        </p:txBody>
+      </p:sp>
+      <p:sp>
+        <p:nvSpPr>
+          <p:cNvPr id="10" name="Text 8"/>
+          <p:cNvSpPr txBox="1"/>
+          <p:nvPr/>
+        </p:nvSpPr>
+        <p:spPr>
+          <a:xfrm>
+            <a:off x="10012680" y="1719072"/>
+            <a:ext cx="1508760" cy="438912"/>
+          </a:xfrm>
+          <a:prstGeom prst="rect">
+            <a:avLst/>
+          </a:prstGeom>
+          <a:noFill/>
+          <a:ln/>
+        </p:spPr>
+        <p:txBody>
+          <a:bodyPr wrap="square" lIns="0" tIns="0" rIns="0" bIns="0" rtlCol="0" anchor="ctr"/>
+          <a:lstStyle/>
+          <a:p>
+            <a:pPr indent="0" marL="0">
+              <a:buNone/>
+            </a:pPr>
+            <a:r>
+              <a:rPr lang="en-US" sz="1100" dirty="0">
+                <a:solidFill>
+                  <a:srgbClr val="D1D5DB"/>
+                </a:solidFill>
+                <a:latin typeface="Calibri" pitchFamily="34" charset="0"/>
+                <a:ea typeface="Calibri" pitchFamily="34" charset="-122"/>
+                <a:cs typeface="Calibri" pitchFamily="34" charset="-120"/>
+              </a:rPr>
+              <a:t>TRIR F27 YTD (Jul–Aug)</a:t>
+            </a:r>
+            <a:endParaRPr lang="en-US" sz="1100" dirty="0"/>
+          </a:p>
+        </p:txBody>
+      </p:sp>
+      <p:sp>
+        <p:nvSpPr>
+          <p:cNvPr id="11" name="Text 9"/>
+          <p:cNvSpPr txBox="1"/>
+          <p:nvPr/>
+        </p:nvSpPr>
+        <p:spPr>
+          <a:xfrm>
+            <a:off x="8641080" y="2176272"/>
+            <a:ext cx="1325880" cy="438912"/>
+          </a:xfrm>
+          <a:prstGeom prst="rect">
+            <a:avLst/>
+          </a:prstGeom>
+          <a:noFill/>
+          <a:ln/>
+        </p:spPr>
+        <p:txBody>
+          <a:bodyPr wrap="square" lIns="0" tIns="0" rIns="0" bIns="0" rtlCol="0" anchor="ctr"/>
+          <a:lstStyle/>
+          <a:p>
+            <a:pPr indent="0" marL="0">
+              <a:buNone/>
+            </a:pPr>
+            <a:r>
+              <a:rPr lang="en-US" sz="2100" b="1" dirty="0">
+                <a:solidFill>
+                  <a:srgbClr val="34D399"/>
+                </a:solidFill>
+                <a:latin typeface="Calibri" pitchFamily="34" charset="0"/>
+                <a:ea typeface="Calibri" pitchFamily="34" charset="-122"/>
+                <a:cs typeface="Calibri" pitchFamily="34" charset="-120"/>
+              </a:rPr>
+              <a:t>93.7%</a:t>
+            </a:r>
+            <a:endParaRPr lang="en-US" sz="2100" dirty="0"/>
+          </a:p>
+        </p:txBody>
+      </p:sp>
+      <p:sp>
+        <p:nvSpPr>
+          <p:cNvPr id="12" name="Text 10"/>
+          <p:cNvSpPr txBox="1"/>
+          <p:nvPr/>
+        </p:nvSpPr>
+        <p:spPr>
+          <a:xfrm>
+            <a:off x="10012680" y="2176272"/>
+            <a:ext cx="1508760" cy="438912"/>
+          </a:xfrm>
+          <a:prstGeom prst="rect">
+            <a:avLst/>
+          </a:prstGeom>
+          <a:noFill/>
+          <a:ln/>
+        </p:spPr>
+        <p:txBody>
+          <a:bodyPr wrap="square" lIns="0" tIns="0" rIns="0" bIns="0" rtlCol="0" anchor="ctr"/>
+          <a:lstStyle/>
+          <a:p>
+            <a:pPr indent="0" marL="0">
+              <a:buNone/>
+            </a:pPr>
+            <a:r>
+              <a:rPr lang="en-US" sz="1100" dirty="0">
+                <a:solidFill>
+                  <a:srgbClr val="D1D5DB"/>
+                </a:solidFill>
+                <a:latin typeface="Calibri" pitchFamily="34" charset="0"/>
+                <a:ea typeface="Calibri" pitchFamily="34" charset="-122"/>
+                <a:cs typeface="Calibri" pitchFamily="34" charset="-120"/>
+              </a:rPr>
+              <a:t>OTS Sept (adj., incl. partners)</a:t>
+            </a:r>
+            <a:endParaRPr lang="en-US" sz="1100" dirty="0"/>
+          </a:p>
+        </p:txBody>
+      </p:sp>
+      <p:sp>
+        <p:nvSpPr>
+          <p:cNvPr id="13" name="Text 11"/>
+          <p:cNvSpPr txBox="1"/>
+          <p:nvPr/>
+        </p:nvSpPr>
+        <p:spPr>
+          <a:xfrm>
+            <a:off x="8641080" y="2633472"/>
+            <a:ext cx="1325880" cy="438912"/>
+          </a:xfrm>
+          <a:prstGeom prst="rect">
+            <a:avLst/>
+          </a:prstGeom>
+          <a:noFill/>
+          <a:ln/>
+        </p:spPr>
+        <p:txBody>
+          <a:bodyPr wrap="square" lIns="0" tIns="0" rIns="0" bIns="0" rtlCol="0" anchor="ctr"/>
+          <a:lstStyle/>
+          <a:p>
+            <a:pPr indent="0" marL="0">
+              <a:buNone/>
+            </a:pPr>
+            <a:r>
+              <a:rPr lang="en-US" sz="2100" b="1" dirty="0">
+                <a:solidFill>
+                  <a:srgbClr val="34D399"/>
+                </a:solidFill>
+                <a:latin typeface="Calibri" pitchFamily="34" charset="0"/>
+                <a:ea typeface="Calibri" pitchFamily="34" charset="-122"/>
+                <a:cs typeface="Calibri" pitchFamily="34" charset="-120"/>
+              </a:rPr>
+              <a:t>91.1%</a:t>
+            </a:r>
+            <a:endParaRPr lang="en-US" sz="2100" dirty="0"/>
+          </a:p>
+        </p:txBody>
+      </p:sp>
+      <p:sp>
+        <p:nvSpPr>
+          <p:cNvPr id="14" name="Text 12"/>
+          <p:cNvSpPr txBox="1"/>
+          <p:nvPr/>
+        </p:nvSpPr>
+        <p:spPr>
+          <a:xfrm>
+            <a:off x="10012680" y="2633472"/>
+            <a:ext cx="1508760" cy="438912"/>
+          </a:xfrm>
+          <a:prstGeom prst="rect">
+            <a:avLst/>
+          </a:prstGeom>
+          <a:noFill/>
+          <a:ln/>
+        </p:spPr>
+        <p:txBody>
+          <a:bodyPr wrap="square" lIns="0" tIns="0" rIns="0" bIns="0" rtlCol="0" anchor="ctr"/>
+          <a:lstStyle/>
+          <a:p>
+            <a:pPr indent="0" marL="0">
+              <a:buNone/>
+            </a:pPr>
+            <a:r>
+              <a:rPr lang="en-US" sz="1100" dirty="0">
+                <a:solidFill>
+                  <a:srgbClr val="D1D5DB"/>
+                </a:solidFill>
+                <a:latin typeface="Calibri" pitchFamily="34" charset="0"/>
+                <a:ea typeface="Calibri" pitchFamily="34" charset="-122"/>
+                <a:cs typeface="Calibri" pitchFamily="34" charset="-120"/>
+              </a:rPr>
+              <a:t>of SCA hour allowance</a:t>
+            </a:r>
+            <a:endParaRPr lang="en-US" sz="1100" dirty="0"/>
+          </a:p>
+        </p:txBody>
+      </p:sp>
+      <p:sp>
+        <p:nvSpPr>
+          <p:cNvPr id="15" name="Text 13"/>
+          <p:cNvSpPr txBox="1"/>
+          <p:nvPr/>
+        </p:nvSpPr>
+        <p:spPr>
+          <a:xfrm>
+            <a:off x="8641080" y="3090672"/>
+            <a:ext cx="1325880" cy="438912"/>
+          </a:xfrm>
+          <a:prstGeom prst="rect">
+            <a:avLst/>
+          </a:prstGeom>
+          <a:noFill/>
+          <a:ln/>
+        </p:spPr>
+        <p:txBody>
+          <a:bodyPr wrap="square" lIns="0" tIns="0" rIns="0" bIns="0" rtlCol="0" anchor="ctr"/>
+          <a:lstStyle/>
+          <a:p>
+            <a:pPr indent="0" marL="0">
+              <a:buNone/>
+            </a:pPr>
+            <a:r>
+              <a:rPr lang="en-US" sz="2100" b="1" dirty="0">
+                <a:solidFill>
+                  <a:srgbClr val="34D399"/>
+                </a:solidFill>
+                <a:latin typeface="Calibri" pitchFamily="34" charset="0"/>
+                <a:ea typeface="Calibri" pitchFamily="34" charset="-122"/>
+                <a:cs typeface="Calibri" pitchFamily="34" charset="-120"/>
+              </a:rPr>
+              <a:t>−16.7%</a:t>
+            </a:r>
+            <a:endParaRPr lang="en-US" sz="2100" dirty="0"/>
+          </a:p>
+        </p:txBody>
+      </p:sp>
+      <p:sp>
+        <p:nvSpPr>
+          <p:cNvPr id="16" name="Text 14"/>
+          <p:cNvSpPr txBox="1"/>
+          <p:nvPr/>
+        </p:nvSpPr>
+        <p:spPr>
+          <a:xfrm>
+            <a:off x="10012680" y="3090672"/>
+            <a:ext cx="1508760" cy="438912"/>
+          </a:xfrm>
+          <a:prstGeom prst="rect">
+            <a:avLst/>
+          </a:prstGeom>
+          <a:noFill/>
+          <a:ln/>
+        </p:spPr>
+        <p:txBody>
+          <a:bodyPr wrap="square" lIns="0" tIns="0" rIns="0" bIns="0" rtlCol="0" anchor="ctr"/>
+          <a:lstStyle/>
+          <a:p>
+            <a:pPr indent="0" marL="0">
+              <a:buNone/>
+            </a:pPr>
+            <a:r>
+              <a:rPr lang="en-US" sz="1100" dirty="0">
+                <a:solidFill>
+                  <a:srgbClr val="D1D5DB"/>
+                </a:solidFill>
+                <a:latin typeface="Calibri" pitchFamily="34" charset="0"/>
+                <a:ea typeface="Calibri" pitchFamily="34" charset="-122"/>
+                <a:cs typeface="Calibri" pitchFamily="34" charset="-120"/>
+              </a:rPr>
+              <a:t>cost per unit vs F26</a:t>
+            </a:r>
+            <a:endParaRPr lang="en-US" sz="1100" dirty="0"/>
+          </a:p>
+        </p:txBody>
+      </p:sp>
+      <p:sp>
+        <p:nvSpPr>
+          <p:cNvPr id="17" name="Text 15"/>
+          <p:cNvSpPr txBox="1"/>
+          <p:nvPr/>
+        </p:nvSpPr>
+        <p:spPr>
+          <a:xfrm>
+            <a:off x="8641080" y="3547872"/>
+            <a:ext cx="1325880" cy="438912"/>
+          </a:xfrm>
+          <a:prstGeom prst="rect">
+            <a:avLst/>
+          </a:prstGeom>
+          <a:noFill/>
+          <a:ln/>
+        </p:spPr>
+        <p:txBody>
+          <a:bodyPr wrap="square" lIns="0" tIns="0" rIns="0" bIns="0" rtlCol="0" anchor="ctr"/>
+          <a:lstStyle/>
+          <a:p>
+            <a:pPr indent="0" marL="0">
+              <a:buNone/>
+            </a:pPr>
+            <a:r>
+              <a:rPr lang="en-US" sz="2100" b="1" dirty="0">
+                <a:solidFill>
+                  <a:srgbClr val="34D399"/>
+                </a:solidFill>
+                <a:latin typeface="Calibri" pitchFamily="34" charset="0"/>
+                <a:ea typeface="Calibri" pitchFamily="34" charset="-122"/>
+                <a:cs typeface="Calibri" pitchFamily="34" charset="-120"/>
+              </a:rPr>
+              <a:t>+26.7%</a:t>
+            </a:r>
+            <a:endParaRPr lang="en-US" sz="2100" dirty="0"/>
+          </a:p>
+        </p:txBody>
+      </p:sp>
+      <p:sp>
+        <p:nvSpPr>
+          <p:cNvPr id="18" name="Text 16"/>
+          <p:cNvSpPr txBox="1"/>
+          <p:nvPr/>
+        </p:nvSpPr>
+        <p:spPr>
+          <a:xfrm>
+            <a:off x="10012680" y="3547872"/>
+            <a:ext cx="1508760" cy="438912"/>
+          </a:xfrm>
+          <a:prstGeom prst="rect">
+            <a:avLst/>
+          </a:prstGeom>
+          <a:noFill/>
+          <a:ln/>
+        </p:spPr>
+        <p:txBody>
+          <a:bodyPr wrap="square" lIns="0" tIns="0" rIns="0" bIns="0" rtlCol="0" anchor="ctr"/>
+          <a:lstStyle/>
+          <a:p>
+            <a:pPr indent="0" marL="0">
+              <a:buNone/>
+            </a:pPr>
+            <a:r>
+              <a:rPr lang="en-US" sz="1100" dirty="0">
+                <a:solidFill>
+                  <a:srgbClr val="D1D5DB"/>
+                </a:solidFill>
+                <a:latin typeface="Calibri" pitchFamily="34" charset="0"/>
+                <a:ea typeface="Calibri" pitchFamily="34" charset="-122"/>
+                <a:cs typeface="Calibri" pitchFamily="34" charset="-120"/>
+              </a:rPr>
+              <a:t>units per hour vs F26</a:t>
+            </a:r>
+            <a:endParaRPr lang="en-US" sz="1100" dirty="0"/>
+          </a:p>
+        </p:txBody>
+      </p:sp>
+      <p:sp>
+        <p:nvSpPr>
+          <p:cNvPr id="19" name="Text 17"/>
+          <p:cNvSpPr txBox="1"/>
+          <p:nvPr/>
+        </p:nvSpPr>
+        <p:spPr>
+          <a:xfrm>
+            <a:off x="8641080" y="4005072"/>
+            <a:ext cx="1325880" cy="438912"/>
+          </a:xfrm>
+          <a:prstGeom prst="rect">
+            <a:avLst/>
+          </a:prstGeom>
+          <a:noFill/>
+          <a:ln/>
+        </p:spPr>
+        <p:txBody>
+          <a:bodyPr wrap="square" lIns="0" tIns="0" rIns="0" bIns="0" rtlCol="0" anchor="ctr"/>
+          <a:lstStyle/>
+          <a:p>
+            <a:pPr indent="0" marL="0">
+              <a:buNone/>
+            </a:pPr>
+            <a:r>
+              <a:rPr lang="en-US" sz="2100" b="1" dirty="0">
+                <a:solidFill>
+                  <a:srgbClr val="34D399"/>
+                </a:solidFill>
+                <a:latin typeface="Calibri" pitchFamily="34" charset="0"/>
+                <a:ea typeface="Calibri" pitchFamily="34" charset="-122"/>
+                <a:cs typeface="Calibri" pitchFamily="34" charset="-120"/>
+              </a:rPr>
+              <a:t>9 hrs</a:t>
+            </a:r>
+            <a:endParaRPr lang="en-US" sz="2100" dirty="0"/>
+          </a:p>
+        </p:txBody>
+      </p:sp>
+      <p:sp>
+        <p:nvSpPr>
+          <p:cNvPr id="20" name="Text 18"/>
+          <p:cNvSpPr txBox="1"/>
+          <p:nvPr/>
+        </p:nvSpPr>
+        <p:spPr>
+          <a:xfrm>
+            <a:off x="10012680" y="4005072"/>
+            <a:ext cx="1508760" cy="438912"/>
+          </a:xfrm>
+          <a:prstGeom prst="rect">
+            <a:avLst/>
+          </a:prstGeom>
+          <a:noFill/>
+          <a:ln/>
+        </p:spPr>
+        <p:txBody>
+          <a:bodyPr wrap="square" lIns="0" tIns="0" rIns="0" bIns="0" rtlCol="0" anchor="ctr"/>
+          <a:lstStyle/>
+          <a:p>
+            <a:pPr indent="0" marL="0">
+              <a:buNone/>
+            </a:pPr>
+            <a:r>
+              <a:rPr lang="en-US" sz="1100" dirty="0">
+                <a:solidFill>
+                  <a:srgbClr val="D1D5DB"/>
+                </a:solidFill>
+                <a:latin typeface="Calibri" pitchFamily="34" charset="0"/>
+                <a:ea typeface="Calibri" pitchFamily="34" charset="-122"/>
+                <a:cs typeface="Calibri" pitchFamily="34" charset="-120"/>
+              </a:rPr>
+              <a:t>overtime MTD</a:t>
+            </a:r>
+            <a:endParaRPr lang="en-US" sz="1100" dirty="0"/>
+          </a:p>
+        </p:txBody>
+      </p:sp>
+      <p:sp>
+        <p:nvSpPr>
+          <p:cNvPr id="21" name="Text 19"/>
+          <p:cNvSpPr txBox="1"/>
+          <p:nvPr/>
+        </p:nvSpPr>
+        <p:spPr>
+          <a:xfrm>
+            <a:off x="8641080" y="4507992"/>
+            <a:ext cx="2834640" cy="274320"/>
+          </a:xfrm>
+          <a:prstGeom prst="rect">
+            <a:avLst/>
+          </a:prstGeom>
+          <a:noFill/>
+          <a:ln/>
+        </p:spPr>
+        <p:txBody>
+          <a:bodyPr wrap="square" lIns="0" tIns="0" rIns="0" bIns="0" rtlCol="0" anchor="ctr"/>
+          <a:lstStyle/>
+          <a:p>
+            <a:pPr indent="0" marL="0">
+              <a:buNone/>
+            </a:pPr>
+            <a:r>
+              <a:rPr lang="en-US" sz="1100" b="1" spc="200" kern="0" dirty="0">
+                <a:solidFill>
+                  <a:srgbClr val="A78BFA"/>
+                </a:solidFill>
+                <a:latin typeface="Calibri" pitchFamily="34" charset="0"/>
+                <a:ea typeface="Calibri" pitchFamily="34" charset="-122"/>
+                <a:cs typeface="Calibri" pitchFamily="34" charset="-120"/>
+              </a:rPr>
+              <a:t>FOCUS</a:t>
+            </a:r>
+            <a:endParaRPr lang="en-US" sz="1100" dirty="0"/>
+          </a:p>
+        </p:txBody>
+      </p:sp>
+      <p:sp>
+        <p:nvSpPr>
+          <p:cNvPr id="22" name="Text 20"/>
+          <p:cNvSpPr txBox="1"/>
+          <p:nvPr/>
+        </p:nvSpPr>
+        <p:spPr>
+          <a:xfrm>
+            <a:off x="8641080" y="4754880"/>
+            <a:ext cx="2834640" cy="457200"/>
+          </a:xfrm>
+          <a:prstGeom prst="rect">
+            <a:avLst/>
+          </a:prstGeom>
+          <a:noFill/>
+          <a:ln/>
+        </p:spPr>
+        <p:txBody>
+          <a:bodyPr wrap="square" lIns="0" tIns="0" rIns="0" bIns="0" rtlCol="0" anchor="ctr"/>
+          <a:lstStyle/>
+          <a:p>
+            <a:pPr indent="0" marL="0">
+              <a:buNone/>
+            </a:pPr>
+            <a:r>
               <a:rPr lang="en-US" sz="2200" b="1" dirty="0">
                 <a:solidFill>
-                  <a:srgbClr val="34D399"/>
-                </a:solidFill>
-                <a:latin typeface="Calibri" pitchFamily="34" charset="0"/>
-                <a:ea typeface="Calibri" pitchFamily="34" charset="-122"/>
-                <a:cs typeface="Calibri" pitchFamily="34" charset="-120"/>
-              </a:rPr>
-              <a:t>93.7%</a:t>
+                  <a:srgbClr val="F87171"/>
+                </a:solidFill>
+                <a:latin typeface="Calibri" pitchFamily="34" charset="0"/>
+                <a:ea typeface="Calibri" pitchFamily="34" charset="-122"/>
+                <a:cs typeface="Calibri" pitchFamily="34" charset="-120"/>
+              </a:rPr>
+              <a:t>−21.9%</a:t>
+            </a:r>
+            <a:pPr indent="0" marL="0">
+              <a:buNone/>
+            </a:pPr>
+            <a:r>
+              <a:rPr lang="en-US" sz="1300" dirty="0">
+                <a:solidFill>
+                  <a:srgbClr val="D1D5DB"/>
+                </a:solidFill>
+                <a:latin typeface="Calibri" pitchFamily="34" charset="0"/>
+                <a:ea typeface="Calibri" pitchFamily="34" charset="-122"/>
+                <a:cs typeface="Calibri" pitchFamily="34" charset="-120"/>
+              </a:rPr>
+              <a:t>  PPH gap to goal</a:t>
             </a:r>
             <a:endParaRPr lang="en-US" sz="2200" dirty="0"/>
           </a:p>
@@ -6903,456 +7424,13 @@
       </p:sp>
       <p:sp>
         <p:nvSpPr>
-          <p:cNvPr id="10" name="Text 8"/>
-          <p:cNvSpPr txBox="1"/>
-          <p:nvPr/>
-        </p:nvSpPr>
-        <p:spPr>
-          <a:xfrm>
-            <a:off x="10012680" y="1783080"/>
-            <a:ext cx="1508760" cy="457200"/>
-          </a:xfrm>
-          <a:prstGeom prst="rect">
-            <a:avLst/>
-          </a:prstGeom>
-          <a:noFill/>
-          <a:ln/>
-        </p:spPr>
-        <p:txBody>
-          <a:bodyPr wrap="square" lIns="0" tIns="0" rIns="0" bIns="0" rtlCol="0" anchor="ctr"/>
-          <a:lstStyle/>
-          <a:p>
-            <a:pPr indent="0" marL="0">
-              <a:buNone/>
-            </a:pPr>
-            <a:r>
-              <a:rPr lang="en-US" sz="1150" dirty="0">
-                <a:solidFill>
-                  <a:srgbClr val="D1D5DB"/>
-                </a:solidFill>
-                <a:latin typeface="Calibri" pitchFamily="34" charset="0"/>
-                <a:ea typeface="Calibri" pitchFamily="34" charset="-122"/>
-                <a:cs typeface="Calibri" pitchFamily="34" charset="-120"/>
-              </a:rPr>
-              <a:t>OTS Sept (adj., incl. partners)</a:t>
-            </a:r>
-            <a:endParaRPr lang="en-US" sz="1150" dirty="0"/>
-          </a:p>
-        </p:txBody>
-      </p:sp>
-      <p:sp>
-        <p:nvSpPr>
-          <p:cNvPr id="11" name="Text 9"/>
-          <p:cNvSpPr txBox="1"/>
-          <p:nvPr/>
-        </p:nvSpPr>
-        <p:spPr>
-          <a:xfrm>
-            <a:off x="8641080" y="2286000"/>
-            <a:ext cx="1325880" cy="457200"/>
-          </a:xfrm>
-          <a:prstGeom prst="rect">
-            <a:avLst/>
-          </a:prstGeom>
-          <a:noFill/>
-          <a:ln/>
-        </p:spPr>
-        <p:txBody>
-          <a:bodyPr wrap="square" lIns="0" tIns="0" rIns="0" bIns="0" rtlCol="0" anchor="ctr"/>
-          <a:lstStyle/>
-          <a:p>
-            <a:pPr indent="0" marL="0">
-              <a:buNone/>
-            </a:pPr>
-            <a:r>
-              <a:rPr lang="en-US" sz="2200" b="1" dirty="0">
-                <a:solidFill>
-                  <a:srgbClr val="34D399"/>
-                </a:solidFill>
-                <a:latin typeface="Calibri" pitchFamily="34" charset="0"/>
-                <a:ea typeface="Calibri" pitchFamily="34" charset="-122"/>
-                <a:cs typeface="Calibri" pitchFamily="34" charset="-120"/>
-              </a:rPr>
-              <a:t>91.1%</a:t>
-            </a:r>
-            <a:endParaRPr lang="en-US" sz="2200" dirty="0"/>
-          </a:p>
-        </p:txBody>
-      </p:sp>
-      <p:sp>
-        <p:nvSpPr>
-          <p:cNvPr id="12" name="Text 10"/>
-          <p:cNvSpPr txBox="1"/>
-          <p:nvPr/>
-        </p:nvSpPr>
-        <p:spPr>
-          <a:xfrm>
-            <a:off x="10012680" y="2286000"/>
-            <a:ext cx="1508760" cy="457200"/>
-          </a:xfrm>
-          <a:prstGeom prst="rect">
-            <a:avLst/>
-          </a:prstGeom>
-          <a:noFill/>
-          <a:ln/>
-        </p:spPr>
-        <p:txBody>
-          <a:bodyPr wrap="square" lIns="0" tIns="0" rIns="0" bIns="0" rtlCol="0" anchor="ctr"/>
-          <a:lstStyle/>
-          <a:p>
-            <a:pPr indent="0" marL="0">
-              <a:buNone/>
-            </a:pPr>
-            <a:r>
-              <a:rPr lang="en-US" sz="1150" dirty="0">
-                <a:solidFill>
-                  <a:srgbClr val="D1D5DB"/>
-                </a:solidFill>
-                <a:latin typeface="Calibri" pitchFamily="34" charset="0"/>
-                <a:ea typeface="Calibri" pitchFamily="34" charset="-122"/>
-                <a:cs typeface="Calibri" pitchFamily="34" charset="-120"/>
-              </a:rPr>
-              <a:t>of SCA hour allowance</a:t>
-            </a:r>
-            <a:endParaRPr lang="en-US" sz="1150" dirty="0"/>
-          </a:p>
-        </p:txBody>
-      </p:sp>
-      <p:sp>
-        <p:nvSpPr>
-          <p:cNvPr id="13" name="Text 11"/>
-          <p:cNvSpPr txBox="1"/>
-          <p:nvPr/>
-        </p:nvSpPr>
-        <p:spPr>
-          <a:xfrm>
-            <a:off x="8641080" y="2788920"/>
-            <a:ext cx="1325880" cy="457200"/>
-          </a:xfrm>
-          <a:prstGeom prst="rect">
-            <a:avLst/>
-          </a:prstGeom>
-          <a:noFill/>
-          <a:ln/>
-        </p:spPr>
-        <p:txBody>
-          <a:bodyPr wrap="square" lIns="0" tIns="0" rIns="0" bIns="0" rtlCol="0" anchor="ctr"/>
-          <a:lstStyle/>
-          <a:p>
-            <a:pPr indent="0" marL="0">
-              <a:buNone/>
-            </a:pPr>
-            <a:r>
-              <a:rPr lang="en-US" sz="2200" b="1" dirty="0">
-                <a:solidFill>
-                  <a:srgbClr val="34D399"/>
-                </a:solidFill>
-                <a:latin typeface="Calibri" pitchFamily="34" charset="0"/>
-                <a:ea typeface="Calibri" pitchFamily="34" charset="-122"/>
-                <a:cs typeface="Calibri" pitchFamily="34" charset="-120"/>
-              </a:rPr>
-              <a:t>−16.7%</a:t>
-            </a:r>
-            <a:endParaRPr lang="en-US" sz="2200" dirty="0"/>
-          </a:p>
-        </p:txBody>
-      </p:sp>
-      <p:sp>
-        <p:nvSpPr>
-          <p:cNvPr id="14" name="Text 12"/>
-          <p:cNvSpPr txBox="1"/>
-          <p:nvPr/>
-        </p:nvSpPr>
-        <p:spPr>
-          <a:xfrm>
-            <a:off x="10012680" y="2788920"/>
-            <a:ext cx="1508760" cy="457200"/>
-          </a:xfrm>
-          <a:prstGeom prst="rect">
-            <a:avLst/>
-          </a:prstGeom>
-          <a:noFill/>
-          <a:ln/>
-        </p:spPr>
-        <p:txBody>
-          <a:bodyPr wrap="square" lIns="0" tIns="0" rIns="0" bIns="0" rtlCol="0" anchor="ctr"/>
-          <a:lstStyle/>
-          <a:p>
-            <a:pPr indent="0" marL="0">
-              <a:buNone/>
-            </a:pPr>
-            <a:r>
-              <a:rPr lang="en-US" sz="1150" dirty="0">
-                <a:solidFill>
-                  <a:srgbClr val="D1D5DB"/>
-                </a:solidFill>
-                <a:latin typeface="Calibri" pitchFamily="34" charset="0"/>
-                <a:ea typeface="Calibri" pitchFamily="34" charset="-122"/>
-                <a:cs typeface="Calibri" pitchFamily="34" charset="-120"/>
-              </a:rPr>
-              <a:t>cost per unit vs F26</a:t>
-            </a:r>
-            <a:endParaRPr lang="en-US" sz="1150" dirty="0"/>
-          </a:p>
-        </p:txBody>
-      </p:sp>
-      <p:sp>
-        <p:nvSpPr>
-          <p:cNvPr id="15" name="Text 13"/>
-          <p:cNvSpPr txBox="1"/>
-          <p:nvPr/>
-        </p:nvSpPr>
-        <p:spPr>
-          <a:xfrm>
-            <a:off x="8641080" y="3291840"/>
-            <a:ext cx="1325880" cy="457200"/>
-          </a:xfrm>
-          <a:prstGeom prst="rect">
-            <a:avLst/>
-          </a:prstGeom>
-          <a:noFill/>
-          <a:ln/>
-        </p:spPr>
-        <p:txBody>
-          <a:bodyPr wrap="square" lIns="0" tIns="0" rIns="0" bIns="0" rtlCol="0" anchor="ctr"/>
-          <a:lstStyle/>
-          <a:p>
-            <a:pPr indent="0" marL="0">
-              <a:buNone/>
-            </a:pPr>
-            <a:r>
-              <a:rPr lang="en-US" sz="2200" b="1" dirty="0">
-                <a:solidFill>
-                  <a:srgbClr val="34D399"/>
-                </a:solidFill>
-                <a:latin typeface="Calibri" pitchFamily="34" charset="0"/>
-                <a:ea typeface="Calibri" pitchFamily="34" charset="-122"/>
-                <a:cs typeface="Calibri" pitchFamily="34" charset="-120"/>
-              </a:rPr>
-              <a:t>+26.7%</a:t>
-            </a:r>
-            <a:endParaRPr lang="en-US" sz="2200" dirty="0"/>
-          </a:p>
-        </p:txBody>
-      </p:sp>
-      <p:sp>
-        <p:nvSpPr>
-          <p:cNvPr id="16" name="Text 14"/>
-          <p:cNvSpPr txBox="1"/>
-          <p:nvPr/>
-        </p:nvSpPr>
-        <p:spPr>
-          <a:xfrm>
-            <a:off x="10012680" y="3291840"/>
-            <a:ext cx="1508760" cy="457200"/>
-          </a:xfrm>
-          <a:prstGeom prst="rect">
-            <a:avLst/>
-          </a:prstGeom>
-          <a:noFill/>
-          <a:ln/>
-        </p:spPr>
-        <p:txBody>
-          <a:bodyPr wrap="square" lIns="0" tIns="0" rIns="0" bIns="0" rtlCol="0" anchor="ctr"/>
-          <a:lstStyle/>
-          <a:p>
-            <a:pPr indent="0" marL="0">
-              <a:buNone/>
-            </a:pPr>
-            <a:r>
-              <a:rPr lang="en-US" sz="1150" dirty="0">
-                <a:solidFill>
-                  <a:srgbClr val="D1D5DB"/>
-                </a:solidFill>
-                <a:latin typeface="Calibri" pitchFamily="34" charset="0"/>
-                <a:ea typeface="Calibri" pitchFamily="34" charset="-122"/>
-                <a:cs typeface="Calibri" pitchFamily="34" charset="-120"/>
-              </a:rPr>
-              <a:t>units per hour vs F26</a:t>
-            </a:r>
-            <a:endParaRPr lang="en-US" sz="1150" dirty="0"/>
-          </a:p>
-        </p:txBody>
-      </p:sp>
-      <p:sp>
-        <p:nvSpPr>
-          <p:cNvPr id="17" name="Text 15"/>
-          <p:cNvSpPr txBox="1"/>
-          <p:nvPr/>
-        </p:nvSpPr>
-        <p:spPr>
-          <a:xfrm>
-            <a:off x="8641080" y="3794760"/>
-            <a:ext cx="1325880" cy="457200"/>
-          </a:xfrm>
-          <a:prstGeom prst="rect">
-            <a:avLst/>
-          </a:prstGeom>
-          <a:noFill/>
-          <a:ln/>
-        </p:spPr>
-        <p:txBody>
-          <a:bodyPr wrap="square" lIns="0" tIns="0" rIns="0" bIns="0" rtlCol="0" anchor="ctr"/>
-          <a:lstStyle/>
-          <a:p>
-            <a:pPr indent="0" marL="0">
-              <a:buNone/>
-            </a:pPr>
-            <a:r>
-              <a:rPr lang="en-US" sz="2200" b="1" dirty="0">
-                <a:solidFill>
-                  <a:srgbClr val="34D399"/>
-                </a:solidFill>
-                <a:latin typeface="Calibri" pitchFamily="34" charset="0"/>
-                <a:ea typeface="Calibri" pitchFamily="34" charset="-122"/>
-                <a:cs typeface="Calibri" pitchFamily="34" charset="-120"/>
-              </a:rPr>
-              <a:t>9 hrs</a:t>
-            </a:r>
-            <a:endParaRPr lang="en-US" sz="2200" dirty="0"/>
-          </a:p>
-        </p:txBody>
-      </p:sp>
-      <p:sp>
-        <p:nvSpPr>
-          <p:cNvPr id="18" name="Text 16"/>
-          <p:cNvSpPr txBox="1"/>
-          <p:nvPr/>
-        </p:nvSpPr>
-        <p:spPr>
-          <a:xfrm>
-            <a:off x="10012680" y="3794760"/>
-            <a:ext cx="1508760" cy="457200"/>
-          </a:xfrm>
-          <a:prstGeom prst="rect">
-            <a:avLst/>
-          </a:prstGeom>
-          <a:noFill/>
-          <a:ln/>
-        </p:spPr>
-        <p:txBody>
-          <a:bodyPr wrap="square" lIns="0" tIns="0" rIns="0" bIns="0" rtlCol="0" anchor="ctr"/>
-          <a:lstStyle/>
-          <a:p>
-            <a:pPr indent="0" marL="0">
-              <a:buNone/>
-            </a:pPr>
-            <a:r>
-              <a:rPr lang="en-US" sz="1150" dirty="0">
-                <a:solidFill>
-                  <a:srgbClr val="D1D5DB"/>
-                </a:solidFill>
-                <a:latin typeface="Calibri" pitchFamily="34" charset="0"/>
-                <a:ea typeface="Calibri" pitchFamily="34" charset="-122"/>
-                <a:cs typeface="Calibri" pitchFamily="34" charset="-120"/>
-              </a:rPr>
-              <a:t>overtime MTD</a:t>
-            </a:r>
-            <a:endParaRPr lang="en-US" sz="1150" dirty="0"/>
-          </a:p>
-        </p:txBody>
-      </p:sp>
-      <p:sp>
-        <p:nvSpPr>
-          <p:cNvPr id="19" name="Text 17"/>
-          <p:cNvSpPr txBox="1"/>
-          <p:nvPr/>
-        </p:nvSpPr>
-        <p:spPr>
-          <a:xfrm>
-            <a:off x="8641080" y="4370832"/>
-            <a:ext cx="2834640" cy="274320"/>
-          </a:xfrm>
-          <a:prstGeom prst="rect">
-            <a:avLst/>
-          </a:prstGeom>
-          <a:noFill/>
-          <a:ln/>
-        </p:spPr>
-        <p:txBody>
-          <a:bodyPr wrap="square" lIns="0" tIns="0" rIns="0" bIns="0" rtlCol="0" anchor="ctr"/>
-          <a:lstStyle/>
-          <a:p>
-            <a:pPr indent="0" marL="0">
-              <a:buNone/>
-            </a:pPr>
-            <a:r>
-              <a:rPr lang="en-US" sz="1100" b="1" spc="200" kern="0" dirty="0">
-                <a:solidFill>
-                  <a:srgbClr val="A78BFA"/>
-                </a:solidFill>
-                <a:latin typeface="Calibri" pitchFamily="34" charset="0"/>
-                <a:ea typeface="Calibri" pitchFamily="34" charset="-122"/>
-                <a:cs typeface="Calibri" pitchFamily="34" charset="-120"/>
-              </a:rPr>
-              <a:t>FOCUS</a:t>
-            </a:r>
-            <a:endParaRPr lang="en-US" sz="1100" dirty="0"/>
-          </a:p>
-        </p:txBody>
-      </p:sp>
-      <p:sp>
-        <p:nvSpPr>
-          <p:cNvPr id="20" name="Text 18"/>
-          <p:cNvSpPr txBox="1"/>
-          <p:nvPr/>
-        </p:nvSpPr>
-        <p:spPr>
-          <a:xfrm>
-            <a:off x="8641080" y="4626864"/>
-            <a:ext cx="2834640" cy="457200"/>
-          </a:xfrm>
-          <a:prstGeom prst="rect">
-            <a:avLst/>
-          </a:prstGeom>
-          <a:noFill/>
-          <a:ln/>
-        </p:spPr>
-        <p:txBody>
-          <a:bodyPr wrap="square" lIns="0" tIns="0" rIns="0" bIns="0" rtlCol="0" anchor="ctr"/>
-          <a:lstStyle/>
-          <a:p>
-            <a:pPr indent="0" marL="0">
-              <a:buNone/>
-            </a:pPr>
-            <a:r>
-              <a:rPr lang="en-US" sz="2200" b="1" dirty="0">
-                <a:solidFill>
-                  <a:srgbClr val="F87171"/>
-                </a:solidFill>
-                <a:latin typeface="Calibri" pitchFamily="34" charset="0"/>
-                <a:ea typeface="Calibri" pitchFamily="34" charset="-122"/>
-                <a:cs typeface="Calibri" pitchFamily="34" charset="-120"/>
-              </a:rPr>
-              <a:t>−21.9%</a:t>
-            </a:r>
-            <a:pPr indent="0" marL="0">
-              <a:buNone/>
-            </a:pPr>
-            <a:r>
-              <a:rPr lang="en-US" sz="1300" dirty="0">
-                <a:solidFill>
-                  <a:srgbClr val="D1D5DB"/>
-                </a:solidFill>
-                <a:latin typeface="Calibri" pitchFamily="34" charset="0"/>
-                <a:ea typeface="Calibri" pitchFamily="34" charset="-122"/>
-                <a:cs typeface="Calibri" pitchFamily="34" charset="-120"/>
-              </a:rPr>
-              <a:t>  PPH gap to goal</a:t>
-            </a:r>
-            <a:endParaRPr lang="en-US" sz="2200" dirty="0"/>
-          </a:p>
-        </p:txBody>
-      </p:sp>
-      <p:sp>
-        <p:nvSpPr>
-          <p:cNvPr id="21" name="Text 19"/>
-          <p:cNvSpPr txBox="1"/>
-          <p:nvPr/>
-        </p:nvSpPr>
-        <p:spPr>
-          <a:xfrm>
-            <a:off x="8641080" y="5084064"/>
+          <p:cNvPr id="23" name="Text 21"/>
+          <p:cNvSpPr txBox="1"/>
+          <p:nvPr/>
+        </p:nvSpPr>
+        <p:spPr>
+          <a:xfrm>
+            <a:off x="8641080" y="5212080"/>
             <a:ext cx="2834640" cy="274320"/>
           </a:xfrm>
           <a:prstGeom prst="rect">
@@ -36892,12 +36970,12 @@
         </p:nvSpPr>
         <p:spPr>
           <a:xfrm>
-            <a:off x="548640" y="1371600"/>
-            <a:ext cx="2072030" cy="1280160"/>
+            <a:off x="548640" y="1325880"/>
+            <a:ext cx="2072030" cy="1188720"/>
           </a:xfrm>
           <a:prstGeom prst="roundRect">
             <a:avLst>
-              <a:gd name="adj" fmla="val 5714"/>
+              <a:gd name="adj" fmla="val 6154"/>
             </a:avLst>
           </a:prstGeom>
           <a:solidFill>
@@ -36919,7 +36997,7 @@
         </p:nvSpPr>
         <p:spPr>
           <a:xfrm>
-            <a:off x="731520" y="1508760"/>
+            <a:off x="731520" y="1463040"/>
             <a:ext cx="1706270" cy="274320"/>
           </a:xfrm>
           <a:prstGeom prst="rect">
@@ -36958,8 +37036,8 @@
         </p:nvSpPr>
         <p:spPr>
           <a:xfrm>
-            <a:off x="731520" y="1783080"/>
-            <a:ext cx="1706270" cy="411480"/>
+            <a:off x="731520" y="1737360"/>
+            <a:ext cx="1706270" cy="320040"/>
           </a:xfrm>
           <a:prstGeom prst="rect">
             <a:avLst/>
@@ -36975,17 +37053,17 @@
               <a:buNone/>
             </a:pPr>
             <a:r>
-              <a:rPr lang="en-US" sz="3000" b="1" dirty="0">
-                <a:solidFill>
-                  <a:srgbClr val="D97706"/>
-                </a:solidFill>
-                <a:latin typeface="Calibri" pitchFamily="34" charset="0"/>
-                <a:ea typeface="Calibri" pitchFamily="34" charset="-122"/>
-                <a:cs typeface="Calibri" pitchFamily="34" charset="-120"/>
-              </a:rPr>
-              <a:t>TBC</a:t>
-            </a:r>
-            <a:endParaRPr lang="en-US" sz="3000" dirty="0"/>
+              <a:rPr lang="en-US" sz="2800" b="1" dirty="0">
+                <a:solidFill>
+                  <a:srgbClr val="059669"/>
+                </a:solidFill>
+                <a:latin typeface="Calibri" pitchFamily="34" charset="0"/>
+                <a:ea typeface="Calibri" pitchFamily="34" charset="-122"/>
+                <a:cs typeface="Calibri" pitchFamily="34" charset="-120"/>
+              </a:rPr>
+              <a:t>0.00</a:t>
+            </a:r>
+            <a:endParaRPr lang="en-US" sz="2800" dirty="0"/>
           </a:p>
         </p:txBody>
       </p:sp>
@@ -36997,7 +37075,7 @@
         </p:nvSpPr>
         <p:spPr>
           <a:xfrm>
-            <a:off x="731520" y="2221992"/>
+            <a:off x="731520" y="2084832"/>
             <a:ext cx="1706270" cy="292608"/>
           </a:xfrm>
           <a:prstGeom prst="rect">
@@ -37022,7 +37100,7 @@
                 <a:ea typeface="Calibri" pitchFamily="34" charset="-122"/>
                 <a:cs typeface="Calibri" pitchFamily="34" charset="-120"/>
               </a:rPr>
-              <a:t>Jul 1 – Sep 29, 2026</a:t>
+              <a:t>Jul–Aug 2026</a:t>
             </a:r>
             <a:endParaRPr lang="en-US" sz="1050" dirty="0"/>
           </a:p>
@@ -37036,12 +37114,12 @@
         </p:nvSpPr>
         <p:spPr>
           <a:xfrm>
-            <a:off x="2803550" y="1371600"/>
-            <a:ext cx="2072030" cy="1280160"/>
+            <a:off x="2803550" y="1325880"/>
+            <a:ext cx="2072030" cy="1188720"/>
           </a:xfrm>
           <a:prstGeom prst="roundRect">
             <a:avLst>
-              <a:gd name="adj" fmla="val 5714"/>
+              <a:gd name="adj" fmla="val 6154"/>
             </a:avLst>
           </a:prstGeom>
           <a:solidFill>
@@ -37063,7 +37141,7 @@
         </p:nvSpPr>
         <p:spPr>
           <a:xfrm>
-            <a:off x="2986430" y="1508760"/>
+            <a:off x="2986430" y="1463040"/>
             <a:ext cx="1706270" cy="274320"/>
           </a:xfrm>
           <a:prstGeom prst="rect">
@@ -37102,8 +37180,8 @@
         </p:nvSpPr>
         <p:spPr>
           <a:xfrm>
-            <a:off x="2986430" y="1783080"/>
-            <a:ext cx="1706270" cy="411480"/>
+            <a:off x="2986430" y="1737360"/>
+            <a:ext cx="1706270" cy="320040"/>
           </a:xfrm>
           <a:prstGeom prst="rect">
             <a:avLst/>
@@ -37119,17 +37197,17 @@
               <a:buNone/>
             </a:pPr>
             <a:r>
-              <a:rPr lang="en-US" sz="3000" b="1" dirty="0">
-                <a:solidFill>
-                  <a:srgbClr val="D97706"/>
-                </a:solidFill>
-                <a:latin typeface="Calibri" pitchFamily="34" charset="0"/>
-                <a:ea typeface="Calibri" pitchFamily="34" charset="-122"/>
-                <a:cs typeface="Calibri" pitchFamily="34" charset="-120"/>
-              </a:rPr>
-              <a:t>TBC</a:t>
-            </a:r>
-            <a:endParaRPr lang="en-US" sz="3000" dirty="0"/>
+              <a:rPr lang="en-US" sz="2800" b="1" dirty="0">
+                <a:solidFill>
+                  <a:srgbClr val="111827"/>
+                </a:solidFill>
+                <a:latin typeface="Calibri" pitchFamily="34" charset="0"/>
+                <a:ea typeface="Calibri" pitchFamily="34" charset="-122"/>
+                <a:cs typeface="Calibri" pitchFamily="34" charset="-120"/>
+              </a:rPr>
+              <a:t>1.21</a:t>
+            </a:r>
+            <a:endParaRPr lang="en-US" sz="2800" dirty="0"/>
           </a:p>
         </p:txBody>
       </p:sp>
@@ -37141,7 +37219,7 @@
         </p:nvSpPr>
         <p:spPr>
           <a:xfrm>
-            <a:off x="2986430" y="2221992"/>
+            <a:off x="2986430" y="2084832"/>
             <a:ext cx="1706270" cy="292608"/>
           </a:xfrm>
           <a:prstGeom prst="rect">
@@ -37180,12 +37258,12 @@
         </p:nvSpPr>
         <p:spPr>
           <a:xfrm>
-            <a:off x="5058461" y="1371600"/>
-            <a:ext cx="2072030" cy="1280160"/>
+            <a:off x="5058461" y="1325880"/>
+            <a:ext cx="2072030" cy="1188720"/>
           </a:xfrm>
           <a:prstGeom prst="roundRect">
             <a:avLst>
-              <a:gd name="adj" fmla="val 5714"/>
+              <a:gd name="adj" fmla="val 6154"/>
             </a:avLst>
           </a:prstGeom>
           <a:solidFill>
@@ -37207,7 +37285,7 @@
         </p:nvSpPr>
         <p:spPr>
           <a:xfrm>
-            <a:off x="5241341" y="1508760"/>
+            <a:off x="5241341" y="1463040"/>
             <a:ext cx="1706270" cy="274320"/>
           </a:xfrm>
           <a:prstGeom prst="rect">
@@ -37232,7 +37310,7 @@
                 <a:ea typeface="Calibri" pitchFamily="34" charset="-122"/>
                 <a:cs typeface="Calibri" pitchFamily="34" charset="-120"/>
               </a:rPr>
-              <a:t>TRIR · F27 target</a:t>
+              <a:t>TRIR · 12-month avg</a:t>
             </a:r>
             <a:endParaRPr lang="en-US" sz="950" dirty="0"/>
           </a:p>
@@ -37246,8 +37324,8 @@
         </p:nvSpPr>
         <p:spPr>
           <a:xfrm>
-            <a:off x="5241341" y="1783080"/>
-            <a:ext cx="1706270" cy="411480"/>
+            <a:off x="5241341" y="1737360"/>
+            <a:ext cx="1706270" cy="320040"/>
           </a:xfrm>
           <a:prstGeom prst="rect">
             <a:avLst/>
@@ -37263,17 +37341,17 @@
               <a:buNone/>
             </a:pPr>
             <a:r>
-              <a:rPr lang="en-US" sz="3000" b="1" dirty="0">
-                <a:solidFill>
-                  <a:srgbClr val="D97706"/>
-                </a:solidFill>
-                <a:latin typeface="Calibri" pitchFamily="34" charset="0"/>
-                <a:ea typeface="Calibri" pitchFamily="34" charset="-122"/>
-                <a:cs typeface="Calibri" pitchFamily="34" charset="-120"/>
-              </a:rPr>
-              <a:t>TBC</a:t>
-            </a:r>
-            <a:endParaRPr lang="en-US" sz="3000" dirty="0"/>
+              <a:rPr lang="en-US" sz="2800" b="1" dirty="0">
+                <a:solidFill>
+                  <a:srgbClr val="111827"/>
+                </a:solidFill>
+                <a:latin typeface="Calibri" pitchFamily="34" charset="0"/>
+                <a:ea typeface="Calibri" pitchFamily="34" charset="-122"/>
+                <a:cs typeface="Calibri" pitchFamily="34" charset="-120"/>
+              </a:rPr>
+              <a:t>1.21</a:t>
+            </a:r>
+            <a:endParaRPr lang="en-US" sz="2800" dirty="0"/>
           </a:p>
         </p:txBody>
       </p:sp>
@@ -37285,7 +37363,7 @@
         </p:nvSpPr>
         <p:spPr>
           <a:xfrm>
-            <a:off x="5241341" y="2221992"/>
+            <a:off x="5241341" y="2084832"/>
             <a:ext cx="1706270" cy="292608"/>
           </a:xfrm>
           <a:prstGeom prst="rect">
@@ -37310,7 +37388,7 @@
                 <a:ea typeface="Calibri" pitchFamily="34" charset="-122"/>
                 <a:cs typeface="Calibri" pitchFamily="34" charset="-120"/>
               </a:rPr>
-              <a:t>F27 target</a:t>
+              <a:t>Rolling 12 months</a:t>
             </a:r>
             <a:endParaRPr lang="en-US" sz="1050" dirty="0"/>
           </a:p>
@@ -37324,12 +37402,12 @@
         </p:nvSpPr>
         <p:spPr>
           <a:xfrm>
-            <a:off x="7313371" y="1371600"/>
-            <a:ext cx="2072030" cy="1280160"/>
+            <a:off x="7313371" y="1325880"/>
+            <a:ext cx="2072030" cy="1188720"/>
           </a:xfrm>
           <a:prstGeom prst="roundRect">
             <a:avLst>
-              <a:gd name="adj" fmla="val 5714"/>
+              <a:gd name="adj" fmla="val 6154"/>
             </a:avLst>
           </a:prstGeom>
           <a:solidFill>
@@ -37351,7 +37429,7 @@
         </p:nvSpPr>
         <p:spPr>
           <a:xfrm>
-            <a:off x="7496251" y="1508760"/>
+            <a:off x="7496251" y="1463040"/>
             <a:ext cx="1706270" cy="274320"/>
           </a:xfrm>
           <a:prstGeom prst="rect">
@@ -37376,7 +37454,7 @@
                 <a:ea typeface="Calibri" pitchFamily="34" charset="-122"/>
                 <a:cs typeface="Calibri" pitchFamily="34" charset="-120"/>
               </a:rPr>
-              <a:t>Recordables · YTD</a:t>
+              <a:t>Recordables · F27 YTD</a:t>
             </a:r>
             <a:endParaRPr lang="en-US" sz="950" dirty="0"/>
           </a:p>
@@ -37390,8 +37468,8 @@
         </p:nvSpPr>
         <p:spPr>
           <a:xfrm>
-            <a:off x="7496251" y="1783080"/>
-            <a:ext cx="1706270" cy="411480"/>
+            <a:off x="7496251" y="1737360"/>
+            <a:ext cx="1706270" cy="320040"/>
           </a:xfrm>
           <a:prstGeom prst="rect">
             <a:avLst/>
@@ -37407,17 +37485,17 @@
               <a:buNone/>
             </a:pPr>
             <a:r>
-              <a:rPr lang="en-US" sz="3000" b="1" dirty="0">
-                <a:solidFill>
-                  <a:srgbClr val="D97706"/>
-                </a:solidFill>
-                <a:latin typeface="Calibri" pitchFamily="34" charset="0"/>
-                <a:ea typeface="Calibri" pitchFamily="34" charset="-122"/>
-                <a:cs typeface="Calibri" pitchFamily="34" charset="-120"/>
-              </a:rPr>
-              <a:t>TBC</a:t>
-            </a:r>
-            <a:endParaRPr lang="en-US" sz="3000" dirty="0"/>
+              <a:rPr lang="en-US" sz="2800" b="1" dirty="0">
+                <a:solidFill>
+                  <a:srgbClr val="059669"/>
+                </a:solidFill>
+                <a:latin typeface="Calibri" pitchFamily="34" charset="0"/>
+                <a:ea typeface="Calibri" pitchFamily="34" charset="-122"/>
+                <a:cs typeface="Calibri" pitchFamily="34" charset="-120"/>
+              </a:rPr>
+              <a:t>0</a:t>
+            </a:r>
+            <a:endParaRPr lang="en-US" sz="2800" dirty="0"/>
           </a:p>
         </p:txBody>
       </p:sp>
@@ -37429,7 +37507,7 @@
         </p:nvSpPr>
         <p:spPr>
           <a:xfrm>
-            <a:off x="7496251" y="2221992"/>
+            <a:off x="7496251" y="2084832"/>
             <a:ext cx="1706270" cy="292608"/>
           </a:xfrm>
           <a:prstGeom prst="rect">
@@ -37454,7 +37532,7 @@
                 <a:ea typeface="Calibri" pitchFamily="34" charset="-122"/>
                 <a:cs typeface="Calibri" pitchFamily="34" charset="-120"/>
               </a:rPr>
-              <a:t>Jul 1 to date</a:t>
+              <a:t>Employee + contractor</a:t>
             </a:r>
             <a:endParaRPr lang="en-US" sz="1050" dirty="0"/>
           </a:p>
@@ -37468,12 +37546,12 @@
         </p:nvSpPr>
         <p:spPr>
           <a:xfrm>
-            <a:off x="9568282" y="1371600"/>
-            <a:ext cx="2072030" cy="1280160"/>
+            <a:off x="9568282" y="1325880"/>
+            <a:ext cx="2072030" cy="1188720"/>
           </a:xfrm>
           <a:prstGeom prst="roundRect">
             <a:avLst>
-              <a:gd name="adj" fmla="val 5714"/>
+              <a:gd name="adj" fmla="val 6154"/>
             </a:avLst>
           </a:prstGeom>
           <a:solidFill>
@@ -37495,7 +37573,7 @@
         </p:nvSpPr>
         <p:spPr>
           <a:xfrm>
-            <a:off x="9751162" y="1508760"/>
+            <a:off x="9751162" y="1463040"/>
             <a:ext cx="1706270" cy="274320"/>
           </a:xfrm>
           <a:prstGeom prst="rect">
@@ -37534,8 +37612,8 @@
         </p:nvSpPr>
         <p:spPr>
           <a:xfrm>
-            <a:off x="9751162" y="1783080"/>
-            <a:ext cx="1706270" cy="411480"/>
+            <a:off x="9751162" y="1737360"/>
+            <a:ext cx="1706270" cy="320040"/>
           </a:xfrm>
           <a:prstGeom prst="rect">
             <a:avLst/>
@@ -37551,7 +37629,7 @@
               <a:buNone/>
             </a:pPr>
             <a:r>
-              <a:rPr lang="en-US" sz="3000" b="1" dirty="0">
+              <a:rPr lang="en-US" sz="2800" b="1" dirty="0">
                 <a:solidFill>
                   <a:srgbClr val="D97706"/>
                 </a:solidFill>
@@ -37561,7 +37639,7 @@
               </a:rPr>
               <a:t>TBC</a:t>
             </a:r>
-            <a:endParaRPr lang="en-US" sz="3000" dirty="0"/>
+            <a:endParaRPr lang="en-US" sz="2800" dirty="0"/>
           </a:p>
         </p:txBody>
       </p:sp>
@@ -37573,7 +37651,7 @@
         </p:nvSpPr>
         <p:spPr>
           <a:xfrm>
-            <a:off x="9751162" y="2221992"/>
+            <a:off x="9751162" y="2084832"/>
             <a:ext cx="1706270" cy="292608"/>
           </a:xfrm>
           <a:prstGeom prst="rect">
@@ -37606,13 +37684,79 @@
       </p:sp>
       <p:sp>
         <p:nvSpPr>
-          <p:cNvPr id="24" name="Text 22"/>
-          <p:cNvSpPr txBox="1"/>
-          <p:nvPr/>
-        </p:nvSpPr>
-        <p:spPr>
-          <a:xfrm>
-            <a:off x="548640" y="2907792"/>
+          <p:cNvPr id="24" name="Shape 22"/>
+          <p:cNvSpPr/>
+          <p:nvPr/>
+        </p:nvSpPr>
+        <p:spPr>
+          <a:xfrm>
+            <a:off x="548640" y="2651760"/>
+            <a:ext cx="11091672" cy="384048"/>
+          </a:xfrm>
+          <a:prstGeom prst="roundRect">
+            <a:avLst>
+              <a:gd name="adj" fmla="val 19048"/>
+            </a:avLst>
+          </a:prstGeom>
+          <a:solidFill>
+            <a:srgbClr val="D1FAE5"/>
+          </a:solidFill>
+          <a:ln w="12700">
+            <a:solidFill>
+              <a:srgbClr val="D1FAE5"/>
+            </a:solidFill>
+            <a:prstDash val="solid"/>
+          </a:ln>
+        </p:spPr>
+      </p:sp>
+      <p:sp>
+        <p:nvSpPr>
+          <p:cNvPr id="25" name="Text 23"/>
+          <p:cNvSpPr txBox="1"/>
+          <p:nvPr/>
+        </p:nvSpPr>
+        <p:spPr>
+          <a:xfrm>
+            <a:off x="731520" y="2651760"/>
+            <a:ext cx="10789920" cy="384048"/>
+          </a:xfrm>
+          <a:prstGeom prst="rect">
+            <a:avLst/>
+          </a:prstGeom>
+          <a:noFill/>
+          <a:ln/>
+        </p:spPr>
+        <p:txBody>
+          <a:bodyPr wrap="square" lIns="0" tIns="0" rIns="0" bIns="0" rtlCol="0" anchor="ctr"/>
+          <a:lstStyle/>
+          <a:p>
+            <a:pPr indent="0" marL="0">
+              <a:buNone/>
+            </a:pPr>
+            <a:r>
+              <a:rPr lang="en-US" sz="1400" b="1" dirty="0">
+                <a:solidFill>
+                  <a:srgbClr val="059669"/>
+                </a:solidFill>
+                <a:latin typeface="Calibri" pitchFamily="34" charset="0"/>
+                <a:ea typeface="Calibri" pitchFamily="34" charset="-122"/>
+                <a:cs typeface="Calibri" pitchFamily="34" charset="-120"/>
+              </a:rPr>
+              <a:t>Zero recordable incidents in F27 to date (Jul–Aug) — 100% improvement vs F26 TRIR of 1.21.</a:t>
+            </a:r>
+            <a:endParaRPr lang="en-US" sz="1400" dirty="0"/>
+          </a:p>
+        </p:txBody>
+      </p:sp>
+      <p:sp>
+        <p:nvSpPr>
+          <p:cNvPr id="26" name="Text 24"/>
+          <p:cNvSpPr txBox="1"/>
+          <p:nvPr/>
+        </p:nvSpPr>
+        <p:spPr>
+          <a:xfrm>
+            <a:off x="548640" y="3127248"/>
             <a:ext cx="7315200" cy="365760"/>
           </a:xfrm>
           <a:prstGeom prst="rect">
@@ -37645,14 +37789,14 @@
       </p:sp>
       <p:sp>
         <p:nvSpPr>
-          <p:cNvPr id="25" name="Shape 23"/>
+          <p:cNvPr id="27" name="Shape 25"/>
           <p:cNvSpPr/>
           <p:nvPr/>
         </p:nvSpPr>
         <p:spPr>
           <a:xfrm>
-            <a:off x="548640" y="3429000"/>
-            <a:ext cx="420624" cy="420624"/>
+            <a:off x="548640" y="3575304"/>
+            <a:ext cx="384048" cy="384048"/>
           </a:xfrm>
           <a:prstGeom prst="ellipse">
             <a:avLst/>
@@ -37670,7 +37814,7 @@
       </p:sp>
       <p:pic>
         <p:nvPicPr>
-          <p:cNvPr id="26" name="Image 0" descr="preencoded.png">    </p:cNvPr>
+          <p:cNvPr id="28" name="Image 0" descr="preencoded.png">    </p:cNvPr>
           <p:cNvPicPr>
             <a:picLocks noChangeAspect="1"/>
           </p:cNvPicPr>
@@ -37684,8 +37828,8 @@
         </p:blipFill>
         <p:spPr>
           <a:xfrm>
-            <a:off x="653796" y="3534156"/>
-            <a:ext cx="210312" cy="210312"/>
+            <a:off x="644652" y="3671316"/>
+            <a:ext cx="192024" cy="192024"/>
           </a:xfrm>
           <a:prstGeom prst="rect">
             <a:avLst/>
@@ -37694,14 +37838,14 @@
       </p:pic>
       <p:sp>
         <p:nvSpPr>
-          <p:cNvPr id="27" name="Text 24"/>
-          <p:cNvSpPr txBox="1"/>
-          <p:nvPr/>
-        </p:nvSpPr>
-        <p:spPr>
-          <a:xfrm>
-            <a:off x="1170432" y="3364992"/>
-            <a:ext cx="10469880" cy="548640"/>
+          <p:cNvPr id="29" name="Text 26"/>
+          <p:cNvSpPr txBox="1"/>
+          <p:nvPr/>
+        </p:nvSpPr>
+        <p:spPr>
+          <a:xfrm>
+            <a:off x="1097280" y="3520440"/>
+            <a:ext cx="10543032" cy="493776"/>
           </a:xfrm>
           <a:prstGeom prst="rect">
             <a:avLst/>
@@ -37717,7 +37861,7 @@
               <a:buNone/>
             </a:pPr>
             <a:r>
-              <a:rPr lang="en-US" sz="1400" dirty="0">
+              <a:rPr lang="en-US" sz="1300" dirty="0">
                 <a:solidFill>
                   <a:srgbClr val="1F2937"/>
                 </a:solidFill>
@@ -37727,20 +37871,20 @@
               </a:rPr>
               <a:t>Tailgates with the team on safety topics and safe work practices, plus specific safety moments after incidents (e.g. avoiding pinch points).</a:t>
             </a:r>
-            <a:endParaRPr lang="en-US" sz="1400" dirty="0"/>
-          </a:p>
-        </p:txBody>
-      </p:sp>
-      <p:sp>
-        <p:nvSpPr>
-          <p:cNvPr id="28" name="Shape 25"/>
+            <a:endParaRPr lang="en-US" sz="1300" dirty="0"/>
+          </a:p>
+        </p:txBody>
+      </p:sp>
+      <p:sp>
+        <p:nvSpPr>
+          <p:cNvPr id="30" name="Shape 27"/>
           <p:cNvSpPr/>
           <p:nvPr/>
         </p:nvSpPr>
         <p:spPr>
           <a:xfrm>
-            <a:off x="548640" y="4032504"/>
-            <a:ext cx="420624" cy="420624"/>
+            <a:off x="548640" y="4096512"/>
+            <a:ext cx="384048" cy="384048"/>
           </a:xfrm>
           <a:prstGeom prst="ellipse">
             <a:avLst/>
@@ -37758,7 +37902,7 @@
       </p:sp>
       <p:pic>
         <p:nvPicPr>
-          <p:cNvPr id="29" name="Image 1" descr="preencoded.png">    </p:cNvPr>
+          <p:cNvPr id="31" name="Image 1" descr="preencoded.png">    </p:cNvPr>
           <p:cNvPicPr>
             <a:picLocks noChangeAspect="1"/>
           </p:cNvPicPr>
@@ -37772,8 +37916,8 @@
         </p:blipFill>
         <p:spPr>
           <a:xfrm>
-            <a:off x="653796" y="4137660"/>
-            <a:ext cx="210312" cy="210312"/>
+            <a:off x="644652" y="4192524"/>
+            <a:ext cx="192024" cy="192024"/>
           </a:xfrm>
           <a:prstGeom prst="rect">
             <a:avLst/>
@@ -37782,14 +37926,14 @@
       </p:pic>
       <p:sp>
         <p:nvSpPr>
-          <p:cNvPr id="30" name="Text 26"/>
-          <p:cNvSpPr txBox="1"/>
-          <p:nvPr/>
-        </p:nvSpPr>
-        <p:spPr>
-          <a:xfrm>
-            <a:off x="1170432" y="3968496"/>
-            <a:ext cx="10469880" cy="548640"/>
+          <p:cNvPr id="32" name="Text 28"/>
+          <p:cNvSpPr txBox="1"/>
+          <p:nvPr/>
+        </p:nvSpPr>
+        <p:spPr>
+          <a:xfrm>
+            <a:off x="1097280" y="4041648"/>
+            <a:ext cx="10543032" cy="493776"/>
           </a:xfrm>
           <a:prstGeom prst="rect">
             <a:avLst/>
@@ -37805,7 +37949,7 @@
               <a:buNone/>
             </a:pPr>
             <a:r>
-              <a:rPr lang="en-US" sz="1400" dirty="0">
+              <a:rPr lang="en-US" sz="1300" dirty="0">
                 <a:solidFill>
                   <a:srgbClr val="1F2937"/>
                 </a:solidFill>
@@ -37815,20 +37959,20 @@
               </a:rPr>
               <a:t>Pre- and post-shift forklift inspections by every operator — deficiencies corrected immediately; shunt pre-trip meeting every shift using the new checklist.</a:t>
             </a:r>
-            <a:endParaRPr lang="en-US" sz="1400" dirty="0"/>
-          </a:p>
-        </p:txBody>
-      </p:sp>
-      <p:sp>
-        <p:nvSpPr>
-          <p:cNvPr id="31" name="Shape 27"/>
+            <a:endParaRPr lang="en-US" sz="1300" dirty="0"/>
+          </a:p>
+        </p:txBody>
+      </p:sp>
+      <p:sp>
+        <p:nvSpPr>
+          <p:cNvPr id="33" name="Shape 29"/>
           <p:cNvSpPr/>
           <p:nvPr/>
         </p:nvSpPr>
         <p:spPr>
           <a:xfrm>
-            <a:off x="548640" y="4636008"/>
-            <a:ext cx="420624" cy="420624"/>
+            <a:off x="548640" y="4617720"/>
+            <a:ext cx="384048" cy="384048"/>
           </a:xfrm>
           <a:prstGeom prst="ellipse">
             <a:avLst/>
@@ -37846,7 +37990,7 @@
       </p:sp>
       <p:pic>
         <p:nvPicPr>
-          <p:cNvPr id="32" name="Image 2" descr="preencoded.png">    </p:cNvPr>
+          <p:cNvPr id="34" name="Image 2" descr="preencoded.png">    </p:cNvPr>
           <p:cNvPicPr>
             <a:picLocks noChangeAspect="1"/>
           </p:cNvPicPr>
@@ -37860,8 +38004,8 @@
         </p:blipFill>
         <p:spPr>
           <a:xfrm>
-            <a:off x="653796" y="4741164"/>
-            <a:ext cx="210312" cy="210312"/>
+            <a:off x="644652" y="4713732"/>
+            <a:ext cx="192024" cy="192024"/>
           </a:xfrm>
           <a:prstGeom prst="rect">
             <a:avLst/>
@@ -37870,14 +38014,14 @@
       </p:pic>
       <p:sp>
         <p:nvSpPr>
-          <p:cNvPr id="33" name="Text 28"/>
-          <p:cNvSpPr txBox="1"/>
-          <p:nvPr/>
-        </p:nvSpPr>
-        <p:spPr>
-          <a:xfrm>
-            <a:off x="1170432" y="4572000"/>
-            <a:ext cx="10469880" cy="548640"/>
+          <p:cNvPr id="35" name="Text 30"/>
+          <p:cNvSpPr txBox="1"/>
+          <p:nvPr/>
+        </p:nvSpPr>
+        <p:spPr>
+          <a:xfrm>
+            <a:off x="1097280" y="4562856"/>
+            <a:ext cx="10543032" cy="493776"/>
           </a:xfrm>
           <a:prstGeom prst="rect">
             <a:avLst/>
@@ -37893,7 +38037,7 @@
               <a:buNone/>
             </a:pPr>
             <a:r>
-              <a:rPr lang="en-US" sz="1400" dirty="0">
+              <a:rPr lang="en-US" sz="1300" dirty="0">
                 <a:solidFill>
                   <a:srgbClr val="1F2937"/>
                 </a:solidFill>
@@ -37903,20 +38047,20 @@
               </a:rPr>
               <a:t>No loading forklifts on straight trucks — prevents serious injuries and forklift damage.</a:t>
             </a:r>
-            <a:endParaRPr lang="en-US" sz="1400" dirty="0"/>
-          </a:p>
-        </p:txBody>
-      </p:sp>
-      <p:sp>
-        <p:nvSpPr>
-          <p:cNvPr id="34" name="Shape 29"/>
+            <a:endParaRPr lang="en-US" sz="1300" dirty="0"/>
+          </a:p>
+        </p:txBody>
+      </p:sp>
+      <p:sp>
+        <p:nvSpPr>
+          <p:cNvPr id="36" name="Shape 31"/>
           <p:cNvSpPr/>
           <p:nvPr/>
         </p:nvSpPr>
         <p:spPr>
           <a:xfrm>
-            <a:off x="548640" y="5239512"/>
-            <a:ext cx="420624" cy="420624"/>
+            <a:off x="548640" y="5138928"/>
+            <a:ext cx="384048" cy="384048"/>
           </a:xfrm>
           <a:prstGeom prst="ellipse">
             <a:avLst/>
@@ -37934,7 +38078,7 @@
       </p:sp>
       <p:pic>
         <p:nvPicPr>
-          <p:cNvPr id="35" name="Image 3" descr="preencoded.png">    </p:cNvPr>
+          <p:cNvPr id="37" name="Image 3" descr="preencoded.png">    </p:cNvPr>
           <p:cNvPicPr>
             <a:picLocks noChangeAspect="1"/>
           </p:cNvPicPr>
@@ -37948,8 +38092,8 @@
         </p:blipFill>
         <p:spPr>
           <a:xfrm>
-            <a:off x="653796" y="5344668"/>
-            <a:ext cx="210312" cy="210312"/>
+            <a:off x="644652" y="5234940"/>
+            <a:ext cx="192024" cy="192024"/>
           </a:xfrm>
           <a:prstGeom prst="rect">
             <a:avLst/>
@@ -37958,14 +38102,14 @@
       </p:pic>
       <p:sp>
         <p:nvSpPr>
-          <p:cNvPr id="36" name="Text 30"/>
-          <p:cNvSpPr txBox="1"/>
-          <p:nvPr/>
-        </p:nvSpPr>
-        <p:spPr>
-          <a:xfrm>
-            <a:off x="1170432" y="5175504"/>
-            <a:ext cx="10469880" cy="548640"/>
+          <p:cNvPr id="38" name="Text 32"/>
+          <p:cNvSpPr txBox="1"/>
+          <p:nvPr/>
+        </p:nvSpPr>
+        <p:spPr>
+          <a:xfrm>
+            <a:off x="1097280" y="5084064"/>
+            <a:ext cx="10543032" cy="493776"/>
           </a:xfrm>
           <a:prstGeom prst="rect">
             <a:avLst/>
@@ -37981,7 +38125,7 @@
               <a:buNone/>
             </a:pPr>
             <a:r>
-              <a:rPr lang="en-US" sz="1400" dirty="0">
+              <a:rPr lang="en-US" sz="1300" dirty="0">
                 <a:solidFill>
                   <a:srgbClr val="1F2937"/>
                 </a:solidFill>
@@ -37991,20 +38135,20 @@
               </a:rPr>
               <a:t>Safety equipment and dock conditions inspected and documented on H&amp;S inspection sheets, collected monthly by OHS and fully reviewed at JHSC.</a:t>
             </a:r>
-            <a:endParaRPr lang="en-US" sz="1400" dirty="0"/>
-          </a:p>
-        </p:txBody>
-      </p:sp>
-      <p:sp>
-        <p:nvSpPr>
-          <p:cNvPr id="37" name="Shape 31"/>
+            <a:endParaRPr lang="en-US" sz="1300" dirty="0"/>
+          </a:p>
+        </p:txBody>
+      </p:sp>
+      <p:sp>
+        <p:nvSpPr>
+          <p:cNvPr id="39" name="Shape 33"/>
           <p:cNvSpPr/>
           <p:nvPr/>
         </p:nvSpPr>
         <p:spPr>
           <a:xfrm>
-            <a:off x="548640" y="5843016"/>
-            <a:ext cx="420624" cy="420624"/>
+            <a:off x="548640" y="5660136"/>
+            <a:ext cx="384048" cy="384048"/>
           </a:xfrm>
           <a:prstGeom prst="ellipse">
             <a:avLst/>
@@ -38022,7 +38166,7 @@
       </p:sp>
       <p:pic>
         <p:nvPicPr>
-          <p:cNvPr id="38" name="Image 4" descr="preencoded.png">    </p:cNvPr>
+          <p:cNvPr id="40" name="Image 4" descr="preencoded.png">    </p:cNvPr>
           <p:cNvPicPr>
             <a:picLocks noChangeAspect="1"/>
           </p:cNvPicPr>
@@ -38036,8 +38180,8 @@
         </p:blipFill>
         <p:spPr>
           <a:xfrm>
-            <a:off x="653796" y="5948172"/>
-            <a:ext cx="210312" cy="210312"/>
+            <a:off x="644652" y="5756148"/>
+            <a:ext cx="192024" cy="192024"/>
           </a:xfrm>
           <a:prstGeom prst="rect">
             <a:avLst/>
@@ -38046,14 +38190,14 @@
       </p:pic>
       <p:sp>
         <p:nvSpPr>
-          <p:cNvPr id="39" name="Text 32"/>
-          <p:cNvSpPr txBox="1"/>
-          <p:nvPr/>
-        </p:nvSpPr>
-        <p:spPr>
-          <a:xfrm>
-            <a:off x="1170432" y="5779008"/>
-            <a:ext cx="10469880" cy="548640"/>
+          <p:cNvPr id="41" name="Text 34"/>
+          <p:cNvSpPr txBox="1"/>
+          <p:nvPr/>
+        </p:nvSpPr>
+        <p:spPr>
+          <a:xfrm>
+            <a:off x="1097280" y="5605272"/>
+            <a:ext cx="10543032" cy="493776"/>
           </a:xfrm>
           <a:prstGeom prst="rect">
             <a:avLst/>
@@ -38069,7 +38213,7 @@
               <a:buNone/>
             </a:pPr>
             <a:r>
-              <a:rPr lang="en-US" sz="1400" dirty="0">
+              <a:rPr lang="en-US" sz="1300" dirty="0">
                 <a:solidFill>
                   <a:srgbClr val="1F2937"/>
                 </a:solidFill>
@@ -38079,13 +38223,52 @@
               </a:rPr>
               <a:t>Supervisors and managers address any non-compliance on the spot and report it in their STEP observations.</a:t>
             </a:r>
-            <a:endParaRPr lang="en-US" sz="1400" dirty="0"/>
-          </a:p>
-        </p:txBody>
-      </p:sp>
-      <p:sp>
-        <p:nvSpPr>
-          <p:cNvPr id="40" name="Text 33"/>
+            <a:endParaRPr lang="en-US" sz="1300" dirty="0"/>
+          </a:p>
+        </p:txBody>
+      </p:sp>
+      <p:sp>
+        <p:nvSpPr>
+          <p:cNvPr id="42" name="Text 35"/>
+          <p:cNvSpPr txBox="1"/>
+          <p:nvPr/>
+        </p:nvSpPr>
+        <p:spPr>
+          <a:xfrm>
+            <a:off x="548640" y="6172200"/>
+            <a:ext cx="11091672" cy="228600"/>
+          </a:xfrm>
+          <a:prstGeom prst="rect">
+            <a:avLst/>
+          </a:prstGeom>
+          <a:noFill/>
+          <a:ln/>
+        </p:spPr>
+        <p:txBody>
+          <a:bodyPr wrap="square" lIns="0" tIns="0" rIns="0" bIns="0" rtlCol="0" anchor="ctr"/>
+          <a:lstStyle/>
+          <a:p>
+            <a:pPr indent="0" marL="0">
+              <a:buNone/>
+            </a:pPr>
+            <a:r>
+              <a:rPr lang="en-US" sz="900" i="1" dirty="0">
+                <a:solidFill>
+                  <a:srgbClr val="6B7280"/>
+                </a:solidFill>
+                <a:latin typeface="Calibri" pitchFamily="34" charset="0"/>
+                <a:ea typeface="Calibri" pitchFamily="34" charset="-122"/>
+                <a:cs typeface="Calibri" pitchFamily="34" charset="-120"/>
+              </a:rPr>
+              <a:t>Source: Management Control Report — F27 TRIR, Aug-26 (Mississauga). Days since last recordable: TBC.</a:t>
+            </a:r>
+            <a:endParaRPr lang="en-US" sz="900" dirty="0"/>
+          </a:p>
+        </p:txBody>
+      </p:sp>
+      <p:sp>
+        <p:nvSpPr>
+          <p:cNvPr id="43" name="Text 36"/>
           <p:cNvSpPr txBox="1"/>
           <p:nvPr/>
         </p:nvSpPr>
@@ -38124,7 +38307,7 @@
       </p:sp>
       <p:sp>
         <p:nvSpPr>
-          <p:cNvPr id="41" name="Text 34"/>
+          <p:cNvPr id="44" name="Text 37"/>
           <p:cNvSpPr txBox="1"/>
           <p:nvPr/>
         </p:nvSpPr>

</xml_diff>

<commit_message>
Deck: real Mississauga outbound load factor slide
Co-Authored-By: Claude Opus 5.5 <noreply@anthropic.com>
Claude-Session: https://claude.ai/code/session_01BwRjju3y2wk3wSHFrM9KLe
</commit_message>
<xml_diff>
--- a/presentation/Mississauga_F27_Leadership_Review_Sep29.pptx
+++ b/presentation/Mississauga_F27_Leadership_Review_Sep29.pptx
@@ -1171,6 +1171,369 @@
 </c:chartSpace>
 </file>
 
+<file path=ppt/charts/chart11.xml><?xml version="1.0" encoding="utf-8"?>
+<c:chartSpace xmlns:c="http://schemas.openxmlformats.org/drawingml/2006/chart" xmlns:a="http://schemas.openxmlformats.org/drawingml/2006/main" xmlns:r="http://schemas.openxmlformats.org/officeDocument/2006/relationships">
+  <c:date1904 val="0"/>
+  <c:roundedCorners val="1"/>
+  <c:chart>
+    <c:title>
+      <c:tx>
+        <c:rich>
+          <a:bodyPr/>
+          <a:lstStyle/>
+          <a:p>
+            <a:pPr>
+              <a:defRPr sz="1100" b="0" i="0" u="none" strike="noStrike">
+                <a:solidFill>
+                  <a:srgbClr val="111827"/>
+                </a:solidFill>
+                <a:latin typeface="Calibri"/>
+              </a:defRPr>
+            </a:pPr>
+            <a:r>
+              <a:rPr sz="1100" b="0" i="0" u="none" strike="noStrike">
+                <a:solidFill>
+                  <a:srgbClr val="111827"/>
+                </a:solidFill>
+                <a:latin typeface="Calibri"/>
+              </a:rPr>
+              <a:t>Monthly LF score &amp; load %</a:t>
+            </a:r>
+          </a:p>
+        </c:rich>
+      </c:tx>
+      <c:layout/>
+      <c:overlay val="0"/>
+    </c:title>
+    <c:autoTitleDeleted val="0"/>
+    <c:plotArea>
+      <c:layout/>
+      <c:barChart>
+        <c:barDir val="col"/>
+        <c:grouping val="clustered"/>
+        <c:varyColors val="0"/>
+        <c:ser>
+          <c:idx val="0"/>
+          <c:order val="0"/>
+          <c:tx>
+            <c:strRef>
+              <c:f>Sheet1!$B$1</c:f>
+              <c:strCache>
+                <c:ptCount val="1"/>
+                <c:pt idx="0">
+                  <c:v>LF score</c:v>
+                </c:pt>
+              </c:strCache>
+            </c:strRef>
+          </c:tx>
+          <c:spPr>
+            <a:solidFill>
+              <a:srgbClr val="7C3AED"/>
+            </a:solidFill>
+            <a:effectLst/>
+          </c:spPr>
+          <c:invertIfNegative val="0"/>
+          <c:dLbls>
+            <c:numFmt formatCode="0.0&quot;%&quot;" sourceLinked="0"/>
+            <c:txPr>
+              <a:bodyPr/>
+              <a:lstStyle/>
+              <a:p>
+                <a:pPr>
+                  <a:defRPr b="0" i="0" strike="noStrike" sz="900" u="none">
+                    <a:solidFill>
+                      <a:srgbClr val="1F2937"/>
+                    </a:solidFill>
+                    <a:latin typeface="Calibri"/>
+                  </a:defRPr>
+                </a:pPr>
+              </a:p>
+            </c:txPr>
+            <c:showLegendKey val="0"/>
+            <c:showVal val="1"/>
+            <c:showCatName val="0"/>
+            <c:showSerName val="0"/>
+            <c:showPercent val="0"/>
+            <c:showBubbleSize val="0"/>
+            <c:showLeaderLines val="0"/>
+          </c:dLbls>
+          <c:cat>
+            <c:multiLvlStrRef>
+              <c:f>Sheet1!$A$2:$A$4</c:f>
+              <c:multiLvlStrCache>
+                <c:ptCount val="3"/>
+                <c:lvl>
+                  <c:pt idx="0">
+                    <c:v>Jul (316 loads)</c:v>
+                  </c:pt>
+                  <c:pt idx="1">
+                    <c:v>Aug (293)</c:v>
+                  </c:pt>
+                  <c:pt idx="2">
+                    <c:v>Sep (245)</c:v>
+                  </c:pt>
+                </c:lvl>
+              </c:multiLvlStrCache>
+            </c:multiLvlStrRef>
+          </c:cat>
+          <c:val>
+            <c:numRef>
+              <c:f>Sheet1!$B$2:$B$4</c:f>
+              <c:numCache>
+                <c:formatCode>General</c:formatCode>
+                <c:ptCount val="3"/>
+                <c:pt idx="0">
+                  <c:v>38.9</c:v>
+                </c:pt>
+                <c:pt idx="1">
+                  <c:v>33.4</c:v>
+                </c:pt>
+                <c:pt idx="2">
+                  <c:v>36.7</c:v>
+                </c:pt>
+              </c:numCache>
+            </c:numRef>
+          </c:val>
+        </c:ser>
+        <c:ser>
+          <c:idx val="1"/>
+          <c:order val="1"/>
+          <c:tx>
+            <c:strRef>
+              <c:f>Sheet1!$C$1</c:f>
+              <c:strCache>
+                <c:ptCount val="1"/>
+                <c:pt idx="0">
+                  <c:v>Load %</c:v>
+                </c:pt>
+              </c:strCache>
+            </c:strRef>
+          </c:tx>
+          <c:spPr>
+            <a:solidFill>
+              <a:srgbClr val="C4B5FD"/>
+            </a:solidFill>
+            <a:effectLst/>
+          </c:spPr>
+          <c:invertIfNegative val="0"/>
+          <c:dLbls>
+            <c:numFmt formatCode="0.0&quot;%&quot;" sourceLinked="0"/>
+            <c:txPr>
+              <a:bodyPr/>
+              <a:lstStyle/>
+              <a:p>
+                <a:pPr>
+                  <a:defRPr b="0" i="0" strike="noStrike" sz="900" u="none">
+                    <a:solidFill>
+                      <a:srgbClr val="1F2937"/>
+                    </a:solidFill>
+                    <a:latin typeface="Calibri"/>
+                  </a:defRPr>
+                </a:pPr>
+              </a:p>
+            </c:txPr>
+            <c:showLegendKey val="0"/>
+            <c:showVal val="1"/>
+            <c:showCatName val="0"/>
+            <c:showSerName val="0"/>
+            <c:showPercent val="0"/>
+            <c:showBubbleSize val="0"/>
+            <c:showLeaderLines val="0"/>
+          </c:dLbls>
+          <c:cat>
+            <c:multiLvlStrRef>
+              <c:f>Sheet1!$A$2:$A$4</c:f>
+              <c:multiLvlStrCache>
+                <c:ptCount val="3"/>
+                <c:lvl>
+                  <c:pt idx="0">
+                    <c:v>Jul (316 loads)</c:v>
+                  </c:pt>
+                  <c:pt idx="1">
+                    <c:v>Aug (293)</c:v>
+                  </c:pt>
+                  <c:pt idx="2">
+                    <c:v>Sep (245)</c:v>
+                  </c:pt>
+                </c:lvl>
+              </c:multiLvlStrCache>
+            </c:multiLvlStrRef>
+          </c:cat>
+          <c:val>
+            <c:numRef>
+              <c:f>Sheet1!$C$2:$C$4</c:f>
+              <c:numCache>
+                <c:formatCode>General</c:formatCode>
+                <c:ptCount val="3"/>
+                <c:pt idx="0">
+                  <c:v>79.6</c:v>
+                </c:pt>
+                <c:pt idx="1">
+                  <c:v>71.5</c:v>
+                </c:pt>
+                <c:pt idx="2">
+                  <c:v>72.8</c:v>
+                </c:pt>
+              </c:numCache>
+            </c:numRef>
+          </c:val>
+        </c:ser>
+        <c:dLbls>
+          <c:numFmt formatCode="0.0&quot;%&quot;" sourceLinked="0"/>
+          <c:txPr>
+            <a:bodyPr/>
+            <a:lstStyle/>
+            <a:p>
+              <a:pPr>
+                <a:defRPr b="0" i="0" strike="noStrike" sz="900" u="none">
+                  <a:solidFill>
+                    <a:srgbClr val="1F2937"/>
+                  </a:solidFill>
+                  <a:latin typeface="Calibri"/>
+                </a:defRPr>
+              </a:pPr>
+            </a:p>
+          </c:txPr>
+          <c:showLegendKey val="0"/>
+          <c:showVal val="1"/>
+          <c:showCatName val="0"/>
+          <c:showSerName val="0"/>
+          <c:showPercent val="0"/>
+          <c:showBubbleSize val="0"/>
+          <c:showLeaderLines val="0"/>
+        </c:dLbls>
+        <c:gapWidth val="50"/>
+        <c:overlap val="0"/>
+        <c:axId val="2094734554"/>
+        <c:axId val="2094734552"/>
+        <c:axId val="2094734556"/>
+      </c:barChart>
+      <c:catAx>
+        <c:axId val="2094734554"/>
+        <c:scaling>
+          <c:orientation val="minMax"/>
+        </c:scaling>
+        <c:delete val="0"/>
+        <c:axPos val="b"/>
+        <c:numFmt formatCode="General" sourceLinked="1"/>
+        <c:majorTickMark val="out"/>
+        <c:minorTickMark val="none"/>
+        <c:tickLblPos val="low"/>
+        <c:spPr>
+          <a:ln w="12700" cap="flat">
+            <a:solidFill>
+              <a:srgbClr val="888888"/>
+            </a:solidFill>
+            <a:prstDash val="solid"/>
+            <a:round/>
+          </a:ln>
+        </c:spPr>
+        <c:txPr>
+          <a:bodyPr/>
+          <a:lstStyle/>
+          <a:p>
+            <a:pPr>
+              <a:defRPr sz="900" b="0" i="0" u="none" strike="noStrike">
+                <a:solidFill>
+                  <a:srgbClr val="1F2937"/>
+                </a:solidFill>
+                <a:latin typeface="Calibri"/>
+              </a:defRPr>
+            </a:pPr>
+            <a:endParaRPr lang="en-US"/>
+          </a:p>
+        </c:txPr>
+        <c:crossAx val="2094734552"/>
+        <c:crosses val="autoZero"/>
+        <c:auto val="1"/>
+        <c:lblAlgn val="ctr"/>
+        <c:noMultiLvlLbl val="1"/>
+      </c:catAx>
+      <c:valAx>
+        <c:axId val="2094734552"/>
+        <c:scaling>
+          <c:orientation val="minMax"/>
+          <c:max val="100"/>
+          <c:min val="0"/>
+        </c:scaling>
+        <c:delete val="1"/>
+        <c:axPos val="l"/>
+        <c:numFmt formatCode="General" sourceLinked="0"/>
+        <c:majorTickMark val="out"/>
+        <c:minorTickMark val="none"/>
+        <c:tickLblPos val="nextTo"/>
+        <c:spPr>
+          <a:ln w="12700" cap="flat">
+            <a:solidFill>
+              <a:srgbClr val="888888"/>
+            </a:solidFill>
+            <a:prstDash val="solid"/>
+            <a:round/>
+          </a:ln>
+        </c:spPr>
+        <c:txPr>
+          <a:bodyPr/>
+          <a:lstStyle/>
+          <a:p>
+            <a:pPr>
+              <a:defRPr sz="1200" b="0" i="0" u="none" strike="noStrike">
+                <a:solidFill>
+                  <a:srgbClr val="000000"/>
+                </a:solidFill>
+                <a:latin typeface="Arial"/>
+              </a:defRPr>
+            </a:pPr>
+            <a:endParaRPr lang="en-US"/>
+          </a:p>
+        </c:txPr>
+        <c:crossAx val="2094734554"/>
+        <c:crosses val="autoZero"/>
+        <c:crossBetween val="between"/>
+      </c:valAx>
+      <c:spPr>
+        <a:noFill/>
+        <a:ln>
+          <a:noFill/>
+        </a:ln>
+        <a:effectLst/>
+      </c:spPr>
+    </c:plotArea>
+    <c:legend>
+      <c:legendPos val="b"/>
+      <c:overlay val="0"/>
+      <c:txPr>
+        <a:bodyPr/>
+        <a:lstStyle/>
+        <a:p>
+          <a:pPr>
+            <a:defRPr sz="900">
+              <a:solidFill>
+                <a:srgbClr val="1F2937"/>
+              </a:solidFill>
+              <a:latin typeface="Calibri"/>
+              <a:cs typeface="Calibri"/>
+            </a:defRPr>
+          </a:pPr>
+          <a:endParaRPr lang="en-US"/>
+        </a:p>
+      </c:txPr>
+    </c:legend>
+    <c:plotVisOnly val="1"/>
+    <c:dispBlanksAs val="span"/>
+  </c:chart>
+  <c:spPr>
+    <a:noFill/>
+    <a:ln>
+      <a:noFill/>
+    </a:ln>
+    <a:effectLst/>
+  </c:spPr>
+  <c:externalData r:id="rId1">
+    <c:autoUpdate val="0"/>
+  </c:externalData>
+</c:chartSpace>
+</file>
+
 <file path=ppt/charts/chart2.xml><?xml version="1.0" encoding="utf-8"?>
 <c:chartSpace xmlns:c="http://schemas.openxmlformats.org/drawingml/2006/chart" xmlns:a="http://schemas.openxmlformats.org/drawingml/2006/main" xmlns:r="http://schemas.openxmlformats.org/officeDocument/2006/relationships">
   <c:date1904 val="0"/>
@@ -5229,7 +5592,7 @@
           <a:p>
             <a:r>
               <a:rPr lang="en-US" dirty="0"/>
-              <a:t>These are the four September weeks for load factor score and load percentage against the 80 and 98 percent targets; the weekly figures are being confirmed. Consolidating large-customer freight into fewer trailers is the main lever here and is part of the F27 savings plan.</a:t>
+              <a:t>Load factor is our biggest open opportunity. Only 36.4 percent of outbound loads so far in F27 are above 80 percent full, with an average load of 74.9 percent. Western lanes like Burnaby, Winnipeg and Calgary load well, while Windsor, Quebec City and Dartmouth run consistently light and need a consolidation and frequency review. Moncton also has most of our bills with no cube, 1,771 of 3,166, so fixing cube capture there will raise that lane's measured load factor.</a:t>
             </a:r>
             <a:endParaRPr lang="en-US" dirty="0"/>
           </a:p>
@@ -28069,7 +28432,7 @@
                 <a:ea typeface="Calibri" pitchFamily="34" charset="-122"/>
                 <a:cs typeface="Calibri" pitchFamily="34" charset="-120"/>
               </a:rPr>
-              <a:t>Load factor — September</a:t>
+              <a:t>Load factor — outbound, F27 Jul–Sep</a:t>
             </a:r>
             <a:endParaRPr lang="en-US" sz="3000" dirty="0"/>
           </a:p>
@@ -28083,8 +28446,8 @@
         </p:nvSpPr>
         <p:spPr>
           <a:xfrm>
-            <a:off x="548640" y="1261872"/>
-            <a:ext cx="10972800" cy="320040"/>
+            <a:off x="548640" y="1243584"/>
+            <a:ext cx="10972800" cy="274320"/>
           </a:xfrm>
           <a:prstGeom prst="rect">
             <a:avLst/>
@@ -28100,7 +28463,7 @@
               <a:buNone/>
             </a:pPr>
             <a:r>
-              <a:rPr lang="en-US" sz="1500" dirty="0">
+              <a:rPr lang="en-US" sz="1250" dirty="0">
                 <a:solidFill>
                   <a:srgbClr val="6B7280"/>
                 </a:solidFill>
@@ -28108,65 +28471,9 @@
                 <a:ea typeface="Calibri" pitchFamily="34" charset="-122"/>
                 <a:cs typeface="Calibri" pitchFamily="34" charset="-120"/>
               </a:rPr>
-              <a:t>Weekly LF score vs </a:t>
-            </a:r>
-            <a:pPr indent="0" marL="0">
-              <a:buNone/>
-            </a:pPr>
-            <a:r>
-              <a:rPr lang="en-US" sz="1500" b="1" dirty="0">
-                <a:solidFill>
-                  <a:srgbClr val="111827"/>
-                </a:solidFill>
-                <a:latin typeface="Calibri" pitchFamily="34" charset="0"/>
-                <a:ea typeface="Calibri" pitchFamily="34" charset="-122"/>
-                <a:cs typeface="Calibri" pitchFamily="34" charset="-120"/>
-              </a:rPr>
-              <a:t>80%</a:t>
-            </a:r>
-            <a:pPr indent="0" marL="0">
-              <a:buNone/>
-            </a:pPr>
-            <a:r>
-              <a:rPr lang="en-US" sz="1500" dirty="0">
-                <a:solidFill>
-                  <a:srgbClr val="6B7280"/>
-                </a:solidFill>
-                <a:latin typeface="Calibri" pitchFamily="34" charset="0"/>
-                <a:ea typeface="Calibri" pitchFamily="34" charset="-122"/>
-                <a:cs typeface="Calibri" pitchFamily="34" charset="-120"/>
-              </a:rPr>
-              <a:t> target  ·  load % vs </a:t>
-            </a:r>
-            <a:pPr indent="0" marL="0">
-              <a:buNone/>
-            </a:pPr>
-            <a:r>
-              <a:rPr lang="en-US" sz="1500" b="1" dirty="0">
-                <a:solidFill>
-                  <a:srgbClr val="111827"/>
-                </a:solidFill>
-                <a:latin typeface="Calibri" pitchFamily="34" charset="0"/>
-                <a:ea typeface="Calibri" pitchFamily="34" charset="-122"/>
-                <a:cs typeface="Calibri" pitchFamily="34" charset="-120"/>
-              </a:rPr>
-              <a:t>98%</a:t>
-            </a:r>
-            <a:pPr indent="0" marL="0">
-              <a:buNone/>
-            </a:pPr>
-            <a:r>
-              <a:rPr lang="en-US" sz="1500" dirty="0">
-                <a:solidFill>
-                  <a:srgbClr val="6B7280"/>
-                </a:solidFill>
-                <a:latin typeface="Calibri" pitchFamily="34" charset="0"/>
-                <a:ea typeface="Calibri" pitchFamily="34" charset="-122"/>
-                <a:cs typeface="Calibri" pitchFamily="34" charset="-120"/>
-              </a:rPr>
-              <a:t> target</a:t>
-            </a:r>
-            <a:endParaRPr lang="en-US" sz="1500" dirty="0"/>
+              <a:t>LF score = % of loads with load factor &gt;80% · Load % = average load percentage</a:t>
+            </a:r>
+            <a:endParaRPr lang="en-US" sz="1250" dirty="0"/>
           </a:p>
         </p:txBody>
       </p:sp>
@@ -28178,12 +28485,12 @@
         </p:nvSpPr>
         <p:spPr>
           <a:xfrm>
-            <a:off x="548640" y="1783080"/>
-            <a:ext cx="2567178" cy="3291840"/>
+            <a:off x="548640" y="1572768"/>
+            <a:ext cx="2635758" cy="987552"/>
           </a:xfrm>
           <a:prstGeom prst="roundRect">
             <a:avLst>
-              <a:gd name="adj" fmla="val 2850"/>
+              <a:gd name="adj" fmla="val 7407"/>
             </a:avLst>
           </a:prstGeom>
           <a:solidFill>
@@ -28199,28 +28506,42 @@
       </p:sp>
       <p:sp>
         <p:nvSpPr>
-          <p:cNvPr id="6" name="Shape 4"/>
-          <p:cNvSpPr/>
-          <p:nvPr/>
-        </p:nvSpPr>
-        <p:spPr>
-          <a:xfrm>
-            <a:off x="777240" y="2011680"/>
-            <a:ext cx="457200" cy="457200"/>
-          </a:xfrm>
-          <a:prstGeom prst="ellipse">
-            <a:avLst/>
-          </a:prstGeom>
-          <a:solidFill>
-            <a:srgbClr val="7C3AED"/>
-          </a:solidFill>
-          <a:ln w="12700">
-            <a:solidFill>
-              <a:srgbClr val="7C3AED"/>
-            </a:solidFill>
-            <a:prstDash val="solid"/>
-          </a:ln>
-        </p:spPr>
+          <p:cNvPr id="6" name="Text 4"/>
+          <p:cNvSpPr txBox="1"/>
+          <p:nvPr/>
+        </p:nvSpPr>
+        <p:spPr>
+          <a:xfrm>
+            <a:off x="731520" y="1664208"/>
+            <a:ext cx="2269998" cy="237744"/>
+          </a:xfrm>
+          <a:prstGeom prst="rect">
+            <a:avLst/>
+          </a:prstGeom>
+          <a:noFill/>
+          <a:ln/>
+        </p:spPr>
+        <p:txBody>
+          <a:bodyPr wrap="square" lIns="0" tIns="0" rIns="0" bIns="0" rtlCol="0" anchor="ctr"/>
+          <a:lstStyle/>
+          <a:p>
+            <a:pPr indent="0" marL="0">
+              <a:buNone/>
+            </a:pPr>
+            <a:r>
+              <a:rPr lang="en-US" sz="1100" b="1" dirty="0">
+                <a:solidFill>
+                  <a:srgbClr val="6B7280"/>
+                </a:solidFill>
+                <a:latin typeface="Calibri" pitchFamily="34" charset="0"/>
+                <a:ea typeface="Calibri" pitchFamily="34" charset="-122"/>
+                <a:cs typeface="Calibri" pitchFamily="34" charset="-120"/>
+              </a:rPr>
+              <a:t>LF score · F27 to date</a:t>
+            </a:r>
+            <a:endParaRPr lang="en-US" sz="1100" dirty="0"/>
+          </a:p>
+        </p:txBody>
       </p:sp>
       <p:sp>
         <p:nvSpPr>
@@ -28230,8 +28551,8 @@
         </p:nvSpPr>
         <p:spPr>
           <a:xfrm>
-            <a:off x="777240" y="2011680"/>
-            <a:ext cx="457200" cy="457200"/>
+            <a:off x="731520" y="1901952"/>
+            <a:ext cx="2269998" cy="402336"/>
           </a:xfrm>
           <a:prstGeom prst="rect">
             <a:avLst/>
@@ -28243,21 +28564,21 @@
           <a:bodyPr wrap="square" lIns="0" tIns="0" rIns="0" bIns="0" rtlCol="0" anchor="ctr"/>
           <a:lstStyle/>
           <a:p>
-            <a:pPr algn="ctr" indent="0" marL="0">
-              <a:buNone/>
-            </a:pPr>
-            <a:r>
-              <a:rPr lang="en-US" sz="1400" b="1" dirty="0">
-                <a:solidFill>
-                  <a:srgbClr val="FFFFFF"/>
-                </a:solidFill>
-                <a:latin typeface="Calibri" pitchFamily="34" charset="0"/>
-                <a:ea typeface="Calibri" pitchFamily="34" charset="-122"/>
-                <a:cs typeface="Calibri" pitchFamily="34" charset="-120"/>
-              </a:rPr>
-              <a:t>1</a:t>
-            </a:r>
-            <a:endParaRPr lang="en-US" sz="1400" dirty="0"/>
+            <a:pPr indent="0" marL="0">
+              <a:buNone/>
+            </a:pPr>
+            <a:r>
+              <a:rPr lang="en-US" sz="2400" b="1" dirty="0">
+                <a:solidFill>
+                  <a:srgbClr val="111827"/>
+                </a:solidFill>
+                <a:latin typeface="Calibri" pitchFamily="34" charset="0"/>
+                <a:ea typeface="Calibri" pitchFamily="34" charset="-122"/>
+                <a:cs typeface="Calibri" pitchFamily="34" charset="-120"/>
+              </a:rPr>
+              <a:t>36.4%</a:t>
+            </a:r>
+            <a:endParaRPr lang="en-US" sz="2400" dirty="0"/>
           </a:p>
         </p:txBody>
       </p:sp>
@@ -28269,8 +28590,8 @@
         </p:nvSpPr>
         <p:spPr>
           <a:xfrm>
-            <a:off x="1371600" y="2011680"/>
-            <a:ext cx="1561338" cy="457200"/>
+            <a:off x="731520" y="2304288"/>
+            <a:ext cx="2269998" cy="219456"/>
           </a:xfrm>
           <a:prstGeom prst="rect">
             <a:avLst/>
@@ -28286,46 +28607,7 @@
               <a:buNone/>
             </a:pPr>
             <a:r>
-              <a:rPr lang="en-US" sz="1600" b="1" dirty="0">
-                <a:solidFill>
-                  <a:srgbClr val="111827"/>
-                </a:solidFill>
-                <a:latin typeface="Calibri" pitchFamily="34" charset="0"/>
-                <a:ea typeface="Calibri" pitchFamily="34" charset="-122"/>
-                <a:cs typeface="Calibri" pitchFamily="34" charset="-120"/>
-              </a:rPr>
-              <a:t>Sep 1–5</a:t>
-            </a:r>
-            <a:endParaRPr lang="en-US" sz="1600" dirty="0"/>
-          </a:p>
-        </p:txBody>
-      </p:sp>
-      <p:sp>
-        <p:nvSpPr>
-          <p:cNvPr id="9" name="Text 7"/>
-          <p:cNvSpPr txBox="1"/>
-          <p:nvPr/>
-        </p:nvSpPr>
-        <p:spPr>
-          <a:xfrm>
-            <a:off x="777240" y="2651760"/>
-            <a:ext cx="2109978" cy="274320"/>
-          </a:xfrm>
-          <a:prstGeom prst="rect">
-            <a:avLst/>
-          </a:prstGeom>
-          <a:noFill/>
-          <a:ln/>
-        </p:spPr>
-        <p:txBody>
-          <a:bodyPr wrap="square" lIns="0" tIns="0" rIns="0" bIns="0" rtlCol="0" anchor="ctr"/>
-          <a:lstStyle/>
-          <a:p>
-            <a:pPr indent="0" marL="0">
-              <a:buNone/>
-            </a:pPr>
-            <a:r>
-              <a:rPr lang="en-US" sz="1200" b="1" dirty="0">
+              <a:rPr lang="en-US" sz="1000" dirty="0">
                 <a:solidFill>
                   <a:srgbClr val="6B7280"/>
                 </a:solidFill>
@@ -28333,221 +28615,26 @@
                 <a:ea typeface="Calibri" pitchFamily="34" charset="-122"/>
                 <a:cs typeface="Calibri" pitchFamily="34" charset="-120"/>
               </a:rPr>
-              <a:t>LF score</a:t>
-            </a:r>
-            <a:endParaRPr lang="en-US" sz="1200" dirty="0"/>
-          </a:p>
-        </p:txBody>
-      </p:sp>
-      <p:sp>
-        <p:nvSpPr>
-          <p:cNvPr id="10" name="Text 8"/>
-          <p:cNvSpPr txBox="1"/>
-          <p:nvPr/>
-        </p:nvSpPr>
-        <p:spPr>
-          <a:xfrm>
-            <a:off x="777240" y="2898648"/>
-            <a:ext cx="2109978" cy="594360"/>
-          </a:xfrm>
-          <a:prstGeom prst="rect">
-            <a:avLst/>
-          </a:prstGeom>
-          <a:noFill/>
-          <a:ln/>
-        </p:spPr>
-        <p:txBody>
-          <a:bodyPr wrap="square" lIns="0" tIns="0" rIns="0" bIns="0" rtlCol="0" anchor="ctr"/>
-          <a:lstStyle/>
-          <a:p>
-            <a:pPr indent="0" marL="0">
-              <a:buNone/>
-            </a:pPr>
-            <a:r>
-              <a:rPr lang="en-US" sz="3200" b="1" dirty="0">
-                <a:solidFill>
-                  <a:srgbClr val="D97706"/>
-                </a:solidFill>
-                <a:latin typeface="Calibri" pitchFamily="34" charset="0"/>
-                <a:ea typeface="Calibri" pitchFamily="34" charset="-122"/>
-                <a:cs typeface="Calibri" pitchFamily="34" charset="-120"/>
-              </a:rPr>
-              <a:t>TBC</a:t>
-            </a:r>
-            <a:endParaRPr lang="en-US" sz="3200" dirty="0"/>
-          </a:p>
-        </p:txBody>
-      </p:sp>
-      <p:sp>
-        <p:nvSpPr>
-          <p:cNvPr id="11" name="Text 9"/>
-          <p:cNvSpPr txBox="1"/>
-          <p:nvPr/>
-        </p:nvSpPr>
-        <p:spPr>
-          <a:xfrm>
-            <a:off x="777240" y="3493008"/>
-            <a:ext cx="2109978" cy="228600"/>
-          </a:xfrm>
-          <a:prstGeom prst="rect">
-            <a:avLst/>
-          </a:prstGeom>
-          <a:noFill/>
-          <a:ln/>
-        </p:spPr>
-        <p:txBody>
-          <a:bodyPr wrap="square" lIns="0" tIns="0" rIns="0" bIns="0" rtlCol="0" anchor="ctr"/>
-          <a:lstStyle/>
-          <a:p>
-            <a:pPr indent="0" marL="0">
-              <a:buNone/>
-            </a:pPr>
-            <a:r>
-              <a:rPr lang="en-US" sz="1100" dirty="0">
-                <a:solidFill>
-                  <a:srgbClr val="6B7280"/>
-                </a:solidFill>
-                <a:latin typeface="Calibri" pitchFamily="34" charset="0"/>
-                <a:ea typeface="Calibri" pitchFamily="34" charset="-122"/>
-                <a:cs typeface="Calibri" pitchFamily="34" charset="-120"/>
-              </a:rPr>
-              <a:t>Target 80%</a:t>
-            </a:r>
-            <a:endParaRPr lang="en-US" sz="1100" dirty="0"/>
-          </a:p>
-        </p:txBody>
-      </p:sp>
-      <p:sp>
-        <p:nvSpPr>
-          <p:cNvPr id="12" name="Text 10"/>
-          <p:cNvSpPr txBox="1"/>
-          <p:nvPr/>
-        </p:nvSpPr>
-        <p:spPr>
-          <a:xfrm>
-            <a:off x="777240" y="3886200"/>
-            <a:ext cx="2109978" cy="274320"/>
-          </a:xfrm>
-          <a:prstGeom prst="rect">
-            <a:avLst/>
-          </a:prstGeom>
-          <a:noFill/>
-          <a:ln/>
-        </p:spPr>
-        <p:txBody>
-          <a:bodyPr wrap="square" lIns="0" tIns="0" rIns="0" bIns="0" rtlCol="0" anchor="ctr"/>
-          <a:lstStyle/>
-          <a:p>
-            <a:pPr indent="0" marL="0">
-              <a:buNone/>
-            </a:pPr>
-            <a:r>
-              <a:rPr lang="en-US" sz="1200" b="1" dirty="0">
-                <a:solidFill>
-                  <a:srgbClr val="6B7280"/>
-                </a:solidFill>
-                <a:latin typeface="Calibri" pitchFamily="34" charset="0"/>
-                <a:ea typeface="Calibri" pitchFamily="34" charset="-122"/>
-                <a:cs typeface="Calibri" pitchFamily="34" charset="-120"/>
-              </a:rPr>
-              <a:t>Load %</a:t>
-            </a:r>
-            <a:endParaRPr lang="en-US" sz="1200" dirty="0"/>
-          </a:p>
-        </p:txBody>
-      </p:sp>
-      <p:sp>
-        <p:nvSpPr>
-          <p:cNvPr id="13" name="Text 11"/>
-          <p:cNvSpPr txBox="1"/>
-          <p:nvPr/>
-        </p:nvSpPr>
-        <p:spPr>
-          <a:xfrm>
-            <a:off x="777240" y="4133088"/>
-            <a:ext cx="2109978" cy="594360"/>
-          </a:xfrm>
-          <a:prstGeom prst="rect">
-            <a:avLst/>
-          </a:prstGeom>
-          <a:noFill/>
-          <a:ln/>
-        </p:spPr>
-        <p:txBody>
-          <a:bodyPr wrap="square" lIns="0" tIns="0" rIns="0" bIns="0" rtlCol="0" anchor="ctr"/>
-          <a:lstStyle/>
-          <a:p>
-            <a:pPr indent="0" marL="0">
-              <a:buNone/>
-            </a:pPr>
-            <a:r>
-              <a:rPr lang="en-US" sz="3200" b="1" dirty="0">
-                <a:solidFill>
-                  <a:srgbClr val="D97706"/>
-                </a:solidFill>
-                <a:latin typeface="Calibri" pitchFamily="34" charset="0"/>
-                <a:ea typeface="Calibri" pitchFamily="34" charset="-122"/>
-                <a:cs typeface="Calibri" pitchFamily="34" charset="-120"/>
-              </a:rPr>
-              <a:t>TBC</a:t>
-            </a:r>
-            <a:endParaRPr lang="en-US" sz="3200" dirty="0"/>
-          </a:p>
-        </p:txBody>
-      </p:sp>
-      <p:sp>
-        <p:nvSpPr>
-          <p:cNvPr id="14" name="Text 12"/>
-          <p:cNvSpPr txBox="1"/>
-          <p:nvPr/>
-        </p:nvSpPr>
-        <p:spPr>
-          <a:xfrm>
-            <a:off x="777240" y="4727448"/>
-            <a:ext cx="2109978" cy="228600"/>
-          </a:xfrm>
-          <a:prstGeom prst="rect">
-            <a:avLst/>
-          </a:prstGeom>
-          <a:noFill/>
-          <a:ln/>
-        </p:spPr>
-        <p:txBody>
-          <a:bodyPr wrap="square" lIns="0" tIns="0" rIns="0" bIns="0" rtlCol="0" anchor="ctr"/>
-          <a:lstStyle/>
-          <a:p>
-            <a:pPr indent="0" marL="0">
-              <a:buNone/>
-            </a:pPr>
-            <a:r>
-              <a:rPr lang="en-US" sz="1100" dirty="0">
-                <a:solidFill>
-                  <a:srgbClr val="6B7280"/>
-                </a:solidFill>
-                <a:latin typeface="Calibri" pitchFamily="34" charset="0"/>
-                <a:ea typeface="Calibri" pitchFamily="34" charset="-122"/>
-                <a:cs typeface="Calibri" pitchFamily="34" charset="-120"/>
-              </a:rPr>
-              <a:t>Target 98%</a:t>
-            </a:r>
-            <a:endParaRPr lang="en-US" sz="1100" dirty="0"/>
-          </a:p>
-        </p:txBody>
-      </p:sp>
-      <p:sp>
-        <p:nvSpPr>
-          <p:cNvPr id="15" name="Shape 13"/>
+              <a:t>311 of 854 loads &gt;80%</a:t>
+            </a:r>
+            <a:endParaRPr lang="en-US" sz="1000" dirty="0"/>
+          </a:p>
+        </p:txBody>
+      </p:sp>
+      <p:sp>
+        <p:nvSpPr>
+          <p:cNvPr id="9" name="Shape 7"/>
           <p:cNvSpPr/>
           <p:nvPr/>
         </p:nvSpPr>
         <p:spPr>
           <a:xfrm>
-            <a:off x="3390138" y="1783080"/>
-            <a:ext cx="2567178" cy="3291840"/>
+            <a:off x="3367278" y="1572768"/>
+            <a:ext cx="2635758" cy="987552"/>
           </a:xfrm>
           <a:prstGeom prst="roundRect">
             <a:avLst>
-              <a:gd name="adj" fmla="val 2850"/>
+              <a:gd name="adj" fmla="val 7407"/>
             </a:avLst>
           </a:prstGeom>
           <a:solidFill>
@@ -28563,39 +28650,14 @@
       </p:sp>
       <p:sp>
         <p:nvSpPr>
-          <p:cNvPr id="16" name="Shape 14"/>
-          <p:cNvSpPr/>
-          <p:nvPr/>
-        </p:nvSpPr>
-        <p:spPr>
-          <a:xfrm>
-            <a:off x="3618738" y="2011680"/>
-            <a:ext cx="457200" cy="457200"/>
-          </a:xfrm>
-          <a:prstGeom prst="ellipse">
-            <a:avLst/>
-          </a:prstGeom>
-          <a:solidFill>
-            <a:srgbClr val="7C3AED"/>
-          </a:solidFill>
-          <a:ln w="12700">
-            <a:solidFill>
-              <a:srgbClr val="7C3AED"/>
-            </a:solidFill>
-            <a:prstDash val="solid"/>
-          </a:ln>
-        </p:spPr>
-      </p:sp>
-      <p:sp>
-        <p:nvSpPr>
-          <p:cNvPr id="17" name="Text 15"/>
+          <p:cNvPr id="10" name="Text 8"/>
           <p:cNvSpPr txBox="1"/>
           <p:nvPr/>
         </p:nvSpPr>
         <p:spPr>
           <a:xfrm>
-            <a:off x="3618738" y="2011680"/>
-            <a:ext cx="457200" cy="457200"/>
+            <a:off x="3550158" y="1664208"/>
+            <a:ext cx="2269998" cy="237744"/>
           </a:xfrm>
           <a:prstGeom prst="rect">
             <a:avLst/>
@@ -28607,34 +28669,34 @@
           <a:bodyPr wrap="square" lIns="0" tIns="0" rIns="0" bIns="0" rtlCol="0" anchor="ctr"/>
           <a:lstStyle/>
           <a:p>
-            <a:pPr algn="ctr" indent="0" marL="0">
-              <a:buNone/>
-            </a:pPr>
-            <a:r>
-              <a:rPr lang="en-US" sz="1400" b="1" dirty="0">
-                <a:solidFill>
-                  <a:srgbClr val="FFFFFF"/>
-                </a:solidFill>
-                <a:latin typeface="Calibri" pitchFamily="34" charset="0"/>
-                <a:ea typeface="Calibri" pitchFamily="34" charset="-122"/>
-                <a:cs typeface="Calibri" pitchFamily="34" charset="-120"/>
-              </a:rPr>
-              <a:t>2</a:t>
-            </a:r>
-            <a:endParaRPr lang="en-US" sz="1400" dirty="0"/>
-          </a:p>
-        </p:txBody>
-      </p:sp>
-      <p:sp>
-        <p:nvSpPr>
-          <p:cNvPr id="18" name="Text 16"/>
+            <a:pPr indent="0" marL="0">
+              <a:buNone/>
+            </a:pPr>
+            <a:r>
+              <a:rPr lang="en-US" sz="1100" b="1" dirty="0">
+                <a:solidFill>
+                  <a:srgbClr val="6B7280"/>
+                </a:solidFill>
+                <a:latin typeface="Calibri" pitchFamily="34" charset="0"/>
+                <a:ea typeface="Calibri" pitchFamily="34" charset="-122"/>
+                <a:cs typeface="Calibri" pitchFamily="34" charset="-120"/>
+              </a:rPr>
+              <a:t>Average load %</a:t>
+            </a:r>
+            <a:endParaRPr lang="en-US" sz="1100" dirty="0"/>
+          </a:p>
+        </p:txBody>
+      </p:sp>
+      <p:sp>
+        <p:nvSpPr>
+          <p:cNvPr id="11" name="Text 9"/>
           <p:cNvSpPr txBox="1"/>
           <p:nvPr/>
         </p:nvSpPr>
         <p:spPr>
           <a:xfrm>
-            <a:off x="4213098" y="2011680"/>
-            <a:ext cx="1561338" cy="457200"/>
+            <a:off x="3550158" y="1901952"/>
+            <a:ext cx="2269998" cy="402336"/>
           </a:xfrm>
           <a:prstGeom prst="rect">
             <a:avLst/>
@@ -28650,7 +28712,7 @@
               <a:buNone/>
             </a:pPr>
             <a:r>
-              <a:rPr lang="en-US" sz="1600" b="1" dirty="0">
+              <a:rPr lang="en-US" sz="2400" b="1" dirty="0">
                 <a:solidFill>
                   <a:srgbClr val="111827"/>
                 </a:solidFill>
@@ -28658,22 +28720,22 @@
                 <a:ea typeface="Calibri" pitchFamily="34" charset="-122"/>
                 <a:cs typeface="Calibri" pitchFamily="34" charset="-120"/>
               </a:rPr>
-              <a:t>Sep 6–12</a:t>
-            </a:r>
-            <a:endParaRPr lang="en-US" sz="1600" dirty="0"/>
-          </a:p>
-        </p:txBody>
-      </p:sp>
-      <p:sp>
-        <p:nvSpPr>
-          <p:cNvPr id="19" name="Text 17"/>
+              <a:t>74.9%</a:t>
+            </a:r>
+            <a:endParaRPr lang="en-US" sz="2400" dirty="0"/>
+          </a:p>
+        </p:txBody>
+      </p:sp>
+      <p:sp>
+        <p:nvSpPr>
+          <p:cNvPr id="12" name="Text 10"/>
           <p:cNvSpPr txBox="1"/>
           <p:nvPr/>
         </p:nvSpPr>
         <p:spPr>
           <a:xfrm>
-            <a:off x="3618738" y="2651760"/>
-            <a:ext cx="2109978" cy="274320"/>
+            <a:off x="3550158" y="2304288"/>
+            <a:ext cx="2269998" cy="219456"/>
           </a:xfrm>
           <a:prstGeom prst="rect">
             <a:avLst/>
@@ -28689,7 +28751,7 @@
               <a:buNone/>
             </a:pPr>
             <a:r>
-              <a:rPr lang="en-US" sz="1200" b="1" dirty="0">
+              <a:rPr lang="en-US" sz="1000" dirty="0">
                 <a:solidFill>
                   <a:srgbClr val="6B7280"/>
                 </a:solidFill>
@@ -28697,221 +28759,26 @@
                 <a:ea typeface="Calibri" pitchFamily="34" charset="-122"/>
                 <a:cs typeface="Calibri" pitchFamily="34" charset="-120"/>
               </a:rPr>
-              <a:t>LF score</a:t>
-            </a:r>
-            <a:endParaRPr lang="en-US" sz="1200" dirty="0"/>
-          </a:p>
-        </p:txBody>
-      </p:sp>
-      <p:sp>
-        <p:nvSpPr>
-          <p:cNvPr id="20" name="Text 18"/>
-          <p:cNvSpPr txBox="1"/>
-          <p:nvPr/>
-        </p:nvSpPr>
-        <p:spPr>
-          <a:xfrm>
-            <a:off x="3618738" y="2898648"/>
-            <a:ext cx="2109978" cy="594360"/>
-          </a:xfrm>
-          <a:prstGeom prst="rect">
-            <a:avLst/>
-          </a:prstGeom>
-          <a:noFill/>
-          <a:ln/>
-        </p:spPr>
-        <p:txBody>
-          <a:bodyPr wrap="square" lIns="0" tIns="0" rIns="0" bIns="0" rtlCol="0" anchor="ctr"/>
-          <a:lstStyle/>
-          <a:p>
-            <a:pPr indent="0" marL="0">
-              <a:buNone/>
-            </a:pPr>
-            <a:r>
-              <a:rPr lang="en-US" sz="3200" b="1" dirty="0">
-                <a:solidFill>
-                  <a:srgbClr val="D97706"/>
-                </a:solidFill>
-                <a:latin typeface="Calibri" pitchFamily="34" charset="0"/>
-                <a:ea typeface="Calibri" pitchFamily="34" charset="-122"/>
-                <a:cs typeface="Calibri" pitchFamily="34" charset="-120"/>
-              </a:rPr>
-              <a:t>TBC</a:t>
-            </a:r>
-            <a:endParaRPr lang="en-US" sz="3200" dirty="0"/>
-          </a:p>
-        </p:txBody>
-      </p:sp>
-      <p:sp>
-        <p:nvSpPr>
-          <p:cNvPr id="21" name="Text 19"/>
-          <p:cNvSpPr txBox="1"/>
-          <p:nvPr/>
-        </p:nvSpPr>
-        <p:spPr>
-          <a:xfrm>
-            <a:off x="3618738" y="3493008"/>
-            <a:ext cx="2109978" cy="228600"/>
-          </a:xfrm>
-          <a:prstGeom prst="rect">
-            <a:avLst/>
-          </a:prstGeom>
-          <a:noFill/>
-          <a:ln/>
-        </p:spPr>
-        <p:txBody>
-          <a:bodyPr wrap="square" lIns="0" tIns="0" rIns="0" bIns="0" rtlCol="0" anchor="ctr"/>
-          <a:lstStyle/>
-          <a:p>
-            <a:pPr indent="0" marL="0">
-              <a:buNone/>
-            </a:pPr>
-            <a:r>
-              <a:rPr lang="en-US" sz="1100" dirty="0">
-                <a:solidFill>
-                  <a:srgbClr val="6B7280"/>
-                </a:solidFill>
-                <a:latin typeface="Calibri" pitchFamily="34" charset="0"/>
-                <a:ea typeface="Calibri" pitchFamily="34" charset="-122"/>
-                <a:cs typeface="Calibri" pitchFamily="34" charset="-120"/>
-              </a:rPr>
-              <a:t>Target 80%</a:t>
-            </a:r>
-            <a:endParaRPr lang="en-US" sz="1100" dirty="0"/>
-          </a:p>
-        </p:txBody>
-      </p:sp>
-      <p:sp>
-        <p:nvSpPr>
-          <p:cNvPr id="22" name="Text 20"/>
-          <p:cNvSpPr txBox="1"/>
-          <p:nvPr/>
-        </p:nvSpPr>
-        <p:spPr>
-          <a:xfrm>
-            <a:off x="3618738" y="3886200"/>
-            <a:ext cx="2109978" cy="274320"/>
-          </a:xfrm>
-          <a:prstGeom prst="rect">
-            <a:avLst/>
-          </a:prstGeom>
-          <a:noFill/>
-          <a:ln/>
-        </p:spPr>
-        <p:txBody>
-          <a:bodyPr wrap="square" lIns="0" tIns="0" rIns="0" bIns="0" rtlCol="0" anchor="ctr"/>
-          <a:lstStyle/>
-          <a:p>
-            <a:pPr indent="0" marL="0">
-              <a:buNone/>
-            </a:pPr>
-            <a:r>
-              <a:rPr lang="en-US" sz="1200" b="1" dirty="0">
-                <a:solidFill>
-                  <a:srgbClr val="6B7280"/>
-                </a:solidFill>
-                <a:latin typeface="Calibri" pitchFamily="34" charset="0"/>
-                <a:ea typeface="Calibri" pitchFamily="34" charset="-122"/>
-                <a:cs typeface="Calibri" pitchFamily="34" charset="-120"/>
-              </a:rPr>
-              <a:t>Load %</a:t>
-            </a:r>
-            <a:endParaRPr lang="en-US" sz="1200" dirty="0"/>
-          </a:p>
-        </p:txBody>
-      </p:sp>
-      <p:sp>
-        <p:nvSpPr>
-          <p:cNvPr id="23" name="Text 21"/>
-          <p:cNvSpPr txBox="1"/>
-          <p:nvPr/>
-        </p:nvSpPr>
-        <p:spPr>
-          <a:xfrm>
-            <a:off x="3618738" y="4133088"/>
-            <a:ext cx="2109978" cy="594360"/>
-          </a:xfrm>
-          <a:prstGeom prst="rect">
-            <a:avLst/>
-          </a:prstGeom>
-          <a:noFill/>
-          <a:ln/>
-        </p:spPr>
-        <p:txBody>
-          <a:bodyPr wrap="square" lIns="0" tIns="0" rIns="0" bIns="0" rtlCol="0" anchor="ctr"/>
-          <a:lstStyle/>
-          <a:p>
-            <a:pPr indent="0" marL="0">
-              <a:buNone/>
-            </a:pPr>
-            <a:r>
-              <a:rPr lang="en-US" sz="3200" b="1" dirty="0">
-                <a:solidFill>
-                  <a:srgbClr val="D97706"/>
-                </a:solidFill>
-                <a:latin typeface="Calibri" pitchFamily="34" charset="0"/>
-                <a:ea typeface="Calibri" pitchFamily="34" charset="-122"/>
-                <a:cs typeface="Calibri" pitchFamily="34" charset="-120"/>
-              </a:rPr>
-              <a:t>TBC</a:t>
-            </a:r>
-            <a:endParaRPr lang="en-US" sz="3200" dirty="0"/>
-          </a:p>
-        </p:txBody>
-      </p:sp>
-      <p:sp>
-        <p:nvSpPr>
-          <p:cNvPr id="24" name="Text 22"/>
-          <p:cNvSpPr txBox="1"/>
-          <p:nvPr/>
-        </p:nvSpPr>
-        <p:spPr>
-          <a:xfrm>
-            <a:off x="3618738" y="4727448"/>
-            <a:ext cx="2109978" cy="228600"/>
-          </a:xfrm>
-          <a:prstGeom prst="rect">
-            <a:avLst/>
-          </a:prstGeom>
-          <a:noFill/>
-          <a:ln/>
-        </p:spPr>
-        <p:txBody>
-          <a:bodyPr wrap="square" lIns="0" tIns="0" rIns="0" bIns="0" rtlCol="0" anchor="ctr"/>
-          <a:lstStyle/>
-          <a:p>
-            <a:pPr indent="0" marL="0">
-              <a:buNone/>
-            </a:pPr>
-            <a:r>
-              <a:rPr lang="en-US" sz="1100" dirty="0">
-                <a:solidFill>
-                  <a:srgbClr val="6B7280"/>
-                </a:solidFill>
-                <a:latin typeface="Calibri" pitchFamily="34" charset="0"/>
-                <a:ea typeface="Calibri" pitchFamily="34" charset="-122"/>
-                <a:cs typeface="Calibri" pitchFamily="34" charset="-120"/>
-              </a:rPr>
-              <a:t>Target 98%</a:t>
-            </a:r>
-            <a:endParaRPr lang="en-US" sz="1100" dirty="0"/>
-          </a:p>
-        </p:txBody>
-      </p:sp>
-      <p:sp>
-        <p:nvSpPr>
-          <p:cNvPr id="25" name="Shape 23"/>
+              <a:t>F27 Jul–Sep</a:t>
+            </a:r>
+            <a:endParaRPr lang="en-US" sz="1000" dirty="0"/>
+          </a:p>
+        </p:txBody>
+      </p:sp>
+      <p:sp>
+        <p:nvSpPr>
+          <p:cNvPr id="13" name="Shape 11"/>
           <p:cNvSpPr/>
           <p:nvPr/>
         </p:nvSpPr>
         <p:spPr>
           <a:xfrm>
-            <a:off x="6231636" y="1783080"/>
-            <a:ext cx="2567178" cy="3291840"/>
+            <a:off x="6185916" y="1572768"/>
+            <a:ext cx="2635758" cy="987552"/>
           </a:xfrm>
           <a:prstGeom prst="roundRect">
             <a:avLst>
-              <a:gd name="adj" fmla="val 2850"/>
+              <a:gd name="adj" fmla="val 7407"/>
             </a:avLst>
           </a:prstGeom>
           <a:solidFill>
@@ -28927,39 +28794,14 @@
       </p:sp>
       <p:sp>
         <p:nvSpPr>
-          <p:cNvPr id="26" name="Shape 24"/>
-          <p:cNvSpPr/>
-          <p:nvPr/>
-        </p:nvSpPr>
-        <p:spPr>
-          <a:xfrm>
-            <a:off x="6460236" y="2011680"/>
-            <a:ext cx="457200" cy="457200"/>
-          </a:xfrm>
-          <a:prstGeom prst="ellipse">
-            <a:avLst/>
-          </a:prstGeom>
-          <a:solidFill>
-            <a:srgbClr val="7C3AED"/>
-          </a:solidFill>
-          <a:ln w="12700">
-            <a:solidFill>
-              <a:srgbClr val="7C3AED"/>
-            </a:solidFill>
-            <a:prstDash val="solid"/>
-          </a:ln>
-        </p:spPr>
-      </p:sp>
-      <p:sp>
-        <p:nvSpPr>
-          <p:cNvPr id="27" name="Text 25"/>
+          <p:cNvPr id="14" name="Text 12"/>
           <p:cNvSpPr txBox="1"/>
           <p:nvPr/>
         </p:nvSpPr>
         <p:spPr>
           <a:xfrm>
-            <a:off x="6460236" y="2011680"/>
-            <a:ext cx="457200" cy="457200"/>
+            <a:off x="6368796" y="1664208"/>
+            <a:ext cx="2269998" cy="237744"/>
           </a:xfrm>
           <a:prstGeom prst="rect">
             <a:avLst/>
@@ -28971,34 +28813,34 @@
           <a:bodyPr wrap="square" lIns="0" tIns="0" rIns="0" bIns="0" rtlCol="0" anchor="ctr"/>
           <a:lstStyle/>
           <a:p>
-            <a:pPr algn="ctr" indent="0" marL="0">
-              <a:buNone/>
-            </a:pPr>
-            <a:r>
-              <a:rPr lang="en-US" sz="1400" b="1" dirty="0">
-                <a:solidFill>
-                  <a:srgbClr val="FFFFFF"/>
-                </a:solidFill>
-                <a:latin typeface="Calibri" pitchFamily="34" charset="0"/>
-                <a:ea typeface="Calibri" pitchFamily="34" charset="-122"/>
-                <a:cs typeface="Calibri" pitchFamily="34" charset="-120"/>
-              </a:rPr>
-              <a:t>3</a:t>
-            </a:r>
-            <a:endParaRPr lang="en-US" sz="1400" dirty="0"/>
-          </a:p>
-        </p:txBody>
-      </p:sp>
-      <p:sp>
-        <p:nvSpPr>
-          <p:cNvPr id="28" name="Text 26"/>
+            <a:pPr indent="0" marL="0">
+              <a:buNone/>
+            </a:pPr>
+            <a:r>
+              <a:rPr lang="en-US" sz="1100" b="1" dirty="0">
+                <a:solidFill>
+                  <a:srgbClr val="6B7280"/>
+                </a:solidFill>
+                <a:latin typeface="Calibri" pitchFamily="34" charset="0"/>
+                <a:ea typeface="Calibri" pitchFamily="34" charset="-122"/>
+                <a:cs typeface="Calibri" pitchFamily="34" charset="-120"/>
+              </a:rPr>
+              <a:t>Outbound loads</a:t>
+            </a:r>
+            <a:endParaRPr lang="en-US" sz="1100" dirty="0"/>
+          </a:p>
+        </p:txBody>
+      </p:sp>
+      <p:sp>
+        <p:nvSpPr>
+          <p:cNvPr id="15" name="Text 13"/>
           <p:cNvSpPr txBox="1"/>
           <p:nvPr/>
         </p:nvSpPr>
         <p:spPr>
           <a:xfrm>
-            <a:off x="7054596" y="2011680"/>
-            <a:ext cx="1561338" cy="457200"/>
+            <a:off x="6368796" y="1901952"/>
+            <a:ext cx="2269998" cy="402336"/>
           </a:xfrm>
           <a:prstGeom prst="rect">
             <a:avLst/>
@@ -29014,7 +28856,7 @@
               <a:buNone/>
             </a:pPr>
             <a:r>
-              <a:rPr lang="en-US" sz="1600" b="1" dirty="0">
+              <a:rPr lang="en-US" sz="2400" b="1" dirty="0">
                 <a:solidFill>
                   <a:srgbClr val="111827"/>
                 </a:solidFill>
@@ -29022,22 +28864,22 @@
                 <a:ea typeface="Calibri" pitchFamily="34" charset="-122"/>
                 <a:cs typeface="Calibri" pitchFamily="34" charset="-120"/>
               </a:rPr>
-              <a:t>Sep 13–19</a:t>
-            </a:r>
-            <a:endParaRPr lang="en-US" sz="1600" dirty="0"/>
-          </a:p>
-        </p:txBody>
-      </p:sp>
-      <p:sp>
-        <p:nvSpPr>
-          <p:cNvPr id="29" name="Text 27"/>
+              <a:t>854</a:t>
+            </a:r>
+            <a:endParaRPr lang="en-US" sz="2400" dirty="0"/>
+          </a:p>
+        </p:txBody>
+      </p:sp>
+      <p:sp>
+        <p:nvSpPr>
+          <p:cNvPr id="16" name="Text 14"/>
           <p:cNvSpPr txBox="1"/>
           <p:nvPr/>
         </p:nvSpPr>
         <p:spPr>
           <a:xfrm>
-            <a:off x="6460236" y="2651760"/>
-            <a:ext cx="2109978" cy="274320"/>
+            <a:off x="6368796" y="2304288"/>
+            <a:ext cx="2269998" cy="219456"/>
           </a:xfrm>
           <a:prstGeom prst="rect">
             <a:avLst/>
@@ -29053,7 +28895,7 @@
               <a:buNone/>
             </a:pPr>
             <a:r>
-              <a:rPr lang="en-US" sz="1200" b="1" dirty="0">
+              <a:rPr lang="en-US" sz="1000" dirty="0">
                 <a:solidFill>
                   <a:srgbClr val="6B7280"/>
                 </a:solidFill>
@@ -29061,221 +28903,26 @@
                 <a:ea typeface="Calibri" pitchFamily="34" charset="-122"/>
                 <a:cs typeface="Calibri" pitchFamily="34" charset="-120"/>
               </a:rPr>
-              <a:t>LF score</a:t>
-            </a:r>
-            <a:endParaRPr lang="en-US" sz="1200" dirty="0"/>
-          </a:p>
-        </p:txBody>
-      </p:sp>
-      <p:sp>
-        <p:nvSpPr>
-          <p:cNvPr id="30" name="Text 28"/>
-          <p:cNvSpPr txBox="1"/>
-          <p:nvPr/>
-        </p:nvSpPr>
-        <p:spPr>
-          <a:xfrm>
-            <a:off x="6460236" y="2898648"/>
-            <a:ext cx="2109978" cy="594360"/>
-          </a:xfrm>
-          <a:prstGeom prst="rect">
-            <a:avLst/>
-          </a:prstGeom>
-          <a:noFill/>
-          <a:ln/>
-        </p:spPr>
-        <p:txBody>
-          <a:bodyPr wrap="square" lIns="0" tIns="0" rIns="0" bIns="0" rtlCol="0" anchor="ctr"/>
-          <a:lstStyle/>
-          <a:p>
-            <a:pPr indent="0" marL="0">
-              <a:buNone/>
-            </a:pPr>
-            <a:r>
-              <a:rPr lang="en-US" sz="3200" b="1" dirty="0">
-                <a:solidFill>
-                  <a:srgbClr val="D97706"/>
-                </a:solidFill>
-                <a:latin typeface="Calibri" pitchFamily="34" charset="0"/>
-                <a:ea typeface="Calibri" pitchFamily="34" charset="-122"/>
-                <a:cs typeface="Calibri" pitchFamily="34" charset="-120"/>
-              </a:rPr>
-              <a:t>TBC</a:t>
-            </a:r>
-            <a:endParaRPr lang="en-US" sz="3200" dirty="0"/>
-          </a:p>
-        </p:txBody>
-      </p:sp>
-      <p:sp>
-        <p:nvSpPr>
-          <p:cNvPr id="31" name="Text 29"/>
-          <p:cNvSpPr txBox="1"/>
-          <p:nvPr/>
-        </p:nvSpPr>
-        <p:spPr>
-          <a:xfrm>
-            <a:off x="6460236" y="3493008"/>
-            <a:ext cx="2109978" cy="228600"/>
-          </a:xfrm>
-          <a:prstGeom prst="rect">
-            <a:avLst/>
-          </a:prstGeom>
-          <a:noFill/>
-          <a:ln/>
-        </p:spPr>
-        <p:txBody>
-          <a:bodyPr wrap="square" lIns="0" tIns="0" rIns="0" bIns="0" rtlCol="0" anchor="ctr"/>
-          <a:lstStyle/>
-          <a:p>
-            <a:pPr indent="0" marL="0">
-              <a:buNone/>
-            </a:pPr>
-            <a:r>
-              <a:rPr lang="en-US" sz="1100" dirty="0">
-                <a:solidFill>
-                  <a:srgbClr val="6B7280"/>
-                </a:solidFill>
-                <a:latin typeface="Calibri" pitchFamily="34" charset="0"/>
-                <a:ea typeface="Calibri" pitchFamily="34" charset="-122"/>
-                <a:cs typeface="Calibri" pitchFamily="34" charset="-120"/>
-              </a:rPr>
-              <a:t>Target 80%</a:t>
-            </a:r>
-            <a:endParaRPr lang="en-US" sz="1100" dirty="0"/>
-          </a:p>
-        </p:txBody>
-      </p:sp>
-      <p:sp>
-        <p:nvSpPr>
-          <p:cNvPr id="32" name="Text 30"/>
-          <p:cNvSpPr txBox="1"/>
-          <p:nvPr/>
-        </p:nvSpPr>
-        <p:spPr>
-          <a:xfrm>
-            <a:off x="6460236" y="3886200"/>
-            <a:ext cx="2109978" cy="274320"/>
-          </a:xfrm>
-          <a:prstGeom prst="rect">
-            <a:avLst/>
-          </a:prstGeom>
-          <a:noFill/>
-          <a:ln/>
-        </p:spPr>
-        <p:txBody>
-          <a:bodyPr wrap="square" lIns="0" tIns="0" rIns="0" bIns="0" rtlCol="0" anchor="ctr"/>
-          <a:lstStyle/>
-          <a:p>
-            <a:pPr indent="0" marL="0">
-              <a:buNone/>
-            </a:pPr>
-            <a:r>
-              <a:rPr lang="en-US" sz="1200" b="1" dirty="0">
-                <a:solidFill>
-                  <a:srgbClr val="6B7280"/>
-                </a:solidFill>
-                <a:latin typeface="Calibri" pitchFamily="34" charset="0"/>
-                <a:ea typeface="Calibri" pitchFamily="34" charset="-122"/>
-                <a:cs typeface="Calibri" pitchFamily="34" charset="-120"/>
-              </a:rPr>
-              <a:t>Load %</a:t>
-            </a:r>
-            <a:endParaRPr lang="en-US" sz="1200" dirty="0"/>
-          </a:p>
-        </p:txBody>
-      </p:sp>
-      <p:sp>
-        <p:nvSpPr>
-          <p:cNvPr id="33" name="Text 31"/>
-          <p:cNvSpPr txBox="1"/>
-          <p:nvPr/>
-        </p:nvSpPr>
-        <p:spPr>
-          <a:xfrm>
-            <a:off x="6460236" y="4133088"/>
-            <a:ext cx="2109978" cy="594360"/>
-          </a:xfrm>
-          <a:prstGeom prst="rect">
-            <a:avLst/>
-          </a:prstGeom>
-          <a:noFill/>
-          <a:ln/>
-        </p:spPr>
-        <p:txBody>
-          <a:bodyPr wrap="square" lIns="0" tIns="0" rIns="0" bIns="0" rtlCol="0" anchor="ctr"/>
-          <a:lstStyle/>
-          <a:p>
-            <a:pPr indent="0" marL="0">
-              <a:buNone/>
-            </a:pPr>
-            <a:r>
-              <a:rPr lang="en-US" sz="3200" b="1" dirty="0">
-                <a:solidFill>
-                  <a:srgbClr val="D97706"/>
-                </a:solidFill>
-                <a:latin typeface="Calibri" pitchFamily="34" charset="0"/>
-                <a:ea typeface="Calibri" pitchFamily="34" charset="-122"/>
-                <a:cs typeface="Calibri" pitchFamily="34" charset="-120"/>
-              </a:rPr>
-              <a:t>TBC</a:t>
-            </a:r>
-            <a:endParaRPr lang="en-US" sz="3200" dirty="0"/>
-          </a:p>
-        </p:txBody>
-      </p:sp>
-      <p:sp>
-        <p:nvSpPr>
-          <p:cNvPr id="34" name="Text 32"/>
-          <p:cNvSpPr txBox="1"/>
-          <p:nvPr/>
-        </p:nvSpPr>
-        <p:spPr>
-          <a:xfrm>
-            <a:off x="6460236" y="4727448"/>
-            <a:ext cx="2109978" cy="228600"/>
-          </a:xfrm>
-          <a:prstGeom prst="rect">
-            <a:avLst/>
-          </a:prstGeom>
-          <a:noFill/>
-          <a:ln/>
-        </p:spPr>
-        <p:txBody>
-          <a:bodyPr wrap="square" lIns="0" tIns="0" rIns="0" bIns="0" rtlCol="0" anchor="ctr"/>
-          <a:lstStyle/>
-          <a:p>
-            <a:pPr indent="0" marL="0">
-              <a:buNone/>
-            </a:pPr>
-            <a:r>
-              <a:rPr lang="en-US" sz="1100" dirty="0">
-                <a:solidFill>
-                  <a:srgbClr val="6B7280"/>
-                </a:solidFill>
-                <a:latin typeface="Calibri" pitchFamily="34" charset="0"/>
-                <a:ea typeface="Calibri" pitchFamily="34" charset="-122"/>
-                <a:cs typeface="Calibri" pitchFamily="34" charset="-120"/>
-              </a:rPr>
-              <a:t>Target 98%</a:t>
-            </a:r>
-            <a:endParaRPr lang="en-US" sz="1100" dirty="0"/>
-          </a:p>
-        </p:txBody>
-      </p:sp>
-      <p:sp>
-        <p:nvSpPr>
-          <p:cNvPr id="35" name="Shape 33"/>
+              <a:t>100 loads &gt;100%</a:t>
+            </a:r>
+            <a:endParaRPr lang="en-US" sz="1000" dirty="0"/>
+          </a:p>
+        </p:txBody>
+      </p:sp>
+      <p:sp>
+        <p:nvSpPr>
+          <p:cNvPr id="17" name="Shape 15"/>
           <p:cNvSpPr/>
           <p:nvPr/>
         </p:nvSpPr>
         <p:spPr>
           <a:xfrm>
-            <a:off x="9073134" y="1783080"/>
-            <a:ext cx="2567178" cy="3291840"/>
+            <a:off x="9004554" y="1572768"/>
+            <a:ext cx="2635758" cy="987552"/>
           </a:xfrm>
           <a:prstGeom prst="roundRect">
             <a:avLst>
-              <a:gd name="adj" fmla="val 2850"/>
+              <a:gd name="adj" fmla="val 7407"/>
             </a:avLst>
           </a:prstGeom>
           <a:solidFill>
@@ -29291,39 +28938,14 @@
       </p:sp>
       <p:sp>
         <p:nvSpPr>
-          <p:cNvPr id="36" name="Shape 34"/>
-          <p:cNvSpPr/>
-          <p:nvPr/>
-        </p:nvSpPr>
-        <p:spPr>
-          <a:xfrm>
-            <a:off x="9301734" y="2011680"/>
-            <a:ext cx="457200" cy="457200"/>
-          </a:xfrm>
-          <a:prstGeom prst="ellipse">
-            <a:avLst/>
-          </a:prstGeom>
-          <a:solidFill>
-            <a:srgbClr val="7C3AED"/>
-          </a:solidFill>
-          <a:ln w="12700">
-            <a:solidFill>
-              <a:srgbClr val="7C3AED"/>
-            </a:solidFill>
-            <a:prstDash val="solid"/>
-          </a:ln>
-        </p:spPr>
-      </p:sp>
-      <p:sp>
-        <p:nvSpPr>
-          <p:cNvPr id="37" name="Text 35"/>
+          <p:cNvPr id="18" name="Text 16"/>
           <p:cNvSpPr txBox="1"/>
           <p:nvPr/>
         </p:nvSpPr>
         <p:spPr>
           <a:xfrm>
-            <a:off x="9301734" y="2011680"/>
-            <a:ext cx="457200" cy="457200"/>
+            <a:off x="9187434" y="1664208"/>
+            <a:ext cx="2269998" cy="237744"/>
           </a:xfrm>
           <a:prstGeom prst="rect">
             <a:avLst/>
@@ -29335,34 +28957,34 @@
           <a:bodyPr wrap="square" lIns="0" tIns="0" rIns="0" bIns="0" rtlCol="0" anchor="ctr"/>
           <a:lstStyle/>
           <a:p>
-            <a:pPr algn="ctr" indent="0" marL="0">
-              <a:buNone/>
-            </a:pPr>
-            <a:r>
-              <a:rPr lang="en-US" sz="1400" b="1" dirty="0">
-                <a:solidFill>
-                  <a:srgbClr val="FFFFFF"/>
-                </a:solidFill>
-                <a:latin typeface="Calibri" pitchFamily="34" charset="0"/>
-                <a:ea typeface="Calibri" pitchFamily="34" charset="-122"/>
-                <a:cs typeface="Calibri" pitchFamily="34" charset="-120"/>
-              </a:rPr>
-              <a:t>4</a:t>
-            </a:r>
-            <a:endParaRPr lang="en-US" sz="1400" dirty="0"/>
-          </a:p>
-        </p:txBody>
-      </p:sp>
-      <p:sp>
-        <p:nvSpPr>
-          <p:cNvPr id="38" name="Text 36"/>
+            <a:pPr indent="0" marL="0">
+              <a:buNone/>
+            </a:pPr>
+            <a:r>
+              <a:rPr lang="en-US" sz="1100" b="1" dirty="0">
+                <a:solidFill>
+                  <a:srgbClr val="6B7280"/>
+                </a:solidFill>
+                <a:latin typeface="Calibri" pitchFamily="34" charset="0"/>
+                <a:ea typeface="Calibri" pitchFamily="34" charset="-122"/>
+                <a:cs typeface="Calibri" pitchFamily="34" charset="-120"/>
+              </a:rPr>
+              <a:t>Bills with no cube</a:t>
+            </a:r>
+            <a:endParaRPr lang="en-US" sz="1100" dirty="0"/>
+          </a:p>
+        </p:txBody>
+      </p:sp>
+      <p:sp>
+        <p:nvSpPr>
+          <p:cNvPr id="19" name="Text 17"/>
           <p:cNvSpPr txBox="1"/>
           <p:nvPr/>
         </p:nvSpPr>
         <p:spPr>
           <a:xfrm>
-            <a:off x="9896094" y="2011680"/>
-            <a:ext cx="1561338" cy="457200"/>
+            <a:off x="9187434" y="1901952"/>
+            <a:ext cx="2269998" cy="402336"/>
           </a:xfrm>
           <a:prstGeom prst="rect">
             <a:avLst/>
@@ -29378,7 +29000,7 @@
               <a:buNone/>
             </a:pPr>
             <a:r>
-              <a:rPr lang="en-US" sz="1600" b="1" dirty="0">
+              <a:rPr lang="en-US" sz="2400" b="1" dirty="0">
                 <a:solidFill>
                   <a:srgbClr val="111827"/>
                 </a:solidFill>
@@ -29386,22 +29008,22 @@
                 <a:ea typeface="Calibri" pitchFamily="34" charset="-122"/>
                 <a:cs typeface="Calibri" pitchFamily="34" charset="-120"/>
               </a:rPr>
-              <a:t>Sep 20–26</a:t>
-            </a:r>
-            <a:endParaRPr lang="en-US" sz="1600" dirty="0"/>
-          </a:p>
-        </p:txBody>
-      </p:sp>
-      <p:sp>
-        <p:nvSpPr>
-          <p:cNvPr id="39" name="Text 37"/>
+              <a:t>3,166</a:t>
+            </a:r>
+            <a:endParaRPr lang="en-US" sz="2400" dirty="0"/>
+          </a:p>
+        </p:txBody>
+      </p:sp>
+      <p:sp>
+        <p:nvSpPr>
+          <p:cNvPr id="20" name="Text 18"/>
           <p:cNvSpPr txBox="1"/>
           <p:nvPr/>
         </p:nvSpPr>
         <p:spPr>
           <a:xfrm>
-            <a:off x="9301734" y="2651760"/>
-            <a:ext cx="2109978" cy="274320"/>
+            <a:off x="9187434" y="2304288"/>
+            <a:ext cx="2269998" cy="219456"/>
           </a:xfrm>
           <a:prstGeom prst="rect">
             <a:avLst/>
@@ -29417,7 +29039,7 @@
               <a:buNone/>
             </a:pPr>
             <a:r>
-              <a:rPr lang="en-US" sz="1200" b="1" dirty="0">
+              <a:rPr lang="en-US" sz="1000" dirty="0">
                 <a:solidFill>
                   <a:srgbClr val="6B7280"/>
                 </a:solidFill>
@@ -29425,22 +29047,38 @@
                 <a:ea typeface="Calibri" pitchFamily="34" charset="-122"/>
                 <a:cs typeface="Calibri" pitchFamily="34" charset="-120"/>
               </a:rPr>
-              <a:t>LF score</a:t>
-            </a:r>
-            <a:endParaRPr lang="en-US" sz="1200" dirty="0"/>
-          </a:p>
-        </p:txBody>
-      </p:sp>
-      <p:sp>
-        <p:nvSpPr>
-          <p:cNvPr id="40" name="Text 38"/>
+              <a:t>5.7% of 55,862 bills</a:t>
+            </a:r>
+            <a:endParaRPr lang="en-US" sz="1000" dirty="0"/>
+          </a:p>
+        </p:txBody>
+      </p:sp>
+      <p:graphicFrame>
+        <p:nvGraphicFramePr>
+          <p:cNvPr id="21" name="Chart 0" descr=""/>
+          <p:cNvGraphicFramePr/>
+          <p:nvPr/>
+        </p:nvGraphicFramePr>
+        <p:xfrm>
+          <a:off x="548640" y="2697480"/>
+          <a:ext cx="4297680" cy="2240280"/>
+        </p:xfrm>
+        <a:graphic xmlns:a="http://schemas.openxmlformats.org/drawingml/2006/main">
+          <a:graphicData uri="http://schemas.openxmlformats.org/drawingml/2006/chart">
+            <c:chart xmlns:c="http://schemas.openxmlformats.org/drawingml/2006/chart" r:id="rId1"/>
+          </a:graphicData>
+        </a:graphic>
+      </p:graphicFrame>
+      <p:sp>
+        <p:nvSpPr>
+          <p:cNvPr id="22" name="Text 19"/>
           <p:cNvSpPr txBox="1"/>
           <p:nvPr/>
         </p:nvSpPr>
         <p:spPr>
           <a:xfrm>
-            <a:off x="9301734" y="2898648"/>
-            <a:ext cx="2109978" cy="594360"/>
+            <a:off x="548640" y="4956048"/>
+            <a:ext cx="4297680" cy="237744"/>
           </a:xfrm>
           <a:prstGeom prst="rect">
             <a:avLst/>
@@ -29452,34 +29090,2258 @@
           <a:bodyPr wrap="square" lIns="0" tIns="0" rIns="0" bIns="0" rtlCol="0" anchor="ctr"/>
           <a:lstStyle/>
           <a:p>
-            <a:pPr indent="0" marL="0">
-              <a:buNone/>
-            </a:pPr>
-            <a:r>
-              <a:rPr lang="en-US" sz="3200" b="1" dirty="0">
-                <a:solidFill>
-                  <a:srgbClr val="D97706"/>
-                </a:solidFill>
-                <a:latin typeface="Calibri" pitchFamily="34" charset="0"/>
-                <a:ea typeface="Calibri" pitchFamily="34" charset="-122"/>
-                <a:cs typeface="Calibri" pitchFamily="34" charset="-120"/>
-              </a:rPr>
-              <a:t>TBC</a:t>
-            </a:r>
-            <a:endParaRPr lang="en-US" sz="3200" dirty="0"/>
-          </a:p>
-        </p:txBody>
-      </p:sp>
-      <p:sp>
-        <p:nvSpPr>
-          <p:cNvPr id="41" name="Text 39"/>
+            <a:pPr algn="ctr" indent="0" marL="0">
+              <a:buNone/>
+            </a:pPr>
+            <a:r>
+              <a:rPr lang="en-US" sz="950" dirty="0">
+                <a:solidFill>
+                  <a:srgbClr val="6B7280"/>
+                </a:solidFill>
+                <a:latin typeface="Calibri" pitchFamily="34" charset="0"/>
+                <a:ea typeface="Calibri" pitchFamily="34" charset="-122"/>
+                <a:cs typeface="Calibri" pitchFamily="34" charset="-120"/>
+              </a:rPr>
+              <a:t>LF buckets (loads): ≤60% 237 · 61–79% 306 · 80–90% 150 · ≥91% 161</a:t>
+            </a:r>
+            <a:endParaRPr lang="en-US" sz="950" dirty="0"/>
+          </a:p>
+        </p:txBody>
+      </p:sp>
+      <p:graphicFrame>
+        <p:nvGraphicFramePr>
+          <p:cNvPr id="20" name="Table 0"/>
+          <p:cNvGraphicFramePr>
+            <a:graphicFrameLocks noGrp="1"/>
+          </p:cNvGraphicFramePr>
+          <p:nvPr>
+            <p:extLst>
+              <p:ext uri="{D42A27DB-BD31-4B8C-83A1-F6EECF244321}">
+                <p14:modId xmlns:p14="http://schemas.microsoft.com/office/powerpoint/2010/main" val="1579011935"/>
+              </p:ext>
+            </p:extLst>
+          </p:nvPr>
+        </p:nvGraphicFramePr>
+        <p:xfrm>
+          <a:off x="5074920" y="2697480"/>
+          <a:ext cx="6565392" cy="914400"/>
+        </p:xfrm>
+        <a:graphic>
+          <a:graphicData uri="http://schemas.openxmlformats.org/drawingml/2006/table">
+            <a:tbl>
+              <a:tblPr/>
+              <a:tblGrid>
+                <a:gridCol w="2176272"/>
+                <a:gridCol w="1463040"/>
+                <a:gridCol w="1463040"/>
+                <a:gridCol w="1463040"/>
+              </a:tblGrid>
+              <a:tr h="274320">
+                <a:tc>
+                  <a:txBody>
+                    <a:bodyPr/>
+                    <a:lstStyle/>
+                    <a:p>
+                      <a:pPr indent="0" marL="0">
+                        <a:buNone/>
+                      </a:pPr>
+                      <a:r>
+                        <a:rPr lang="en-US" sz="1050" b="1" dirty="0">
+                          <a:solidFill>
+                            <a:srgbClr val="FFFFFF"/>
+                          </a:solidFill>
+                          <a:latin typeface="Calibri" pitchFamily="34" charset="0"/>
+                          <a:ea typeface="Calibri" pitchFamily="34" charset="-122"/>
+                          <a:cs typeface="Calibri" pitchFamily="34" charset="-120"/>
+                        </a:rPr>
+                        <a:t>Lane · LF score / load %</a:t>
+                      </a:r>
+                      <a:endParaRPr lang="en-US" sz="1050" dirty="0">
+                        <a:latin typeface="Calibri" charset="0"/>
+                        <a:ea typeface="Calibri" charset="0"/>
+                        <a:cs typeface="Calibri" charset="0"/>
+                      </a:endParaRPr>
+                    </a:p>
+                  </a:txBody>
+                  <a:tcPr marL="91440" marR="91440" marT="36576" marB="36576" anchor="ctr">
+                    <a:lnL w="9525" cap="flat" cmpd="sng" algn="ctr">
+                      <a:solidFill>
+                        <a:srgbClr val="E5E7EB"/>
+                      </a:solidFill>
+                      <a:prstDash val="solid"/>
+                      <a:round/>
+                      <a:headEnd type="none" w="med" len="med"/>
+                      <a:tailEnd type="none" w="med" len="med"/>
+                    </a:lnL>
+                    <a:lnR w="9525" cap="flat" cmpd="sng" algn="ctr">
+                      <a:solidFill>
+                        <a:srgbClr val="E5E7EB"/>
+                      </a:solidFill>
+                      <a:prstDash val="solid"/>
+                      <a:round/>
+                      <a:headEnd type="none" w="med" len="med"/>
+                      <a:tailEnd type="none" w="med" len="med"/>
+                    </a:lnR>
+                    <a:lnT w="9525" cap="flat" cmpd="sng" algn="ctr">
+                      <a:solidFill>
+                        <a:srgbClr val="E5E7EB"/>
+                      </a:solidFill>
+                      <a:prstDash val="solid"/>
+                      <a:round/>
+                      <a:headEnd type="none" w="med" len="med"/>
+                      <a:tailEnd type="none" w="med" len="med"/>
+                    </a:lnT>
+                    <a:lnB w="9525" cap="flat" cmpd="sng" algn="ctr">
+                      <a:solidFill>
+                        <a:srgbClr val="E5E7EB"/>
+                      </a:solidFill>
+                      <a:prstDash val="solid"/>
+                      <a:round/>
+                      <a:headEnd type="none" w="med" len="med"/>
+                      <a:tailEnd type="none" w="med" len="med"/>
+                    </a:lnB>
+                    <a:solidFill>
+                      <a:srgbClr val="1F2937"/>
+                    </a:solidFill>
+                  </a:tcPr>
+                </a:tc>
+                <a:tc>
+                  <a:txBody>
+                    <a:bodyPr/>
+                    <a:lstStyle/>
+                    <a:p>
+                      <a:pPr algn="r" indent="0" marL="0">
+                        <a:buNone/>
+                      </a:pPr>
+                      <a:r>
+                        <a:rPr lang="en-US" sz="1050" b="1" dirty="0">
+                          <a:solidFill>
+                            <a:srgbClr val="FFFFFF"/>
+                          </a:solidFill>
+                          <a:latin typeface="Calibri" pitchFamily="34" charset="0"/>
+                          <a:ea typeface="Calibri" pitchFamily="34" charset="-122"/>
+                          <a:cs typeface="Calibri" pitchFamily="34" charset="-120"/>
+                        </a:rPr>
+                        <a:t>Jul</a:t>
+                      </a:r>
+                      <a:endParaRPr lang="en-US" sz="1050" dirty="0">
+                        <a:latin typeface="Calibri" charset="0"/>
+                        <a:ea typeface="Calibri" charset="0"/>
+                        <a:cs typeface="Calibri" charset="0"/>
+                      </a:endParaRPr>
+                    </a:p>
+                  </a:txBody>
+                  <a:tcPr marL="91440" marR="91440" marT="36576" marB="36576" anchor="ctr">
+                    <a:lnL w="9525" cap="flat" cmpd="sng" algn="ctr">
+                      <a:solidFill>
+                        <a:srgbClr val="E5E7EB"/>
+                      </a:solidFill>
+                      <a:prstDash val="solid"/>
+                      <a:round/>
+                      <a:headEnd type="none" w="med" len="med"/>
+                      <a:tailEnd type="none" w="med" len="med"/>
+                    </a:lnL>
+                    <a:lnR w="9525" cap="flat" cmpd="sng" algn="ctr">
+                      <a:solidFill>
+                        <a:srgbClr val="E5E7EB"/>
+                      </a:solidFill>
+                      <a:prstDash val="solid"/>
+                      <a:round/>
+                      <a:headEnd type="none" w="med" len="med"/>
+                      <a:tailEnd type="none" w="med" len="med"/>
+                    </a:lnR>
+                    <a:lnT w="9525" cap="flat" cmpd="sng" algn="ctr">
+                      <a:solidFill>
+                        <a:srgbClr val="E5E7EB"/>
+                      </a:solidFill>
+                      <a:prstDash val="solid"/>
+                      <a:round/>
+                      <a:headEnd type="none" w="med" len="med"/>
+                      <a:tailEnd type="none" w="med" len="med"/>
+                    </a:lnT>
+                    <a:lnB w="9525" cap="flat" cmpd="sng" algn="ctr">
+                      <a:solidFill>
+                        <a:srgbClr val="E5E7EB"/>
+                      </a:solidFill>
+                      <a:prstDash val="solid"/>
+                      <a:round/>
+                      <a:headEnd type="none" w="med" len="med"/>
+                      <a:tailEnd type="none" w="med" len="med"/>
+                    </a:lnB>
+                    <a:solidFill>
+                      <a:srgbClr val="1F2937"/>
+                    </a:solidFill>
+                  </a:tcPr>
+                </a:tc>
+                <a:tc>
+                  <a:txBody>
+                    <a:bodyPr/>
+                    <a:lstStyle/>
+                    <a:p>
+                      <a:pPr algn="r" indent="0" marL="0">
+                        <a:buNone/>
+                      </a:pPr>
+                      <a:r>
+                        <a:rPr lang="en-US" sz="1050" b="1" dirty="0">
+                          <a:solidFill>
+                            <a:srgbClr val="FFFFFF"/>
+                          </a:solidFill>
+                          <a:latin typeface="Calibri" pitchFamily="34" charset="0"/>
+                          <a:ea typeface="Calibri" pitchFamily="34" charset="-122"/>
+                          <a:cs typeface="Calibri" pitchFamily="34" charset="-120"/>
+                        </a:rPr>
+                        <a:t>Aug</a:t>
+                      </a:r>
+                      <a:endParaRPr lang="en-US" sz="1050" dirty="0">
+                        <a:latin typeface="Calibri" charset="0"/>
+                        <a:ea typeface="Calibri" charset="0"/>
+                        <a:cs typeface="Calibri" charset="0"/>
+                      </a:endParaRPr>
+                    </a:p>
+                  </a:txBody>
+                  <a:tcPr marL="91440" marR="91440" marT="36576" marB="36576" anchor="ctr">
+                    <a:lnL w="9525" cap="flat" cmpd="sng" algn="ctr">
+                      <a:solidFill>
+                        <a:srgbClr val="E5E7EB"/>
+                      </a:solidFill>
+                      <a:prstDash val="solid"/>
+                      <a:round/>
+                      <a:headEnd type="none" w="med" len="med"/>
+                      <a:tailEnd type="none" w="med" len="med"/>
+                    </a:lnL>
+                    <a:lnR w="9525" cap="flat" cmpd="sng" algn="ctr">
+                      <a:solidFill>
+                        <a:srgbClr val="E5E7EB"/>
+                      </a:solidFill>
+                      <a:prstDash val="solid"/>
+                      <a:round/>
+                      <a:headEnd type="none" w="med" len="med"/>
+                      <a:tailEnd type="none" w="med" len="med"/>
+                    </a:lnR>
+                    <a:lnT w="9525" cap="flat" cmpd="sng" algn="ctr">
+                      <a:solidFill>
+                        <a:srgbClr val="E5E7EB"/>
+                      </a:solidFill>
+                      <a:prstDash val="solid"/>
+                      <a:round/>
+                      <a:headEnd type="none" w="med" len="med"/>
+                      <a:tailEnd type="none" w="med" len="med"/>
+                    </a:lnT>
+                    <a:lnB w="9525" cap="flat" cmpd="sng" algn="ctr">
+                      <a:solidFill>
+                        <a:srgbClr val="E5E7EB"/>
+                      </a:solidFill>
+                      <a:prstDash val="solid"/>
+                      <a:round/>
+                      <a:headEnd type="none" w="med" len="med"/>
+                      <a:tailEnd type="none" w="med" len="med"/>
+                    </a:lnB>
+                    <a:solidFill>
+                      <a:srgbClr val="1F2937"/>
+                    </a:solidFill>
+                  </a:tcPr>
+                </a:tc>
+                <a:tc>
+                  <a:txBody>
+                    <a:bodyPr/>
+                    <a:lstStyle/>
+                    <a:p>
+                      <a:pPr algn="r" indent="0" marL="0">
+                        <a:buNone/>
+                      </a:pPr>
+                      <a:r>
+                        <a:rPr lang="en-US" sz="1050" b="1" dirty="0">
+                          <a:solidFill>
+                            <a:srgbClr val="FFFFFF"/>
+                          </a:solidFill>
+                          <a:latin typeface="Calibri" pitchFamily="34" charset="0"/>
+                          <a:ea typeface="Calibri" pitchFamily="34" charset="-122"/>
+                          <a:cs typeface="Calibri" pitchFamily="34" charset="-120"/>
+                        </a:rPr>
+                        <a:t>Sep</a:t>
+                      </a:r>
+                      <a:endParaRPr lang="en-US" sz="1050" dirty="0">
+                        <a:latin typeface="Calibri" charset="0"/>
+                        <a:ea typeface="Calibri" charset="0"/>
+                        <a:cs typeface="Calibri" charset="0"/>
+                      </a:endParaRPr>
+                    </a:p>
+                  </a:txBody>
+                  <a:tcPr marL="91440" marR="91440" marT="36576" marB="36576" anchor="ctr">
+                    <a:lnL w="9525" cap="flat" cmpd="sng" algn="ctr">
+                      <a:solidFill>
+                        <a:srgbClr val="E5E7EB"/>
+                      </a:solidFill>
+                      <a:prstDash val="solid"/>
+                      <a:round/>
+                      <a:headEnd type="none" w="med" len="med"/>
+                      <a:tailEnd type="none" w="med" len="med"/>
+                    </a:lnL>
+                    <a:lnR w="9525" cap="flat" cmpd="sng" algn="ctr">
+                      <a:solidFill>
+                        <a:srgbClr val="E5E7EB"/>
+                      </a:solidFill>
+                      <a:prstDash val="solid"/>
+                      <a:round/>
+                      <a:headEnd type="none" w="med" len="med"/>
+                      <a:tailEnd type="none" w="med" len="med"/>
+                    </a:lnR>
+                    <a:lnT w="9525" cap="flat" cmpd="sng" algn="ctr">
+                      <a:solidFill>
+                        <a:srgbClr val="E5E7EB"/>
+                      </a:solidFill>
+                      <a:prstDash val="solid"/>
+                      <a:round/>
+                      <a:headEnd type="none" w="med" len="med"/>
+                      <a:tailEnd type="none" w="med" len="med"/>
+                    </a:lnT>
+                    <a:lnB w="9525" cap="flat" cmpd="sng" algn="ctr">
+                      <a:solidFill>
+                        <a:srgbClr val="E5E7EB"/>
+                      </a:solidFill>
+                      <a:prstDash val="solid"/>
+                      <a:round/>
+                      <a:headEnd type="none" w="med" len="med"/>
+                      <a:tailEnd type="none" w="med" len="med"/>
+                    </a:lnB>
+                    <a:solidFill>
+                      <a:srgbClr val="1F2937"/>
+                    </a:solidFill>
+                  </a:tcPr>
+                </a:tc>
+              </a:tr>
+              <a:tr h="274320">
+                <a:tc>
+                  <a:txBody>
+                    <a:bodyPr/>
+                    <a:lstStyle/>
+                    <a:p>
+                      <a:pPr indent="0" marL="0">
+                        <a:buNone/>
+                      </a:pPr>
+                      <a:r>
+                        <a:rPr lang="en-US" sz="1050" b="1" dirty="0">
+                          <a:solidFill>
+                            <a:srgbClr val="111827"/>
+                          </a:solidFill>
+                          <a:latin typeface="Calibri" pitchFamily="34" charset="0"/>
+                          <a:ea typeface="Calibri" pitchFamily="34" charset="-122"/>
+                          <a:cs typeface="Calibri" pitchFamily="34" charset="-120"/>
+                        </a:rPr>
+                        <a:t>Burnaby</a:t>
+                      </a:r>
+                      <a:endParaRPr lang="en-US" sz="1050" dirty="0">
+                        <a:latin typeface="Calibri" charset="0"/>
+                        <a:ea typeface="Calibri" charset="0"/>
+                        <a:cs typeface="Calibri" charset="0"/>
+                      </a:endParaRPr>
+                    </a:p>
+                  </a:txBody>
+                  <a:tcPr marL="91440" marR="91440" marT="36576" marB="36576" anchor="ctr">
+                    <a:lnL w="9525" cap="flat" cmpd="sng" algn="ctr">
+                      <a:solidFill>
+                        <a:srgbClr val="E5E7EB"/>
+                      </a:solidFill>
+                      <a:prstDash val="solid"/>
+                      <a:round/>
+                      <a:headEnd type="none" w="med" len="med"/>
+                      <a:tailEnd type="none" w="med" len="med"/>
+                    </a:lnL>
+                    <a:lnR w="9525" cap="flat" cmpd="sng" algn="ctr">
+                      <a:solidFill>
+                        <a:srgbClr val="E5E7EB"/>
+                      </a:solidFill>
+                      <a:prstDash val="solid"/>
+                      <a:round/>
+                      <a:headEnd type="none" w="med" len="med"/>
+                      <a:tailEnd type="none" w="med" len="med"/>
+                    </a:lnR>
+                    <a:lnT w="9525" cap="flat" cmpd="sng" algn="ctr">
+                      <a:solidFill>
+                        <a:srgbClr val="E5E7EB"/>
+                      </a:solidFill>
+                      <a:prstDash val="solid"/>
+                      <a:round/>
+                      <a:headEnd type="none" w="med" len="med"/>
+                      <a:tailEnd type="none" w="med" len="med"/>
+                    </a:lnT>
+                    <a:lnB w="9525" cap="flat" cmpd="sng" algn="ctr">
+                      <a:solidFill>
+                        <a:srgbClr val="E5E7EB"/>
+                      </a:solidFill>
+                      <a:prstDash val="solid"/>
+                      <a:round/>
+                      <a:headEnd type="none" w="med" len="med"/>
+                      <a:tailEnd type="none" w="med" len="med"/>
+                    </a:lnB>
+                    <a:solidFill>
+                      <a:srgbClr val="ECFDF5"/>
+                    </a:solidFill>
+                  </a:tcPr>
+                </a:tc>
+                <a:tc>
+                  <a:txBody>
+                    <a:bodyPr/>
+                    <a:lstStyle/>
+                    <a:p>
+                      <a:pPr algn="r" indent="0" marL="0">
+                        <a:buNone/>
+                      </a:pPr>
+                      <a:r>
+                        <a:rPr lang="en-US" sz="1050" dirty="0">
+                          <a:solidFill>
+                            <a:srgbClr val="111827"/>
+                          </a:solidFill>
+                          <a:latin typeface="Calibri" pitchFamily="34" charset="0"/>
+                          <a:ea typeface="Calibri" pitchFamily="34" charset="-122"/>
+                          <a:cs typeface="Calibri" pitchFamily="34" charset="-120"/>
+                        </a:rPr>
+                        <a:t>69.6 / 91.4</a:t>
+                      </a:r>
+                      <a:endParaRPr lang="en-US" sz="1050" dirty="0">
+                        <a:latin typeface="Calibri" charset="0"/>
+                        <a:ea typeface="Calibri" charset="0"/>
+                        <a:cs typeface="Calibri" charset="0"/>
+                      </a:endParaRPr>
+                    </a:p>
+                  </a:txBody>
+                  <a:tcPr marL="91440" marR="91440" marT="36576" marB="36576" anchor="ctr">
+                    <a:lnL w="9525" cap="flat" cmpd="sng" algn="ctr">
+                      <a:solidFill>
+                        <a:srgbClr val="E5E7EB"/>
+                      </a:solidFill>
+                      <a:prstDash val="solid"/>
+                      <a:round/>
+                      <a:headEnd type="none" w="med" len="med"/>
+                      <a:tailEnd type="none" w="med" len="med"/>
+                    </a:lnL>
+                    <a:lnR w="9525" cap="flat" cmpd="sng" algn="ctr">
+                      <a:solidFill>
+                        <a:srgbClr val="E5E7EB"/>
+                      </a:solidFill>
+                      <a:prstDash val="solid"/>
+                      <a:round/>
+                      <a:headEnd type="none" w="med" len="med"/>
+                      <a:tailEnd type="none" w="med" len="med"/>
+                    </a:lnR>
+                    <a:lnT w="9525" cap="flat" cmpd="sng" algn="ctr">
+                      <a:solidFill>
+                        <a:srgbClr val="E5E7EB"/>
+                      </a:solidFill>
+                      <a:prstDash val="solid"/>
+                      <a:round/>
+                      <a:headEnd type="none" w="med" len="med"/>
+                      <a:tailEnd type="none" w="med" len="med"/>
+                    </a:lnT>
+                    <a:lnB w="9525" cap="flat" cmpd="sng" algn="ctr">
+                      <a:solidFill>
+                        <a:srgbClr val="E5E7EB"/>
+                      </a:solidFill>
+                      <a:prstDash val="solid"/>
+                      <a:round/>
+                      <a:headEnd type="none" w="med" len="med"/>
+                      <a:tailEnd type="none" w="med" len="med"/>
+                    </a:lnB>
+                    <a:solidFill>
+                      <a:srgbClr val="ECFDF5"/>
+                    </a:solidFill>
+                  </a:tcPr>
+                </a:tc>
+                <a:tc>
+                  <a:txBody>
+                    <a:bodyPr/>
+                    <a:lstStyle/>
+                    <a:p>
+                      <a:pPr algn="r" indent="0" marL="0">
+                        <a:buNone/>
+                      </a:pPr>
+                      <a:r>
+                        <a:rPr lang="en-US" sz="1050" dirty="0">
+                          <a:solidFill>
+                            <a:srgbClr val="111827"/>
+                          </a:solidFill>
+                          <a:latin typeface="Calibri" pitchFamily="34" charset="0"/>
+                          <a:ea typeface="Calibri" pitchFamily="34" charset="-122"/>
+                          <a:cs typeface="Calibri" pitchFamily="34" charset="-120"/>
+                        </a:rPr>
+                        <a:t>81.8 / 93.8</a:t>
+                      </a:r>
+                      <a:endParaRPr lang="en-US" sz="1050" dirty="0">
+                        <a:latin typeface="Calibri" charset="0"/>
+                        <a:ea typeface="Calibri" charset="0"/>
+                        <a:cs typeface="Calibri" charset="0"/>
+                      </a:endParaRPr>
+                    </a:p>
+                  </a:txBody>
+                  <a:tcPr marL="91440" marR="91440" marT="36576" marB="36576" anchor="ctr">
+                    <a:lnL w="9525" cap="flat" cmpd="sng" algn="ctr">
+                      <a:solidFill>
+                        <a:srgbClr val="E5E7EB"/>
+                      </a:solidFill>
+                      <a:prstDash val="solid"/>
+                      <a:round/>
+                      <a:headEnd type="none" w="med" len="med"/>
+                      <a:tailEnd type="none" w="med" len="med"/>
+                    </a:lnL>
+                    <a:lnR w="9525" cap="flat" cmpd="sng" algn="ctr">
+                      <a:solidFill>
+                        <a:srgbClr val="E5E7EB"/>
+                      </a:solidFill>
+                      <a:prstDash val="solid"/>
+                      <a:round/>
+                      <a:headEnd type="none" w="med" len="med"/>
+                      <a:tailEnd type="none" w="med" len="med"/>
+                    </a:lnR>
+                    <a:lnT w="9525" cap="flat" cmpd="sng" algn="ctr">
+                      <a:solidFill>
+                        <a:srgbClr val="E5E7EB"/>
+                      </a:solidFill>
+                      <a:prstDash val="solid"/>
+                      <a:round/>
+                      <a:headEnd type="none" w="med" len="med"/>
+                      <a:tailEnd type="none" w="med" len="med"/>
+                    </a:lnT>
+                    <a:lnB w="9525" cap="flat" cmpd="sng" algn="ctr">
+                      <a:solidFill>
+                        <a:srgbClr val="E5E7EB"/>
+                      </a:solidFill>
+                      <a:prstDash val="solid"/>
+                      <a:round/>
+                      <a:headEnd type="none" w="med" len="med"/>
+                      <a:tailEnd type="none" w="med" len="med"/>
+                    </a:lnB>
+                    <a:solidFill>
+                      <a:srgbClr val="ECFDF5"/>
+                    </a:solidFill>
+                  </a:tcPr>
+                </a:tc>
+                <a:tc>
+                  <a:txBody>
+                    <a:bodyPr/>
+                    <a:lstStyle/>
+                    <a:p>
+                      <a:pPr algn="r" indent="0" marL="0">
+                        <a:buNone/>
+                      </a:pPr>
+                      <a:r>
+                        <a:rPr lang="en-US" sz="1050" b="1" dirty="0">
+                          <a:solidFill>
+                            <a:srgbClr val="111827"/>
+                          </a:solidFill>
+                          <a:latin typeface="Calibri" pitchFamily="34" charset="0"/>
+                          <a:ea typeface="Calibri" pitchFamily="34" charset="-122"/>
+                          <a:cs typeface="Calibri" pitchFamily="34" charset="-120"/>
+                        </a:rPr>
+                        <a:t>89.5 / 95.6</a:t>
+                      </a:r>
+                      <a:endParaRPr lang="en-US" sz="1050" dirty="0">
+                        <a:latin typeface="Calibri" charset="0"/>
+                        <a:ea typeface="Calibri" charset="0"/>
+                        <a:cs typeface="Calibri" charset="0"/>
+                      </a:endParaRPr>
+                    </a:p>
+                  </a:txBody>
+                  <a:tcPr marL="91440" marR="91440" marT="36576" marB="36576" anchor="ctr">
+                    <a:lnL w="9525" cap="flat" cmpd="sng" algn="ctr">
+                      <a:solidFill>
+                        <a:srgbClr val="E5E7EB"/>
+                      </a:solidFill>
+                      <a:prstDash val="solid"/>
+                      <a:round/>
+                      <a:headEnd type="none" w="med" len="med"/>
+                      <a:tailEnd type="none" w="med" len="med"/>
+                    </a:lnL>
+                    <a:lnR w="9525" cap="flat" cmpd="sng" algn="ctr">
+                      <a:solidFill>
+                        <a:srgbClr val="E5E7EB"/>
+                      </a:solidFill>
+                      <a:prstDash val="solid"/>
+                      <a:round/>
+                      <a:headEnd type="none" w="med" len="med"/>
+                      <a:tailEnd type="none" w="med" len="med"/>
+                    </a:lnR>
+                    <a:lnT w="9525" cap="flat" cmpd="sng" algn="ctr">
+                      <a:solidFill>
+                        <a:srgbClr val="E5E7EB"/>
+                      </a:solidFill>
+                      <a:prstDash val="solid"/>
+                      <a:round/>
+                      <a:headEnd type="none" w="med" len="med"/>
+                      <a:tailEnd type="none" w="med" len="med"/>
+                    </a:lnT>
+                    <a:lnB w="9525" cap="flat" cmpd="sng" algn="ctr">
+                      <a:solidFill>
+                        <a:srgbClr val="E5E7EB"/>
+                      </a:solidFill>
+                      <a:prstDash val="solid"/>
+                      <a:round/>
+                      <a:headEnd type="none" w="med" len="med"/>
+                      <a:tailEnd type="none" w="med" len="med"/>
+                    </a:lnB>
+                    <a:solidFill>
+                      <a:srgbClr val="ECFDF5"/>
+                    </a:solidFill>
+                  </a:tcPr>
+                </a:tc>
+              </a:tr>
+              <a:tr h="274320">
+                <a:tc>
+                  <a:txBody>
+                    <a:bodyPr/>
+                    <a:lstStyle/>
+                    <a:p>
+                      <a:pPr indent="0" marL="0">
+                        <a:buNone/>
+                      </a:pPr>
+                      <a:r>
+                        <a:rPr lang="en-US" sz="1050" b="1" dirty="0">
+                          <a:solidFill>
+                            <a:srgbClr val="111827"/>
+                          </a:solidFill>
+                          <a:latin typeface="Calibri" pitchFamily="34" charset="0"/>
+                          <a:ea typeface="Calibri" pitchFamily="34" charset="-122"/>
+                          <a:cs typeface="Calibri" pitchFamily="34" charset="-120"/>
+                        </a:rPr>
+                        <a:t>Winnipeg</a:t>
+                      </a:r>
+                      <a:endParaRPr lang="en-US" sz="1050" dirty="0">
+                        <a:latin typeface="Calibri" charset="0"/>
+                        <a:ea typeface="Calibri" charset="0"/>
+                        <a:cs typeface="Calibri" charset="0"/>
+                      </a:endParaRPr>
+                    </a:p>
+                  </a:txBody>
+                  <a:tcPr marL="91440" marR="91440" marT="36576" marB="36576" anchor="ctr">
+                    <a:lnL w="9525" cap="flat" cmpd="sng" algn="ctr">
+                      <a:solidFill>
+                        <a:srgbClr val="E5E7EB"/>
+                      </a:solidFill>
+                      <a:prstDash val="solid"/>
+                      <a:round/>
+                      <a:headEnd type="none" w="med" len="med"/>
+                      <a:tailEnd type="none" w="med" len="med"/>
+                    </a:lnL>
+                    <a:lnR w="9525" cap="flat" cmpd="sng" algn="ctr">
+                      <a:solidFill>
+                        <a:srgbClr val="E5E7EB"/>
+                      </a:solidFill>
+                      <a:prstDash val="solid"/>
+                      <a:round/>
+                      <a:headEnd type="none" w="med" len="med"/>
+                      <a:tailEnd type="none" w="med" len="med"/>
+                    </a:lnR>
+                    <a:lnT w="9525" cap="flat" cmpd="sng" algn="ctr">
+                      <a:solidFill>
+                        <a:srgbClr val="E5E7EB"/>
+                      </a:solidFill>
+                      <a:prstDash val="solid"/>
+                      <a:round/>
+                      <a:headEnd type="none" w="med" len="med"/>
+                      <a:tailEnd type="none" w="med" len="med"/>
+                    </a:lnT>
+                    <a:lnB w="9525" cap="flat" cmpd="sng" algn="ctr">
+                      <a:solidFill>
+                        <a:srgbClr val="E5E7EB"/>
+                      </a:solidFill>
+                      <a:prstDash val="solid"/>
+                      <a:round/>
+                      <a:headEnd type="none" w="med" len="med"/>
+                      <a:tailEnd type="none" w="med" len="med"/>
+                    </a:lnB>
+                    <a:solidFill>
+                      <a:srgbClr val="ECFDF5"/>
+                    </a:solidFill>
+                  </a:tcPr>
+                </a:tc>
+                <a:tc>
+                  <a:txBody>
+                    <a:bodyPr/>
+                    <a:lstStyle/>
+                    <a:p>
+                      <a:pPr algn="r" indent="0" marL="0">
+                        <a:buNone/>
+                      </a:pPr>
+                      <a:r>
+                        <a:rPr lang="en-US" sz="1050" dirty="0">
+                          <a:solidFill>
+                            <a:srgbClr val="111827"/>
+                          </a:solidFill>
+                          <a:latin typeface="Calibri" pitchFamily="34" charset="0"/>
+                          <a:ea typeface="Calibri" pitchFamily="34" charset="-122"/>
+                          <a:cs typeface="Calibri" pitchFamily="34" charset="-120"/>
+                        </a:rPr>
+                        <a:t>61.3 / 94.7</a:t>
+                      </a:r>
+                      <a:endParaRPr lang="en-US" sz="1050" dirty="0">
+                        <a:latin typeface="Calibri" charset="0"/>
+                        <a:ea typeface="Calibri" charset="0"/>
+                        <a:cs typeface="Calibri" charset="0"/>
+                      </a:endParaRPr>
+                    </a:p>
+                  </a:txBody>
+                  <a:tcPr marL="91440" marR="91440" marT="36576" marB="36576" anchor="ctr">
+                    <a:lnL w="9525" cap="flat" cmpd="sng" algn="ctr">
+                      <a:solidFill>
+                        <a:srgbClr val="E5E7EB"/>
+                      </a:solidFill>
+                      <a:prstDash val="solid"/>
+                      <a:round/>
+                      <a:headEnd type="none" w="med" len="med"/>
+                      <a:tailEnd type="none" w="med" len="med"/>
+                    </a:lnL>
+                    <a:lnR w="9525" cap="flat" cmpd="sng" algn="ctr">
+                      <a:solidFill>
+                        <a:srgbClr val="E5E7EB"/>
+                      </a:solidFill>
+                      <a:prstDash val="solid"/>
+                      <a:round/>
+                      <a:headEnd type="none" w="med" len="med"/>
+                      <a:tailEnd type="none" w="med" len="med"/>
+                    </a:lnR>
+                    <a:lnT w="9525" cap="flat" cmpd="sng" algn="ctr">
+                      <a:solidFill>
+                        <a:srgbClr val="E5E7EB"/>
+                      </a:solidFill>
+                      <a:prstDash val="solid"/>
+                      <a:round/>
+                      <a:headEnd type="none" w="med" len="med"/>
+                      <a:tailEnd type="none" w="med" len="med"/>
+                    </a:lnT>
+                    <a:lnB w="9525" cap="flat" cmpd="sng" algn="ctr">
+                      <a:solidFill>
+                        <a:srgbClr val="E5E7EB"/>
+                      </a:solidFill>
+                      <a:prstDash val="solid"/>
+                      <a:round/>
+                      <a:headEnd type="none" w="med" len="med"/>
+                      <a:tailEnd type="none" w="med" len="med"/>
+                    </a:lnB>
+                    <a:solidFill>
+                      <a:srgbClr val="ECFDF5"/>
+                    </a:solidFill>
+                  </a:tcPr>
+                </a:tc>
+                <a:tc>
+                  <a:txBody>
+                    <a:bodyPr/>
+                    <a:lstStyle/>
+                    <a:p>
+                      <a:pPr algn="r" indent="0" marL="0">
+                        <a:buNone/>
+                      </a:pPr>
+                      <a:r>
+                        <a:rPr lang="en-US" sz="1050" dirty="0">
+                          <a:solidFill>
+                            <a:srgbClr val="111827"/>
+                          </a:solidFill>
+                          <a:latin typeface="Calibri" pitchFamily="34" charset="0"/>
+                          <a:ea typeface="Calibri" pitchFamily="34" charset="-122"/>
+                          <a:cs typeface="Calibri" pitchFamily="34" charset="-120"/>
+                        </a:rPr>
+                        <a:t>57.7 / 103.0</a:t>
+                      </a:r>
+                      <a:endParaRPr lang="en-US" sz="1050" dirty="0">
+                        <a:latin typeface="Calibri" charset="0"/>
+                        <a:ea typeface="Calibri" charset="0"/>
+                        <a:cs typeface="Calibri" charset="0"/>
+                      </a:endParaRPr>
+                    </a:p>
+                  </a:txBody>
+                  <a:tcPr marL="91440" marR="91440" marT="36576" marB="36576" anchor="ctr">
+                    <a:lnL w="9525" cap="flat" cmpd="sng" algn="ctr">
+                      <a:solidFill>
+                        <a:srgbClr val="E5E7EB"/>
+                      </a:solidFill>
+                      <a:prstDash val="solid"/>
+                      <a:round/>
+                      <a:headEnd type="none" w="med" len="med"/>
+                      <a:tailEnd type="none" w="med" len="med"/>
+                    </a:lnL>
+                    <a:lnR w="9525" cap="flat" cmpd="sng" algn="ctr">
+                      <a:solidFill>
+                        <a:srgbClr val="E5E7EB"/>
+                      </a:solidFill>
+                      <a:prstDash val="solid"/>
+                      <a:round/>
+                      <a:headEnd type="none" w="med" len="med"/>
+                      <a:tailEnd type="none" w="med" len="med"/>
+                    </a:lnR>
+                    <a:lnT w="9525" cap="flat" cmpd="sng" algn="ctr">
+                      <a:solidFill>
+                        <a:srgbClr val="E5E7EB"/>
+                      </a:solidFill>
+                      <a:prstDash val="solid"/>
+                      <a:round/>
+                      <a:headEnd type="none" w="med" len="med"/>
+                      <a:tailEnd type="none" w="med" len="med"/>
+                    </a:lnT>
+                    <a:lnB w="9525" cap="flat" cmpd="sng" algn="ctr">
+                      <a:solidFill>
+                        <a:srgbClr val="E5E7EB"/>
+                      </a:solidFill>
+                      <a:prstDash val="solid"/>
+                      <a:round/>
+                      <a:headEnd type="none" w="med" len="med"/>
+                      <a:tailEnd type="none" w="med" len="med"/>
+                    </a:lnB>
+                    <a:solidFill>
+                      <a:srgbClr val="ECFDF5"/>
+                    </a:solidFill>
+                  </a:tcPr>
+                </a:tc>
+                <a:tc>
+                  <a:txBody>
+                    <a:bodyPr/>
+                    <a:lstStyle/>
+                    <a:p>
+                      <a:pPr algn="r" indent="0" marL="0">
+                        <a:buNone/>
+                      </a:pPr>
+                      <a:r>
+                        <a:rPr lang="en-US" sz="1050" b="1" dirty="0">
+                          <a:solidFill>
+                            <a:srgbClr val="111827"/>
+                          </a:solidFill>
+                          <a:latin typeface="Calibri" pitchFamily="34" charset="0"/>
+                          <a:ea typeface="Calibri" pitchFamily="34" charset="-122"/>
+                          <a:cs typeface="Calibri" pitchFamily="34" charset="-120"/>
+                        </a:rPr>
+                        <a:t>76.5 / 86.6</a:t>
+                      </a:r>
+                      <a:endParaRPr lang="en-US" sz="1050" dirty="0">
+                        <a:latin typeface="Calibri" charset="0"/>
+                        <a:ea typeface="Calibri" charset="0"/>
+                        <a:cs typeface="Calibri" charset="0"/>
+                      </a:endParaRPr>
+                    </a:p>
+                  </a:txBody>
+                  <a:tcPr marL="91440" marR="91440" marT="36576" marB="36576" anchor="ctr">
+                    <a:lnL w="9525" cap="flat" cmpd="sng" algn="ctr">
+                      <a:solidFill>
+                        <a:srgbClr val="E5E7EB"/>
+                      </a:solidFill>
+                      <a:prstDash val="solid"/>
+                      <a:round/>
+                      <a:headEnd type="none" w="med" len="med"/>
+                      <a:tailEnd type="none" w="med" len="med"/>
+                    </a:lnL>
+                    <a:lnR w="9525" cap="flat" cmpd="sng" algn="ctr">
+                      <a:solidFill>
+                        <a:srgbClr val="E5E7EB"/>
+                      </a:solidFill>
+                      <a:prstDash val="solid"/>
+                      <a:round/>
+                      <a:headEnd type="none" w="med" len="med"/>
+                      <a:tailEnd type="none" w="med" len="med"/>
+                    </a:lnR>
+                    <a:lnT w="9525" cap="flat" cmpd="sng" algn="ctr">
+                      <a:solidFill>
+                        <a:srgbClr val="E5E7EB"/>
+                      </a:solidFill>
+                      <a:prstDash val="solid"/>
+                      <a:round/>
+                      <a:headEnd type="none" w="med" len="med"/>
+                      <a:tailEnd type="none" w="med" len="med"/>
+                    </a:lnT>
+                    <a:lnB w="9525" cap="flat" cmpd="sng" algn="ctr">
+                      <a:solidFill>
+                        <a:srgbClr val="E5E7EB"/>
+                      </a:solidFill>
+                      <a:prstDash val="solid"/>
+                      <a:round/>
+                      <a:headEnd type="none" w="med" len="med"/>
+                      <a:tailEnd type="none" w="med" len="med"/>
+                    </a:lnB>
+                    <a:solidFill>
+                      <a:srgbClr val="ECFDF5"/>
+                    </a:solidFill>
+                  </a:tcPr>
+                </a:tc>
+              </a:tr>
+              <a:tr h="274320">
+                <a:tc>
+                  <a:txBody>
+                    <a:bodyPr/>
+                    <a:lstStyle/>
+                    <a:p>
+                      <a:pPr indent="0" marL="0">
+                        <a:buNone/>
+                      </a:pPr>
+                      <a:r>
+                        <a:rPr lang="en-US" sz="1050" b="1" dirty="0">
+                          <a:solidFill>
+                            <a:srgbClr val="111827"/>
+                          </a:solidFill>
+                          <a:latin typeface="Calibri" pitchFamily="34" charset="0"/>
+                          <a:ea typeface="Calibri" pitchFamily="34" charset="-122"/>
+                          <a:cs typeface="Calibri" pitchFamily="34" charset="-120"/>
+                        </a:rPr>
+                        <a:t>Calgary</a:t>
+                      </a:r>
+                      <a:endParaRPr lang="en-US" sz="1050" dirty="0">
+                        <a:latin typeface="Calibri" charset="0"/>
+                        <a:ea typeface="Calibri" charset="0"/>
+                        <a:cs typeface="Calibri" charset="0"/>
+                      </a:endParaRPr>
+                    </a:p>
+                  </a:txBody>
+                  <a:tcPr marL="91440" marR="91440" marT="36576" marB="36576" anchor="ctr">
+                    <a:lnL w="9525" cap="flat" cmpd="sng" algn="ctr">
+                      <a:solidFill>
+                        <a:srgbClr val="E5E7EB"/>
+                      </a:solidFill>
+                      <a:prstDash val="solid"/>
+                      <a:round/>
+                      <a:headEnd type="none" w="med" len="med"/>
+                      <a:tailEnd type="none" w="med" len="med"/>
+                    </a:lnL>
+                    <a:lnR w="9525" cap="flat" cmpd="sng" algn="ctr">
+                      <a:solidFill>
+                        <a:srgbClr val="E5E7EB"/>
+                      </a:solidFill>
+                      <a:prstDash val="solid"/>
+                      <a:round/>
+                      <a:headEnd type="none" w="med" len="med"/>
+                      <a:tailEnd type="none" w="med" len="med"/>
+                    </a:lnR>
+                    <a:lnT w="9525" cap="flat" cmpd="sng" algn="ctr">
+                      <a:solidFill>
+                        <a:srgbClr val="E5E7EB"/>
+                      </a:solidFill>
+                      <a:prstDash val="solid"/>
+                      <a:round/>
+                      <a:headEnd type="none" w="med" len="med"/>
+                      <a:tailEnd type="none" w="med" len="med"/>
+                    </a:lnT>
+                    <a:lnB w="9525" cap="flat" cmpd="sng" algn="ctr">
+                      <a:solidFill>
+                        <a:srgbClr val="E5E7EB"/>
+                      </a:solidFill>
+                      <a:prstDash val="solid"/>
+                      <a:round/>
+                      <a:headEnd type="none" w="med" len="med"/>
+                      <a:tailEnd type="none" w="med" len="med"/>
+                    </a:lnB>
+                    <a:solidFill>
+                      <a:srgbClr val="ECFDF5"/>
+                    </a:solidFill>
+                  </a:tcPr>
+                </a:tc>
+                <a:tc>
+                  <a:txBody>
+                    <a:bodyPr/>
+                    <a:lstStyle/>
+                    <a:p>
+                      <a:pPr algn="r" indent="0" marL="0">
+                        <a:buNone/>
+                      </a:pPr>
+                      <a:r>
+                        <a:rPr lang="en-US" sz="1050" dirty="0">
+                          <a:solidFill>
+                            <a:srgbClr val="111827"/>
+                          </a:solidFill>
+                          <a:latin typeface="Calibri" pitchFamily="34" charset="0"/>
+                          <a:ea typeface="Calibri" pitchFamily="34" charset="-122"/>
+                          <a:cs typeface="Calibri" pitchFamily="34" charset="-120"/>
+                        </a:rPr>
+                        <a:t>59.1 / 83.4</a:t>
+                      </a:r>
+                      <a:endParaRPr lang="en-US" sz="1050" dirty="0">
+                        <a:latin typeface="Calibri" charset="0"/>
+                        <a:ea typeface="Calibri" charset="0"/>
+                        <a:cs typeface="Calibri" charset="0"/>
+                      </a:endParaRPr>
+                    </a:p>
+                  </a:txBody>
+                  <a:tcPr marL="91440" marR="91440" marT="36576" marB="36576" anchor="ctr">
+                    <a:lnL w="9525" cap="flat" cmpd="sng" algn="ctr">
+                      <a:solidFill>
+                        <a:srgbClr val="E5E7EB"/>
+                      </a:solidFill>
+                      <a:prstDash val="solid"/>
+                      <a:round/>
+                      <a:headEnd type="none" w="med" len="med"/>
+                      <a:tailEnd type="none" w="med" len="med"/>
+                    </a:lnL>
+                    <a:lnR w="9525" cap="flat" cmpd="sng" algn="ctr">
+                      <a:solidFill>
+                        <a:srgbClr val="E5E7EB"/>
+                      </a:solidFill>
+                      <a:prstDash val="solid"/>
+                      <a:round/>
+                      <a:headEnd type="none" w="med" len="med"/>
+                      <a:tailEnd type="none" w="med" len="med"/>
+                    </a:lnR>
+                    <a:lnT w="9525" cap="flat" cmpd="sng" algn="ctr">
+                      <a:solidFill>
+                        <a:srgbClr val="E5E7EB"/>
+                      </a:solidFill>
+                      <a:prstDash val="solid"/>
+                      <a:round/>
+                      <a:headEnd type="none" w="med" len="med"/>
+                      <a:tailEnd type="none" w="med" len="med"/>
+                    </a:lnT>
+                    <a:lnB w="9525" cap="flat" cmpd="sng" algn="ctr">
+                      <a:solidFill>
+                        <a:srgbClr val="E5E7EB"/>
+                      </a:solidFill>
+                      <a:prstDash val="solid"/>
+                      <a:round/>
+                      <a:headEnd type="none" w="med" len="med"/>
+                      <a:tailEnd type="none" w="med" len="med"/>
+                    </a:lnB>
+                    <a:solidFill>
+                      <a:srgbClr val="ECFDF5"/>
+                    </a:solidFill>
+                  </a:tcPr>
+                </a:tc>
+                <a:tc>
+                  <a:txBody>
+                    <a:bodyPr/>
+                    <a:lstStyle/>
+                    <a:p>
+                      <a:pPr algn="r" indent="0" marL="0">
+                        <a:buNone/>
+                      </a:pPr>
+                      <a:r>
+                        <a:rPr lang="en-US" sz="1050" dirty="0">
+                          <a:solidFill>
+                            <a:srgbClr val="111827"/>
+                          </a:solidFill>
+                          <a:latin typeface="Calibri" pitchFamily="34" charset="0"/>
+                          <a:ea typeface="Calibri" pitchFamily="34" charset="-122"/>
+                          <a:cs typeface="Calibri" pitchFamily="34" charset="-120"/>
+                        </a:rPr>
+                        <a:t>57.9 / 94.9</a:t>
+                      </a:r>
+                      <a:endParaRPr lang="en-US" sz="1050" dirty="0">
+                        <a:latin typeface="Calibri" charset="0"/>
+                        <a:ea typeface="Calibri" charset="0"/>
+                        <a:cs typeface="Calibri" charset="0"/>
+                      </a:endParaRPr>
+                    </a:p>
+                  </a:txBody>
+                  <a:tcPr marL="91440" marR="91440" marT="36576" marB="36576" anchor="ctr">
+                    <a:lnL w="9525" cap="flat" cmpd="sng" algn="ctr">
+                      <a:solidFill>
+                        <a:srgbClr val="E5E7EB"/>
+                      </a:solidFill>
+                      <a:prstDash val="solid"/>
+                      <a:round/>
+                      <a:headEnd type="none" w="med" len="med"/>
+                      <a:tailEnd type="none" w="med" len="med"/>
+                    </a:lnL>
+                    <a:lnR w="9525" cap="flat" cmpd="sng" algn="ctr">
+                      <a:solidFill>
+                        <a:srgbClr val="E5E7EB"/>
+                      </a:solidFill>
+                      <a:prstDash val="solid"/>
+                      <a:round/>
+                      <a:headEnd type="none" w="med" len="med"/>
+                      <a:tailEnd type="none" w="med" len="med"/>
+                    </a:lnR>
+                    <a:lnT w="9525" cap="flat" cmpd="sng" algn="ctr">
+                      <a:solidFill>
+                        <a:srgbClr val="E5E7EB"/>
+                      </a:solidFill>
+                      <a:prstDash val="solid"/>
+                      <a:round/>
+                      <a:headEnd type="none" w="med" len="med"/>
+                      <a:tailEnd type="none" w="med" len="med"/>
+                    </a:lnT>
+                    <a:lnB w="9525" cap="flat" cmpd="sng" algn="ctr">
+                      <a:solidFill>
+                        <a:srgbClr val="E5E7EB"/>
+                      </a:solidFill>
+                      <a:prstDash val="solid"/>
+                      <a:round/>
+                      <a:headEnd type="none" w="med" len="med"/>
+                      <a:tailEnd type="none" w="med" len="med"/>
+                    </a:lnB>
+                    <a:solidFill>
+                      <a:srgbClr val="ECFDF5"/>
+                    </a:solidFill>
+                  </a:tcPr>
+                </a:tc>
+                <a:tc>
+                  <a:txBody>
+                    <a:bodyPr/>
+                    <a:lstStyle/>
+                    <a:p>
+                      <a:pPr algn="r" indent="0" marL="0">
+                        <a:buNone/>
+                      </a:pPr>
+                      <a:r>
+                        <a:rPr lang="en-US" sz="1050" b="1" dirty="0">
+                          <a:solidFill>
+                            <a:srgbClr val="111827"/>
+                          </a:solidFill>
+                          <a:latin typeface="Calibri" pitchFamily="34" charset="0"/>
+                          <a:ea typeface="Calibri" pitchFamily="34" charset="-122"/>
+                          <a:cs typeface="Calibri" pitchFamily="34" charset="-120"/>
+                        </a:rPr>
+                        <a:t>54.5 / 82.1</a:t>
+                      </a:r>
+                      <a:endParaRPr lang="en-US" sz="1050" dirty="0">
+                        <a:latin typeface="Calibri" charset="0"/>
+                        <a:ea typeface="Calibri" charset="0"/>
+                        <a:cs typeface="Calibri" charset="0"/>
+                      </a:endParaRPr>
+                    </a:p>
+                  </a:txBody>
+                  <a:tcPr marL="91440" marR="91440" marT="36576" marB="36576" anchor="ctr">
+                    <a:lnL w="9525" cap="flat" cmpd="sng" algn="ctr">
+                      <a:solidFill>
+                        <a:srgbClr val="E5E7EB"/>
+                      </a:solidFill>
+                      <a:prstDash val="solid"/>
+                      <a:round/>
+                      <a:headEnd type="none" w="med" len="med"/>
+                      <a:tailEnd type="none" w="med" len="med"/>
+                    </a:lnL>
+                    <a:lnR w="9525" cap="flat" cmpd="sng" algn="ctr">
+                      <a:solidFill>
+                        <a:srgbClr val="E5E7EB"/>
+                      </a:solidFill>
+                      <a:prstDash val="solid"/>
+                      <a:round/>
+                      <a:headEnd type="none" w="med" len="med"/>
+                      <a:tailEnd type="none" w="med" len="med"/>
+                    </a:lnR>
+                    <a:lnT w="9525" cap="flat" cmpd="sng" algn="ctr">
+                      <a:solidFill>
+                        <a:srgbClr val="E5E7EB"/>
+                      </a:solidFill>
+                      <a:prstDash val="solid"/>
+                      <a:round/>
+                      <a:headEnd type="none" w="med" len="med"/>
+                      <a:tailEnd type="none" w="med" len="med"/>
+                    </a:lnT>
+                    <a:lnB w="9525" cap="flat" cmpd="sng" algn="ctr">
+                      <a:solidFill>
+                        <a:srgbClr val="E5E7EB"/>
+                      </a:solidFill>
+                      <a:prstDash val="solid"/>
+                      <a:round/>
+                      <a:headEnd type="none" w="med" len="med"/>
+                      <a:tailEnd type="none" w="med" len="med"/>
+                    </a:lnB>
+                    <a:solidFill>
+                      <a:srgbClr val="ECFDF5"/>
+                    </a:solidFill>
+                  </a:tcPr>
+                </a:tc>
+              </a:tr>
+              <a:tr h="274320">
+                <a:tc>
+                  <a:txBody>
+                    <a:bodyPr/>
+                    <a:lstStyle/>
+                    <a:p>
+                      <a:pPr indent="0" marL="0">
+                        <a:buNone/>
+                      </a:pPr>
+                      <a:r>
+                        <a:rPr lang="en-US" sz="1050" b="1" dirty="0">
+                          <a:solidFill>
+                            <a:srgbClr val="111827"/>
+                          </a:solidFill>
+                          <a:latin typeface="Calibri" pitchFamily="34" charset="0"/>
+                          <a:ea typeface="Calibri" pitchFamily="34" charset="-122"/>
+                          <a:cs typeface="Calibri" pitchFamily="34" charset="-120"/>
+                        </a:rPr>
+                        <a:t>Moncton</a:t>
+                      </a:r>
+                      <a:endParaRPr lang="en-US" sz="1050" dirty="0">
+                        <a:latin typeface="Calibri" charset="0"/>
+                        <a:ea typeface="Calibri" charset="0"/>
+                        <a:cs typeface="Calibri" charset="0"/>
+                      </a:endParaRPr>
+                    </a:p>
+                  </a:txBody>
+                  <a:tcPr marL="91440" marR="91440" marT="36576" marB="36576" anchor="ctr">
+                    <a:lnL w="9525" cap="flat" cmpd="sng" algn="ctr">
+                      <a:solidFill>
+                        <a:srgbClr val="E5E7EB"/>
+                      </a:solidFill>
+                      <a:prstDash val="solid"/>
+                      <a:round/>
+                      <a:headEnd type="none" w="med" len="med"/>
+                      <a:tailEnd type="none" w="med" len="med"/>
+                    </a:lnL>
+                    <a:lnR w="9525" cap="flat" cmpd="sng" algn="ctr">
+                      <a:solidFill>
+                        <a:srgbClr val="E5E7EB"/>
+                      </a:solidFill>
+                      <a:prstDash val="solid"/>
+                      <a:round/>
+                      <a:headEnd type="none" w="med" len="med"/>
+                      <a:tailEnd type="none" w="med" len="med"/>
+                    </a:lnR>
+                    <a:lnT w="9525" cap="flat" cmpd="sng" algn="ctr">
+                      <a:solidFill>
+                        <a:srgbClr val="E5E7EB"/>
+                      </a:solidFill>
+                      <a:prstDash val="solid"/>
+                      <a:round/>
+                      <a:headEnd type="none" w="med" len="med"/>
+                      <a:tailEnd type="none" w="med" len="med"/>
+                    </a:lnT>
+                    <a:lnB w="9525" cap="flat" cmpd="sng" algn="ctr">
+                      <a:solidFill>
+                        <a:srgbClr val="E5E7EB"/>
+                      </a:solidFill>
+                      <a:prstDash val="solid"/>
+                      <a:round/>
+                      <a:headEnd type="none" w="med" len="med"/>
+                      <a:tailEnd type="none" w="med" len="med"/>
+                    </a:lnB>
+                    <a:solidFill>
+                      <a:srgbClr val="FFFFFF"/>
+                    </a:solidFill>
+                  </a:tcPr>
+                </a:tc>
+                <a:tc>
+                  <a:txBody>
+                    <a:bodyPr/>
+                    <a:lstStyle/>
+                    <a:p>
+                      <a:pPr algn="r" indent="0" marL="0">
+                        <a:buNone/>
+                      </a:pPr>
+                      <a:r>
+                        <a:rPr lang="en-US" sz="1050" dirty="0">
+                          <a:solidFill>
+                            <a:srgbClr val="111827"/>
+                          </a:solidFill>
+                          <a:latin typeface="Calibri" pitchFamily="34" charset="0"/>
+                          <a:ea typeface="Calibri" pitchFamily="34" charset="-122"/>
+                          <a:cs typeface="Calibri" pitchFamily="34" charset="-120"/>
+                        </a:rPr>
+                        <a:t>26.2 / 81.3</a:t>
+                      </a:r>
+                      <a:endParaRPr lang="en-US" sz="1050" dirty="0">
+                        <a:latin typeface="Calibri" charset="0"/>
+                        <a:ea typeface="Calibri" charset="0"/>
+                        <a:cs typeface="Calibri" charset="0"/>
+                      </a:endParaRPr>
+                    </a:p>
+                  </a:txBody>
+                  <a:tcPr marL="91440" marR="91440" marT="36576" marB="36576" anchor="ctr">
+                    <a:lnL w="9525" cap="flat" cmpd="sng" algn="ctr">
+                      <a:solidFill>
+                        <a:srgbClr val="E5E7EB"/>
+                      </a:solidFill>
+                      <a:prstDash val="solid"/>
+                      <a:round/>
+                      <a:headEnd type="none" w="med" len="med"/>
+                      <a:tailEnd type="none" w="med" len="med"/>
+                    </a:lnL>
+                    <a:lnR w="9525" cap="flat" cmpd="sng" algn="ctr">
+                      <a:solidFill>
+                        <a:srgbClr val="E5E7EB"/>
+                      </a:solidFill>
+                      <a:prstDash val="solid"/>
+                      <a:round/>
+                      <a:headEnd type="none" w="med" len="med"/>
+                      <a:tailEnd type="none" w="med" len="med"/>
+                    </a:lnR>
+                    <a:lnT w="9525" cap="flat" cmpd="sng" algn="ctr">
+                      <a:solidFill>
+                        <a:srgbClr val="E5E7EB"/>
+                      </a:solidFill>
+                      <a:prstDash val="solid"/>
+                      <a:round/>
+                      <a:headEnd type="none" w="med" len="med"/>
+                      <a:tailEnd type="none" w="med" len="med"/>
+                    </a:lnT>
+                    <a:lnB w="9525" cap="flat" cmpd="sng" algn="ctr">
+                      <a:solidFill>
+                        <a:srgbClr val="E5E7EB"/>
+                      </a:solidFill>
+                      <a:prstDash val="solid"/>
+                      <a:round/>
+                      <a:headEnd type="none" w="med" len="med"/>
+                      <a:tailEnd type="none" w="med" len="med"/>
+                    </a:lnB>
+                    <a:solidFill>
+                      <a:srgbClr val="FFFFFF"/>
+                    </a:solidFill>
+                  </a:tcPr>
+                </a:tc>
+                <a:tc>
+                  <a:txBody>
+                    <a:bodyPr/>
+                    <a:lstStyle/>
+                    <a:p>
+                      <a:pPr algn="r" indent="0" marL="0">
+                        <a:buNone/>
+                      </a:pPr>
+                      <a:r>
+                        <a:rPr lang="en-US" sz="1050" dirty="0">
+                          <a:solidFill>
+                            <a:srgbClr val="111827"/>
+                          </a:solidFill>
+                          <a:latin typeface="Calibri" pitchFamily="34" charset="0"/>
+                          <a:ea typeface="Calibri" pitchFamily="34" charset="-122"/>
+                          <a:cs typeface="Calibri" pitchFamily="34" charset="-120"/>
+                        </a:rPr>
+                        <a:t>13.6 / 54.7</a:t>
+                      </a:r>
+                      <a:endParaRPr lang="en-US" sz="1050" dirty="0">
+                        <a:latin typeface="Calibri" charset="0"/>
+                        <a:ea typeface="Calibri" charset="0"/>
+                        <a:cs typeface="Calibri" charset="0"/>
+                      </a:endParaRPr>
+                    </a:p>
+                  </a:txBody>
+                  <a:tcPr marL="91440" marR="91440" marT="36576" marB="36576" anchor="ctr">
+                    <a:lnL w="9525" cap="flat" cmpd="sng" algn="ctr">
+                      <a:solidFill>
+                        <a:srgbClr val="E5E7EB"/>
+                      </a:solidFill>
+                      <a:prstDash val="solid"/>
+                      <a:round/>
+                      <a:headEnd type="none" w="med" len="med"/>
+                      <a:tailEnd type="none" w="med" len="med"/>
+                    </a:lnL>
+                    <a:lnR w="9525" cap="flat" cmpd="sng" algn="ctr">
+                      <a:solidFill>
+                        <a:srgbClr val="E5E7EB"/>
+                      </a:solidFill>
+                      <a:prstDash val="solid"/>
+                      <a:round/>
+                      <a:headEnd type="none" w="med" len="med"/>
+                      <a:tailEnd type="none" w="med" len="med"/>
+                    </a:lnR>
+                    <a:lnT w="9525" cap="flat" cmpd="sng" algn="ctr">
+                      <a:solidFill>
+                        <a:srgbClr val="E5E7EB"/>
+                      </a:solidFill>
+                      <a:prstDash val="solid"/>
+                      <a:round/>
+                      <a:headEnd type="none" w="med" len="med"/>
+                      <a:tailEnd type="none" w="med" len="med"/>
+                    </a:lnT>
+                    <a:lnB w="9525" cap="flat" cmpd="sng" algn="ctr">
+                      <a:solidFill>
+                        <a:srgbClr val="E5E7EB"/>
+                      </a:solidFill>
+                      <a:prstDash val="solid"/>
+                      <a:round/>
+                      <a:headEnd type="none" w="med" len="med"/>
+                      <a:tailEnd type="none" w="med" len="med"/>
+                    </a:lnB>
+                    <a:solidFill>
+                      <a:srgbClr val="FFFFFF"/>
+                    </a:solidFill>
+                  </a:tcPr>
+                </a:tc>
+                <a:tc>
+                  <a:txBody>
+                    <a:bodyPr/>
+                    <a:lstStyle/>
+                    <a:p>
+                      <a:pPr algn="r" indent="0" marL="0">
+                        <a:buNone/>
+                      </a:pPr>
+                      <a:r>
+                        <a:rPr lang="en-US" sz="1050" b="1" dirty="0">
+                          <a:solidFill>
+                            <a:srgbClr val="111827"/>
+                          </a:solidFill>
+                          <a:latin typeface="Calibri" pitchFamily="34" charset="0"/>
+                          <a:ea typeface="Calibri" pitchFamily="34" charset="-122"/>
+                          <a:cs typeface="Calibri" pitchFamily="34" charset="-120"/>
+                        </a:rPr>
+                        <a:t>33.3 / 79.2</a:t>
+                      </a:r>
+                      <a:endParaRPr lang="en-US" sz="1050" dirty="0">
+                        <a:latin typeface="Calibri" charset="0"/>
+                        <a:ea typeface="Calibri" charset="0"/>
+                        <a:cs typeface="Calibri" charset="0"/>
+                      </a:endParaRPr>
+                    </a:p>
+                  </a:txBody>
+                  <a:tcPr marL="91440" marR="91440" marT="36576" marB="36576" anchor="ctr">
+                    <a:lnL w="9525" cap="flat" cmpd="sng" algn="ctr">
+                      <a:solidFill>
+                        <a:srgbClr val="E5E7EB"/>
+                      </a:solidFill>
+                      <a:prstDash val="solid"/>
+                      <a:round/>
+                      <a:headEnd type="none" w="med" len="med"/>
+                      <a:tailEnd type="none" w="med" len="med"/>
+                    </a:lnL>
+                    <a:lnR w="9525" cap="flat" cmpd="sng" algn="ctr">
+                      <a:solidFill>
+                        <a:srgbClr val="E5E7EB"/>
+                      </a:solidFill>
+                      <a:prstDash val="solid"/>
+                      <a:round/>
+                      <a:headEnd type="none" w="med" len="med"/>
+                      <a:tailEnd type="none" w="med" len="med"/>
+                    </a:lnR>
+                    <a:lnT w="9525" cap="flat" cmpd="sng" algn="ctr">
+                      <a:solidFill>
+                        <a:srgbClr val="E5E7EB"/>
+                      </a:solidFill>
+                      <a:prstDash val="solid"/>
+                      <a:round/>
+                      <a:headEnd type="none" w="med" len="med"/>
+                      <a:tailEnd type="none" w="med" len="med"/>
+                    </a:lnT>
+                    <a:lnB w="9525" cap="flat" cmpd="sng" algn="ctr">
+                      <a:solidFill>
+                        <a:srgbClr val="E5E7EB"/>
+                      </a:solidFill>
+                      <a:prstDash val="solid"/>
+                      <a:round/>
+                      <a:headEnd type="none" w="med" len="med"/>
+                      <a:tailEnd type="none" w="med" len="med"/>
+                    </a:lnB>
+                    <a:solidFill>
+                      <a:srgbClr val="FFFFFF"/>
+                    </a:solidFill>
+                  </a:tcPr>
+                </a:tc>
+              </a:tr>
+              <a:tr h="274320">
+                <a:tc>
+                  <a:txBody>
+                    <a:bodyPr/>
+                    <a:lstStyle/>
+                    <a:p>
+                      <a:pPr indent="0" marL="0">
+                        <a:buNone/>
+                      </a:pPr>
+                      <a:r>
+                        <a:rPr lang="en-US" sz="1050" b="1" dirty="0">
+                          <a:solidFill>
+                            <a:srgbClr val="111827"/>
+                          </a:solidFill>
+                          <a:latin typeface="Calibri" pitchFamily="34" charset="0"/>
+                          <a:ea typeface="Calibri" pitchFamily="34" charset="-122"/>
+                          <a:cs typeface="Calibri" pitchFamily="34" charset="-120"/>
+                        </a:rPr>
+                        <a:t>Dartmouth</a:t>
+                      </a:r>
+                      <a:endParaRPr lang="en-US" sz="1050" dirty="0">
+                        <a:latin typeface="Calibri" charset="0"/>
+                        <a:ea typeface="Calibri" charset="0"/>
+                        <a:cs typeface="Calibri" charset="0"/>
+                      </a:endParaRPr>
+                    </a:p>
+                  </a:txBody>
+                  <a:tcPr marL="91440" marR="91440" marT="36576" marB="36576" anchor="ctr">
+                    <a:lnL w="9525" cap="flat" cmpd="sng" algn="ctr">
+                      <a:solidFill>
+                        <a:srgbClr val="E5E7EB"/>
+                      </a:solidFill>
+                      <a:prstDash val="solid"/>
+                      <a:round/>
+                      <a:headEnd type="none" w="med" len="med"/>
+                      <a:tailEnd type="none" w="med" len="med"/>
+                    </a:lnL>
+                    <a:lnR w="9525" cap="flat" cmpd="sng" algn="ctr">
+                      <a:solidFill>
+                        <a:srgbClr val="E5E7EB"/>
+                      </a:solidFill>
+                      <a:prstDash val="solid"/>
+                      <a:round/>
+                      <a:headEnd type="none" w="med" len="med"/>
+                      <a:tailEnd type="none" w="med" len="med"/>
+                    </a:lnR>
+                    <a:lnT w="9525" cap="flat" cmpd="sng" algn="ctr">
+                      <a:solidFill>
+                        <a:srgbClr val="E5E7EB"/>
+                      </a:solidFill>
+                      <a:prstDash val="solid"/>
+                      <a:round/>
+                      <a:headEnd type="none" w="med" len="med"/>
+                      <a:tailEnd type="none" w="med" len="med"/>
+                    </a:lnT>
+                    <a:lnB w="9525" cap="flat" cmpd="sng" algn="ctr">
+                      <a:solidFill>
+                        <a:srgbClr val="E5E7EB"/>
+                      </a:solidFill>
+                      <a:prstDash val="solid"/>
+                      <a:round/>
+                      <a:headEnd type="none" w="med" len="med"/>
+                      <a:tailEnd type="none" w="med" len="med"/>
+                    </a:lnB>
+                    <a:solidFill>
+                      <a:srgbClr val="FEF2F2"/>
+                    </a:solidFill>
+                  </a:tcPr>
+                </a:tc>
+                <a:tc>
+                  <a:txBody>
+                    <a:bodyPr/>
+                    <a:lstStyle/>
+                    <a:p>
+                      <a:pPr algn="r" indent="0" marL="0">
+                        <a:buNone/>
+                      </a:pPr>
+                      <a:r>
+                        <a:rPr lang="en-US" sz="1050" dirty="0">
+                          <a:solidFill>
+                            <a:srgbClr val="111827"/>
+                          </a:solidFill>
+                          <a:latin typeface="Calibri" pitchFamily="34" charset="0"/>
+                          <a:ea typeface="Calibri" pitchFamily="34" charset="-122"/>
+                          <a:cs typeface="Calibri" pitchFamily="34" charset="-120"/>
+                        </a:rPr>
+                        <a:t>7.1 / 67.3</a:t>
+                      </a:r>
+                      <a:endParaRPr lang="en-US" sz="1050" dirty="0">
+                        <a:latin typeface="Calibri" charset="0"/>
+                        <a:ea typeface="Calibri" charset="0"/>
+                        <a:cs typeface="Calibri" charset="0"/>
+                      </a:endParaRPr>
+                    </a:p>
+                  </a:txBody>
+                  <a:tcPr marL="91440" marR="91440" marT="36576" marB="36576" anchor="ctr">
+                    <a:lnL w="9525" cap="flat" cmpd="sng" algn="ctr">
+                      <a:solidFill>
+                        <a:srgbClr val="E5E7EB"/>
+                      </a:solidFill>
+                      <a:prstDash val="solid"/>
+                      <a:round/>
+                      <a:headEnd type="none" w="med" len="med"/>
+                      <a:tailEnd type="none" w="med" len="med"/>
+                    </a:lnL>
+                    <a:lnR w="9525" cap="flat" cmpd="sng" algn="ctr">
+                      <a:solidFill>
+                        <a:srgbClr val="E5E7EB"/>
+                      </a:solidFill>
+                      <a:prstDash val="solid"/>
+                      <a:round/>
+                      <a:headEnd type="none" w="med" len="med"/>
+                      <a:tailEnd type="none" w="med" len="med"/>
+                    </a:lnR>
+                    <a:lnT w="9525" cap="flat" cmpd="sng" algn="ctr">
+                      <a:solidFill>
+                        <a:srgbClr val="E5E7EB"/>
+                      </a:solidFill>
+                      <a:prstDash val="solid"/>
+                      <a:round/>
+                      <a:headEnd type="none" w="med" len="med"/>
+                      <a:tailEnd type="none" w="med" len="med"/>
+                    </a:lnT>
+                    <a:lnB w="9525" cap="flat" cmpd="sng" algn="ctr">
+                      <a:solidFill>
+                        <a:srgbClr val="E5E7EB"/>
+                      </a:solidFill>
+                      <a:prstDash val="solid"/>
+                      <a:round/>
+                      <a:headEnd type="none" w="med" len="med"/>
+                      <a:tailEnd type="none" w="med" len="med"/>
+                    </a:lnB>
+                    <a:solidFill>
+                      <a:srgbClr val="FEF2F2"/>
+                    </a:solidFill>
+                  </a:tcPr>
+                </a:tc>
+                <a:tc>
+                  <a:txBody>
+                    <a:bodyPr/>
+                    <a:lstStyle/>
+                    <a:p>
+                      <a:pPr algn="r" indent="0" marL="0">
+                        <a:buNone/>
+                      </a:pPr>
+                      <a:r>
+                        <a:rPr lang="en-US" sz="1050" dirty="0">
+                          <a:solidFill>
+                            <a:srgbClr val="111827"/>
+                          </a:solidFill>
+                          <a:latin typeface="Calibri" pitchFamily="34" charset="0"/>
+                          <a:ea typeface="Calibri" pitchFamily="34" charset="-122"/>
+                          <a:cs typeface="Calibri" pitchFamily="34" charset="-120"/>
+                        </a:rPr>
+                        <a:t>14.3 / 69.1</a:t>
+                      </a:r>
+                      <a:endParaRPr lang="en-US" sz="1050" dirty="0">
+                        <a:latin typeface="Calibri" charset="0"/>
+                        <a:ea typeface="Calibri" charset="0"/>
+                        <a:cs typeface="Calibri" charset="0"/>
+                      </a:endParaRPr>
+                    </a:p>
+                  </a:txBody>
+                  <a:tcPr marL="91440" marR="91440" marT="36576" marB="36576" anchor="ctr">
+                    <a:lnL w="9525" cap="flat" cmpd="sng" algn="ctr">
+                      <a:solidFill>
+                        <a:srgbClr val="E5E7EB"/>
+                      </a:solidFill>
+                      <a:prstDash val="solid"/>
+                      <a:round/>
+                      <a:headEnd type="none" w="med" len="med"/>
+                      <a:tailEnd type="none" w="med" len="med"/>
+                    </a:lnL>
+                    <a:lnR w="9525" cap="flat" cmpd="sng" algn="ctr">
+                      <a:solidFill>
+                        <a:srgbClr val="E5E7EB"/>
+                      </a:solidFill>
+                      <a:prstDash val="solid"/>
+                      <a:round/>
+                      <a:headEnd type="none" w="med" len="med"/>
+                      <a:tailEnd type="none" w="med" len="med"/>
+                    </a:lnR>
+                    <a:lnT w="9525" cap="flat" cmpd="sng" algn="ctr">
+                      <a:solidFill>
+                        <a:srgbClr val="E5E7EB"/>
+                      </a:solidFill>
+                      <a:prstDash val="solid"/>
+                      <a:round/>
+                      <a:headEnd type="none" w="med" len="med"/>
+                      <a:tailEnd type="none" w="med" len="med"/>
+                    </a:lnT>
+                    <a:lnB w="9525" cap="flat" cmpd="sng" algn="ctr">
+                      <a:solidFill>
+                        <a:srgbClr val="E5E7EB"/>
+                      </a:solidFill>
+                      <a:prstDash val="solid"/>
+                      <a:round/>
+                      <a:headEnd type="none" w="med" len="med"/>
+                      <a:tailEnd type="none" w="med" len="med"/>
+                    </a:lnB>
+                    <a:solidFill>
+                      <a:srgbClr val="FEF2F2"/>
+                    </a:solidFill>
+                  </a:tcPr>
+                </a:tc>
+                <a:tc>
+                  <a:txBody>
+                    <a:bodyPr/>
+                    <a:lstStyle/>
+                    <a:p>
+                      <a:pPr algn="r" indent="0" marL="0">
+                        <a:buNone/>
+                      </a:pPr>
+                      <a:r>
+                        <a:rPr lang="en-US" sz="1050" b="1" dirty="0">
+                          <a:solidFill>
+                            <a:srgbClr val="111827"/>
+                          </a:solidFill>
+                          <a:latin typeface="Calibri" pitchFamily="34" charset="0"/>
+                          <a:ea typeface="Calibri" pitchFamily="34" charset="-122"/>
+                          <a:cs typeface="Calibri" pitchFamily="34" charset="-120"/>
+                        </a:rPr>
+                        <a:t>8.3 / 63.5</a:t>
+                      </a:r>
+                      <a:endParaRPr lang="en-US" sz="1050" dirty="0">
+                        <a:latin typeface="Calibri" charset="0"/>
+                        <a:ea typeface="Calibri" charset="0"/>
+                        <a:cs typeface="Calibri" charset="0"/>
+                      </a:endParaRPr>
+                    </a:p>
+                  </a:txBody>
+                  <a:tcPr marL="91440" marR="91440" marT="36576" marB="36576" anchor="ctr">
+                    <a:lnL w="9525" cap="flat" cmpd="sng" algn="ctr">
+                      <a:solidFill>
+                        <a:srgbClr val="E5E7EB"/>
+                      </a:solidFill>
+                      <a:prstDash val="solid"/>
+                      <a:round/>
+                      <a:headEnd type="none" w="med" len="med"/>
+                      <a:tailEnd type="none" w="med" len="med"/>
+                    </a:lnL>
+                    <a:lnR w="9525" cap="flat" cmpd="sng" algn="ctr">
+                      <a:solidFill>
+                        <a:srgbClr val="E5E7EB"/>
+                      </a:solidFill>
+                      <a:prstDash val="solid"/>
+                      <a:round/>
+                      <a:headEnd type="none" w="med" len="med"/>
+                      <a:tailEnd type="none" w="med" len="med"/>
+                    </a:lnR>
+                    <a:lnT w="9525" cap="flat" cmpd="sng" algn="ctr">
+                      <a:solidFill>
+                        <a:srgbClr val="E5E7EB"/>
+                      </a:solidFill>
+                      <a:prstDash val="solid"/>
+                      <a:round/>
+                      <a:headEnd type="none" w="med" len="med"/>
+                      <a:tailEnd type="none" w="med" len="med"/>
+                    </a:lnT>
+                    <a:lnB w="9525" cap="flat" cmpd="sng" algn="ctr">
+                      <a:solidFill>
+                        <a:srgbClr val="E5E7EB"/>
+                      </a:solidFill>
+                      <a:prstDash val="solid"/>
+                      <a:round/>
+                      <a:headEnd type="none" w="med" len="med"/>
+                      <a:tailEnd type="none" w="med" len="med"/>
+                    </a:lnB>
+                    <a:solidFill>
+                      <a:srgbClr val="FEF2F2"/>
+                    </a:solidFill>
+                  </a:tcPr>
+                </a:tc>
+              </a:tr>
+              <a:tr h="274320">
+                <a:tc>
+                  <a:txBody>
+                    <a:bodyPr/>
+                    <a:lstStyle/>
+                    <a:p>
+                      <a:pPr indent="0" marL="0">
+                        <a:buNone/>
+                      </a:pPr>
+                      <a:r>
+                        <a:rPr lang="en-US" sz="1050" b="1" dirty="0">
+                          <a:solidFill>
+                            <a:srgbClr val="111827"/>
+                          </a:solidFill>
+                          <a:latin typeface="Calibri" pitchFamily="34" charset="0"/>
+                          <a:ea typeface="Calibri" pitchFamily="34" charset="-122"/>
+                          <a:cs typeface="Calibri" pitchFamily="34" charset="-120"/>
+                        </a:rPr>
+                        <a:t>Quebec City</a:t>
+                      </a:r>
+                      <a:endParaRPr lang="en-US" sz="1050" dirty="0">
+                        <a:latin typeface="Calibri" charset="0"/>
+                        <a:ea typeface="Calibri" charset="0"/>
+                        <a:cs typeface="Calibri" charset="0"/>
+                      </a:endParaRPr>
+                    </a:p>
+                  </a:txBody>
+                  <a:tcPr marL="91440" marR="91440" marT="36576" marB="36576" anchor="ctr">
+                    <a:lnL w="9525" cap="flat" cmpd="sng" algn="ctr">
+                      <a:solidFill>
+                        <a:srgbClr val="E5E7EB"/>
+                      </a:solidFill>
+                      <a:prstDash val="solid"/>
+                      <a:round/>
+                      <a:headEnd type="none" w="med" len="med"/>
+                      <a:tailEnd type="none" w="med" len="med"/>
+                    </a:lnL>
+                    <a:lnR w="9525" cap="flat" cmpd="sng" algn="ctr">
+                      <a:solidFill>
+                        <a:srgbClr val="E5E7EB"/>
+                      </a:solidFill>
+                      <a:prstDash val="solid"/>
+                      <a:round/>
+                      <a:headEnd type="none" w="med" len="med"/>
+                      <a:tailEnd type="none" w="med" len="med"/>
+                    </a:lnR>
+                    <a:lnT w="9525" cap="flat" cmpd="sng" algn="ctr">
+                      <a:solidFill>
+                        <a:srgbClr val="E5E7EB"/>
+                      </a:solidFill>
+                      <a:prstDash val="solid"/>
+                      <a:round/>
+                      <a:headEnd type="none" w="med" len="med"/>
+                      <a:tailEnd type="none" w="med" len="med"/>
+                    </a:lnT>
+                    <a:lnB w="9525" cap="flat" cmpd="sng" algn="ctr">
+                      <a:solidFill>
+                        <a:srgbClr val="E5E7EB"/>
+                      </a:solidFill>
+                      <a:prstDash val="solid"/>
+                      <a:round/>
+                      <a:headEnd type="none" w="med" len="med"/>
+                      <a:tailEnd type="none" w="med" len="med"/>
+                    </a:lnB>
+                    <a:solidFill>
+                      <a:srgbClr val="FEF2F2"/>
+                    </a:solidFill>
+                  </a:tcPr>
+                </a:tc>
+                <a:tc>
+                  <a:txBody>
+                    <a:bodyPr/>
+                    <a:lstStyle/>
+                    <a:p>
+                      <a:pPr algn="r" indent="0" marL="0">
+                        <a:buNone/>
+                      </a:pPr>
+                      <a:r>
+                        <a:rPr lang="en-US" sz="1050" dirty="0">
+                          <a:solidFill>
+                            <a:srgbClr val="111827"/>
+                          </a:solidFill>
+                          <a:latin typeface="Calibri" pitchFamily="34" charset="0"/>
+                          <a:ea typeface="Calibri" pitchFamily="34" charset="-122"/>
+                          <a:cs typeface="Calibri" pitchFamily="34" charset="-120"/>
+                        </a:rPr>
+                        <a:t>12.5 / 60.6</a:t>
+                      </a:r>
+                      <a:endParaRPr lang="en-US" sz="1050" dirty="0">
+                        <a:latin typeface="Calibri" charset="0"/>
+                        <a:ea typeface="Calibri" charset="0"/>
+                        <a:cs typeface="Calibri" charset="0"/>
+                      </a:endParaRPr>
+                    </a:p>
+                  </a:txBody>
+                  <a:tcPr marL="91440" marR="91440" marT="36576" marB="36576" anchor="ctr">
+                    <a:lnL w="9525" cap="flat" cmpd="sng" algn="ctr">
+                      <a:solidFill>
+                        <a:srgbClr val="E5E7EB"/>
+                      </a:solidFill>
+                      <a:prstDash val="solid"/>
+                      <a:round/>
+                      <a:headEnd type="none" w="med" len="med"/>
+                      <a:tailEnd type="none" w="med" len="med"/>
+                    </a:lnL>
+                    <a:lnR w="9525" cap="flat" cmpd="sng" algn="ctr">
+                      <a:solidFill>
+                        <a:srgbClr val="E5E7EB"/>
+                      </a:solidFill>
+                      <a:prstDash val="solid"/>
+                      <a:round/>
+                      <a:headEnd type="none" w="med" len="med"/>
+                      <a:tailEnd type="none" w="med" len="med"/>
+                    </a:lnR>
+                    <a:lnT w="9525" cap="flat" cmpd="sng" algn="ctr">
+                      <a:solidFill>
+                        <a:srgbClr val="E5E7EB"/>
+                      </a:solidFill>
+                      <a:prstDash val="solid"/>
+                      <a:round/>
+                      <a:headEnd type="none" w="med" len="med"/>
+                      <a:tailEnd type="none" w="med" len="med"/>
+                    </a:lnT>
+                    <a:lnB w="9525" cap="flat" cmpd="sng" algn="ctr">
+                      <a:solidFill>
+                        <a:srgbClr val="E5E7EB"/>
+                      </a:solidFill>
+                      <a:prstDash val="solid"/>
+                      <a:round/>
+                      <a:headEnd type="none" w="med" len="med"/>
+                      <a:tailEnd type="none" w="med" len="med"/>
+                    </a:lnB>
+                    <a:solidFill>
+                      <a:srgbClr val="FEF2F2"/>
+                    </a:solidFill>
+                  </a:tcPr>
+                </a:tc>
+                <a:tc>
+                  <a:txBody>
+                    <a:bodyPr/>
+                    <a:lstStyle/>
+                    <a:p>
+                      <a:pPr algn="r" indent="0" marL="0">
+                        <a:buNone/>
+                      </a:pPr>
+                      <a:r>
+                        <a:rPr lang="en-US" sz="1050" dirty="0">
+                          <a:solidFill>
+                            <a:srgbClr val="111827"/>
+                          </a:solidFill>
+                          <a:latin typeface="Calibri" pitchFamily="34" charset="0"/>
+                          <a:ea typeface="Calibri" pitchFamily="34" charset="-122"/>
+                          <a:cs typeface="Calibri" pitchFamily="34" charset="-120"/>
+                        </a:rPr>
+                        <a:t>0.0 / 45.1</a:t>
+                      </a:r>
+                      <a:endParaRPr lang="en-US" sz="1050" dirty="0">
+                        <a:latin typeface="Calibri" charset="0"/>
+                        <a:ea typeface="Calibri" charset="0"/>
+                        <a:cs typeface="Calibri" charset="0"/>
+                      </a:endParaRPr>
+                    </a:p>
+                  </a:txBody>
+                  <a:tcPr marL="91440" marR="91440" marT="36576" marB="36576" anchor="ctr">
+                    <a:lnL w="9525" cap="flat" cmpd="sng" algn="ctr">
+                      <a:solidFill>
+                        <a:srgbClr val="E5E7EB"/>
+                      </a:solidFill>
+                      <a:prstDash val="solid"/>
+                      <a:round/>
+                      <a:headEnd type="none" w="med" len="med"/>
+                      <a:tailEnd type="none" w="med" len="med"/>
+                    </a:lnL>
+                    <a:lnR w="9525" cap="flat" cmpd="sng" algn="ctr">
+                      <a:solidFill>
+                        <a:srgbClr val="E5E7EB"/>
+                      </a:solidFill>
+                      <a:prstDash val="solid"/>
+                      <a:round/>
+                      <a:headEnd type="none" w="med" len="med"/>
+                      <a:tailEnd type="none" w="med" len="med"/>
+                    </a:lnR>
+                    <a:lnT w="9525" cap="flat" cmpd="sng" algn="ctr">
+                      <a:solidFill>
+                        <a:srgbClr val="E5E7EB"/>
+                      </a:solidFill>
+                      <a:prstDash val="solid"/>
+                      <a:round/>
+                      <a:headEnd type="none" w="med" len="med"/>
+                      <a:tailEnd type="none" w="med" len="med"/>
+                    </a:lnT>
+                    <a:lnB w="9525" cap="flat" cmpd="sng" algn="ctr">
+                      <a:solidFill>
+                        <a:srgbClr val="E5E7EB"/>
+                      </a:solidFill>
+                      <a:prstDash val="solid"/>
+                      <a:round/>
+                      <a:headEnd type="none" w="med" len="med"/>
+                      <a:tailEnd type="none" w="med" len="med"/>
+                    </a:lnB>
+                    <a:solidFill>
+                      <a:srgbClr val="FEF2F2"/>
+                    </a:solidFill>
+                  </a:tcPr>
+                </a:tc>
+                <a:tc>
+                  <a:txBody>
+                    <a:bodyPr/>
+                    <a:lstStyle/>
+                    <a:p>
+                      <a:pPr algn="r" indent="0" marL="0">
+                        <a:buNone/>
+                      </a:pPr>
+                      <a:r>
+                        <a:rPr lang="en-US" sz="1050" b="1" dirty="0">
+                          <a:solidFill>
+                            <a:srgbClr val="111827"/>
+                          </a:solidFill>
+                          <a:latin typeface="Calibri" pitchFamily="34" charset="0"/>
+                          <a:ea typeface="Calibri" pitchFamily="34" charset="-122"/>
+                          <a:cs typeface="Calibri" pitchFamily="34" charset="-120"/>
+                        </a:rPr>
+                        <a:t>0.0 / 42.4</a:t>
+                      </a:r>
+                      <a:endParaRPr lang="en-US" sz="1050" dirty="0">
+                        <a:latin typeface="Calibri" charset="0"/>
+                        <a:ea typeface="Calibri" charset="0"/>
+                        <a:cs typeface="Calibri" charset="0"/>
+                      </a:endParaRPr>
+                    </a:p>
+                  </a:txBody>
+                  <a:tcPr marL="91440" marR="91440" marT="36576" marB="36576" anchor="ctr">
+                    <a:lnL w="9525" cap="flat" cmpd="sng" algn="ctr">
+                      <a:solidFill>
+                        <a:srgbClr val="E5E7EB"/>
+                      </a:solidFill>
+                      <a:prstDash val="solid"/>
+                      <a:round/>
+                      <a:headEnd type="none" w="med" len="med"/>
+                      <a:tailEnd type="none" w="med" len="med"/>
+                    </a:lnL>
+                    <a:lnR w="9525" cap="flat" cmpd="sng" algn="ctr">
+                      <a:solidFill>
+                        <a:srgbClr val="E5E7EB"/>
+                      </a:solidFill>
+                      <a:prstDash val="solid"/>
+                      <a:round/>
+                      <a:headEnd type="none" w="med" len="med"/>
+                      <a:tailEnd type="none" w="med" len="med"/>
+                    </a:lnR>
+                    <a:lnT w="9525" cap="flat" cmpd="sng" algn="ctr">
+                      <a:solidFill>
+                        <a:srgbClr val="E5E7EB"/>
+                      </a:solidFill>
+                      <a:prstDash val="solid"/>
+                      <a:round/>
+                      <a:headEnd type="none" w="med" len="med"/>
+                      <a:tailEnd type="none" w="med" len="med"/>
+                    </a:lnT>
+                    <a:lnB w="9525" cap="flat" cmpd="sng" algn="ctr">
+                      <a:solidFill>
+                        <a:srgbClr val="E5E7EB"/>
+                      </a:solidFill>
+                      <a:prstDash val="solid"/>
+                      <a:round/>
+                      <a:headEnd type="none" w="med" len="med"/>
+                      <a:tailEnd type="none" w="med" len="med"/>
+                    </a:lnB>
+                    <a:solidFill>
+                      <a:srgbClr val="FEF2F2"/>
+                    </a:solidFill>
+                  </a:tcPr>
+                </a:tc>
+              </a:tr>
+              <a:tr h="274320">
+                <a:tc>
+                  <a:txBody>
+                    <a:bodyPr/>
+                    <a:lstStyle/>
+                    <a:p>
+                      <a:pPr indent="0" marL="0">
+                        <a:buNone/>
+                      </a:pPr>
+                      <a:r>
+                        <a:rPr lang="en-US" sz="1050" b="1" dirty="0">
+                          <a:solidFill>
+                            <a:srgbClr val="111827"/>
+                          </a:solidFill>
+                          <a:latin typeface="Calibri" pitchFamily="34" charset="0"/>
+                          <a:ea typeface="Calibri" pitchFamily="34" charset="-122"/>
+                          <a:cs typeface="Calibri" pitchFamily="34" charset="-120"/>
+                        </a:rPr>
+                        <a:t>Windsor</a:t>
+                      </a:r>
+                      <a:endParaRPr lang="en-US" sz="1050" dirty="0">
+                        <a:latin typeface="Calibri" charset="0"/>
+                        <a:ea typeface="Calibri" charset="0"/>
+                        <a:cs typeface="Calibri" charset="0"/>
+                      </a:endParaRPr>
+                    </a:p>
+                  </a:txBody>
+                  <a:tcPr marL="91440" marR="91440" marT="36576" marB="36576" anchor="ctr">
+                    <a:lnL w="9525" cap="flat" cmpd="sng" algn="ctr">
+                      <a:solidFill>
+                        <a:srgbClr val="E5E7EB"/>
+                      </a:solidFill>
+                      <a:prstDash val="solid"/>
+                      <a:round/>
+                      <a:headEnd type="none" w="med" len="med"/>
+                      <a:tailEnd type="none" w="med" len="med"/>
+                    </a:lnL>
+                    <a:lnR w="9525" cap="flat" cmpd="sng" algn="ctr">
+                      <a:solidFill>
+                        <a:srgbClr val="E5E7EB"/>
+                      </a:solidFill>
+                      <a:prstDash val="solid"/>
+                      <a:round/>
+                      <a:headEnd type="none" w="med" len="med"/>
+                      <a:tailEnd type="none" w="med" len="med"/>
+                    </a:lnR>
+                    <a:lnT w="9525" cap="flat" cmpd="sng" algn="ctr">
+                      <a:solidFill>
+                        <a:srgbClr val="E5E7EB"/>
+                      </a:solidFill>
+                      <a:prstDash val="solid"/>
+                      <a:round/>
+                      <a:headEnd type="none" w="med" len="med"/>
+                      <a:tailEnd type="none" w="med" len="med"/>
+                    </a:lnT>
+                    <a:lnB w="9525" cap="flat" cmpd="sng" algn="ctr">
+                      <a:solidFill>
+                        <a:srgbClr val="E5E7EB"/>
+                      </a:solidFill>
+                      <a:prstDash val="solid"/>
+                      <a:round/>
+                      <a:headEnd type="none" w="med" len="med"/>
+                      <a:tailEnd type="none" w="med" len="med"/>
+                    </a:lnB>
+                    <a:solidFill>
+                      <a:srgbClr val="FEF2F2"/>
+                    </a:solidFill>
+                  </a:tcPr>
+                </a:tc>
+                <a:tc>
+                  <a:txBody>
+                    <a:bodyPr/>
+                    <a:lstStyle/>
+                    <a:p>
+                      <a:pPr algn="r" indent="0" marL="0">
+                        <a:buNone/>
+                      </a:pPr>
+                      <a:r>
+                        <a:rPr lang="en-US" sz="1050" dirty="0">
+                          <a:solidFill>
+                            <a:srgbClr val="111827"/>
+                          </a:solidFill>
+                          <a:latin typeface="Calibri" pitchFamily="34" charset="0"/>
+                          <a:ea typeface="Calibri" pitchFamily="34" charset="-122"/>
+                          <a:cs typeface="Calibri" pitchFamily="34" charset="-120"/>
+                        </a:rPr>
+                        <a:t>6.7 / 38.5</a:t>
+                      </a:r>
+                      <a:endParaRPr lang="en-US" sz="1050" dirty="0">
+                        <a:latin typeface="Calibri" charset="0"/>
+                        <a:ea typeface="Calibri" charset="0"/>
+                        <a:cs typeface="Calibri" charset="0"/>
+                      </a:endParaRPr>
+                    </a:p>
+                  </a:txBody>
+                  <a:tcPr marL="91440" marR="91440" marT="36576" marB="36576" anchor="ctr">
+                    <a:lnL w="9525" cap="flat" cmpd="sng" algn="ctr">
+                      <a:solidFill>
+                        <a:srgbClr val="E5E7EB"/>
+                      </a:solidFill>
+                      <a:prstDash val="solid"/>
+                      <a:round/>
+                      <a:headEnd type="none" w="med" len="med"/>
+                      <a:tailEnd type="none" w="med" len="med"/>
+                    </a:lnL>
+                    <a:lnR w="9525" cap="flat" cmpd="sng" algn="ctr">
+                      <a:solidFill>
+                        <a:srgbClr val="E5E7EB"/>
+                      </a:solidFill>
+                      <a:prstDash val="solid"/>
+                      <a:round/>
+                      <a:headEnd type="none" w="med" len="med"/>
+                      <a:tailEnd type="none" w="med" len="med"/>
+                    </a:lnR>
+                    <a:lnT w="9525" cap="flat" cmpd="sng" algn="ctr">
+                      <a:solidFill>
+                        <a:srgbClr val="E5E7EB"/>
+                      </a:solidFill>
+                      <a:prstDash val="solid"/>
+                      <a:round/>
+                      <a:headEnd type="none" w="med" len="med"/>
+                      <a:tailEnd type="none" w="med" len="med"/>
+                    </a:lnT>
+                    <a:lnB w="9525" cap="flat" cmpd="sng" algn="ctr">
+                      <a:solidFill>
+                        <a:srgbClr val="E5E7EB"/>
+                      </a:solidFill>
+                      <a:prstDash val="solid"/>
+                      <a:round/>
+                      <a:headEnd type="none" w="med" len="med"/>
+                      <a:tailEnd type="none" w="med" len="med"/>
+                    </a:lnB>
+                    <a:solidFill>
+                      <a:srgbClr val="FEF2F2"/>
+                    </a:solidFill>
+                  </a:tcPr>
+                </a:tc>
+                <a:tc>
+                  <a:txBody>
+                    <a:bodyPr/>
+                    <a:lstStyle/>
+                    <a:p>
+                      <a:pPr algn="r" indent="0" marL="0">
+                        <a:buNone/>
+                      </a:pPr>
+                      <a:r>
+                        <a:rPr lang="en-US" sz="1050" dirty="0">
+                          <a:solidFill>
+                            <a:srgbClr val="111827"/>
+                          </a:solidFill>
+                          <a:latin typeface="Calibri" pitchFamily="34" charset="0"/>
+                          <a:ea typeface="Calibri" pitchFamily="34" charset="-122"/>
+                          <a:cs typeface="Calibri" pitchFamily="34" charset="-120"/>
+                        </a:rPr>
+                        <a:t>0.0 / 36.6</a:t>
+                      </a:r>
+                      <a:endParaRPr lang="en-US" sz="1050" dirty="0">
+                        <a:latin typeface="Calibri" charset="0"/>
+                        <a:ea typeface="Calibri" charset="0"/>
+                        <a:cs typeface="Calibri" charset="0"/>
+                      </a:endParaRPr>
+                    </a:p>
+                  </a:txBody>
+                  <a:tcPr marL="91440" marR="91440" marT="36576" marB="36576" anchor="ctr">
+                    <a:lnL w="9525" cap="flat" cmpd="sng" algn="ctr">
+                      <a:solidFill>
+                        <a:srgbClr val="E5E7EB"/>
+                      </a:solidFill>
+                      <a:prstDash val="solid"/>
+                      <a:round/>
+                      <a:headEnd type="none" w="med" len="med"/>
+                      <a:tailEnd type="none" w="med" len="med"/>
+                    </a:lnL>
+                    <a:lnR w="9525" cap="flat" cmpd="sng" algn="ctr">
+                      <a:solidFill>
+                        <a:srgbClr val="E5E7EB"/>
+                      </a:solidFill>
+                      <a:prstDash val="solid"/>
+                      <a:round/>
+                      <a:headEnd type="none" w="med" len="med"/>
+                      <a:tailEnd type="none" w="med" len="med"/>
+                    </a:lnR>
+                    <a:lnT w="9525" cap="flat" cmpd="sng" algn="ctr">
+                      <a:solidFill>
+                        <a:srgbClr val="E5E7EB"/>
+                      </a:solidFill>
+                      <a:prstDash val="solid"/>
+                      <a:round/>
+                      <a:headEnd type="none" w="med" len="med"/>
+                      <a:tailEnd type="none" w="med" len="med"/>
+                    </a:lnT>
+                    <a:lnB w="9525" cap="flat" cmpd="sng" algn="ctr">
+                      <a:solidFill>
+                        <a:srgbClr val="E5E7EB"/>
+                      </a:solidFill>
+                      <a:prstDash val="solid"/>
+                      <a:round/>
+                      <a:headEnd type="none" w="med" len="med"/>
+                      <a:tailEnd type="none" w="med" len="med"/>
+                    </a:lnB>
+                    <a:solidFill>
+                      <a:srgbClr val="FEF2F2"/>
+                    </a:solidFill>
+                  </a:tcPr>
+                </a:tc>
+                <a:tc>
+                  <a:txBody>
+                    <a:bodyPr/>
+                    <a:lstStyle/>
+                    <a:p>
+                      <a:pPr algn="r" indent="0" marL="0">
+                        <a:buNone/>
+                      </a:pPr>
+                      <a:r>
+                        <a:rPr lang="en-US" sz="1050" b="1" dirty="0">
+                          <a:solidFill>
+                            <a:srgbClr val="111827"/>
+                          </a:solidFill>
+                          <a:latin typeface="Calibri" pitchFamily="34" charset="0"/>
+                          <a:ea typeface="Calibri" pitchFamily="34" charset="-122"/>
+                          <a:cs typeface="Calibri" pitchFamily="34" charset="-120"/>
+                        </a:rPr>
+                        <a:t>0.0 / 33.5</a:t>
+                      </a:r>
+                      <a:endParaRPr lang="en-US" sz="1050" dirty="0">
+                        <a:latin typeface="Calibri" charset="0"/>
+                        <a:ea typeface="Calibri" charset="0"/>
+                        <a:cs typeface="Calibri" charset="0"/>
+                      </a:endParaRPr>
+                    </a:p>
+                  </a:txBody>
+                  <a:tcPr marL="91440" marR="91440" marT="36576" marB="36576" anchor="ctr">
+                    <a:lnL w="9525" cap="flat" cmpd="sng" algn="ctr">
+                      <a:solidFill>
+                        <a:srgbClr val="E5E7EB"/>
+                      </a:solidFill>
+                      <a:prstDash val="solid"/>
+                      <a:round/>
+                      <a:headEnd type="none" w="med" len="med"/>
+                      <a:tailEnd type="none" w="med" len="med"/>
+                    </a:lnL>
+                    <a:lnR w="9525" cap="flat" cmpd="sng" algn="ctr">
+                      <a:solidFill>
+                        <a:srgbClr val="E5E7EB"/>
+                      </a:solidFill>
+                      <a:prstDash val="solid"/>
+                      <a:round/>
+                      <a:headEnd type="none" w="med" len="med"/>
+                      <a:tailEnd type="none" w="med" len="med"/>
+                    </a:lnR>
+                    <a:lnT w="9525" cap="flat" cmpd="sng" algn="ctr">
+                      <a:solidFill>
+                        <a:srgbClr val="E5E7EB"/>
+                      </a:solidFill>
+                      <a:prstDash val="solid"/>
+                      <a:round/>
+                      <a:headEnd type="none" w="med" len="med"/>
+                      <a:tailEnd type="none" w="med" len="med"/>
+                    </a:lnT>
+                    <a:lnB w="9525" cap="flat" cmpd="sng" algn="ctr">
+                      <a:solidFill>
+                        <a:srgbClr val="E5E7EB"/>
+                      </a:solidFill>
+                      <a:prstDash val="solid"/>
+                      <a:round/>
+                      <a:headEnd type="none" w="med" len="med"/>
+                      <a:tailEnd type="none" w="med" len="med"/>
+                    </a:lnB>
+                    <a:solidFill>
+                      <a:srgbClr val="FEF2F2"/>
+                    </a:solidFill>
+                  </a:tcPr>
+                </a:tc>
+              </a:tr>
+            </a:tbl>
+          </a:graphicData>
+        </a:graphic>
+      </p:graphicFrame>
+      <p:sp>
+        <p:nvSpPr>
+          <p:cNvPr id="24" name="Text 20"/>
           <p:cNvSpPr txBox="1"/>
           <p:nvPr/>
         </p:nvSpPr>
         <p:spPr>
           <a:xfrm>
-            <a:off x="9301734" y="3493008"/>
-            <a:ext cx="2109978" cy="228600"/>
+            <a:off x="5074920" y="4956048"/>
+            <a:ext cx="6565392" cy="237744"/>
           </a:xfrm>
           <a:prstGeom prst="rect">
             <a:avLst/>
@@ -29495,7 +31357,7 @@
               <a:buNone/>
             </a:pPr>
             <a:r>
-              <a:rPr lang="en-US" sz="1100" dirty="0">
+              <a:rPr lang="en-US" sz="950" i="1" dirty="0">
                 <a:solidFill>
                   <a:srgbClr val="6B7280"/>
                 </a:solidFill>
@@ -29503,143 +31365,26 @@
                 <a:ea typeface="Calibri" pitchFamily="34" charset="-122"/>
                 <a:cs typeface="Calibri" pitchFamily="34" charset="-120"/>
               </a:rPr>
-              <a:t>Target 80%</a:t>
-            </a:r>
-            <a:endParaRPr lang="en-US" sz="1100" dirty="0"/>
-          </a:p>
-        </p:txBody>
-      </p:sp>
-      <p:sp>
-        <p:nvSpPr>
-          <p:cNvPr id="42" name="Text 40"/>
-          <p:cNvSpPr txBox="1"/>
-          <p:nvPr/>
-        </p:nvSpPr>
-        <p:spPr>
-          <a:xfrm>
-            <a:off x="9301734" y="3886200"/>
-            <a:ext cx="2109978" cy="274320"/>
-          </a:xfrm>
-          <a:prstGeom prst="rect">
-            <a:avLst/>
-          </a:prstGeom>
-          <a:noFill/>
-          <a:ln/>
-        </p:spPr>
-        <p:txBody>
-          <a:bodyPr wrap="square" lIns="0" tIns="0" rIns="0" bIns="0" rtlCol="0" anchor="ctr"/>
-          <a:lstStyle/>
-          <a:p>
-            <a:pPr indent="0" marL="0">
-              <a:buNone/>
-            </a:pPr>
-            <a:r>
-              <a:rPr lang="en-US" sz="1200" b="1" dirty="0">
-                <a:solidFill>
-                  <a:srgbClr val="6B7280"/>
-                </a:solidFill>
-                <a:latin typeface="Calibri" pitchFamily="34" charset="0"/>
-                <a:ea typeface="Calibri" pitchFamily="34" charset="-122"/>
-                <a:cs typeface="Calibri" pitchFamily="34" charset="-120"/>
-              </a:rPr>
-              <a:t>Load %</a:t>
-            </a:r>
-            <a:endParaRPr lang="en-US" sz="1200" dirty="0"/>
-          </a:p>
-        </p:txBody>
-      </p:sp>
-      <p:sp>
-        <p:nvSpPr>
-          <p:cNvPr id="43" name="Text 41"/>
-          <p:cNvSpPr txBox="1"/>
-          <p:nvPr/>
-        </p:nvSpPr>
-        <p:spPr>
-          <a:xfrm>
-            <a:off x="9301734" y="4133088"/>
-            <a:ext cx="2109978" cy="594360"/>
-          </a:xfrm>
-          <a:prstGeom prst="rect">
-            <a:avLst/>
-          </a:prstGeom>
-          <a:noFill/>
-          <a:ln/>
-        </p:spPr>
-        <p:txBody>
-          <a:bodyPr wrap="square" lIns="0" tIns="0" rIns="0" bIns="0" rtlCol="0" anchor="ctr"/>
-          <a:lstStyle/>
-          <a:p>
-            <a:pPr indent="0" marL="0">
-              <a:buNone/>
-            </a:pPr>
-            <a:r>
-              <a:rPr lang="en-US" sz="3200" b="1" dirty="0">
-                <a:solidFill>
-                  <a:srgbClr val="D97706"/>
-                </a:solidFill>
-                <a:latin typeface="Calibri" pitchFamily="34" charset="0"/>
-                <a:ea typeface="Calibri" pitchFamily="34" charset="-122"/>
-                <a:cs typeface="Calibri" pitchFamily="34" charset="-120"/>
-              </a:rPr>
-              <a:t>TBC</a:t>
-            </a:r>
-            <a:endParaRPr lang="en-US" sz="3200" dirty="0"/>
-          </a:p>
-        </p:txBody>
-      </p:sp>
-      <p:sp>
-        <p:nvSpPr>
-          <p:cNvPr id="44" name="Text 42"/>
-          <p:cNvSpPr txBox="1"/>
-          <p:nvPr/>
-        </p:nvSpPr>
-        <p:spPr>
-          <a:xfrm>
-            <a:off x="9301734" y="4727448"/>
-            <a:ext cx="2109978" cy="228600"/>
-          </a:xfrm>
-          <a:prstGeom prst="rect">
-            <a:avLst/>
-          </a:prstGeom>
-          <a:noFill/>
-          <a:ln/>
-        </p:spPr>
-        <p:txBody>
-          <a:bodyPr wrap="square" lIns="0" tIns="0" rIns="0" bIns="0" rtlCol="0" anchor="ctr"/>
-          <a:lstStyle/>
-          <a:p>
-            <a:pPr indent="0" marL="0">
-              <a:buNone/>
-            </a:pPr>
-            <a:r>
-              <a:rPr lang="en-US" sz="1100" dirty="0">
-                <a:solidFill>
-                  <a:srgbClr val="6B7280"/>
-                </a:solidFill>
-                <a:latin typeface="Calibri" pitchFamily="34" charset="0"/>
-                <a:ea typeface="Calibri" pitchFamily="34" charset="-122"/>
-                <a:cs typeface="Calibri" pitchFamily="34" charset="-120"/>
-              </a:rPr>
-              <a:t>Target 98%</a:t>
-            </a:r>
-            <a:endParaRPr lang="en-US" sz="1100" dirty="0"/>
-          </a:p>
-        </p:txBody>
-      </p:sp>
-      <p:sp>
-        <p:nvSpPr>
-          <p:cNvPr id="45" name="Shape 43"/>
+              <a:t>Green = strongest · red = lightest · Edmonton, Montreal, Woodstock, Ottawa in full report</a:t>
+            </a:r>
+            <a:endParaRPr lang="en-US" sz="950" dirty="0"/>
+          </a:p>
+        </p:txBody>
+      </p:sp>
+      <p:sp>
+        <p:nvSpPr>
+          <p:cNvPr id="25" name="Shape 21"/>
           <p:cNvSpPr/>
           <p:nvPr/>
         </p:nvSpPr>
         <p:spPr>
           <a:xfrm>
-            <a:off x="548640" y="5303520"/>
-            <a:ext cx="11091672" cy="868680"/>
+            <a:off x="548640" y="5285232"/>
+            <a:ext cx="11091672" cy="804672"/>
           </a:xfrm>
           <a:prstGeom prst="roundRect">
             <a:avLst>
-              <a:gd name="adj" fmla="val 8421"/>
+              <a:gd name="adj" fmla="val 9091"/>
             </a:avLst>
           </a:prstGeom>
           <a:solidFill>
@@ -29655,63 +31400,14 @@
       </p:sp>
       <p:sp>
         <p:nvSpPr>
-          <p:cNvPr id="46" name="Shape 44"/>
-          <p:cNvSpPr/>
-          <p:nvPr/>
-        </p:nvSpPr>
-        <p:spPr>
-          <a:xfrm>
-            <a:off x="777240" y="5477256"/>
-            <a:ext cx="512064" cy="512064"/>
-          </a:xfrm>
-          <a:prstGeom prst="ellipse">
-            <a:avLst/>
-          </a:prstGeom>
-          <a:solidFill>
-            <a:srgbClr val="7C3AED"/>
-          </a:solidFill>
-          <a:ln w="12700">
-            <a:solidFill>
-              <a:srgbClr val="7C3AED"/>
-            </a:solidFill>
-            <a:prstDash val="solid"/>
-          </a:ln>
-        </p:spPr>
-      </p:sp>
-      <p:pic>
-        <p:nvPicPr>
-          <p:cNvPr id="47" name="Image 0" descr="preencoded.png">    </p:cNvPr>
-          <p:cNvPicPr>
-            <a:picLocks noChangeAspect="1"/>
-          </p:cNvPicPr>
-          <p:nvPr/>
-        </p:nvPicPr>
-        <p:blipFill>
-          <a:blip r:embed="rId1"/>
-          <a:stretch>
-            <a:fillRect/>
-          </a:stretch>
-        </p:blipFill>
-        <p:spPr>
-          <a:xfrm>
-            <a:off x="905256" y="5605272"/>
-            <a:ext cx="256032" cy="256032"/>
-          </a:xfrm>
-          <a:prstGeom prst="rect">
-            <a:avLst/>
-          </a:prstGeom>
-        </p:spPr>
-      </p:pic>
-      <p:sp>
-        <p:nvSpPr>
-          <p:cNvPr id="48" name="Text 45"/>
+          <p:cNvPr id="26" name="Text 22"/>
           <p:cNvSpPr txBox="1"/>
           <p:nvPr/>
         </p:nvSpPr>
         <p:spPr>
           <a:xfrm>
-            <a:off x="1508760" y="5303520"/>
-            <a:ext cx="9966960" cy="868680"/>
+            <a:off x="731520" y="5303520"/>
+            <a:ext cx="10744200" cy="768096"/>
           </a:xfrm>
           <a:prstGeom prst="rect">
             <a:avLst/>
@@ -29727,7 +31423,7 @@
               <a:buNone/>
             </a:pPr>
             <a:r>
-              <a:rPr lang="en-US" sz="1500" b="1" dirty="0">
+              <a:rPr lang="en-US" sz="1100" b="1" dirty="0">
                 <a:solidFill>
                   <a:srgbClr val="111827"/>
                 </a:solidFill>
@@ -29735,29 +31431,54 @@
                 <a:ea typeface="Calibri" pitchFamily="34" charset="-122"/>
                 <a:cs typeface="Calibri" pitchFamily="34" charset="-120"/>
               </a:rPr>
-              <a:t>Load factor &amp; trailer consolidation  ·  </a:t>
-            </a:r>
+              <a:t>Load factor is the biggest open opportunity: LF score 36.4% F27 to date. Western lanes are strong (Burnaby 89.5% in Sept); Windsor, Quebec City and Dartmouth run consistently light — consolidation / frequency review. Moncton accounts for 1,771 of 3,166 bills with no cube (56%, calculated) — fixing cube capture will lift that lane's measured LF.</a:t>
+            </a:r>
+            <a:endParaRPr lang="en-US" sz="1100" dirty="0"/>
+          </a:p>
+        </p:txBody>
+      </p:sp>
+      <p:sp>
+        <p:nvSpPr>
+          <p:cNvPr id="27" name="Text 23"/>
+          <p:cNvSpPr txBox="1"/>
+          <p:nvPr/>
+        </p:nvSpPr>
+        <p:spPr>
+          <a:xfrm>
+            <a:off x="548640" y="6163056"/>
+            <a:ext cx="11091672" cy="228600"/>
+          </a:xfrm>
+          <a:prstGeom prst="rect">
+            <a:avLst/>
+          </a:prstGeom>
+          <a:noFill/>
+          <a:ln/>
+        </p:spPr>
+        <p:txBody>
+          <a:bodyPr wrap="square" lIns="0" tIns="0" rIns="0" bIns="0" rtlCol="0" anchor="ctr"/>
+          <a:lstStyle/>
+          <a:p>
             <a:pPr indent="0" marL="0">
               <a:buNone/>
             </a:pPr>
             <a:r>
-              <a:rPr lang="en-US" sz="1500" dirty="0">
-                <a:solidFill>
-                  <a:srgbClr val="1F2937"/>
-                </a:solidFill>
-                <a:latin typeface="Calibri" pitchFamily="34" charset="0"/>
-                <a:ea typeface="Calibri" pitchFamily="34" charset="-122"/>
-                <a:cs typeface="Calibri" pitchFamily="34" charset="-120"/>
-              </a:rPr>
-              <a:t>Consolidating large-customer freight into fewer trailers.</a:t>
-            </a:r>
-            <a:endParaRPr lang="en-US" sz="1500" dirty="0"/>
-          </a:p>
-        </p:txBody>
-      </p:sp>
-      <p:sp>
-        <p:nvSpPr>
-          <p:cNvPr id="49" name="Text 46"/>
+              <a:rPr lang="en-US" sz="900" i="1" dirty="0">
+                <a:solidFill>
+                  <a:srgbClr val="6B7280"/>
+                </a:solidFill>
+                <a:latin typeface="Calibri" pitchFamily="34" charset="0"/>
+                <a:ea typeface="Calibri" pitchFamily="34" charset="-122"/>
+                <a:cs typeface="Calibri" pitchFamily="34" charset="-120"/>
+              </a:rPr>
+              <a:t>Source: Load factor report — Mississauga outbound, F27 Jul–Sep (ready date: all).</a:t>
+            </a:r>
+            <a:endParaRPr lang="en-US" sz="900" dirty="0"/>
+          </a:p>
+        </p:txBody>
+      </p:sp>
+      <p:sp>
+        <p:nvSpPr>
+          <p:cNvPr id="28" name="Text 24"/>
           <p:cNvSpPr txBox="1"/>
           <p:nvPr/>
         </p:nvSpPr>
@@ -29796,7 +31517,7 @@
       </p:sp>
       <p:sp>
         <p:nvSpPr>
-          <p:cNvPr id="50" name="Text 47"/>
+          <p:cNvPr id="29" name="Text 25"/>
           <p:cNvSpPr txBox="1"/>
           <p:nvPr/>
         </p:nvSpPr>

</xml_diff>

<commit_message>
Deck: add load factor excluding-Moncton / distance band slide (23 slides)
Co-Authored-By: Claude Opus 5.5 <noreply@anthropic.com>
Claude-Session: https://claude.ai/code/session_01BwRjju3y2wk3wSHFrM9KLe
</commit_message>
<xml_diff>
--- a/presentation/Mississauga_F27_Leadership_Review_Sep29.pptx
+++ b/presentation/Mississauga_F27_Leadership_Review_Sep29.pptx
@@ -27,9 +27,10 @@
     <p:sldId id="275" r:id="rId21"/>
     <p:sldId id="276" r:id="rId22"/>
     <p:sldId id="277" r:id="rId23"/>
+    <p:sldId id="278" r:id="rId24"/>
   </p:sldIdLst>
   <p:notesMasterIdLst>
-    <p:notesMasterId r:id="rId24"/>
+    <p:notesMasterId r:id="rId25"/>
   </p:notesMasterIdLst>
   <p:sldSz cx="12192000" cy="6858000"/>
   <p:notesSz cx="6858000" cy="12192000"/>
@@ -1534,6 +1535,369 @@
 </c:chartSpace>
 </file>
 
+<file path=ppt/charts/chart12.xml><?xml version="1.0" encoding="utf-8"?>
+<c:chartSpace xmlns:c="http://schemas.openxmlformats.org/drawingml/2006/chart" xmlns:a="http://schemas.openxmlformats.org/drawingml/2006/main" xmlns:r="http://schemas.openxmlformats.org/officeDocument/2006/relationships">
+  <c:date1904 val="0"/>
+  <c:roundedCorners val="1"/>
+  <c:chart>
+    <c:title>
+      <c:tx>
+        <c:rich>
+          <a:bodyPr/>
+          <a:lstStyle/>
+          <a:p>
+            <a:pPr>
+              <a:defRPr sz="1100" b="0" i="0" u="none" strike="noStrike">
+                <a:solidFill>
+                  <a:srgbClr val="111827"/>
+                </a:solidFill>
+                <a:latin typeface="Calibri"/>
+              </a:defRPr>
+            </a:pPr>
+            <a:r>
+              <a:rPr sz="1100" b="0" i="0" u="none" strike="noStrike">
+                <a:solidFill>
+                  <a:srgbClr val="111827"/>
+                </a:solidFill>
+                <a:latin typeface="Calibri"/>
+              </a:rPr>
+              <a:t>By distance band (report bands) · F27</a:t>
+            </a:r>
+          </a:p>
+        </c:rich>
+      </c:tx>
+      <c:layout/>
+      <c:overlay val="0"/>
+    </c:title>
+    <c:autoTitleDeleted val="0"/>
+    <c:plotArea>
+      <c:layout/>
+      <c:barChart>
+        <c:barDir val="col"/>
+        <c:grouping val="clustered"/>
+        <c:varyColors val="0"/>
+        <c:ser>
+          <c:idx val="0"/>
+          <c:order val="0"/>
+          <c:tx>
+            <c:strRef>
+              <c:f>Sheet1!$B$1</c:f>
+              <c:strCache>
+                <c:ptCount val="1"/>
+                <c:pt idx="0">
+                  <c:v>LF score</c:v>
+                </c:pt>
+              </c:strCache>
+            </c:strRef>
+          </c:tx>
+          <c:spPr>
+            <a:solidFill>
+              <a:srgbClr val="7C3AED"/>
+            </a:solidFill>
+            <a:effectLst/>
+          </c:spPr>
+          <c:invertIfNegative val="0"/>
+          <c:dLbls>
+            <c:numFmt formatCode="0.0&quot;%&quot;" sourceLinked="0"/>
+            <c:txPr>
+              <a:bodyPr/>
+              <a:lstStyle/>
+              <a:p>
+                <a:pPr>
+                  <a:defRPr b="0" i="0" strike="noStrike" sz="900" u="none">
+                    <a:solidFill>
+                      <a:srgbClr val="1F2937"/>
+                    </a:solidFill>
+                    <a:latin typeface="Calibri"/>
+                  </a:defRPr>
+                </a:pPr>
+              </a:p>
+            </c:txPr>
+            <c:showLegendKey val="0"/>
+            <c:showVal val="1"/>
+            <c:showCatName val="0"/>
+            <c:showSerName val="0"/>
+            <c:showPercent val="0"/>
+            <c:showBubbleSize val="0"/>
+            <c:showLeaderLines val="0"/>
+          </c:dLbls>
+          <c:cat>
+            <c:multiLvlStrRef>
+              <c:f>Sheet1!$A$2:$A$4</c:f>
+              <c:multiLvlStrCache>
+                <c:ptCount val="3"/>
+                <c:lvl>
+                  <c:pt idx="0">
+                    <c:v>&lt;500 (343 loads)</c:v>
+                  </c:pt>
+                  <c:pt idx="1">
+                    <c:v>&lt;1,000 (212)</c:v>
+                  </c:pt>
+                  <c:pt idx="2">
+                    <c:v>&gt;1,000 (299)</c:v>
+                  </c:pt>
+                </c:lvl>
+              </c:multiLvlStrCache>
+            </c:multiLvlStrRef>
+          </c:cat>
+          <c:val>
+            <c:numRef>
+              <c:f>Sheet1!$B$2:$B$4</c:f>
+              <c:numCache>
+                <c:formatCode>General</c:formatCode>
+                <c:ptCount val="3"/>
+                <c:pt idx="0">
+                  <c:v>32.1</c:v>
+                </c:pt>
+                <c:pt idx="1">
+                  <c:v>18.9</c:v>
+                </c:pt>
+                <c:pt idx="2">
+                  <c:v>53.8</c:v>
+                </c:pt>
+              </c:numCache>
+            </c:numRef>
+          </c:val>
+        </c:ser>
+        <c:ser>
+          <c:idx val="1"/>
+          <c:order val="1"/>
+          <c:tx>
+            <c:strRef>
+              <c:f>Sheet1!$C$1</c:f>
+              <c:strCache>
+                <c:ptCount val="1"/>
+                <c:pt idx="0">
+                  <c:v>Load %</c:v>
+                </c:pt>
+              </c:strCache>
+            </c:strRef>
+          </c:tx>
+          <c:spPr>
+            <a:solidFill>
+              <a:srgbClr val="C4B5FD"/>
+            </a:solidFill>
+            <a:effectLst/>
+          </c:spPr>
+          <c:invertIfNegative val="0"/>
+          <c:dLbls>
+            <c:numFmt formatCode="0.0&quot;%&quot;" sourceLinked="0"/>
+            <c:txPr>
+              <a:bodyPr/>
+              <a:lstStyle/>
+              <a:p>
+                <a:pPr>
+                  <a:defRPr b="0" i="0" strike="noStrike" sz="900" u="none">
+                    <a:solidFill>
+                      <a:srgbClr val="1F2937"/>
+                    </a:solidFill>
+                    <a:latin typeface="Calibri"/>
+                  </a:defRPr>
+                </a:pPr>
+              </a:p>
+            </c:txPr>
+            <c:showLegendKey val="0"/>
+            <c:showVal val="1"/>
+            <c:showCatName val="0"/>
+            <c:showSerName val="0"/>
+            <c:showPercent val="0"/>
+            <c:showBubbleSize val="0"/>
+            <c:showLeaderLines val="0"/>
+          </c:dLbls>
+          <c:cat>
+            <c:multiLvlStrRef>
+              <c:f>Sheet1!$A$2:$A$4</c:f>
+              <c:multiLvlStrCache>
+                <c:ptCount val="3"/>
+                <c:lvl>
+                  <c:pt idx="0">
+                    <c:v>&lt;500 (343 loads)</c:v>
+                  </c:pt>
+                  <c:pt idx="1">
+                    <c:v>&lt;1,000 (212)</c:v>
+                  </c:pt>
+                  <c:pt idx="2">
+                    <c:v>&gt;1,000 (299)</c:v>
+                  </c:pt>
+                </c:lvl>
+              </c:multiLvlStrCache>
+            </c:multiLvlStrRef>
+          </c:cat>
+          <c:val>
+            <c:numRef>
+              <c:f>Sheet1!$C$2:$C$4</c:f>
+              <c:numCache>
+                <c:formatCode>General</c:formatCode>
+                <c:ptCount val="3"/>
+                <c:pt idx="0">
+                  <c:v>71.2</c:v>
+                </c:pt>
+                <c:pt idx="1">
+                  <c:v>65.1</c:v>
+                </c:pt>
+                <c:pt idx="2">
+                  <c:v>86</c:v>
+                </c:pt>
+              </c:numCache>
+            </c:numRef>
+          </c:val>
+        </c:ser>
+        <c:dLbls>
+          <c:numFmt formatCode="0.0&quot;%&quot;" sourceLinked="0"/>
+          <c:txPr>
+            <a:bodyPr/>
+            <a:lstStyle/>
+            <a:p>
+              <a:pPr>
+                <a:defRPr b="0" i="0" strike="noStrike" sz="900" u="none">
+                  <a:solidFill>
+                    <a:srgbClr val="1F2937"/>
+                  </a:solidFill>
+                  <a:latin typeface="Calibri"/>
+                </a:defRPr>
+              </a:pPr>
+            </a:p>
+          </c:txPr>
+          <c:showLegendKey val="0"/>
+          <c:showVal val="1"/>
+          <c:showCatName val="0"/>
+          <c:showSerName val="0"/>
+          <c:showPercent val="0"/>
+          <c:showBubbleSize val="0"/>
+          <c:showLeaderLines val="0"/>
+        </c:dLbls>
+        <c:gapWidth val="50"/>
+        <c:overlap val="0"/>
+        <c:axId val="2094734554"/>
+        <c:axId val="2094734552"/>
+        <c:axId val="2094734556"/>
+      </c:barChart>
+      <c:catAx>
+        <c:axId val="2094734554"/>
+        <c:scaling>
+          <c:orientation val="minMax"/>
+        </c:scaling>
+        <c:delete val="0"/>
+        <c:axPos val="b"/>
+        <c:numFmt formatCode="General" sourceLinked="1"/>
+        <c:majorTickMark val="out"/>
+        <c:minorTickMark val="none"/>
+        <c:tickLblPos val="low"/>
+        <c:spPr>
+          <a:ln w="12700" cap="flat">
+            <a:solidFill>
+              <a:srgbClr val="888888"/>
+            </a:solidFill>
+            <a:prstDash val="solid"/>
+            <a:round/>
+          </a:ln>
+        </c:spPr>
+        <c:txPr>
+          <a:bodyPr/>
+          <a:lstStyle/>
+          <a:p>
+            <a:pPr>
+              <a:defRPr sz="950" b="0" i="0" u="none" strike="noStrike">
+                <a:solidFill>
+                  <a:srgbClr val="1F2937"/>
+                </a:solidFill>
+                <a:latin typeface="Calibri"/>
+              </a:defRPr>
+            </a:pPr>
+            <a:endParaRPr lang="en-US"/>
+          </a:p>
+        </c:txPr>
+        <c:crossAx val="2094734552"/>
+        <c:crosses val="autoZero"/>
+        <c:auto val="1"/>
+        <c:lblAlgn val="ctr"/>
+        <c:noMultiLvlLbl val="1"/>
+      </c:catAx>
+      <c:valAx>
+        <c:axId val="2094734552"/>
+        <c:scaling>
+          <c:orientation val="minMax"/>
+          <c:max val="100"/>
+          <c:min val="0"/>
+        </c:scaling>
+        <c:delete val="1"/>
+        <c:axPos val="l"/>
+        <c:numFmt formatCode="General" sourceLinked="0"/>
+        <c:majorTickMark val="out"/>
+        <c:minorTickMark val="none"/>
+        <c:tickLblPos val="nextTo"/>
+        <c:spPr>
+          <a:ln w="12700" cap="flat">
+            <a:solidFill>
+              <a:srgbClr val="888888"/>
+            </a:solidFill>
+            <a:prstDash val="solid"/>
+            <a:round/>
+          </a:ln>
+        </c:spPr>
+        <c:txPr>
+          <a:bodyPr/>
+          <a:lstStyle/>
+          <a:p>
+            <a:pPr>
+              <a:defRPr sz="1200" b="0" i="0" u="none" strike="noStrike">
+                <a:solidFill>
+                  <a:srgbClr val="000000"/>
+                </a:solidFill>
+                <a:latin typeface="Arial"/>
+              </a:defRPr>
+            </a:pPr>
+            <a:endParaRPr lang="en-US"/>
+          </a:p>
+        </c:txPr>
+        <c:crossAx val="2094734554"/>
+        <c:crosses val="autoZero"/>
+        <c:crossBetween val="between"/>
+      </c:valAx>
+      <c:spPr>
+        <a:noFill/>
+        <a:ln>
+          <a:noFill/>
+        </a:ln>
+        <a:effectLst/>
+      </c:spPr>
+    </c:plotArea>
+    <c:legend>
+      <c:legendPos val="b"/>
+      <c:overlay val="0"/>
+      <c:txPr>
+        <a:bodyPr/>
+        <a:lstStyle/>
+        <a:p>
+          <a:pPr>
+            <a:defRPr sz="900">
+              <a:solidFill>
+                <a:srgbClr val="1F2937"/>
+              </a:solidFill>
+              <a:latin typeface="Calibri"/>
+              <a:cs typeface="Calibri"/>
+            </a:defRPr>
+          </a:pPr>
+          <a:endParaRPr lang="en-US"/>
+        </a:p>
+      </c:txPr>
+    </c:legend>
+    <c:plotVisOnly val="1"/>
+    <c:dispBlanksAs val="span"/>
+  </c:chart>
+  <c:spPr>
+    <a:noFill/>
+    <a:ln>
+      <a:noFill/>
+    </a:ln>
+    <a:effectLst/>
+  </c:spPr>
+  <c:externalData r:id="rId1">
+    <c:autoUpdate val="0"/>
+  </c:externalData>
+</c:chartSpace>
+</file>
+
 <file path=ppt/charts/chart2.xml><?xml version="1.0" encoding="utf-8"?>
 <c:chartSpace xmlns:c="http://schemas.openxmlformats.org/drawingml/2006/chart" xmlns:a="http://schemas.openxmlformats.org/drawingml/2006/main" xmlns:r="http://schemas.openxmlformats.org/officeDocument/2006/relationships">
   <c:date1904 val="0"/>
@@ -5768,7 +6132,7 @@
           <a:p>
             <a:r>
               <a:rPr lang="en-US" dirty="0"/>
-              <a:t>Clock-in and clock-out discipline turns late starts, missed lunches and early releases into hours we do not pay for. Weekly hours saved are being confirmed; once entered, dollars are calculated at the September month-to-date rate of 33.43 per hour from the productivity dashboard.</a:t>
+              <a:t>Taking Moncton out, our LF score moves from 36.4 to 39.5 percent and bills with no cube drop from 5.7 to 3.0 percent. That matters because Toyota loads our trailer at Bowmanville and we top it off here, and the Toyota footage is not being captured correctly; on Moncton, 20.5 percent of bills have no cube, often the same 24 to 27 bills per load, so measured load factor is understated and that fix is under way. By distance band, the long lanes over 1,000 are strongest at 53.8 percent LF score, while the under-1,000 band of Moncton and Quebec City is lightest at 18.9 percent.</a:t>
             </a:r>
             <a:endParaRPr lang="en-US" dirty="0"/>
           </a:p>
@@ -5856,7 +6220,7 @@
           <a:p>
             <a:r>
               <a:rPr lang="en-US" dirty="0"/>
-              <a:t>This slide covers the state of the building: how many dock doors we have, how many are out of service, and the repairs we need, by priority. The list and cost estimates are being finalized with facilities and will be filled in before distribution.</a:t>
+              <a:t>Clock-in and clock-out discipline turns late starts, missed lunches and early releases into hours we do not pay for. Weekly hours saved are being confirmed; once entered, dollars are calculated at the September month-to-date rate of 33.43 per hour from the productivity dashboard.</a:t>
             </a:r>
             <a:endParaRPr lang="en-US" dirty="0"/>
           </a:p>
@@ -5944,7 +6308,7 @@
           <a:p>
             <a:r>
               <a:rPr lang="en-US" dirty="0"/>
-              <a:t>To close: in F26 we set out to take 386,589 dollars out against the F25 baseline and identified 427,001 dollars of savings, 110 percent of the requirement; the F26 actuals will be added once the year is closed. In F27 September we are under our SCA hour allowance and cost per unit is down on last year, and our focus is closing the gap to the PPH goal. Happy to take questions.</a:t>
+              <a:t>This slide covers the state of the building: how many dock doors we have, how many are out of service, and the repairs we need, by priority. The list and cost estimates are being finalized with facilities and will be filled in before distribution.</a:t>
             </a:r>
             <a:endParaRPr lang="en-US" dirty="0"/>
           </a:p>
@@ -5968,6 +6332,94 @@
             <a:fld id="{F7021451-1387-4CA6-816F-3879F97B5CBC}" type="slidenum">
               <a:rPr lang="en-US"/>
               <a:t>22</a:t>
+            </a:fld>
+            <a:endParaRPr lang="en-US"/>
+          </a:p>
+        </p:txBody>
+      </p:sp>
+    </p:spTree>
+    <p:extLst>
+      <p:ext uri="{BB962C8B-B14F-4D97-AF65-F5344CB8AC3E}">
+        <p14:creationId xmlns:p14="http://schemas.microsoft.com/office/powerpoint/2010/main" val="1024086991"/>
+      </p:ext>
+    </p:extLst>
+  </p:cSld>
+  <p:clrMapOvr>
+    <a:masterClrMapping/>
+  </p:clrMapOvr>
+</p:notes>
+</file>
+
+<file path=ppt/notesSlides/notesSlide23.xml><?xml version="1.0" encoding="utf-8"?>
+<p:notes xmlns:a="http://schemas.openxmlformats.org/drawingml/2006/main" xmlns:r="http://schemas.openxmlformats.org/officeDocument/2006/relationships" xmlns:p="http://schemas.openxmlformats.org/presentationml/2006/main">
+  <p:cSld>
+    <p:spTree>
+      <p:nvGrpSpPr>
+        <p:cNvPr id="1" name=""/>
+        <p:cNvGrpSpPr/>
+        <p:nvPr/>
+      </p:nvGrpSpPr>
+      <p:grpSpPr>
+        <a:xfrm>
+          <a:off x="0" y="0"/>
+          <a:ext cx="0" cy="0"/>
+          <a:chOff x="0" y="0"/>
+          <a:chExt cx="0" cy="0"/>
+        </a:xfrm>
+      </p:grpSpPr>
+      <p:sp>
+        <p:nvSpPr>
+          <p:cNvPr id="2" name="Slide Image Placeholder 1"/>
+          <p:cNvSpPr>
+            <a:spLocks noGrp="1" noRot="1" noChangeAspect="1"/>
+          </p:cNvSpPr>
+          <p:nvPr>
+            <p:ph type="sldImg"/>
+          </p:nvPr>
+        </p:nvSpPr>
+        <p:spPr/>
+      </p:sp>
+      <p:sp>
+        <p:nvSpPr>
+          <p:cNvPr id="3" name="Notes Placeholder 2"/>
+          <p:cNvSpPr>
+            <a:spLocks noGrp="1"/>
+          </p:cNvSpPr>
+          <p:nvPr>
+            <p:ph type="body" idx="1"/>
+          </p:nvPr>
+        </p:nvSpPr>
+        <p:spPr/>
+        <p:txBody>
+          <a:bodyPr/>
+          <a:lstStyle/>
+          <a:p>
+            <a:r>
+              <a:rPr lang="en-US" dirty="0"/>
+              <a:t>To close: in F26 we set out to take 386,589 dollars out against the F25 baseline and identified 427,001 dollars of savings, 110 percent of the requirement; the F26 actuals will be added once the year is closed. In F27 September we are under our SCA hour allowance and cost per unit is down on last year, and our focus is closing the gap to the PPH goal. Happy to take questions.</a:t>
+            </a:r>
+            <a:endParaRPr lang="en-US" dirty="0"/>
+          </a:p>
+        </p:txBody>
+      </p:sp>
+      <p:sp>
+        <p:nvSpPr>
+          <p:cNvPr id="4" name="Slide Number Placeholder 3"/>
+          <p:cNvSpPr>
+            <a:spLocks noGrp="1"/>
+          </p:cNvSpPr>
+          <p:nvPr>
+            <p:ph type="sldNum" sz="quarter" idx="10"/>
+          </p:nvPr>
+        </p:nvSpPr>
+        <p:spPr/>
+        <p:txBody>
+          <a:bodyPr/>
+          <a:lstStyle/>
+          <a:p>
+            <a:fld id="{F7021451-1387-4CA6-816F-3879F97B5CBC}" type="slidenum">
+              <a:rPr lang="en-US"/>
+              <a:t>23</a:t>
             </a:fld>
             <a:endParaRPr lang="en-US"/>
           </a:p>
@@ -8951,7 +9403,7 @@
                 <a:ea typeface="Calibri" pitchFamily="34" charset="-122"/>
                 <a:cs typeface="Calibri" pitchFamily="34" charset="-120"/>
               </a:rPr>
-              <a:t>10 / 22</a:t>
+              <a:t>10 / 23</a:t>
             </a:r>
             <a:endParaRPr lang="en-US" sz="900" dirty="0"/>
           </a:p>
@@ -13444,7 +13896,7 @@
                 <a:ea typeface="Calibri" pitchFamily="34" charset="-122"/>
                 <a:cs typeface="Calibri" pitchFamily="34" charset="-120"/>
               </a:rPr>
-              <a:t>11 / 22</a:t>
+              <a:t>11 / 23</a:t>
             </a:r>
             <a:endParaRPr lang="en-US" sz="900" dirty="0"/>
           </a:p>
@@ -15208,7 +15660,7 @@
                 <a:ea typeface="Calibri" pitchFamily="34" charset="-122"/>
                 <a:cs typeface="Calibri" pitchFamily="34" charset="-120"/>
               </a:rPr>
-              <a:t>12 / 22</a:t>
+              <a:t>12 / 23</a:t>
             </a:r>
             <a:endParaRPr lang="en-US" sz="900" dirty="0"/>
           </a:p>
@@ -15845,7 +16297,7 @@
                 <a:ea typeface="Calibri" pitchFamily="34" charset="-122"/>
                 <a:cs typeface="Calibri" pitchFamily="34" charset="-120"/>
               </a:rPr>
-              <a:t>13 / 22</a:t>
+              <a:t>13 / 23</a:t>
             </a:r>
             <a:endParaRPr lang="en-US" sz="900" dirty="0"/>
           </a:p>
@@ -17352,7 +17804,7 @@
                 <a:ea typeface="Calibri" pitchFamily="34" charset="-122"/>
                 <a:cs typeface="Calibri" pitchFamily="34" charset="-120"/>
               </a:rPr>
-              <a:t>14 / 22</a:t>
+              <a:t>14 / 23</a:t>
             </a:r>
             <a:endParaRPr lang="en-US" sz="900" dirty="0"/>
           </a:p>
@@ -21614,7 +22066,7 @@
                 <a:ea typeface="Calibri" pitchFamily="34" charset="-122"/>
                 <a:cs typeface="Calibri" pitchFamily="34" charset="-120"/>
               </a:rPr>
-              <a:t>15 / 22</a:t>
+              <a:t>15 / 23</a:t>
             </a:r>
             <a:endParaRPr lang="en-US" sz="900" dirty="0"/>
           </a:p>
@@ -22702,7 +23154,7 @@
                 <a:ea typeface="Calibri" pitchFamily="34" charset="-122"/>
                 <a:cs typeface="Calibri" pitchFamily="34" charset="-120"/>
               </a:rPr>
-              <a:t>16 / 22</a:t>
+              <a:t>16 / 23</a:t>
             </a:r>
             <a:endParaRPr lang="en-US" sz="900" dirty="0"/>
           </a:p>
@@ -25602,7 +26054,7 @@
                 <a:ea typeface="Calibri" pitchFamily="34" charset="-122"/>
                 <a:cs typeface="Calibri" pitchFamily="34" charset="-120"/>
               </a:rPr>
-              <a:t>17 / 22</a:t>
+              <a:t>17 / 23</a:t>
             </a:r>
             <a:endParaRPr lang="en-US" sz="900" dirty="0"/>
           </a:p>
@@ -28322,7 +28774,7 @@
                 <a:ea typeface="Calibri" pitchFamily="34" charset="-122"/>
                 <a:cs typeface="Calibri" pitchFamily="34" charset="-120"/>
               </a:rPr>
-              <a:t>18 / 22</a:t>
+              <a:t>18 / 23</a:t>
             </a:r>
             <a:endParaRPr lang="en-US" sz="900" dirty="0"/>
           </a:p>
@@ -31548,7 +32000,7 @@
                 <a:ea typeface="Calibri" pitchFamily="34" charset="-122"/>
                 <a:cs typeface="Calibri" pitchFamily="34" charset="-120"/>
               </a:rPr>
-              <a:t>19 / 22</a:t>
+              <a:t>19 / 23</a:t>
             </a:r>
             <a:endParaRPr lang="en-US" sz="900" dirty="0"/>
           </a:p>
@@ -32944,7 +33396,7 @@
                 <a:ea typeface="Calibri" pitchFamily="34" charset="-122"/>
                 <a:cs typeface="Calibri" pitchFamily="34" charset="-120"/>
               </a:rPr>
-              <a:t>2 / 22</a:t>
+              <a:t>2 / 23</a:t>
             </a:r>
             <a:endParaRPr lang="en-US" sz="900" dirty="0"/>
           </a:p>
@@ -33054,15 +33506,2917 @@
                 <a:ea typeface="Calibri" pitchFamily="34" charset="-122"/>
                 <a:cs typeface="Calibri" pitchFamily="34" charset="-120"/>
               </a:rPr>
-              <a:t>CICO — hours saved</a:t>
+              <a:t>Load factor — ex-Moncton &amp; distance bands</a:t>
             </a:r>
             <a:endParaRPr lang="en-US" sz="3000" dirty="0"/>
+          </a:p>
+        </p:txBody>
+      </p:sp>
+      <p:sp>
+        <p:nvSpPr>
+          <p:cNvPr id="4" name="Text 2"/>
+          <p:cNvSpPr txBox="1"/>
+          <p:nvPr/>
+        </p:nvSpPr>
+        <p:spPr>
+          <a:xfrm>
+            <a:off x="548640" y="1243584"/>
+            <a:ext cx="10972800" cy="274320"/>
+          </a:xfrm>
+          <a:prstGeom prst="rect">
+            <a:avLst/>
+          </a:prstGeom>
+          <a:noFill/>
+          <a:ln/>
+        </p:spPr>
+        <p:txBody>
+          <a:bodyPr wrap="square" lIns="0" tIns="0" rIns="0" bIns="0" rtlCol="0" anchor="ctr"/>
+          <a:lstStyle/>
+          <a:p>
+            <a:pPr indent="0" marL="0">
+              <a:buNone/>
+            </a:pPr>
+            <a:r>
+              <a:rPr lang="en-US" sz="1250" dirty="0">
+                <a:solidFill>
+                  <a:srgbClr val="6B7280"/>
+                </a:solidFill>
+                <a:latin typeface="Calibri" pitchFamily="34" charset="0"/>
+                <a:ea typeface="Calibri" pitchFamily="34" charset="-122"/>
+                <a:cs typeface="Calibri" pitchFamily="34" charset="-120"/>
+              </a:rPr>
+              <a:t>Mississauga outbound · F27 Jul–Sep · ex-Moncton and band figures calculated from the load factor report</a:t>
+            </a:r>
+            <a:endParaRPr lang="en-US" sz="1250" dirty="0"/>
+          </a:p>
+        </p:txBody>
+      </p:sp>
+      <p:sp>
+        <p:nvSpPr>
+          <p:cNvPr id="5" name="Shape 3"/>
+          <p:cNvSpPr/>
+          <p:nvPr/>
+        </p:nvSpPr>
+        <p:spPr>
+          <a:xfrm>
+            <a:off x="548640" y="1600200"/>
+            <a:ext cx="2651760" cy="896112"/>
+          </a:xfrm>
+          <a:prstGeom prst="roundRect">
+            <a:avLst>
+              <a:gd name="adj" fmla="val 8163"/>
+            </a:avLst>
+          </a:prstGeom>
+          <a:solidFill>
+            <a:srgbClr val="F3F4F6"/>
+          </a:solidFill>
+          <a:ln w="12700">
+            <a:solidFill>
+              <a:srgbClr val="F3F4F6"/>
+            </a:solidFill>
+            <a:prstDash val="solid"/>
+          </a:ln>
+        </p:spPr>
+      </p:sp>
+      <p:sp>
+        <p:nvSpPr>
+          <p:cNvPr id="6" name="Text 4"/>
+          <p:cNvSpPr txBox="1"/>
+          <p:nvPr/>
+        </p:nvSpPr>
+        <p:spPr>
+          <a:xfrm>
+            <a:off x="713232" y="1673352"/>
+            <a:ext cx="2331720" cy="237744"/>
+          </a:xfrm>
+          <a:prstGeom prst="rect">
+            <a:avLst/>
+          </a:prstGeom>
+          <a:noFill/>
+          <a:ln/>
+        </p:spPr>
+        <p:txBody>
+          <a:bodyPr wrap="square" lIns="0" tIns="0" rIns="0" bIns="0" rtlCol="0" anchor="ctr"/>
+          <a:lstStyle/>
+          <a:p>
+            <a:pPr indent="0" marL="0">
+              <a:buNone/>
+            </a:pPr>
+            <a:r>
+              <a:rPr lang="en-US" sz="1100" b="1" dirty="0">
+                <a:solidFill>
+                  <a:srgbClr val="6B7280"/>
+                </a:solidFill>
+                <a:latin typeface="Calibri" pitchFamily="34" charset="0"/>
+                <a:ea typeface="Calibri" pitchFamily="34" charset="-122"/>
+                <a:cs typeface="Calibri" pitchFamily="34" charset="-120"/>
+              </a:rPr>
+              <a:t>LF score</a:t>
+            </a:r>
+            <a:endParaRPr lang="en-US" sz="1100" dirty="0"/>
+          </a:p>
+        </p:txBody>
+      </p:sp>
+      <p:sp>
+        <p:nvSpPr>
+          <p:cNvPr id="7" name="Text 5"/>
+          <p:cNvSpPr txBox="1"/>
+          <p:nvPr/>
+        </p:nvSpPr>
+        <p:spPr>
+          <a:xfrm>
+            <a:off x="713232" y="1911096"/>
+            <a:ext cx="2377440" cy="384048"/>
+          </a:xfrm>
+          <a:prstGeom prst="rect">
+            <a:avLst/>
+          </a:prstGeom>
+          <a:noFill/>
+          <a:ln/>
+        </p:spPr>
+        <p:txBody>
+          <a:bodyPr wrap="square" lIns="0" tIns="0" rIns="0" bIns="0" rtlCol="0" anchor="ctr"/>
+          <a:lstStyle/>
+          <a:p>
+            <a:pPr indent="0" marL="0">
+              <a:buNone/>
+            </a:pPr>
+            <a:r>
+              <a:rPr lang="en-US" sz="1600" dirty="0">
+                <a:solidFill>
+                  <a:srgbClr val="6B7280"/>
+                </a:solidFill>
+                <a:latin typeface="Calibri" pitchFamily="34" charset="0"/>
+                <a:ea typeface="Calibri" pitchFamily="34" charset="-122"/>
+                <a:cs typeface="Calibri" pitchFamily="34" charset="-120"/>
+              </a:rPr>
+              <a:t>36.4%</a:t>
+            </a:r>
+            <a:pPr indent="0" marL="0">
+              <a:buNone/>
+            </a:pPr>
+            <a:r>
+              <a:rPr lang="en-US" sz="1400" dirty="0">
+                <a:solidFill>
+                  <a:srgbClr val="9CA3AF"/>
+                </a:solidFill>
+                <a:latin typeface="Calibri" pitchFamily="34" charset="0"/>
+                <a:ea typeface="Calibri" pitchFamily="34" charset="-122"/>
+                <a:cs typeface="Calibri" pitchFamily="34" charset="-120"/>
+              </a:rPr>
+              <a:t>  →  </a:t>
+            </a:r>
+            <a:pPr indent="0" marL="0">
+              <a:buNone/>
+            </a:pPr>
+            <a:r>
+              <a:rPr lang="en-US" sz="2200" b="1" dirty="0">
+                <a:solidFill>
+                  <a:srgbClr val="111827"/>
+                </a:solidFill>
+                <a:latin typeface="Calibri" pitchFamily="34" charset="0"/>
+                <a:ea typeface="Calibri" pitchFamily="34" charset="-122"/>
+                <a:cs typeface="Calibri" pitchFamily="34" charset="-120"/>
+              </a:rPr>
+              <a:t>39.5%</a:t>
+            </a:r>
+            <a:endParaRPr lang="en-US" sz="1600" dirty="0"/>
+          </a:p>
+        </p:txBody>
+      </p:sp>
+      <p:sp>
+        <p:nvSpPr>
+          <p:cNvPr id="8" name="Text 6"/>
+          <p:cNvSpPr txBox="1"/>
+          <p:nvPr/>
+        </p:nvSpPr>
+        <p:spPr>
+          <a:xfrm>
+            <a:off x="713232" y="2276856"/>
+            <a:ext cx="2331720" cy="182880"/>
+          </a:xfrm>
+          <a:prstGeom prst="rect">
+            <a:avLst/>
+          </a:prstGeom>
+          <a:noFill/>
+          <a:ln/>
+        </p:spPr>
+        <p:txBody>
+          <a:bodyPr wrap="square" lIns="0" tIns="0" rIns="0" bIns="0" rtlCol="0" anchor="ctr"/>
+          <a:lstStyle/>
+          <a:p>
+            <a:pPr indent="0" marL="0">
+              <a:buNone/>
+            </a:pPr>
+            <a:r>
+              <a:rPr lang="en-US" sz="850" dirty="0">
+                <a:solidFill>
+                  <a:srgbClr val="9CA3AF"/>
+                </a:solidFill>
+                <a:latin typeface="Calibri" pitchFamily="34" charset="0"/>
+                <a:ea typeface="Calibri" pitchFamily="34" charset="-122"/>
+                <a:cs typeface="Calibri" pitchFamily="34" charset="-120"/>
+              </a:rPr>
+              <a:t>all lanes → ex-Moncton</a:t>
+            </a:r>
+            <a:endParaRPr lang="en-US" sz="850" dirty="0"/>
+          </a:p>
+        </p:txBody>
+      </p:sp>
+      <p:sp>
+        <p:nvSpPr>
+          <p:cNvPr id="9" name="Shape 7"/>
+          <p:cNvSpPr/>
+          <p:nvPr/>
+        </p:nvSpPr>
+        <p:spPr>
+          <a:xfrm>
+            <a:off x="3337560" y="1600200"/>
+            <a:ext cx="2651760" cy="896112"/>
+          </a:xfrm>
+          <a:prstGeom prst="roundRect">
+            <a:avLst>
+              <a:gd name="adj" fmla="val 8163"/>
+            </a:avLst>
+          </a:prstGeom>
+          <a:solidFill>
+            <a:srgbClr val="F3F4F6"/>
+          </a:solidFill>
+          <a:ln w="12700">
+            <a:solidFill>
+              <a:srgbClr val="F3F4F6"/>
+            </a:solidFill>
+            <a:prstDash val="solid"/>
+          </a:ln>
+        </p:spPr>
+      </p:sp>
+      <p:sp>
+        <p:nvSpPr>
+          <p:cNvPr id="10" name="Text 8"/>
+          <p:cNvSpPr txBox="1"/>
+          <p:nvPr/>
+        </p:nvSpPr>
+        <p:spPr>
+          <a:xfrm>
+            <a:off x="3502152" y="1673352"/>
+            <a:ext cx="2331720" cy="237744"/>
+          </a:xfrm>
+          <a:prstGeom prst="rect">
+            <a:avLst/>
+          </a:prstGeom>
+          <a:noFill/>
+          <a:ln/>
+        </p:spPr>
+        <p:txBody>
+          <a:bodyPr wrap="square" lIns="0" tIns="0" rIns="0" bIns="0" rtlCol="0" anchor="ctr"/>
+          <a:lstStyle/>
+          <a:p>
+            <a:pPr indent="0" marL="0">
+              <a:buNone/>
+            </a:pPr>
+            <a:r>
+              <a:rPr lang="en-US" sz="1100" b="1" dirty="0">
+                <a:solidFill>
+                  <a:srgbClr val="6B7280"/>
+                </a:solidFill>
+                <a:latin typeface="Calibri" pitchFamily="34" charset="0"/>
+                <a:ea typeface="Calibri" pitchFamily="34" charset="-122"/>
+                <a:cs typeface="Calibri" pitchFamily="34" charset="-120"/>
+              </a:rPr>
+              <a:t>Average load %</a:t>
+            </a:r>
+            <a:endParaRPr lang="en-US" sz="1100" dirty="0"/>
+          </a:p>
+        </p:txBody>
+      </p:sp>
+      <p:sp>
+        <p:nvSpPr>
+          <p:cNvPr id="11" name="Text 9"/>
+          <p:cNvSpPr txBox="1"/>
+          <p:nvPr/>
+        </p:nvSpPr>
+        <p:spPr>
+          <a:xfrm>
+            <a:off x="3502152" y="1911096"/>
+            <a:ext cx="2377440" cy="384048"/>
+          </a:xfrm>
+          <a:prstGeom prst="rect">
+            <a:avLst/>
+          </a:prstGeom>
+          <a:noFill/>
+          <a:ln/>
+        </p:spPr>
+        <p:txBody>
+          <a:bodyPr wrap="square" lIns="0" tIns="0" rIns="0" bIns="0" rtlCol="0" anchor="ctr"/>
+          <a:lstStyle/>
+          <a:p>
+            <a:pPr indent="0" marL="0">
+              <a:buNone/>
+            </a:pPr>
+            <a:r>
+              <a:rPr lang="en-US" sz="1600" dirty="0">
+                <a:solidFill>
+                  <a:srgbClr val="6B7280"/>
+                </a:solidFill>
+                <a:latin typeface="Calibri" pitchFamily="34" charset="0"/>
+                <a:ea typeface="Calibri" pitchFamily="34" charset="-122"/>
+                <a:cs typeface="Calibri" pitchFamily="34" charset="-120"/>
+              </a:rPr>
+              <a:t>74.9%</a:t>
+            </a:r>
+            <a:pPr indent="0" marL="0">
+              <a:buNone/>
+            </a:pPr>
+            <a:r>
+              <a:rPr lang="en-US" sz="1400" dirty="0">
+                <a:solidFill>
+                  <a:srgbClr val="9CA3AF"/>
+                </a:solidFill>
+                <a:latin typeface="Calibri" pitchFamily="34" charset="0"/>
+                <a:ea typeface="Calibri" pitchFamily="34" charset="-122"/>
+                <a:cs typeface="Calibri" pitchFamily="34" charset="-120"/>
+              </a:rPr>
+              <a:t>  →  </a:t>
+            </a:r>
+            <a:pPr indent="0" marL="0">
+              <a:buNone/>
+            </a:pPr>
+            <a:r>
+              <a:rPr lang="en-US" sz="2200" b="1" dirty="0">
+                <a:solidFill>
+                  <a:srgbClr val="111827"/>
+                </a:solidFill>
+                <a:latin typeface="Calibri" pitchFamily="34" charset="0"/>
+                <a:ea typeface="Calibri" pitchFamily="34" charset="-122"/>
+                <a:cs typeface="Calibri" pitchFamily="34" charset="-120"/>
+              </a:rPr>
+              <a:t>75.8%</a:t>
+            </a:r>
+            <a:endParaRPr lang="en-US" sz="1600" dirty="0"/>
+          </a:p>
+        </p:txBody>
+      </p:sp>
+      <p:sp>
+        <p:nvSpPr>
+          <p:cNvPr id="12" name="Text 10"/>
+          <p:cNvSpPr txBox="1"/>
+          <p:nvPr/>
+        </p:nvSpPr>
+        <p:spPr>
+          <a:xfrm>
+            <a:off x="3502152" y="2276856"/>
+            <a:ext cx="2331720" cy="182880"/>
+          </a:xfrm>
+          <a:prstGeom prst="rect">
+            <a:avLst/>
+          </a:prstGeom>
+          <a:noFill/>
+          <a:ln/>
+        </p:spPr>
+        <p:txBody>
+          <a:bodyPr wrap="square" lIns="0" tIns="0" rIns="0" bIns="0" rtlCol="0" anchor="ctr"/>
+          <a:lstStyle/>
+          <a:p>
+            <a:pPr indent="0" marL="0">
+              <a:buNone/>
+            </a:pPr>
+            <a:r>
+              <a:rPr lang="en-US" sz="850" dirty="0">
+                <a:solidFill>
+                  <a:srgbClr val="9CA3AF"/>
+                </a:solidFill>
+                <a:latin typeface="Calibri" pitchFamily="34" charset="0"/>
+                <a:ea typeface="Calibri" pitchFamily="34" charset="-122"/>
+                <a:cs typeface="Calibri" pitchFamily="34" charset="-120"/>
+              </a:rPr>
+              <a:t>all lanes → ex-Moncton</a:t>
+            </a:r>
+            <a:endParaRPr lang="en-US" sz="850" dirty="0"/>
+          </a:p>
+        </p:txBody>
+      </p:sp>
+      <p:sp>
+        <p:nvSpPr>
+          <p:cNvPr id="13" name="Shape 11"/>
+          <p:cNvSpPr/>
+          <p:nvPr/>
+        </p:nvSpPr>
+        <p:spPr>
+          <a:xfrm>
+            <a:off x="548640" y="2587752"/>
+            <a:ext cx="2651760" cy="896112"/>
+          </a:xfrm>
+          <a:prstGeom prst="roundRect">
+            <a:avLst>
+              <a:gd name="adj" fmla="val 8163"/>
+            </a:avLst>
+          </a:prstGeom>
+          <a:solidFill>
+            <a:srgbClr val="F3F4F6"/>
+          </a:solidFill>
+          <a:ln w="12700">
+            <a:solidFill>
+              <a:srgbClr val="F3F4F6"/>
+            </a:solidFill>
+            <a:prstDash val="solid"/>
+          </a:ln>
+        </p:spPr>
+      </p:sp>
+      <p:sp>
+        <p:nvSpPr>
+          <p:cNvPr id="14" name="Text 12"/>
+          <p:cNvSpPr txBox="1"/>
+          <p:nvPr/>
+        </p:nvSpPr>
+        <p:spPr>
+          <a:xfrm>
+            <a:off x="713232" y="2660904"/>
+            <a:ext cx="2331720" cy="237744"/>
+          </a:xfrm>
+          <a:prstGeom prst="rect">
+            <a:avLst/>
+          </a:prstGeom>
+          <a:noFill/>
+          <a:ln/>
+        </p:spPr>
+        <p:txBody>
+          <a:bodyPr wrap="square" lIns="0" tIns="0" rIns="0" bIns="0" rtlCol="0" anchor="ctr"/>
+          <a:lstStyle/>
+          <a:p>
+            <a:pPr indent="0" marL="0">
+              <a:buNone/>
+            </a:pPr>
+            <a:r>
+              <a:rPr lang="en-US" sz="1100" b="1" dirty="0">
+                <a:solidFill>
+                  <a:srgbClr val="6B7280"/>
+                </a:solidFill>
+                <a:latin typeface="Calibri" pitchFamily="34" charset="0"/>
+                <a:ea typeface="Calibri" pitchFamily="34" charset="-122"/>
+                <a:cs typeface="Calibri" pitchFamily="34" charset="-120"/>
+              </a:rPr>
+              <a:t>Loads</a:t>
+            </a:r>
+            <a:endParaRPr lang="en-US" sz="1100" dirty="0"/>
+          </a:p>
+        </p:txBody>
+      </p:sp>
+      <p:sp>
+        <p:nvSpPr>
+          <p:cNvPr id="15" name="Text 13"/>
+          <p:cNvSpPr txBox="1"/>
+          <p:nvPr/>
+        </p:nvSpPr>
+        <p:spPr>
+          <a:xfrm>
+            <a:off x="713232" y="2898648"/>
+            <a:ext cx="2377440" cy="384048"/>
+          </a:xfrm>
+          <a:prstGeom prst="rect">
+            <a:avLst/>
+          </a:prstGeom>
+          <a:noFill/>
+          <a:ln/>
+        </p:spPr>
+        <p:txBody>
+          <a:bodyPr wrap="square" lIns="0" tIns="0" rIns="0" bIns="0" rtlCol="0" anchor="ctr"/>
+          <a:lstStyle/>
+          <a:p>
+            <a:pPr indent="0" marL="0">
+              <a:buNone/>
+            </a:pPr>
+            <a:r>
+              <a:rPr lang="en-US" sz="1600" dirty="0">
+                <a:solidFill>
+                  <a:srgbClr val="6B7280"/>
+                </a:solidFill>
+                <a:latin typeface="Calibri" pitchFamily="34" charset="0"/>
+                <a:ea typeface="Calibri" pitchFamily="34" charset="-122"/>
+                <a:cs typeface="Calibri" pitchFamily="34" charset="-120"/>
+              </a:rPr>
+              <a:t>854</a:t>
+            </a:r>
+            <a:pPr indent="0" marL="0">
+              <a:buNone/>
+            </a:pPr>
+            <a:r>
+              <a:rPr lang="en-US" sz="1400" dirty="0">
+                <a:solidFill>
+                  <a:srgbClr val="9CA3AF"/>
+                </a:solidFill>
+                <a:latin typeface="Calibri" pitchFamily="34" charset="0"/>
+                <a:ea typeface="Calibri" pitchFamily="34" charset="-122"/>
+                <a:cs typeface="Calibri" pitchFamily="34" charset="-120"/>
+              </a:rPr>
+              <a:t>  →  </a:t>
+            </a:r>
+            <a:pPr indent="0" marL="0">
+              <a:buNone/>
+            </a:pPr>
+            <a:r>
+              <a:rPr lang="en-US" sz="2200" b="1" dirty="0">
+                <a:solidFill>
+                  <a:srgbClr val="111827"/>
+                </a:solidFill>
+                <a:latin typeface="Calibri" pitchFamily="34" charset="0"/>
+                <a:ea typeface="Calibri" pitchFamily="34" charset="-122"/>
+                <a:cs typeface="Calibri" pitchFamily="34" charset="-120"/>
+              </a:rPr>
+              <a:t>686</a:t>
+            </a:r>
+            <a:endParaRPr lang="en-US" sz="1600" dirty="0"/>
+          </a:p>
+        </p:txBody>
+      </p:sp>
+      <p:sp>
+        <p:nvSpPr>
+          <p:cNvPr id="16" name="Text 14"/>
+          <p:cNvSpPr txBox="1"/>
+          <p:nvPr/>
+        </p:nvSpPr>
+        <p:spPr>
+          <a:xfrm>
+            <a:off x="713232" y="3264408"/>
+            <a:ext cx="2331720" cy="182880"/>
+          </a:xfrm>
+          <a:prstGeom prst="rect">
+            <a:avLst/>
+          </a:prstGeom>
+          <a:noFill/>
+          <a:ln/>
+        </p:spPr>
+        <p:txBody>
+          <a:bodyPr wrap="square" lIns="0" tIns="0" rIns="0" bIns="0" rtlCol="0" anchor="ctr"/>
+          <a:lstStyle/>
+          <a:p>
+            <a:pPr indent="0" marL="0">
+              <a:buNone/>
+            </a:pPr>
+            <a:r>
+              <a:rPr lang="en-US" sz="850" dirty="0">
+                <a:solidFill>
+                  <a:srgbClr val="9CA3AF"/>
+                </a:solidFill>
+                <a:latin typeface="Calibri" pitchFamily="34" charset="0"/>
+                <a:ea typeface="Calibri" pitchFamily="34" charset="-122"/>
+                <a:cs typeface="Calibri" pitchFamily="34" charset="-120"/>
+              </a:rPr>
+              <a:t>all lanes → ex-Moncton</a:t>
+            </a:r>
+            <a:endParaRPr lang="en-US" sz="850" dirty="0"/>
+          </a:p>
+        </p:txBody>
+      </p:sp>
+      <p:sp>
+        <p:nvSpPr>
+          <p:cNvPr id="17" name="Shape 15"/>
+          <p:cNvSpPr/>
+          <p:nvPr/>
+        </p:nvSpPr>
+        <p:spPr>
+          <a:xfrm>
+            <a:off x="3337560" y="2587752"/>
+            <a:ext cx="2651760" cy="896112"/>
+          </a:xfrm>
+          <a:prstGeom prst="roundRect">
+            <a:avLst>
+              <a:gd name="adj" fmla="val 8163"/>
+            </a:avLst>
+          </a:prstGeom>
+          <a:solidFill>
+            <a:srgbClr val="F3F4F6"/>
+          </a:solidFill>
+          <a:ln w="12700">
+            <a:solidFill>
+              <a:srgbClr val="F3F4F6"/>
+            </a:solidFill>
+            <a:prstDash val="solid"/>
+          </a:ln>
+        </p:spPr>
+      </p:sp>
+      <p:sp>
+        <p:nvSpPr>
+          <p:cNvPr id="18" name="Text 16"/>
+          <p:cNvSpPr txBox="1"/>
+          <p:nvPr/>
+        </p:nvSpPr>
+        <p:spPr>
+          <a:xfrm>
+            <a:off x="3502152" y="2660904"/>
+            <a:ext cx="2331720" cy="237744"/>
+          </a:xfrm>
+          <a:prstGeom prst="rect">
+            <a:avLst/>
+          </a:prstGeom>
+          <a:noFill/>
+          <a:ln/>
+        </p:spPr>
+        <p:txBody>
+          <a:bodyPr wrap="square" lIns="0" tIns="0" rIns="0" bIns="0" rtlCol="0" anchor="ctr"/>
+          <a:lstStyle/>
+          <a:p>
+            <a:pPr indent="0" marL="0">
+              <a:buNone/>
+            </a:pPr>
+            <a:r>
+              <a:rPr lang="en-US" sz="1100" b="1" dirty="0">
+                <a:solidFill>
+                  <a:srgbClr val="6B7280"/>
+                </a:solidFill>
+                <a:latin typeface="Calibri" pitchFamily="34" charset="0"/>
+                <a:ea typeface="Calibri" pitchFamily="34" charset="-122"/>
+                <a:cs typeface="Calibri" pitchFamily="34" charset="-120"/>
+              </a:rPr>
+              <a:t>Bills with no cube</a:t>
+            </a:r>
+            <a:endParaRPr lang="en-US" sz="1100" dirty="0"/>
+          </a:p>
+        </p:txBody>
+      </p:sp>
+      <p:sp>
+        <p:nvSpPr>
+          <p:cNvPr id="19" name="Text 17"/>
+          <p:cNvSpPr txBox="1"/>
+          <p:nvPr/>
+        </p:nvSpPr>
+        <p:spPr>
+          <a:xfrm>
+            <a:off x="3502152" y="2898648"/>
+            <a:ext cx="2377440" cy="384048"/>
+          </a:xfrm>
+          <a:prstGeom prst="rect">
+            <a:avLst/>
+          </a:prstGeom>
+          <a:noFill/>
+          <a:ln/>
+        </p:spPr>
+        <p:txBody>
+          <a:bodyPr wrap="square" lIns="0" tIns="0" rIns="0" bIns="0" rtlCol="0" anchor="ctr"/>
+          <a:lstStyle/>
+          <a:p>
+            <a:pPr indent="0" marL="0">
+              <a:buNone/>
+            </a:pPr>
+            <a:r>
+              <a:rPr lang="en-US" sz="1600" dirty="0">
+                <a:solidFill>
+                  <a:srgbClr val="6B7280"/>
+                </a:solidFill>
+                <a:latin typeface="Calibri" pitchFamily="34" charset="0"/>
+                <a:ea typeface="Calibri" pitchFamily="34" charset="-122"/>
+                <a:cs typeface="Calibri" pitchFamily="34" charset="-120"/>
+              </a:rPr>
+              <a:t>5.7%</a:t>
+            </a:r>
+            <a:pPr indent="0" marL="0">
+              <a:buNone/>
+            </a:pPr>
+            <a:r>
+              <a:rPr lang="en-US" sz="1400" dirty="0">
+                <a:solidFill>
+                  <a:srgbClr val="9CA3AF"/>
+                </a:solidFill>
+                <a:latin typeface="Calibri" pitchFamily="34" charset="0"/>
+                <a:ea typeface="Calibri" pitchFamily="34" charset="-122"/>
+                <a:cs typeface="Calibri" pitchFamily="34" charset="-120"/>
+              </a:rPr>
+              <a:t>  →  </a:t>
+            </a:r>
+            <a:pPr indent="0" marL="0">
+              <a:buNone/>
+            </a:pPr>
+            <a:r>
+              <a:rPr lang="en-US" sz="2200" b="1" dirty="0">
+                <a:solidFill>
+                  <a:srgbClr val="111827"/>
+                </a:solidFill>
+                <a:latin typeface="Calibri" pitchFamily="34" charset="0"/>
+                <a:ea typeface="Calibri" pitchFamily="34" charset="-122"/>
+                <a:cs typeface="Calibri" pitchFamily="34" charset="-120"/>
+              </a:rPr>
+              <a:t>3.0%</a:t>
+            </a:r>
+            <a:endParaRPr lang="en-US" sz="1600" dirty="0"/>
+          </a:p>
+        </p:txBody>
+      </p:sp>
+      <p:sp>
+        <p:nvSpPr>
+          <p:cNvPr id="20" name="Text 18"/>
+          <p:cNvSpPr txBox="1"/>
+          <p:nvPr/>
+        </p:nvSpPr>
+        <p:spPr>
+          <a:xfrm>
+            <a:off x="3502152" y="3264408"/>
+            <a:ext cx="2331720" cy="182880"/>
+          </a:xfrm>
+          <a:prstGeom prst="rect">
+            <a:avLst/>
+          </a:prstGeom>
+          <a:noFill/>
+          <a:ln/>
+        </p:spPr>
+        <p:txBody>
+          <a:bodyPr wrap="square" lIns="0" tIns="0" rIns="0" bIns="0" rtlCol="0" anchor="ctr"/>
+          <a:lstStyle/>
+          <a:p>
+            <a:pPr indent="0" marL="0">
+              <a:buNone/>
+            </a:pPr>
+            <a:r>
+              <a:rPr lang="en-US" sz="850" dirty="0">
+                <a:solidFill>
+                  <a:srgbClr val="9CA3AF"/>
+                </a:solidFill>
+                <a:latin typeface="Calibri" pitchFamily="34" charset="0"/>
+                <a:ea typeface="Calibri" pitchFamily="34" charset="-122"/>
+                <a:cs typeface="Calibri" pitchFamily="34" charset="-120"/>
+              </a:rPr>
+              <a:t>all lanes → ex-Moncton</a:t>
+            </a:r>
+            <a:endParaRPr lang="en-US" sz="850" dirty="0"/>
           </a:p>
         </p:txBody>
       </p:sp>
       <p:graphicFrame>
         <p:nvGraphicFramePr>
           <p:cNvPr id="21" name="Table 0"/>
+          <p:cNvGraphicFramePr>
+            <a:graphicFrameLocks noGrp="1"/>
+          </p:cNvGraphicFramePr>
+          <p:nvPr>
+            <p:extLst>
+              <p:ext uri="{D42A27DB-BD31-4B8C-83A1-F6EECF244321}">
+                <p14:modId xmlns:p14="http://schemas.microsoft.com/office/powerpoint/2010/main" val="1579011935"/>
+              </p:ext>
+            </p:extLst>
+          </p:nvPr>
+        </p:nvGraphicFramePr>
+        <p:xfrm>
+          <a:off x="548640" y="3657600"/>
+          <a:ext cx="5440680" cy="914400"/>
+        </p:xfrm>
+        <a:graphic>
+          <a:graphicData uri="http://schemas.openxmlformats.org/drawingml/2006/table">
+            <a:tbl>
+              <a:tblPr/>
+              <a:tblGrid>
+                <a:gridCol w="731520"/>
+                <a:gridCol w="960120"/>
+                <a:gridCol w="1234440"/>
+                <a:gridCol w="960120"/>
+                <a:gridCol w="1554480"/>
+              </a:tblGrid>
+              <a:tr h="246888">
+                <a:tc>
+                  <a:txBody>
+                    <a:bodyPr/>
+                    <a:lstStyle/>
+                    <a:p>
+                      <a:pPr indent="0" marL="0">
+                        <a:buNone/>
+                      </a:pPr>
+                      <a:r>
+                        <a:rPr lang="en-US" sz="1000" b="1" dirty="0">
+                          <a:solidFill>
+                            <a:srgbClr val="FFFFFF"/>
+                          </a:solidFill>
+                          <a:latin typeface="Calibri" pitchFamily="34" charset="0"/>
+                          <a:ea typeface="Calibri" pitchFamily="34" charset="-122"/>
+                          <a:cs typeface="Calibri" pitchFamily="34" charset="-120"/>
+                        </a:rPr>
+                        <a:t>Month</a:t>
+                      </a:r>
+                      <a:endParaRPr lang="en-US" sz="1000" dirty="0">
+                        <a:latin typeface="Calibri" charset="0"/>
+                        <a:ea typeface="Calibri" charset="0"/>
+                        <a:cs typeface="Calibri" charset="0"/>
+                      </a:endParaRPr>
+                    </a:p>
+                  </a:txBody>
+                  <a:tcPr marL="91440" marR="91440" marT="36576" marB="36576" anchor="ctr">
+                    <a:lnL w="9525" cap="flat" cmpd="sng" algn="ctr">
+                      <a:solidFill>
+                        <a:srgbClr val="E5E7EB"/>
+                      </a:solidFill>
+                      <a:prstDash val="solid"/>
+                      <a:round/>
+                      <a:headEnd type="none" w="med" len="med"/>
+                      <a:tailEnd type="none" w="med" len="med"/>
+                    </a:lnL>
+                    <a:lnR w="9525" cap="flat" cmpd="sng" algn="ctr">
+                      <a:solidFill>
+                        <a:srgbClr val="E5E7EB"/>
+                      </a:solidFill>
+                      <a:prstDash val="solid"/>
+                      <a:round/>
+                      <a:headEnd type="none" w="med" len="med"/>
+                      <a:tailEnd type="none" w="med" len="med"/>
+                    </a:lnR>
+                    <a:lnT w="9525" cap="flat" cmpd="sng" algn="ctr">
+                      <a:solidFill>
+                        <a:srgbClr val="E5E7EB"/>
+                      </a:solidFill>
+                      <a:prstDash val="solid"/>
+                      <a:round/>
+                      <a:headEnd type="none" w="med" len="med"/>
+                      <a:tailEnd type="none" w="med" len="med"/>
+                    </a:lnT>
+                    <a:lnB w="9525" cap="flat" cmpd="sng" algn="ctr">
+                      <a:solidFill>
+                        <a:srgbClr val="E5E7EB"/>
+                      </a:solidFill>
+                      <a:prstDash val="solid"/>
+                      <a:round/>
+                      <a:headEnd type="none" w="med" len="med"/>
+                      <a:tailEnd type="none" w="med" len="med"/>
+                    </a:lnB>
+                    <a:solidFill>
+                      <a:srgbClr val="1F2937"/>
+                    </a:solidFill>
+                  </a:tcPr>
+                </a:tc>
+                <a:tc>
+                  <a:txBody>
+                    <a:bodyPr/>
+                    <a:lstStyle/>
+                    <a:p>
+                      <a:pPr algn="r" indent="0" marL="0">
+                        <a:buNone/>
+                      </a:pPr>
+                      <a:r>
+                        <a:rPr lang="en-US" sz="1000" b="1" dirty="0">
+                          <a:solidFill>
+                            <a:srgbClr val="FFFFFF"/>
+                          </a:solidFill>
+                          <a:latin typeface="Calibri" pitchFamily="34" charset="0"/>
+                          <a:ea typeface="Calibri" pitchFamily="34" charset="-122"/>
+                          <a:cs typeface="Calibri" pitchFamily="34" charset="-120"/>
+                        </a:rPr>
+                        <a:t>LF all</a:t>
+                      </a:r>
+                      <a:endParaRPr lang="en-US" sz="1000" dirty="0">
+                        <a:latin typeface="Calibri" charset="0"/>
+                        <a:ea typeface="Calibri" charset="0"/>
+                        <a:cs typeface="Calibri" charset="0"/>
+                      </a:endParaRPr>
+                    </a:p>
+                  </a:txBody>
+                  <a:tcPr marL="91440" marR="91440" marT="36576" marB="36576" anchor="ctr">
+                    <a:lnL w="9525" cap="flat" cmpd="sng" algn="ctr">
+                      <a:solidFill>
+                        <a:srgbClr val="E5E7EB"/>
+                      </a:solidFill>
+                      <a:prstDash val="solid"/>
+                      <a:round/>
+                      <a:headEnd type="none" w="med" len="med"/>
+                      <a:tailEnd type="none" w="med" len="med"/>
+                    </a:lnL>
+                    <a:lnR w="9525" cap="flat" cmpd="sng" algn="ctr">
+                      <a:solidFill>
+                        <a:srgbClr val="E5E7EB"/>
+                      </a:solidFill>
+                      <a:prstDash val="solid"/>
+                      <a:round/>
+                      <a:headEnd type="none" w="med" len="med"/>
+                      <a:tailEnd type="none" w="med" len="med"/>
+                    </a:lnR>
+                    <a:lnT w="9525" cap="flat" cmpd="sng" algn="ctr">
+                      <a:solidFill>
+                        <a:srgbClr val="E5E7EB"/>
+                      </a:solidFill>
+                      <a:prstDash val="solid"/>
+                      <a:round/>
+                      <a:headEnd type="none" w="med" len="med"/>
+                      <a:tailEnd type="none" w="med" len="med"/>
+                    </a:lnT>
+                    <a:lnB w="9525" cap="flat" cmpd="sng" algn="ctr">
+                      <a:solidFill>
+                        <a:srgbClr val="E5E7EB"/>
+                      </a:solidFill>
+                      <a:prstDash val="solid"/>
+                      <a:round/>
+                      <a:headEnd type="none" w="med" len="med"/>
+                      <a:tailEnd type="none" w="med" len="med"/>
+                    </a:lnB>
+                    <a:solidFill>
+                      <a:srgbClr val="1F2937"/>
+                    </a:solidFill>
+                  </a:tcPr>
+                </a:tc>
+                <a:tc>
+                  <a:txBody>
+                    <a:bodyPr/>
+                    <a:lstStyle/>
+                    <a:p>
+                      <a:pPr algn="r" indent="0" marL="0">
+                        <a:buNone/>
+                      </a:pPr>
+                      <a:r>
+                        <a:rPr lang="en-US" sz="1000" b="1" dirty="0">
+                          <a:solidFill>
+                            <a:srgbClr val="FFFFFF"/>
+                          </a:solidFill>
+                          <a:latin typeface="Calibri" pitchFamily="34" charset="0"/>
+                          <a:ea typeface="Calibri" pitchFamily="34" charset="-122"/>
+                          <a:cs typeface="Calibri" pitchFamily="34" charset="-120"/>
+                        </a:rPr>
+                        <a:t>LF ex-Moncton</a:t>
+                      </a:r>
+                      <a:endParaRPr lang="en-US" sz="1000" dirty="0">
+                        <a:latin typeface="Calibri" charset="0"/>
+                        <a:ea typeface="Calibri" charset="0"/>
+                        <a:cs typeface="Calibri" charset="0"/>
+                      </a:endParaRPr>
+                    </a:p>
+                  </a:txBody>
+                  <a:tcPr marL="91440" marR="91440" marT="36576" marB="36576" anchor="ctr">
+                    <a:lnL w="9525" cap="flat" cmpd="sng" algn="ctr">
+                      <a:solidFill>
+                        <a:srgbClr val="E5E7EB"/>
+                      </a:solidFill>
+                      <a:prstDash val="solid"/>
+                      <a:round/>
+                      <a:headEnd type="none" w="med" len="med"/>
+                      <a:tailEnd type="none" w="med" len="med"/>
+                    </a:lnL>
+                    <a:lnR w="9525" cap="flat" cmpd="sng" algn="ctr">
+                      <a:solidFill>
+                        <a:srgbClr val="E5E7EB"/>
+                      </a:solidFill>
+                      <a:prstDash val="solid"/>
+                      <a:round/>
+                      <a:headEnd type="none" w="med" len="med"/>
+                      <a:tailEnd type="none" w="med" len="med"/>
+                    </a:lnR>
+                    <a:lnT w="9525" cap="flat" cmpd="sng" algn="ctr">
+                      <a:solidFill>
+                        <a:srgbClr val="E5E7EB"/>
+                      </a:solidFill>
+                      <a:prstDash val="solid"/>
+                      <a:round/>
+                      <a:headEnd type="none" w="med" len="med"/>
+                      <a:tailEnd type="none" w="med" len="med"/>
+                    </a:lnT>
+                    <a:lnB w="9525" cap="flat" cmpd="sng" algn="ctr">
+                      <a:solidFill>
+                        <a:srgbClr val="E5E7EB"/>
+                      </a:solidFill>
+                      <a:prstDash val="solid"/>
+                      <a:round/>
+                      <a:headEnd type="none" w="med" len="med"/>
+                      <a:tailEnd type="none" w="med" len="med"/>
+                    </a:lnB>
+                    <a:solidFill>
+                      <a:srgbClr val="1F2937"/>
+                    </a:solidFill>
+                  </a:tcPr>
+                </a:tc>
+                <a:tc>
+                  <a:txBody>
+                    <a:bodyPr/>
+                    <a:lstStyle/>
+                    <a:p>
+                      <a:pPr algn="r" indent="0" marL="0">
+                        <a:buNone/>
+                      </a:pPr>
+                      <a:r>
+                        <a:rPr lang="en-US" sz="1000" b="1" dirty="0">
+                          <a:solidFill>
+                            <a:srgbClr val="FFFFFF"/>
+                          </a:solidFill>
+                          <a:latin typeface="Calibri" pitchFamily="34" charset="0"/>
+                          <a:ea typeface="Calibri" pitchFamily="34" charset="-122"/>
+                          <a:cs typeface="Calibri" pitchFamily="34" charset="-120"/>
+                        </a:rPr>
+                        <a:t>Load all</a:t>
+                      </a:r>
+                      <a:endParaRPr lang="en-US" sz="1000" dirty="0">
+                        <a:latin typeface="Calibri" charset="0"/>
+                        <a:ea typeface="Calibri" charset="0"/>
+                        <a:cs typeface="Calibri" charset="0"/>
+                      </a:endParaRPr>
+                    </a:p>
+                  </a:txBody>
+                  <a:tcPr marL="91440" marR="91440" marT="36576" marB="36576" anchor="ctr">
+                    <a:lnL w="9525" cap="flat" cmpd="sng" algn="ctr">
+                      <a:solidFill>
+                        <a:srgbClr val="E5E7EB"/>
+                      </a:solidFill>
+                      <a:prstDash val="solid"/>
+                      <a:round/>
+                      <a:headEnd type="none" w="med" len="med"/>
+                      <a:tailEnd type="none" w="med" len="med"/>
+                    </a:lnL>
+                    <a:lnR w="9525" cap="flat" cmpd="sng" algn="ctr">
+                      <a:solidFill>
+                        <a:srgbClr val="E5E7EB"/>
+                      </a:solidFill>
+                      <a:prstDash val="solid"/>
+                      <a:round/>
+                      <a:headEnd type="none" w="med" len="med"/>
+                      <a:tailEnd type="none" w="med" len="med"/>
+                    </a:lnR>
+                    <a:lnT w="9525" cap="flat" cmpd="sng" algn="ctr">
+                      <a:solidFill>
+                        <a:srgbClr val="E5E7EB"/>
+                      </a:solidFill>
+                      <a:prstDash val="solid"/>
+                      <a:round/>
+                      <a:headEnd type="none" w="med" len="med"/>
+                      <a:tailEnd type="none" w="med" len="med"/>
+                    </a:lnT>
+                    <a:lnB w="9525" cap="flat" cmpd="sng" algn="ctr">
+                      <a:solidFill>
+                        <a:srgbClr val="E5E7EB"/>
+                      </a:solidFill>
+                      <a:prstDash val="solid"/>
+                      <a:round/>
+                      <a:headEnd type="none" w="med" len="med"/>
+                      <a:tailEnd type="none" w="med" len="med"/>
+                    </a:lnB>
+                    <a:solidFill>
+                      <a:srgbClr val="1F2937"/>
+                    </a:solidFill>
+                  </a:tcPr>
+                </a:tc>
+                <a:tc>
+                  <a:txBody>
+                    <a:bodyPr/>
+                    <a:lstStyle/>
+                    <a:p>
+                      <a:pPr algn="r" indent="0" marL="0">
+                        <a:buNone/>
+                      </a:pPr>
+                      <a:r>
+                        <a:rPr lang="en-US" sz="1000" b="1" dirty="0">
+                          <a:solidFill>
+                            <a:srgbClr val="FFFFFF"/>
+                          </a:solidFill>
+                          <a:latin typeface="Calibri" pitchFamily="34" charset="0"/>
+                          <a:ea typeface="Calibri" pitchFamily="34" charset="-122"/>
+                          <a:cs typeface="Calibri" pitchFamily="34" charset="-120"/>
+                        </a:rPr>
+                        <a:t>Load ex-Moncton</a:t>
+                      </a:r>
+                      <a:endParaRPr lang="en-US" sz="1000" dirty="0">
+                        <a:latin typeface="Calibri" charset="0"/>
+                        <a:ea typeface="Calibri" charset="0"/>
+                        <a:cs typeface="Calibri" charset="0"/>
+                      </a:endParaRPr>
+                    </a:p>
+                  </a:txBody>
+                  <a:tcPr marL="91440" marR="91440" marT="36576" marB="36576" anchor="ctr">
+                    <a:lnL w="9525" cap="flat" cmpd="sng" algn="ctr">
+                      <a:solidFill>
+                        <a:srgbClr val="E5E7EB"/>
+                      </a:solidFill>
+                      <a:prstDash val="solid"/>
+                      <a:round/>
+                      <a:headEnd type="none" w="med" len="med"/>
+                      <a:tailEnd type="none" w="med" len="med"/>
+                    </a:lnL>
+                    <a:lnR w="9525" cap="flat" cmpd="sng" algn="ctr">
+                      <a:solidFill>
+                        <a:srgbClr val="E5E7EB"/>
+                      </a:solidFill>
+                      <a:prstDash val="solid"/>
+                      <a:round/>
+                      <a:headEnd type="none" w="med" len="med"/>
+                      <a:tailEnd type="none" w="med" len="med"/>
+                    </a:lnR>
+                    <a:lnT w="9525" cap="flat" cmpd="sng" algn="ctr">
+                      <a:solidFill>
+                        <a:srgbClr val="E5E7EB"/>
+                      </a:solidFill>
+                      <a:prstDash val="solid"/>
+                      <a:round/>
+                      <a:headEnd type="none" w="med" len="med"/>
+                      <a:tailEnd type="none" w="med" len="med"/>
+                    </a:lnT>
+                    <a:lnB w="9525" cap="flat" cmpd="sng" algn="ctr">
+                      <a:solidFill>
+                        <a:srgbClr val="E5E7EB"/>
+                      </a:solidFill>
+                      <a:prstDash val="solid"/>
+                      <a:round/>
+                      <a:headEnd type="none" w="med" len="med"/>
+                      <a:tailEnd type="none" w="med" len="med"/>
+                    </a:lnB>
+                    <a:solidFill>
+                      <a:srgbClr val="1F2937"/>
+                    </a:solidFill>
+                  </a:tcPr>
+                </a:tc>
+              </a:tr>
+              <a:tr h="246888">
+                <a:tc>
+                  <a:txBody>
+                    <a:bodyPr/>
+                    <a:lstStyle/>
+                    <a:p>
+                      <a:pPr indent="0" marL="0">
+                        <a:buNone/>
+                      </a:pPr>
+                      <a:r>
+                        <a:rPr lang="en-US" sz="1000" b="1" dirty="0">
+                          <a:solidFill>
+                            <a:srgbClr val="111827"/>
+                          </a:solidFill>
+                          <a:latin typeface="Calibri" pitchFamily="34" charset="0"/>
+                          <a:ea typeface="Calibri" pitchFamily="34" charset="-122"/>
+                          <a:cs typeface="Calibri" pitchFamily="34" charset="-120"/>
+                        </a:rPr>
+                        <a:t>Jul</a:t>
+                      </a:r>
+                      <a:endParaRPr lang="en-US" sz="1000" dirty="0">
+                        <a:latin typeface="Calibri" charset="0"/>
+                        <a:ea typeface="Calibri" charset="0"/>
+                        <a:cs typeface="Calibri" charset="0"/>
+                      </a:endParaRPr>
+                    </a:p>
+                  </a:txBody>
+                  <a:tcPr marL="91440" marR="91440" marT="36576" marB="36576" anchor="ctr">
+                    <a:lnL w="9525" cap="flat" cmpd="sng" algn="ctr">
+                      <a:solidFill>
+                        <a:srgbClr val="E5E7EB"/>
+                      </a:solidFill>
+                      <a:prstDash val="solid"/>
+                      <a:round/>
+                      <a:headEnd type="none" w="med" len="med"/>
+                      <a:tailEnd type="none" w="med" len="med"/>
+                    </a:lnL>
+                    <a:lnR w="9525" cap="flat" cmpd="sng" algn="ctr">
+                      <a:solidFill>
+                        <a:srgbClr val="E5E7EB"/>
+                      </a:solidFill>
+                      <a:prstDash val="solid"/>
+                      <a:round/>
+                      <a:headEnd type="none" w="med" len="med"/>
+                      <a:tailEnd type="none" w="med" len="med"/>
+                    </a:lnR>
+                    <a:lnT w="9525" cap="flat" cmpd="sng" algn="ctr">
+                      <a:solidFill>
+                        <a:srgbClr val="E5E7EB"/>
+                      </a:solidFill>
+                      <a:prstDash val="solid"/>
+                      <a:round/>
+                      <a:headEnd type="none" w="med" len="med"/>
+                      <a:tailEnd type="none" w="med" len="med"/>
+                    </a:lnT>
+                    <a:lnB w="9525" cap="flat" cmpd="sng" algn="ctr">
+                      <a:solidFill>
+                        <a:srgbClr val="E5E7EB"/>
+                      </a:solidFill>
+                      <a:prstDash val="solid"/>
+                      <a:round/>
+                      <a:headEnd type="none" w="med" len="med"/>
+                      <a:tailEnd type="none" w="med" len="med"/>
+                    </a:lnB>
+                  </a:tcPr>
+                </a:tc>
+                <a:tc>
+                  <a:txBody>
+                    <a:bodyPr/>
+                    <a:lstStyle/>
+                    <a:p>
+                      <a:pPr algn="r" indent="0" marL="0">
+                        <a:buNone/>
+                      </a:pPr>
+                      <a:r>
+                        <a:rPr lang="en-US" sz="1000" dirty="0">
+                          <a:solidFill>
+                            <a:srgbClr val="6B7280"/>
+                          </a:solidFill>
+                          <a:latin typeface="Calibri" pitchFamily="34" charset="0"/>
+                          <a:ea typeface="Calibri" pitchFamily="34" charset="-122"/>
+                          <a:cs typeface="Calibri" pitchFamily="34" charset="-120"/>
+                        </a:rPr>
+                        <a:t>38.9%</a:t>
+                      </a:r>
+                      <a:endParaRPr lang="en-US" sz="1000" dirty="0">
+                        <a:latin typeface="Calibri" charset="0"/>
+                        <a:ea typeface="Calibri" charset="0"/>
+                        <a:cs typeface="Calibri" charset="0"/>
+                      </a:endParaRPr>
+                    </a:p>
+                  </a:txBody>
+                  <a:tcPr marL="91440" marR="91440" marT="36576" marB="36576" anchor="ctr">
+                    <a:lnL w="9525" cap="flat" cmpd="sng" algn="ctr">
+                      <a:solidFill>
+                        <a:srgbClr val="E5E7EB"/>
+                      </a:solidFill>
+                      <a:prstDash val="solid"/>
+                      <a:round/>
+                      <a:headEnd type="none" w="med" len="med"/>
+                      <a:tailEnd type="none" w="med" len="med"/>
+                    </a:lnL>
+                    <a:lnR w="9525" cap="flat" cmpd="sng" algn="ctr">
+                      <a:solidFill>
+                        <a:srgbClr val="E5E7EB"/>
+                      </a:solidFill>
+                      <a:prstDash val="solid"/>
+                      <a:round/>
+                      <a:headEnd type="none" w="med" len="med"/>
+                      <a:tailEnd type="none" w="med" len="med"/>
+                    </a:lnR>
+                    <a:lnT w="9525" cap="flat" cmpd="sng" algn="ctr">
+                      <a:solidFill>
+                        <a:srgbClr val="E5E7EB"/>
+                      </a:solidFill>
+                      <a:prstDash val="solid"/>
+                      <a:round/>
+                      <a:headEnd type="none" w="med" len="med"/>
+                      <a:tailEnd type="none" w="med" len="med"/>
+                    </a:lnT>
+                    <a:lnB w="9525" cap="flat" cmpd="sng" algn="ctr">
+                      <a:solidFill>
+                        <a:srgbClr val="E5E7EB"/>
+                      </a:solidFill>
+                      <a:prstDash val="solid"/>
+                      <a:round/>
+                      <a:headEnd type="none" w="med" len="med"/>
+                      <a:tailEnd type="none" w="med" len="med"/>
+                    </a:lnB>
+                  </a:tcPr>
+                </a:tc>
+                <a:tc>
+                  <a:txBody>
+                    <a:bodyPr/>
+                    <a:lstStyle/>
+                    <a:p>
+                      <a:pPr algn="r" indent="0" marL="0">
+                        <a:buNone/>
+                      </a:pPr>
+                      <a:r>
+                        <a:rPr lang="en-US" sz="1000" b="1" dirty="0">
+                          <a:solidFill>
+                            <a:srgbClr val="111827"/>
+                          </a:solidFill>
+                          <a:latin typeface="Calibri" pitchFamily="34" charset="0"/>
+                          <a:ea typeface="Calibri" pitchFamily="34" charset="-122"/>
+                          <a:cs typeface="Calibri" pitchFamily="34" charset="-120"/>
+                        </a:rPr>
+                        <a:t>42.0%</a:t>
+                      </a:r>
+                      <a:endParaRPr lang="en-US" sz="1000" dirty="0">
+                        <a:latin typeface="Calibri" charset="0"/>
+                        <a:ea typeface="Calibri" charset="0"/>
+                        <a:cs typeface="Calibri" charset="0"/>
+                      </a:endParaRPr>
+                    </a:p>
+                  </a:txBody>
+                  <a:tcPr marL="91440" marR="91440" marT="36576" marB="36576" anchor="ctr">
+                    <a:lnL w="9525" cap="flat" cmpd="sng" algn="ctr">
+                      <a:solidFill>
+                        <a:srgbClr val="E5E7EB"/>
+                      </a:solidFill>
+                      <a:prstDash val="solid"/>
+                      <a:round/>
+                      <a:headEnd type="none" w="med" len="med"/>
+                      <a:tailEnd type="none" w="med" len="med"/>
+                    </a:lnL>
+                    <a:lnR w="9525" cap="flat" cmpd="sng" algn="ctr">
+                      <a:solidFill>
+                        <a:srgbClr val="E5E7EB"/>
+                      </a:solidFill>
+                      <a:prstDash val="solid"/>
+                      <a:round/>
+                      <a:headEnd type="none" w="med" len="med"/>
+                      <a:tailEnd type="none" w="med" len="med"/>
+                    </a:lnR>
+                    <a:lnT w="9525" cap="flat" cmpd="sng" algn="ctr">
+                      <a:solidFill>
+                        <a:srgbClr val="E5E7EB"/>
+                      </a:solidFill>
+                      <a:prstDash val="solid"/>
+                      <a:round/>
+                      <a:headEnd type="none" w="med" len="med"/>
+                      <a:tailEnd type="none" w="med" len="med"/>
+                    </a:lnT>
+                    <a:lnB w="9525" cap="flat" cmpd="sng" algn="ctr">
+                      <a:solidFill>
+                        <a:srgbClr val="E5E7EB"/>
+                      </a:solidFill>
+                      <a:prstDash val="solid"/>
+                      <a:round/>
+                      <a:headEnd type="none" w="med" len="med"/>
+                      <a:tailEnd type="none" w="med" len="med"/>
+                    </a:lnB>
+                  </a:tcPr>
+                </a:tc>
+                <a:tc>
+                  <a:txBody>
+                    <a:bodyPr/>
+                    <a:lstStyle/>
+                    <a:p>
+                      <a:pPr algn="r" indent="0" marL="0">
+                        <a:buNone/>
+                      </a:pPr>
+                      <a:r>
+                        <a:rPr lang="en-US" sz="1000" dirty="0">
+                          <a:solidFill>
+                            <a:srgbClr val="6B7280"/>
+                          </a:solidFill>
+                          <a:latin typeface="Calibri" pitchFamily="34" charset="0"/>
+                          <a:ea typeface="Calibri" pitchFamily="34" charset="-122"/>
+                          <a:cs typeface="Calibri" pitchFamily="34" charset="-120"/>
+                        </a:rPr>
+                        <a:t>79.6%</a:t>
+                      </a:r>
+                      <a:endParaRPr lang="en-US" sz="1000" dirty="0">
+                        <a:latin typeface="Calibri" charset="0"/>
+                        <a:ea typeface="Calibri" charset="0"/>
+                        <a:cs typeface="Calibri" charset="0"/>
+                      </a:endParaRPr>
+                    </a:p>
+                  </a:txBody>
+                  <a:tcPr marL="91440" marR="91440" marT="36576" marB="36576" anchor="ctr">
+                    <a:lnL w="9525" cap="flat" cmpd="sng" algn="ctr">
+                      <a:solidFill>
+                        <a:srgbClr val="E5E7EB"/>
+                      </a:solidFill>
+                      <a:prstDash val="solid"/>
+                      <a:round/>
+                      <a:headEnd type="none" w="med" len="med"/>
+                      <a:tailEnd type="none" w="med" len="med"/>
+                    </a:lnL>
+                    <a:lnR w="9525" cap="flat" cmpd="sng" algn="ctr">
+                      <a:solidFill>
+                        <a:srgbClr val="E5E7EB"/>
+                      </a:solidFill>
+                      <a:prstDash val="solid"/>
+                      <a:round/>
+                      <a:headEnd type="none" w="med" len="med"/>
+                      <a:tailEnd type="none" w="med" len="med"/>
+                    </a:lnR>
+                    <a:lnT w="9525" cap="flat" cmpd="sng" algn="ctr">
+                      <a:solidFill>
+                        <a:srgbClr val="E5E7EB"/>
+                      </a:solidFill>
+                      <a:prstDash val="solid"/>
+                      <a:round/>
+                      <a:headEnd type="none" w="med" len="med"/>
+                      <a:tailEnd type="none" w="med" len="med"/>
+                    </a:lnT>
+                    <a:lnB w="9525" cap="flat" cmpd="sng" algn="ctr">
+                      <a:solidFill>
+                        <a:srgbClr val="E5E7EB"/>
+                      </a:solidFill>
+                      <a:prstDash val="solid"/>
+                      <a:round/>
+                      <a:headEnd type="none" w="med" len="med"/>
+                      <a:tailEnd type="none" w="med" len="med"/>
+                    </a:lnB>
+                  </a:tcPr>
+                </a:tc>
+                <a:tc>
+                  <a:txBody>
+                    <a:bodyPr/>
+                    <a:lstStyle/>
+                    <a:p>
+                      <a:pPr algn="r" indent="0" marL="0">
+                        <a:buNone/>
+                      </a:pPr>
+                      <a:r>
+                        <a:rPr lang="en-US" sz="1000" b="1" dirty="0">
+                          <a:solidFill>
+                            <a:srgbClr val="111827"/>
+                          </a:solidFill>
+                          <a:latin typeface="Calibri" pitchFamily="34" charset="0"/>
+                          <a:ea typeface="Calibri" pitchFamily="34" charset="-122"/>
+                          <a:cs typeface="Calibri" pitchFamily="34" charset="-120"/>
+                        </a:rPr>
+                        <a:t>79.2%</a:t>
+                      </a:r>
+                      <a:endParaRPr lang="en-US" sz="1000" dirty="0">
+                        <a:latin typeface="Calibri" charset="0"/>
+                        <a:ea typeface="Calibri" charset="0"/>
+                        <a:cs typeface="Calibri" charset="0"/>
+                      </a:endParaRPr>
+                    </a:p>
+                  </a:txBody>
+                  <a:tcPr marL="91440" marR="91440" marT="36576" marB="36576" anchor="ctr">
+                    <a:lnL w="9525" cap="flat" cmpd="sng" algn="ctr">
+                      <a:solidFill>
+                        <a:srgbClr val="E5E7EB"/>
+                      </a:solidFill>
+                      <a:prstDash val="solid"/>
+                      <a:round/>
+                      <a:headEnd type="none" w="med" len="med"/>
+                      <a:tailEnd type="none" w="med" len="med"/>
+                    </a:lnL>
+                    <a:lnR w="9525" cap="flat" cmpd="sng" algn="ctr">
+                      <a:solidFill>
+                        <a:srgbClr val="E5E7EB"/>
+                      </a:solidFill>
+                      <a:prstDash val="solid"/>
+                      <a:round/>
+                      <a:headEnd type="none" w="med" len="med"/>
+                      <a:tailEnd type="none" w="med" len="med"/>
+                    </a:lnR>
+                    <a:lnT w="9525" cap="flat" cmpd="sng" algn="ctr">
+                      <a:solidFill>
+                        <a:srgbClr val="E5E7EB"/>
+                      </a:solidFill>
+                      <a:prstDash val="solid"/>
+                      <a:round/>
+                      <a:headEnd type="none" w="med" len="med"/>
+                      <a:tailEnd type="none" w="med" len="med"/>
+                    </a:lnT>
+                    <a:lnB w="9525" cap="flat" cmpd="sng" algn="ctr">
+                      <a:solidFill>
+                        <a:srgbClr val="E5E7EB"/>
+                      </a:solidFill>
+                      <a:prstDash val="solid"/>
+                      <a:round/>
+                      <a:headEnd type="none" w="med" len="med"/>
+                      <a:tailEnd type="none" w="med" len="med"/>
+                    </a:lnB>
+                  </a:tcPr>
+                </a:tc>
+              </a:tr>
+              <a:tr h="246888">
+                <a:tc>
+                  <a:txBody>
+                    <a:bodyPr/>
+                    <a:lstStyle/>
+                    <a:p>
+                      <a:pPr indent="0" marL="0">
+                        <a:buNone/>
+                      </a:pPr>
+                      <a:r>
+                        <a:rPr lang="en-US" sz="1000" b="1" dirty="0">
+                          <a:solidFill>
+                            <a:srgbClr val="111827"/>
+                          </a:solidFill>
+                          <a:latin typeface="Calibri" pitchFamily="34" charset="0"/>
+                          <a:ea typeface="Calibri" pitchFamily="34" charset="-122"/>
+                          <a:cs typeface="Calibri" pitchFamily="34" charset="-120"/>
+                        </a:rPr>
+                        <a:t>Aug</a:t>
+                      </a:r>
+                      <a:endParaRPr lang="en-US" sz="1000" dirty="0">
+                        <a:latin typeface="Calibri" charset="0"/>
+                        <a:ea typeface="Calibri" charset="0"/>
+                        <a:cs typeface="Calibri" charset="0"/>
+                      </a:endParaRPr>
+                    </a:p>
+                  </a:txBody>
+                  <a:tcPr marL="91440" marR="91440" marT="36576" marB="36576" anchor="ctr">
+                    <a:lnL w="9525" cap="flat" cmpd="sng" algn="ctr">
+                      <a:solidFill>
+                        <a:srgbClr val="E5E7EB"/>
+                      </a:solidFill>
+                      <a:prstDash val="solid"/>
+                      <a:round/>
+                      <a:headEnd type="none" w="med" len="med"/>
+                      <a:tailEnd type="none" w="med" len="med"/>
+                    </a:lnL>
+                    <a:lnR w="9525" cap="flat" cmpd="sng" algn="ctr">
+                      <a:solidFill>
+                        <a:srgbClr val="E5E7EB"/>
+                      </a:solidFill>
+                      <a:prstDash val="solid"/>
+                      <a:round/>
+                      <a:headEnd type="none" w="med" len="med"/>
+                      <a:tailEnd type="none" w="med" len="med"/>
+                    </a:lnR>
+                    <a:lnT w="9525" cap="flat" cmpd="sng" algn="ctr">
+                      <a:solidFill>
+                        <a:srgbClr val="E5E7EB"/>
+                      </a:solidFill>
+                      <a:prstDash val="solid"/>
+                      <a:round/>
+                      <a:headEnd type="none" w="med" len="med"/>
+                      <a:tailEnd type="none" w="med" len="med"/>
+                    </a:lnT>
+                    <a:lnB w="9525" cap="flat" cmpd="sng" algn="ctr">
+                      <a:solidFill>
+                        <a:srgbClr val="E5E7EB"/>
+                      </a:solidFill>
+                      <a:prstDash val="solid"/>
+                      <a:round/>
+                      <a:headEnd type="none" w="med" len="med"/>
+                      <a:tailEnd type="none" w="med" len="med"/>
+                    </a:lnB>
+                  </a:tcPr>
+                </a:tc>
+                <a:tc>
+                  <a:txBody>
+                    <a:bodyPr/>
+                    <a:lstStyle/>
+                    <a:p>
+                      <a:pPr algn="r" indent="0" marL="0">
+                        <a:buNone/>
+                      </a:pPr>
+                      <a:r>
+                        <a:rPr lang="en-US" sz="1000" dirty="0">
+                          <a:solidFill>
+                            <a:srgbClr val="6B7280"/>
+                          </a:solidFill>
+                          <a:latin typeface="Calibri" pitchFamily="34" charset="0"/>
+                          <a:ea typeface="Calibri" pitchFamily="34" charset="-122"/>
+                          <a:cs typeface="Calibri" pitchFamily="34" charset="-120"/>
+                        </a:rPr>
+                        <a:t>33.4%</a:t>
+                      </a:r>
+                      <a:endParaRPr lang="en-US" sz="1000" dirty="0">
+                        <a:latin typeface="Calibri" charset="0"/>
+                        <a:ea typeface="Calibri" charset="0"/>
+                        <a:cs typeface="Calibri" charset="0"/>
+                      </a:endParaRPr>
+                    </a:p>
+                  </a:txBody>
+                  <a:tcPr marL="91440" marR="91440" marT="36576" marB="36576" anchor="ctr">
+                    <a:lnL w="9525" cap="flat" cmpd="sng" algn="ctr">
+                      <a:solidFill>
+                        <a:srgbClr val="E5E7EB"/>
+                      </a:solidFill>
+                      <a:prstDash val="solid"/>
+                      <a:round/>
+                      <a:headEnd type="none" w="med" len="med"/>
+                      <a:tailEnd type="none" w="med" len="med"/>
+                    </a:lnL>
+                    <a:lnR w="9525" cap="flat" cmpd="sng" algn="ctr">
+                      <a:solidFill>
+                        <a:srgbClr val="E5E7EB"/>
+                      </a:solidFill>
+                      <a:prstDash val="solid"/>
+                      <a:round/>
+                      <a:headEnd type="none" w="med" len="med"/>
+                      <a:tailEnd type="none" w="med" len="med"/>
+                    </a:lnR>
+                    <a:lnT w="9525" cap="flat" cmpd="sng" algn="ctr">
+                      <a:solidFill>
+                        <a:srgbClr val="E5E7EB"/>
+                      </a:solidFill>
+                      <a:prstDash val="solid"/>
+                      <a:round/>
+                      <a:headEnd type="none" w="med" len="med"/>
+                      <a:tailEnd type="none" w="med" len="med"/>
+                    </a:lnT>
+                    <a:lnB w="9525" cap="flat" cmpd="sng" algn="ctr">
+                      <a:solidFill>
+                        <a:srgbClr val="E5E7EB"/>
+                      </a:solidFill>
+                      <a:prstDash val="solid"/>
+                      <a:round/>
+                      <a:headEnd type="none" w="med" len="med"/>
+                      <a:tailEnd type="none" w="med" len="med"/>
+                    </a:lnB>
+                  </a:tcPr>
+                </a:tc>
+                <a:tc>
+                  <a:txBody>
+                    <a:bodyPr/>
+                    <a:lstStyle/>
+                    <a:p>
+                      <a:pPr algn="r" indent="0" marL="0">
+                        <a:buNone/>
+                      </a:pPr>
+                      <a:r>
+                        <a:rPr lang="en-US" sz="1000" b="1" dirty="0">
+                          <a:solidFill>
+                            <a:srgbClr val="111827"/>
+                          </a:solidFill>
+                          <a:latin typeface="Calibri" pitchFamily="34" charset="0"/>
+                          <a:ea typeface="Calibri" pitchFamily="34" charset="-122"/>
+                          <a:cs typeface="Calibri" pitchFamily="34" charset="-120"/>
+                        </a:rPr>
+                        <a:t>38.5%</a:t>
+                      </a:r>
+                      <a:endParaRPr lang="en-US" sz="1000" dirty="0">
+                        <a:latin typeface="Calibri" charset="0"/>
+                        <a:ea typeface="Calibri" charset="0"/>
+                        <a:cs typeface="Calibri" charset="0"/>
+                      </a:endParaRPr>
+                    </a:p>
+                  </a:txBody>
+                  <a:tcPr marL="91440" marR="91440" marT="36576" marB="36576" anchor="ctr">
+                    <a:lnL w="9525" cap="flat" cmpd="sng" algn="ctr">
+                      <a:solidFill>
+                        <a:srgbClr val="E5E7EB"/>
+                      </a:solidFill>
+                      <a:prstDash val="solid"/>
+                      <a:round/>
+                      <a:headEnd type="none" w="med" len="med"/>
+                      <a:tailEnd type="none" w="med" len="med"/>
+                    </a:lnL>
+                    <a:lnR w="9525" cap="flat" cmpd="sng" algn="ctr">
+                      <a:solidFill>
+                        <a:srgbClr val="E5E7EB"/>
+                      </a:solidFill>
+                      <a:prstDash val="solid"/>
+                      <a:round/>
+                      <a:headEnd type="none" w="med" len="med"/>
+                      <a:tailEnd type="none" w="med" len="med"/>
+                    </a:lnR>
+                    <a:lnT w="9525" cap="flat" cmpd="sng" algn="ctr">
+                      <a:solidFill>
+                        <a:srgbClr val="E5E7EB"/>
+                      </a:solidFill>
+                      <a:prstDash val="solid"/>
+                      <a:round/>
+                      <a:headEnd type="none" w="med" len="med"/>
+                      <a:tailEnd type="none" w="med" len="med"/>
+                    </a:lnT>
+                    <a:lnB w="9525" cap="flat" cmpd="sng" algn="ctr">
+                      <a:solidFill>
+                        <a:srgbClr val="E5E7EB"/>
+                      </a:solidFill>
+                      <a:prstDash val="solid"/>
+                      <a:round/>
+                      <a:headEnd type="none" w="med" len="med"/>
+                      <a:tailEnd type="none" w="med" len="med"/>
+                    </a:lnB>
+                  </a:tcPr>
+                </a:tc>
+                <a:tc>
+                  <a:txBody>
+                    <a:bodyPr/>
+                    <a:lstStyle/>
+                    <a:p>
+                      <a:pPr algn="r" indent="0" marL="0">
+                        <a:buNone/>
+                      </a:pPr>
+                      <a:r>
+                        <a:rPr lang="en-US" sz="1000" dirty="0">
+                          <a:solidFill>
+                            <a:srgbClr val="6B7280"/>
+                          </a:solidFill>
+                          <a:latin typeface="Calibri" pitchFamily="34" charset="0"/>
+                          <a:ea typeface="Calibri" pitchFamily="34" charset="-122"/>
+                          <a:cs typeface="Calibri" pitchFamily="34" charset="-120"/>
+                        </a:rPr>
+                        <a:t>71.5%</a:t>
+                      </a:r>
+                      <a:endParaRPr lang="en-US" sz="1000" dirty="0">
+                        <a:latin typeface="Calibri" charset="0"/>
+                        <a:ea typeface="Calibri" charset="0"/>
+                        <a:cs typeface="Calibri" charset="0"/>
+                      </a:endParaRPr>
+                    </a:p>
+                  </a:txBody>
+                  <a:tcPr marL="91440" marR="91440" marT="36576" marB="36576" anchor="ctr">
+                    <a:lnL w="9525" cap="flat" cmpd="sng" algn="ctr">
+                      <a:solidFill>
+                        <a:srgbClr val="E5E7EB"/>
+                      </a:solidFill>
+                      <a:prstDash val="solid"/>
+                      <a:round/>
+                      <a:headEnd type="none" w="med" len="med"/>
+                      <a:tailEnd type="none" w="med" len="med"/>
+                    </a:lnL>
+                    <a:lnR w="9525" cap="flat" cmpd="sng" algn="ctr">
+                      <a:solidFill>
+                        <a:srgbClr val="E5E7EB"/>
+                      </a:solidFill>
+                      <a:prstDash val="solid"/>
+                      <a:round/>
+                      <a:headEnd type="none" w="med" len="med"/>
+                      <a:tailEnd type="none" w="med" len="med"/>
+                    </a:lnR>
+                    <a:lnT w="9525" cap="flat" cmpd="sng" algn="ctr">
+                      <a:solidFill>
+                        <a:srgbClr val="E5E7EB"/>
+                      </a:solidFill>
+                      <a:prstDash val="solid"/>
+                      <a:round/>
+                      <a:headEnd type="none" w="med" len="med"/>
+                      <a:tailEnd type="none" w="med" len="med"/>
+                    </a:lnT>
+                    <a:lnB w="9525" cap="flat" cmpd="sng" algn="ctr">
+                      <a:solidFill>
+                        <a:srgbClr val="E5E7EB"/>
+                      </a:solidFill>
+                      <a:prstDash val="solid"/>
+                      <a:round/>
+                      <a:headEnd type="none" w="med" len="med"/>
+                      <a:tailEnd type="none" w="med" len="med"/>
+                    </a:lnB>
+                  </a:tcPr>
+                </a:tc>
+                <a:tc>
+                  <a:txBody>
+                    <a:bodyPr/>
+                    <a:lstStyle/>
+                    <a:p>
+                      <a:pPr algn="r" indent="0" marL="0">
+                        <a:buNone/>
+                      </a:pPr>
+                      <a:r>
+                        <a:rPr lang="en-US" sz="1000" b="1" dirty="0">
+                          <a:solidFill>
+                            <a:srgbClr val="111827"/>
+                          </a:solidFill>
+                          <a:latin typeface="Calibri" pitchFamily="34" charset="0"/>
+                          <a:ea typeface="Calibri" pitchFamily="34" charset="-122"/>
+                          <a:cs typeface="Calibri" pitchFamily="34" charset="-120"/>
+                        </a:rPr>
+                        <a:t>75.7%</a:t>
+                      </a:r>
+                      <a:endParaRPr lang="en-US" sz="1000" dirty="0">
+                        <a:latin typeface="Calibri" charset="0"/>
+                        <a:ea typeface="Calibri" charset="0"/>
+                        <a:cs typeface="Calibri" charset="0"/>
+                      </a:endParaRPr>
+                    </a:p>
+                  </a:txBody>
+                  <a:tcPr marL="91440" marR="91440" marT="36576" marB="36576" anchor="ctr">
+                    <a:lnL w="9525" cap="flat" cmpd="sng" algn="ctr">
+                      <a:solidFill>
+                        <a:srgbClr val="E5E7EB"/>
+                      </a:solidFill>
+                      <a:prstDash val="solid"/>
+                      <a:round/>
+                      <a:headEnd type="none" w="med" len="med"/>
+                      <a:tailEnd type="none" w="med" len="med"/>
+                    </a:lnL>
+                    <a:lnR w="9525" cap="flat" cmpd="sng" algn="ctr">
+                      <a:solidFill>
+                        <a:srgbClr val="E5E7EB"/>
+                      </a:solidFill>
+                      <a:prstDash val="solid"/>
+                      <a:round/>
+                      <a:headEnd type="none" w="med" len="med"/>
+                      <a:tailEnd type="none" w="med" len="med"/>
+                    </a:lnR>
+                    <a:lnT w="9525" cap="flat" cmpd="sng" algn="ctr">
+                      <a:solidFill>
+                        <a:srgbClr val="E5E7EB"/>
+                      </a:solidFill>
+                      <a:prstDash val="solid"/>
+                      <a:round/>
+                      <a:headEnd type="none" w="med" len="med"/>
+                      <a:tailEnd type="none" w="med" len="med"/>
+                    </a:lnT>
+                    <a:lnB w="9525" cap="flat" cmpd="sng" algn="ctr">
+                      <a:solidFill>
+                        <a:srgbClr val="E5E7EB"/>
+                      </a:solidFill>
+                      <a:prstDash val="solid"/>
+                      <a:round/>
+                      <a:headEnd type="none" w="med" len="med"/>
+                      <a:tailEnd type="none" w="med" len="med"/>
+                    </a:lnB>
+                  </a:tcPr>
+                </a:tc>
+              </a:tr>
+              <a:tr h="246888">
+                <a:tc>
+                  <a:txBody>
+                    <a:bodyPr/>
+                    <a:lstStyle/>
+                    <a:p>
+                      <a:pPr indent="0" marL="0">
+                        <a:buNone/>
+                      </a:pPr>
+                      <a:r>
+                        <a:rPr lang="en-US" sz="1000" b="1" dirty="0">
+                          <a:solidFill>
+                            <a:srgbClr val="111827"/>
+                          </a:solidFill>
+                          <a:latin typeface="Calibri" pitchFamily="34" charset="0"/>
+                          <a:ea typeface="Calibri" pitchFamily="34" charset="-122"/>
+                          <a:cs typeface="Calibri" pitchFamily="34" charset="-120"/>
+                        </a:rPr>
+                        <a:t>Sep</a:t>
+                      </a:r>
+                      <a:endParaRPr lang="en-US" sz="1000" dirty="0">
+                        <a:latin typeface="Calibri" charset="0"/>
+                        <a:ea typeface="Calibri" charset="0"/>
+                        <a:cs typeface="Calibri" charset="0"/>
+                      </a:endParaRPr>
+                    </a:p>
+                  </a:txBody>
+                  <a:tcPr marL="91440" marR="91440" marT="36576" marB="36576" anchor="ctr">
+                    <a:lnL w="9525" cap="flat" cmpd="sng" algn="ctr">
+                      <a:solidFill>
+                        <a:srgbClr val="E5E7EB"/>
+                      </a:solidFill>
+                      <a:prstDash val="solid"/>
+                      <a:round/>
+                      <a:headEnd type="none" w="med" len="med"/>
+                      <a:tailEnd type="none" w="med" len="med"/>
+                    </a:lnL>
+                    <a:lnR w="9525" cap="flat" cmpd="sng" algn="ctr">
+                      <a:solidFill>
+                        <a:srgbClr val="E5E7EB"/>
+                      </a:solidFill>
+                      <a:prstDash val="solid"/>
+                      <a:round/>
+                      <a:headEnd type="none" w="med" len="med"/>
+                      <a:tailEnd type="none" w="med" len="med"/>
+                    </a:lnR>
+                    <a:lnT w="9525" cap="flat" cmpd="sng" algn="ctr">
+                      <a:solidFill>
+                        <a:srgbClr val="E5E7EB"/>
+                      </a:solidFill>
+                      <a:prstDash val="solid"/>
+                      <a:round/>
+                      <a:headEnd type="none" w="med" len="med"/>
+                      <a:tailEnd type="none" w="med" len="med"/>
+                    </a:lnT>
+                    <a:lnB w="9525" cap="flat" cmpd="sng" algn="ctr">
+                      <a:solidFill>
+                        <a:srgbClr val="E5E7EB"/>
+                      </a:solidFill>
+                      <a:prstDash val="solid"/>
+                      <a:round/>
+                      <a:headEnd type="none" w="med" len="med"/>
+                      <a:tailEnd type="none" w="med" len="med"/>
+                    </a:lnB>
+                  </a:tcPr>
+                </a:tc>
+                <a:tc>
+                  <a:txBody>
+                    <a:bodyPr/>
+                    <a:lstStyle/>
+                    <a:p>
+                      <a:pPr algn="r" indent="0" marL="0">
+                        <a:buNone/>
+                      </a:pPr>
+                      <a:r>
+                        <a:rPr lang="en-US" sz="1000" dirty="0">
+                          <a:solidFill>
+                            <a:srgbClr val="6B7280"/>
+                          </a:solidFill>
+                          <a:latin typeface="Calibri" pitchFamily="34" charset="0"/>
+                          <a:ea typeface="Calibri" pitchFamily="34" charset="-122"/>
+                          <a:cs typeface="Calibri" pitchFamily="34" charset="-120"/>
+                        </a:rPr>
+                        <a:t>36.7%</a:t>
+                      </a:r>
+                      <a:endParaRPr lang="en-US" sz="1000" dirty="0">
+                        <a:latin typeface="Calibri" charset="0"/>
+                        <a:ea typeface="Calibri" charset="0"/>
+                        <a:cs typeface="Calibri" charset="0"/>
+                      </a:endParaRPr>
+                    </a:p>
+                  </a:txBody>
+                  <a:tcPr marL="91440" marR="91440" marT="36576" marB="36576" anchor="ctr">
+                    <a:lnL w="9525" cap="flat" cmpd="sng" algn="ctr">
+                      <a:solidFill>
+                        <a:srgbClr val="E5E7EB"/>
+                      </a:solidFill>
+                      <a:prstDash val="solid"/>
+                      <a:round/>
+                      <a:headEnd type="none" w="med" len="med"/>
+                      <a:tailEnd type="none" w="med" len="med"/>
+                    </a:lnL>
+                    <a:lnR w="9525" cap="flat" cmpd="sng" algn="ctr">
+                      <a:solidFill>
+                        <a:srgbClr val="E5E7EB"/>
+                      </a:solidFill>
+                      <a:prstDash val="solid"/>
+                      <a:round/>
+                      <a:headEnd type="none" w="med" len="med"/>
+                      <a:tailEnd type="none" w="med" len="med"/>
+                    </a:lnR>
+                    <a:lnT w="9525" cap="flat" cmpd="sng" algn="ctr">
+                      <a:solidFill>
+                        <a:srgbClr val="E5E7EB"/>
+                      </a:solidFill>
+                      <a:prstDash val="solid"/>
+                      <a:round/>
+                      <a:headEnd type="none" w="med" len="med"/>
+                      <a:tailEnd type="none" w="med" len="med"/>
+                    </a:lnT>
+                    <a:lnB w="9525" cap="flat" cmpd="sng" algn="ctr">
+                      <a:solidFill>
+                        <a:srgbClr val="E5E7EB"/>
+                      </a:solidFill>
+                      <a:prstDash val="solid"/>
+                      <a:round/>
+                      <a:headEnd type="none" w="med" len="med"/>
+                      <a:tailEnd type="none" w="med" len="med"/>
+                    </a:lnB>
+                  </a:tcPr>
+                </a:tc>
+                <a:tc>
+                  <a:txBody>
+                    <a:bodyPr/>
+                    <a:lstStyle/>
+                    <a:p>
+                      <a:pPr algn="r" indent="0" marL="0">
+                        <a:buNone/>
+                      </a:pPr>
+                      <a:r>
+                        <a:rPr lang="en-US" sz="1000" b="1" dirty="0">
+                          <a:solidFill>
+                            <a:srgbClr val="111827"/>
+                          </a:solidFill>
+                          <a:latin typeface="Calibri" pitchFamily="34" charset="0"/>
+                          <a:ea typeface="Calibri" pitchFamily="34" charset="-122"/>
+                          <a:cs typeface="Calibri" pitchFamily="34" charset="-120"/>
+                        </a:rPr>
+                        <a:t>37.6%</a:t>
+                      </a:r>
+                      <a:endParaRPr lang="en-US" sz="1000" dirty="0">
+                        <a:latin typeface="Calibri" charset="0"/>
+                        <a:ea typeface="Calibri" charset="0"/>
+                        <a:cs typeface="Calibri" charset="0"/>
+                      </a:endParaRPr>
+                    </a:p>
+                  </a:txBody>
+                  <a:tcPr marL="91440" marR="91440" marT="36576" marB="36576" anchor="ctr">
+                    <a:lnL w="9525" cap="flat" cmpd="sng" algn="ctr">
+                      <a:solidFill>
+                        <a:srgbClr val="E5E7EB"/>
+                      </a:solidFill>
+                      <a:prstDash val="solid"/>
+                      <a:round/>
+                      <a:headEnd type="none" w="med" len="med"/>
+                      <a:tailEnd type="none" w="med" len="med"/>
+                    </a:lnL>
+                    <a:lnR w="9525" cap="flat" cmpd="sng" algn="ctr">
+                      <a:solidFill>
+                        <a:srgbClr val="E5E7EB"/>
+                      </a:solidFill>
+                      <a:prstDash val="solid"/>
+                      <a:round/>
+                      <a:headEnd type="none" w="med" len="med"/>
+                      <a:tailEnd type="none" w="med" len="med"/>
+                    </a:lnR>
+                    <a:lnT w="9525" cap="flat" cmpd="sng" algn="ctr">
+                      <a:solidFill>
+                        <a:srgbClr val="E5E7EB"/>
+                      </a:solidFill>
+                      <a:prstDash val="solid"/>
+                      <a:round/>
+                      <a:headEnd type="none" w="med" len="med"/>
+                      <a:tailEnd type="none" w="med" len="med"/>
+                    </a:lnT>
+                    <a:lnB w="9525" cap="flat" cmpd="sng" algn="ctr">
+                      <a:solidFill>
+                        <a:srgbClr val="E5E7EB"/>
+                      </a:solidFill>
+                      <a:prstDash val="solid"/>
+                      <a:round/>
+                      <a:headEnd type="none" w="med" len="med"/>
+                      <a:tailEnd type="none" w="med" len="med"/>
+                    </a:lnB>
+                  </a:tcPr>
+                </a:tc>
+                <a:tc>
+                  <a:txBody>
+                    <a:bodyPr/>
+                    <a:lstStyle/>
+                    <a:p>
+                      <a:pPr algn="r" indent="0" marL="0">
+                        <a:buNone/>
+                      </a:pPr>
+                      <a:r>
+                        <a:rPr lang="en-US" sz="1000" dirty="0">
+                          <a:solidFill>
+                            <a:srgbClr val="6B7280"/>
+                          </a:solidFill>
+                          <a:latin typeface="Calibri" pitchFamily="34" charset="0"/>
+                          <a:ea typeface="Calibri" pitchFamily="34" charset="-122"/>
+                          <a:cs typeface="Calibri" pitchFamily="34" charset="-120"/>
+                        </a:rPr>
+                        <a:t>72.8%</a:t>
+                      </a:r>
+                      <a:endParaRPr lang="en-US" sz="1000" dirty="0">
+                        <a:latin typeface="Calibri" charset="0"/>
+                        <a:ea typeface="Calibri" charset="0"/>
+                        <a:cs typeface="Calibri" charset="0"/>
+                      </a:endParaRPr>
+                    </a:p>
+                  </a:txBody>
+                  <a:tcPr marL="91440" marR="91440" marT="36576" marB="36576" anchor="ctr">
+                    <a:lnL w="9525" cap="flat" cmpd="sng" algn="ctr">
+                      <a:solidFill>
+                        <a:srgbClr val="E5E7EB"/>
+                      </a:solidFill>
+                      <a:prstDash val="solid"/>
+                      <a:round/>
+                      <a:headEnd type="none" w="med" len="med"/>
+                      <a:tailEnd type="none" w="med" len="med"/>
+                    </a:lnL>
+                    <a:lnR w="9525" cap="flat" cmpd="sng" algn="ctr">
+                      <a:solidFill>
+                        <a:srgbClr val="E5E7EB"/>
+                      </a:solidFill>
+                      <a:prstDash val="solid"/>
+                      <a:round/>
+                      <a:headEnd type="none" w="med" len="med"/>
+                      <a:tailEnd type="none" w="med" len="med"/>
+                    </a:lnR>
+                    <a:lnT w="9525" cap="flat" cmpd="sng" algn="ctr">
+                      <a:solidFill>
+                        <a:srgbClr val="E5E7EB"/>
+                      </a:solidFill>
+                      <a:prstDash val="solid"/>
+                      <a:round/>
+                      <a:headEnd type="none" w="med" len="med"/>
+                      <a:tailEnd type="none" w="med" len="med"/>
+                    </a:lnT>
+                    <a:lnB w="9525" cap="flat" cmpd="sng" algn="ctr">
+                      <a:solidFill>
+                        <a:srgbClr val="E5E7EB"/>
+                      </a:solidFill>
+                      <a:prstDash val="solid"/>
+                      <a:round/>
+                      <a:headEnd type="none" w="med" len="med"/>
+                      <a:tailEnd type="none" w="med" len="med"/>
+                    </a:lnB>
+                  </a:tcPr>
+                </a:tc>
+                <a:tc>
+                  <a:txBody>
+                    <a:bodyPr/>
+                    <a:lstStyle/>
+                    <a:p>
+                      <a:pPr algn="r" indent="0" marL="0">
+                        <a:buNone/>
+                      </a:pPr>
+                      <a:r>
+                        <a:rPr lang="en-US" sz="1000" b="1" dirty="0">
+                          <a:solidFill>
+                            <a:srgbClr val="111827"/>
+                          </a:solidFill>
+                          <a:latin typeface="Calibri" pitchFamily="34" charset="0"/>
+                          <a:ea typeface="Calibri" pitchFamily="34" charset="-122"/>
+                          <a:cs typeface="Calibri" pitchFamily="34" charset="-120"/>
+                        </a:rPr>
+                        <a:t>71.2%</a:t>
+                      </a:r>
+                      <a:endParaRPr lang="en-US" sz="1000" dirty="0">
+                        <a:latin typeface="Calibri" charset="0"/>
+                        <a:ea typeface="Calibri" charset="0"/>
+                        <a:cs typeface="Calibri" charset="0"/>
+                      </a:endParaRPr>
+                    </a:p>
+                  </a:txBody>
+                  <a:tcPr marL="91440" marR="91440" marT="36576" marB="36576" anchor="ctr">
+                    <a:lnL w="9525" cap="flat" cmpd="sng" algn="ctr">
+                      <a:solidFill>
+                        <a:srgbClr val="E5E7EB"/>
+                      </a:solidFill>
+                      <a:prstDash val="solid"/>
+                      <a:round/>
+                      <a:headEnd type="none" w="med" len="med"/>
+                      <a:tailEnd type="none" w="med" len="med"/>
+                    </a:lnL>
+                    <a:lnR w="9525" cap="flat" cmpd="sng" algn="ctr">
+                      <a:solidFill>
+                        <a:srgbClr val="E5E7EB"/>
+                      </a:solidFill>
+                      <a:prstDash val="solid"/>
+                      <a:round/>
+                      <a:headEnd type="none" w="med" len="med"/>
+                      <a:tailEnd type="none" w="med" len="med"/>
+                    </a:lnR>
+                    <a:lnT w="9525" cap="flat" cmpd="sng" algn="ctr">
+                      <a:solidFill>
+                        <a:srgbClr val="E5E7EB"/>
+                      </a:solidFill>
+                      <a:prstDash val="solid"/>
+                      <a:round/>
+                      <a:headEnd type="none" w="med" len="med"/>
+                      <a:tailEnd type="none" w="med" len="med"/>
+                    </a:lnT>
+                    <a:lnB w="9525" cap="flat" cmpd="sng" algn="ctr">
+                      <a:solidFill>
+                        <a:srgbClr val="E5E7EB"/>
+                      </a:solidFill>
+                      <a:prstDash val="solid"/>
+                      <a:round/>
+                      <a:headEnd type="none" w="med" len="med"/>
+                      <a:tailEnd type="none" w="med" len="med"/>
+                    </a:lnB>
+                  </a:tcPr>
+                </a:tc>
+              </a:tr>
+            </a:tbl>
+          </a:graphicData>
+        </a:graphic>
+      </p:graphicFrame>
+      <p:sp>
+        <p:nvSpPr>
+          <p:cNvPr id="22" name="Shape 19"/>
+          <p:cNvSpPr/>
+          <p:nvPr/>
+        </p:nvSpPr>
+        <p:spPr>
+          <a:xfrm>
+            <a:off x="548640" y="4800600"/>
+            <a:ext cx="5440680" cy="1234440"/>
+          </a:xfrm>
+          <a:prstGeom prst="roundRect">
+            <a:avLst>
+              <a:gd name="adj" fmla="val 5926"/>
+            </a:avLst>
+          </a:prstGeom>
+          <a:solidFill>
+            <a:srgbClr val="F5F3FF"/>
+          </a:solidFill>
+          <a:ln w="12700">
+            <a:solidFill>
+              <a:srgbClr val="F5F3FF"/>
+            </a:solidFill>
+            <a:prstDash val="solid"/>
+          </a:ln>
+        </p:spPr>
+      </p:sp>
+      <p:sp>
+        <p:nvSpPr>
+          <p:cNvPr id="23" name="Text 20"/>
+          <p:cNvSpPr txBox="1"/>
+          <p:nvPr/>
+        </p:nvSpPr>
+        <p:spPr>
+          <a:xfrm>
+            <a:off x="731520" y="4873752"/>
+            <a:ext cx="5029200" cy="256032"/>
+          </a:xfrm>
+          <a:prstGeom prst="rect">
+            <a:avLst/>
+          </a:prstGeom>
+          <a:noFill/>
+          <a:ln/>
+        </p:spPr>
+        <p:txBody>
+          <a:bodyPr wrap="square" lIns="0" tIns="0" rIns="0" bIns="0" rtlCol="0" anchor="ctr"/>
+          <a:lstStyle/>
+          <a:p>
+            <a:pPr indent="0" marL="0">
+              <a:buNone/>
+            </a:pPr>
+            <a:r>
+              <a:rPr lang="en-US" sz="1200" b="1" dirty="0">
+                <a:solidFill>
+                  <a:srgbClr val="111827"/>
+                </a:solidFill>
+                <a:latin typeface="Calibri" pitchFamily="34" charset="0"/>
+                <a:ea typeface="Calibri" pitchFamily="34" charset="-122"/>
+                <a:cs typeface="Calibri" pitchFamily="34" charset="-120"/>
+              </a:rPr>
+              <a:t>Moncton lane alone · F27</a:t>
+            </a:r>
+            <a:endParaRPr lang="en-US" sz="1200" dirty="0"/>
+          </a:p>
+        </p:txBody>
+      </p:sp>
+      <p:sp>
+        <p:nvSpPr>
+          <p:cNvPr id="24" name="Text 21"/>
+          <p:cNvSpPr txBox="1"/>
+          <p:nvPr/>
+        </p:nvSpPr>
+        <p:spPr>
+          <a:xfrm>
+            <a:off x="731520" y="5175504"/>
+            <a:ext cx="1143000" cy="219456"/>
+          </a:xfrm>
+          <a:prstGeom prst="rect">
+            <a:avLst/>
+          </a:prstGeom>
+          <a:noFill/>
+          <a:ln/>
+        </p:spPr>
+        <p:txBody>
+          <a:bodyPr wrap="square" lIns="0" tIns="0" rIns="0" bIns="0" rtlCol="0" anchor="ctr"/>
+          <a:lstStyle/>
+          <a:p>
+            <a:pPr indent="0" marL="0">
+              <a:buNone/>
+            </a:pPr>
+            <a:r>
+              <a:rPr lang="en-US" sz="1000" dirty="0">
+                <a:solidFill>
+                  <a:srgbClr val="6B7280"/>
+                </a:solidFill>
+                <a:latin typeface="Calibri" pitchFamily="34" charset="0"/>
+                <a:ea typeface="Calibri" pitchFamily="34" charset="-122"/>
+                <a:cs typeface="Calibri" pitchFamily="34" charset="-120"/>
+              </a:rPr>
+              <a:t>Loads</a:t>
+            </a:r>
+            <a:endParaRPr lang="en-US" sz="1000" dirty="0"/>
+          </a:p>
+        </p:txBody>
+      </p:sp>
+      <p:sp>
+        <p:nvSpPr>
+          <p:cNvPr id="25" name="Text 22"/>
+          <p:cNvSpPr txBox="1"/>
+          <p:nvPr/>
+        </p:nvSpPr>
+        <p:spPr>
+          <a:xfrm>
+            <a:off x="731520" y="5394960"/>
+            <a:ext cx="1143000" cy="411480"/>
+          </a:xfrm>
+          <a:prstGeom prst="rect">
+            <a:avLst/>
+          </a:prstGeom>
+          <a:noFill/>
+          <a:ln/>
+        </p:spPr>
+        <p:txBody>
+          <a:bodyPr wrap="square" lIns="0" tIns="0" rIns="0" bIns="0" rtlCol="0" anchor="ctr"/>
+          <a:lstStyle/>
+          <a:p>
+            <a:pPr indent="0" marL="0">
+              <a:buNone/>
+            </a:pPr>
+            <a:r>
+              <a:rPr lang="en-US" sz="1800" b="1" dirty="0">
+                <a:solidFill>
+                  <a:srgbClr val="111827"/>
+                </a:solidFill>
+                <a:latin typeface="Calibri" pitchFamily="34" charset="0"/>
+                <a:ea typeface="Calibri" pitchFamily="34" charset="-122"/>
+                <a:cs typeface="Calibri" pitchFamily="34" charset="-120"/>
+              </a:rPr>
+              <a:t>168</a:t>
+            </a:r>
+            <a:endParaRPr lang="en-US" sz="1800" dirty="0"/>
+          </a:p>
+        </p:txBody>
+      </p:sp>
+      <p:sp>
+        <p:nvSpPr>
+          <p:cNvPr id="26" name="Text 23"/>
+          <p:cNvSpPr txBox="1"/>
+          <p:nvPr/>
+        </p:nvSpPr>
+        <p:spPr>
+          <a:xfrm>
+            <a:off x="1920240" y="5175504"/>
+            <a:ext cx="1143000" cy="219456"/>
+          </a:xfrm>
+          <a:prstGeom prst="rect">
+            <a:avLst/>
+          </a:prstGeom>
+          <a:noFill/>
+          <a:ln/>
+        </p:spPr>
+        <p:txBody>
+          <a:bodyPr wrap="square" lIns="0" tIns="0" rIns="0" bIns="0" rtlCol="0" anchor="ctr"/>
+          <a:lstStyle/>
+          <a:p>
+            <a:pPr indent="0" marL="0">
+              <a:buNone/>
+            </a:pPr>
+            <a:r>
+              <a:rPr lang="en-US" sz="1000" dirty="0">
+                <a:solidFill>
+                  <a:srgbClr val="6B7280"/>
+                </a:solidFill>
+                <a:latin typeface="Calibri" pitchFamily="34" charset="0"/>
+                <a:ea typeface="Calibri" pitchFamily="34" charset="-122"/>
+                <a:cs typeface="Calibri" pitchFamily="34" charset="-120"/>
+              </a:rPr>
+              <a:t>LF score</a:t>
+            </a:r>
+            <a:endParaRPr lang="en-US" sz="1000" dirty="0"/>
+          </a:p>
+        </p:txBody>
+      </p:sp>
+      <p:sp>
+        <p:nvSpPr>
+          <p:cNvPr id="27" name="Text 24"/>
+          <p:cNvSpPr txBox="1"/>
+          <p:nvPr/>
+        </p:nvSpPr>
+        <p:spPr>
+          <a:xfrm>
+            <a:off x="1920240" y="5394960"/>
+            <a:ext cx="1143000" cy="411480"/>
+          </a:xfrm>
+          <a:prstGeom prst="rect">
+            <a:avLst/>
+          </a:prstGeom>
+          <a:noFill/>
+          <a:ln/>
+        </p:spPr>
+        <p:txBody>
+          <a:bodyPr wrap="square" lIns="0" tIns="0" rIns="0" bIns="0" rtlCol="0" anchor="ctr"/>
+          <a:lstStyle/>
+          <a:p>
+            <a:pPr indent="0" marL="0">
+              <a:buNone/>
+            </a:pPr>
+            <a:r>
+              <a:rPr lang="en-US" sz="1800" b="1" dirty="0">
+                <a:solidFill>
+                  <a:srgbClr val="111827"/>
+                </a:solidFill>
+                <a:latin typeface="Calibri" pitchFamily="34" charset="0"/>
+                <a:ea typeface="Calibri" pitchFamily="34" charset="-122"/>
+                <a:cs typeface="Calibri" pitchFamily="34" charset="-120"/>
+              </a:rPr>
+              <a:t>23.8%</a:t>
+            </a:r>
+            <a:endParaRPr lang="en-US" sz="1800" dirty="0"/>
+          </a:p>
+        </p:txBody>
+      </p:sp>
+      <p:sp>
+        <p:nvSpPr>
+          <p:cNvPr id="28" name="Text 25"/>
+          <p:cNvSpPr txBox="1"/>
+          <p:nvPr/>
+        </p:nvSpPr>
+        <p:spPr>
+          <a:xfrm>
+            <a:off x="3108960" y="5175504"/>
+            <a:ext cx="1143000" cy="219456"/>
+          </a:xfrm>
+          <a:prstGeom prst="rect">
+            <a:avLst/>
+          </a:prstGeom>
+          <a:noFill/>
+          <a:ln/>
+        </p:spPr>
+        <p:txBody>
+          <a:bodyPr wrap="square" lIns="0" tIns="0" rIns="0" bIns="0" rtlCol="0" anchor="ctr"/>
+          <a:lstStyle/>
+          <a:p>
+            <a:pPr indent="0" marL="0">
+              <a:buNone/>
+            </a:pPr>
+            <a:r>
+              <a:rPr lang="en-US" sz="1000" dirty="0">
+                <a:solidFill>
+                  <a:srgbClr val="6B7280"/>
+                </a:solidFill>
+                <a:latin typeface="Calibri" pitchFamily="34" charset="0"/>
+                <a:ea typeface="Calibri" pitchFamily="34" charset="-122"/>
+                <a:cs typeface="Calibri" pitchFamily="34" charset="-120"/>
+              </a:rPr>
+              <a:t>Bills</a:t>
+            </a:r>
+            <a:endParaRPr lang="en-US" sz="1000" dirty="0"/>
+          </a:p>
+        </p:txBody>
+      </p:sp>
+      <p:sp>
+        <p:nvSpPr>
+          <p:cNvPr id="29" name="Text 26"/>
+          <p:cNvSpPr txBox="1"/>
+          <p:nvPr/>
+        </p:nvSpPr>
+        <p:spPr>
+          <a:xfrm>
+            <a:off x="3108960" y="5394960"/>
+            <a:ext cx="1143000" cy="411480"/>
+          </a:xfrm>
+          <a:prstGeom prst="rect">
+            <a:avLst/>
+          </a:prstGeom>
+          <a:noFill/>
+          <a:ln/>
+        </p:spPr>
+        <p:txBody>
+          <a:bodyPr wrap="square" lIns="0" tIns="0" rIns="0" bIns="0" rtlCol="0" anchor="ctr"/>
+          <a:lstStyle/>
+          <a:p>
+            <a:pPr indent="0" marL="0">
+              <a:buNone/>
+            </a:pPr>
+            <a:r>
+              <a:rPr lang="en-US" sz="1800" b="1" dirty="0">
+                <a:solidFill>
+                  <a:srgbClr val="111827"/>
+                </a:solidFill>
+                <a:latin typeface="Calibri" pitchFamily="34" charset="0"/>
+                <a:ea typeface="Calibri" pitchFamily="34" charset="-122"/>
+                <a:cs typeface="Calibri" pitchFamily="34" charset="-120"/>
+              </a:rPr>
+              <a:t>8,629</a:t>
+            </a:r>
+            <a:endParaRPr lang="en-US" sz="1800" dirty="0"/>
+          </a:p>
+        </p:txBody>
+      </p:sp>
+      <p:sp>
+        <p:nvSpPr>
+          <p:cNvPr id="30" name="Text 27"/>
+          <p:cNvSpPr txBox="1"/>
+          <p:nvPr/>
+        </p:nvSpPr>
+        <p:spPr>
+          <a:xfrm>
+            <a:off x="4297680" y="5175504"/>
+            <a:ext cx="1143000" cy="219456"/>
+          </a:xfrm>
+          <a:prstGeom prst="rect">
+            <a:avLst/>
+          </a:prstGeom>
+          <a:noFill/>
+          <a:ln/>
+        </p:spPr>
+        <p:txBody>
+          <a:bodyPr wrap="square" lIns="0" tIns="0" rIns="0" bIns="0" rtlCol="0" anchor="ctr"/>
+          <a:lstStyle/>
+          <a:p>
+            <a:pPr indent="0" marL="0">
+              <a:buNone/>
+            </a:pPr>
+            <a:r>
+              <a:rPr lang="en-US" sz="1000" dirty="0">
+                <a:solidFill>
+                  <a:srgbClr val="6B7280"/>
+                </a:solidFill>
+                <a:latin typeface="Calibri" pitchFamily="34" charset="0"/>
+                <a:ea typeface="Calibri" pitchFamily="34" charset="-122"/>
+                <a:cs typeface="Calibri" pitchFamily="34" charset="-120"/>
+              </a:rPr>
+              <a:t>No cube</a:t>
+            </a:r>
+            <a:endParaRPr lang="en-US" sz="1000" dirty="0"/>
+          </a:p>
+        </p:txBody>
+      </p:sp>
+      <p:sp>
+        <p:nvSpPr>
+          <p:cNvPr id="31" name="Text 28"/>
+          <p:cNvSpPr txBox="1"/>
+          <p:nvPr/>
+        </p:nvSpPr>
+        <p:spPr>
+          <a:xfrm>
+            <a:off x="4297680" y="5394960"/>
+            <a:ext cx="1554480" cy="411480"/>
+          </a:xfrm>
+          <a:prstGeom prst="rect">
+            <a:avLst/>
+          </a:prstGeom>
+          <a:noFill/>
+          <a:ln/>
+        </p:spPr>
+        <p:txBody>
+          <a:bodyPr wrap="square" lIns="0" tIns="0" rIns="0" bIns="0" rtlCol="0" anchor="ctr"/>
+          <a:lstStyle/>
+          <a:p>
+            <a:pPr indent="0" marL="0">
+              <a:buNone/>
+            </a:pPr>
+            <a:r>
+              <a:rPr lang="en-US" sz="1300" b="1" dirty="0">
+                <a:solidFill>
+                  <a:srgbClr val="DC2626"/>
+                </a:solidFill>
+                <a:latin typeface="Calibri" pitchFamily="34" charset="0"/>
+                <a:ea typeface="Calibri" pitchFamily="34" charset="-122"/>
+                <a:cs typeface="Calibri" pitchFamily="34" charset="-120"/>
+              </a:rPr>
+              <a:t>1,771 (20.5%)</a:t>
+            </a:r>
+            <a:endParaRPr lang="en-US" sz="1300" dirty="0"/>
+          </a:p>
+        </p:txBody>
+      </p:sp>
+      <p:graphicFrame>
+        <p:nvGraphicFramePr>
+          <p:cNvPr id="32" name="Chart 0" descr=""/>
+          <p:cNvGraphicFramePr/>
+          <p:nvPr/>
+        </p:nvGraphicFramePr>
+        <p:xfrm>
+          <a:off x="6263640" y="1554480"/>
+          <a:ext cx="5376672" cy="2194560"/>
+        </p:xfrm>
+        <a:graphic xmlns:a="http://schemas.openxmlformats.org/drawingml/2006/main">
+          <a:graphicData uri="http://schemas.openxmlformats.org/drawingml/2006/chart">
+            <c:chart xmlns:c="http://schemas.openxmlformats.org/drawingml/2006/chart" r:id="rId1"/>
+          </a:graphicData>
+        </a:graphic>
+      </p:graphicFrame>
+      <p:sp>
+        <p:nvSpPr>
+          <p:cNvPr id="33" name="Text 29"/>
+          <p:cNvSpPr txBox="1"/>
+          <p:nvPr/>
+        </p:nvSpPr>
+        <p:spPr>
+          <a:xfrm>
+            <a:off x="6355080" y="3749040"/>
+            <a:ext cx="5257800" cy="658368"/>
+          </a:xfrm>
+          <a:prstGeom prst="rect">
+            <a:avLst/>
+          </a:prstGeom>
+          <a:noFill/>
+          <a:ln/>
+        </p:spPr>
+        <p:txBody>
+          <a:bodyPr wrap="square" lIns="0" tIns="0" rIns="0" bIns="0" rtlCol="0" anchor="t"/>
+          <a:lstStyle/>
+          <a:p>
+            <a:pPr indent="0" marL="0">
+              <a:buNone/>
+            </a:pPr>
+            <a:r>
+              <a:rPr lang="en-US" sz="950" b="1" dirty="0">
+                <a:solidFill>
+                  <a:srgbClr val="1F2937"/>
+                </a:solidFill>
+                <a:latin typeface="Calibri" pitchFamily="34" charset="0"/>
+                <a:ea typeface="Calibri" pitchFamily="34" charset="-122"/>
+                <a:cs typeface="Calibri" pitchFamily="34" charset="-120"/>
+              </a:rPr>
+              <a:t>&lt;500: </a:t>
+            </a:r>
+            <a:pPr indent="0" marL="0">
+              <a:buNone/>
+            </a:pPr>
+            <a:r>
+              <a:rPr lang="en-US" sz="950" dirty="0">
+                <a:solidFill>
+                  <a:srgbClr val="6B7280"/>
+                </a:solidFill>
+                <a:latin typeface="Calibri" pitchFamily="34" charset="0"/>
+                <a:ea typeface="Calibri" pitchFamily="34" charset="-122"/>
+                <a:cs typeface="Calibri" pitchFamily="34" charset="-120"/>
+              </a:rPr>
+              <a:t>Montreal, Ottawa, Windsor, Woodstock</a:t>
+            </a:r>
+            <a:endParaRPr lang="en-US" sz="950" dirty="0"/>
+          </a:p>
+          <a:p>
+            <a:pPr indent="0" marL="0">
+              <a:buNone/>
+            </a:pPr>
+            <a:r>
+              <a:rPr lang="en-US" sz="950" b="1" dirty="0">
+                <a:solidFill>
+                  <a:srgbClr val="1F2937"/>
+                </a:solidFill>
+                <a:latin typeface="Calibri" pitchFamily="34" charset="0"/>
+                <a:ea typeface="Calibri" pitchFamily="34" charset="-122"/>
+                <a:cs typeface="Calibri" pitchFamily="34" charset="-120"/>
+              </a:rPr>
+              <a:t>&lt;1,000: </a:t>
+            </a:r>
+            <a:pPr indent="0" marL="0">
+              <a:buNone/>
+            </a:pPr>
+            <a:r>
+              <a:rPr lang="en-US" sz="950" dirty="0">
+                <a:solidFill>
+                  <a:srgbClr val="6B7280"/>
+                </a:solidFill>
+                <a:latin typeface="Calibri" pitchFamily="34" charset="0"/>
+                <a:ea typeface="Calibri" pitchFamily="34" charset="-122"/>
+                <a:cs typeface="Calibri" pitchFamily="34" charset="-120"/>
+              </a:rPr>
+              <a:t>Moncton, Quebec City</a:t>
+            </a:r>
+            <a:endParaRPr lang="en-US" sz="950" dirty="0"/>
+          </a:p>
+          <a:p>
+            <a:pPr indent="0" marL="0">
+              <a:buNone/>
+            </a:pPr>
+            <a:r>
+              <a:rPr lang="en-US" sz="950" b="1" dirty="0">
+                <a:solidFill>
+                  <a:srgbClr val="1F2937"/>
+                </a:solidFill>
+                <a:latin typeface="Calibri" pitchFamily="34" charset="0"/>
+                <a:ea typeface="Calibri" pitchFamily="34" charset="-122"/>
+                <a:cs typeface="Calibri" pitchFamily="34" charset="-120"/>
+              </a:rPr>
+              <a:t>&gt;1,000: </a:t>
+            </a:r>
+            <a:pPr indent="0" marL="0">
+              <a:buNone/>
+            </a:pPr>
+            <a:r>
+              <a:rPr lang="en-US" sz="950" dirty="0">
+                <a:solidFill>
+                  <a:srgbClr val="6B7280"/>
+                </a:solidFill>
+                <a:latin typeface="Calibri" pitchFamily="34" charset="0"/>
+                <a:ea typeface="Calibri" pitchFamily="34" charset="-122"/>
+                <a:cs typeface="Calibri" pitchFamily="34" charset="-120"/>
+              </a:rPr>
+              <a:t>Burnaby, Calgary, Winnipeg, Edmonton, Dartmouth, Saskatoon</a:t>
+            </a:r>
+            <a:endParaRPr lang="en-US" sz="950" dirty="0"/>
+          </a:p>
+        </p:txBody>
+      </p:sp>
+      <p:sp>
+        <p:nvSpPr>
+          <p:cNvPr id="34" name="Shape 30"/>
+          <p:cNvSpPr/>
+          <p:nvPr/>
+        </p:nvSpPr>
+        <p:spPr>
+          <a:xfrm>
+            <a:off x="6263640" y="4480560"/>
+            <a:ext cx="5376672" cy="1554480"/>
+          </a:xfrm>
+          <a:prstGeom prst="roundRect">
+            <a:avLst>
+              <a:gd name="adj" fmla="val 4706"/>
+            </a:avLst>
+          </a:prstGeom>
+          <a:solidFill>
+            <a:srgbClr val="FFFBEB"/>
+          </a:solidFill>
+          <a:ln w="12700">
+            <a:solidFill>
+              <a:srgbClr val="FFFBEB"/>
+            </a:solidFill>
+            <a:prstDash val="solid"/>
+          </a:ln>
+        </p:spPr>
+      </p:sp>
+      <p:sp>
+        <p:nvSpPr>
+          <p:cNvPr id="35" name="Text 31"/>
+          <p:cNvSpPr txBox="1"/>
+          <p:nvPr/>
+        </p:nvSpPr>
+        <p:spPr>
+          <a:xfrm>
+            <a:off x="6419088" y="4526280"/>
+            <a:ext cx="5102352" cy="1463040"/>
+          </a:xfrm>
+          <a:prstGeom prst="rect">
+            <a:avLst/>
+          </a:prstGeom>
+          <a:noFill/>
+          <a:ln/>
+        </p:spPr>
+        <p:txBody>
+          <a:bodyPr wrap="square" lIns="0" tIns="0" rIns="0" bIns="0" rtlCol="0" anchor="ctr"/>
+          <a:lstStyle/>
+          <a:p>
+            <a:pPr indent="0" marL="0">
+              <a:buNone/>
+            </a:pPr>
+            <a:r>
+              <a:rPr lang="en-US" sz="1200" b="1" dirty="0">
+                <a:solidFill>
+                  <a:srgbClr val="B45309"/>
+                </a:solidFill>
+                <a:latin typeface="Calibri" pitchFamily="34" charset="0"/>
+                <a:ea typeface="Calibri" pitchFamily="34" charset="-122"/>
+                <a:cs typeface="Calibri" pitchFamily="34" charset="-120"/>
+              </a:rPr>
+              <a:t>Toyota baseload footage</a:t>
+            </a:r>
+            <a:endParaRPr lang="en-US" sz="1000" dirty="0"/>
+          </a:p>
+          <a:p>
+            <a:pPr indent="0" marL="0">
+              <a:buNone/>
+            </a:pPr>
+            <a:r>
+              <a:rPr lang="en-US" sz="1000" dirty="0">
+                <a:solidFill>
+                  <a:srgbClr val="1F2937"/>
+                </a:solidFill>
+                <a:latin typeface="Calibri" pitchFamily="34" charset="0"/>
+                <a:ea typeface="Calibri" pitchFamily="34" charset="-122"/>
+                <a:cs typeface="Calibri" pitchFamily="34" charset="-120"/>
+              </a:rPr>
+              <a:t>Toyota loads our trailer at Bowmanville; we top it off in Mississauga before linehaul. Toyota footage is not being captured correctly — being fixed now. Moncton: 20.5% of bills have no cube vs 3.0% on all other lanes, with many loads carrying the same 24–27 no-cube bills — the pattern of an uncaptured baseload. Measured LF on affected loads is understated.</a:t>
+            </a:r>
+            <a:endParaRPr lang="en-US" sz="1000" dirty="0"/>
+          </a:p>
+        </p:txBody>
+      </p:sp>
+      <p:sp>
+        <p:nvSpPr>
+          <p:cNvPr id="36" name="Text 32"/>
+          <p:cNvSpPr txBox="1"/>
+          <p:nvPr/>
+        </p:nvSpPr>
+        <p:spPr>
+          <a:xfrm>
+            <a:off x="548640" y="6144768"/>
+            <a:ext cx="11091672" cy="228600"/>
+          </a:xfrm>
+          <a:prstGeom prst="rect">
+            <a:avLst/>
+          </a:prstGeom>
+          <a:noFill/>
+          <a:ln/>
+        </p:spPr>
+        <p:txBody>
+          <a:bodyPr wrap="square" lIns="0" tIns="0" rIns="0" bIns="0" rtlCol="0" anchor="ctr"/>
+          <a:lstStyle/>
+          <a:p>
+            <a:pPr indent="0" marL="0">
+              <a:buNone/>
+            </a:pPr>
+            <a:r>
+              <a:rPr lang="en-US" sz="900" i="1" dirty="0">
+                <a:solidFill>
+                  <a:srgbClr val="6B7280"/>
+                </a:solidFill>
+                <a:latin typeface="Calibri" pitchFamily="34" charset="0"/>
+                <a:ea typeface="Calibri" pitchFamily="34" charset="-122"/>
+                <a:cs typeface="Calibri" pitchFamily="34" charset="-120"/>
+              </a:rPr>
+              <a:t>Source: Load factor report — Mississauga outbound, F27 Jul–Sep. Lane type is "Not Defined" for all loads, so no headhaul/backhaul split — grouped by the report's distance bands.</a:t>
+            </a:r>
+            <a:endParaRPr lang="en-US" sz="900" dirty="0"/>
+          </a:p>
+        </p:txBody>
+      </p:sp>
+      <p:sp>
+        <p:nvSpPr>
+          <p:cNvPr id="37" name="Text 33"/>
+          <p:cNvSpPr txBox="1"/>
+          <p:nvPr/>
+        </p:nvSpPr>
+        <p:spPr>
+          <a:xfrm>
+            <a:off x="548640" y="6473952"/>
+            <a:ext cx="7315200" cy="228600"/>
+          </a:xfrm>
+          <a:prstGeom prst="rect">
+            <a:avLst/>
+          </a:prstGeom>
+          <a:noFill/>
+          <a:ln/>
+        </p:spPr>
+        <p:txBody>
+          <a:bodyPr wrap="square" lIns="0" tIns="0" rIns="0" bIns="0" rtlCol="0" anchor="ctr"/>
+          <a:lstStyle/>
+          <a:p>
+            <a:pPr indent="0" marL="0">
+              <a:buNone/>
+            </a:pPr>
+            <a:r>
+              <a:rPr lang="en-US" sz="900" dirty="0">
+                <a:solidFill>
+                  <a:srgbClr val="9CA3AF"/>
+                </a:solidFill>
+                <a:latin typeface="Calibri" pitchFamily="34" charset="0"/>
+                <a:ea typeface="Calibri" pitchFamily="34" charset="-122"/>
+                <a:cs typeface="Calibri" pitchFamily="34" charset="-120"/>
+              </a:rPr>
+              <a:t>Mississauga Terminal · F27 Senior Leadership Review · Sep 29, 2026</a:t>
+            </a:r>
+            <a:endParaRPr lang="en-US" sz="900" dirty="0"/>
+          </a:p>
+        </p:txBody>
+      </p:sp>
+      <p:sp>
+        <p:nvSpPr>
+          <p:cNvPr id="38" name="Text 34"/>
+          <p:cNvSpPr txBox="1"/>
+          <p:nvPr/>
+        </p:nvSpPr>
+        <p:spPr>
+          <a:xfrm>
+            <a:off x="10725912" y="6473952"/>
+            <a:ext cx="914400" cy="228600"/>
+          </a:xfrm>
+          <a:prstGeom prst="rect">
+            <a:avLst/>
+          </a:prstGeom>
+          <a:noFill/>
+          <a:ln/>
+        </p:spPr>
+        <p:txBody>
+          <a:bodyPr wrap="square" lIns="0" tIns="0" rIns="0" bIns="0" rtlCol="0" anchor="ctr"/>
+          <a:lstStyle/>
+          <a:p>
+            <a:pPr algn="r" indent="0" marL="0">
+              <a:buNone/>
+            </a:pPr>
+            <a:r>
+              <a:rPr lang="en-US" sz="900" dirty="0">
+                <a:solidFill>
+                  <a:srgbClr val="9CA3AF"/>
+                </a:solidFill>
+                <a:latin typeface="Calibri" pitchFamily="34" charset="0"/>
+                <a:ea typeface="Calibri" pitchFamily="34" charset="-122"/>
+                <a:cs typeface="Calibri" pitchFamily="34" charset="-120"/>
+              </a:rPr>
+              <a:t>20 / 23</a:t>
+            </a:r>
+            <a:endParaRPr lang="en-US" sz="900" dirty="0"/>
+          </a:p>
+        </p:txBody>
+      </p:sp>
+    </p:spTree>
+  </p:cSld>
+  <p:clrMapOvr>
+    <a:masterClrMapping/>
+  </p:clrMapOvr>
+</p:sld>
+</file>
+
+<file path=ppt/slides/slide21.xml><?xml version="1.0" encoding="utf-8"?>
+<p:sld xmlns:a="http://schemas.openxmlformats.org/drawingml/2006/main" xmlns:r="http://schemas.openxmlformats.org/officeDocument/2006/relationships" xmlns:p="http://schemas.openxmlformats.org/presentationml/2006/main">
+  <p:cSld name="Slide 21">
+    <p:bg>
+      <p:bgPr>
+        <a:solidFill>
+          <a:srgbClr val="FFFFFF"/>
+        </a:solidFill>
+      </p:bgPr>
+    </p:bg>
+    <p:spTree>
+      <p:nvGrpSpPr>
+        <p:cNvPr id="1" name=""/>
+        <p:cNvGrpSpPr/>
+        <p:nvPr/>
+      </p:nvGrpSpPr>
+      <p:grpSpPr>
+        <a:xfrm>
+          <a:off x="0" y="0"/>
+          <a:ext cx="0" cy="0"/>
+          <a:chOff x="0" y="0"/>
+          <a:chExt cx="0" cy="0"/>
+        </a:xfrm>
+      </p:grpSpPr>
+      <p:sp>
+        <p:nvSpPr>
+          <p:cNvPr id="2" name="Text 0"/>
+          <p:cNvSpPr txBox="1"/>
+          <p:nvPr/>
+        </p:nvSpPr>
+        <p:spPr>
+          <a:xfrm>
+            <a:off x="548640" y="320040"/>
+            <a:ext cx="9144000" cy="274320"/>
+          </a:xfrm>
+          <a:prstGeom prst="rect">
+            <a:avLst/>
+          </a:prstGeom>
+          <a:noFill/>
+          <a:ln/>
+        </p:spPr>
+        <p:txBody>
+          <a:bodyPr wrap="square" lIns="0" tIns="0" rIns="0" bIns="0" rtlCol="0" anchor="ctr"/>
+          <a:lstStyle/>
+          <a:p>
+            <a:pPr indent="0" marL="0">
+              <a:buNone/>
+            </a:pPr>
+            <a:r>
+              <a:rPr lang="en-US" sz="1200" b="1" spc="300" kern="0" dirty="0">
+                <a:solidFill>
+                  <a:srgbClr val="7C3AED"/>
+                </a:solidFill>
+                <a:latin typeface="Calibri" pitchFamily="34" charset="0"/>
+                <a:ea typeface="Calibri" pitchFamily="34" charset="-122"/>
+                <a:cs typeface="Calibri" pitchFamily="34" charset="-120"/>
+              </a:rPr>
+              <a:t>PRODUCTIVITY</a:t>
+            </a:r>
+            <a:endParaRPr lang="en-US" sz="1200" dirty="0"/>
+          </a:p>
+        </p:txBody>
+      </p:sp>
+      <p:sp>
+        <p:nvSpPr>
+          <p:cNvPr id="3" name="Text 1"/>
+          <p:cNvSpPr txBox="1"/>
+          <p:nvPr/>
+        </p:nvSpPr>
+        <p:spPr>
+          <a:xfrm>
+            <a:off x="548640" y="603504"/>
+            <a:ext cx="11091672" cy="603504"/>
+          </a:xfrm>
+          <a:prstGeom prst="rect">
+            <a:avLst/>
+          </a:prstGeom>
+          <a:noFill/>
+          <a:ln/>
+        </p:spPr>
+        <p:txBody>
+          <a:bodyPr wrap="square" lIns="0" tIns="0" rIns="0" bIns="0" rtlCol="0" anchor="t"/>
+          <a:lstStyle/>
+          <a:p>
+            <a:pPr indent="0" marL="0">
+              <a:buNone/>
+            </a:pPr>
+            <a:r>
+              <a:rPr lang="en-US" sz="3000" b="1" dirty="0">
+                <a:solidFill>
+                  <a:srgbClr val="111827"/>
+                </a:solidFill>
+                <a:latin typeface="Calibri" pitchFamily="34" charset="0"/>
+                <a:ea typeface="Calibri" pitchFamily="34" charset="-122"/>
+                <a:cs typeface="Calibri" pitchFamily="34" charset="-120"/>
+              </a:rPr>
+              <a:t>CICO — hours saved</a:t>
+            </a:r>
+            <a:endParaRPr lang="en-US" sz="3000" dirty="0"/>
+          </a:p>
+        </p:txBody>
+      </p:sp>
+      <p:graphicFrame>
+        <p:nvGraphicFramePr>
+          <p:cNvPr id="22" name="Table 0"/>
           <p:cNvGraphicFramePr>
             <a:graphicFrameLocks noGrp="1"/>
           </p:cNvGraphicFramePr>
@@ -35151,7 +38505,7 @@
                 <a:ea typeface="Calibri" pitchFamily="34" charset="-122"/>
                 <a:cs typeface="Calibri" pitchFamily="34" charset="-120"/>
               </a:rPr>
-              <a:t>20 / 22</a:t>
+              <a:t>21 / 23</a:t>
             </a:r>
             <a:endParaRPr lang="en-US" sz="900" dirty="0"/>
           </a:p>
@@ -35165,9 +38519,9 @@
 </p:sld>
 </file>
 
-<file path=ppt/slides/slide21.xml><?xml version="1.0" encoding="utf-8"?>
+<file path=ppt/slides/slide22.xml><?xml version="1.0" encoding="utf-8"?>
 <p:sld xmlns:a="http://schemas.openxmlformats.org/drawingml/2006/main" xmlns:r="http://schemas.openxmlformats.org/officeDocument/2006/relationships" xmlns:p="http://schemas.openxmlformats.org/presentationml/2006/main">
-  <p:cSld name="Slide 21">
+  <p:cSld name="Slide 22">
     <p:bg>
       <p:bgPr>
         <a:solidFill>
@@ -35770,7 +39124,7 @@
       </p:sp>
       <p:graphicFrame>
         <p:nvGraphicFramePr>
-          <p:cNvPr id="22" name="Table 0"/>
+          <p:cNvPr id="23" name="Table 0"/>
           <p:cNvGraphicFramePr>
             <a:graphicFrameLocks noGrp="1"/>
           </p:cNvGraphicFramePr>
@@ -37220,7 +40574,7 @@
                 <a:ea typeface="Calibri" pitchFamily="34" charset="-122"/>
                 <a:cs typeface="Calibri" pitchFamily="34" charset="-120"/>
               </a:rPr>
-              <a:t>21 / 22</a:t>
+              <a:t>22 / 23</a:t>
             </a:r>
             <a:endParaRPr lang="en-US" sz="900" dirty="0"/>
           </a:p>
@@ -37234,9 +40588,9 @@
 </p:sld>
 </file>
 
-<file path=ppt/slides/slide22.xml><?xml version="1.0" encoding="utf-8"?>
+<file path=ppt/slides/slide23.xml><?xml version="1.0" encoding="utf-8"?>
 <p:sld xmlns:a="http://schemas.openxmlformats.org/drawingml/2006/main" xmlns:r="http://schemas.openxmlformats.org/officeDocument/2006/relationships" xmlns:p="http://schemas.openxmlformats.org/presentationml/2006/main">
-  <p:cSld name="Slide 22">
+  <p:cSld name="Slide 23">
     <p:bg>
       <p:bgPr>
         <a:solidFill>
@@ -38567,7 +41921,7 @@
                 <a:ea typeface="Calibri" pitchFamily="34" charset="-122"/>
                 <a:cs typeface="Calibri" pitchFamily="34" charset="-120"/>
               </a:rPr>
-              <a:t>22 / 22</a:t>
+              <a:t>23 / 23</a:t>
             </a:r>
             <a:endParaRPr lang="en-US" sz="900" dirty="0"/>
           </a:p>
@@ -40059,7 +43413,7 @@
                 <a:ea typeface="Calibri" pitchFamily="34" charset="-122"/>
                 <a:cs typeface="Calibri" pitchFamily="34" charset="-120"/>
               </a:rPr>
-              <a:t>3 / 22</a:t>
+              <a:t>3 / 23</a:t>
             </a:r>
             <a:endParaRPr lang="en-US" sz="900" dirty="0"/>
           </a:p>
@@ -40894,7 +44248,7 @@
                 <a:ea typeface="Calibri" pitchFamily="34" charset="-122"/>
                 <a:cs typeface="Calibri" pitchFamily="34" charset="-120"/>
               </a:rPr>
-              <a:t>4 / 22</a:t>
+              <a:t>4 / 23</a:t>
             </a:r>
             <a:endParaRPr lang="en-US" sz="900" dirty="0"/>
           </a:p>
@@ -42299,7 +45653,7 @@
                 <a:ea typeface="Calibri" pitchFamily="34" charset="-122"/>
                 <a:cs typeface="Calibri" pitchFamily="34" charset="-120"/>
               </a:rPr>
-              <a:t>5 / 22</a:t>
+              <a:t>5 / 23</a:t>
             </a:r>
             <a:endParaRPr lang="en-US" sz="900" dirty="0"/>
           </a:p>
@@ -45123,7 +48477,7 @@
                 <a:ea typeface="Calibri" pitchFamily="34" charset="-122"/>
                 <a:cs typeface="Calibri" pitchFamily="34" charset="-120"/>
               </a:rPr>
-              <a:t>6 / 22</a:t>
+              <a:t>6 / 23</a:t>
             </a:r>
             <a:endParaRPr lang="en-US" sz="900" dirty="0"/>
           </a:p>
@@ -46730,7 +50084,7 @@
                 <a:ea typeface="Calibri" pitchFamily="34" charset="-122"/>
                 <a:cs typeface="Calibri" pitchFamily="34" charset="-120"/>
               </a:rPr>
-              <a:t>7 / 22</a:t>
+              <a:t>7 / 23</a:t>
             </a:r>
             <a:endParaRPr lang="en-US" sz="900" dirty="0"/>
           </a:p>
@@ -48073,7 +51427,7 @@
                 <a:ea typeface="Calibri" pitchFamily="34" charset="-122"/>
                 <a:cs typeface="Calibri" pitchFamily="34" charset="-120"/>
               </a:rPr>
-              <a:t>8 / 22</a:t>
+              <a:t>8 / 23</a:t>
             </a:r>
             <a:endParaRPr lang="en-US" sz="900" dirty="0"/>
           </a:p>
@@ -49178,7 +52532,7 @@
                 <a:ea typeface="Calibri" pitchFamily="34" charset="-122"/>
                 <a:cs typeface="Calibri" pitchFamily="34" charset="-120"/>
               </a:rPr>
-              <a:t>9 / 22</a:t>
+              <a:t>9 / 23</a:t>
             </a:r>
             <a:endParaRPr lang="en-US" sz="900" dirty="0"/>
           </a:p>

</xml_diff>

<commit_message>
Deck: backup Q&A slide (23 slides)
Co-Authored-By: Claude Opus 5.5 <noreply@anthropic.com>
Claude-Session: https://claude.ai/code/session_01BwRjju3y2wk3wSHFrM9KLe
</commit_message>
<xml_diff>
--- a/presentation/Mississauga_F27_Leadership_Review_Sep29.pptx
+++ b/presentation/Mississauga_F27_Leadership_Review_Sep29.pptx
@@ -27,9 +27,10 @@
     <p:sldId id="275" r:id="rId21"/>
     <p:sldId id="276" r:id="rId22"/>
     <p:sldId id="277" r:id="rId23"/>
+    <p:sldId id="278" r:id="rId24"/>
   </p:sldIdLst>
   <p:notesMasterIdLst>
-    <p:notesMasterId r:id="rId24"/>
+    <p:notesMasterId r:id="rId25"/>
   </p:notesMasterIdLst>
   <p:sldSz cx="12192000" cy="6858000"/>
   <p:notesSz cx="6858000" cy="12192000"/>
@@ -5968,6 +5969,94 @@
             <a:fld id="{F7021451-1387-4CA6-816F-3879F97B5CBC}" type="slidenum">
               <a:rPr lang="en-US"/>
               <a:t>22</a:t>
+            </a:fld>
+            <a:endParaRPr lang="en-US"/>
+          </a:p>
+        </p:txBody>
+      </p:sp>
+    </p:spTree>
+    <p:extLst>
+      <p:ext uri="{BB962C8B-B14F-4D97-AF65-F5344CB8AC3E}">
+        <p14:creationId xmlns:p14="http://schemas.microsoft.com/office/powerpoint/2010/main" val="1024086991"/>
+      </p:ext>
+    </p:extLst>
+  </p:cSld>
+  <p:clrMapOvr>
+    <a:masterClrMapping/>
+  </p:clrMapOvr>
+</p:notes>
+</file>
+
+<file path=ppt/notesSlides/notesSlide23.xml><?xml version="1.0" encoding="utf-8"?>
+<p:notes xmlns:a="http://schemas.openxmlformats.org/drawingml/2006/main" xmlns:r="http://schemas.openxmlformats.org/officeDocument/2006/relationships" xmlns:p="http://schemas.openxmlformats.org/presentationml/2006/main">
+  <p:cSld>
+    <p:spTree>
+      <p:nvGrpSpPr>
+        <p:cNvPr id="1" name=""/>
+        <p:cNvGrpSpPr/>
+        <p:nvPr/>
+      </p:nvGrpSpPr>
+      <p:grpSpPr>
+        <a:xfrm>
+          <a:off x="0" y="0"/>
+          <a:ext cx="0" cy="0"/>
+          <a:chOff x="0" y="0"/>
+          <a:chExt cx="0" cy="0"/>
+        </a:xfrm>
+      </p:grpSpPr>
+      <p:sp>
+        <p:nvSpPr>
+          <p:cNvPr id="2" name="Slide Image Placeholder 1"/>
+          <p:cNvSpPr>
+            <a:spLocks noGrp="1" noRot="1" noChangeAspect="1"/>
+          </p:cNvSpPr>
+          <p:nvPr>
+            <p:ph type="sldImg"/>
+          </p:nvPr>
+        </p:nvSpPr>
+        <p:spPr/>
+      </p:sp>
+      <p:sp>
+        <p:nvSpPr>
+          <p:cNvPr id="3" name="Notes Placeholder 2"/>
+          <p:cNvSpPr>
+            <a:spLocks noGrp="1"/>
+          </p:cNvSpPr>
+          <p:nvPr>
+            <p:ph type="body" idx="1"/>
+          </p:nvPr>
+        </p:nvSpPr>
+        <p:spPr/>
+        <p:txBody>
+          <a:bodyPr/>
+          <a:lstStyle/>
+          <a:p>
+            <a:r>
+              <a:rPr lang="en-US" dirty="0"/>
+              <a:t>Backup — use only if asked.</a:t>
+            </a:r>
+            <a:endParaRPr lang="en-US" dirty="0"/>
+          </a:p>
+        </p:txBody>
+      </p:sp>
+      <p:sp>
+        <p:nvSpPr>
+          <p:cNvPr id="4" name="Slide Number Placeholder 3"/>
+          <p:cNvSpPr>
+            <a:spLocks noGrp="1"/>
+          </p:cNvSpPr>
+          <p:nvPr>
+            <p:ph type="sldNum" sz="quarter" idx="10"/>
+          </p:nvPr>
+        </p:nvSpPr>
+        <p:spPr/>
+        <p:txBody>
+          <a:bodyPr/>
+          <a:lstStyle/>
+          <a:p>
+            <a:fld id="{F7021451-1387-4CA6-816F-3879F97B5CBC}" type="slidenum">
+              <a:rPr lang="en-US"/>
+              <a:t>23</a:t>
             </a:fld>
             <a:endParaRPr lang="en-US"/>
           </a:p>
@@ -8951,7 +9040,7 @@
                 <a:ea typeface="Calibri" pitchFamily="34" charset="-122"/>
                 <a:cs typeface="Calibri" pitchFamily="34" charset="-120"/>
               </a:rPr>
-              <a:t>10 / 22</a:t>
+              <a:t>10 / 23</a:t>
             </a:r>
             <a:endParaRPr lang="en-US" sz="900" dirty="0"/>
           </a:p>
@@ -13444,7 +13533,7 @@
                 <a:ea typeface="Calibri" pitchFamily="34" charset="-122"/>
                 <a:cs typeface="Calibri" pitchFamily="34" charset="-120"/>
               </a:rPr>
-              <a:t>11 / 22</a:t>
+              <a:t>11 / 23</a:t>
             </a:r>
             <a:endParaRPr lang="en-US" sz="900" dirty="0"/>
           </a:p>
@@ -15456,7 +15545,7 @@
                 <a:ea typeface="Calibri" pitchFamily="34" charset="-122"/>
                 <a:cs typeface="Calibri" pitchFamily="34" charset="-120"/>
               </a:rPr>
-              <a:t>12 / 22</a:t>
+              <a:t>12 / 23</a:t>
             </a:r>
             <a:endParaRPr lang="en-US" sz="900" dirty="0"/>
           </a:p>
@@ -16093,7 +16182,7 @@
                 <a:ea typeface="Calibri" pitchFamily="34" charset="-122"/>
                 <a:cs typeface="Calibri" pitchFamily="34" charset="-120"/>
               </a:rPr>
-              <a:t>13 / 22</a:t>
+              <a:t>13 / 23</a:t>
             </a:r>
             <a:endParaRPr lang="en-US" sz="900" dirty="0"/>
           </a:p>
@@ -17600,7 +17689,7 @@
                 <a:ea typeface="Calibri" pitchFamily="34" charset="-122"/>
                 <a:cs typeface="Calibri" pitchFamily="34" charset="-120"/>
               </a:rPr>
-              <a:t>14 / 22</a:t>
+              <a:t>14 / 23</a:t>
             </a:r>
             <a:endParaRPr lang="en-US" sz="900" dirty="0"/>
           </a:p>
@@ -19955,7 +20044,7 @@
                 <a:ea typeface="Calibri" pitchFamily="34" charset="-122"/>
                 <a:cs typeface="Calibri" pitchFamily="34" charset="-120"/>
               </a:rPr>
-              <a:t>15 / 22</a:t>
+              <a:t>15 / 23</a:t>
             </a:r>
             <a:endParaRPr lang="en-US" sz="900" dirty="0"/>
           </a:p>
@@ -21043,7 +21132,7 @@
                 <a:ea typeface="Calibri" pitchFamily="34" charset="-122"/>
                 <a:cs typeface="Calibri" pitchFamily="34" charset="-120"/>
               </a:rPr>
-              <a:t>16 / 22</a:t>
+              <a:t>16 / 23</a:t>
             </a:r>
             <a:endParaRPr lang="en-US" sz="900" dirty="0"/>
           </a:p>
@@ -23943,7 +24032,7 @@
                 <a:ea typeface="Calibri" pitchFamily="34" charset="-122"/>
                 <a:cs typeface="Calibri" pitchFamily="34" charset="-120"/>
               </a:rPr>
-              <a:t>17 / 22</a:t>
+              <a:t>17 / 23</a:t>
             </a:r>
             <a:endParaRPr lang="en-US" sz="900" dirty="0"/>
           </a:p>
@@ -26663,7 +26752,7 @@
                 <a:ea typeface="Calibri" pitchFamily="34" charset="-122"/>
                 <a:cs typeface="Calibri" pitchFamily="34" charset="-120"/>
               </a:rPr>
-              <a:t>18 / 22</a:t>
+              <a:t>18 / 23</a:t>
             </a:r>
             <a:endParaRPr lang="en-US" sz="900" dirty="0"/>
           </a:p>
@@ -27860,7 +27949,7 @@
                 <a:ea typeface="Calibri" pitchFamily="34" charset="-122"/>
                 <a:cs typeface="Calibri" pitchFamily="34" charset="-120"/>
               </a:rPr>
-              <a:t>19 / 22</a:t>
+              <a:t>19 / 23</a:t>
             </a:r>
             <a:endParaRPr lang="en-US" sz="900" dirty="0"/>
           </a:p>
@@ -29256,7 +29345,7 @@
                 <a:ea typeface="Calibri" pitchFamily="34" charset="-122"/>
                 <a:cs typeface="Calibri" pitchFamily="34" charset="-120"/>
               </a:rPr>
-              <a:t>2 / 22</a:t>
+              <a:t>2 / 23</a:t>
             </a:r>
             <a:endParaRPr lang="en-US" sz="900" dirty="0"/>
           </a:p>
@@ -31463,7 +31552,7 @@
                 <a:ea typeface="Calibri" pitchFamily="34" charset="-122"/>
                 <a:cs typeface="Calibri" pitchFamily="34" charset="-120"/>
               </a:rPr>
-              <a:t>20 / 22</a:t>
+              <a:t>20 / 23</a:t>
             </a:r>
             <a:endParaRPr lang="en-US" sz="900" dirty="0"/>
           </a:p>
@@ -32152,7 +32241,7 @@
                 <a:ea typeface="Calibri" pitchFamily="34" charset="-122"/>
                 <a:cs typeface="Calibri" pitchFamily="34" charset="-120"/>
               </a:rPr>
-              <a:t>21 / 22</a:t>
+              <a:t>21 / 23</a:t>
             </a:r>
             <a:endParaRPr lang="en-US" sz="900" dirty="0"/>
           </a:p>
@@ -33520,7 +33609,1312 @@
                 <a:ea typeface="Calibri" pitchFamily="34" charset="-122"/>
                 <a:cs typeface="Calibri" pitchFamily="34" charset="-120"/>
               </a:rPr>
-              <a:t>22 / 22</a:t>
+              <a:t>22 / 23</a:t>
+            </a:r>
+            <a:endParaRPr lang="en-US" sz="900" dirty="0"/>
+          </a:p>
+        </p:txBody>
+      </p:sp>
+    </p:spTree>
+  </p:cSld>
+  <p:clrMapOvr>
+    <a:masterClrMapping/>
+  </p:clrMapOvr>
+</p:sld>
+</file>
+
+<file path=ppt/slides/slide23.xml><?xml version="1.0" encoding="utf-8"?>
+<p:sld xmlns:a="http://schemas.openxmlformats.org/drawingml/2006/main" xmlns:r="http://schemas.openxmlformats.org/officeDocument/2006/relationships" xmlns:p="http://schemas.openxmlformats.org/presentationml/2006/main">
+  <p:cSld name="Slide 23">
+    <p:bg>
+      <p:bgPr>
+        <a:solidFill>
+          <a:srgbClr val="FFFFFF"/>
+        </a:solidFill>
+      </p:bgPr>
+    </p:bg>
+    <p:spTree>
+      <p:nvGrpSpPr>
+        <p:cNvPr id="1" name=""/>
+        <p:cNvGrpSpPr/>
+        <p:nvPr/>
+      </p:nvGrpSpPr>
+      <p:grpSpPr>
+        <a:xfrm>
+          <a:off x="0" y="0"/>
+          <a:ext cx="0" cy="0"/>
+          <a:chOff x="0" y="0"/>
+          <a:chExt cx="0" cy="0"/>
+        </a:xfrm>
+      </p:grpSpPr>
+      <p:sp>
+        <p:nvSpPr>
+          <p:cNvPr id="2" name="Text 0"/>
+          <p:cNvSpPr txBox="1"/>
+          <p:nvPr/>
+        </p:nvSpPr>
+        <p:spPr>
+          <a:xfrm>
+            <a:off x="548640" y="320040"/>
+            <a:ext cx="9144000" cy="274320"/>
+          </a:xfrm>
+          <a:prstGeom prst="rect">
+            <a:avLst/>
+          </a:prstGeom>
+          <a:noFill/>
+          <a:ln/>
+        </p:spPr>
+        <p:txBody>
+          <a:bodyPr wrap="square" lIns="0" tIns="0" rIns="0" bIns="0" rtlCol="0" anchor="ctr"/>
+          <a:lstStyle/>
+          <a:p>
+            <a:pPr indent="0" marL="0">
+              <a:buNone/>
+            </a:pPr>
+            <a:r>
+              <a:rPr lang="en-US" sz="1200" b="1" spc="300" kern="0" dirty="0">
+                <a:solidFill>
+                  <a:srgbClr val="7C3AED"/>
+                </a:solidFill>
+                <a:latin typeface="Calibri" pitchFamily="34" charset="0"/>
+                <a:ea typeface="Calibri" pitchFamily="34" charset="-122"/>
+                <a:cs typeface="Calibri" pitchFamily="34" charset="-120"/>
+              </a:rPr>
+              <a:t>BACKUP</a:t>
+            </a:r>
+            <a:endParaRPr lang="en-US" sz="1200" dirty="0"/>
+          </a:p>
+        </p:txBody>
+      </p:sp>
+      <p:sp>
+        <p:nvSpPr>
+          <p:cNvPr id="3" name="Text 1"/>
+          <p:cNvSpPr txBox="1"/>
+          <p:nvPr/>
+        </p:nvSpPr>
+        <p:spPr>
+          <a:xfrm>
+            <a:off x="548640" y="603504"/>
+            <a:ext cx="11091672" cy="603504"/>
+          </a:xfrm>
+          <a:prstGeom prst="rect">
+            <a:avLst/>
+          </a:prstGeom>
+          <a:noFill/>
+          <a:ln/>
+        </p:spPr>
+        <p:txBody>
+          <a:bodyPr wrap="square" lIns="0" tIns="0" rIns="0" bIns="0" rtlCol="0" anchor="t"/>
+          <a:lstStyle/>
+          <a:p>
+            <a:pPr indent="0" marL="0">
+              <a:buNone/>
+            </a:pPr>
+            <a:r>
+              <a:rPr lang="en-US" sz="3000" b="1" dirty="0">
+                <a:solidFill>
+                  <a:srgbClr val="111827"/>
+                </a:solidFill>
+                <a:latin typeface="Calibri" pitchFamily="34" charset="0"/>
+                <a:ea typeface="Calibri" pitchFamily="34" charset="-122"/>
+                <a:cs typeface="Calibri" pitchFamily="34" charset="-120"/>
+              </a:rPr>
+              <a:t>Backup — key numbers for Q&amp;A</a:t>
+            </a:r>
+            <a:endParaRPr lang="en-US" sz="3000" dirty="0"/>
+          </a:p>
+        </p:txBody>
+      </p:sp>
+      <p:sp>
+        <p:nvSpPr>
+          <p:cNvPr id="4" name="Text 2"/>
+          <p:cNvSpPr txBox="1"/>
+          <p:nvPr/>
+        </p:nvSpPr>
+        <p:spPr>
+          <a:xfrm>
+            <a:off x="548640" y="1243584"/>
+            <a:ext cx="11091672" cy="274320"/>
+          </a:xfrm>
+          <a:prstGeom prst="rect">
+            <a:avLst/>
+          </a:prstGeom>
+          <a:noFill/>
+          <a:ln/>
+        </p:spPr>
+        <p:txBody>
+          <a:bodyPr wrap="square" lIns="0" tIns="0" rIns="0" bIns="0" rtlCol="0" anchor="ctr"/>
+          <a:lstStyle/>
+          <a:p>
+            <a:pPr indent="0" marL="0">
+              <a:buNone/>
+            </a:pPr>
+            <a:r>
+              <a:rPr lang="en-US" sz="1200" dirty="0">
+                <a:solidFill>
+                  <a:srgbClr val="6B7280"/>
+                </a:solidFill>
+                <a:latin typeface="Calibri" pitchFamily="34" charset="0"/>
+                <a:ea typeface="Calibri" pitchFamily="34" charset="-122"/>
+                <a:cs typeface="Calibri" pitchFamily="34" charset="-120"/>
+              </a:rPr>
+              <a:t>Mississauga · September MTD to Sep 26 unless noted · (calc.) = calculated from report figures</a:t>
+            </a:r>
+            <a:endParaRPr lang="en-US" sz="1200" dirty="0"/>
+          </a:p>
+        </p:txBody>
+      </p:sp>
+      <p:sp>
+        <p:nvSpPr>
+          <p:cNvPr id="5" name="Shape 3"/>
+          <p:cNvSpPr/>
+          <p:nvPr/>
+        </p:nvSpPr>
+        <p:spPr>
+          <a:xfrm>
+            <a:off x="548640" y="1627632"/>
+            <a:ext cx="5431536" cy="822960"/>
+          </a:xfrm>
+          <a:prstGeom prst="roundRect">
+            <a:avLst>
+              <a:gd name="adj" fmla="val 8889"/>
+            </a:avLst>
+          </a:prstGeom>
+          <a:solidFill>
+            <a:srgbClr val="F3F4F6"/>
+          </a:solidFill>
+          <a:ln w="12700">
+            <a:solidFill>
+              <a:srgbClr val="F3F4F6"/>
+            </a:solidFill>
+            <a:prstDash val="solid"/>
+          </a:ln>
+        </p:spPr>
+      </p:sp>
+      <p:sp>
+        <p:nvSpPr>
+          <p:cNvPr id="6" name="Text 4"/>
+          <p:cNvSpPr txBox="1"/>
+          <p:nvPr/>
+        </p:nvSpPr>
+        <p:spPr>
+          <a:xfrm>
+            <a:off x="685800" y="1627632"/>
+            <a:ext cx="1234440" cy="822960"/>
+          </a:xfrm>
+          <a:prstGeom prst="rect">
+            <a:avLst/>
+          </a:prstGeom>
+          <a:noFill/>
+          <a:ln/>
+        </p:spPr>
+        <p:txBody>
+          <a:bodyPr wrap="square" lIns="0" tIns="0" rIns="0" bIns="0" rtlCol="0" anchor="ctr"/>
+          <a:lstStyle/>
+          <a:p>
+            <a:pPr indent="0" marL="0">
+              <a:buNone/>
+            </a:pPr>
+            <a:r>
+              <a:rPr lang="en-US" sz="1100" b="1" dirty="0">
+                <a:solidFill>
+                  <a:srgbClr val="7C3AED"/>
+                </a:solidFill>
+                <a:latin typeface="Calibri" pitchFamily="34" charset="0"/>
+                <a:ea typeface="Calibri" pitchFamily="34" charset="-122"/>
+                <a:cs typeface="Calibri" pitchFamily="34" charset="-120"/>
+              </a:rPr>
+              <a:t>SCA target?</a:t>
+            </a:r>
+            <a:endParaRPr lang="en-US" sz="1100" dirty="0"/>
+          </a:p>
+        </p:txBody>
+      </p:sp>
+      <p:sp>
+        <p:nvSpPr>
+          <p:cNvPr id="7" name="Text 5"/>
+          <p:cNvSpPr txBox="1"/>
+          <p:nvPr/>
+        </p:nvSpPr>
+        <p:spPr>
+          <a:xfrm>
+            <a:off x="1965960" y="1664208"/>
+            <a:ext cx="3877056" cy="749808"/>
+          </a:xfrm>
+          <a:prstGeom prst="rect">
+            <a:avLst/>
+          </a:prstGeom>
+          <a:noFill/>
+          <a:ln/>
+        </p:spPr>
+        <p:txBody>
+          <a:bodyPr wrap="square" lIns="0" tIns="0" rIns="0" bIns="0" rtlCol="0" anchor="ctr"/>
+          <a:lstStyle/>
+          <a:p>
+            <a:pPr indent="0" marL="0">
+              <a:buNone/>
+            </a:pPr>
+            <a:r>
+              <a:rPr lang="en-US" sz="1000" dirty="0">
+                <a:solidFill>
+                  <a:srgbClr val="1F2937"/>
+                </a:solidFill>
+                <a:latin typeface="Calibri" pitchFamily="34" charset="0"/>
+                <a:ea typeface="Calibri" pitchFamily="34" charset="-122"/>
+                <a:cs typeface="Calibri" pitchFamily="34" charset="-120"/>
+              </a:rPr>
+              <a:t>Sept SCA target 5,122 dock hrs (F26 Sept 6,303 − 1,181-hr reduction target) · 244 hrs per working day · cost per PRO target $6.85.</a:t>
+            </a:r>
+            <a:endParaRPr lang="en-US" sz="1000" dirty="0"/>
+          </a:p>
+        </p:txBody>
+      </p:sp>
+      <p:sp>
+        <p:nvSpPr>
+          <p:cNvPr id="8" name="Shape 6"/>
+          <p:cNvSpPr/>
+          <p:nvPr/>
+        </p:nvSpPr>
+        <p:spPr>
+          <a:xfrm>
+            <a:off x="548640" y="2523744"/>
+            <a:ext cx="5431536" cy="822960"/>
+          </a:xfrm>
+          <a:prstGeom prst="roundRect">
+            <a:avLst>
+              <a:gd name="adj" fmla="val 8889"/>
+            </a:avLst>
+          </a:prstGeom>
+          <a:solidFill>
+            <a:srgbClr val="F9FAFB"/>
+          </a:solidFill>
+          <a:ln w="12700">
+            <a:solidFill>
+              <a:srgbClr val="F9FAFB"/>
+            </a:solidFill>
+            <a:prstDash val="solid"/>
+          </a:ln>
+        </p:spPr>
+      </p:sp>
+      <p:sp>
+        <p:nvSpPr>
+          <p:cNvPr id="9" name="Text 7"/>
+          <p:cNvSpPr txBox="1"/>
+          <p:nvPr/>
+        </p:nvSpPr>
+        <p:spPr>
+          <a:xfrm>
+            <a:off x="685800" y="2523744"/>
+            <a:ext cx="1234440" cy="822960"/>
+          </a:xfrm>
+          <a:prstGeom prst="rect">
+            <a:avLst/>
+          </a:prstGeom>
+          <a:noFill/>
+          <a:ln/>
+        </p:spPr>
+        <p:txBody>
+          <a:bodyPr wrap="square" lIns="0" tIns="0" rIns="0" bIns="0" rtlCol="0" anchor="ctr"/>
+          <a:lstStyle/>
+          <a:p>
+            <a:pPr indent="0" marL="0">
+              <a:buNone/>
+            </a:pPr>
+            <a:r>
+              <a:rPr lang="en-US" sz="1100" b="1" dirty="0">
+                <a:solidFill>
+                  <a:srgbClr val="7C3AED"/>
+                </a:solidFill>
+                <a:latin typeface="Calibri" pitchFamily="34" charset="0"/>
+                <a:ea typeface="Calibri" pitchFamily="34" charset="-122"/>
+                <a:cs typeface="Calibri" pitchFamily="34" charset="-120"/>
+              </a:rPr>
+              <a:t>Tracking?</a:t>
+            </a:r>
+            <a:endParaRPr lang="en-US" sz="1100" dirty="0"/>
+          </a:p>
+        </p:txBody>
+      </p:sp>
+      <p:sp>
+        <p:nvSpPr>
+          <p:cNvPr id="10" name="Text 8"/>
+          <p:cNvSpPr txBox="1"/>
+          <p:nvPr/>
+        </p:nvSpPr>
+        <p:spPr>
+          <a:xfrm>
+            <a:off x="1965960" y="2560320"/>
+            <a:ext cx="3877056" cy="749808"/>
+          </a:xfrm>
+          <a:prstGeom prst="rect">
+            <a:avLst/>
+          </a:prstGeom>
+          <a:noFill/>
+          <a:ln/>
+        </p:spPr>
+        <p:txBody>
+          <a:bodyPr wrap="square" lIns="0" tIns="0" rIns="0" bIns="0" rtlCol="0" anchor="ctr"/>
+          <a:lstStyle/>
+          <a:p>
+            <a:pPr indent="0" marL="0">
+              <a:buNone/>
+            </a:pPr>
+            <a:r>
+              <a:rPr lang="en-US" sz="1000" dirty="0">
+                <a:solidFill>
+                  <a:srgbClr val="1F2937"/>
+                </a:solidFill>
+                <a:latin typeface="Calibri" pitchFamily="34" charset="0"/>
+                <a:ea typeface="Calibri" pitchFamily="34" charset="-122"/>
+                <a:cs typeface="Calibri" pitchFamily="34" charset="-120"/>
+              </a:rPr>
+              <a:t>3,999 hrs used vs 4,390 allowed MTD = 91.1% (391 hrs under ≈ $13.1K) · pace ≈4,666 hrs vs 5,122 target = 139% of reduction target · cost per PRO $6.60 = 96.3% of target (amber).</a:t>
+            </a:r>
+            <a:endParaRPr lang="en-US" sz="1000" dirty="0"/>
+          </a:p>
+        </p:txBody>
+      </p:sp>
+      <p:sp>
+        <p:nvSpPr>
+          <p:cNvPr id="11" name="Shape 9"/>
+          <p:cNvSpPr/>
+          <p:nvPr/>
+        </p:nvSpPr>
+        <p:spPr>
+          <a:xfrm>
+            <a:off x="548640" y="3419856"/>
+            <a:ext cx="5431536" cy="822960"/>
+          </a:xfrm>
+          <a:prstGeom prst="roundRect">
+            <a:avLst>
+              <a:gd name="adj" fmla="val 8889"/>
+            </a:avLst>
+          </a:prstGeom>
+          <a:solidFill>
+            <a:srgbClr val="F3F4F6"/>
+          </a:solidFill>
+          <a:ln w="12700">
+            <a:solidFill>
+              <a:srgbClr val="F3F4F6"/>
+            </a:solidFill>
+            <a:prstDash val="solid"/>
+          </a:ln>
+        </p:spPr>
+      </p:sp>
+      <p:sp>
+        <p:nvSpPr>
+          <p:cNvPr id="12" name="Text 10"/>
+          <p:cNvSpPr txBox="1"/>
+          <p:nvPr/>
+        </p:nvSpPr>
+        <p:spPr>
+          <a:xfrm>
+            <a:off x="685800" y="3419856"/>
+            <a:ext cx="1234440" cy="822960"/>
+          </a:xfrm>
+          <a:prstGeom prst="rect">
+            <a:avLst/>
+          </a:prstGeom>
+          <a:noFill/>
+          <a:ln/>
+        </p:spPr>
+        <p:txBody>
+          <a:bodyPr wrap="square" lIns="0" tIns="0" rIns="0" bIns="0" rtlCol="0" anchor="ctr"/>
+          <a:lstStyle/>
+          <a:p>
+            <a:pPr indent="0" marL="0">
+              <a:buNone/>
+            </a:pPr>
+            <a:r>
+              <a:rPr lang="en-US" sz="1100" b="1" dirty="0">
+                <a:solidFill>
+                  <a:srgbClr val="7C3AED"/>
+                </a:solidFill>
+                <a:latin typeface="Calibri" pitchFamily="34" charset="0"/>
+                <a:ea typeface="Calibri" pitchFamily="34" charset="-122"/>
+                <a:cs typeface="Calibri" pitchFamily="34" charset="-120"/>
+              </a:rPr>
+              <a:t>Spend rate?</a:t>
+            </a:r>
+            <a:endParaRPr lang="en-US" sz="1100" dirty="0"/>
+          </a:p>
+        </p:txBody>
+      </p:sp>
+      <p:sp>
+        <p:nvSpPr>
+          <p:cNvPr id="13" name="Text 11"/>
+          <p:cNvSpPr txBox="1"/>
+          <p:nvPr/>
+        </p:nvSpPr>
+        <p:spPr>
+          <a:xfrm>
+            <a:off x="1965960" y="3456432"/>
+            <a:ext cx="3877056" cy="749808"/>
+          </a:xfrm>
+          <a:prstGeom prst="rect">
+            <a:avLst/>
+          </a:prstGeom>
+          <a:noFill/>
+          <a:ln/>
+        </p:spPr>
+        <p:txBody>
+          <a:bodyPr wrap="square" lIns="0" tIns="0" rIns="0" bIns="0" rtlCol="0" anchor="ctr"/>
+          <a:lstStyle/>
+          <a:p>
+            <a:pPr indent="0" marL="0">
+              <a:buNone/>
+            </a:pPr>
+            <a:r>
+              <a:rPr lang="en-US" sz="1000" dirty="0">
+                <a:solidFill>
+                  <a:srgbClr val="1F2937"/>
+                </a:solidFill>
+                <a:latin typeface="Calibri" pitchFamily="34" charset="0"/>
+                <a:ea typeface="Calibri" pitchFamily="34" charset="-122"/>
+                <a:cs typeface="Calibri" pitchFamily="34" charset="-120"/>
+              </a:rPr>
+              <a:t>Dock labour $133,692 MTD over 18 working days ≈ $7,427 per working day (calc.) · projected Sept ≈ $156K vs $199.7K F26 Sept (≈ −22%, calc.) · $33.43/hr (+5.5% YoY wage rate) · cost per unit $2.19 vs $2.64 (−16.7%).</a:t>
+            </a:r>
+            <a:endParaRPr lang="en-US" sz="1000" dirty="0"/>
+          </a:p>
+        </p:txBody>
+      </p:sp>
+      <p:sp>
+        <p:nvSpPr>
+          <p:cNvPr id="14" name="Shape 12"/>
+          <p:cNvSpPr/>
+          <p:nvPr/>
+        </p:nvSpPr>
+        <p:spPr>
+          <a:xfrm>
+            <a:off x="548640" y="4315968"/>
+            <a:ext cx="5431536" cy="822960"/>
+          </a:xfrm>
+          <a:prstGeom prst="roundRect">
+            <a:avLst>
+              <a:gd name="adj" fmla="val 8889"/>
+            </a:avLst>
+          </a:prstGeom>
+          <a:solidFill>
+            <a:srgbClr val="F9FAFB"/>
+          </a:solidFill>
+          <a:ln w="12700">
+            <a:solidFill>
+              <a:srgbClr val="F9FAFB"/>
+            </a:solidFill>
+            <a:prstDash val="solid"/>
+          </a:ln>
+        </p:spPr>
+      </p:sp>
+      <p:sp>
+        <p:nvSpPr>
+          <p:cNvPr id="15" name="Text 13"/>
+          <p:cNvSpPr txBox="1"/>
+          <p:nvPr/>
+        </p:nvSpPr>
+        <p:spPr>
+          <a:xfrm>
+            <a:off x="685800" y="4315968"/>
+            <a:ext cx="1234440" cy="822960"/>
+          </a:xfrm>
+          <a:prstGeom prst="rect">
+            <a:avLst/>
+          </a:prstGeom>
+          <a:noFill/>
+          <a:ln/>
+        </p:spPr>
+        <p:txBody>
+          <a:bodyPr wrap="square" lIns="0" tIns="0" rIns="0" bIns="0" rtlCol="0" anchor="ctr"/>
+          <a:lstStyle/>
+          <a:p>
+            <a:pPr indent="0" marL="0">
+              <a:buNone/>
+            </a:pPr>
+            <a:r>
+              <a:rPr lang="en-US" sz="1100" b="1" dirty="0">
+                <a:solidFill>
+                  <a:srgbClr val="7C3AED"/>
+                </a:solidFill>
+                <a:latin typeface="Calibri" pitchFamily="34" charset="0"/>
+                <a:ea typeface="Calibri" pitchFamily="34" charset="-122"/>
+                <a:cs typeface="Calibri" pitchFamily="34" charset="-120"/>
+              </a:rPr>
+              <a:t>Agency mix?</a:t>
+            </a:r>
+            <a:endParaRPr lang="en-US" sz="1100" dirty="0"/>
+          </a:p>
+        </p:txBody>
+      </p:sp>
+      <p:sp>
+        <p:nvSpPr>
+          <p:cNvPr id="16" name="Text 14"/>
+          <p:cNvSpPr txBox="1"/>
+          <p:nvPr/>
+        </p:nvSpPr>
+        <p:spPr>
+          <a:xfrm>
+            <a:off x="1965960" y="4352544"/>
+            <a:ext cx="3877056" cy="749808"/>
+          </a:xfrm>
+          <a:prstGeom prst="rect">
+            <a:avLst/>
+          </a:prstGeom>
+          <a:noFill/>
+          <a:ln/>
+        </p:spPr>
+        <p:txBody>
+          <a:bodyPr wrap="square" lIns="0" tIns="0" rIns="0" bIns="0" rtlCol="0" anchor="ctr"/>
+          <a:lstStyle/>
+          <a:p>
+            <a:pPr indent="0" marL="0">
+              <a:buNone/>
+            </a:pPr>
+            <a:r>
+              <a:rPr lang="en-US" sz="1000" dirty="0">
+                <a:solidFill>
+                  <a:srgbClr val="1F2937"/>
+                </a:solidFill>
+                <a:latin typeface="Calibri" pitchFamily="34" charset="0"/>
+                <a:ea typeface="Calibri" pitchFamily="34" charset="-122"/>
+                <a:cs typeface="Calibri" pitchFamily="34" charset="-120"/>
+              </a:rPr>
+              <a:t>Agency 61% of dock hours (2,457 of 3,999) vs 70.5% F26 · agency cost $74,775 = 56% of dock labour vs 65% F26 (calc.).</a:t>
+            </a:r>
+            <a:endParaRPr lang="en-US" sz="1000" dirty="0"/>
+          </a:p>
+        </p:txBody>
+      </p:sp>
+      <p:sp>
+        <p:nvSpPr>
+          <p:cNvPr id="17" name="Shape 15"/>
+          <p:cNvSpPr/>
+          <p:nvPr/>
+        </p:nvSpPr>
+        <p:spPr>
+          <a:xfrm>
+            <a:off x="548640" y="5212080"/>
+            <a:ext cx="5431536" cy="822960"/>
+          </a:xfrm>
+          <a:prstGeom prst="roundRect">
+            <a:avLst>
+              <a:gd name="adj" fmla="val 8889"/>
+            </a:avLst>
+          </a:prstGeom>
+          <a:solidFill>
+            <a:srgbClr val="F3F4F6"/>
+          </a:solidFill>
+          <a:ln w="12700">
+            <a:solidFill>
+              <a:srgbClr val="F3F4F6"/>
+            </a:solidFill>
+            <a:prstDash val="solid"/>
+          </a:ln>
+        </p:spPr>
+      </p:sp>
+      <p:sp>
+        <p:nvSpPr>
+          <p:cNvPr id="18" name="Text 16"/>
+          <p:cNvSpPr txBox="1"/>
+          <p:nvPr/>
+        </p:nvSpPr>
+        <p:spPr>
+          <a:xfrm>
+            <a:off x="685800" y="5212080"/>
+            <a:ext cx="1234440" cy="822960"/>
+          </a:xfrm>
+          <a:prstGeom prst="rect">
+            <a:avLst/>
+          </a:prstGeom>
+          <a:noFill/>
+          <a:ln/>
+        </p:spPr>
+        <p:txBody>
+          <a:bodyPr wrap="square" lIns="0" tIns="0" rIns="0" bIns="0" rtlCol="0" anchor="ctr"/>
+          <a:lstStyle/>
+          <a:p>
+            <a:pPr indent="0" marL="0">
+              <a:buNone/>
+            </a:pPr>
+            <a:r>
+              <a:rPr lang="en-US" sz="1100" b="1" dirty="0">
+                <a:solidFill>
+                  <a:srgbClr val="7C3AED"/>
+                </a:solidFill>
+                <a:latin typeface="Calibri" pitchFamily="34" charset="0"/>
+                <a:ea typeface="Calibri" pitchFamily="34" charset="-122"/>
+                <a:cs typeface="Calibri" pitchFamily="34" charset="-120"/>
+              </a:rPr>
+              <a:t>Year-end goal?</a:t>
+            </a:r>
+            <a:endParaRPr lang="en-US" sz="1100" dirty="0"/>
+          </a:p>
+        </p:txBody>
+      </p:sp>
+      <p:sp>
+        <p:nvSpPr>
+          <p:cNvPr id="19" name="Text 17"/>
+          <p:cNvSpPr txBox="1"/>
+          <p:nvPr/>
+        </p:nvSpPr>
+        <p:spPr>
+          <a:xfrm>
+            <a:off x="1965960" y="5248656"/>
+            <a:ext cx="3877056" cy="749808"/>
+          </a:xfrm>
+          <a:prstGeom prst="rect">
+            <a:avLst/>
+          </a:prstGeom>
+          <a:noFill/>
+          <a:ln/>
+        </p:spPr>
+        <p:txBody>
+          <a:bodyPr wrap="square" lIns="0" tIns="0" rIns="0" bIns="0" rtlCol="0" anchor="ctr"/>
+          <a:lstStyle/>
+          <a:p>
+            <a:pPr indent="0" marL="0">
+              <a:buNone/>
+            </a:pPr>
+            <a:r>
+              <a:rPr lang="en-US" sz="1000" dirty="0">
+                <a:solidFill>
+                  <a:srgbClr val="1F2937"/>
+                </a:solidFill>
+                <a:latin typeface="Calibri" pitchFamily="34" charset="0"/>
+                <a:ea typeface="Calibri" pitchFamily="34" charset="-122"/>
+                <a:cs typeface="Calibri" pitchFamily="34" charset="-120"/>
+              </a:rPr>
+              <a:t>F27 cost take-out target: </a:t>
+            </a:r>
+            <a:pPr indent="0" marL="0">
+              <a:buNone/>
+            </a:pPr>
+            <a:r>
+              <a:rPr lang="en-US" sz="1000" b="1" dirty="0">
+                <a:solidFill>
+                  <a:srgbClr val="D97706"/>
+                </a:solidFill>
+                <a:latin typeface="Calibri" pitchFamily="34" charset="0"/>
+                <a:ea typeface="Calibri" pitchFamily="34" charset="-122"/>
+                <a:cs typeface="Calibri" pitchFamily="34" charset="-120"/>
+              </a:rPr>
+              <a:t>TBC</a:t>
+            </a:r>
+            <a:pPr indent="0" marL="0">
+              <a:buNone/>
+            </a:pPr>
+            <a:r>
+              <a:rPr lang="en-US" sz="1000" dirty="0">
+                <a:solidFill>
+                  <a:srgbClr val="1F2937"/>
+                </a:solidFill>
+                <a:latin typeface="Calibri" pitchFamily="34" charset="0"/>
+                <a:ea typeface="Calibri" pitchFamily="34" charset="-122"/>
+                <a:cs typeface="Calibri" pitchFamily="34" charset="-120"/>
+              </a:rPr>
+              <a:t> · identified so far $61K/yr (dispatcher role eliminated).</a:t>
+            </a:r>
+            <a:endParaRPr lang="en-US" sz="1000" dirty="0"/>
+          </a:p>
+        </p:txBody>
+      </p:sp>
+      <p:sp>
+        <p:nvSpPr>
+          <p:cNvPr id="20" name="Shape 18"/>
+          <p:cNvSpPr/>
+          <p:nvPr/>
+        </p:nvSpPr>
+        <p:spPr>
+          <a:xfrm>
+            <a:off x="6208776" y="1627632"/>
+            <a:ext cx="5431536" cy="822960"/>
+          </a:xfrm>
+          <a:prstGeom prst="roundRect">
+            <a:avLst>
+              <a:gd name="adj" fmla="val 8889"/>
+            </a:avLst>
+          </a:prstGeom>
+          <a:solidFill>
+            <a:srgbClr val="F3F4F6"/>
+          </a:solidFill>
+          <a:ln w="12700">
+            <a:solidFill>
+              <a:srgbClr val="F3F4F6"/>
+            </a:solidFill>
+            <a:prstDash val="solid"/>
+          </a:ln>
+        </p:spPr>
+      </p:sp>
+      <p:sp>
+        <p:nvSpPr>
+          <p:cNvPr id="21" name="Text 19"/>
+          <p:cNvSpPr txBox="1"/>
+          <p:nvPr/>
+        </p:nvSpPr>
+        <p:spPr>
+          <a:xfrm>
+            <a:off x="6345936" y="1627632"/>
+            <a:ext cx="1234440" cy="822960"/>
+          </a:xfrm>
+          <a:prstGeom prst="rect">
+            <a:avLst/>
+          </a:prstGeom>
+          <a:noFill/>
+          <a:ln/>
+        </p:spPr>
+        <p:txBody>
+          <a:bodyPr wrap="square" lIns="0" tIns="0" rIns="0" bIns="0" rtlCol="0" anchor="ctr"/>
+          <a:lstStyle/>
+          <a:p>
+            <a:pPr indent="0" marL="0">
+              <a:buNone/>
+            </a:pPr>
+            <a:r>
+              <a:rPr lang="en-US" sz="1100" b="1" dirty="0">
+                <a:solidFill>
+                  <a:srgbClr val="7C3AED"/>
+                </a:solidFill>
+                <a:latin typeface="Calibri" pitchFamily="34" charset="0"/>
+                <a:ea typeface="Calibri" pitchFamily="34" charset="-122"/>
+                <a:cs typeface="Calibri" pitchFamily="34" charset="-120"/>
+              </a:rPr>
+              <a:t>Overtime?</a:t>
+            </a:r>
+            <a:endParaRPr lang="en-US" sz="1100" dirty="0"/>
+          </a:p>
+        </p:txBody>
+      </p:sp>
+      <p:sp>
+        <p:nvSpPr>
+          <p:cNvPr id="22" name="Text 20"/>
+          <p:cNvSpPr txBox="1"/>
+          <p:nvPr/>
+        </p:nvSpPr>
+        <p:spPr>
+          <a:xfrm>
+            <a:off x="7626096" y="1664208"/>
+            <a:ext cx="3877056" cy="749808"/>
+          </a:xfrm>
+          <a:prstGeom prst="rect">
+            <a:avLst/>
+          </a:prstGeom>
+          <a:noFill/>
+          <a:ln/>
+        </p:spPr>
+        <p:txBody>
+          <a:bodyPr wrap="square" lIns="0" tIns="0" rIns="0" bIns="0" rtlCol="0" anchor="ctr"/>
+          <a:lstStyle/>
+          <a:p>
+            <a:pPr indent="0" marL="0">
+              <a:buNone/>
+            </a:pPr>
+            <a:r>
+              <a:rPr lang="en-US" sz="1000" dirty="0">
+                <a:solidFill>
+                  <a:srgbClr val="1F2937"/>
+                </a:solidFill>
+                <a:latin typeface="Calibri" pitchFamily="34" charset="0"/>
+                <a:ea typeface="Calibri" pitchFamily="34" charset="-122"/>
+                <a:cs typeface="Calibri" pitchFamily="34" charset="-120"/>
+              </a:rPr>
+              <a:t>9 hrs Sept (0.2%) · Q1 OT 62.3 hrs, 1.0% of hours.</a:t>
+            </a:r>
+            <a:endParaRPr lang="en-US" sz="1000" dirty="0"/>
+          </a:p>
+        </p:txBody>
+      </p:sp>
+      <p:sp>
+        <p:nvSpPr>
+          <p:cNvPr id="23" name="Shape 21"/>
+          <p:cNvSpPr/>
+          <p:nvPr/>
+        </p:nvSpPr>
+        <p:spPr>
+          <a:xfrm>
+            <a:off x="6208776" y="2523744"/>
+            <a:ext cx="5431536" cy="822960"/>
+          </a:xfrm>
+          <a:prstGeom prst="roundRect">
+            <a:avLst>
+              <a:gd name="adj" fmla="val 8889"/>
+            </a:avLst>
+          </a:prstGeom>
+          <a:solidFill>
+            <a:srgbClr val="F9FAFB"/>
+          </a:solidFill>
+          <a:ln w="12700">
+            <a:solidFill>
+              <a:srgbClr val="F9FAFB"/>
+            </a:solidFill>
+            <a:prstDash val="solid"/>
+          </a:ln>
+        </p:spPr>
+      </p:sp>
+      <p:sp>
+        <p:nvSpPr>
+          <p:cNvPr id="24" name="Text 22"/>
+          <p:cNvSpPr txBox="1"/>
+          <p:nvPr/>
+        </p:nvSpPr>
+        <p:spPr>
+          <a:xfrm>
+            <a:off x="6345936" y="2523744"/>
+            <a:ext cx="1234440" cy="822960"/>
+          </a:xfrm>
+          <a:prstGeom prst="rect">
+            <a:avLst/>
+          </a:prstGeom>
+          <a:noFill/>
+          <a:ln/>
+        </p:spPr>
+        <p:txBody>
+          <a:bodyPr wrap="square" lIns="0" tIns="0" rIns="0" bIns="0" rtlCol="0" anchor="ctr"/>
+          <a:lstStyle/>
+          <a:p>
+            <a:pPr indent="0" marL="0">
+              <a:buNone/>
+            </a:pPr>
+            <a:r>
+              <a:rPr lang="en-US" sz="1100" b="1" dirty="0">
+                <a:solidFill>
+                  <a:srgbClr val="7C3AED"/>
+                </a:solidFill>
+                <a:latin typeface="Calibri" pitchFamily="34" charset="0"/>
+                <a:ea typeface="Calibri" pitchFamily="34" charset="-122"/>
+                <a:cs typeface="Calibri" pitchFamily="34" charset="-120"/>
+              </a:rPr>
+              <a:t>PPH gap?</a:t>
+            </a:r>
+            <a:endParaRPr lang="en-US" sz="1100" dirty="0"/>
+          </a:p>
+        </p:txBody>
+      </p:sp>
+      <p:sp>
+        <p:nvSpPr>
+          <p:cNvPr id="25" name="Text 23"/>
+          <p:cNvSpPr txBox="1"/>
+          <p:nvPr/>
+        </p:nvSpPr>
+        <p:spPr>
+          <a:xfrm>
+            <a:off x="7626096" y="2560320"/>
+            <a:ext cx="3877056" cy="749808"/>
+          </a:xfrm>
+          <a:prstGeom prst="rect">
+            <a:avLst/>
+          </a:prstGeom>
+          <a:noFill/>
+          <a:ln/>
+        </p:spPr>
+        <p:txBody>
+          <a:bodyPr wrap="square" lIns="0" tIns="0" rIns="0" bIns="0" rtlCol="0" anchor="ctr"/>
+          <a:lstStyle/>
+          <a:p>
+            <a:pPr indent="0" marL="0">
+              <a:buNone/>
+            </a:pPr>
+            <a:r>
+              <a:rPr lang="en-US" sz="1000" dirty="0">
+                <a:solidFill>
+                  <a:srgbClr val="1F2937"/>
+                </a:solidFill>
+                <a:latin typeface="Calibri" pitchFamily="34" charset="0"/>
+                <a:ea typeface="Calibri" pitchFamily="34" charset="-122"/>
+                <a:cs typeface="Calibri" pitchFamily="34" charset="-120"/>
+              </a:rPr>
+              <a:t>3,327 vs 4,258 goal (−21.9%); flat YoY on lighter freight (218 vs ≈275 lbs/unit); levers: load factor, Toyota footage capture, shift alignment.</a:t>
+            </a:r>
+            <a:endParaRPr lang="en-US" sz="1000" dirty="0"/>
+          </a:p>
+        </p:txBody>
+      </p:sp>
+      <p:sp>
+        <p:nvSpPr>
+          <p:cNvPr id="26" name="Shape 24"/>
+          <p:cNvSpPr/>
+          <p:nvPr/>
+        </p:nvSpPr>
+        <p:spPr>
+          <a:xfrm>
+            <a:off x="6208776" y="3419856"/>
+            <a:ext cx="5431536" cy="822960"/>
+          </a:xfrm>
+          <a:prstGeom prst="roundRect">
+            <a:avLst>
+              <a:gd name="adj" fmla="val 8889"/>
+            </a:avLst>
+          </a:prstGeom>
+          <a:solidFill>
+            <a:srgbClr val="F3F4F6"/>
+          </a:solidFill>
+          <a:ln w="12700">
+            <a:solidFill>
+              <a:srgbClr val="F3F4F6"/>
+            </a:solidFill>
+            <a:prstDash val="solid"/>
+          </a:ln>
+        </p:spPr>
+      </p:sp>
+      <p:sp>
+        <p:nvSpPr>
+          <p:cNvPr id="27" name="Text 25"/>
+          <p:cNvSpPr txBox="1"/>
+          <p:nvPr/>
+        </p:nvSpPr>
+        <p:spPr>
+          <a:xfrm>
+            <a:off x="6345936" y="3419856"/>
+            <a:ext cx="1234440" cy="822960"/>
+          </a:xfrm>
+          <a:prstGeom prst="rect">
+            <a:avLst/>
+          </a:prstGeom>
+          <a:noFill/>
+          <a:ln/>
+        </p:spPr>
+        <p:txBody>
+          <a:bodyPr wrap="square" lIns="0" tIns="0" rIns="0" bIns="0" rtlCol="0" anchor="ctr"/>
+          <a:lstStyle/>
+          <a:p>
+            <a:pPr indent="0" marL="0">
+              <a:buNone/>
+            </a:pPr>
+            <a:r>
+              <a:rPr lang="en-US" sz="1100" b="1" dirty="0">
+                <a:solidFill>
+                  <a:srgbClr val="7C3AED"/>
+                </a:solidFill>
+                <a:latin typeface="Calibri" pitchFamily="34" charset="0"/>
+                <a:ea typeface="Calibri" pitchFamily="34" charset="-122"/>
+                <a:cs typeface="Calibri" pitchFamily="34" charset="-120"/>
+              </a:rPr>
+              <a:t>Admin hours up?</a:t>
+            </a:r>
+            <a:endParaRPr lang="en-US" sz="1100" dirty="0"/>
+          </a:p>
+        </p:txBody>
+      </p:sp>
+      <p:sp>
+        <p:nvSpPr>
+          <p:cNvPr id="28" name="Text 26"/>
+          <p:cNvSpPr txBox="1"/>
+          <p:nvPr/>
+        </p:nvSpPr>
+        <p:spPr>
+          <a:xfrm>
+            <a:off x="7626096" y="3456432"/>
+            <a:ext cx="3877056" cy="749808"/>
+          </a:xfrm>
+          <a:prstGeom prst="rect">
+            <a:avLst/>
+          </a:prstGeom>
+          <a:noFill/>
+          <a:ln/>
+        </p:spPr>
+        <p:txBody>
+          <a:bodyPr wrap="square" lIns="0" tIns="0" rIns="0" bIns="0" rtlCol="0" anchor="ctr"/>
+          <a:lstStyle/>
+          <a:p>
+            <a:pPr indent="0" marL="0">
+              <a:buNone/>
+            </a:pPr>
+            <a:r>
+              <a:rPr lang="en-US" sz="1000" dirty="0">
+                <a:solidFill>
+                  <a:srgbClr val="1F2937"/>
+                </a:solidFill>
+                <a:latin typeface="Calibri" pitchFamily="34" charset="0"/>
+                <a:ea typeface="Calibri" pitchFamily="34" charset="-122"/>
+                <a:cs typeface="Calibri" pitchFamily="34" charset="-120"/>
+              </a:rPr>
+              <a:t>446 → 909 hrs Q1; admin cost $18.4K vs $9.2K F26, but below F24 $21.5K / F25 $22.7K.</a:t>
+            </a:r>
+            <a:endParaRPr lang="en-US" sz="1000" dirty="0"/>
+          </a:p>
+        </p:txBody>
+      </p:sp>
+      <p:sp>
+        <p:nvSpPr>
+          <p:cNvPr id="29" name="Shape 27"/>
+          <p:cNvSpPr/>
+          <p:nvPr/>
+        </p:nvSpPr>
+        <p:spPr>
+          <a:xfrm>
+            <a:off x="6208776" y="4315968"/>
+            <a:ext cx="5431536" cy="822960"/>
+          </a:xfrm>
+          <a:prstGeom prst="roundRect">
+            <a:avLst>
+              <a:gd name="adj" fmla="val 8889"/>
+            </a:avLst>
+          </a:prstGeom>
+          <a:solidFill>
+            <a:srgbClr val="F9FAFB"/>
+          </a:solidFill>
+          <a:ln w="12700">
+            <a:solidFill>
+              <a:srgbClr val="F9FAFB"/>
+            </a:solidFill>
+            <a:prstDash val="solid"/>
+          </a:ln>
+        </p:spPr>
+      </p:sp>
+      <p:sp>
+        <p:nvSpPr>
+          <p:cNvPr id="30" name="Text 28"/>
+          <p:cNvSpPr txBox="1"/>
+          <p:nvPr/>
+        </p:nvSpPr>
+        <p:spPr>
+          <a:xfrm>
+            <a:off x="6345936" y="4315968"/>
+            <a:ext cx="1234440" cy="822960"/>
+          </a:xfrm>
+          <a:prstGeom prst="rect">
+            <a:avLst/>
+          </a:prstGeom>
+          <a:noFill/>
+          <a:ln/>
+        </p:spPr>
+        <p:txBody>
+          <a:bodyPr wrap="square" lIns="0" tIns="0" rIns="0" bIns="0" rtlCol="0" anchor="ctr"/>
+          <a:lstStyle/>
+          <a:p>
+            <a:pPr indent="0" marL="0">
+              <a:buNone/>
+            </a:pPr>
+            <a:r>
+              <a:rPr lang="en-US" sz="1100" b="1" dirty="0">
+                <a:solidFill>
+                  <a:srgbClr val="7C3AED"/>
+                </a:solidFill>
+                <a:latin typeface="Calibri" pitchFamily="34" charset="0"/>
+                <a:ea typeface="Calibri" pitchFamily="34" charset="-122"/>
+                <a:cs typeface="Calibri" pitchFamily="34" charset="-120"/>
+              </a:rPr>
+              <a:t>Service?</a:t>
+            </a:r>
+            <a:endParaRPr lang="en-US" sz="1100" dirty="0"/>
+          </a:p>
+        </p:txBody>
+      </p:sp>
+      <p:sp>
+        <p:nvSpPr>
+          <p:cNvPr id="31" name="Text 29"/>
+          <p:cNvSpPr txBox="1"/>
+          <p:nvPr/>
+        </p:nvSpPr>
+        <p:spPr>
+          <a:xfrm>
+            <a:off x="7626096" y="4352544"/>
+            <a:ext cx="3877056" cy="749808"/>
+          </a:xfrm>
+          <a:prstGeom prst="rect">
+            <a:avLst/>
+          </a:prstGeom>
+          <a:noFill/>
+          <a:ln/>
+        </p:spPr>
+        <p:txBody>
+          <a:bodyPr wrap="square" lIns="0" tIns="0" rIns="0" bIns="0" rtlCol="0" anchor="ctr"/>
+          <a:lstStyle/>
+          <a:p>
+            <a:pPr indent="0" marL="0">
+              <a:buNone/>
+            </a:pPr>
+            <a:r>
+              <a:rPr lang="en-US" sz="1000" dirty="0">
+                <a:solidFill>
+                  <a:srgbClr val="1F2937"/>
+                </a:solidFill>
+                <a:latin typeface="Calibri" pitchFamily="34" charset="0"/>
+                <a:ea typeface="Calibri" pitchFamily="34" charset="-122"/>
+                <a:cs typeface="Calibri" pitchFamily="34" charset="-120"/>
+              </a:rPr>
+              <a:t>Adj OTS Sept 93.7% (96.7% excl. partner carriers), target 90% · missed PU 4.70% all dates, 3.75% last 7 days, 45% false positives.</a:t>
+            </a:r>
+            <a:endParaRPr lang="en-US" sz="1000" dirty="0"/>
+          </a:p>
+        </p:txBody>
+      </p:sp>
+      <p:sp>
+        <p:nvSpPr>
+          <p:cNvPr id="32" name="Shape 30"/>
+          <p:cNvSpPr/>
+          <p:nvPr/>
+        </p:nvSpPr>
+        <p:spPr>
+          <a:xfrm>
+            <a:off x="6208776" y="5212080"/>
+            <a:ext cx="5431536" cy="822960"/>
+          </a:xfrm>
+          <a:prstGeom prst="roundRect">
+            <a:avLst>
+              <a:gd name="adj" fmla="val 8889"/>
+            </a:avLst>
+          </a:prstGeom>
+          <a:solidFill>
+            <a:srgbClr val="F3F4F6"/>
+          </a:solidFill>
+          <a:ln w="12700">
+            <a:solidFill>
+              <a:srgbClr val="F3F4F6"/>
+            </a:solidFill>
+            <a:prstDash val="solid"/>
+          </a:ln>
+        </p:spPr>
+      </p:sp>
+      <p:sp>
+        <p:nvSpPr>
+          <p:cNvPr id="33" name="Text 31"/>
+          <p:cNvSpPr txBox="1"/>
+          <p:nvPr/>
+        </p:nvSpPr>
+        <p:spPr>
+          <a:xfrm>
+            <a:off x="6345936" y="5212080"/>
+            <a:ext cx="1234440" cy="822960"/>
+          </a:xfrm>
+          <a:prstGeom prst="rect">
+            <a:avLst/>
+          </a:prstGeom>
+          <a:noFill/>
+          <a:ln/>
+        </p:spPr>
+        <p:txBody>
+          <a:bodyPr wrap="square" lIns="0" tIns="0" rIns="0" bIns="0" rtlCol="0" anchor="ctr"/>
+          <a:lstStyle/>
+          <a:p>
+            <a:pPr indent="0" marL="0">
+              <a:buNone/>
+            </a:pPr>
+            <a:r>
+              <a:rPr lang="en-US" sz="1100" b="1" dirty="0">
+                <a:solidFill>
+                  <a:srgbClr val="7C3AED"/>
+                </a:solidFill>
+                <a:latin typeface="Calibri" pitchFamily="34" charset="0"/>
+                <a:ea typeface="Calibri" pitchFamily="34" charset="-122"/>
+                <a:cs typeface="Calibri" pitchFamily="34" charset="-120"/>
+              </a:rPr>
+              <a:t>Safety?</a:t>
+            </a:r>
+            <a:endParaRPr lang="en-US" sz="1100" dirty="0"/>
+          </a:p>
+        </p:txBody>
+      </p:sp>
+      <p:sp>
+        <p:nvSpPr>
+          <p:cNvPr id="34" name="Text 32"/>
+          <p:cNvSpPr txBox="1"/>
+          <p:nvPr/>
+        </p:nvSpPr>
+        <p:spPr>
+          <a:xfrm>
+            <a:off x="7626096" y="5248656"/>
+            <a:ext cx="3877056" cy="749808"/>
+          </a:xfrm>
+          <a:prstGeom prst="rect">
+            <a:avLst/>
+          </a:prstGeom>
+          <a:noFill/>
+          <a:ln/>
+        </p:spPr>
+        <p:txBody>
+          <a:bodyPr wrap="square" lIns="0" tIns="0" rIns="0" bIns="0" rtlCol="0" anchor="ctr"/>
+          <a:lstStyle/>
+          <a:p>
+            <a:pPr indent="0" marL="0">
+              <a:buNone/>
+            </a:pPr>
+            <a:r>
+              <a:rPr lang="en-US" sz="1000" dirty="0">
+                <a:solidFill>
+                  <a:srgbClr val="1F2937"/>
+                </a:solidFill>
+                <a:latin typeface="Calibri" pitchFamily="34" charset="0"/>
+                <a:ea typeface="Calibri" pitchFamily="34" charset="-122"/>
+                <a:cs typeface="Calibri" pitchFamily="34" charset="-120"/>
+              </a:rPr>
+              <a:t>0 recordables F27, TRIR 0.00 vs 1.21 F26 · 384 days since last recordable.</a:t>
+            </a:r>
+            <a:endParaRPr lang="en-US" sz="1000" dirty="0"/>
+          </a:p>
+        </p:txBody>
+      </p:sp>
+      <p:sp>
+        <p:nvSpPr>
+          <p:cNvPr id="35" name="Text 33"/>
+          <p:cNvSpPr txBox="1"/>
+          <p:nvPr/>
+        </p:nvSpPr>
+        <p:spPr>
+          <a:xfrm>
+            <a:off x="548640" y="6473952"/>
+            <a:ext cx="7315200" cy="228600"/>
+          </a:xfrm>
+          <a:prstGeom prst="rect">
+            <a:avLst/>
+          </a:prstGeom>
+          <a:noFill/>
+          <a:ln/>
+        </p:spPr>
+        <p:txBody>
+          <a:bodyPr wrap="square" lIns="0" tIns="0" rIns="0" bIns="0" rtlCol="0" anchor="ctr"/>
+          <a:lstStyle/>
+          <a:p>
+            <a:pPr indent="0" marL="0">
+              <a:buNone/>
+            </a:pPr>
+            <a:r>
+              <a:rPr lang="en-US" sz="900" dirty="0">
+                <a:solidFill>
+                  <a:srgbClr val="9CA3AF"/>
+                </a:solidFill>
+                <a:latin typeface="Calibri" pitchFamily="34" charset="0"/>
+                <a:ea typeface="Calibri" pitchFamily="34" charset="-122"/>
+                <a:cs typeface="Calibri" pitchFamily="34" charset="-120"/>
+              </a:rPr>
+              <a:t>Mississauga Terminal · F27 Senior Leadership Review · Sep 29, 2026</a:t>
+            </a:r>
+            <a:endParaRPr lang="en-US" sz="900" dirty="0"/>
+          </a:p>
+        </p:txBody>
+      </p:sp>
+      <p:sp>
+        <p:nvSpPr>
+          <p:cNvPr id="36" name="Text 34"/>
+          <p:cNvSpPr txBox="1"/>
+          <p:nvPr/>
+        </p:nvSpPr>
+        <p:spPr>
+          <a:xfrm>
+            <a:off x="10725912" y="6473952"/>
+            <a:ext cx="914400" cy="228600"/>
+          </a:xfrm>
+          <a:prstGeom prst="rect">
+            <a:avLst/>
+          </a:prstGeom>
+          <a:noFill/>
+          <a:ln/>
+        </p:spPr>
+        <p:txBody>
+          <a:bodyPr wrap="square" lIns="0" tIns="0" rIns="0" bIns="0" rtlCol="0" anchor="ctr"/>
+          <a:lstStyle/>
+          <a:p>
+            <a:pPr algn="r" indent="0" marL="0">
+              <a:buNone/>
+            </a:pPr>
+            <a:r>
+              <a:rPr lang="en-US" sz="900" dirty="0">
+                <a:solidFill>
+                  <a:srgbClr val="9CA3AF"/>
+                </a:solidFill>
+                <a:latin typeface="Calibri" pitchFamily="34" charset="0"/>
+                <a:ea typeface="Calibri" pitchFamily="34" charset="-122"/>
+                <a:cs typeface="Calibri" pitchFamily="34" charset="-120"/>
+              </a:rPr>
+              <a:t>23 / 23</a:t>
             </a:r>
             <a:endParaRPr lang="en-US" sz="900" dirty="0"/>
           </a:p>
@@ -35012,7 +36406,7 @@
                 <a:ea typeface="Calibri" pitchFamily="34" charset="-122"/>
                 <a:cs typeface="Calibri" pitchFamily="34" charset="-120"/>
               </a:rPr>
-              <a:t>3 / 22</a:t>
+              <a:t>3 / 23</a:t>
             </a:r>
             <a:endParaRPr lang="en-US" sz="900" dirty="0"/>
           </a:p>
@@ -35847,7 +37241,7 @@
                 <a:ea typeface="Calibri" pitchFamily="34" charset="-122"/>
                 <a:cs typeface="Calibri" pitchFamily="34" charset="-120"/>
               </a:rPr>
-              <a:t>4 / 22</a:t>
+              <a:t>4 / 23</a:t>
             </a:r>
             <a:endParaRPr lang="en-US" sz="900" dirty="0"/>
           </a:p>
@@ -37252,7 +38646,7 @@
                 <a:ea typeface="Calibri" pitchFamily="34" charset="-122"/>
                 <a:cs typeface="Calibri" pitchFamily="34" charset="-120"/>
               </a:rPr>
-              <a:t>5 / 22</a:t>
+              <a:t>5 / 23</a:t>
             </a:r>
             <a:endParaRPr lang="en-US" sz="900" dirty="0"/>
           </a:p>
@@ -40234,7 +41628,7 @@
                 <a:ea typeface="Calibri" pitchFamily="34" charset="-122"/>
                 <a:cs typeface="Calibri" pitchFamily="34" charset="-120"/>
               </a:rPr>
-              <a:t>6 / 22</a:t>
+              <a:t>6 / 23</a:t>
             </a:r>
             <a:endParaRPr lang="en-US" sz="900" dirty="0"/>
           </a:p>
@@ -41841,7 +43235,7 @@
                 <a:ea typeface="Calibri" pitchFamily="34" charset="-122"/>
                 <a:cs typeface="Calibri" pitchFamily="34" charset="-120"/>
               </a:rPr>
-              <a:t>7 / 22</a:t>
+              <a:t>7 / 23</a:t>
             </a:r>
             <a:endParaRPr lang="en-US" sz="900" dirty="0"/>
           </a:p>
@@ -43184,7 +44578,7 @@
                 <a:ea typeface="Calibri" pitchFamily="34" charset="-122"/>
                 <a:cs typeface="Calibri" pitchFamily="34" charset="-120"/>
               </a:rPr>
-              <a:t>8 / 22</a:t>
+              <a:t>8 / 23</a:t>
             </a:r>
             <a:endParaRPr lang="en-US" sz="900" dirty="0"/>
           </a:p>
@@ -44289,7 +45683,7 @@
                 <a:ea typeface="Calibri" pitchFamily="34" charset="-122"/>
                 <a:cs typeface="Calibri" pitchFamily="34" charset="-120"/>
               </a:rPr>
-              <a:t>9 / 22</a:t>
+              <a:t>9 / 23</a:t>
             </a:r>
             <a:endParaRPr lang="en-US" sz="900" dirty="0"/>
           </a:p>

</xml_diff>

<commit_message>
Deck: safety initiatives slide (completed/active/planned/ideas)
Co-Authored-By: Claude Opus 5.5 <noreply@anthropic.com>
Claude-Session: https://claude.ai/code/session_01BwRjju3y2wk3wSHFrM9KLe
</commit_message>
<xml_diff>
--- a/presentation/Mississauga_F27_Leadership_Review_Sep29.pptx
+++ b/presentation/Mississauga_F27_Leadership_Review_Sep29.pptx
@@ -6209,7 +6209,7 @@
           <a:p>
             <a:r>
               <a:rPr lang="en-US" dirty="0"/>
-              <a:t>Every incident is reported promptly and investigated with OHS for root cause, with corrective actions followed up so controls prevent a repeat; forklift and TDG training is completed before it expires. Specific to our site, roofing work over the dock is barricaded so no one works under overhead activity, and N95 masks are available on the dock for airborne debris. After every incident we hold a safety moment so the whole team learns from it.</a:t>
+              <a:t>Here is where our safety work stands. Completed: the roofing work zones are barricaded with N95 masks available, and the new shunt pre-trip checklist is used every shift. Our ongoing practices include incident reporting: incidents are reported promptly and supervisors work directly with OHS on WSIB forms and a safe return to work; we document detailed descriptions, identify root cause with OHS, and follow up corrective actions so controls prevent recurrence; and forklift and TDG training is completed before expiry. Planned is freight-handling equipment such as panel trucks and racks for windows, panels and car parts to improve handling and cut damages, and the ideas list is where we go next, including agency onboarding and a safety plan for the new building.</a:t>
             </a:r>
             <a:endParaRPr lang="en-US" dirty="0"/>
           </a:p>
@@ -28250,7 +28250,7 @@
                 <a:ea typeface="Calibri" pitchFamily="34" charset="-122"/>
                 <a:cs typeface="Calibri" pitchFamily="34" charset="-120"/>
               </a:rPr>
-              <a:t>TRIR, shift practices, incident reporting, site initiatives</a:t>
+              <a:t>TRIR, shift practices, safety initiatives</a:t>
             </a:r>
             <a:endParaRPr lang="en-US" sz="1300" dirty="0"/>
           </a:p>
@@ -34836,7 +34836,7 @@
                 <a:ea typeface="Calibri" pitchFamily="34" charset="-122"/>
                 <a:cs typeface="Calibri" pitchFamily="34" charset="-120"/>
               </a:rPr>
-              <a:t>0 recordables F27, TRIR 0.00 vs 1.21 F26 · 384 days since last recordable.</a:t>
+              <a:t>0 recordables F27, TRIR 0.00 vs 1.21 F26 · 384 days since last recordable · Initiatives: 3 completed · 7 active · 1 planned (freight-handling equipment).</a:t>
             </a:r>
             <a:endParaRPr lang="en-US" sz="1000" dirty="0"/>
           </a:p>
@@ -36508,7 +36508,7 @@
               <a:buNone/>
             </a:pPr>
             <a:r>
-              <a:rPr lang="en-US" sz="3000" b="1" dirty="0">
+              <a:rPr lang="en-US" sz="2500" b="1" dirty="0">
                 <a:solidFill>
                   <a:srgbClr val="111827"/>
                 </a:solidFill>
@@ -36516,9 +36516,9 @@
                 <a:ea typeface="Calibri" pitchFamily="34" charset="-122"/>
                 <a:cs typeface="Calibri" pitchFamily="34" charset="-120"/>
               </a:rPr>
-              <a:t>Incident reporting &amp; site-specific initiatives</a:t>
-            </a:r>
-            <a:endParaRPr lang="en-US" sz="3000" dirty="0"/>
+              <a:t>Safety initiatives — completed · active · planned · ideas</a:t>
+            </a:r>
+            <a:endParaRPr lang="en-US" sz="2500" dirty="0"/>
           </a:p>
         </p:txBody>
       </p:sp>
@@ -36531,11 +36531,11 @@
         <p:spPr>
           <a:xfrm>
             <a:off x="548640" y="1371600"/>
-            <a:ext cx="5486400" cy="4846320"/>
+            <a:ext cx="5431536" cy="2240280"/>
           </a:xfrm>
           <a:prstGeom prst="roundRect">
             <a:avLst>
-              <a:gd name="adj" fmla="val 1509"/>
+              <a:gd name="adj" fmla="val 3265"/>
             </a:avLst>
           </a:prstGeom>
           <a:solidFill>
@@ -36557,11 +36557,733 @@
         </p:nvSpPr>
         <p:spPr>
           <a:xfrm>
-            <a:off x="822960" y="1645920"/>
-            <a:ext cx="548640" cy="548640"/>
-          </a:xfrm>
-          <a:prstGeom prst="ellipse">
-            <a:avLst/>
+            <a:off x="731520" y="1536192"/>
+            <a:ext cx="1920240" cy="329184"/>
+          </a:xfrm>
+          <a:prstGeom prst="roundRect">
+            <a:avLst>
+              <a:gd name="adj" fmla="val 22222"/>
+            </a:avLst>
+          </a:prstGeom>
+          <a:solidFill>
+            <a:srgbClr val="D1FAE5"/>
+          </a:solidFill>
+          <a:ln w="12700">
+            <a:solidFill>
+              <a:srgbClr val="D1FAE5"/>
+            </a:solidFill>
+            <a:prstDash val="solid"/>
+          </a:ln>
+        </p:spPr>
+      </p:sp>
+      <p:sp>
+        <p:nvSpPr>
+          <p:cNvPr id="6" name="Text 4"/>
+          <p:cNvSpPr txBox="1"/>
+          <p:nvPr/>
+        </p:nvSpPr>
+        <p:spPr>
+          <a:xfrm>
+            <a:off x="731520" y="1536192"/>
+            <a:ext cx="1920240" cy="329184"/>
+          </a:xfrm>
+          <a:prstGeom prst="rect">
+            <a:avLst/>
+          </a:prstGeom>
+          <a:noFill/>
+          <a:ln/>
+        </p:spPr>
+        <p:txBody>
+          <a:bodyPr wrap="square" lIns="0" tIns="0" rIns="0" bIns="0" rtlCol="0" anchor="ctr"/>
+          <a:lstStyle/>
+          <a:p>
+            <a:pPr algn="ctr" indent="0" marL="0">
+              <a:buNone/>
+            </a:pPr>
+            <a:r>
+              <a:rPr lang="en-US" sz="1150" b="1" spc="100" kern="0" dirty="0">
+                <a:solidFill>
+                  <a:srgbClr val="059669"/>
+                </a:solidFill>
+                <a:latin typeface="Calibri" pitchFamily="34" charset="0"/>
+                <a:ea typeface="Calibri" pitchFamily="34" charset="-122"/>
+                <a:cs typeface="Calibri" pitchFamily="34" charset="-120"/>
+              </a:rPr>
+              <a:t>COMPLETED</a:t>
+            </a:r>
+            <a:endParaRPr lang="en-US" sz="1150" dirty="0"/>
+          </a:p>
+        </p:txBody>
+      </p:sp>
+      <p:sp>
+        <p:nvSpPr>
+          <p:cNvPr id="7" name="Text 5"/>
+          <p:cNvSpPr txBox="1"/>
+          <p:nvPr/>
+        </p:nvSpPr>
+        <p:spPr>
+          <a:xfrm>
+            <a:off x="2788920" y="1536192"/>
+            <a:ext cx="3008376" cy="329184"/>
+          </a:xfrm>
+          <a:prstGeom prst="rect">
+            <a:avLst/>
+          </a:prstGeom>
+          <a:noFill/>
+          <a:ln/>
+        </p:spPr>
+        <p:txBody>
+          <a:bodyPr wrap="square" lIns="0" tIns="0" rIns="0" bIns="0" rtlCol="0" anchor="ctr"/>
+          <a:lstStyle/>
+          <a:p>
+            <a:pPr indent="0" marL="0">
+              <a:buNone/>
+            </a:pPr>
+            <a:r>
+              <a:rPr lang="en-US" sz="1050" i="1" dirty="0">
+                <a:solidFill>
+                  <a:srgbClr val="6B7280"/>
+                </a:solidFill>
+                <a:latin typeface="Calibri" pitchFamily="34" charset="0"/>
+                <a:ea typeface="Calibri" pitchFamily="34" charset="-122"/>
+                <a:cs typeface="Calibri" pitchFamily="34" charset="-120"/>
+              </a:rPr>
+              <a:t>3 done</a:t>
+            </a:r>
+            <a:endParaRPr lang="en-US" sz="1050" dirty="0"/>
+          </a:p>
+        </p:txBody>
+      </p:sp>
+      <p:sp>
+        <p:nvSpPr>
+          <p:cNvPr id="8" name="Text 6"/>
+          <p:cNvSpPr txBox="1"/>
+          <p:nvPr/>
+        </p:nvSpPr>
+        <p:spPr>
+          <a:xfrm>
+            <a:off x="777240" y="1965960"/>
+            <a:ext cx="5020056" cy="1554480"/>
+          </a:xfrm>
+          <a:prstGeom prst="rect">
+            <a:avLst/>
+          </a:prstGeom>
+          <a:noFill/>
+          <a:ln/>
+        </p:spPr>
+        <p:txBody>
+          <a:bodyPr wrap="square" lIns="0" tIns="0" rIns="0" bIns="0" rtlCol="0" anchor="t"/>
+          <a:lstStyle/>
+          <a:p>
+            <a:pPr marL="203200" indent="-203200">
+              <a:spcAft>
+                <a:spcPts val="300"/>
+              </a:spcAft>
+              <a:buSzPct val="100000"/>
+              <a:buChar char="•"/>
+            </a:pPr>
+            <a:r>
+              <a:rPr lang="en-US" sz="1250" dirty="0">
+                <a:solidFill>
+                  <a:srgbClr val="1F2937"/>
+                </a:solidFill>
+                <a:latin typeface="Calibri" pitchFamily="34" charset="0"/>
+                <a:ea typeface="Calibri" pitchFamily="34" charset="-122"/>
+                <a:cs typeface="Calibri" pitchFamily="34" charset="-120"/>
+              </a:rPr>
+              <a:t>Roofing work zones barricaded — no access under overhead work.</a:t>
+            </a:r>
+            <a:endParaRPr lang="en-US" sz="1250" dirty="0"/>
+          </a:p>
+          <a:p>
+            <a:pPr marL="203200" indent="-203200">
+              <a:spcAft>
+                <a:spcPts val="300"/>
+              </a:spcAft>
+              <a:buSzPct val="100000"/>
+              <a:buChar char="•"/>
+            </a:pPr>
+            <a:r>
+              <a:rPr lang="en-US" sz="1250" dirty="0">
+                <a:solidFill>
+                  <a:srgbClr val="1F2937"/>
+                </a:solidFill>
+                <a:latin typeface="Calibri" pitchFamily="34" charset="0"/>
+                <a:ea typeface="Calibri" pitchFamily="34" charset="-122"/>
+                <a:cs typeface="Calibri" pitchFamily="34" charset="-120"/>
+              </a:rPr>
+              <a:t>N95 masks available on the dock during roofing work.</a:t>
+            </a:r>
+            <a:endParaRPr lang="en-US" sz="1250" dirty="0"/>
+          </a:p>
+          <a:p>
+            <a:pPr marL="203200" indent="-203200">
+              <a:spcAft>
+                <a:spcPts val="300"/>
+              </a:spcAft>
+              <a:buSzPct val="100000"/>
+              <a:buChar char="•"/>
+            </a:pPr>
+            <a:r>
+              <a:rPr lang="en-US" sz="1250" dirty="0">
+                <a:solidFill>
+                  <a:srgbClr val="1F2937"/>
+                </a:solidFill>
+                <a:latin typeface="Calibri" pitchFamily="34" charset="0"/>
+                <a:ea typeface="Calibri" pitchFamily="34" charset="-122"/>
+                <a:cs typeface="Calibri" pitchFamily="34" charset="-120"/>
+              </a:rPr>
+              <a:t>New shunt pre-trip checklist rolled out — used every shift.</a:t>
+            </a:r>
+            <a:endParaRPr lang="en-US" sz="1250" dirty="0"/>
+          </a:p>
+        </p:txBody>
+      </p:sp>
+      <p:sp>
+        <p:nvSpPr>
+          <p:cNvPr id="9" name="Shape 7"/>
+          <p:cNvSpPr/>
+          <p:nvPr/>
+        </p:nvSpPr>
+        <p:spPr>
+          <a:xfrm>
+            <a:off x="6208776" y="1371600"/>
+            <a:ext cx="5431536" cy="2240280"/>
+          </a:xfrm>
+          <a:prstGeom prst="roundRect">
+            <a:avLst>
+              <a:gd name="adj" fmla="val 3265"/>
+            </a:avLst>
+          </a:prstGeom>
+          <a:solidFill>
+            <a:srgbClr val="F3F4F6"/>
+          </a:solidFill>
+          <a:ln w="12700">
+            <a:solidFill>
+              <a:srgbClr val="F3F4F6"/>
+            </a:solidFill>
+            <a:prstDash val="solid"/>
+          </a:ln>
+        </p:spPr>
+      </p:sp>
+      <p:sp>
+        <p:nvSpPr>
+          <p:cNvPr id="10" name="Shape 8"/>
+          <p:cNvSpPr/>
+          <p:nvPr/>
+        </p:nvSpPr>
+        <p:spPr>
+          <a:xfrm>
+            <a:off x="6391656" y="1536192"/>
+            <a:ext cx="1920240" cy="329184"/>
+          </a:xfrm>
+          <a:prstGeom prst="roundRect">
+            <a:avLst>
+              <a:gd name="adj" fmla="val 22222"/>
+            </a:avLst>
+          </a:prstGeom>
+          <a:solidFill>
+            <a:srgbClr val="DBEAFE"/>
+          </a:solidFill>
+          <a:ln w="12700">
+            <a:solidFill>
+              <a:srgbClr val="DBEAFE"/>
+            </a:solidFill>
+            <a:prstDash val="solid"/>
+          </a:ln>
+        </p:spPr>
+      </p:sp>
+      <p:sp>
+        <p:nvSpPr>
+          <p:cNvPr id="11" name="Text 9"/>
+          <p:cNvSpPr txBox="1"/>
+          <p:nvPr/>
+        </p:nvSpPr>
+        <p:spPr>
+          <a:xfrm>
+            <a:off x="6391656" y="1536192"/>
+            <a:ext cx="1920240" cy="329184"/>
+          </a:xfrm>
+          <a:prstGeom prst="rect">
+            <a:avLst/>
+          </a:prstGeom>
+          <a:noFill/>
+          <a:ln/>
+        </p:spPr>
+        <p:txBody>
+          <a:bodyPr wrap="square" lIns="0" tIns="0" rIns="0" bIns="0" rtlCol="0" anchor="ctr"/>
+          <a:lstStyle/>
+          <a:p>
+            <a:pPr algn="ctr" indent="0" marL="0">
+              <a:buNone/>
+            </a:pPr>
+            <a:r>
+              <a:rPr lang="en-US" sz="1150" b="1" spc="100" kern="0" dirty="0">
+                <a:solidFill>
+                  <a:srgbClr val="2563EB"/>
+                </a:solidFill>
+                <a:latin typeface="Calibri" pitchFamily="34" charset="0"/>
+                <a:ea typeface="Calibri" pitchFamily="34" charset="-122"/>
+                <a:cs typeface="Calibri" pitchFamily="34" charset="-120"/>
+              </a:rPr>
+              <a:t>ACTIVE</a:t>
+            </a:r>
+            <a:endParaRPr lang="en-US" sz="1150" dirty="0"/>
+          </a:p>
+        </p:txBody>
+      </p:sp>
+      <p:sp>
+        <p:nvSpPr>
+          <p:cNvPr id="12" name="Text 10"/>
+          <p:cNvSpPr txBox="1"/>
+          <p:nvPr/>
+        </p:nvSpPr>
+        <p:spPr>
+          <a:xfrm>
+            <a:off x="8449056" y="1536192"/>
+            <a:ext cx="3008376" cy="329184"/>
+          </a:xfrm>
+          <a:prstGeom prst="rect">
+            <a:avLst/>
+          </a:prstGeom>
+          <a:noFill/>
+          <a:ln/>
+        </p:spPr>
+        <p:txBody>
+          <a:bodyPr wrap="square" lIns="0" tIns="0" rIns="0" bIns="0" rtlCol="0" anchor="ctr"/>
+          <a:lstStyle/>
+          <a:p>
+            <a:pPr indent="0" marL="0">
+              <a:buNone/>
+            </a:pPr>
+            <a:r>
+              <a:rPr lang="en-US" sz="1050" i="1" dirty="0">
+                <a:solidFill>
+                  <a:srgbClr val="6B7280"/>
+                </a:solidFill>
+                <a:latin typeface="Calibri" pitchFamily="34" charset="0"/>
+                <a:ea typeface="Calibri" pitchFamily="34" charset="-122"/>
+                <a:cs typeface="Calibri" pitchFamily="34" charset="-120"/>
+              </a:rPr>
+              <a:t>7 ongoing</a:t>
+            </a:r>
+            <a:endParaRPr lang="en-US" sz="1050" dirty="0"/>
+          </a:p>
+        </p:txBody>
+      </p:sp>
+      <p:sp>
+        <p:nvSpPr>
+          <p:cNvPr id="13" name="Text 11"/>
+          <p:cNvSpPr txBox="1"/>
+          <p:nvPr/>
+        </p:nvSpPr>
+        <p:spPr>
+          <a:xfrm>
+            <a:off x="6437376" y="1965960"/>
+            <a:ext cx="5020056" cy="1554480"/>
+          </a:xfrm>
+          <a:prstGeom prst="rect">
+            <a:avLst/>
+          </a:prstGeom>
+          <a:noFill/>
+          <a:ln/>
+        </p:spPr>
+        <p:txBody>
+          <a:bodyPr wrap="square" lIns="0" tIns="0" rIns="0" bIns="0" rtlCol="0" anchor="t"/>
+          <a:lstStyle/>
+          <a:p>
+            <a:pPr marL="203200" indent="-203200">
+              <a:spcAft>
+                <a:spcPts val="300"/>
+              </a:spcAft>
+              <a:buSzPct val="100000"/>
+              <a:buChar char="•"/>
+            </a:pPr>
+            <a:r>
+              <a:rPr lang="en-US" sz="1050" dirty="0">
+                <a:solidFill>
+                  <a:srgbClr val="1F2937"/>
+                </a:solidFill>
+                <a:latin typeface="Calibri" pitchFamily="34" charset="0"/>
+                <a:ea typeface="Calibri" pitchFamily="34" charset="-122"/>
+                <a:cs typeface="Calibri" pitchFamily="34" charset="-120"/>
+              </a:rPr>
+              <a:t>Tailgates + safety moments after incidents</a:t>
+            </a:r>
+            <a:endParaRPr lang="en-US" sz="1050" dirty="0"/>
+          </a:p>
+          <a:p>
+            <a:pPr marL="203200" indent="-203200">
+              <a:spcAft>
+                <a:spcPts val="300"/>
+              </a:spcAft>
+              <a:buSzPct val="100000"/>
+              <a:buChar char="•"/>
+            </a:pPr>
+            <a:r>
+              <a:rPr lang="en-US" sz="1050" dirty="0">
+                <a:solidFill>
+                  <a:srgbClr val="1F2937"/>
+                </a:solidFill>
+                <a:latin typeface="Calibri" pitchFamily="34" charset="0"/>
+                <a:ea typeface="Calibri" pitchFamily="34" charset="-122"/>
+                <a:cs typeface="Calibri" pitchFamily="34" charset="-120"/>
+              </a:rPr>
+              <a:t>Forklift pre/post inspections — every operator</a:t>
+            </a:r>
+            <a:endParaRPr lang="en-US" sz="1050" dirty="0"/>
+          </a:p>
+          <a:p>
+            <a:pPr marL="203200" indent="-203200">
+              <a:spcAft>
+                <a:spcPts val="300"/>
+              </a:spcAft>
+              <a:buSzPct val="100000"/>
+              <a:buChar char="•"/>
+            </a:pPr>
+            <a:r>
+              <a:rPr lang="en-US" sz="1050" dirty="0">
+                <a:solidFill>
+                  <a:srgbClr val="1F2937"/>
+                </a:solidFill>
+                <a:latin typeface="Calibri" pitchFamily="34" charset="0"/>
+                <a:ea typeface="Calibri" pitchFamily="34" charset="-122"/>
+                <a:cs typeface="Calibri" pitchFamily="34" charset="-120"/>
+              </a:rPr>
+              <a:t>No forklifts loaded on straight trucks</a:t>
+            </a:r>
+            <a:endParaRPr lang="en-US" sz="1050" dirty="0"/>
+          </a:p>
+          <a:p>
+            <a:pPr marL="203200" indent="-203200">
+              <a:spcAft>
+                <a:spcPts val="300"/>
+              </a:spcAft>
+              <a:buSzPct val="100000"/>
+              <a:buChar char="•"/>
+            </a:pPr>
+            <a:r>
+              <a:rPr lang="en-US" sz="1050" dirty="0">
+                <a:solidFill>
+                  <a:srgbClr val="1F2937"/>
+                </a:solidFill>
+                <a:latin typeface="Calibri" pitchFamily="34" charset="0"/>
+                <a:ea typeface="Calibri" pitchFamily="34" charset="-122"/>
+                <a:cs typeface="Calibri" pitchFamily="34" charset="-120"/>
+              </a:rPr>
+              <a:t>Monthly H&amp;S inspections → OHS / JHSC review</a:t>
+            </a:r>
+            <a:endParaRPr lang="en-US" sz="1050" dirty="0"/>
+          </a:p>
+          <a:p>
+            <a:pPr marL="203200" indent="-203200">
+              <a:spcAft>
+                <a:spcPts val="300"/>
+              </a:spcAft>
+              <a:buSzPct val="100000"/>
+              <a:buChar char="•"/>
+            </a:pPr>
+            <a:r>
+              <a:rPr lang="en-US" sz="1050" dirty="0">
+                <a:solidFill>
+                  <a:srgbClr val="1F2937"/>
+                </a:solidFill>
+                <a:latin typeface="Calibri" pitchFamily="34" charset="0"/>
+                <a:ea typeface="Calibri" pitchFamily="34" charset="-122"/>
+                <a:cs typeface="Calibri" pitchFamily="34" charset="-120"/>
+              </a:rPr>
+              <a:t>STEP observations — non-compliance addressed on the spot</a:t>
+            </a:r>
+            <a:endParaRPr lang="en-US" sz="1050" dirty="0"/>
+          </a:p>
+          <a:p>
+            <a:pPr marL="203200" indent="-203200">
+              <a:spcAft>
+                <a:spcPts val="300"/>
+              </a:spcAft>
+              <a:buSzPct val="100000"/>
+              <a:buChar char="•"/>
+            </a:pPr>
+            <a:r>
+              <a:rPr lang="en-US" sz="1050" dirty="0">
+                <a:solidFill>
+                  <a:srgbClr val="1F2937"/>
+                </a:solidFill>
+                <a:latin typeface="Calibri" pitchFamily="34" charset="0"/>
+                <a:ea typeface="Calibri" pitchFamily="34" charset="-122"/>
+                <a:cs typeface="Calibri" pitchFamily="34" charset="-120"/>
+              </a:rPr>
+              <a:t>Incident root cause + corrective-action follow-up with OHS</a:t>
+            </a:r>
+            <a:endParaRPr lang="en-US" sz="1050" dirty="0"/>
+          </a:p>
+          <a:p>
+            <a:pPr marL="203200" indent="-203200">
+              <a:spcAft>
+                <a:spcPts val="300"/>
+              </a:spcAft>
+              <a:buSzPct val="100000"/>
+              <a:buChar char="•"/>
+            </a:pPr>
+            <a:r>
+              <a:rPr lang="en-US" sz="1050" dirty="0">
+                <a:solidFill>
+                  <a:srgbClr val="1F2937"/>
+                </a:solidFill>
+                <a:latin typeface="Calibri" pitchFamily="34" charset="0"/>
+                <a:ea typeface="Calibri" pitchFamily="34" charset="-122"/>
+                <a:cs typeface="Calibri" pitchFamily="34" charset="-120"/>
+              </a:rPr>
+              <a:t>Monthly e-learning; forklift / TDG renewed before expiry</a:t>
+            </a:r>
+            <a:endParaRPr lang="en-US" sz="1050" dirty="0"/>
+          </a:p>
+        </p:txBody>
+      </p:sp>
+      <p:sp>
+        <p:nvSpPr>
+          <p:cNvPr id="14" name="Shape 12"/>
+          <p:cNvSpPr/>
+          <p:nvPr/>
+        </p:nvSpPr>
+        <p:spPr>
+          <a:xfrm>
+            <a:off x="548640" y="3749040"/>
+            <a:ext cx="5431536" cy="2240280"/>
+          </a:xfrm>
+          <a:prstGeom prst="roundRect">
+            <a:avLst>
+              <a:gd name="adj" fmla="val 3265"/>
+            </a:avLst>
+          </a:prstGeom>
+          <a:solidFill>
+            <a:srgbClr val="F3F4F6"/>
+          </a:solidFill>
+          <a:ln w="12700">
+            <a:solidFill>
+              <a:srgbClr val="F3F4F6"/>
+            </a:solidFill>
+            <a:prstDash val="solid"/>
+          </a:ln>
+        </p:spPr>
+      </p:sp>
+      <p:sp>
+        <p:nvSpPr>
+          <p:cNvPr id="15" name="Shape 13"/>
+          <p:cNvSpPr/>
+          <p:nvPr/>
+        </p:nvSpPr>
+        <p:spPr>
+          <a:xfrm>
+            <a:off x="731520" y="3913632"/>
+            <a:ext cx="1920240" cy="329184"/>
+          </a:xfrm>
+          <a:prstGeom prst="roundRect">
+            <a:avLst>
+              <a:gd name="adj" fmla="val 22222"/>
+            </a:avLst>
+          </a:prstGeom>
+          <a:solidFill>
+            <a:srgbClr val="FEF3C7"/>
+          </a:solidFill>
+          <a:ln w="12700">
+            <a:solidFill>
+              <a:srgbClr val="FEF3C7"/>
+            </a:solidFill>
+            <a:prstDash val="solid"/>
+          </a:ln>
+        </p:spPr>
+      </p:sp>
+      <p:sp>
+        <p:nvSpPr>
+          <p:cNvPr id="16" name="Text 14"/>
+          <p:cNvSpPr txBox="1"/>
+          <p:nvPr/>
+        </p:nvSpPr>
+        <p:spPr>
+          <a:xfrm>
+            <a:off x="731520" y="3913632"/>
+            <a:ext cx="1920240" cy="329184"/>
+          </a:xfrm>
+          <a:prstGeom prst="rect">
+            <a:avLst/>
+          </a:prstGeom>
+          <a:noFill/>
+          <a:ln/>
+        </p:spPr>
+        <p:txBody>
+          <a:bodyPr wrap="square" lIns="0" tIns="0" rIns="0" bIns="0" rtlCol="0" anchor="ctr"/>
+          <a:lstStyle/>
+          <a:p>
+            <a:pPr algn="ctr" indent="0" marL="0">
+              <a:buNone/>
+            </a:pPr>
+            <a:r>
+              <a:rPr lang="en-US" sz="1150" b="1" spc="100" kern="0" dirty="0">
+                <a:solidFill>
+                  <a:srgbClr val="B45309"/>
+                </a:solidFill>
+                <a:latin typeface="Calibri" pitchFamily="34" charset="0"/>
+                <a:ea typeface="Calibri" pitchFamily="34" charset="-122"/>
+                <a:cs typeface="Calibri" pitchFamily="34" charset="-120"/>
+              </a:rPr>
+              <a:t>PLANNED</a:t>
+            </a:r>
+            <a:endParaRPr lang="en-US" sz="1150" dirty="0"/>
+          </a:p>
+        </p:txBody>
+      </p:sp>
+      <p:sp>
+        <p:nvSpPr>
+          <p:cNvPr id="17" name="Text 15"/>
+          <p:cNvSpPr txBox="1"/>
+          <p:nvPr/>
+        </p:nvSpPr>
+        <p:spPr>
+          <a:xfrm>
+            <a:off x="2788920" y="3913632"/>
+            <a:ext cx="3008376" cy="329184"/>
+          </a:xfrm>
+          <a:prstGeom prst="rect">
+            <a:avLst/>
+          </a:prstGeom>
+          <a:noFill/>
+          <a:ln/>
+        </p:spPr>
+        <p:txBody>
+          <a:bodyPr wrap="square" lIns="0" tIns="0" rIns="0" bIns="0" rtlCol="0" anchor="ctr"/>
+          <a:lstStyle/>
+          <a:p>
+            <a:pPr indent="0" marL="0">
+              <a:buNone/>
+            </a:pPr>
+            <a:r>
+              <a:rPr lang="en-US" sz="1050" i="1" dirty="0">
+                <a:solidFill>
+                  <a:srgbClr val="6B7280"/>
+                </a:solidFill>
+                <a:latin typeface="Calibri" pitchFamily="34" charset="0"/>
+                <a:ea typeface="Calibri" pitchFamily="34" charset="-122"/>
+                <a:cs typeface="Calibri" pitchFamily="34" charset="-120"/>
+              </a:rPr>
+              <a:t>1 planned</a:t>
+            </a:r>
+            <a:endParaRPr lang="en-US" sz="1050" dirty="0"/>
+          </a:p>
+        </p:txBody>
+      </p:sp>
+      <p:sp>
+        <p:nvSpPr>
+          <p:cNvPr id="18" name="Text 16"/>
+          <p:cNvSpPr txBox="1"/>
+          <p:nvPr/>
+        </p:nvSpPr>
+        <p:spPr>
+          <a:xfrm>
+            <a:off x="777240" y="4343400"/>
+            <a:ext cx="5020056" cy="1554480"/>
+          </a:xfrm>
+          <a:prstGeom prst="rect">
+            <a:avLst/>
+          </a:prstGeom>
+          <a:noFill/>
+          <a:ln/>
+        </p:spPr>
+        <p:txBody>
+          <a:bodyPr wrap="square" lIns="0" tIns="0" rIns="0" bIns="0" rtlCol="0" anchor="t"/>
+          <a:lstStyle/>
+          <a:p>
+            <a:pPr indent="0" marL="0">
+              <a:buNone/>
+            </a:pPr>
+            <a:r>
+              <a:rPr lang="en-US" sz="1200" b="1" dirty="0">
+                <a:solidFill>
+                  <a:srgbClr val="111827"/>
+                </a:solidFill>
+                <a:latin typeface="Calibri" pitchFamily="34" charset="0"/>
+                <a:ea typeface="Calibri" pitchFamily="34" charset="-122"/>
+                <a:cs typeface="Calibri" pitchFamily="34" charset="-120"/>
+              </a:rPr>
+              <a:t>Freight-handling equipment: </a:t>
+            </a:r>
+            <a:pPr indent="0" marL="0">
+              <a:buNone/>
+            </a:pPr>
+            <a:r>
+              <a:rPr lang="en-US" sz="1200" dirty="0">
+                <a:solidFill>
+                  <a:srgbClr val="1F2937"/>
+                </a:solidFill>
+                <a:latin typeface="Calibri" pitchFamily="34" charset="0"/>
+                <a:ea typeface="Calibri" pitchFamily="34" charset="-122"/>
+                <a:cs typeface="Calibri" pitchFamily="34" charset="-120"/>
+              </a:rPr>
+              <a:t>panel trucks &amp; reconfigurable racks for windows, panels and car parts (Sawtrax, Rack and Shelf, Grainger vertical panel truck 1,800 lb, Uline carpeted panel truck).</a:t>
+            </a:r>
+            <a:endParaRPr lang="en-US" sz="1200" dirty="0"/>
+          </a:p>
+          <a:p>
+            <a:pPr indent="0" marL="0">
+              <a:buNone/>
+            </a:pPr>
+            <a:r>
+              <a:rPr lang="en-US" sz="1200" b="1" dirty="0">
+                <a:solidFill>
+                  <a:srgbClr val="059669"/>
+                </a:solidFill>
+                <a:latin typeface="Calibri" pitchFamily="34" charset="0"/>
+                <a:ea typeface="Calibri" pitchFamily="34" charset="-122"/>
+                <a:cs typeface="Calibri" pitchFamily="34" charset="-120"/>
+              </a:rPr>
+              <a:t>→ Safer handling, better load quality, fewer damages (damaged FB 1.61%, 7-day avg).</a:t>
+            </a:r>
+            <a:endParaRPr lang="en-US" sz="1200" dirty="0"/>
+          </a:p>
+        </p:txBody>
+      </p:sp>
+      <p:sp>
+        <p:nvSpPr>
+          <p:cNvPr id="19" name="Shape 17"/>
+          <p:cNvSpPr/>
+          <p:nvPr/>
+        </p:nvSpPr>
+        <p:spPr>
+          <a:xfrm>
+            <a:off x="6208776" y="3749040"/>
+            <a:ext cx="5431536" cy="2240280"/>
+          </a:xfrm>
+          <a:prstGeom prst="roundRect">
+            <a:avLst>
+              <a:gd name="adj" fmla="val 3265"/>
+            </a:avLst>
+          </a:prstGeom>
+          <a:solidFill>
+            <a:srgbClr val="F5F3FF"/>
+          </a:solidFill>
+          <a:ln w="12700">
+            <a:solidFill>
+              <a:srgbClr val="F5F3FF"/>
+            </a:solidFill>
+            <a:prstDash val="solid"/>
+          </a:ln>
+        </p:spPr>
+      </p:sp>
+      <p:sp>
+        <p:nvSpPr>
+          <p:cNvPr id="20" name="Shape 18"/>
+          <p:cNvSpPr/>
+          <p:nvPr/>
+        </p:nvSpPr>
+        <p:spPr>
+          <a:xfrm>
+            <a:off x="6391656" y="3913632"/>
+            <a:ext cx="1920240" cy="329184"/>
+          </a:xfrm>
+          <a:prstGeom prst="roundRect">
+            <a:avLst>
+              <a:gd name="adj" fmla="val 22222"/>
+            </a:avLst>
           </a:prstGeom>
           <a:solidFill>
             <a:srgbClr val="EDE9FE"/>
@@ -36574,40 +37296,16 @@
           </a:ln>
         </p:spPr>
       </p:sp>
-      <p:pic>
-        <p:nvPicPr>
-          <p:cNvPr id="6" name="Image 0" descr="preencoded.png">    </p:cNvPr>
-          <p:cNvPicPr>
-            <a:picLocks noChangeAspect="1"/>
-          </p:cNvPicPr>
-          <p:nvPr/>
-        </p:nvPicPr>
-        <p:blipFill>
-          <a:blip r:embed="rId1"/>
-          <a:stretch>
-            <a:fillRect/>
-          </a:stretch>
-        </p:blipFill>
-        <p:spPr>
-          <a:xfrm>
-            <a:off x="960120" y="1783080"/>
-            <a:ext cx="274320" cy="274320"/>
-          </a:xfrm>
-          <a:prstGeom prst="rect">
-            <a:avLst/>
-          </a:prstGeom>
-        </p:spPr>
-      </p:pic>
-      <p:sp>
-        <p:nvSpPr>
-          <p:cNvPr id="7" name="Text 4"/>
-          <p:cNvSpPr txBox="1"/>
-          <p:nvPr/>
-        </p:nvSpPr>
-        <p:spPr>
-          <a:xfrm>
-            <a:off x="1554480" y="1719072"/>
-            <a:ext cx="4297680" cy="411480"/>
+      <p:sp>
+        <p:nvSpPr>
+          <p:cNvPr id="21" name="Text 19"/>
+          <p:cNvSpPr txBox="1"/>
+          <p:nvPr/>
+        </p:nvSpPr>
+        <p:spPr>
+          <a:xfrm>
+            <a:off x="6391656" y="3913632"/>
+            <a:ext cx="1920240" cy="329184"/>
           </a:xfrm>
           <a:prstGeom prst="rect">
             <a:avLst/>
@@ -36619,34 +37317,34 @@
           <a:bodyPr wrap="square" lIns="0" tIns="0" rIns="0" bIns="0" rtlCol="0" anchor="ctr"/>
           <a:lstStyle/>
           <a:p>
-            <a:pPr indent="0" marL="0">
-              <a:buNone/>
-            </a:pPr>
-            <a:r>
-              <a:rPr lang="en-US" sz="2000" b="1" dirty="0">
-                <a:solidFill>
-                  <a:srgbClr val="111827"/>
-                </a:solidFill>
-                <a:latin typeface="Calibri" pitchFamily="34" charset="0"/>
-                <a:ea typeface="Calibri" pitchFamily="34" charset="-122"/>
-                <a:cs typeface="Calibri" pitchFamily="34" charset="-120"/>
-              </a:rPr>
-              <a:t>Incident reporting &amp; training</a:t>
-            </a:r>
-            <a:endParaRPr lang="en-US" sz="2000" dirty="0"/>
-          </a:p>
-        </p:txBody>
-      </p:sp>
-      <p:sp>
-        <p:nvSpPr>
-          <p:cNvPr id="8" name="Text 5"/>
-          <p:cNvSpPr txBox="1"/>
-          <p:nvPr/>
-        </p:nvSpPr>
-        <p:spPr>
-          <a:xfrm>
-            <a:off x="868680" y="2423160"/>
-            <a:ext cx="4892040" cy="3611880"/>
+            <a:pPr algn="ctr" indent="0" marL="0">
+              <a:buNone/>
+            </a:pPr>
+            <a:r>
+              <a:rPr lang="en-US" sz="1150" b="1" spc="100" kern="0" dirty="0">
+                <a:solidFill>
+                  <a:srgbClr val="7C3AED"/>
+                </a:solidFill>
+                <a:latin typeface="Calibri" pitchFamily="34" charset="0"/>
+                <a:ea typeface="Calibri" pitchFamily="34" charset="-122"/>
+                <a:cs typeface="Calibri" pitchFamily="34" charset="-120"/>
+              </a:rPr>
+              <a:t>IDEAS TO ACTION</a:t>
+            </a:r>
+            <a:endParaRPr lang="en-US" sz="1150" dirty="0"/>
+          </a:p>
+        </p:txBody>
+      </p:sp>
+      <p:sp>
+        <p:nvSpPr>
+          <p:cNvPr id="22" name="Text 20"/>
+          <p:cNvSpPr txBox="1"/>
+          <p:nvPr/>
+        </p:nvSpPr>
+        <p:spPr>
+          <a:xfrm>
+            <a:off x="6437376" y="4343400"/>
+            <a:ext cx="5020056" cy="1554480"/>
           </a:xfrm>
           <a:prstGeom prst="rect">
             <a:avLst/>
@@ -36660,13 +37358,13 @@
           <a:p>
             <a:pPr marL="203200" indent="-203200">
               <a:spcAft>
-                <a:spcPts val="1200"/>
+                <a:spcPts val="300"/>
               </a:spcAft>
               <a:buSzPct val="100000"/>
               <a:buChar char="•"/>
             </a:pPr>
             <a:r>
-              <a:rPr lang="en-US" sz="1400" dirty="0">
+              <a:rPr lang="en-US" sz="1100" dirty="0">
                 <a:solidFill>
                   <a:srgbClr val="1F2937"/>
                 </a:solidFill>
@@ -36674,20 +37372,20 @@
                 <a:ea typeface="Calibri" pitchFamily="34" charset="-122"/>
                 <a:cs typeface="Calibri" pitchFamily="34" charset="-120"/>
               </a:rPr>
-              <a:t>Incidents reported promptly — supervisors and managers work directly with OHS on WSIB forms and a safe return to work.</a:t>
-            </a:r>
-            <a:endParaRPr lang="en-US" sz="1400" dirty="0"/>
+              <a:t>Agency safety onboarding (agency ~61% of dock hours)</a:t>
+            </a:r>
+            <a:endParaRPr lang="en-US" sz="1100" dirty="0"/>
           </a:p>
           <a:p>
             <a:pPr marL="203200" indent="-203200">
               <a:spcAft>
-                <a:spcPts val="1200"/>
+                <a:spcPts val="300"/>
               </a:spcAft>
               <a:buSzPct val="100000"/>
               <a:buChar char="•"/>
             </a:pPr>
             <a:r>
-              <a:rPr lang="en-US" sz="1400" dirty="0">
+              <a:rPr lang="en-US" sz="1100" dirty="0">
                 <a:solidFill>
                   <a:srgbClr val="1F2937"/>
                 </a:solidFill>
@@ -36695,20 +37393,20 @@
                 <a:ea typeface="Calibri" pitchFamily="34" charset="-122"/>
                 <a:cs typeface="Calibri" pitchFamily="34" charset="-120"/>
               </a:rPr>
-              <a:t>Detailed incident descriptions; root cause identified with OHS; corrective action plans implemented and follow-up prioritized so controls prevent recurrence.</a:t>
-            </a:r>
-            <a:endParaRPr lang="en-US" sz="1400" dirty="0"/>
+              <a:t>New-building safety plan before the move</a:t>
+            </a:r>
+            <a:endParaRPr lang="en-US" sz="1100" dirty="0"/>
           </a:p>
           <a:p>
             <a:pPr marL="203200" indent="-203200">
               <a:spcAft>
-                <a:spcPts val="1200"/>
+                <a:spcPts val="300"/>
               </a:spcAft>
               <a:buSzPct val="100000"/>
               <a:buChar char="•"/>
             </a:pPr>
             <a:r>
-              <a:rPr lang="en-US" sz="1400" dirty="0">
+              <a:rPr lang="en-US" sz="1100" dirty="0">
                 <a:solidFill>
                   <a:srgbClr val="1F2937"/>
                 </a:solidFill>
@@ -36716,20 +37414,20 @@
                 <a:ea typeface="Calibri" pitchFamily="34" charset="-122"/>
                 <a:cs typeface="Calibri" pitchFamily="34" charset="-120"/>
               </a:rPr>
-              <a:t>Monthly safety e-learning for managers and supervisors on topics tied to our operation.</a:t>
-            </a:r>
-            <a:endParaRPr lang="en-US" sz="1400" dirty="0"/>
+              <a:t>Near-miss reporting</a:t>
+            </a:r>
+            <a:endParaRPr lang="en-US" sz="1100" dirty="0"/>
           </a:p>
           <a:p>
             <a:pPr marL="203200" indent="-203200">
               <a:spcAft>
-                <a:spcPts val="1200"/>
+                <a:spcPts val="300"/>
               </a:spcAft>
               <a:buSzPct val="100000"/>
               <a:buChar char="•"/>
             </a:pPr>
             <a:r>
-              <a:rPr lang="en-US" sz="1400" dirty="0">
+              <a:rPr lang="en-US" sz="1100" dirty="0">
                 <a:solidFill>
                   <a:srgbClr val="1F2937"/>
                 </a:solidFill>
@@ -36737,217 +37435,20 @@
                 <a:ea typeface="Calibri" pitchFamily="34" charset="-122"/>
                 <a:cs typeface="Calibri" pitchFamily="34" charset="-120"/>
               </a:rPr>
-              <a:t>Forklift and TDG training completed before expiry.</a:t>
-            </a:r>
-            <a:endParaRPr lang="en-US" sz="1400" dirty="0"/>
-          </a:p>
-        </p:txBody>
-      </p:sp>
-      <p:sp>
-        <p:nvSpPr>
-          <p:cNvPr id="9" name="Shape 6"/>
-          <p:cNvSpPr/>
-          <p:nvPr/>
-        </p:nvSpPr>
-        <p:spPr>
-          <a:xfrm>
-            <a:off x="6336792" y="1371600"/>
-            <a:ext cx="5303520" cy="4846320"/>
-          </a:xfrm>
-          <a:prstGeom prst="roundRect">
-            <a:avLst>
-              <a:gd name="adj" fmla="val 1509"/>
-            </a:avLst>
-          </a:prstGeom>
-          <a:solidFill>
-            <a:srgbClr val="F5F3FF"/>
-          </a:solidFill>
-          <a:ln w="12700">
-            <a:solidFill>
-              <a:srgbClr val="F5F3FF"/>
-            </a:solidFill>
-            <a:prstDash val="solid"/>
-          </a:ln>
-        </p:spPr>
-      </p:sp>
-      <p:sp>
-        <p:nvSpPr>
-          <p:cNvPr id="10" name="Shape 7"/>
-          <p:cNvSpPr/>
-          <p:nvPr/>
-        </p:nvSpPr>
-        <p:spPr>
-          <a:xfrm>
-            <a:off x="6611112" y="1645920"/>
-            <a:ext cx="548640" cy="548640"/>
-          </a:xfrm>
-          <a:prstGeom prst="ellipse">
-            <a:avLst/>
-          </a:prstGeom>
-          <a:solidFill>
-            <a:srgbClr val="7C3AED"/>
-          </a:solidFill>
-          <a:ln w="12700">
-            <a:solidFill>
-              <a:srgbClr val="7C3AED"/>
-            </a:solidFill>
-            <a:prstDash val="solid"/>
-          </a:ln>
-        </p:spPr>
-      </p:sp>
-      <p:pic>
-        <p:nvPicPr>
-          <p:cNvPr id="11" name="Image 1" descr="preencoded.png">    </p:cNvPr>
-          <p:cNvPicPr>
-            <a:picLocks noChangeAspect="1"/>
-          </p:cNvPicPr>
-          <p:nvPr/>
-        </p:nvPicPr>
-        <p:blipFill>
-          <a:blip r:embed="rId2"/>
-          <a:stretch>
-            <a:fillRect/>
-          </a:stretch>
-        </p:blipFill>
-        <p:spPr>
-          <a:xfrm>
-            <a:off x="6748272" y="1783080"/>
-            <a:ext cx="274320" cy="274320"/>
-          </a:xfrm>
-          <a:prstGeom prst="rect">
-            <a:avLst/>
-          </a:prstGeom>
-        </p:spPr>
-      </p:pic>
-      <p:sp>
-        <p:nvSpPr>
-          <p:cNvPr id="12" name="Text 8"/>
-          <p:cNvSpPr txBox="1"/>
-          <p:nvPr/>
-        </p:nvSpPr>
-        <p:spPr>
-          <a:xfrm>
-            <a:off x="7342632" y="1719072"/>
-            <a:ext cx="4023360" cy="411480"/>
-          </a:xfrm>
-          <a:prstGeom prst="rect">
-            <a:avLst/>
-          </a:prstGeom>
-          <a:noFill/>
-          <a:ln/>
-        </p:spPr>
-        <p:txBody>
-          <a:bodyPr wrap="square" lIns="0" tIns="0" rIns="0" bIns="0" rtlCol="0" anchor="ctr"/>
-          <a:lstStyle/>
-          <a:p>
-            <a:pPr indent="0" marL="0">
-              <a:buNone/>
-            </a:pPr>
-            <a:r>
-              <a:rPr lang="en-US" sz="2000" b="1" dirty="0">
-                <a:solidFill>
-                  <a:srgbClr val="111827"/>
-                </a:solidFill>
-                <a:latin typeface="Calibri" pitchFamily="34" charset="0"/>
-                <a:ea typeface="Calibri" pitchFamily="34" charset="-122"/>
-                <a:cs typeface="Calibri" pitchFamily="34" charset="-120"/>
-              </a:rPr>
-              <a:t>Site-specific initiatives</a:t>
-            </a:r>
-            <a:endParaRPr lang="en-US" sz="2000" dirty="0"/>
-          </a:p>
-        </p:txBody>
-      </p:sp>
-      <p:sp>
-        <p:nvSpPr>
-          <p:cNvPr id="13" name="Shape 9"/>
-          <p:cNvSpPr/>
-          <p:nvPr/>
-        </p:nvSpPr>
-        <p:spPr>
-          <a:xfrm>
-            <a:off x="6611112" y="2450592"/>
-            <a:ext cx="384048" cy="384048"/>
-          </a:xfrm>
-          <a:prstGeom prst="ellipse">
-            <a:avLst/>
-          </a:prstGeom>
-          <a:solidFill>
-            <a:srgbClr val="7C3AED"/>
-          </a:solidFill>
-          <a:ln w="12700">
-            <a:solidFill>
-              <a:srgbClr val="7C3AED"/>
-            </a:solidFill>
-            <a:prstDash val="solid"/>
-          </a:ln>
-        </p:spPr>
-      </p:sp>
-      <p:sp>
-        <p:nvSpPr>
-          <p:cNvPr id="14" name="Text 10"/>
-          <p:cNvSpPr txBox="1"/>
-          <p:nvPr/>
-        </p:nvSpPr>
-        <p:spPr>
-          <a:xfrm>
-            <a:off x="6611112" y="2450592"/>
-            <a:ext cx="384048" cy="384048"/>
-          </a:xfrm>
-          <a:prstGeom prst="rect">
-            <a:avLst/>
-          </a:prstGeom>
-          <a:noFill/>
-          <a:ln/>
-        </p:spPr>
-        <p:txBody>
-          <a:bodyPr wrap="square" lIns="0" tIns="0" rIns="0" bIns="0" rtlCol="0" anchor="ctr"/>
-          <a:lstStyle/>
-          <a:p>
-            <a:pPr algn="ctr" indent="0" marL="0">
-              <a:buNone/>
-            </a:pPr>
-            <a:r>
-              <a:rPr lang="en-US" sz="1300" b="1" dirty="0">
-                <a:solidFill>
-                  <a:srgbClr val="FFFFFF"/>
-                </a:solidFill>
-                <a:latin typeface="Calibri" pitchFamily="34" charset="0"/>
-                <a:ea typeface="Calibri" pitchFamily="34" charset="-122"/>
-                <a:cs typeface="Calibri" pitchFamily="34" charset="-120"/>
-              </a:rPr>
-              <a:t>1</a:t>
-            </a:r>
-            <a:endParaRPr lang="en-US" sz="1300" dirty="0"/>
-          </a:p>
-        </p:txBody>
-      </p:sp>
-      <p:sp>
-        <p:nvSpPr>
-          <p:cNvPr id="15" name="Text 11"/>
-          <p:cNvSpPr txBox="1"/>
-          <p:nvPr/>
-        </p:nvSpPr>
-        <p:spPr>
-          <a:xfrm>
-            <a:off x="7178040" y="2423160"/>
-            <a:ext cx="4206240" cy="1691640"/>
-          </a:xfrm>
-          <a:prstGeom prst="rect">
-            <a:avLst/>
-          </a:prstGeom>
-          <a:noFill/>
-          <a:ln/>
-        </p:spPr>
-        <p:txBody>
-          <a:bodyPr wrap="square" lIns="0" tIns="0" rIns="0" bIns="0" rtlCol="0" anchor="t"/>
-          <a:lstStyle/>
-          <a:p>
-            <a:pPr indent="0" marL="0">
-              <a:buNone/>
-            </a:pPr>
-            <a:r>
-              <a:rPr lang="en-US" sz="1400" dirty="0">
+              <a:t>Pedestrian–forklift separation</a:t>
+            </a:r>
+            <a:endParaRPr lang="en-US" sz="1100" dirty="0"/>
+          </a:p>
+          <a:p>
+            <a:pPr marL="203200" indent="-203200">
+              <a:spcAft>
+                <a:spcPts val="300"/>
+              </a:spcAft>
+              <a:buSzPct val="100000"/>
+              <a:buChar char="•"/>
+            </a:pPr>
+            <a:r>
+              <a:rPr lang="en-US" sz="1100" dirty="0">
                 <a:solidFill>
                   <a:srgbClr val="1F2937"/>
                 </a:solidFill>
@@ -36955,102 +37456,20 @@
                 <a:ea typeface="Calibri" pitchFamily="34" charset="-122"/>
                 <a:cs typeface="Calibri" pitchFamily="34" charset="-120"/>
               </a:rPr>
-              <a:t>Roofing work over the dock: work areas identified and barricaded so no one enters zones under overhead work (falling-debris risk); N95 masks readily available on the dock to minimize airborne debris exposure.</a:t>
-            </a:r>
-            <a:endParaRPr lang="en-US" sz="1400" dirty="0"/>
-          </a:p>
-        </p:txBody>
-      </p:sp>
-      <p:sp>
-        <p:nvSpPr>
-          <p:cNvPr id="16" name="Shape 12"/>
-          <p:cNvSpPr/>
-          <p:nvPr/>
-        </p:nvSpPr>
-        <p:spPr>
-          <a:xfrm>
-            <a:off x="6611112" y="4233672"/>
-            <a:ext cx="384048" cy="384048"/>
-          </a:xfrm>
-          <a:prstGeom prst="ellipse">
-            <a:avLst/>
-          </a:prstGeom>
-          <a:solidFill>
-            <a:srgbClr val="7C3AED"/>
-          </a:solidFill>
-          <a:ln w="12700">
-            <a:solidFill>
-              <a:srgbClr val="7C3AED"/>
-            </a:solidFill>
-            <a:prstDash val="solid"/>
-          </a:ln>
-        </p:spPr>
-      </p:sp>
-      <p:sp>
-        <p:nvSpPr>
-          <p:cNvPr id="17" name="Text 13"/>
-          <p:cNvSpPr txBox="1"/>
-          <p:nvPr/>
-        </p:nvSpPr>
-        <p:spPr>
-          <a:xfrm>
-            <a:off x="6611112" y="4233672"/>
-            <a:ext cx="384048" cy="384048"/>
-          </a:xfrm>
-          <a:prstGeom prst="rect">
-            <a:avLst/>
-          </a:prstGeom>
-          <a:noFill/>
-          <a:ln/>
-        </p:spPr>
-        <p:txBody>
-          <a:bodyPr wrap="square" lIns="0" tIns="0" rIns="0" bIns="0" rtlCol="0" anchor="ctr"/>
-          <a:lstStyle/>
-          <a:p>
-            <a:pPr algn="ctr" indent="0" marL="0">
-              <a:buNone/>
-            </a:pPr>
-            <a:r>
-              <a:rPr lang="en-US" sz="1300" b="1" dirty="0">
-                <a:solidFill>
-                  <a:srgbClr val="FFFFFF"/>
-                </a:solidFill>
-                <a:latin typeface="Calibri" pitchFamily="34" charset="0"/>
-                <a:ea typeface="Calibri" pitchFamily="34" charset="-122"/>
-                <a:cs typeface="Calibri" pitchFamily="34" charset="-120"/>
-              </a:rPr>
-              <a:t>2</a:t>
-            </a:r>
-            <a:endParaRPr lang="en-US" sz="1300" dirty="0"/>
-          </a:p>
-        </p:txBody>
-      </p:sp>
-      <p:sp>
-        <p:nvSpPr>
-          <p:cNvPr id="18" name="Text 14"/>
-          <p:cNvSpPr txBox="1"/>
-          <p:nvPr/>
-        </p:nvSpPr>
-        <p:spPr>
-          <a:xfrm>
-            <a:off x="7178040" y="4206240"/>
-            <a:ext cx="4206240" cy="777240"/>
-          </a:xfrm>
-          <a:prstGeom prst="rect">
-            <a:avLst/>
-          </a:prstGeom>
-          <a:noFill/>
-          <a:ln/>
-        </p:spPr>
-        <p:txBody>
-          <a:bodyPr wrap="square" lIns="0" tIns="0" rIns="0" bIns="0" rtlCol="0" anchor="t"/>
-          <a:lstStyle/>
-          <a:p>
-            <a:pPr indent="0" marL="0">
-              <a:buNone/>
-            </a:pPr>
-            <a:r>
-              <a:rPr lang="en-US" sz="1400" dirty="0">
+              <a:t>Trailer securement audit each shift</a:t>
+            </a:r>
+            <a:endParaRPr lang="en-US" sz="1100" dirty="0"/>
+          </a:p>
+          <a:p>
+            <a:pPr marL="203200" indent="-203200">
+              <a:spcAft>
+                <a:spcPts val="300"/>
+              </a:spcAft>
+              <a:buSzPct val="100000"/>
+              <a:buChar char="•"/>
+            </a:pPr>
+            <a:r>
+              <a:rPr lang="en-US" sz="1100" dirty="0">
                 <a:solidFill>
                   <a:srgbClr val="1F2937"/>
                 </a:solidFill>
@@ -37058,120 +37477,15 @@
                 <a:ea typeface="Calibri" pitchFamily="34" charset="-122"/>
                 <a:cs typeface="Calibri" pitchFamily="34" charset="-120"/>
               </a:rPr>
-              <a:t>Safety moments after every incident to share the specific learning with the whole team.</a:t>
-            </a:r>
-            <a:endParaRPr lang="en-US" sz="1400" dirty="0"/>
-          </a:p>
-        </p:txBody>
-      </p:sp>
-      <p:sp>
-        <p:nvSpPr>
-          <p:cNvPr id="19" name="Shape 15"/>
-          <p:cNvSpPr/>
-          <p:nvPr/>
-        </p:nvSpPr>
-        <p:spPr>
-          <a:xfrm>
-            <a:off x="6611112" y="5120640"/>
-            <a:ext cx="4754880" cy="868680"/>
-          </a:xfrm>
-          <a:prstGeom prst="roundRect">
-            <a:avLst>
-              <a:gd name="adj" fmla="val 8421"/>
-            </a:avLst>
-          </a:prstGeom>
-          <a:solidFill>
-            <a:srgbClr val="FFFFFF"/>
-          </a:solidFill>
-          <a:ln w="12700">
-            <a:solidFill>
-              <a:srgbClr val="FFFFFF"/>
-            </a:solidFill>
-            <a:prstDash val="solid"/>
-          </a:ln>
-        </p:spPr>
-      </p:sp>
-      <p:sp>
-        <p:nvSpPr>
-          <p:cNvPr id="20" name="Text 16"/>
-          <p:cNvSpPr txBox="1"/>
-          <p:nvPr/>
-        </p:nvSpPr>
-        <p:spPr>
-          <a:xfrm>
-            <a:off x="6812280" y="5120640"/>
-            <a:ext cx="2926080" cy="868680"/>
-          </a:xfrm>
-          <a:prstGeom prst="rect">
-            <a:avLst/>
-          </a:prstGeom>
-          <a:noFill/>
-          <a:ln/>
-        </p:spPr>
-        <p:txBody>
-          <a:bodyPr wrap="square" lIns="0" tIns="0" rIns="0" bIns="0" rtlCol="0" anchor="ctr"/>
-          <a:lstStyle/>
-          <a:p>
-            <a:pPr indent="0" marL="0">
-              <a:buNone/>
-            </a:pPr>
-            <a:r>
-              <a:rPr lang="en-US" sz="1300" b="1" dirty="0">
-                <a:solidFill>
-                  <a:srgbClr val="6B7280"/>
-                </a:solidFill>
-                <a:latin typeface="Calibri" pitchFamily="34" charset="0"/>
-                <a:ea typeface="Calibri" pitchFamily="34" charset="-122"/>
-                <a:cs typeface="Calibri" pitchFamily="34" charset="-120"/>
-              </a:rPr>
-              <a:t>STEP observations · MTD</a:t>
-            </a:r>
-            <a:endParaRPr lang="en-US" sz="1300" dirty="0"/>
-          </a:p>
-        </p:txBody>
-      </p:sp>
-      <p:sp>
-        <p:nvSpPr>
-          <p:cNvPr id="21" name="Text 17"/>
-          <p:cNvSpPr txBox="1"/>
-          <p:nvPr/>
-        </p:nvSpPr>
-        <p:spPr>
-          <a:xfrm>
-            <a:off x="9555480" y="5120640"/>
-            <a:ext cx="1645920" cy="868680"/>
-          </a:xfrm>
-          <a:prstGeom prst="rect">
-            <a:avLst/>
-          </a:prstGeom>
-          <a:noFill/>
-          <a:ln/>
-        </p:spPr>
-        <p:txBody>
-          <a:bodyPr wrap="square" lIns="0" tIns="0" rIns="0" bIns="0" rtlCol="0" anchor="ctr"/>
-          <a:lstStyle/>
-          <a:p>
-            <a:pPr algn="r" indent="0" marL="0">
-              <a:buNone/>
-            </a:pPr>
-            <a:r>
-              <a:rPr lang="en-US" sz="2600" b="1" dirty="0">
-                <a:solidFill>
-                  <a:srgbClr val="D97706"/>
-                </a:solidFill>
-                <a:latin typeface="Calibri" pitchFamily="34" charset="0"/>
-                <a:ea typeface="Calibri" pitchFamily="34" charset="-122"/>
-                <a:cs typeface="Calibri" pitchFamily="34" charset="-120"/>
-              </a:rPr>
-              <a:t>TBC</a:t>
-            </a:r>
-            <a:endParaRPr lang="en-US" sz="2600" dirty="0"/>
-          </a:p>
-        </p:txBody>
-      </p:sp>
-      <p:sp>
-        <p:nvSpPr>
-          <p:cNvPr id="22" name="Text 18"/>
+              <a:t>Winter yard readiness</a:t>
+            </a:r>
+            <a:endParaRPr lang="en-US" sz="1100" dirty="0"/>
+          </a:p>
+        </p:txBody>
+      </p:sp>
+      <p:sp>
+        <p:nvSpPr>
+          <p:cNvPr id="23" name="Text 21"/>
           <p:cNvSpPr txBox="1"/>
           <p:nvPr/>
         </p:nvSpPr>
@@ -37210,7 +37524,7 @@
       </p:sp>
       <p:sp>
         <p:nvSpPr>
-          <p:cNvPr id="23" name="Text 19"/>
+          <p:cNvPr id="24" name="Text 22"/>
           <p:cNvSpPr txBox="1"/>
           <p:nvPr/>
         </p:nvSpPr>

</xml_diff>

<commit_message>
Deck: load quality & securement slide with trailer photos (24 slides)
Co-Authored-By: Claude Opus 5.5 <noreply@anthropic.com>
Claude-Session: https://claude.ai/code/session_01BwRjju3y2wk3wSHFrM9KLe
</commit_message>
<xml_diff>
--- a/presentation/Mississauga_F27_Leadership_Review_Sep29.pptx
+++ b/presentation/Mississauga_F27_Leadership_Review_Sep29.pptx
@@ -28,9 +28,10 @@
     <p:sldId id="276" r:id="rId22"/>
     <p:sldId id="277" r:id="rId23"/>
     <p:sldId id="278" r:id="rId24"/>
+    <p:sldId id="279" r:id="rId25"/>
   </p:sldIdLst>
   <p:notesMasterIdLst>
-    <p:notesMasterId r:id="rId25"/>
+    <p:notesMasterId r:id="rId26"/>
   </p:notesMasterIdLst>
   <p:sldSz cx="12192000" cy="6858000"/>
   <p:notesSz cx="6858000" cy="12192000"/>
@@ -5769,7 +5770,7 @@
           <a:p>
             <a:r>
               <a:rPr lang="en-US" dirty="0"/>
-              <a:t>Clock-in and clock-out discipline turns late starts, missed lunches and early releases into hours we do not pay for. Weekly hours saved are being confirmed; once entered, dollars are calculated at the September month-to-date rate of 33.43 per hour from the productivity dashboard.</a:t>
+              <a:t>This is what good and bad loads look like on our dock. The target loads use a deck beam or deck board to build a second tier and are strapped; the fix examples are loose freight on a diagonal and floor-only loads with the top half of the trailer empty. We plan to add ANCRA knock-down pallet decks and divider deck-board kits, panel trucks and racks for windows, doors, panels and car parts, and load bars and straps on every mixed load, to lift load factor, reduce damages and claims, and make unloading safer. For example, MAAX shower doors and bases and 75-inch TVs currently ride standing loose, as on trailer 47520; slotting them into panel carts, the yellow cart by hand or the grey cage by forklift, secures them in transit, speeds loading and unloading, and cuts breakage.</a:t>
             </a:r>
             <a:endParaRPr lang="en-US" dirty="0"/>
           </a:p>
@@ -5857,7 +5858,7 @@
           <a:p>
             <a:r>
               <a:rPr lang="en-US" dirty="0"/>
-              <a:t>Mississauga is relocating to a new building by year end, most likely before 2027. Because of that, we are not planning any major repair spend at the current site; our focus is a clean transition for the team and our customers.</a:t>
+              <a:t>Clock-in and clock-out discipline turns late starts, missed lunches and early releases into hours we do not pay for. Weekly hours saved are being confirmed; once entered, dollars are calculated at the September month-to-date rate of 33.43 per hour from the productivity dashboard.</a:t>
             </a:r>
             <a:endParaRPr lang="en-US" dirty="0"/>
           </a:p>
@@ -5945,7 +5946,7 @@
           <a:p>
             <a:r>
               <a:rPr lang="en-US" dirty="0"/>
-              <a:t>To close: in F26 we set out to take 386,589 dollars out against the F25 baseline and identified 427,001 dollars of savings, 110 percent of the requirement; the F26 actuals will be added once the year is closed. In F27 September we are under our SCA hour allowance and cost per unit is down on last year, and our focus is closing the gap to the PPH goal. Happy to take questions.</a:t>
+              <a:t>Mississauga is relocating to a new building by year end, most likely before 2027. Because of that, we are not planning any major repair spend at the current site; our focus is a clean transition for the team and our customers.</a:t>
             </a:r>
             <a:endParaRPr lang="en-US" dirty="0"/>
           </a:p>
@@ -6033,7 +6034,7 @@
           <a:p>
             <a:r>
               <a:rPr lang="en-US" dirty="0"/>
-              <a:t>Backup — use only if asked.</a:t>
+              <a:t>To close: in F26 we set out to take 386,589 dollars out against the F25 baseline and identified 427,001 dollars of savings, 110 percent of the requirement; the F26 actuals will be added once the year is closed. In F27 September we are under our SCA hour allowance and cost per unit is down on last year, and our focus is closing the gap to the PPH goal. Happy to take questions.</a:t>
             </a:r>
             <a:endParaRPr lang="en-US" dirty="0"/>
           </a:p>
@@ -6057,6 +6058,94 @@
             <a:fld id="{F7021451-1387-4CA6-816F-3879F97B5CBC}" type="slidenum">
               <a:rPr lang="en-US"/>
               <a:t>23</a:t>
+            </a:fld>
+            <a:endParaRPr lang="en-US"/>
+          </a:p>
+        </p:txBody>
+      </p:sp>
+    </p:spTree>
+    <p:extLst>
+      <p:ext uri="{BB962C8B-B14F-4D97-AF65-F5344CB8AC3E}">
+        <p14:creationId xmlns:p14="http://schemas.microsoft.com/office/powerpoint/2010/main" val="1024086991"/>
+      </p:ext>
+    </p:extLst>
+  </p:cSld>
+  <p:clrMapOvr>
+    <a:masterClrMapping/>
+  </p:clrMapOvr>
+</p:notes>
+</file>
+
+<file path=ppt/notesSlides/notesSlide24.xml><?xml version="1.0" encoding="utf-8"?>
+<p:notes xmlns:a="http://schemas.openxmlformats.org/drawingml/2006/main" xmlns:r="http://schemas.openxmlformats.org/officeDocument/2006/relationships" xmlns:p="http://schemas.openxmlformats.org/presentationml/2006/main">
+  <p:cSld>
+    <p:spTree>
+      <p:nvGrpSpPr>
+        <p:cNvPr id="1" name=""/>
+        <p:cNvGrpSpPr/>
+        <p:nvPr/>
+      </p:nvGrpSpPr>
+      <p:grpSpPr>
+        <a:xfrm>
+          <a:off x="0" y="0"/>
+          <a:ext cx="0" cy="0"/>
+          <a:chOff x="0" y="0"/>
+          <a:chExt cx="0" cy="0"/>
+        </a:xfrm>
+      </p:grpSpPr>
+      <p:sp>
+        <p:nvSpPr>
+          <p:cNvPr id="2" name="Slide Image Placeholder 1"/>
+          <p:cNvSpPr>
+            <a:spLocks noGrp="1" noRot="1" noChangeAspect="1"/>
+          </p:cNvSpPr>
+          <p:nvPr>
+            <p:ph type="sldImg"/>
+          </p:nvPr>
+        </p:nvSpPr>
+        <p:spPr/>
+      </p:sp>
+      <p:sp>
+        <p:nvSpPr>
+          <p:cNvPr id="3" name="Notes Placeholder 2"/>
+          <p:cNvSpPr>
+            <a:spLocks noGrp="1"/>
+          </p:cNvSpPr>
+          <p:nvPr>
+            <p:ph type="body" idx="1"/>
+          </p:nvPr>
+        </p:nvSpPr>
+        <p:spPr/>
+        <p:txBody>
+          <a:bodyPr/>
+          <a:lstStyle/>
+          <a:p>
+            <a:r>
+              <a:rPr lang="en-US" dirty="0"/>
+              <a:t>Backup — use only if asked.</a:t>
+            </a:r>
+            <a:endParaRPr lang="en-US" dirty="0"/>
+          </a:p>
+        </p:txBody>
+      </p:sp>
+      <p:sp>
+        <p:nvSpPr>
+          <p:cNvPr id="4" name="Slide Number Placeholder 3"/>
+          <p:cNvSpPr>
+            <a:spLocks noGrp="1"/>
+          </p:cNvSpPr>
+          <p:nvPr>
+            <p:ph type="sldNum" sz="quarter" idx="10"/>
+          </p:nvPr>
+        </p:nvSpPr>
+        <p:spPr/>
+        <p:txBody>
+          <a:bodyPr/>
+          <a:lstStyle/>
+          <a:p>
+            <a:fld id="{F7021451-1387-4CA6-816F-3879F97B5CBC}" type="slidenum">
+              <a:rPr lang="en-US"/>
+              <a:t>24</a:t>
             </a:fld>
             <a:endParaRPr lang="en-US"/>
           </a:p>
@@ -6209,7 +6298,7 @@
           <a:p>
             <a:r>
               <a:rPr lang="en-US" dirty="0"/>
-              <a:t>Here is where our safety work stands. Completed: the roofing work zones are barricaded with N95 masks available, and the new shunt pre-trip checklist is used every shift. Our ongoing practices include incident reporting: incidents are reported promptly and supervisors work directly with OHS on WSIB forms and a safe return to work; we document detailed descriptions, identify root cause with OHS, and follow up corrective actions so controls prevent recurrence; and forklift and TDG training is completed before expiry. Planned is freight-handling equipment such as panel trucks and racks for windows, panels and car parts to improve handling and cut damages, and the ideas list is where we go next, including agency onboarding and a safety plan for the new building.</a:t>
+              <a:t>Here is where our safety work stands. Completed: the roofing work zones are barricaded with N95 masks available, and the new shunt pre-trip checklist is used every shift. Our ongoing practices include incident reporting: incidents are reported promptly and supervisors work directly with OHS on WSIB forms and a safe return to work; we document detailed descriptions, identify root cause with OHS, and follow up corrective actions so controls prevent recurrence; and forklift and TDG training is completed before expiry. Planned are load securement and decking with ANCRA decks and divider deck-board kits, and freight-handling equipment such as panel trucks and racks for windows, panels and car parts to improve handling and cut damages, and the ideas list is where we go next, including agency onboarding and a safety plan for the new building.</a:t>
             </a:r>
             <a:endParaRPr lang="en-US" dirty="0"/>
           </a:p>
@@ -9040,7 +9129,7 @@
                 <a:ea typeface="Calibri" pitchFamily="34" charset="-122"/>
                 <a:cs typeface="Calibri" pitchFamily="34" charset="-120"/>
               </a:rPr>
-              <a:t>10 / 23</a:t>
+              <a:t>10 / 24</a:t>
             </a:r>
             <a:endParaRPr lang="en-US" sz="900" dirty="0"/>
           </a:p>
@@ -13533,7 +13622,7 @@
                 <a:ea typeface="Calibri" pitchFamily="34" charset="-122"/>
                 <a:cs typeface="Calibri" pitchFamily="34" charset="-120"/>
               </a:rPr>
-              <a:t>11 / 23</a:t>
+              <a:t>11 / 24</a:t>
             </a:r>
             <a:endParaRPr lang="en-US" sz="900" dirty="0"/>
           </a:p>
@@ -15545,7 +15634,7 @@
                 <a:ea typeface="Calibri" pitchFamily="34" charset="-122"/>
                 <a:cs typeface="Calibri" pitchFamily="34" charset="-120"/>
               </a:rPr>
-              <a:t>12 / 23</a:t>
+              <a:t>12 / 24</a:t>
             </a:r>
             <a:endParaRPr lang="en-US" sz="900" dirty="0"/>
           </a:p>
@@ -16182,7 +16271,7 @@
                 <a:ea typeface="Calibri" pitchFamily="34" charset="-122"/>
                 <a:cs typeface="Calibri" pitchFamily="34" charset="-120"/>
               </a:rPr>
-              <a:t>13 / 23</a:t>
+              <a:t>13 / 24</a:t>
             </a:r>
             <a:endParaRPr lang="en-US" sz="900" dirty="0"/>
           </a:p>
@@ -17689,7 +17778,7 @@
                 <a:ea typeface="Calibri" pitchFamily="34" charset="-122"/>
                 <a:cs typeface="Calibri" pitchFamily="34" charset="-120"/>
               </a:rPr>
-              <a:t>14 / 23</a:t>
+              <a:t>14 / 24</a:t>
             </a:r>
             <a:endParaRPr lang="en-US" sz="900" dirty="0"/>
           </a:p>
@@ -20044,7 +20133,7 @@
                 <a:ea typeface="Calibri" pitchFamily="34" charset="-122"/>
                 <a:cs typeface="Calibri" pitchFamily="34" charset="-120"/>
               </a:rPr>
-              <a:t>15 / 23</a:t>
+              <a:t>15 / 24</a:t>
             </a:r>
             <a:endParaRPr lang="en-US" sz="900" dirty="0"/>
           </a:p>
@@ -21132,7 +21221,7 @@
                 <a:ea typeface="Calibri" pitchFamily="34" charset="-122"/>
                 <a:cs typeface="Calibri" pitchFamily="34" charset="-120"/>
               </a:rPr>
-              <a:t>16 / 23</a:t>
+              <a:t>16 / 24</a:t>
             </a:r>
             <a:endParaRPr lang="en-US" sz="900" dirty="0"/>
           </a:p>
@@ -24032,7 +24121,7 @@
                 <a:ea typeface="Calibri" pitchFamily="34" charset="-122"/>
                 <a:cs typeface="Calibri" pitchFamily="34" charset="-120"/>
               </a:rPr>
-              <a:t>17 / 23</a:t>
+              <a:t>17 / 24</a:t>
             </a:r>
             <a:endParaRPr lang="en-US" sz="900" dirty="0"/>
           </a:p>
@@ -26752,7 +26841,7 @@
                 <a:ea typeface="Calibri" pitchFamily="34" charset="-122"/>
                 <a:cs typeface="Calibri" pitchFamily="34" charset="-120"/>
               </a:rPr>
-              <a:t>18 / 23</a:t>
+              <a:t>18 / 24</a:t>
             </a:r>
             <a:endParaRPr lang="en-US" sz="900" dirty="0"/>
           </a:p>
@@ -27949,7 +28038,7 @@
                 <a:ea typeface="Calibri" pitchFamily="34" charset="-122"/>
                 <a:cs typeface="Calibri" pitchFamily="34" charset="-120"/>
               </a:rPr>
-              <a:t>19 / 23</a:t>
+              <a:t>19 / 24</a:t>
             </a:r>
             <a:endParaRPr lang="en-US" sz="900" dirty="0"/>
           </a:p>
@@ -29345,7 +29434,7 @@
                 <a:ea typeface="Calibri" pitchFamily="34" charset="-122"/>
                 <a:cs typeface="Calibri" pitchFamily="34" charset="-120"/>
               </a:rPr>
-              <a:t>2 / 23</a:t>
+              <a:t>2 / 24</a:t>
             </a:r>
             <a:endParaRPr lang="en-US" sz="900" dirty="0"/>
           </a:p>
@@ -29455,6 +29544,1131 @@
                 <a:ea typeface="Calibri" pitchFamily="34" charset="-122"/>
                 <a:cs typeface="Calibri" pitchFamily="34" charset="-120"/>
               </a:rPr>
+              <a:t>Load quality &amp; securement — planned</a:t>
+            </a:r>
+            <a:endParaRPr lang="en-US" sz="3000" dirty="0"/>
+          </a:p>
+        </p:txBody>
+      </p:sp>
+      <p:sp>
+        <p:nvSpPr>
+          <p:cNvPr id="4" name="Shape 2"/>
+          <p:cNvSpPr/>
+          <p:nvPr/>
+        </p:nvSpPr>
+        <p:spPr>
+          <a:xfrm>
+            <a:off x="548640" y="1371600"/>
+            <a:ext cx="1700784" cy="292608"/>
+          </a:xfrm>
+          <a:prstGeom prst="roundRect">
+            <a:avLst>
+              <a:gd name="adj" fmla="val 25000"/>
+            </a:avLst>
+          </a:prstGeom>
+          <a:solidFill>
+            <a:srgbClr val="D1FAE5"/>
+          </a:solidFill>
+          <a:ln w="12700">
+            <a:solidFill>
+              <a:srgbClr val="D1FAE5"/>
+            </a:solidFill>
+            <a:prstDash val="solid"/>
+          </a:ln>
+        </p:spPr>
+      </p:sp>
+      <p:sp>
+        <p:nvSpPr>
+          <p:cNvPr id="5" name="Text 3"/>
+          <p:cNvSpPr txBox="1"/>
+          <p:nvPr/>
+        </p:nvSpPr>
+        <p:spPr>
+          <a:xfrm>
+            <a:off x="548640" y="1371600"/>
+            <a:ext cx="1700784" cy="292608"/>
+          </a:xfrm>
+          <a:prstGeom prst="rect">
+            <a:avLst/>
+          </a:prstGeom>
+          <a:noFill/>
+          <a:ln/>
+        </p:spPr>
+        <p:txBody>
+          <a:bodyPr wrap="square" lIns="0" tIns="0" rIns="0" bIns="0" rtlCol="0" anchor="ctr"/>
+          <a:lstStyle/>
+          <a:p>
+            <a:pPr algn="ctr" indent="0" marL="0">
+              <a:buNone/>
+            </a:pPr>
+            <a:r>
+              <a:rPr lang="en-US" sz="1100" b="1" spc="200" kern="0" dirty="0">
+                <a:solidFill>
+                  <a:srgbClr val="059669"/>
+                </a:solidFill>
+                <a:latin typeface="Calibri" pitchFamily="34" charset="0"/>
+                <a:ea typeface="Calibri" pitchFamily="34" charset="-122"/>
+                <a:cs typeface="Calibri" pitchFamily="34" charset="-120"/>
+              </a:rPr>
+              <a:t>TARGET</a:t>
+            </a:r>
+            <a:endParaRPr lang="en-US" sz="1100" dirty="0"/>
+          </a:p>
+        </p:txBody>
+      </p:sp>
+      <p:pic>
+        <p:nvPicPr>
+          <p:cNvPr id="6" name="Image 0" descr="570260 — deck beam builds a second tier">    </p:cNvPr>
+          <p:cNvPicPr>
+            <a:picLocks noChangeAspect="1"/>
+          </p:cNvPicPr>
+          <p:nvPr/>
+        </p:nvPicPr>
+        <p:blipFill>
+          <a:blip r:embed="rId1"/>
+          <a:stretch>
+            <a:fillRect/>
+          </a:stretch>
+        </p:blipFill>
+        <p:spPr>
+          <a:xfrm>
+            <a:off x="548640" y="1737360"/>
+            <a:ext cx="1700784" cy="2267712"/>
+          </a:xfrm>
+          <a:prstGeom prst="rect">
+            <a:avLst/>
+          </a:prstGeom>
+        </p:spPr>
+      </p:pic>
+      <p:sp>
+        <p:nvSpPr>
+          <p:cNvPr id="7" name="Text 4"/>
+          <p:cNvSpPr txBox="1"/>
+          <p:nvPr/>
+        </p:nvSpPr>
+        <p:spPr>
+          <a:xfrm>
+            <a:off x="548640" y="4059936"/>
+            <a:ext cx="1700784" cy="502920"/>
+          </a:xfrm>
+          <a:prstGeom prst="rect">
+            <a:avLst/>
+          </a:prstGeom>
+          <a:noFill/>
+          <a:ln/>
+        </p:spPr>
+        <p:txBody>
+          <a:bodyPr wrap="square" lIns="0" tIns="0" rIns="0" bIns="0" rtlCol="0" anchor="t"/>
+          <a:lstStyle/>
+          <a:p>
+            <a:pPr indent="0" marL="0">
+              <a:buNone/>
+            </a:pPr>
+            <a:r>
+              <a:rPr lang="en-US" sz="950" dirty="0">
+                <a:solidFill>
+                  <a:srgbClr val="1F2937"/>
+                </a:solidFill>
+                <a:latin typeface="Calibri" pitchFamily="34" charset="0"/>
+                <a:ea typeface="Calibri" pitchFamily="34" charset="-122"/>
+                <a:cs typeface="Calibri" pitchFamily="34" charset="-120"/>
+              </a:rPr>
+              <a:t>570260 — deck beam builds a second tier</a:t>
+            </a:r>
+            <a:endParaRPr lang="en-US" sz="950" dirty="0"/>
+          </a:p>
+        </p:txBody>
+      </p:sp>
+      <p:sp>
+        <p:nvSpPr>
+          <p:cNvPr id="8" name="Shape 5"/>
+          <p:cNvSpPr/>
+          <p:nvPr/>
+        </p:nvSpPr>
+        <p:spPr>
+          <a:xfrm>
+            <a:off x="2377440" y="1371600"/>
+            <a:ext cx="1700784" cy="292608"/>
+          </a:xfrm>
+          <a:prstGeom prst="roundRect">
+            <a:avLst>
+              <a:gd name="adj" fmla="val 25000"/>
+            </a:avLst>
+          </a:prstGeom>
+          <a:solidFill>
+            <a:srgbClr val="D1FAE5"/>
+          </a:solidFill>
+          <a:ln w="12700">
+            <a:solidFill>
+              <a:srgbClr val="D1FAE5"/>
+            </a:solidFill>
+            <a:prstDash val="solid"/>
+          </a:ln>
+        </p:spPr>
+      </p:sp>
+      <p:sp>
+        <p:nvSpPr>
+          <p:cNvPr id="9" name="Text 6"/>
+          <p:cNvSpPr txBox="1"/>
+          <p:nvPr/>
+        </p:nvSpPr>
+        <p:spPr>
+          <a:xfrm>
+            <a:off x="2377440" y="1371600"/>
+            <a:ext cx="1700784" cy="292608"/>
+          </a:xfrm>
+          <a:prstGeom prst="rect">
+            <a:avLst/>
+          </a:prstGeom>
+          <a:noFill/>
+          <a:ln/>
+        </p:spPr>
+        <p:txBody>
+          <a:bodyPr wrap="square" lIns="0" tIns="0" rIns="0" bIns="0" rtlCol="0" anchor="ctr"/>
+          <a:lstStyle/>
+          <a:p>
+            <a:pPr algn="ctr" indent="0" marL="0">
+              <a:buNone/>
+            </a:pPr>
+            <a:r>
+              <a:rPr lang="en-US" sz="1100" b="1" spc="200" kern="0" dirty="0">
+                <a:solidFill>
+                  <a:srgbClr val="059669"/>
+                </a:solidFill>
+                <a:latin typeface="Calibri" pitchFamily="34" charset="0"/>
+                <a:ea typeface="Calibri" pitchFamily="34" charset="-122"/>
+                <a:cs typeface="Calibri" pitchFamily="34" charset="-120"/>
+              </a:rPr>
+              <a:t>TARGET</a:t>
+            </a:r>
+            <a:endParaRPr lang="en-US" sz="1100" dirty="0"/>
+          </a:p>
+        </p:txBody>
+      </p:sp>
+      <p:pic>
+        <p:nvPicPr>
+          <p:cNvPr id="10" name="Image 1" descr="470275 — deck board overhead + strap">    </p:cNvPr>
+          <p:cNvPicPr>
+            <a:picLocks noChangeAspect="1"/>
+          </p:cNvPicPr>
+          <p:nvPr/>
+        </p:nvPicPr>
+        <p:blipFill>
+          <a:blip r:embed="rId2"/>
+          <a:stretch>
+            <a:fillRect/>
+          </a:stretch>
+        </p:blipFill>
+        <p:spPr>
+          <a:xfrm>
+            <a:off x="2377440" y="1737360"/>
+            <a:ext cx="1700784" cy="2267712"/>
+          </a:xfrm>
+          <a:prstGeom prst="rect">
+            <a:avLst/>
+          </a:prstGeom>
+        </p:spPr>
+      </p:pic>
+      <p:sp>
+        <p:nvSpPr>
+          <p:cNvPr id="11" name="Text 7"/>
+          <p:cNvSpPr txBox="1"/>
+          <p:nvPr/>
+        </p:nvSpPr>
+        <p:spPr>
+          <a:xfrm>
+            <a:off x="2377440" y="4059936"/>
+            <a:ext cx="1700784" cy="502920"/>
+          </a:xfrm>
+          <a:prstGeom prst="rect">
+            <a:avLst/>
+          </a:prstGeom>
+          <a:noFill/>
+          <a:ln/>
+        </p:spPr>
+        <p:txBody>
+          <a:bodyPr wrap="square" lIns="0" tIns="0" rIns="0" bIns="0" rtlCol="0" anchor="t"/>
+          <a:lstStyle/>
+          <a:p>
+            <a:pPr indent="0" marL="0">
+              <a:buNone/>
+            </a:pPr>
+            <a:r>
+              <a:rPr lang="en-US" sz="950" dirty="0">
+                <a:solidFill>
+                  <a:srgbClr val="1F2937"/>
+                </a:solidFill>
+                <a:latin typeface="Calibri" pitchFamily="34" charset="0"/>
+                <a:ea typeface="Calibri" pitchFamily="34" charset="-122"/>
+                <a:cs typeface="Calibri" pitchFamily="34" charset="-120"/>
+              </a:rPr>
+              <a:t>470275 — deck board overhead + strap</a:t>
+            </a:r>
+            <a:endParaRPr lang="en-US" sz="950" dirty="0"/>
+          </a:p>
+        </p:txBody>
+      </p:sp>
+      <p:sp>
+        <p:nvSpPr>
+          <p:cNvPr id="12" name="Shape 8"/>
+          <p:cNvSpPr/>
+          <p:nvPr/>
+        </p:nvSpPr>
+        <p:spPr>
+          <a:xfrm>
+            <a:off x="4206240" y="1371600"/>
+            <a:ext cx="1700784" cy="292608"/>
+          </a:xfrm>
+          <a:prstGeom prst="roundRect">
+            <a:avLst>
+              <a:gd name="adj" fmla="val 25000"/>
+            </a:avLst>
+          </a:prstGeom>
+          <a:solidFill>
+            <a:srgbClr val="FEE2E2"/>
+          </a:solidFill>
+          <a:ln w="12700">
+            <a:solidFill>
+              <a:srgbClr val="FEE2E2"/>
+            </a:solidFill>
+            <a:prstDash val="solid"/>
+          </a:ln>
+        </p:spPr>
+      </p:sp>
+      <p:sp>
+        <p:nvSpPr>
+          <p:cNvPr id="13" name="Text 9"/>
+          <p:cNvSpPr txBox="1"/>
+          <p:nvPr/>
+        </p:nvSpPr>
+        <p:spPr>
+          <a:xfrm>
+            <a:off x="4206240" y="1371600"/>
+            <a:ext cx="1700784" cy="292608"/>
+          </a:xfrm>
+          <a:prstGeom prst="rect">
+            <a:avLst/>
+          </a:prstGeom>
+          <a:noFill/>
+          <a:ln/>
+        </p:spPr>
+        <p:txBody>
+          <a:bodyPr wrap="square" lIns="0" tIns="0" rIns="0" bIns="0" rtlCol="0" anchor="ctr"/>
+          <a:lstStyle/>
+          <a:p>
+            <a:pPr algn="ctr" indent="0" marL="0">
+              <a:buNone/>
+            </a:pPr>
+            <a:r>
+              <a:rPr lang="en-US" sz="1100" b="1" spc="200" kern="0" dirty="0">
+                <a:solidFill>
+                  <a:srgbClr val="DC2626"/>
+                </a:solidFill>
+                <a:latin typeface="Calibri" pitchFamily="34" charset="0"/>
+                <a:ea typeface="Calibri" pitchFamily="34" charset="-122"/>
+                <a:cs typeface="Calibri" pitchFamily="34" charset="-120"/>
+              </a:rPr>
+              <a:t>FIX</a:t>
+            </a:r>
+            <a:endParaRPr lang="en-US" sz="1100" dirty="0"/>
+          </a:p>
+        </p:txBody>
+      </p:sp>
+      <p:pic>
+        <p:nvPicPr>
+          <p:cNvPr id="14" name="Image 2" descr="470236 — loose freight on a diagonal: damage risk, wasted cube">    </p:cNvPr>
+          <p:cNvPicPr>
+            <a:picLocks noChangeAspect="1"/>
+          </p:cNvPicPr>
+          <p:nvPr/>
+        </p:nvPicPr>
+        <p:blipFill>
+          <a:blip r:embed="rId3"/>
+          <a:stretch>
+            <a:fillRect/>
+          </a:stretch>
+        </p:blipFill>
+        <p:spPr>
+          <a:xfrm>
+            <a:off x="4206240" y="1737360"/>
+            <a:ext cx="1700784" cy="2267712"/>
+          </a:xfrm>
+          <a:prstGeom prst="rect">
+            <a:avLst/>
+          </a:prstGeom>
+        </p:spPr>
+      </p:pic>
+      <p:sp>
+        <p:nvSpPr>
+          <p:cNvPr id="15" name="Text 10"/>
+          <p:cNvSpPr txBox="1"/>
+          <p:nvPr/>
+        </p:nvSpPr>
+        <p:spPr>
+          <a:xfrm>
+            <a:off x="4206240" y="4059936"/>
+            <a:ext cx="1700784" cy="502920"/>
+          </a:xfrm>
+          <a:prstGeom prst="rect">
+            <a:avLst/>
+          </a:prstGeom>
+          <a:noFill/>
+          <a:ln/>
+        </p:spPr>
+        <p:txBody>
+          <a:bodyPr wrap="square" lIns="0" tIns="0" rIns="0" bIns="0" rtlCol="0" anchor="t"/>
+          <a:lstStyle/>
+          <a:p>
+            <a:pPr indent="0" marL="0">
+              <a:buNone/>
+            </a:pPr>
+            <a:r>
+              <a:rPr lang="en-US" sz="950" dirty="0">
+                <a:solidFill>
+                  <a:srgbClr val="1F2937"/>
+                </a:solidFill>
+                <a:latin typeface="Calibri" pitchFamily="34" charset="0"/>
+                <a:ea typeface="Calibri" pitchFamily="34" charset="-122"/>
+                <a:cs typeface="Calibri" pitchFamily="34" charset="-120"/>
+              </a:rPr>
+              <a:t>470236 — loose freight on a diagonal: damage risk, wasted cube</a:t>
+            </a:r>
+            <a:endParaRPr lang="en-US" sz="950" dirty="0"/>
+          </a:p>
+        </p:txBody>
+      </p:sp>
+      <p:sp>
+        <p:nvSpPr>
+          <p:cNvPr id="16" name="Shape 11"/>
+          <p:cNvSpPr/>
+          <p:nvPr/>
+        </p:nvSpPr>
+        <p:spPr>
+          <a:xfrm>
+            <a:off x="6035040" y="1371600"/>
+            <a:ext cx="1700784" cy="292608"/>
+          </a:xfrm>
+          <a:prstGeom prst="roundRect">
+            <a:avLst>
+              <a:gd name="adj" fmla="val 25000"/>
+            </a:avLst>
+          </a:prstGeom>
+          <a:solidFill>
+            <a:srgbClr val="FEE2E2"/>
+          </a:solidFill>
+          <a:ln w="12700">
+            <a:solidFill>
+              <a:srgbClr val="FEE2E2"/>
+            </a:solidFill>
+            <a:prstDash val="solid"/>
+          </a:ln>
+        </p:spPr>
+      </p:sp>
+      <p:sp>
+        <p:nvSpPr>
+          <p:cNvPr id="17" name="Text 12"/>
+          <p:cNvSpPr txBox="1"/>
+          <p:nvPr/>
+        </p:nvSpPr>
+        <p:spPr>
+          <a:xfrm>
+            <a:off x="6035040" y="1371600"/>
+            <a:ext cx="1700784" cy="292608"/>
+          </a:xfrm>
+          <a:prstGeom prst="rect">
+            <a:avLst/>
+          </a:prstGeom>
+          <a:noFill/>
+          <a:ln/>
+        </p:spPr>
+        <p:txBody>
+          <a:bodyPr wrap="square" lIns="0" tIns="0" rIns="0" bIns="0" rtlCol="0" anchor="ctr"/>
+          <a:lstStyle/>
+          <a:p>
+            <a:pPr algn="ctr" indent="0" marL="0">
+              <a:buNone/>
+            </a:pPr>
+            <a:r>
+              <a:rPr lang="en-US" sz="1100" b="1" spc="200" kern="0" dirty="0">
+                <a:solidFill>
+                  <a:srgbClr val="DC2626"/>
+                </a:solidFill>
+                <a:latin typeface="Calibri" pitchFamily="34" charset="0"/>
+                <a:ea typeface="Calibri" pitchFamily="34" charset="-122"/>
+                <a:cs typeface="Calibri" pitchFamily="34" charset="-120"/>
+              </a:rPr>
+              <a:t>FIX</a:t>
+            </a:r>
+            <a:endParaRPr lang="en-US" sz="1100" dirty="0"/>
+          </a:p>
+        </p:txBody>
+      </p:sp>
+      <p:pic>
+        <p:nvPicPr>
+          <p:cNvPr id="18" name="Image 3" descr="570419 — floor-loaded only, top half empty">    </p:cNvPr>
+          <p:cNvPicPr>
+            <a:picLocks noChangeAspect="1"/>
+          </p:cNvPicPr>
+          <p:nvPr/>
+        </p:nvPicPr>
+        <p:blipFill>
+          <a:blip r:embed="rId4"/>
+          <a:stretch>
+            <a:fillRect/>
+          </a:stretch>
+        </p:blipFill>
+        <p:spPr>
+          <a:xfrm>
+            <a:off x="6035040" y="1737360"/>
+            <a:ext cx="1700784" cy="2267712"/>
+          </a:xfrm>
+          <a:prstGeom prst="rect">
+            <a:avLst/>
+          </a:prstGeom>
+        </p:spPr>
+      </p:pic>
+      <p:sp>
+        <p:nvSpPr>
+          <p:cNvPr id="19" name="Text 13"/>
+          <p:cNvSpPr txBox="1"/>
+          <p:nvPr/>
+        </p:nvSpPr>
+        <p:spPr>
+          <a:xfrm>
+            <a:off x="6035040" y="4059936"/>
+            <a:ext cx="1700784" cy="502920"/>
+          </a:xfrm>
+          <a:prstGeom prst="rect">
+            <a:avLst/>
+          </a:prstGeom>
+          <a:noFill/>
+          <a:ln/>
+        </p:spPr>
+        <p:txBody>
+          <a:bodyPr wrap="square" lIns="0" tIns="0" rIns="0" bIns="0" rtlCol="0" anchor="t"/>
+          <a:lstStyle/>
+          <a:p>
+            <a:pPr indent="0" marL="0">
+              <a:buNone/>
+            </a:pPr>
+            <a:r>
+              <a:rPr lang="en-US" sz="950" dirty="0">
+                <a:solidFill>
+                  <a:srgbClr val="1F2937"/>
+                </a:solidFill>
+                <a:latin typeface="Calibri" pitchFamily="34" charset="0"/>
+                <a:ea typeface="Calibri" pitchFamily="34" charset="-122"/>
+                <a:cs typeface="Calibri" pitchFamily="34" charset="-120"/>
+              </a:rPr>
+              <a:t>570419 — floor-loaded only, top half empty</a:t>
+            </a:r>
+            <a:endParaRPr lang="en-US" sz="950" dirty="0"/>
+          </a:p>
+        </p:txBody>
+      </p:sp>
+      <p:sp>
+        <p:nvSpPr>
+          <p:cNvPr id="20" name="Shape 14"/>
+          <p:cNvSpPr/>
+          <p:nvPr/>
+        </p:nvSpPr>
+        <p:spPr>
+          <a:xfrm>
+            <a:off x="548640" y="4709160"/>
+            <a:ext cx="7187184" cy="1325880"/>
+          </a:xfrm>
+          <a:prstGeom prst="roundRect">
+            <a:avLst>
+              <a:gd name="adj" fmla="val 5517"/>
+            </a:avLst>
+          </a:prstGeom>
+          <a:solidFill>
+            <a:srgbClr val="F5F3FF"/>
+          </a:solidFill>
+          <a:ln w="12700">
+            <a:solidFill>
+              <a:srgbClr val="F5F3FF"/>
+            </a:solidFill>
+            <a:prstDash val="solid"/>
+          </a:ln>
+        </p:spPr>
+      </p:sp>
+      <p:sp>
+        <p:nvSpPr>
+          <p:cNvPr id="21" name="Text 15"/>
+          <p:cNvSpPr txBox="1"/>
+          <p:nvPr/>
+        </p:nvSpPr>
+        <p:spPr>
+          <a:xfrm>
+            <a:off x="731520" y="4754880"/>
+            <a:ext cx="6858000" cy="1234440"/>
+          </a:xfrm>
+          <a:prstGeom prst="rect">
+            <a:avLst/>
+          </a:prstGeom>
+          <a:noFill/>
+          <a:ln/>
+        </p:spPr>
+        <p:txBody>
+          <a:bodyPr wrap="square" lIns="0" tIns="0" rIns="0" bIns="0" rtlCol="0" anchor="ctr"/>
+          <a:lstStyle/>
+          <a:p>
+            <a:pPr indent="0" marL="0">
+              <a:buNone/>
+            </a:pPr>
+            <a:r>
+              <a:rPr lang="en-US" sz="1300" b="1" dirty="0">
+                <a:solidFill>
+                  <a:srgbClr val="7C3AED"/>
+                </a:solidFill>
+                <a:latin typeface="Calibri" pitchFamily="34" charset="0"/>
+                <a:ea typeface="Calibri" pitchFamily="34" charset="-122"/>
+                <a:cs typeface="Calibri" pitchFamily="34" charset="-120"/>
+              </a:rPr>
+              <a:t>Why</a:t>
+            </a:r>
+            <a:endParaRPr lang="en-US" sz="1200" dirty="0"/>
+          </a:p>
+          <a:p>
+            <a:pPr marL="177800" indent="-177800">
+              <a:buSzPct val="100000"/>
+              <a:buChar char="•"/>
+            </a:pPr>
+            <a:r>
+              <a:rPr lang="en-US" sz="1200" dirty="0">
+                <a:solidFill>
+                  <a:srgbClr val="1F2937"/>
+                </a:solidFill>
+                <a:latin typeface="Calibri" pitchFamily="34" charset="0"/>
+                <a:ea typeface="Calibri" pitchFamily="34" charset="-122"/>
+                <a:cs typeface="Calibri" pitchFamily="34" charset="-120"/>
+              </a:rPr>
+              <a:t>Uses the top half of the trailer — lifts LF score (36.4% F27).</a:t>
+            </a:r>
+            <a:endParaRPr lang="en-US" sz="1200" dirty="0"/>
+          </a:p>
+          <a:p>
+            <a:pPr marL="177800" indent="-177800">
+              <a:buSzPct val="100000"/>
+              <a:buChar char="•"/>
+            </a:pPr>
+            <a:r>
+              <a:rPr lang="en-US" sz="1200" dirty="0">
+                <a:solidFill>
+                  <a:srgbClr val="1F2937"/>
+                </a:solidFill>
+                <a:latin typeface="Calibri" pitchFamily="34" charset="0"/>
+                <a:ea typeface="Calibri" pitchFamily="34" charset="-122"/>
+                <a:cs typeface="Calibri" pitchFamily="34" charset="-120"/>
+              </a:rPr>
+              <a:t>Fewer damaged FBs (1.61% 7-day avg) and claims.</a:t>
+            </a:r>
+            <a:endParaRPr lang="en-US" sz="1200" dirty="0"/>
+          </a:p>
+          <a:p>
+            <a:pPr marL="177800" indent="-177800">
+              <a:buSzPct val="100000"/>
+              <a:buChar char="•"/>
+            </a:pPr>
+            <a:r>
+              <a:rPr lang="en-US" sz="1200" dirty="0">
+                <a:solidFill>
+                  <a:srgbClr val="1F2937"/>
+                </a:solidFill>
+                <a:latin typeface="Calibri" pitchFamily="34" charset="0"/>
+                <a:ea typeface="Calibri" pitchFamily="34" charset="-122"/>
+                <a:cs typeface="Calibri" pitchFamily="34" charset="-120"/>
+              </a:rPr>
+              <a:t>Safer unloading.</a:t>
+            </a:r>
+            <a:endParaRPr lang="en-US" sz="1200" dirty="0"/>
+          </a:p>
+        </p:txBody>
+      </p:sp>
+      <p:sp>
+        <p:nvSpPr>
+          <p:cNvPr id="22" name="Shape 16"/>
+          <p:cNvSpPr/>
+          <p:nvPr/>
+        </p:nvSpPr>
+        <p:spPr>
+          <a:xfrm>
+            <a:off x="8001000" y="1371600"/>
+            <a:ext cx="3639312" cy="3108960"/>
+          </a:xfrm>
+          <a:prstGeom prst="roundRect">
+            <a:avLst>
+              <a:gd name="adj" fmla="val 2353"/>
+            </a:avLst>
+          </a:prstGeom>
+          <a:solidFill>
+            <a:srgbClr val="F3F4F6"/>
+          </a:solidFill>
+          <a:ln w="12700">
+            <a:solidFill>
+              <a:srgbClr val="F3F4F6"/>
+            </a:solidFill>
+            <a:prstDash val="solid"/>
+          </a:ln>
+        </p:spPr>
+      </p:sp>
+      <p:sp>
+        <p:nvSpPr>
+          <p:cNvPr id="23" name="Shape 17"/>
+          <p:cNvSpPr/>
+          <p:nvPr/>
+        </p:nvSpPr>
+        <p:spPr>
+          <a:xfrm>
+            <a:off x="8229600" y="1572768"/>
+            <a:ext cx="502920" cy="502920"/>
+          </a:xfrm>
+          <a:prstGeom prst="ellipse">
+            <a:avLst/>
+          </a:prstGeom>
+          <a:solidFill>
+            <a:srgbClr val="7C3AED"/>
+          </a:solidFill>
+          <a:ln w="12700">
+            <a:solidFill>
+              <a:srgbClr val="7C3AED"/>
+            </a:solidFill>
+            <a:prstDash val="solid"/>
+          </a:ln>
+        </p:spPr>
+      </p:sp>
+      <p:pic>
+        <p:nvPicPr>
+          <p:cNvPr id="24" name="Image 4" descr="preencoded.png">    </p:cNvPr>
+          <p:cNvPicPr>
+            <a:picLocks noChangeAspect="1"/>
+          </p:cNvPicPr>
+          <p:nvPr/>
+        </p:nvPicPr>
+        <p:blipFill>
+          <a:blip r:embed="rId5"/>
+          <a:stretch>
+            <a:fillRect/>
+          </a:stretch>
+        </p:blipFill>
+        <p:spPr>
+          <a:xfrm>
+            <a:off x="8355330" y="1698498"/>
+            <a:ext cx="251460" cy="251460"/>
+          </a:xfrm>
+          <a:prstGeom prst="rect">
+            <a:avLst/>
+          </a:prstGeom>
+        </p:spPr>
+      </p:pic>
+      <p:sp>
+        <p:nvSpPr>
+          <p:cNvPr id="25" name="Text 18"/>
+          <p:cNvSpPr txBox="1"/>
+          <p:nvPr/>
+        </p:nvSpPr>
+        <p:spPr>
+          <a:xfrm>
+            <a:off x="8869680" y="1572768"/>
+            <a:ext cx="2560320" cy="502920"/>
+          </a:xfrm>
+          <a:prstGeom prst="rect">
+            <a:avLst/>
+          </a:prstGeom>
+          <a:noFill/>
+          <a:ln/>
+        </p:spPr>
+        <p:txBody>
+          <a:bodyPr wrap="square" lIns="0" tIns="0" rIns="0" bIns="0" rtlCol="0" anchor="ctr"/>
+          <a:lstStyle/>
+          <a:p>
+            <a:pPr indent="0" marL="0">
+              <a:buNone/>
+            </a:pPr>
+            <a:r>
+              <a:rPr lang="en-US" sz="1700" b="1" dirty="0">
+                <a:solidFill>
+                  <a:srgbClr val="111827"/>
+                </a:solidFill>
+                <a:latin typeface="Calibri" pitchFamily="34" charset="0"/>
+                <a:ea typeface="Calibri" pitchFamily="34" charset="-122"/>
+                <a:cs typeface="Calibri" pitchFamily="34" charset="-120"/>
+              </a:rPr>
+              <a:t>Equipment</a:t>
+            </a:r>
+            <a:endParaRPr lang="en-US" sz="1700" dirty="0"/>
+          </a:p>
+        </p:txBody>
+      </p:sp>
+      <p:sp>
+        <p:nvSpPr>
+          <p:cNvPr id="26" name="Text 19"/>
+          <p:cNvSpPr txBox="1"/>
+          <p:nvPr/>
+        </p:nvSpPr>
+        <p:spPr>
+          <a:xfrm>
+            <a:off x="8229600" y="2148840"/>
+            <a:ext cx="3246120" cy="2240280"/>
+          </a:xfrm>
+          <a:prstGeom prst="rect">
+            <a:avLst/>
+          </a:prstGeom>
+          <a:noFill/>
+          <a:ln/>
+        </p:spPr>
+        <p:txBody>
+          <a:bodyPr wrap="square" lIns="0" tIns="0" rIns="0" bIns="0" rtlCol="0" anchor="t"/>
+          <a:lstStyle/>
+          <a:p>
+            <a:pPr marL="203200" indent="-203200">
+              <a:spcAft>
+                <a:spcPts val="500"/>
+              </a:spcAft>
+              <a:buSzPct val="100000"/>
+              <a:buChar char="•"/>
+            </a:pPr>
+            <a:r>
+              <a:rPr lang="en-US" sz="1150" dirty="0">
+                <a:solidFill>
+                  <a:srgbClr val="1F2937"/>
+                </a:solidFill>
+                <a:latin typeface="Calibri" pitchFamily="34" charset="0"/>
+                <a:ea typeface="Calibri" pitchFamily="34" charset="-122"/>
+                <a:cs typeface="Calibri" pitchFamily="34" charset="-120"/>
+              </a:rPr>
+              <a:t>ANCRA knock-down pallet decks (intermodal)</a:t>
+            </a:r>
+            <a:endParaRPr lang="en-US" sz="1150" dirty="0"/>
+          </a:p>
+          <a:p>
+            <a:pPr marL="203200" indent="-203200">
+              <a:spcAft>
+                <a:spcPts val="500"/>
+              </a:spcAft>
+              <a:buSzPct val="100000"/>
+              <a:buChar char="•"/>
+            </a:pPr>
+            <a:r>
+              <a:rPr lang="en-US" sz="1150" dirty="0">
+                <a:solidFill>
+                  <a:srgbClr val="1F2937"/>
+                </a:solidFill>
+                <a:latin typeface="Calibri" pitchFamily="34" charset="0"/>
+                <a:ea typeface="Calibri" pitchFamily="34" charset="-122"/>
+                <a:cs typeface="Calibri" pitchFamily="34" charset="-120"/>
+              </a:rPr>
+              <a:t>ANCRA security divider deck-board kits (E-track)</a:t>
+            </a:r>
+            <a:endParaRPr lang="en-US" sz="1150" dirty="0"/>
+          </a:p>
+          <a:p>
+            <a:pPr marL="203200" indent="-203200">
+              <a:spcAft>
+                <a:spcPts val="500"/>
+              </a:spcAft>
+              <a:buSzPct val="100000"/>
+              <a:buChar char="•"/>
+            </a:pPr>
+            <a:r>
+              <a:rPr lang="en-US" sz="1150" dirty="0">
+                <a:solidFill>
+                  <a:srgbClr val="1F2937"/>
+                </a:solidFill>
+                <a:latin typeface="Calibri" pitchFamily="34" charset="0"/>
+                <a:ea typeface="Calibri" pitchFamily="34" charset="-122"/>
+                <a:cs typeface="Calibri" pitchFamily="34" charset="-120"/>
+              </a:rPr>
+              <a:t>Panel trucks &amp; reconfigurable racks for windows, doors, panels, car parts (Sawtrax, Rack and Shelf, Grainger, Uline)</a:t>
+            </a:r>
+            <a:endParaRPr lang="en-US" sz="1150" dirty="0"/>
+          </a:p>
+          <a:p>
+            <a:pPr marL="203200" indent="-203200">
+              <a:spcAft>
+                <a:spcPts val="500"/>
+              </a:spcAft>
+              <a:buSzPct val="100000"/>
+              <a:buChar char="•"/>
+            </a:pPr>
+            <a:r>
+              <a:rPr lang="en-US" sz="1150" dirty="0">
+                <a:solidFill>
+                  <a:srgbClr val="1F2937"/>
+                </a:solidFill>
+                <a:latin typeface="Calibri" pitchFamily="34" charset="0"/>
+                <a:ea typeface="Calibri" pitchFamily="34" charset="-122"/>
+                <a:cs typeface="Calibri" pitchFamily="34" charset="-120"/>
+              </a:rPr>
+              <a:t>Load bars &amp; straps on every mixed load</a:t>
+            </a:r>
+            <a:endParaRPr lang="en-US" sz="1150" dirty="0"/>
+          </a:p>
+        </p:txBody>
+      </p:sp>
+      <p:sp>
+        <p:nvSpPr>
+          <p:cNvPr id="27" name="Shape 20"/>
+          <p:cNvSpPr/>
+          <p:nvPr/>
+        </p:nvSpPr>
+        <p:spPr>
+          <a:xfrm>
+            <a:off x="8001000" y="4617720"/>
+            <a:ext cx="3639312" cy="1417320"/>
+          </a:xfrm>
+          <a:prstGeom prst="roundRect">
+            <a:avLst>
+              <a:gd name="adj" fmla="val 5161"/>
+            </a:avLst>
+          </a:prstGeom>
+          <a:solidFill>
+            <a:srgbClr val="FFFBEB"/>
+          </a:solidFill>
+          <a:ln w="12700">
+            <a:solidFill>
+              <a:srgbClr val="FFFBEB"/>
+            </a:solidFill>
+            <a:prstDash val="solid"/>
+          </a:ln>
+        </p:spPr>
+      </p:sp>
+      <p:sp>
+        <p:nvSpPr>
+          <p:cNvPr id="28" name="Text 21"/>
+          <p:cNvSpPr txBox="1"/>
+          <p:nvPr/>
+        </p:nvSpPr>
+        <p:spPr>
+          <a:xfrm>
+            <a:off x="8138160" y="4663440"/>
+            <a:ext cx="3383280" cy="1325880"/>
+          </a:xfrm>
+          <a:prstGeom prst="rect">
+            <a:avLst/>
+          </a:prstGeom>
+          <a:noFill/>
+          <a:ln/>
+        </p:spPr>
+        <p:txBody>
+          <a:bodyPr wrap="square" lIns="0" tIns="0" rIns="0" bIns="0" rtlCol="0" anchor="ctr"/>
+          <a:lstStyle/>
+          <a:p>
+            <a:pPr indent="0" marL="0">
+              <a:buNone/>
+            </a:pPr>
+            <a:r>
+              <a:rPr lang="en-US" sz="950" b="1" dirty="0">
+                <a:solidFill>
+                  <a:srgbClr val="B45309"/>
+                </a:solidFill>
+                <a:latin typeface="Calibri" pitchFamily="34" charset="0"/>
+                <a:ea typeface="Calibri" pitchFamily="34" charset="-122"/>
+                <a:cs typeface="Calibri" pitchFamily="34" charset="-120"/>
+              </a:rPr>
+              <a:t>Example: </a:t>
+            </a:r>
+            <a:pPr indent="0" marL="0">
+              <a:buNone/>
+            </a:pPr>
+            <a:r>
+              <a:rPr lang="en-US" sz="950" dirty="0">
+                <a:solidFill>
+                  <a:srgbClr val="1F2937"/>
+                </a:solidFill>
+                <a:latin typeface="Calibri" pitchFamily="34" charset="0"/>
+                <a:ea typeface="Calibri" pitchFamily="34" charset="-122"/>
+                <a:cs typeface="Calibri" pitchFamily="34" charset="-120"/>
+              </a:rPr>
+              <a:t>MAAX shower doors and bases (thin, all glass) and 75-inch TVs ride standing loose today (trailer 47520). Slot them into panel carts — yellow cart rolls by hand, grey cage lifts by forklift: secured in transit, faster in/out, less breakage.</a:t>
+            </a:r>
+            <a:endParaRPr lang="en-US" sz="950" dirty="0"/>
+          </a:p>
+        </p:txBody>
+      </p:sp>
+      <p:sp>
+        <p:nvSpPr>
+          <p:cNvPr id="29" name="Text 22"/>
+          <p:cNvSpPr txBox="1"/>
+          <p:nvPr/>
+        </p:nvSpPr>
+        <p:spPr>
+          <a:xfrm>
+            <a:off x="548640" y="6473952"/>
+            <a:ext cx="7315200" cy="228600"/>
+          </a:xfrm>
+          <a:prstGeom prst="rect">
+            <a:avLst/>
+          </a:prstGeom>
+          <a:noFill/>
+          <a:ln/>
+        </p:spPr>
+        <p:txBody>
+          <a:bodyPr wrap="square" lIns="0" tIns="0" rIns="0" bIns="0" rtlCol="0" anchor="ctr"/>
+          <a:lstStyle/>
+          <a:p>
+            <a:pPr indent="0" marL="0">
+              <a:buNone/>
+            </a:pPr>
+            <a:r>
+              <a:rPr lang="en-US" sz="900" dirty="0">
+                <a:solidFill>
+                  <a:srgbClr val="9CA3AF"/>
+                </a:solidFill>
+                <a:latin typeface="Calibri" pitchFamily="34" charset="0"/>
+                <a:ea typeface="Calibri" pitchFamily="34" charset="-122"/>
+                <a:cs typeface="Calibri" pitchFamily="34" charset="-120"/>
+              </a:rPr>
+              <a:t>Mississauga Terminal · F27 Senior Leadership Review · Sep 29, 2026</a:t>
+            </a:r>
+            <a:endParaRPr lang="en-US" sz="900" dirty="0"/>
+          </a:p>
+        </p:txBody>
+      </p:sp>
+      <p:sp>
+        <p:nvSpPr>
+          <p:cNvPr id="30" name="Text 23"/>
+          <p:cNvSpPr txBox="1"/>
+          <p:nvPr/>
+        </p:nvSpPr>
+        <p:spPr>
+          <a:xfrm>
+            <a:off x="10725912" y="6473952"/>
+            <a:ext cx="914400" cy="228600"/>
+          </a:xfrm>
+          <a:prstGeom prst="rect">
+            <a:avLst/>
+          </a:prstGeom>
+          <a:noFill/>
+          <a:ln/>
+        </p:spPr>
+        <p:txBody>
+          <a:bodyPr wrap="square" lIns="0" tIns="0" rIns="0" bIns="0" rtlCol="0" anchor="ctr"/>
+          <a:lstStyle/>
+          <a:p>
+            <a:pPr algn="r" indent="0" marL="0">
+              <a:buNone/>
+            </a:pPr>
+            <a:r>
+              <a:rPr lang="en-US" sz="900" dirty="0">
+                <a:solidFill>
+                  <a:srgbClr val="9CA3AF"/>
+                </a:solidFill>
+                <a:latin typeface="Calibri" pitchFamily="34" charset="0"/>
+                <a:ea typeface="Calibri" pitchFamily="34" charset="-122"/>
+                <a:cs typeface="Calibri" pitchFamily="34" charset="-120"/>
+              </a:rPr>
+              <a:t>20 / 24</a:t>
+            </a:r>
+            <a:endParaRPr lang="en-US" sz="900" dirty="0"/>
+          </a:p>
+        </p:txBody>
+      </p:sp>
+    </p:spTree>
+  </p:cSld>
+  <p:clrMapOvr>
+    <a:masterClrMapping/>
+  </p:clrMapOvr>
+</p:sld>
+</file>
+
+<file path=ppt/slides/slide21.xml><?xml version="1.0" encoding="utf-8"?>
+<p:sld xmlns:a="http://schemas.openxmlformats.org/drawingml/2006/main" xmlns:r="http://schemas.openxmlformats.org/officeDocument/2006/relationships" xmlns:p="http://schemas.openxmlformats.org/presentationml/2006/main">
+  <p:cSld name="Slide 21">
+    <p:bg>
+      <p:bgPr>
+        <a:solidFill>
+          <a:srgbClr val="FFFFFF"/>
+        </a:solidFill>
+      </p:bgPr>
+    </p:bg>
+    <p:spTree>
+      <p:nvGrpSpPr>
+        <p:cNvPr id="1" name=""/>
+        <p:cNvGrpSpPr/>
+        <p:nvPr/>
+      </p:nvGrpSpPr>
+      <p:grpSpPr>
+        <a:xfrm>
+          <a:off x="0" y="0"/>
+          <a:ext cx="0" cy="0"/>
+          <a:chOff x="0" y="0"/>
+          <a:chExt cx="0" cy="0"/>
+        </a:xfrm>
+      </p:grpSpPr>
+      <p:sp>
+        <p:nvSpPr>
+          <p:cNvPr id="2" name="Text 0"/>
+          <p:cNvSpPr txBox="1"/>
+          <p:nvPr/>
+        </p:nvSpPr>
+        <p:spPr>
+          <a:xfrm>
+            <a:off x="548640" y="320040"/>
+            <a:ext cx="9144000" cy="274320"/>
+          </a:xfrm>
+          <a:prstGeom prst="rect">
+            <a:avLst/>
+          </a:prstGeom>
+          <a:noFill/>
+          <a:ln/>
+        </p:spPr>
+        <p:txBody>
+          <a:bodyPr wrap="square" lIns="0" tIns="0" rIns="0" bIns="0" rtlCol="0" anchor="ctr"/>
+          <a:lstStyle/>
+          <a:p>
+            <a:pPr indent="0" marL="0">
+              <a:buNone/>
+            </a:pPr>
+            <a:r>
+              <a:rPr lang="en-US" sz="1200" b="1" spc="300" kern="0" dirty="0">
+                <a:solidFill>
+                  <a:srgbClr val="7C3AED"/>
+                </a:solidFill>
+                <a:latin typeface="Calibri" pitchFamily="34" charset="0"/>
+                <a:ea typeface="Calibri" pitchFamily="34" charset="-122"/>
+                <a:cs typeface="Calibri" pitchFamily="34" charset="-120"/>
+              </a:rPr>
+              <a:t>PRODUCTIVITY</a:t>
+            </a:r>
+            <a:endParaRPr lang="en-US" sz="1200" dirty="0"/>
+          </a:p>
+        </p:txBody>
+      </p:sp>
+      <p:sp>
+        <p:nvSpPr>
+          <p:cNvPr id="3" name="Text 1"/>
+          <p:cNvSpPr txBox="1"/>
+          <p:nvPr/>
+        </p:nvSpPr>
+        <p:spPr>
+          <a:xfrm>
+            <a:off x="548640" y="603504"/>
+            <a:ext cx="11091672" cy="603504"/>
+          </a:xfrm>
+          <a:prstGeom prst="rect">
+            <a:avLst/>
+          </a:prstGeom>
+          <a:noFill/>
+          <a:ln/>
+        </p:spPr>
+        <p:txBody>
+          <a:bodyPr wrap="square" lIns="0" tIns="0" rIns="0" bIns="0" rtlCol="0" anchor="t"/>
+          <a:lstStyle/>
+          <a:p>
+            <a:pPr indent="0" marL="0">
+              <a:buNone/>
+            </a:pPr>
+            <a:r>
+              <a:rPr lang="en-US" sz="3000" b="1" dirty="0">
+                <a:solidFill>
+                  <a:srgbClr val="111827"/>
+                </a:solidFill>
+                <a:latin typeface="Calibri" pitchFamily="34" charset="0"/>
+                <a:ea typeface="Calibri" pitchFamily="34" charset="-122"/>
+                <a:cs typeface="Calibri" pitchFamily="34" charset="-120"/>
+              </a:rPr>
               <a:t>CICO — hours saved</a:t>
             </a:r>
             <a:endParaRPr lang="en-US" sz="3000" dirty="0"/>
@@ -29463,7 +30677,7 @@
       </p:sp>
       <p:graphicFrame>
         <p:nvGraphicFramePr>
-          <p:cNvPr id="21" name="Table 0"/>
+          <p:cNvPr id="22" name="Table 0"/>
           <p:cNvGraphicFramePr>
             <a:graphicFrameLocks noGrp="1"/>
           </p:cNvGraphicFramePr>
@@ -31552,7 +32766,7 @@
                 <a:ea typeface="Calibri" pitchFamily="34" charset="-122"/>
                 <a:cs typeface="Calibri" pitchFamily="34" charset="-120"/>
               </a:rPr>
-              <a:t>20 / 23</a:t>
+              <a:t>21 / 24</a:t>
             </a:r>
             <a:endParaRPr lang="en-US" sz="900" dirty="0"/>
           </a:p>
@@ -31566,9 +32780,9 @@
 </p:sld>
 </file>
 
-<file path=ppt/slides/slide21.xml><?xml version="1.0" encoding="utf-8"?>
+<file path=ppt/slides/slide22.xml><?xml version="1.0" encoding="utf-8"?>
 <p:sld xmlns:a="http://schemas.openxmlformats.org/drawingml/2006/main" xmlns:r="http://schemas.openxmlformats.org/officeDocument/2006/relationships" xmlns:p="http://schemas.openxmlformats.org/presentationml/2006/main">
-  <p:cSld name="Slide 21">
+  <p:cSld name="Slide 22">
     <p:bg>
       <p:bgPr>
         <a:solidFill>
@@ -32241,7 +33455,7 @@
                 <a:ea typeface="Calibri" pitchFamily="34" charset="-122"/>
                 <a:cs typeface="Calibri" pitchFamily="34" charset="-120"/>
               </a:rPr>
-              <a:t>21 / 23</a:t>
+              <a:t>22 / 24</a:t>
             </a:r>
             <a:endParaRPr lang="en-US" sz="900" dirty="0"/>
           </a:p>
@@ -32255,9 +33469,9 @@
 </p:sld>
 </file>
 
-<file path=ppt/slides/slide22.xml><?xml version="1.0" encoding="utf-8"?>
+<file path=ppt/slides/slide23.xml><?xml version="1.0" encoding="utf-8"?>
 <p:sld xmlns:a="http://schemas.openxmlformats.org/drawingml/2006/main" xmlns:r="http://schemas.openxmlformats.org/officeDocument/2006/relationships" xmlns:p="http://schemas.openxmlformats.org/presentationml/2006/main">
-  <p:cSld name="Slide 22">
+  <p:cSld name="Slide 23">
     <p:bg>
       <p:bgPr>
         <a:solidFill>
@@ -33609,7 +34823,7 @@
                 <a:ea typeface="Calibri" pitchFamily="34" charset="-122"/>
                 <a:cs typeface="Calibri" pitchFamily="34" charset="-120"/>
               </a:rPr>
-              <a:t>22 / 23</a:t>
+              <a:t>23 / 24</a:t>
             </a:r>
             <a:endParaRPr lang="en-US" sz="900" dirty="0"/>
           </a:p>
@@ -33623,9 +34837,9 @@
 </p:sld>
 </file>
 
-<file path=ppt/slides/slide23.xml><?xml version="1.0" encoding="utf-8"?>
+<file path=ppt/slides/slide24.xml><?xml version="1.0" encoding="utf-8"?>
 <p:sld xmlns:a="http://schemas.openxmlformats.org/drawingml/2006/main" xmlns:r="http://schemas.openxmlformats.org/officeDocument/2006/relationships" xmlns:p="http://schemas.openxmlformats.org/presentationml/2006/main">
-  <p:cSld name="Slide 23">
+  <p:cSld name="Slide 24">
     <p:bg>
       <p:bgPr>
         <a:solidFill>
@@ -34836,7 +36050,7 @@
                 <a:ea typeface="Calibri" pitchFamily="34" charset="-122"/>
                 <a:cs typeface="Calibri" pitchFamily="34" charset="-120"/>
               </a:rPr>
-              <a:t>0 recordables F27, TRIR 0.00 vs 1.21 F26 · 384 days since last recordable · Initiatives: 3 completed · 7 active · 1 planned (freight-handling equipment).</a:t>
+              <a:t>0 recordables F27, TRIR 0.00 vs 1.21 F26 · 384 days since last recordable · Initiatives: 3 completed · 7 active · 2 planned (load securement &amp; decking; freight-handling equipment).</a:t>
             </a:r>
             <a:endParaRPr lang="en-US" sz="1000" dirty="0"/>
           </a:p>
@@ -34914,7 +36128,7 @@
                 <a:ea typeface="Calibri" pitchFamily="34" charset="-122"/>
                 <a:cs typeface="Calibri" pitchFamily="34" charset="-120"/>
               </a:rPr>
-              <a:t>23 / 23</a:t>
+              <a:t>24 / 24</a:t>
             </a:r>
             <a:endParaRPr lang="en-US" sz="900" dirty="0"/>
           </a:p>
@@ -36406,7 +37620,7 @@
                 <a:ea typeface="Calibri" pitchFamily="34" charset="-122"/>
                 <a:cs typeface="Calibri" pitchFamily="34" charset="-120"/>
               </a:rPr>
-              <a:t>3 / 23</a:t>
+              <a:t>3 / 24</a:t>
             </a:r>
             <a:endParaRPr lang="en-US" sz="900" dirty="0"/>
           </a:p>
@@ -37166,7 +38380,7 @@
                 <a:ea typeface="Calibri" pitchFamily="34" charset="-122"/>
                 <a:cs typeface="Calibri" pitchFamily="34" charset="-120"/>
               </a:rPr>
-              <a:t>1 planned</a:t>
+              <a:t>2 planned</a:t>
             </a:r>
             <a:endParaRPr lang="en-US" sz="1050" dirty="0"/>
           </a:p>
@@ -37197,7 +38411,7 @@
               <a:buNone/>
             </a:pPr>
             <a:r>
-              <a:rPr lang="en-US" sz="1200" b="1" dirty="0">
+              <a:rPr lang="en-US" sz="1100" b="1" dirty="0">
                 <a:solidFill>
                   <a:srgbClr val="111827"/>
                 </a:solidFill>
@@ -37205,13 +38419,44 @@
                 <a:ea typeface="Calibri" pitchFamily="34" charset="-122"/>
                 <a:cs typeface="Calibri" pitchFamily="34" charset="-120"/>
               </a:rPr>
+              <a:t>Load securement &amp; decking </a:t>
+            </a:r>
+            <a:pPr indent="0" marL="0">
+              <a:buNone/>
+            </a:pPr>
+            <a:r>
+              <a:rPr lang="en-US" sz="1100" dirty="0">
+                <a:solidFill>
+                  <a:srgbClr val="1F2937"/>
+                </a:solidFill>
+                <a:latin typeface="Calibri" pitchFamily="34" charset="0"/>
+                <a:ea typeface="Calibri" pitchFamily="34" charset="-122"/>
+                <a:cs typeface="Calibri" pitchFamily="34" charset="-120"/>
+              </a:rPr>
+              <a:t>(ANCRA decks, divider deck-board kits).</a:t>
+            </a:r>
+            <a:endParaRPr lang="en-US" sz="1100" dirty="0"/>
+          </a:p>
+          <a:p>
+            <a:pPr indent="0" marL="0">
+              <a:buNone/>
+            </a:pPr>
+            <a:r>
+              <a:rPr lang="en-US" sz="1100" b="1" dirty="0">
+                <a:solidFill>
+                  <a:srgbClr val="111827"/>
+                </a:solidFill>
+                <a:latin typeface="Calibri" pitchFamily="34" charset="0"/>
+                <a:ea typeface="Calibri" pitchFamily="34" charset="-122"/>
+                <a:cs typeface="Calibri" pitchFamily="34" charset="-120"/>
+              </a:rPr>
               <a:t>Freight-handling equipment: </a:t>
             </a:r>
             <a:pPr indent="0" marL="0">
               <a:buNone/>
             </a:pPr>
             <a:r>
-              <a:rPr lang="en-US" sz="1200" dirty="0">
+              <a:rPr lang="en-US" sz="1100" dirty="0">
                 <a:solidFill>
                   <a:srgbClr val="1F2937"/>
                 </a:solidFill>
@@ -37221,14 +38466,14 @@
               </a:rPr>
               <a:t>panel trucks &amp; reconfigurable racks for windows, panels and car parts (Sawtrax, Rack and Shelf, Grainger vertical panel truck 1,800 lb, Uline carpeted panel truck).</a:t>
             </a:r>
-            <a:endParaRPr lang="en-US" sz="1200" dirty="0"/>
-          </a:p>
-          <a:p>
-            <a:pPr indent="0" marL="0">
-              <a:buNone/>
-            </a:pPr>
-            <a:r>
-              <a:rPr lang="en-US" sz="1200" b="1" dirty="0">
+            <a:endParaRPr lang="en-US" sz="1100" dirty="0"/>
+          </a:p>
+          <a:p>
+            <a:pPr indent="0" marL="0">
+              <a:buNone/>
+            </a:pPr>
+            <a:r>
+              <a:rPr lang="en-US" sz="1100" b="1" dirty="0">
                 <a:solidFill>
                   <a:srgbClr val="059669"/>
                 </a:solidFill>
@@ -37238,7 +38483,7 @@
               </a:rPr>
               <a:t>→ Safer handling, better load quality, fewer damages (damaged FB 1.61%, 7-day avg).</a:t>
             </a:r>
-            <a:endParaRPr lang="en-US" sz="1200" dirty="0"/>
+            <a:endParaRPr lang="en-US" sz="1100" dirty="0"/>
           </a:p>
         </p:txBody>
       </p:sp>
@@ -37555,7 +38800,7 @@
                 <a:ea typeface="Calibri" pitchFamily="34" charset="-122"/>
                 <a:cs typeface="Calibri" pitchFamily="34" charset="-120"/>
               </a:rPr>
-              <a:t>4 / 23</a:t>
+              <a:t>4 / 24</a:t>
             </a:r>
             <a:endParaRPr lang="en-US" sz="900" dirty="0"/>
           </a:p>
@@ -38960,7 +40205,7 @@
                 <a:ea typeface="Calibri" pitchFamily="34" charset="-122"/>
                 <a:cs typeface="Calibri" pitchFamily="34" charset="-120"/>
               </a:rPr>
-              <a:t>5 / 23</a:t>
+              <a:t>5 / 24</a:t>
             </a:r>
             <a:endParaRPr lang="en-US" sz="900" dirty="0"/>
           </a:p>
@@ -41942,7 +43187,7 @@
                 <a:ea typeface="Calibri" pitchFamily="34" charset="-122"/>
                 <a:cs typeface="Calibri" pitchFamily="34" charset="-120"/>
               </a:rPr>
-              <a:t>6 / 23</a:t>
+              <a:t>6 / 24</a:t>
             </a:r>
             <a:endParaRPr lang="en-US" sz="900" dirty="0"/>
           </a:p>
@@ -43549,7 +44794,7 @@
                 <a:ea typeface="Calibri" pitchFamily="34" charset="-122"/>
                 <a:cs typeface="Calibri" pitchFamily="34" charset="-120"/>
               </a:rPr>
-              <a:t>7 / 23</a:t>
+              <a:t>7 / 24</a:t>
             </a:r>
             <a:endParaRPr lang="en-US" sz="900" dirty="0"/>
           </a:p>
@@ -44892,7 +46137,7 @@
                 <a:ea typeface="Calibri" pitchFamily="34" charset="-122"/>
                 <a:cs typeface="Calibri" pitchFamily="34" charset="-120"/>
               </a:rPr>
-              <a:t>8 / 23</a:t>
+              <a:t>8 / 24</a:t>
             </a:r>
             <a:endParaRPr lang="en-US" sz="900" dirty="0"/>
           </a:p>
@@ -45997,7 +47242,7 @@
                 <a:ea typeface="Calibri" pitchFamily="34" charset="-122"/>
                 <a:cs typeface="Calibri" pitchFamily="34" charset="-120"/>
               </a:rPr>
-              <a:t>9 / 23</a:t>
+              <a:t>9 / 24</a:t>
             </a:r>
             <a:endParaRPr lang="en-US" sz="900" dirty="0"/>
           </a:p>

</xml_diff>

<commit_message>
F27 Initiatives tab (tracked like F26): target, identified, gap, breakdown, status cards; deck glass photos
Co-Authored-By: Claude Opus 5.5 <noreply@anthropic.com>
Claude-Session: https://claude.ai/code/session_01BwRjju3y2wk3wSHFrM9KLe
</commit_message>
<xml_diff>
--- a/presentation/Mississauga_F27_Leadership_Review_Sep29.pptx
+++ b/presentation/Mississauga_F27_Leadership_Review_Sep29.pptx
@@ -5770,7 +5770,7 @@
           <a:p>
             <a:r>
               <a:rPr lang="en-US" dirty="0"/>
-              <a:t>This is what good and bad loads look like on our dock. The target loads use a deck beam or deck board to build a second tier and are strapped; the fix examples are loose freight on a diagonal and floor-only loads with the top half of the trailer empty. We plan to add ANCRA knock-down pallet decks and divider deck-board kits, panel trucks and racks for windows, doors, panels and car parts, and load bars and straps on every mixed load, to lift load factor, reduce damages and claims, and make unloading safer. For example, MAAX shower doors and bases and 75-inch TVs currently ride standing loose, as on trailer 47520; slotting them into panel carts, the yellow cart by hand or the grey cage by forklift, secures them in transit, speeds loading and unloading, and cuts breakage.</a:t>
+              <a:t>This is what good and bad loads look like on our dock. The target loads use a deck beam or deck board to build a second tier and are strapped; the fix examples are loose freight on a diagonal and MAAX glass shower doors on improvised wooden A-frames or leaning in transit. We plan to add ANCRA knock-down pallet decks and divider deck-board kits, panel trucks and racks for windows, doors, panels and car parts, and load bars and straps on every mixed load, to lift load factor, reduce damages and claims, and make unloading safer. For example, MAAX shower doors and bases and 75-inch TVs currently ride standing loose, as on trailer 47520; slotting them into panel carts, the yellow cart by hand or the grey cage by forklift, secures them in transit, speeds loading and unloading, and cuts breakage.</a:t>
             </a:r>
             <a:endParaRPr lang="en-US" dirty="0"/>
           </a:p>
@@ -29559,11 +29559,11 @@
         <p:spPr>
           <a:xfrm>
             <a:off x="548640" y="1371600"/>
-            <a:ext cx="1700784" cy="292608"/>
+            <a:ext cx="1347826" cy="274320"/>
           </a:xfrm>
           <a:prstGeom prst="roundRect">
             <a:avLst>
-              <a:gd name="adj" fmla="val 25000"/>
+              <a:gd name="adj" fmla="val 26667"/>
             </a:avLst>
           </a:prstGeom>
           <a:solidFill>
@@ -29586,7 +29586,7 @@
         <p:spPr>
           <a:xfrm>
             <a:off x="548640" y="1371600"/>
-            <a:ext cx="1700784" cy="292608"/>
+            <a:ext cx="1347826" cy="274320"/>
           </a:xfrm>
           <a:prstGeom prst="rect">
             <a:avLst/>
@@ -29602,7 +29602,7 @@
               <a:buNone/>
             </a:pPr>
             <a:r>
-              <a:rPr lang="en-US" sz="1100" b="1" spc="200" kern="0" dirty="0">
+              <a:rPr lang="en-US" sz="1000" b="1" spc="100" kern="0" dirty="0">
                 <a:solidFill>
                   <a:srgbClr val="059669"/>
                 </a:solidFill>
@@ -29612,13 +29612,13 @@
               </a:rPr>
               <a:t>TARGET</a:t>
             </a:r>
-            <a:endParaRPr lang="en-US" sz="1100" dirty="0"/>
+            <a:endParaRPr lang="en-US" sz="1000" dirty="0"/>
           </a:p>
         </p:txBody>
       </p:sp>
       <p:pic>
         <p:nvPicPr>
-          <p:cNvPr id="6" name="Image 0" descr="570260 — deck beam builds a second tier">    </p:cNvPr>
+          <p:cNvPr id="6" name="Image 0" descr="570260 — deck beam, 2nd tier">    </p:cNvPr>
           <p:cNvPicPr>
             <a:picLocks noChangeAspect="1"/>
           </p:cNvPicPr>
@@ -29626,14 +29626,13 @@
         </p:nvPicPr>
         <p:blipFill>
           <a:blip r:embed="rId1"/>
-          <a:stretch>
-            <a:fillRect/>
-          </a:stretch>
+          <a:srcRect l="0" r="0" t="0" b="0"/>
+          <a:stretch/>
         </p:blipFill>
         <p:spPr>
           <a:xfrm>
-            <a:off x="548640" y="1737360"/>
-            <a:ext cx="1700784" cy="2267712"/>
+            <a:off x="548640" y="1719072"/>
+            <a:ext cx="1347826" cy="1797101"/>
           </a:xfrm>
           <a:prstGeom prst="rect">
             <a:avLst/>
@@ -29648,8 +29647,8 @@
         </p:nvSpPr>
         <p:spPr>
           <a:xfrm>
-            <a:off x="548640" y="4059936"/>
-            <a:ext cx="1700784" cy="502920"/>
+            <a:off x="548640" y="3561893"/>
+            <a:ext cx="1347826" cy="411480"/>
           </a:xfrm>
           <a:prstGeom prst="rect">
             <a:avLst/>
@@ -29665,7 +29664,7 @@
               <a:buNone/>
             </a:pPr>
             <a:r>
-              <a:rPr lang="en-US" sz="950" dirty="0">
+              <a:rPr lang="en-US" sz="900" dirty="0">
                 <a:solidFill>
                   <a:srgbClr val="1F2937"/>
                 </a:solidFill>
@@ -29673,9 +29672,9 @@
                 <a:ea typeface="Calibri" pitchFamily="34" charset="-122"/>
                 <a:cs typeface="Calibri" pitchFamily="34" charset="-120"/>
               </a:rPr>
-              <a:t>570260 — deck beam builds a second tier</a:t>
-            </a:r>
-            <a:endParaRPr lang="en-US" sz="950" dirty="0"/>
+              <a:t>570260 — deck beam, 2nd tier</a:t>
+            </a:r>
+            <a:endParaRPr lang="en-US" sz="900" dirty="0"/>
           </a:p>
         </p:txBody>
       </p:sp>
@@ -29687,12 +29686,12 @@
         </p:nvSpPr>
         <p:spPr>
           <a:xfrm>
-            <a:off x="2377440" y="1371600"/>
-            <a:ext cx="1700784" cy="292608"/>
+            <a:off x="2006194" y="1371600"/>
+            <a:ext cx="1347826" cy="274320"/>
           </a:xfrm>
           <a:prstGeom prst="roundRect">
             <a:avLst>
-              <a:gd name="adj" fmla="val 25000"/>
+              <a:gd name="adj" fmla="val 26667"/>
             </a:avLst>
           </a:prstGeom>
           <a:solidFill>
@@ -29714,8 +29713,8 @@
         </p:nvSpPr>
         <p:spPr>
           <a:xfrm>
-            <a:off x="2377440" y="1371600"/>
-            <a:ext cx="1700784" cy="292608"/>
+            <a:off x="2006194" y="1371600"/>
+            <a:ext cx="1347826" cy="274320"/>
           </a:xfrm>
           <a:prstGeom prst="rect">
             <a:avLst/>
@@ -29731,7 +29730,7 @@
               <a:buNone/>
             </a:pPr>
             <a:r>
-              <a:rPr lang="en-US" sz="1100" b="1" spc="200" kern="0" dirty="0">
+              <a:rPr lang="en-US" sz="1000" b="1" spc="100" kern="0" dirty="0">
                 <a:solidFill>
                   <a:srgbClr val="059669"/>
                 </a:solidFill>
@@ -29741,13 +29740,13 @@
               </a:rPr>
               <a:t>TARGET</a:t>
             </a:r>
-            <a:endParaRPr lang="en-US" sz="1100" dirty="0"/>
+            <a:endParaRPr lang="en-US" sz="1000" dirty="0"/>
           </a:p>
         </p:txBody>
       </p:sp>
       <p:pic>
         <p:nvPicPr>
-          <p:cNvPr id="10" name="Image 1" descr="470275 — deck board overhead + strap">    </p:cNvPr>
+          <p:cNvPr id="10" name="Image 1" descr="470275 — deck board + strap">    </p:cNvPr>
           <p:cNvPicPr>
             <a:picLocks noChangeAspect="1"/>
           </p:cNvPicPr>
@@ -29755,14 +29754,13 @@
         </p:nvPicPr>
         <p:blipFill>
           <a:blip r:embed="rId2"/>
-          <a:stretch>
-            <a:fillRect/>
-          </a:stretch>
+          <a:srcRect l="0" r="0" t="0" b="0"/>
+          <a:stretch/>
         </p:blipFill>
         <p:spPr>
           <a:xfrm>
-            <a:off x="2377440" y="1737360"/>
-            <a:ext cx="1700784" cy="2267712"/>
+            <a:off x="2006194" y="1719072"/>
+            <a:ext cx="1347826" cy="1797101"/>
           </a:xfrm>
           <a:prstGeom prst="rect">
             <a:avLst/>
@@ -29777,8 +29775,8 @@
         </p:nvSpPr>
         <p:spPr>
           <a:xfrm>
-            <a:off x="2377440" y="4059936"/>
-            <a:ext cx="1700784" cy="502920"/>
+            <a:off x="2006194" y="3561893"/>
+            <a:ext cx="1347826" cy="411480"/>
           </a:xfrm>
           <a:prstGeom prst="rect">
             <a:avLst/>
@@ -29794,7 +29792,7 @@
               <a:buNone/>
             </a:pPr>
             <a:r>
-              <a:rPr lang="en-US" sz="950" dirty="0">
+              <a:rPr lang="en-US" sz="900" dirty="0">
                 <a:solidFill>
                   <a:srgbClr val="1F2937"/>
                 </a:solidFill>
@@ -29802,9 +29800,9 @@
                 <a:ea typeface="Calibri" pitchFamily="34" charset="-122"/>
                 <a:cs typeface="Calibri" pitchFamily="34" charset="-120"/>
               </a:rPr>
-              <a:t>470275 — deck board overhead + strap</a:t>
-            </a:r>
-            <a:endParaRPr lang="en-US" sz="950" dirty="0"/>
+              <a:t>470275 — deck board + strap</a:t>
+            </a:r>
+            <a:endParaRPr lang="en-US" sz="900" dirty="0"/>
           </a:p>
         </p:txBody>
       </p:sp>
@@ -29816,12 +29814,12 @@
         </p:nvSpPr>
         <p:spPr>
           <a:xfrm>
-            <a:off x="4206240" y="1371600"/>
-            <a:ext cx="1700784" cy="292608"/>
+            <a:off x="3463747" y="1371600"/>
+            <a:ext cx="1347826" cy="274320"/>
           </a:xfrm>
           <a:prstGeom prst="roundRect">
             <a:avLst>
-              <a:gd name="adj" fmla="val 25000"/>
+              <a:gd name="adj" fmla="val 26667"/>
             </a:avLst>
           </a:prstGeom>
           <a:solidFill>
@@ -29843,8 +29841,8 @@
         </p:nvSpPr>
         <p:spPr>
           <a:xfrm>
-            <a:off x="4206240" y="1371600"/>
-            <a:ext cx="1700784" cy="292608"/>
+            <a:off x="3463747" y="1371600"/>
+            <a:ext cx="1347826" cy="274320"/>
           </a:xfrm>
           <a:prstGeom prst="rect">
             <a:avLst/>
@@ -29860,7 +29858,7 @@
               <a:buNone/>
             </a:pPr>
             <a:r>
-              <a:rPr lang="en-US" sz="1100" b="1" spc="200" kern="0" dirty="0">
+              <a:rPr lang="en-US" sz="1000" b="1" spc="100" kern="0" dirty="0">
                 <a:solidFill>
                   <a:srgbClr val="DC2626"/>
                 </a:solidFill>
@@ -29870,13 +29868,13 @@
               </a:rPr>
               <a:t>FIX</a:t>
             </a:r>
-            <a:endParaRPr lang="en-US" sz="1100" dirty="0"/>
+            <a:endParaRPr lang="en-US" sz="1000" dirty="0"/>
           </a:p>
         </p:txBody>
       </p:sp>
       <p:pic>
         <p:nvPicPr>
-          <p:cNvPr id="14" name="Image 2" descr="470236 — loose freight on a diagonal: damage risk, wasted cube">    </p:cNvPr>
+          <p:cNvPr id="14" name="Image 2" descr="470236 — loose on a diagonal">    </p:cNvPr>
           <p:cNvPicPr>
             <a:picLocks noChangeAspect="1"/>
           </p:cNvPicPr>
@@ -29884,14 +29882,13 @@
         </p:nvPicPr>
         <p:blipFill>
           <a:blip r:embed="rId3"/>
-          <a:stretch>
-            <a:fillRect/>
-          </a:stretch>
+          <a:srcRect l="0" r="0" t="0" b="0"/>
+          <a:stretch/>
         </p:blipFill>
         <p:spPr>
           <a:xfrm>
-            <a:off x="4206240" y="1737360"/>
-            <a:ext cx="1700784" cy="2267712"/>
+            <a:off x="3463747" y="1719072"/>
+            <a:ext cx="1347826" cy="1797101"/>
           </a:xfrm>
           <a:prstGeom prst="rect">
             <a:avLst/>
@@ -29906,8 +29903,8 @@
         </p:nvSpPr>
         <p:spPr>
           <a:xfrm>
-            <a:off x="4206240" y="4059936"/>
-            <a:ext cx="1700784" cy="502920"/>
+            <a:off x="3463747" y="3561893"/>
+            <a:ext cx="1347826" cy="411480"/>
           </a:xfrm>
           <a:prstGeom prst="rect">
             <a:avLst/>
@@ -29923,7 +29920,7 @@
               <a:buNone/>
             </a:pPr>
             <a:r>
-              <a:rPr lang="en-US" sz="950" dirty="0">
+              <a:rPr lang="en-US" sz="900" dirty="0">
                 <a:solidFill>
                   <a:srgbClr val="1F2937"/>
                 </a:solidFill>
@@ -29931,9 +29928,9 @@
                 <a:ea typeface="Calibri" pitchFamily="34" charset="-122"/>
                 <a:cs typeface="Calibri" pitchFamily="34" charset="-120"/>
               </a:rPr>
-              <a:t>470236 — loose freight on a diagonal: damage risk, wasted cube</a:t>
-            </a:r>
-            <a:endParaRPr lang="en-US" sz="950" dirty="0"/>
+              <a:t>470236 — loose on a diagonal</a:t>
+            </a:r>
+            <a:endParaRPr lang="en-US" sz="900" dirty="0"/>
           </a:p>
         </p:txBody>
       </p:sp>
@@ -29945,12 +29942,12 @@
         </p:nvSpPr>
         <p:spPr>
           <a:xfrm>
-            <a:off x="6035040" y="1371600"/>
-            <a:ext cx="1700784" cy="292608"/>
+            <a:off x="4921301" y="1371600"/>
+            <a:ext cx="1347826" cy="274320"/>
           </a:xfrm>
           <a:prstGeom prst="roundRect">
             <a:avLst>
-              <a:gd name="adj" fmla="val 25000"/>
+              <a:gd name="adj" fmla="val 26667"/>
             </a:avLst>
           </a:prstGeom>
           <a:solidFill>
@@ -29972,8 +29969,8 @@
         </p:nvSpPr>
         <p:spPr>
           <a:xfrm>
-            <a:off x="6035040" y="1371600"/>
-            <a:ext cx="1700784" cy="292608"/>
+            <a:off x="4921301" y="1371600"/>
+            <a:ext cx="1347826" cy="274320"/>
           </a:xfrm>
           <a:prstGeom prst="rect">
             <a:avLst/>
@@ -29989,7 +29986,7 @@
               <a:buNone/>
             </a:pPr>
             <a:r>
-              <a:rPr lang="en-US" sz="1100" b="1" spc="200" kern="0" dirty="0">
+              <a:rPr lang="en-US" sz="1000" b="1" spc="100" kern="0" dirty="0">
                 <a:solidFill>
                   <a:srgbClr val="DC2626"/>
                 </a:solidFill>
@@ -29997,15 +29994,15 @@
                 <a:ea typeface="Calibri" pitchFamily="34" charset="-122"/>
                 <a:cs typeface="Calibri" pitchFamily="34" charset="-120"/>
               </a:rPr>
-              <a:t>FIX</a:t>
-            </a:r>
-            <a:endParaRPr lang="en-US" sz="1100" dirty="0"/>
+              <a:t>FIX · MAAX</a:t>
+            </a:r>
+            <a:endParaRPr lang="en-US" sz="1000" dirty="0"/>
           </a:p>
         </p:txBody>
       </p:sp>
       <p:pic>
         <p:nvPicPr>
-          <p:cNvPr id="18" name="Image 3" descr="570419 — floor-loaded only, top half empty">    </p:cNvPr>
+          <p:cNvPr id="18" name="Image 3" descr="57937 — glass doors on improvised A-frames">    </p:cNvPr>
           <p:cNvPicPr>
             <a:picLocks noChangeAspect="1"/>
           </p:cNvPicPr>
@@ -30013,14 +30010,13 @@
         </p:nvPicPr>
         <p:blipFill>
           <a:blip r:embed="rId4"/>
-          <a:stretch>
-            <a:fillRect/>
-          </a:stretch>
+          <a:srcRect l="0" r="0" t="0" b="0"/>
+          <a:stretch/>
         </p:blipFill>
         <p:spPr>
           <a:xfrm>
-            <a:off x="6035040" y="1737360"/>
-            <a:ext cx="1700784" cy="2267712"/>
+            <a:off x="4921301" y="1719072"/>
+            <a:ext cx="1347826" cy="1797101"/>
           </a:xfrm>
           <a:prstGeom prst="rect">
             <a:avLst/>
@@ -30035,8 +30031,8 @@
         </p:nvSpPr>
         <p:spPr>
           <a:xfrm>
-            <a:off x="6035040" y="4059936"/>
-            <a:ext cx="1700784" cy="502920"/>
+            <a:off x="4921301" y="3561893"/>
+            <a:ext cx="1347826" cy="411480"/>
           </a:xfrm>
           <a:prstGeom prst="rect">
             <a:avLst/>
@@ -30052,7 +30048,7 @@
               <a:buNone/>
             </a:pPr>
             <a:r>
-              <a:rPr lang="en-US" sz="950" dirty="0">
+              <a:rPr lang="en-US" sz="900" dirty="0">
                 <a:solidFill>
                   <a:srgbClr val="1F2937"/>
                 </a:solidFill>
@@ -30060,9 +30056,9 @@
                 <a:ea typeface="Calibri" pitchFamily="34" charset="-122"/>
                 <a:cs typeface="Calibri" pitchFamily="34" charset="-120"/>
               </a:rPr>
-              <a:t>570419 — floor-loaded only, top half empty</a:t>
-            </a:r>
-            <a:endParaRPr lang="en-US" sz="950" dirty="0"/>
+              <a:t>57937 — glass doors on improvised A-frames</a:t>
+            </a:r>
+            <a:endParaRPr lang="en-US" sz="900" dirty="0"/>
           </a:p>
         </p:txBody>
       </p:sp>
@@ -30074,12 +30070,140 @@
         </p:nvSpPr>
         <p:spPr>
           <a:xfrm>
-            <a:off x="548640" y="4709160"/>
-            <a:ext cx="7187184" cy="1325880"/>
+            <a:off x="6378854" y="1371600"/>
+            <a:ext cx="1347826" cy="274320"/>
           </a:xfrm>
           <a:prstGeom prst="roundRect">
             <a:avLst>
-              <a:gd name="adj" fmla="val 5517"/>
+              <a:gd name="adj" fmla="val 26667"/>
+            </a:avLst>
+          </a:prstGeom>
+          <a:solidFill>
+            <a:srgbClr val="FEE2E2"/>
+          </a:solidFill>
+          <a:ln w="12700">
+            <a:solidFill>
+              <a:srgbClr val="FEE2E2"/>
+            </a:solidFill>
+            <a:prstDash val="solid"/>
+          </a:ln>
+        </p:spPr>
+      </p:sp>
+      <p:sp>
+        <p:nvSpPr>
+          <p:cNvPr id="21" name="Text 15"/>
+          <p:cNvSpPr txBox="1"/>
+          <p:nvPr/>
+        </p:nvSpPr>
+        <p:spPr>
+          <a:xfrm>
+            <a:off x="6378854" y="1371600"/>
+            <a:ext cx="1347826" cy="274320"/>
+          </a:xfrm>
+          <a:prstGeom prst="rect">
+            <a:avLst/>
+          </a:prstGeom>
+          <a:noFill/>
+          <a:ln/>
+        </p:spPr>
+        <p:txBody>
+          <a:bodyPr wrap="square" lIns="0" tIns="0" rIns="0" bIns="0" rtlCol="0" anchor="ctr"/>
+          <a:lstStyle/>
+          <a:p>
+            <a:pPr algn="ctr" indent="0" marL="0">
+              <a:buNone/>
+            </a:pPr>
+            <a:r>
+              <a:rPr lang="en-US" sz="1000" b="1" spc="100" kern="0" dirty="0">
+                <a:solidFill>
+                  <a:srgbClr val="DC2626"/>
+                </a:solidFill>
+                <a:latin typeface="Calibri" pitchFamily="34" charset="0"/>
+                <a:ea typeface="Calibri" pitchFamily="34" charset="-122"/>
+                <a:cs typeface="Calibri" pitchFamily="34" charset="-120"/>
+              </a:rPr>
+              <a:t>FIX · MAAX</a:t>
+            </a:r>
+            <a:endParaRPr lang="en-US" sz="1000" dirty="0"/>
+          </a:p>
+        </p:txBody>
+      </p:sp>
+      <p:pic>
+        <p:nvPicPr>
+          <p:cNvPr id="22" name="Image 4" descr="Door boxes leaning / toppling">    </p:cNvPr>
+          <p:cNvPicPr>
+            <a:picLocks noChangeAspect="1"/>
+          </p:cNvPicPr>
+          <p:nvPr/>
+        </p:nvPicPr>
+        <p:blipFill>
+          <a:blip r:embed="rId5"/>
+          <a:srcRect l="0" r="0" t="0" b="0"/>
+          <a:stretch/>
+        </p:blipFill>
+        <p:spPr>
+          <a:xfrm>
+            <a:off x="6378854" y="1719072"/>
+            <a:ext cx="1347826" cy="1797101"/>
+          </a:xfrm>
+          <a:prstGeom prst="rect">
+            <a:avLst/>
+          </a:prstGeom>
+        </p:spPr>
+      </p:pic>
+      <p:sp>
+        <p:nvSpPr>
+          <p:cNvPr id="23" name="Text 16"/>
+          <p:cNvSpPr txBox="1"/>
+          <p:nvPr/>
+        </p:nvSpPr>
+        <p:spPr>
+          <a:xfrm>
+            <a:off x="6378854" y="3561893"/>
+            <a:ext cx="1347826" cy="411480"/>
+          </a:xfrm>
+          <a:prstGeom prst="rect">
+            <a:avLst/>
+          </a:prstGeom>
+          <a:noFill/>
+          <a:ln/>
+        </p:spPr>
+        <p:txBody>
+          <a:bodyPr wrap="square" lIns="0" tIns="0" rIns="0" bIns="0" rtlCol="0" anchor="t"/>
+          <a:lstStyle/>
+          <a:p>
+            <a:pPr indent="0" marL="0">
+              <a:buNone/>
+            </a:pPr>
+            <a:r>
+              <a:rPr lang="en-US" sz="900" dirty="0">
+                <a:solidFill>
+                  <a:srgbClr val="1F2937"/>
+                </a:solidFill>
+                <a:latin typeface="Calibri" pitchFamily="34" charset="0"/>
+                <a:ea typeface="Calibri" pitchFamily="34" charset="-122"/>
+                <a:cs typeface="Calibri" pitchFamily="34" charset="-120"/>
+              </a:rPr>
+              <a:t>Door boxes leaning / toppling</a:t>
+            </a:r>
+            <a:endParaRPr lang="en-US" sz="900" dirty="0"/>
+          </a:p>
+        </p:txBody>
+      </p:sp>
+      <p:sp>
+        <p:nvSpPr>
+          <p:cNvPr id="24" name="Shape 17"/>
+          <p:cNvSpPr/>
+          <p:nvPr/>
+        </p:nvSpPr>
+        <p:spPr>
+          <a:xfrm>
+            <a:off x="548640" y="4069080"/>
+            <a:ext cx="4189781" cy="1965960"/>
+          </a:xfrm>
+          <a:prstGeom prst="roundRect">
+            <a:avLst>
+              <a:gd name="adj" fmla="val 3721"/>
             </a:avLst>
           </a:prstGeom>
           <a:solidFill>
@@ -30095,14 +30219,14 @@
       </p:sp>
       <p:sp>
         <p:nvSpPr>
-          <p:cNvPr id="21" name="Text 15"/>
-          <p:cNvSpPr txBox="1"/>
-          <p:nvPr/>
-        </p:nvSpPr>
-        <p:spPr>
-          <a:xfrm>
-            <a:off x="731520" y="4754880"/>
-            <a:ext cx="6858000" cy="1234440"/>
+          <p:cNvPr id="25" name="Text 18"/>
+          <p:cNvSpPr txBox="1"/>
+          <p:nvPr/>
+        </p:nvSpPr>
+        <p:spPr>
+          <a:xfrm>
+            <a:off x="731520" y="4114800"/>
+            <a:ext cx="3869741" cy="1874520"/>
           </a:xfrm>
           <a:prstGeom prst="rect">
             <a:avLst/>
@@ -30115,6 +30239,9 @@
           <a:lstStyle/>
           <a:p>
             <a:pPr indent="0" marL="0">
+              <a:spcAft>
+                <a:spcPts val="400"/>
+              </a:spcAft>
               <a:buNone/>
             </a:pPr>
             <a:r>
@@ -30132,6 +30259,9 @@
           </a:p>
           <a:p>
             <a:pPr marL="177800" indent="-177800">
+              <a:spcAft>
+                <a:spcPts val="400"/>
+              </a:spcAft>
               <a:buSzPct val="100000"/>
               <a:buChar char="•"/>
             </a:pPr>
@@ -30150,6 +30280,9 @@
           </a:p>
           <a:p>
             <a:pPr marL="177800" indent="-177800">
+              <a:spcAft>
+                <a:spcPts val="400"/>
+              </a:spcAft>
               <a:buSzPct val="100000"/>
               <a:buChar char="•"/>
             </a:pPr>
@@ -30168,6 +30301,9 @@
           </a:p>
           <a:p>
             <a:pPr marL="177800" indent="-177800">
+              <a:spcAft>
+                <a:spcPts val="400"/>
+              </a:spcAft>
               <a:buSzPct val="100000"/>
               <a:buChar char="•"/>
             </a:pPr>
@@ -30188,18 +30324,126 @@
       </p:sp>
       <p:sp>
         <p:nvSpPr>
-          <p:cNvPr id="22" name="Shape 16"/>
+          <p:cNvPr id="26" name="Shape 19"/>
           <p:cNvSpPr/>
           <p:nvPr/>
         </p:nvSpPr>
         <p:spPr>
           <a:xfrm>
-            <a:off x="8001000" y="1371600"/>
-            <a:ext cx="3639312" cy="3108960"/>
+            <a:off x="4921301" y="4069080"/>
+            <a:ext cx="2805379" cy="1965960"/>
           </a:xfrm>
           <a:prstGeom prst="roundRect">
             <a:avLst>
-              <a:gd name="adj" fmla="val 2353"/>
+              <a:gd name="adj" fmla="val 3721"/>
+            </a:avLst>
+          </a:prstGeom>
+          <a:solidFill>
+            <a:srgbClr val="FFFBEB"/>
+          </a:solidFill>
+          <a:ln w="12700">
+            <a:solidFill>
+              <a:srgbClr val="FFFBEB"/>
+            </a:solidFill>
+            <a:prstDash val="solid"/>
+          </a:ln>
+        </p:spPr>
+      </p:sp>
+      <p:sp>
+        <p:nvSpPr>
+          <p:cNvPr id="27" name="Text 20"/>
+          <p:cNvSpPr txBox="1"/>
+          <p:nvPr/>
+        </p:nvSpPr>
+        <p:spPr>
+          <a:xfrm>
+            <a:off x="5031029" y="4114800"/>
+            <a:ext cx="2585923" cy="1874520"/>
+          </a:xfrm>
+          <a:prstGeom prst="rect">
+            <a:avLst/>
+          </a:prstGeom>
+          <a:noFill/>
+          <a:ln/>
+        </p:spPr>
+        <p:txBody>
+          <a:bodyPr wrap="square" lIns="0" tIns="0" rIns="0" bIns="0" rtlCol="0" anchor="ctr"/>
+          <a:lstStyle/>
+          <a:p>
+            <a:pPr indent="0" marL="0">
+              <a:buNone/>
+            </a:pPr>
+            <a:r>
+              <a:rPr lang="en-US" sz="1050" b="1" dirty="0">
+                <a:solidFill>
+                  <a:srgbClr val="B45309"/>
+                </a:solidFill>
+                <a:latin typeface="Calibri" pitchFamily="34" charset="0"/>
+                <a:ea typeface="Calibri" pitchFamily="34" charset="-122"/>
+                <a:cs typeface="Calibri" pitchFamily="34" charset="-120"/>
+              </a:rPr>
+              <a:t>MAAX example: </a:t>
+            </a:r>
+            <a:pPr indent="0" marL="0">
+              <a:buNone/>
+            </a:pPr>
+            <a:r>
+              <a:rPr lang="en-US" sz="1050" dirty="0">
+                <a:solidFill>
+                  <a:srgbClr val="1F2937"/>
+                </a:solidFill>
+                <a:latin typeface="Calibri" pitchFamily="34" charset="0"/>
+                <a:ea typeface="Calibri" pitchFamily="34" charset="-122"/>
+                <a:cs typeface="Calibri" pitchFamily="34" charset="-120"/>
+              </a:rPr>
+              <a:t>shower doors and bases (thin, all glass) and 75-inch TVs ride standing loose today (trailer 47520). </a:t>
+            </a:r>
+            <a:pPr indent="0" marL="0">
+              <a:buNone/>
+            </a:pPr>
+            <a:r>
+              <a:rPr lang="en-US" sz="1050" b="1" dirty="0">
+                <a:solidFill>
+                  <a:srgbClr val="111827"/>
+                </a:solidFill>
+                <a:latin typeface="Calibri" pitchFamily="34" charset="0"/>
+                <a:ea typeface="Calibri" pitchFamily="34" charset="-122"/>
+                <a:cs typeface="Calibri" pitchFamily="34" charset="-120"/>
+              </a:rPr>
+              <a:t>Slot them into panel carts — yellow cart rolls by hand, grey cage lifts by forklift</a:t>
+            </a:r>
+            <a:pPr indent="0" marL="0">
+              <a:buNone/>
+            </a:pPr>
+            <a:r>
+              <a:rPr lang="en-US" sz="1050" dirty="0">
+                <a:solidFill>
+                  <a:srgbClr val="1F2937"/>
+                </a:solidFill>
+                <a:latin typeface="Calibri" pitchFamily="34" charset="0"/>
+                <a:ea typeface="Calibri" pitchFamily="34" charset="-122"/>
+                <a:cs typeface="Calibri" pitchFamily="34" charset="-120"/>
+              </a:rPr>
+              <a:t>: secured in transit, faster in/out, less breakage.</a:t>
+            </a:r>
+            <a:endParaRPr lang="en-US" sz="1050" dirty="0"/>
+          </a:p>
+        </p:txBody>
+      </p:sp>
+      <p:sp>
+        <p:nvSpPr>
+          <p:cNvPr id="28" name="Shape 21"/>
+          <p:cNvSpPr/>
+          <p:nvPr/>
+        </p:nvSpPr>
+        <p:spPr>
+          <a:xfrm>
+            <a:off x="8001000" y="1371600"/>
+            <a:ext cx="3639312" cy="4663440"/>
+          </a:xfrm>
+          <a:prstGeom prst="roundRect">
+            <a:avLst>
+              <a:gd name="adj" fmla="val 2010"/>
             </a:avLst>
           </a:prstGeom>
           <a:solidFill>
@@ -30215,7 +30459,7 @@
       </p:sp>
       <p:sp>
         <p:nvSpPr>
-          <p:cNvPr id="23" name="Shape 17"/>
+          <p:cNvPr id="29" name="Shape 22"/>
           <p:cNvSpPr/>
           <p:nvPr/>
         </p:nvSpPr>
@@ -30240,14 +30484,14 @@
       </p:sp>
       <p:pic>
         <p:nvPicPr>
-          <p:cNvPr id="24" name="Image 4" descr="preencoded.png">    </p:cNvPr>
+          <p:cNvPr id="30" name="Image 5" descr="preencoded.png">    </p:cNvPr>
           <p:cNvPicPr>
             <a:picLocks noChangeAspect="1"/>
           </p:cNvPicPr>
           <p:nvPr/>
         </p:nvPicPr>
         <p:blipFill>
-          <a:blip r:embed="rId5"/>
+          <a:blip r:embed="rId6"/>
           <a:stretch>
             <a:fillRect/>
           </a:stretch>
@@ -30264,7 +30508,7 @@
       </p:pic>
       <p:sp>
         <p:nvSpPr>
-          <p:cNvPr id="25" name="Text 18"/>
+          <p:cNvPr id="31" name="Text 23"/>
           <p:cNvSpPr txBox="1"/>
           <p:nvPr/>
         </p:nvSpPr>
@@ -30303,14 +30547,14 @@
       </p:sp>
       <p:sp>
         <p:nvSpPr>
-          <p:cNvPr id="26" name="Text 19"/>
-          <p:cNvSpPr txBox="1"/>
-          <p:nvPr/>
-        </p:nvSpPr>
-        <p:spPr>
-          <a:xfrm>
-            <a:off x="8229600" y="2148840"/>
-            <a:ext cx="3246120" cy="2240280"/>
+          <p:cNvPr id="32" name="Text 24"/>
+          <p:cNvSpPr txBox="1"/>
+          <p:nvPr/>
+        </p:nvSpPr>
+        <p:spPr>
+          <a:xfrm>
+            <a:off x="8229600" y="2286000"/>
+            <a:ext cx="3246120" cy="3566160"/>
           </a:xfrm>
           <a:prstGeom prst="rect">
             <a:avLst/>
@@ -30324,13 +30568,13 @@
           <a:p>
             <a:pPr marL="203200" indent="-203200">
               <a:spcAft>
-                <a:spcPts val="500"/>
+                <a:spcPts val="1000"/>
               </a:spcAft>
               <a:buSzPct val="100000"/>
               <a:buChar char="•"/>
             </a:pPr>
             <a:r>
-              <a:rPr lang="en-US" sz="1150" dirty="0">
+              <a:rPr lang="en-US" sz="1300" dirty="0">
                 <a:solidFill>
                   <a:srgbClr val="1F2937"/>
                 </a:solidFill>
@@ -30340,18 +30584,18 @@
               </a:rPr>
               <a:t>ANCRA knock-down pallet decks (intermodal)</a:t>
             </a:r>
-            <a:endParaRPr lang="en-US" sz="1150" dirty="0"/>
+            <a:endParaRPr lang="en-US" sz="1300" dirty="0"/>
           </a:p>
           <a:p>
             <a:pPr marL="203200" indent="-203200">
               <a:spcAft>
-                <a:spcPts val="500"/>
+                <a:spcPts val="1000"/>
               </a:spcAft>
               <a:buSzPct val="100000"/>
               <a:buChar char="•"/>
             </a:pPr>
             <a:r>
-              <a:rPr lang="en-US" sz="1150" dirty="0">
+              <a:rPr lang="en-US" sz="1300" dirty="0">
                 <a:solidFill>
                   <a:srgbClr val="1F2937"/>
                 </a:solidFill>
@@ -30361,18 +30605,18 @@
               </a:rPr>
               <a:t>ANCRA security divider deck-board kits (E-track)</a:t>
             </a:r>
-            <a:endParaRPr lang="en-US" sz="1150" dirty="0"/>
+            <a:endParaRPr lang="en-US" sz="1300" dirty="0"/>
           </a:p>
           <a:p>
             <a:pPr marL="203200" indent="-203200">
               <a:spcAft>
-                <a:spcPts val="500"/>
+                <a:spcPts val="1000"/>
               </a:spcAft>
               <a:buSzPct val="100000"/>
               <a:buChar char="•"/>
             </a:pPr>
             <a:r>
-              <a:rPr lang="en-US" sz="1150" dirty="0">
+              <a:rPr lang="en-US" sz="1300" dirty="0">
                 <a:solidFill>
                   <a:srgbClr val="1F2937"/>
                 </a:solidFill>
@@ -30382,18 +30626,18 @@
               </a:rPr>
               <a:t>Panel trucks &amp; reconfigurable racks for windows, doors, panels, car parts (Sawtrax, Rack and Shelf, Grainger, Uline)</a:t>
             </a:r>
-            <a:endParaRPr lang="en-US" sz="1150" dirty="0"/>
+            <a:endParaRPr lang="en-US" sz="1300" dirty="0"/>
           </a:p>
           <a:p>
             <a:pPr marL="203200" indent="-203200">
               <a:spcAft>
-                <a:spcPts val="500"/>
+                <a:spcPts val="1000"/>
               </a:spcAft>
               <a:buSzPct val="100000"/>
               <a:buChar char="•"/>
             </a:pPr>
             <a:r>
-              <a:rPr lang="en-US" sz="1150" dirty="0">
+              <a:rPr lang="en-US" sz="1300" dirty="0">
                 <a:solidFill>
                   <a:srgbClr val="1F2937"/>
                 </a:solidFill>
@@ -30403,93 +30647,13 @@
               </a:rPr>
               <a:t>Load bars &amp; straps on every mixed load</a:t>
             </a:r>
-            <a:endParaRPr lang="en-US" sz="1150" dirty="0"/>
-          </a:p>
-        </p:txBody>
-      </p:sp>
-      <p:sp>
-        <p:nvSpPr>
-          <p:cNvPr id="27" name="Shape 20"/>
-          <p:cNvSpPr/>
-          <p:nvPr/>
-        </p:nvSpPr>
-        <p:spPr>
-          <a:xfrm>
-            <a:off x="8001000" y="4617720"/>
-            <a:ext cx="3639312" cy="1417320"/>
-          </a:xfrm>
-          <a:prstGeom prst="roundRect">
-            <a:avLst>
-              <a:gd name="adj" fmla="val 5161"/>
-            </a:avLst>
-          </a:prstGeom>
-          <a:solidFill>
-            <a:srgbClr val="FFFBEB"/>
-          </a:solidFill>
-          <a:ln w="12700">
-            <a:solidFill>
-              <a:srgbClr val="FFFBEB"/>
-            </a:solidFill>
-            <a:prstDash val="solid"/>
-          </a:ln>
-        </p:spPr>
-      </p:sp>
-      <p:sp>
-        <p:nvSpPr>
-          <p:cNvPr id="28" name="Text 21"/>
-          <p:cNvSpPr txBox="1"/>
-          <p:nvPr/>
-        </p:nvSpPr>
-        <p:spPr>
-          <a:xfrm>
-            <a:off x="8138160" y="4663440"/>
-            <a:ext cx="3383280" cy="1325880"/>
-          </a:xfrm>
-          <a:prstGeom prst="rect">
-            <a:avLst/>
-          </a:prstGeom>
-          <a:noFill/>
-          <a:ln/>
-        </p:spPr>
-        <p:txBody>
-          <a:bodyPr wrap="square" lIns="0" tIns="0" rIns="0" bIns="0" rtlCol="0" anchor="ctr"/>
-          <a:lstStyle/>
-          <a:p>
-            <a:pPr indent="0" marL="0">
-              <a:buNone/>
-            </a:pPr>
-            <a:r>
-              <a:rPr lang="en-US" sz="950" b="1" dirty="0">
-                <a:solidFill>
-                  <a:srgbClr val="B45309"/>
-                </a:solidFill>
-                <a:latin typeface="Calibri" pitchFamily="34" charset="0"/>
-                <a:ea typeface="Calibri" pitchFamily="34" charset="-122"/>
-                <a:cs typeface="Calibri" pitchFamily="34" charset="-120"/>
-              </a:rPr>
-              <a:t>Example: </a:t>
-            </a:r>
-            <a:pPr indent="0" marL="0">
-              <a:buNone/>
-            </a:pPr>
-            <a:r>
-              <a:rPr lang="en-US" sz="950" dirty="0">
-                <a:solidFill>
-                  <a:srgbClr val="1F2937"/>
-                </a:solidFill>
-                <a:latin typeface="Calibri" pitchFamily="34" charset="0"/>
-                <a:ea typeface="Calibri" pitchFamily="34" charset="-122"/>
-                <a:cs typeface="Calibri" pitchFamily="34" charset="-120"/>
-              </a:rPr>
-              <a:t>MAAX shower doors and bases (thin, all glass) and 75-inch TVs ride standing loose today (trailer 47520). Slot them into panel carts — yellow cart rolls by hand, grey cage lifts by forklift: secured in transit, faster in/out, less breakage.</a:t>
-            </a:r>
-            <a:endParaRPr lang="en-US" sz="950" dirty="0"/>
-          </a:p>
-        </p:txBody>
-      </p:sp>
-      <p:sp>
-        <p:nvSpPr>
-          <p:cNvPr id="29" name="Text 22"/>
+            <a:endParaRPr lang="en-US" sz="1300" dirty="0"/>
+          </a:p>
+        </p:txBody>
+      </p:sp>
+      <p:sp>
+        <p:nvSpPr>
+          <p:cNvPr id="33" name="Text 25"/>
           <p:cNvSpPr txBox="1"/>
           <p:nvPr/>
         </p:nvSpPr>
@@ -30528,7 +30692,7 @@
       </p:sp>
       <p:sp>
         <p:nvSpPr>
-          <p:cNvPr id="30" name="Text 23"/>
+          <p:cNvPr id="34" name="Text 26"/>
           <p:cNvSpPr txBox="1"/>
           <p:nvPr/>
         </p:nvSpPr>

</xml_diff>

<commit_message>
Deck: F27 initiative tracker on savings slide
Co-Authored-By: Claude Opus 5.5 <noreply@anthropic.com>
Claude-Session: https://claude.ai/code/session_01BwRjju3y2wk3wSHFrM9KLe
</commit_message>
<xml_diff>
--- a/presentation/Mississauga_F27_Leadership_Review_Sep29.pptx
+++ b/presentation/Mississauga_F27_Leadership_Review_Sep29.pptx
@@ -5242,7 +5242,7 @@
           <a:p>
             <a:r>
               <a:rPr lang="en-US" dirty="0"/>
-              <a:t>Our confirmed F27 saving so far is 61,000 dollars a year from eliminating the dispatcher role and centralizing dispatch. Additional initiatives are in development and will be added as they are confirmed; the F27 take-out target is being confirmed with Finance. Cargo claims on the claims report for our terminal, T-0502, total 13,432.53 dollars for August 2026, as September has not closed.</a:t>
+              <a:t>This is our F27 initiative tracker, laid out like the F26 page. One initiative is confirmed: eliminating the dispatcher role and centralizing dispatch saves 61,000 dollars a year. Six more are in progress or planned — agency labour mix, running under the SCA hour allowance, load securement and decking, freight-handling equipment, accessorial capture and Toyota footage capture — and their dollar values and the F27 take-out target are being confirmed with Finance. Cargo claims for August 2026 were 13,432.53 dollars.</a:t>
             </a:r>
             <a:endParaRPr lang="en-US" dirty="0"/>
           </a:p>
@@ -17888,9 +17888,585 @@
                 <a:ea typeface="Calibri" pitchFamily="34" charset="-122"/>
                 <a:cs typeface="Calibri" pitchFamily="34" charset="-120"/>
               </a:rPr>
-              <a:t>F27 savings plan</a:t>
+              <a:t>F27 savings — initiative tracker</a:t>
             </a:r>
             <a:endParaRPr lang="en-US" sz="3000" dirty="0"/>
+          </a:p>
+        </p:txBody>
+      </p:sp>
+      <p:sp>
+        <p:nvSpPr>
+          <p:cNvPr id="4" name="Shape 2"/>
+          <p:cNvSpPr/>
+          <p:nvPr/>
+        </p:nvSpPr>
+        <p:spPr>
+          <a:xfrm>
+            <a:off x="548640" y="1371600"/>
+            <a:ext cx="2635758" cy="1005840"/>
+          </a:xfrm>
+          <a:prstGeom prst="roundRect">
+            <a:avLst>
+              <a:gd name="adj" fmla="val 7273"/>
+            </a:avLst>
+          </a:prstGeom>
+          <a:solidFill>
+            <a:srgbClr val="F5F3FF"/>
+          </a:solidFill>
+          <a:ln w="12700">
+            <a:solidFill>
+              <a:srgbClr val="F5F3FF"/>
+            </a:solidFill>
+            <a:prstDash val="solid"/>
+          </a:ln>
+        </p:spPr>
+      </p:sp>
+      <p:sp>
+        <p:nvSpPr>
+          <p:cNvPr id="5" name="Text 3"/>
+          <p:cNvSpPr txBox="1"/>
+          <p:nvPr/>
+        </p:nvSpPr>
+        <p:spPr>
+          <a:xfrm>
+            <a:off x="731520" y="1463040"/>
+            <a:ext cx="2269998" cy="237744"/>
+          </a:xfrm>
+          <a:prstGeom prst="rect">
+            <a:avLst/>
+          </a:prstGeom>
+          <a:noFill/>
+          <a:ln/>
+        </p:spPr>
+        <p:txBody>
+          <a:bodyPr wrap="square" lIns="0" tIns="0" rIns="0" bIns="0" rtlCol="0" anchor="ctr"/>
+          <a:lstStyle/>
+          <a:p>
+            <a:pPr indent="0" marL="0">
+              <a:buNone/>
+            </a:pPr>
+            <a:r>
+              <a:rPr lang="en-US" sz="1100" b="1" dirty="0">
+                <a:solidFill>
+                  <a:srgbClr val="6B7280"/>
+                </a:solidFill>
+                <a:latin typeface="Calibri" pitchFamily="34" charset="0"/>
+                <a:ea typeface="Calibri" pitchFamily="34" charset="-122"/>
+                <a:cs typeface="Calibri" pitchFamily="34" charset="-120"/>
+              </a:rPr>
+              <a:t>F27 take-out target</a:t>
+            </a:r>
+            <a:endParaRPr lang="en-US" sz="1100" dirty="0"/>
+          </a:p>
+        </p:txBody>
+      </p:sp>
+      <p:sp>
+        <p:nvSpPr>
+          <p:cNvPr id="6" name="Text 4"/>
+          <p:cNvSpPr txBox="1"/>
+          <p:nvPr/>
+        </p:nvSpPr>
+        <p:spPr>
+          <a:xfrm>
+            <a:off x="731520" y="1700784"/>
+            <a:ext cx="2269998" cy="384048"/>
+          </a:xfrm>
+          <a:prstGeom prst="rect">
+            <a:avLst/>
+          </a:prstGeom>
+          <a:noFill/>
+          <a:ln/>
+        </p:spPr>
+        <p:txBody>
+          <a:bodyPr wrap="square" lIns="0" tIns="0" rIns="0" bIns="0" rtlCol="0" anchor="ctr"/>
+          <a:lstStyle/>
+          <a:p>
+            <a:pPr indent="0" marL="0">
+              <a:buNone/>
+            </a:pPr>
+            <a:r>
+              <a:rPr lang="en-US" sz="2200" b="1" dirty="0">
+                <a:solidFill>
+                  <a:srgbClr val="D97706"/>
+                </a:solidFill>
+                <a:latin typeface="Calibri" pitchFamily="34" charset="0"/>
+                <a:ea typeface="Calibri" pitchFamily="34" charset="-122"/>
+                <a:cs typeface="Calibri" pitchFamily="34" charset="-120"/>
+              </a:rPr>
+              <a:t>TBC</a:t>
+            </a:r>
+            <a:endParaRPr lang="en-US" sz="2200" dirty="0"/>
+          </a:p>
+        </p:txBody>
+      </p:sp>
+      <p:sp>
+        <p:nvSpPr>
+          <p:cNvPr id="7" name="Text 5"/>
+          <p:cNvSpPr txBox="1"/>
+          <p:nvPr/>
+        </p:nvSpPr>
+        <p:spPr>
+          <a:xfrm>
+            <a:off x="731520" y="2103120"/>
+            <a:ext cx="2269998" cy="219456"/>
+          </a:xfrm>
+          <a:prstGeom prst="rect">
+            <a:avLst/>
+          </a:prstGeom>
+          <a:noFill/>
+          <a:ln/>
+        </p:spPr>
+        <p:txBody>
+          <a:bodyPr wrap="square" lIns="0" tIns="0" rIns="0" bIns="0" rtlCol="0" anchor="ctr"/>
+          <a:lstStyle/>
+          <a:p>
+            <a:pPr indent="0" marL="0">
+              <a:buNone/>
+            </a:pPr>
+            <a:r>
+              <a:rPr lang="en-US" sz="1000" dirty="0">
+                <a:solidFill>
+                  <a:srgbClr val="6B7280"/>
+                </a:solidFill>
+                <a:latin typeface="Calibri" pitchFamily="34" charset="0"/>
+                <a:ea typeface="Calibri" pitchFamily="34" charset="-122"/>
+                <a:cs typeface="Calibri" pitchFamily="34" charset="-120"/>
+              </a:rPr>
+              <a:t>Full year</a:t>
+            </a:r>
+            <a:endParaRPr lang="en-US" sz="1000" dirty="0"/>
+          </a:p>
+        </p:txBody>
+      </p:sp>
+      <p:sp>
+        <p:nvSpPr>
+          <p:cNvPr id="8" name="Shape 6"/>
+          <p:cNvSpPr/>
+          <p:nvPr/>
+        </p:nvSpPr>
+        <p:spPr>
+          <a:xfrm>
+            <a:off x="3367278" y="1371600"/>
+            <a:ext cx="2635758" cy="1005840"/>
+          </a:xfrm>
+          <a:prstGeom prst="roundRect">
+            <a:avLst>
+              <a:gd name="adj" fmla="val 7273"/>
+            </a:avLst>
+          </a:prstGeom>
+          <a:solidFill>
+            <a:srgbClr val="F3F4F6"/>
+          </a:solidFill>
+          <a:ln w="12700">
+            <a:solidFill>
+              <a:srgbClr val="F3F4F6"/>
+            </a:solidFill>
+            <a:prstDash val="solid"/>
+          </a:ln>
+        </p:spPr>
+      </p:sp>
+      <p:sp>
+        <p:nvSpPr>
+          <p:cNvPr id="9" name="Text 7"/>
+          <p:cNvSpPr txBox="1"/>
+          <p:nvPr/>
+        </p:nvSpPr>
+        <p:spPr>
+          <a:xfrm>
+            <a:off x="3550158" y="1463040"/>
+            <a:ext cx="2269998" cy="237744"/>
+          </a:xfrm>
+          <a:prstGeom prst="rect">
+            <a:avLst/>
+          </a:prstGeom>
+          <a:noFill/>
+          <a:ln/>
+        </p:spPr>
+        <p:txBody>
+          <a:bodyPr wrap="square" lIns="0" tIns="0" rIns="0" bIns="0" rtlCol="0" anchor="ctr"/>
+          <a:lstStyle/>
+          <a:p>
+            <a:pPr indent="0" marL="0">
+              <a:buNone/>
+            </a:pPr>
+            <a:r>
+              <a:rPr lang="en-US" sz="1100" b="1" dirty="0">
+                <a:solidFill>
+                  <a:srgbClr val="6B7280"/>
+                </a:solidFill>
+                <a:latin typeface="Calibri" pitchFamily="34" charset="0"/>
+                <a:ea typeface="Calibri" pitchFamily="34" charset="-122"/>
+                <a:cs typeface="Calibri" pitchFamily="34" charset="-120"/>
+              </a:rPr>
+              <a:t>Identified</a:t>
+            </a:r>
+            <a:endParaRPr lang="en-US" sz="1100" dirty="0"/>
+          </a:p>
+        </p:txBody>
+      </p:sp>
+      <p:sp>
+        <p:nvSpPr>
+          <p:cNvPr id="10" name="Text 8"/>
+          <p:cNvSpPr txBox="1"/>
+          <p:nvPr/>
+        </p:nvSpPr>
+        <p:spPr>
+          <a:xfrm>
+            <a:off x="3550158" y="1700784"/>
+            <a:ext cx="2269998" cy="384048"/>
+          </a:xfrm>
+          <a:prstGeom prst="rect">
+            <a:avLst/>
+          </a:prstGeom>
+          <a:noFill/>
+          <a:ln/>
+        </p:spPr>
+        <p:txBody>
+          <a:bodyPr wrap="square" lIns="0" tIns="0" rIns="0" bIns="0" rtlCol="0" anchor="ctr"/>
+          <a:lstStyle/>
+          <a:p>
+            <a:pPr indent="0" marL="0">
+              <a:buNone/>
+            </a:pPr>
+            <a:r>
+              <a:rPr lang="en-US" sz="2200" b="1" dirty="0">
+                <a:solidFill>
+                  <a:srgbClr val="059669"/>
+                </a:solidFill>
+                <a:latin typeface="Calibri" pitchFamily="34" charset="0"/>
+                <a:ea typeface="Calibri" pitchFamily="34" charset="-122"/>
+                <a:cs typeface="Calibri" pitchFamily="34" charset="-120"/>
+              </a:rPr>
+              <a:t>$61,000/yr</a:t>
+            </a:r>
+            <a:endParaRPr lang="en-US" sz="2200" dirty="0"/>
+          </a:p>
+        </p:txBody>
+      </p:sp>
+      <p:sp>
+        <p:nvSpPr>
+          <p:cNvPr id="11" name="Text 9"/>
+          <p:cNvSpPr txBox="1"/>
+          <p:nvPr/>
+        </p:nvSpPr>
+        <p:spPr>
+          <a:xfrm>
+            <a:off x="3550158" y="2103120"/>
+            <a:ext cx="2269998" cy="219456"/>
+          </a:xfrm>
+          <a:prstGeom prst="rect">
+            <a:avLst/>
+          </a:prstGeom>
+          <a:noFill/>
+          <a:ln/>
+        </p:spPr>
+        <p:txBody>
+          <a:bodyPr wrap="square" lIns="0" tIns="0" rIns="0" bIns="0" rtlCol="0" anchor="ctr"/>
+          <a:lstStyle/>
+          <a:p>
+            <a:pPr indent="0" marL="0">
+              <a:buNone/>
+            </a:pPr>
+            <a:r>
+              <a:rPr lang="en-US" sz="1000" dirty="0">
+                <a:solidFill>
+                  <a:srgbClr val="6B7280"/>
+                </a:solidFill>
+                <a:latin typeface="Calibri" pitchFamily="34" charset="0"/>
+                <a:ea typeface="Calibri" pitchFamily="34" charset="-122"/>
+                <a:cs typeface="Calibri" pitchFamily="34" charset="-120"/>
+              </a:rPr>
+              <a:t>1 confirmed initiative</a:t>
+            </a:r>
+            <a:endParaRPr lang="en-US" sz="1000" dirty="0"/>
+          </a:p>
+        </p:txBody>
+      </p:sp>
+      <p:sp>
+        <p:nvSpPr>
+          <p:cNvPr id="12" name="Shape 10"/>
+          <p:cNvSpPr/>
+          <p:nvPr/>
+        </p:nvSpPr>
+        <p:spPr>
+          <a:xfrm>
+            <a:off x="6185916" y="1371600"/>
+            <a:ext cx="2635758" cy="1005840"/>
+          </a:xfrm>
+          <a:prstGeom prst="roundRect">
+            <a:avLst>
+              <a:gd name="adj" fmla="val 7273"/>
+            </a:avLst>
+          </a:prstGeom>
+          <a:solidFill>
+            <a:srgbClr val="F3F4F6"/>
+          </a:solidFill>
+          <a:ln w="12700">
+            <a:solidFill>
+              <a:srgbClr val="F3F4F6"/>
+            </a:solidFill>
+            <a:prstDash val="solid"/>
+          </a:ln>
+        </p:spPr>
+      </p:sp>
+      <p:sp>
+        <p:nvSpPr>
+          <p:cNvPr id="13" name="Text 11"/>
+          <p:cNvSpPr txBox="1"/>
+          <p:nvPr/>
+        </p:nvSpPr>
+        <p:spPr>
+          <a:xfrm>
+            <a:off x="6368796" y="1463040"/>
+            <a:ext cx="2269998" cy="237744"/>
+          </a:xfrm>
+          <a:prstGeom prst="rect">
+            <a:avLst/>
+          </a:prstGeom>
+          <a:noFill/>
+          <a:ln/>
+        </p:spPr>
+        <p:txBody>
+          <a:bodyPr wrap="square" lIns="0" tIns="0" rIns="0" bIns="0" rtlCol="0" anchor="ctr"/>
+          <a:lstStyle/>
+          <a:p>
+            <a:pPr indent="0" marL="0">
+              <a:buNone/>
+            </a:pPr>
+            <a:r>
+              <a:rPr lang="en-US" sz="1100" b="1" dirty="0">
+                <a:solidFill>
+                  <a:srgbClr val="6B7280"/>
+                </a:solidFill>
+                <a:latin typeface="Calibri" pitchFamily="34" charset="0"/>
+                <a:ea typeface="Calibri" pitchFamily="34" charset="-122"/>
+                <a:cs typeface="Calibri" pitchFamily="34" charset="-120"/>
+              </a:rPr>
+              <a:t>Still to identify</a:t>
+            </a:r>
+            <a:endParaRPr lang="en-US" sz="1100" dirty="0"/>
+          </a:p>
+        </p:txBody>
+      </p:sp>
+      <p:sp>
+        <p:nvSpPr>
+          <p:cNvPr id="14" name="Text 12"/>
+          <p:cNvSpPr txBox="1"/>
+          <p:nvPr/>
+        </p:nvSpPr>
+        <p:spPr>
+          <a:xfrm>
+            <a:off x="6368796" y="1700784"/>
+            <a:ext cx="2269998" cy="384048"/>
+          </a:xfrm>
+          <a:prstGeom prst="rect">
+            <a:avLst/>
+          </a:prstGeom>
+          <a:noFill/>
+          <a:ln/>
+        </p:spPr>
+        <p:txBody>
+          <a:bodyPr wrap="square" lIns="0" tIns="0" rIns="0" bIns="0" rtlCol="0" anchor="ctr"/>
+          <a:lstStyle/>
+          <a:p>
+            <a:pPr indent="0" marL="0">
+              <a:buNone/>
+            </a:pPr>
+            <a:r>
+              <a:rPr lang="en-US" sz="2200" b="1" dirty="0">
+                <a:solidFill>
+                  <a:srgbClr val="D97706"/>
+                </a:solidFill>
+                <a:latin typeface="Calibri" pitchFamily="34" charset="0"/>
+                <a:ea typeface="Calibri" pitchFamily="34" charset="-122"/>
+                <a:cs typeface="Calibri" pitchFamily="34" charset="-120"/>
+              </a:rPr>
+              <a:t>TBC</a:t>
+            </a:r>
+            <a:endParaRPr lang="en-US" sz="2200" dirty="0"/>
+          </a:p>
+        </p:txBody>
+      </p:sp>
+      <p:sp>
+        <p:nvSpPr>
+          <p:cNvPr id="15" name="Text 13"/>
+          <p:cNvSpPr txBox="1"/>
+          <p:nvPr/>
+        </p:nvSpPr>
+        <p:spPr>
+          <a:xfrm>
+            <a:off x="6368796" y="2103120"/>
+            <a:ext cx="2269998" cy="219456"/>
+          </a:xfrm>
+          <a:prstGeom prst="rect">
+            <a:avLst/>
+          </a:prstGeom>
+          <a:noFill/>
+          <a:ln/>
+        </p:spPr>
+        <p:txBody>
+          <a:bodyPr wrap="square" lIns="0" tIns="0" rIns="0" bIns="0" rtlCol="0" anchor="ctr"/>
+          <a:lstStyle/>
+          <a:p>
+            <a:pPr indent="0" marL="0">
+              <a:buNone/>
+            </a:pPr>
+            <a:r>
+              <a:rPr lang="en-US" sz="1000" dirty="0">
+                <a:solidFill>
+                  <a:srgbClr val="6B7280"/>
+                </a:solidFill>
+                <a:latin typeface="Calibri" pitchFamily="34" charset="0"/>
+                <a:ea typeface="Calibri" pitchFamily="34" charset="-122"/>
+                <a:cs typeface="Calibri" pitchFamily="34" charset="-120"/>
+              </a:rPr>
+              <a:t>Target − identified</a:t>
+            </a:r>
+            <a:endParaRPr lang="en-US" sz="1000" dirty="0"/>
+          </a:p>
+        </p:txBody>
+      </p:sp>
+      <p:sp>
+        <p:nvSpPr>
+          <p:cNvPr id="16" name="Shape 14"/>
+          <p:cNvSpPr/>
+          <p:nvPr/>
+        </p:nvSpPr>
+        <p:spPr>
+          <a:xfrm>
+            <a:off x="9004554" y="1371600"/>
+            <a:ext cx="2635758" cy="1005840"/>
+          </a:xfrm>
+          <a:prstGeom prst="roundRect">
+            <a:avLst>
+              <a:gd name="adj" fmla="val 7273"/>
+            </a:avLst>
+          </a:prstGeom>
+          <a:solidFill>
+            <a:srgbClr val="F3F4F6"/>
+          </a:solidFill>
+          <a:ln w="12700">
+            <a:solidFill>
+              <a:srgbClr val="F3F4F6"/>
+            </a:solidFill>
+            <a:prstDash val="solid"/>
+          </a:ln>
+        </p:spPr>
+      </p:sp>
+      <p:sp>
+        <p:nvSpPr>
+          <p:cNvPr id="17" name="Text 15"/>
+          <p:cNvSpPr txBox="1"/>
+          <p:nvPr/>
+        </p:nvSpPr>
+        <p:spPr>
+          <a:xfrm>
+            <a:off x="9187434" y="1463040"/>
+            <a:ext cx="2269998" cy="237744"/>
+          </a:xfrm>
+          <a:prstGeom prst="rect">
+            <a:avLst/>
+          </a:prstGeom>
+          <a:noFill/>
+          <a:ln/>
+        </p:spPr>
+        <p:txBody>
+          <a:bodyPr wrap="square" lIns="0" tIns="0" rIns="0" bIns="0" rtlCol="0" anchor="ctr"/>
+          <a:lstStyle/>
+          <a:p>
+            <a:pPr indent="0" marL="0">
+              <a:buNone/>
+            </a:pPr>
+            <a:r>
+              <a:rPr lang="en-US" sz="1100" b="1" dirty="0">
+                <a:solidFill>
+                  <a:srgbClr val="6B7280"/>
+                </a:solidFill>
+                <a:latin typeface="Calibri" pitchFamily="34" charset="0"/>
+                <a:ea typeface="Calibri" pitchFamily="34" charset="-122"/>
+                <a:cs typeface="Calibri" pitchFamily="34" charset="-120"/>
+              </a:rPr>
+              <a:t>Realized YTD</a:t>
+            </a:r>
+            <a:endParaRPr lang="en-US" sz="1100" dirty="0"/>
+          </a:p>
+        </p:txBody>
+      </p:sp>
+      <p:sp>
+        <p:nvSpPr>
+          <p:cNvPr id="18" name="Text 16"/>
+          <p:cNvSpPr txBox="1"/>
+          <p:nvPr/>
+        </p:nvSpPr>
+        <p:spPr>
+          <a:xfrm>
+            <a:off x="9187434" y="1700784"/>
+            <a:ext cx="2269998" cy="384048"/>
+          </a:xfrm>
+          <a:prstGeom prst="rect">
+            <a:avLst/>
+          </a:prstGeom>
+          <a:noFill/>
+          <a:ln/>
+        </p:spPr>
+        <p:txBody>
+          <a:bodyPr wrap="square" lIns="0" tIns="0" rIns="0" bIns="0" rtlCol="0" anchor="ctr"/>
+          <a:lstStyle/>
+          <a:p>
+            <a:pPr indent="0" marL="0">
+              <a:buNone/>
+            </a:pPr>
+            <a:r>
+              <a:rPr lang="en-US" sz="2200" b="1" dirty="0">
+                <a:solidFill>
+                  <a:srgbClr val="D97706"/>
+                </a:solidFill>
+                <a:latin typeface="Calibri" pitchFamily="34" charset="0"/>
+                <a:ea typeface="Calibri" pitchFamily="34" charset="-122"/>
+                <a:cs typeface="Calibri" pitchFamily="34" charset="-120"/>
+              </a:rPr>
+              <a:t>TBC</a:t>
+            </a:r>
+            <a:endParaRPr lang="en-US" sz="2200" dirty="0"/>
+          </a:p>
+        </p:txBody>
+      </p:sp>
+      <p:sp>
+        <p:nvSpPr>
+          <p:cNvPr id="19" name="Text 17"/>
+          <p:cNvSpPr txBox="1"/>
+          <p:nvPr/>
+        </p:nvSpPr>
+        <p:spPr>
+          <a:xfrm>
+            <a:off x="9187434" y="2103120"/>
+            <a:ext cx="2269998" cy="219456"/>
+          </a:xfrm>
+          <a:prstGeom prst="rect">
+            <a:avLst/>
+          </a:prstGeom>
+          <a:noFill/>
+          <a:ln/>
+        </p:spPr>
+        <p:txBody>
+          <a:bodyPr wrap="square" lIns="0" tIns="0" rIns="0" bIns="0" rtlCol="0" anchor="ctr"/>
+          <a:lstStyle/>
+          <a:p>
+            <a:pPr indent="0" marL="0">
+              <a:buNone/>
+            </a:pPr>
+            <a:r>
+              <a:rPr lang="en-US" sz="1000" dirty="0">
+                <a:solidFill>
+                  <a:srgbClr val="6B7280"/>
+                </a:solidFill>
+                <a:latin typeface="Calibri" pitchFamily="34" charset="0"/>
+                <a:ea typeface="Calibri" pitchFamily="34" charset="-122"/>
+                <a:cs typeface="Calibri" pitchFamily="34" charset="-120"/>
+              </a:rPr>
+              <a:t>Jul 1 to date</a:t>
+            </a:r>
+            <a:endParaRPr lang="en-US" sz="1000" dirty="0"/>
           </a:p>
         </p:txBody>
       </p:sp>
@@ -17909,8 +18485,8 @@
           </p:nvPr>
         </p:nvGraphicFramePr>
         <p:xfrm>
-          <a:off x="548640" y="1371600"/>
-          <a:ext cx="8229600" cy="914400"/>
+          <a:off x="548640" y="2560320"/>
+          <a:ext cx="11091672" cy="914400"/>
         </p:xfrm>
         <a:graphic>
           <a:graphicData uri="http://schemas.openxmlformats.org/drawingml/2006/table">
@@ -17918,12 +18494,12 @@
               <a:tblPr/>
               <a:tblGrid>
                 <a:gridCol w="411480"/>
-                <a:gridCol w="3611880"/>
-                <a:gridCol w="1325880"/>
-                <a:gridCol w="1325880"/>
-                <a:gridCol w="1554480"/>
+                <a:gridCol w="5120640"/>
+                <a:gridCol w="2148840"/>
+                <a:gridCol w="1463040"/>
+                <a:gridCol w="1947672"/>
               </a:tblGrid>
-              <a:tr h="502920">
+              <a:tr h="365760">
                 <a:tc>
                   <a:txBody>
                     <a:bodyPr/>
@@ -17933,7 +18509,7 @@
                         <a:buNone/>
                       </a:pPr>
                       <a:r>
-                        <a:rPr lang="en-US" sz="1200" b="1" dirty="0">
+                        <a:rPr lang="en-US" sz="1100" b="1" dirty="0">
                           <a:solidFill>
                             <a:srgbClr val="FFFFFF"/>
                           </a:solidFill>
@@ -17943,7 +18519,7 @@
                         </a:rPr>
                         <a:t>#</a:t>
                       </a:r>
-                      <a:endParaRPr lang="en-US" sz="1200" dirty="0">
+                      <a:endParaRPr lang="en-US" sz="1100" dirty="0">
                         <a:latin typeface="Calibri" charset="0"/>
                         <a:ea typeface="Calibri" charset="0"/>
                         <a:cs typeface="Calibri" charset="0"/>
@@ -18001,7 +18577,7 @@
                         <a:buNone/>
                       </a:pPr>
                       <a:r>
-                        <a:rPr lang="en-US" sz="1200" b="1" dirty="0">
+                        <a:rPr lang="en-US" sz="1100" b="1" dirty="0">
                           <a:solidFill>
                             <a:srgbClr val="FFFFFF"/>
                           </a:solidFill>
@@ -18011,7 +18587,143 @@
                         </a:rPr>
                         <a:t>Initiative</a:t>
                       </a:r>
-                      <a:endParaRPr lang="en-US" sz="1200" dirty="0">
+                      <a:endParaRPr lang="en-US" sz="1100" dirty="0">
+                        <a:latin typeface="Calibri" charset="0"/>
+                        <a:ea typeface="Calibri" charset="0"/>
+                        <a:cs typeface="Calibri" charset="0"/>
+                      </a:endParaRPr>
+                    </a:p>
+                  </a:txBody>
+                  <a:tcPr marL="91440" marR="91440" marT="36576" marB="36576" anchor="ctr">
+                    <a:lnL w="9525" cap="flat" cmpd="sng" algn="ctr">
+                      <a:solidFill>
+                        <a:srgbClr val="E5E7EB"/>
+                      </a:solidFill>
+                      <a:prstDash val="solid"/>
+                      <a:round/>
+                      <a:headEnd type="none" w="med" len="med"/>
+                      <a:tailEnd type="none" w="med" len="med"/>
+                    </a:lnL>
+                    <a:lnR w="9525" cap="flat" cmpd="sng" algn="ctr">
+                      <a:solidFill>
+                        <a:srgbClr val="E5E7EB"/>
+                      </a:solidFill>
+                      <a:prstDash val="solid"/>
+                      <a:round/>
+                      <a:headEnd type="none" w="med" len="med"/>
+                      <a:tailEnd type="none" w="med" len="med"/>
+                    </a:lnR>
+                    <a:lnT w="9525" cap="flat" cmpd="sng" algn="ctr">
+                      <a:solidFill>
+                        <a:srgbClr val="E5E7EB"/>
+                      </a:solidFill>
+                      <a:prstDash val="solid"/>
+                      <a:round/>
+                      <a:headEnd type="none" w="med" len="med"/>
+                      <a:tailEnd type="none" w="med" len="med"/>
+                    </a:lnT>
+                    <a:lnB w="9525" cap="flat" cmpd="sng" algn="ctr">
+                      <a:solidFill>
+                        <a:srgbClr val="E5E7EB"/>
+                      </a:solidFill>
+                      <a:prstDash val="solid"/>
+                      <a:round/>
+                      <a:headEnd type="none" w="med" len="med"/>
+                      <a:tailEnd type="none" w="med" len="med"/>
+                    </a:lnB>
+                    <a:solidFill>
+                      <a:srgbClr val="1F2937"/>
+                    </a:solidFill>
+                  </a:tcPr>
+                </a:tc>
+                <a:tc>
+                  <a:txBody>
+                    <a:bodyPr/>
+                    <a:lstStyle/>
+                    <a:p>
+                      <a:pPr indent="0" marL="0">
+                        <a:buNone/>
+                      </a:pPr>
+                      <a:r>
+                        <a:rPr lang="en-US" sz="1100" b="1" dirty="0">
+                          <a:solidFill>
+                            <a:srgbClr val="FFFFFF"/>
+                          </a:solidFill>
+                          <a:latin typeface="Calibri" pitchFamily="34" charset="0"/>
+                          <a:ea typeface="Calibri" pitchFamily="34" charset="-122"/>
+                          <a:cs typeface="Calibri" pitchFamily="34" charset="-120"/>
+                        </a:rPr>
+                        <a:t>Category</a:t>
+                      </a:r>
+                      <a:endParaRPr lang="en-US" sz="1100" dirty="0">
+                        <a:latin typeface="Calibri" charset="0"/>
+                        <a:ea typeface="Calibri" charset="0"/>
+                        <a:cs typeface="Calibri" charset="0"/>
+                      </a:endParaRPr>
+                    </a:p>
+                  </a:txBody>
+                  <a:tcPr marL="91440" marR="91440" marT="36576" marB="36576" anchor="ctr">
+                    <a:lnL w="9525" cap="flat" cmpd="sng" algn="ctr">
+                      <a:solidFill>
+                        <a:srgbClr val="E5E7EB"/>
+                      </a:solidFill>
+                      <a:prstDash val="solid"/>
+                      <a:round/>
+                      <a:headEnd type="none" w="med" len="med"/>
+                      <a:tailEnd type="none" w="med" len="med"/>
+                    </a:lnL>
+                    <a:lnR w="9525" cap="flat" cmpd="sng" algn="ctr">
+                      <a:solidFill>
+                        <a:srgbClr val="E5E7EB"/>
+                      </a:solidFill>
+                      <a:prstDash val="solid"/>
+                      <a:round/>
+                      <a:headEnd type="none" w="med" len="med"/>
+                      <a:tailEnd type="none" w="med" len="med"/>
+                    </a:lnR>
+                    <a:lnT w="9525" cap="flat" cmpd="sng" algn="ctr">
+                      <a:solidFill>
+                        <a:srgbClr val="E5E7EB"/>
+                      </a:solidFill>
+                      <a:prstDash val="solid"/>
+                      <a:round/>
+                      <a:headEnd type="none" w="med" len="med"/>
+                      <a:tailEnd type="none" w="med" len="med"/>
+                    </a:lnT>
+                    <a:lnB w="9525" cap="flat" cmpd="sng" algn="ctr">
+                      <a:solidFill>
+                        <a:srgbClr val="E5E7EB"/>
+                      </a:solidFill>
+                      <a:prstDash val="solid"/>
+                      <a:round/>
+                      <a:headEnd type="none" w="med" len="med"/>
+                      <a:tailEnd type="none" w="med" len="med"/>
+                    </a:lnB>
+                    <a:solidFill>
+                      <a:srgbClr val="1F2937"/>
+                    </a:solidFill>
+                  </a:tcPr>
+                </a:tc>
+                <a:tc>
+                  <a:txBody>
+                    <a:bodyPr/>
+                    <a:lstStyle/>
+                    <a:p>
+                      <a:pPr algn="ctr" indent="0" marL="0">
+                        <a:buNone/>
+                      </a:pPr>
+                      <a:r>
+                        <a:rPr lang="en-US" sz="1100" b="1" dirty="0">
+                          <a:solidFill>
+                            <a:srgbClr val="FFFFFF"/>
+                          </a:solidFill>
+                          <a:latin typeface="Calibri" pitchFamily="34" charset="0"/>
+                          <a:ea typeface="Calibri" pitchFamily="34" charset="-122"/>
+                          <a:cs typeface="Calibri" pitchFamily="34" charset="-120"/>
+                        </a:rPr>
+                        <a:t>Status</a:t>
+                      </a:r>
+                      <a:endParaRPr lang="en-US" sz="1100" dirty="0">
                         <a:latin typeface="Calibri" charset="0"/>
                         <a:ea typeface="Calibri" charset="0"/>
                         <a:cs typeface="Calibri" charset="0"/>
@@ -18069,7 +18781,7 @@
                         <a:buNone/>
                       </a:pPr>
                       <a:r>
-                        <a:rPr lang="en-US" sz="1200" b="1" dirty="0">
+                        <a:rPr lang="en-US" sz="1100" b="1" dirty="0">
                           <a:solidFill>
                             <a:srgbClr val="FFFFFF"/>
                           </a:solidFill>
@@ -18077,9 +18789,9 @@
                           <a:ea typeface="Calibri" pitchFamily="34" charset="-122"/>
                           <a:cs typeface="Calibri" pitchFamily="34" charset="-120"/>
                         </a:rPr>
-                        <a:t>F27 plan ($/yr)</a:t>
+                        <a:t>$ / yr</a:t>
                       </a:r>
-                      <a:endParaRPr lang="en-US" sz="1200" dirty="0">
+                      <a:endParaRPr lang="en-US" sz="1100" dirty="0">
                         <a:latin typeface="Calibri" charset="0"/>
                         <a:ea typeface="Calibri" charset="0"/>
                         <a:cs typeface="Calibri" charset="0"/>
@@ -18125,6 +18837,280 @@
                     </a:lnB>
                     <a:solidFill>
                       <a:srgbClr val="1F2937"/>
+                    </a:solidFill>
+                  </a:tcPr>
+                </a:tc>
+              </a:tr>
+              <a:tr h="365760">
+                <a:tc>
+                  <a:txBody>
+                    <a:bodyPr/>
+                    <a:lstStyle/>
+                    <a:p>
+                      <a:pPr algn="ctr" indent="0" marL="0">
+                        <a:buNone/>
+                      </a:pPr>
+                      <a:r>
+                        <a:rPr lang="en-US" sz="1150" dirty="0">
+                          <a:solidFill>
+                            <a:srgbClr val="6B7280"/>
+                          </a:solidFill>
+                          <a:latin typeface="Calibri" pitchFamily="34" charset="0"/>
+                          <a:ea typeface="Calibri" pitchFamily="34" charset="-122"/>
+                          <a:cs typeface="Calibri" pitchFamily="34" charset="-120"/>
+                        </a:rPr>
+                        <a:t>1</a:t>
+                      </a:r>
+                      <a:endParaRPr lang="en-US" sz="1150" dirty="0">
+                        <a:latin typeface="Calibri" charset="0"/>
+                        <a:ea typeface="Calibri" charset="0"/>
+                        <a:cs typeface="Calibri" charset="0"/>
+                      </a:endParaRPr>
+                    </a:p>
+                  </a:txBody>
+                  <a:tcPr marL="91440" marR="91440" marT="36576" marB="36576" anchor="ctr">
+                    <a:lnL w="9525" cap="flat" cmpd="sng" algn="ctr">
+                      <a:solidFill>
+                        <a:srgbClr val="E5E7EB"/>
+                      </a:solidFill>
+                      <a:prstDash val="solid"/>
+                      <a:round/>
+                      <a:headEnd type="none" w="med" len="med"/>
+                      <a:tailEnd type="none" w="med" len="med"/>
+                    </a:lnL>
+                    <a:lnR w="9525" cap="flat" cmpd="sng" algn="ctr">
+                      <a:solidFill>
+                        <a:srgbClr val="E5E7EB"/>
+                      </a:solidFill>
+                      <a:prstDash val="solid"/>
+                      <a:round/>
+                      <a:headEnd type="none" w="med" len="med"/>
+                      <a:tailEnd type="none" w="med" len="med"/>
+                    </a:lnR>
+                    <a:lnT w="9525" cap="flat" cmpd="sng" algn="ctr">
+                      <a:solidFill>
+                        <a:srgbClr val="E5E7EB"/>
+                      </a:solidFill>
+                      <a:prstDash val="solid"/>
+                      <a:round/>
+                      <a:headEnd type="none" w="med" len="med"/>
+                      <a:tailEnd type="none" w="med" len="med"/>
+                    </a:lnT>
+                    <a:lnB w="9525" cap="flat" cmpd="sng" algn="ctr">
+                      <a:solidFill>
+                        <a:srgbClr val="E5E7EB"/>
+                      </a:solidFill>
+                      <a:prstDash val="solid"/>
+                      <a:round/>
+                      <a:headEnd type="none" w="med" len="med"/>
+                      <a:tailEnd type="none" w="med" len="med"/>
+                    </a:lnB>
+                    <a:solidFill>
+                      <a:srgbClr val="FFFFFF"/>
+                    </a:solidFill>
+                  </a:tcPr>
+                </a:tc>
+                <a:tc>
+                  <a:txBody>
+                    <a:bodyPr/>
+                    <a:lstStyle/>
+                    <a:p>
+                      <a:pPr indent="0" marL="0">
+                        <a:buNone/>
+                      </a:pPr>
+                      <a:r>
+                        <a:rPr lang="en-US" sz="1150" b="1" dirty="0">
+                          <a:solidFill>
+                            <a:srgbClr val="111827"/>
+                          </a:solidFill>
+                          <a:latin typeface="Calibri" pitchFamily="34" charset="0"/>
+                          <a:ea typeface="Calibri" pitchFamily="34" charset="-122"/>
+                          <a:cs typeface="Calibri" pitchFamily="34" charset="-120"/>
+                        </a:rPr>
+                        <a:t>Dispatcher role eliminated (dispatch centralized)</a:t>
+                      </a:r>
+                      <a:endParaRPr lang="en-US" sz="1150" dirty="0">
+                        <a:latin typeface="Calibri" charset="0"/>
+                        <a:ea typeface="Calibri" charset="0"/>
+                        <a:cs typeface="Calibri" charset="0"/>
+                      </a:endParaRPr>
+                    </a:p>
+                  </a:txBody>
+                  <a:tcPr marL="91440" marR="91440" marT="36576" marB="36576" anchor="ctr">
+                    <a:lnL w="9525" cap="flat" cmpd="sng" algn="ctr">
+                      <a:solidFill>
+                        <a:srgbClr val="E5E7EB"/>
+                      </a:solidFill>
+                      <a:prstDash val="solid"/>
+                      <a:round/>
+                      <a:headEnd type="none" w="med" len="med"/>
+                      <a:tailEnd type="none" w="med" len="med"/>
+                    </a:lnL>
+                    <a:lnR w="9525" cap="flat" cmpd="sng" algn="ctr">
+                      <a:solidFill>
+                        <a:srgbClr val="E5E7EB"/>
+                      </a:solidFill>
+                      <a:prstDash val="solid"/>
+                      <a:round/>
+                      <a:headEnd type="none" w="med" len="med"/>
+                      <a:tailEnd type="none" w="med" len="med"/>
+                    </a:lnR>
+                    <a:lnT w="9525" cap="flat" cmpd="sng" algn="ctr">
+                      <a:solidFill>
+                        <a:srgbClr val="E5E7EB"/>
+                      </a:solidFill>
+                      <a:prstDash val="solid"/>
+                      <a:round/>
+                      <a:headEnd type="none" w="med" len="med"/>
+                      <a:tailEnd type="none" w="med" len="med"/>
+                    </a:lnT>
+                    <a:lnB w="9525" cap="flat" cmpd="sng" algn="ctr">
+                      <a:solidFill>
+                        <a:srgbClr val="E5E7EB"/>
+                      </a:solidFill>
+                      <a:prstDash val="solid"/>
+                      <a:round/>
+                      <a:headEnd type="none" w="med" len="med"/>
+                      <a:tailEnd type="none" w="med" len="med"/>
+                    </a:lnB>
+                    <a:solidFill>
+                      <a:srgbClr val="FFFFFF"/>
+                    </a:solidFill>
+                  </a:tcPr>
+                </a:tc>
+                <a:tc>
+                  <a:txBody>
+                    <a:bodyPr/>
+                    <a:lstStyle/>
+                    <a:p>
+                      <a:pPr indent="0" marL="0">
+                        <a:buNone/>
+                      </a:pPr>
+                      <a:r>
+                        <a:rPr lang="en-US" sz="1100" dirty="0">
+                          <a:solidFill>
+                            <a:srgbClr val="6B7280"/>
+                          </a:solidFill>
+                          <a:latin typeface="Calibri" pitchFamily="34" charset="0"/>
+                          <a:ea typeface="Calibri" pitchFamily="34" charset="-122"/>
+                          <a:cs typeface="Calibri" pitchFamily="34" charset="-120"/>
+                        </a:rPr>
+                        <a:t>Admin labour</a:t>
+                      </a:r>
+                      <a:endParaRPr lang="en-US" sz="1100" dirty="0">
+                        <a:latin typeface="Calibri" charset="0"/>
+                        <a:ea typeface="Calibri" charset="0"/>
+                        <a:cs typeface="Calibri" charset="0"/>
+                      </a:endParaRPr>
+                    </a:p>
+                  </a:txBody>
+                  <a:tcPr marL="91440" marR="91440" marT="36576" marB="36576" anchor="ctr">
+                    <a:lnL w="9525" cap="flat" cmpd="sng" algn="ctr">
+                      <a:solidFill>
+                        <a:srgbClr val="E5E7EB"/>
+                      </a:solidFill>
+                      <a:prstDash val="solid"/>
+                      <a:round/>
+                      <a:headEnd type="none" w="med" len="med"/>
+                      <a:tailEnd type="none" w="med" len="med"/>
+                    </a:lnL>
+                    <a:lnR w="9525" cap="flat" cmpd="sng" algn="ctr">
+                      <a:solidFill>
+                        <a:srgbClr val="E5E7EB"/>
+                      </a:solidFill>
+                      <a:prstDash val="solid"/>
+                      <a:round/>
+                      <a:headEnd type="none" w="med" len="med"/>
+                      <a:tailEnd type="none" w="med" len="med"/>
+                    </a:lnR>
+                    <a:lnT w="9525" cap="flat" cmpd="sng" algn="ctr">
+                      <a:solidFill>
+                        <a:srgbClr val="E5E7EB"/>
+                      </a:solidFill>
+                      <a:prstDash val="solid"/>
+                      <a:round/>
+                      <a:headEnd type="none" w="med" len="med"/>
+                      <a:tailEnd type="none" w="med" len="med"/>
+                    </a:lnT>
+                    <a:lnB w="9525" cap="flat" cmpd="sng" algn="ctr">
+                      <a:solidFill>
+                        <a:srgbClr val="E5E7EB"/>
+                      </a:solidFill>
+                      <a:prstDash val="solid"/>
+                      <a:round/>
+                      <a:headEnd type="none" w="med" len="med"/>
+                      <a:tailEnd type="none" w="med" len="med"/>
+                    </a:lnB>
+                    <a:solidFill>
+                      <a:srgbClr val="FFFFFF"/>
+                    </a:solidFill>
+                  </a:tcPr>
+                </a:tc>
+                <a:tc>
+                  <a:txBody>
+                    <a:bodyPr/>
+                    <a:lstStyle/>
+                    <a:p>
+                      <a:pPr algn="ctr" indent="0" marL="0">
+                        <a:buNone/>
+                      </a:pPr>
+                      <a:r>
+                        <a:rPr lang="en-US" sz="1100" b="1" dirty="0">
+                          <a:solidFill>
+                            <a:srgbClr val="059669"/>
+                          </a:solidFill>
+                          <a:latin typeface="Calibri" pitchFamily="34" charset="0"/>
+                          <a:ea typeface="Calibri" pitchFamily="34" charset="-122"/>
+                          <a:cs typeface="Calibri" pitchFamily="34" charset="-120"/>
+                        </a:rPr>
+                        <a:t>Confirmed</a:t>
+                      </a:r>
+                      <a:endParaRPr lang="en-US" sz="1100" dirty="0">
+                        <a:latin typeface="Calibri" charset="0"/>
+                        <a:ea typeface="Calibri" charset="0"/>
+                        <a:cs typeface="Calibri" charset="0"/>
+                      </a:endParaRPr>
+                    </a:p>
+                  </a:txBody>
+                  <a:tcPr marL="91440" marR="91440" marT="36576" marB="36576" anchor="ctr">
+                    <a:lnL w="9525" cap="flat" cmpd="sng" algn="ctr">
+                      <a:solidFill>
+                        <a:srgbClr val="E5E7EB"/>
+                      </a:solidFill>
+                      <a:prstDash val="solid"/>
+                      <a:round/>
+                      <a:headEnd type="none" w="med" len="med"/>
+                      <a:tailEnd type="none" w="med" len="med"/>
+                    </a:lnL>
+                    <a:lnR w="9525" cap="flat" cmpd="sng" algn="ctr">
+                      <a:solidFill>
+                        <a:srgbClr val="E5E7EB"/>
+                      </a:solidFill>
+                      <a:prstDash val="solid"/>
+                      <a:round/>
+                      <a:headEnd type="none" w="med" len="med"/>
+                      <a:tailEnd type="none" w="med" len="med"/>
+                    </a:lnR>
+                    <a:lnT w="9525" cap="flat" cmpd="sng" algn="ctr">
+                      <a:solidFill>
+                        <a:srgbClr val="E5E7EB"/>
+                      </a:solidFill>
+                      <a:prstDash val="solid"/>
+                      <a:round/>
+                      <a:headEnd type="none" w="med" len="med"/>
+                      <a:tailEnd type="none" w="med" len="med"/>
+                    </a:lnT>
+                    <a:lnB w="9525" cap="flat" cmpd="sng" algn="ctr">
+                      <a:solidFill>
+                        <a:srgbClr val="E5E7EB"/>
+                      </a:solidFill>
+                      <a:prstDash val="solid"/>
+                      <a:round/>
+                      <a:headEnd type="none" w="med" len="med"/>
+                      <a:tailEnd type="none" w="med" len="med"/>
+                    </a:lnB>
+                    <a:solidFill>
+                      <a:srgbClr val="D1FAE5"/>
                     </a:solidFill>
                   </a:tcPr>
                 </a:tc>
@@ -18137,17 +19123,17 @@
                         <a:buNone/>
                       </a:pPr>
                       <a:r>
-                        <a:rPr lang="en-US" sz="1200" b="1" dirty="0">
+                        <a:rPr lang="en-US" sz="1150" b="1" dirty="0">
                           <a:solidFill>
-                            <a:srgbClr val="FFFFFF"/>
+                            <a:srgbClr val="059669"/>
                           </a:solidFill>
                           <a:latin typeface="Calibri" pitchFamily="34" charset="0"/>
                           <a:ea typeface="Calibri" pitchFamily="34" charset="-122"/>
                           <a:cs typeface="Calibri" pitchFamily="34" charset="-120"/>
                         </a:rPr>
-                        <a:t>Realized YTD ($)</a:t>
+                        <a:t>$61,000</a:t>
                       </a:r>
-                      <a:endParaRPr lang="en-US" sz="1200" dirty="0">
+                      <a:endParaRPr lang="en-US" sz="1150" dirty="0">
                         <a:latin typeface="Calibri" charset="0"/>
                         <a:ea typeface="Calibri" charset="0"/>
                         <a:cs typeface="Calibri" charset="0"/>
@@ -18192,7 +19178,77 @@
                       <a:tailEnd type="none" w="med" len="med"/>
                     </a:lnB>
                     <a:solidFill>
-                      <a:srgbClr val="1F2937"/>
+                      <a:srgbClr val="FFFFFF"/>
+                    </a:solidFill>
+                  </a:tcPr>
+                </a:tc>
+              </a:tr>
+              <a:tr h="365760">
+                <a:tc>
+                  <a:txBody>
+                    <a:bodyPr/>
+                    <a:lstStyle/>
+                    <a:p>
+                      <a:pPr algn="ctr" indent="0" marL="0">
+                        <a:buNone/>
+                      </a:pPr>
+                      <a:r>
+                        <a:rPr lang="en-US" sz="1150" dirty="0">
+                          <a:solidFill>
+                            <a:srgbClr val="6B7280"/>
+                          </a:solidFill>
+                          <a:latin typeface="Calibri" pitchFamily="34" charset="0"/>
+                          <a:ea typeface="Calibri" pitchFamily="34" charset="-122"/>
+                          <a:cs typeface="Calibri" pitchFamily="34" charset="-120"/>
+                        </a:rPr>
+                        <a:t>2</a:t>
+                      </a:r>
+                      <a:endParaRPr lang="en-US" sz="1150" dirty="0">
+                        <a:latin typeface="Calibri" charset="0"/>
+                        <a:ea typeface="Calibri" charset="0"/>
+                        <a:cs typeface="Calibri" charset="0"/>
+                      </a:endParaRPr>
+                    </a:p>
+                  </a:txBody>
+                  <a:tcPr marL="91440" marR="91440" marT="36576" marB="36576" anchor="ctr">
+                    <a:lnL w="9525" cap="flat" cmpd="sng" algn="ctr">
+                      <a:solidFill>
+                        <a:srgbClr val="E5E7EB"/>
+                      </a:solidFill>
+                      <a:prstDash val="solid"/>
+                      <a:round/>
+                      <a:headEnd type="none" w="med" len="med"/>
+                      <a:tailEnd type="none" w="med" len="med"/>
+                    </a:lnL>
+                    <a:lnR w="9525" cap="flat" cmpd="sng" algn="ctr">
+                      <a:solidFill>
+                        <a:srgbClr val="E5E7EB"/>
+                      </a:solidFill>
+                      <a:prstDash val="solid"/>
+                      <a:round/>
+                      <a:headEnd type="none" w="med" len="med"/>
+                      <a:tailEnd type="none" w="med" len="med"/>
+                    </a:lnR>
+                    <a:lnT w="9525" cap="flat" cmpd="sng" algn="ctr">
+                      <a:solidFill>
+                        <a:srgbClr val="E5E7EB"/>
+                      </a:solidFill>
+                      <a:prstDash val="solid"/>
+                      <a:round/>
+                      <a:headEnd type="none" w="med" len="med"/>
+                      <a:tailEnd type="none" w="med" len="med"/>
+                    </a:lnT>
+                    <a:lnB w="9525" cap="flat" cmpd="sng" algn="ctr">
+                      <a:solidFill>
+                        <a:srgbClr val="E5E7EB"/>
+                      </a:solidFill>
+                      <a:prstDash val="solid"/>
+                      <a:round/>
+                      <a:headEnd type="none" w="med" len="med"/>
+                      <a:tailEnd type="none" w="med" len="med"/>
+                    </a:lnB>
+                    <a:solidFill>
+                      <a:srgbClr val="F9FAFB"/>
                     </a:solidFill>
                   </a:tcPr>
                 </a:tc>
@@ -18205,17 +19261,17 @@
                         <a:buNone/>
                       </a:pPr>
                       <a:r>
-                        <a:rPr lang="en-US" sz="1200" b="1" dirty="0">
+                        <a:rPr lang="en-US" sz="1150" dirty="0">
                           <a:solidFill>
-                            <a:srgbClr val="FFFFFF"/>
+                            <a:srgbClr val="111827"/>
                           </a:solidFill>
                           <a:latin typeface="Calibri" pitchFamily="34" charset="0"/>
                           <a:ea typeface="Calibri" pitchFamily="34" charset="-122"/>
                           <a:cs typeface="Calibri" pitchFamily="34" charset="-120"/>
                         </a:rPr>
-                        <a:t>Status</a:t>
+                        <a:t>Agency labour mix (≤61% of dock hours vs 70.5% F26)</a:t>
                       </a:r>
-                      <a:endParaRPr lang="en-US" sz="1200" dirty="0">
+                      <a:endParaRPr lang="en-US" sz="1150" dirty="0">
                         <a:latin typeface="Calibri" charset="0"/>
                         <a:ea typeface="Calibri" charset="0"/>
                         <a:cs typeface="Calibri" charset="0"/>
@@ -18260,75 +19316,8 @@
                       <a:tailEnd type="none" w="med" len="med"/>
                     </a:lnB>
                     <a:solidFill>
-                      <a:srgbClr val="1F2937"/>
+                      <a:srgbClr val="F9FAFB"/>
                     </a:solidFill>
-                  </a:tcPr>
-                </a:tc>
-              </a:tr>
-              <a:tr h="502920">
-                <a:tc>
-                  <a:txBody>
-                    <a:bodyPr/>
-                    <a:lstStyle/>
-                    <a:p>
-                      <a:pPr algn="ctr" indent="0" marL="0">
-                        <a:buNone/>
-                      </a:pPr>
-                      <a:r>
-                        <a:rPr lang="en-US" sz="1200" dirty="0">
-                          <a:solidFill>
-                            <a:srgbClr val="6B7280"/>
-                          </a:solidFill>
-                          <a:latin typeface="Calibri" pitchFamily="34" charset="0"/>
-                          <a:ea typeface="Calibri" pitchFamily="34" charset="-122"/>
-                          <a:cs typeface="Calibri" pitchFamily="34" charset="-120"/>
-                        </a:rPr>
-                        <a:t>1</a:t>
-                      </a:r>
-                      <a:endParaRPr lang="en-US" sz="1200" dirty="0">
-                        <a:latin typeface="Calibri" charset="0"/>
-                        <a:ea typeface="Calibri" charset="0"/>
-                        <a:cs typeface="Calibri" charset="0"/>
-                      </a:endParaRPr>
-                    </a:p>
-                  </a:txBody>
-                  <a:tcPr marL="91440" marR="91440" marT="36576" marB="36576" anchor="ctr">
-                    <a:lnL w="9525" cap="flat" cmpd="sng" algn="ctr">
-                      <a:solidFill>
-                        <a:srgbClr val="E5E7EB"/>
-                      </a:solidFill>
-                      <a:prstDash val="solid"/>
-                      <a:round/>
-                      <a:headEnd type="none" w="med" len="med"/>
-                      <a:tailEnd type="none" w="med" len="med"/>
-                    </a:lnL>
-                    <a:lnR w="9525" cap="flat" cmpd="sng" algn="ctr">
-                      <a:solidFill>
-                        <a:srgbClr val="E5E7EB"/>
-                      </a:solidFill>
-                      <a:prstDash val="solid"/>
-                      <a:round/>
-                      <a:headEnd type="none" w="med" len="med"/>
-                      <a:tailEnd type="none" w="med" len="med"/>
-                    </a:lnR>
-                    <a:lnT w="9525" cap="flat" cmpd="sng" algn="ctr">
-                      <a:solidFill>
-                        <a:srgbClr val="E5E7EB"/>
-                      </a:solidFill>
-                      <a:prstDash val="solid"/>
-                      <a:round/>
-                      <a:headEnd type="none" w="med" len="med"/>
-                      <a:tailEnd type="none" w="med" len="med"/>
-                    </a:lnT>
-                    <a:lnB w="9525" cap="flat" cmpd="sng" algn="ctr">
-                      <a:solidFill>
-                        <a:srgbClr val="E5E7EB"/>
-                      </a:solidFill>
-                      <a:prstDash val="solid"/>
-                      <a:round/>
-                      <a:headEnd type="none" w="med" len="med"/>
-                      <a:tailEnd type="none" w="med" len="med"/>
-                    </a:lnB>
                   </a:tcPr>
                 </a:tc>
                 <a:tc>
@@ -18340,17 +19329,17 @@
                         <a:buNone/>
                       </a:pPr>
                       <a:r>
-                        <a:rPr lang="en-US" sz="1200" b="1" dirty="0">
+                        <a:rPr lang="en-US" sz="1100" dirty="0">
                           <a:solidFill>
-                            <a:srgbClr val="111827"/>
+                            <a:srgbClr val="6B7280"/>
                           </a:solidFill>
                           <a:latin typeface="Calibri" pitchFamily="34" charset="0"/>
                           <a:ea typeface="Calibri" pitchFamily="34" charset="-122"/>
                           <a:cs typeface="Calibri" pitchFamily="34" charset="-120"/>
                         </a:rPr>
-                        <a:t>Dispatcher role eliminated — dispatch centralized</a:t>
+                        <a:t>Dock labour</a:t>
                       </a:r>
-                      <a:endParaRPr lang="en-US" sz="1200" dirty="0">
+                      <a:endParaRPr lang="en-US" sz="1100" dirty="0">
                         <a:latin typeface="Calibri" charset="0"/>
                         <a:ea typeface="Calibri" charset="0"/>
                         <a:cs typeface="Calibri" charset="0"/>
@@ -18394,6 +19383,77 @@
                       <a:headEnd type="none" w="med" len="med"/>
                       <a:tailEnd type="none" w="med" len="med"/>
                     </a:lnB>
+                    <a:solidFill>
+                      <a:srgbClr val="F9FAFB"/>
+                    </a:solidFill>
+                  </a:tcPr>
+                </a:tc>
+                <a:tc>
+                  <a:txBody>
+                    <a:bodyPr/>
+                    <a:lstStyle/>
+                    <a:p>
+                      <a:pPr algn="ctr" indent="0" marL="0">
+                        <a:buNone/>
+                      </a:pPr>
+                      <a:r>
+                        <a:rPr lang="en-US" sz="1100" b="1" dirty="0">
+                          <a:solidFill>
+                            <a:srgbClr val="2563EB"/>
+                          </a:solidFill>
+                          <a:latin typeface="Calibri" pitchFamily="34" charset="0"/>
+                          <a:ea typeface="Calibri" pitchFamily="34" charset="-122"/>
+                          <a:cs typeface="Calibri" pitchFamily="34" charset="-120"/>
+                        </a:rPr>
+                        <a:t>In progress</a:t>
+                      </a:r>
+                      <a:endParaRPr lang="en-US" sz="1100" dirty="0">
+                        <a:latin typeface="Calibri" charset="0"/>
+                        <a:ea typeface="Calibri" charset="0"/>
+                        <a:cs typeface="Calibri" charset="0"/>
+                      </a:endParaRPr>
+                    </a:p>
+                  </a:txBody>
+                  <a:tcPr marL="91440" marR="91440" marT="36576" marB="36576" anchor="ctr">
+                    <a:lnL w="9525" cap="flat" cmpd="sng" algn="ctr">
+                      <a:solidFill>
+                        <a:srgbClr val="E5E7EB"/>
+                      </a:solidFill>
+                      <a:prstDash val="solid"/>
+                      <a:round/>
+                      <a:headEnd type="none" w="med" len="med"/>
+                      <a:tailEnd type="none" w="med" len="med"/>
+                    </a:lnL>
+                    <a:lnR w="9525" cap="flat" cmpd="sng" algn="ctr">
+                      <a:solidFill>
+                        <a:srgbClr val="E5E7EB"/>
+                      </a:solidFill>
+                      <a:prstDash val="solid"/>
+                      <a:round/>
+                      <a:headEnd type="none" w="med" len="med"/>
+                      <a:tailEnd type="none" w="med" len="med"/>
+                    </a:lnR>
+                    <a:lnT w="9525" cap="flat" cmpd="sng" algn="ctr">
+                      <a:solidFill>
+                        <a:srgbClr val="E5E7EB"/>
+                      </a:solidFill>
+                      <a:prstDash val="solid"/>
+                      <a:round/>
+                      <a:headEnd type="none" w="med" len="med"/>
+                      <a:tailEnd type="none" w="med" len="med"/>
+                    </a:lnT>
+                    <a:lnB w="9525" cap="flat" cmpd="sng" algn="ctr">
+                      <a:solidFill>
+                        <a:srgbClr val="E5E7EB"/>
+                      </a:solidFill>
+                      <a:prstDash val="solid"/>
+                      <a:round/>
+                      <a:headEnd type="none" w="med" len="med"/>
+                      <a:tailEnd type="none" w="med" len="med"/>
+                    </a:lnB>
+                    <a:solidFill>
+                      <a:srgbClr val="DBEAFE"/>
+                    </a:solidFill>
                   </a:tcPr>
                 </a:tc>
                 <a:tc>
@@ -18405,17 +19465,17 @@
                         <a:buNone/>
                       </a:pPr>
                       <a:r>
-                        <a:rPr lang="en-US" sz="1200" b="1" dirty="0">
+                        <a:rPr lang="en-US" sz="1150" b="1" dirty="0">
                           <a:solidFill>
-                            <a:srgbClr val="111827"/>
+                            <a:srgbClr val="D97706"/>
                           </a:solidFill>
                           <a:latin typeface="Calibri" pitchFamily="34" charset="0"/>
                           <a:ea typeface="Calibri" pitchFamily="34" charset="-122"/>
                           <a:cs typeface="Calibri" pitchFamily="34" charset="-120"/>
                         </a:rPr>
-                        <a:t>$61,000</a:t>
+                        <a:t>TBC</a:t>
                       </a:r>
-                      <a:endParaRPr lang="en-US" sz="1200" dirty="0">
+                      <a:endParaRPr lang="en-US" sz="1150" dirty="0">
                         <a:latin typeface="Calibri" charset="0"/>
                         <a:ea typeface="Calibri" charset="0"/>
                         <a:cs typeface="Calibri" charset="0"/>
@@ -18459,6 +19519,283 @@
                       <a:headEnd type="none" w="med" len="med"/>
                       <a:tailEnd type="none" w="med" len="med"/>
                     </a:lnB>
+                    <a:solidFill>
+                      <a:srgbClr val="F9FAFB"/>
+                    </a:solidFill>
+                  </a:tcPr>
+                </a:tc>
+              </a:tr>
+              <a:tr h="365760">
+                <a:tc>
+                  <a:txBody>
+                    <a:bodyPr/>
+                    <a:lstStyle/>
+                    <a:p>
+                      <a:pPr algn="ctr" indent="0" marL="0">
+                        <a:buNone/>
+                      </a:pPr>
+                      <a:r>
+                        <a:rPr lang="en-US" sz="1150" dirty="0">
+                          <a:solidFill>
+                            <a:srgbClr val="6B7280"/>
+                          </a:solidFill>
+                          <a:latin typeface="Calibri" pitchFamily="34" charset="0"/>
+                          <a:ea typeface="Calibri" pitchFamily="34" charset="-122"/>
+                          <a:cs typeface="Calibri" pitchFamily="34" charset="-120"/>
+                        </a:rPr>
+                        <a:t>3</a:t>
+                      </a:r>
+                      <a:endParaRPr lang="en-US" sz="1150" dirty="0">
+                        <a:latin typeface="Calibri" charset="0"/>
+                        <a:ea typeface="Calibri" charset="0"/>
+                        <a:cs typeface="Calibri" charset="0"/>
+                      </a:endParaRPr>
+                    </a:p>
+                  </a:txBody>
+                  <a:tcPr marL="91440" marR="91440" marT="36576" marB="36576" anchor="ctr">
+                    <a:lnL w="9525" cap="flat" cmpd="sng" algn="ctr">
+                      <a:solidFill>
+                        <a:srgbClr val="E5E7EB"/>
+                      </a:solidFill>
+                      <a:prstDash val="solid"/>
+                      <a:round/>
+                      <a:headEnd type="none" w="med" len="med"/>
+                      <a:tailEnd type="none" w="med" len="med"/>
+                    </a:lnL>
+                    <a:lnR w="9525" cap="flat" cmpd="sng" algn="ctr">
+                      <a:solidFill>
+                        <a:srgbClr val="E5E7EB"/>
+                      </a:solidFill>
+                      <a:prstDash val="solid"/>
+                      <a:round/>
+                      <a:headEnd type="none" w="med" len="med"/>
+                      <a:tailEnd type="none" w="med" len="med"/>
+                    </a:lnR>
+                    <a:lnT w="9525" cap="flat" cmpd="sng" algn="ctr">
+                      <a:solidFill>
+                        <a:srgbClr val="E5E7EB"/>
+                      </a:solidFill>
+                      <a:prstDash val="solid"/>
+                      <a:round/>
+                      <a:headEnd type="none" w="med" len="med"/>
+                      <a:tailEnd type="none" w="med" len="med"/>
+                    </a:lnT>
+                    <a:lnB w="9525" cap="flat" cmpd="sng" algn="ctr">
+                      <a:solidFill>
+                        <a:srgbClr val="E5E7EB"/>
+                      </a:solidFill>
+                      <a:prstDash val="solid"/>
+                      <a:round/>
+                      <a:headEnd type="none" w="med" len="med"/>
+                      <a:tailEnd type="none" w="med" len="med"/>
+                    </a:lnB>
+                    <a:solidFill>
+                      <a:srgbClr val="FFFFFF"/>
+                    </a:solidFill>
+                  </a:tcPr>
+                </a:tc>
+                <a:tc>
+                  <a:txBody>
+                    <a:bodyPr/>
+                    <a:lstStyle/>
+                    <a:p>
+                      <a:pPr indent="0" marL="0">
+                        <a:buNone/>
+                      </a:pPr>
+                      <a:r>
+                        <a:rPr lang="en-US" sz="1150" dirty="0">
+                          <a:solidFill>
+                            <a:srgbClr val="111827"/>
+                          </a:solidFill>
+                          <a:latin typeface="Calibri" pitchFamily="34" charset="0"/>
+                          <a:ea typeface="Calibri" pitchFamily="34" charset="-122"/>
+                          <a:cs typeface="Calibri" pitchFamily="34" charset="-120"/>
+                        </a:rPr>
+                        <a:t>Hours under SCA allowance (391 hrs Sept MTD ≈ $13.1K)</a:t>
+                      </a:r>
+                      <a:endParaRPr lang="en-US" sz="1150" dirty="0">
+                        <a:latin typeface="Calibri" charset="0"/>
+                        <a:ea typeface="Calibri" charset="0"/>
+                        <a:cs typeface="Calibri" charset="0"/>
+                      </a:endParaRPr>
+                    </a:p>
+                  </a:txBody>
+                  <a:tcPr marL="91440" marR="91440" marT="36576" marB="36576" anchor="ctr">
+                    <a:lnL w="9525" cap="flat" cmpd="sng" algn="ctr">
+                      <a:solidFill>
+                        <a:srgbClr val="E5E7EB"/>
+                      </a:solidFill>
+                      <a:prstDash val="solid"/>
+                      <a:round/>
+                      <a:headEnd type="none" w="med" len="med"/>
+                      <a:tailEnd type="none" w="med" len="med"/>
+                    </a:lnL>
+                    <a:lnR w="9525" cap="flat" cmpd="sng" algn="ctr">
+                      <a:solidFill>
+                        <a:srgbClr val="E5E7EB"/>
+                      </a:solidFill>
+                      <a:prstDash val="solid"/>
+                      <a:round/>
+                      <a:headEnd type="none" w="med" len="med"/>
+                      <a:tailEnd type="none" w="med" len="med"/>
+                    </a:lnR>
+                    <a:lnT w="9525" cap="flat" cmpd="sng" algn="ctr">
+                      <a:solidFill>
+                        <a:srgbClr val="E5E7EB"/>
+                      </a:solidFill>
+                      <a:prstDash val="solid"/>
+                      <a:round/>
+                      <a:headEnd type="none" w="med" len="med"/>
+                      <a:tailEnd type="none" w="med" len="med"/>
+                    </a:lnT>
+                    <a:lnB w="9525" cap="flat" cmpd="sng" algn="ctr">
+                      <a:solidFill>
+                        <a:srgbClr val="E5E7EB"/>
+                      </a:solidFill>
+                      <a:prstDash val="solid"/>
+                      <a:round/>
+                      <a:headEnd type="none" w="med" len="med"/>
+                      <a:tailEnd type="none" w="med" len="med"/>
+                    </a:lnB>
+                    <a:solidFill>
+                      <a:srgbClr val="FFFFFF"/>
+                    </a:solidFill>
+                  </a:tcPr>
+                </a:tc>
+                <a:tc>
+                  <a:txBody>
+                    <a:bodyPr/>
+                    <a:lstStyle/>
+                    <a:p>
+                      <a:pPr indent="0" marL="0">
+                        <a:buNone/>
+                      </a:pPr>
+                      <a:r>
+                        <a:rPr lang="en-US" sz="1100" dirty="0">
+                          <a:solidFill>
+                            <a:srgbClr val="6B7280"/>
+                          </a:solidFill>
+                          <a:latin typeface="Calibri" pitchFamily="34" charset="0"/>
+                          <a:ea typeface="Calibri" pitchFamily="34" charset="-122"/>
+                          <a:cs typeface="Calibri" pitchFamily="34" charset="-120"/>
+                        </a:rPr>
+                        <a:t>Dock labour</a:t>
+                      </a:r>
+                      <a:endParaRPr lang="en-US" sz="1100" dirty="0">
+                        <a:latin typeface="Calibri" charset="0"/>
+                        <a:ea typeface="Calibri" charset="0"/>
+                        <a:cs typeface="Calibri" charset="0"/>
+                      </a:endParaRPr>
+                    </a:p>
+                  </a:txBody>
+                  <a:tcPr marL="91440" marR="91440" marT="36576" marB="36576" anchor="ctr">
+                    <a:lnL w="9525" cap="flat" cmpd="sng" algn="ctr">
+                      <a:solidFill>
+                        <a:srgbClr val="E5E7EB"/>
+                      </a:solidFill>
+                      <a:prstDash val="solid"/>
+                      <a:round/>
+                      <a:headEnd type="none" w="med" len="med"/>
+                      <a:tailEnd type="none" w="med" len="med"/>
+                    </a:lnL>
+                    <a:lnR w="9525" cap="flat" cmpd="sng" algn="ctr">
+                      <a:solidFill>
+                        <a:srgbClr val="E5E7EB"/>
+                      </a:solidFill>
+                      <a:prstDash val="solid"/>
+                      <a:round/>
+                      <a:headEnd type="none" w="med" len="med"/>
+                      <a:tailEnd type="none" w="med" len="med"/>
+                    </a:lnR>
+                    <a:lnT w="9525" cap="flat" cmpd="sng" algn="ctr">
+                      <a:solidFill>
+                        <a:srgbClr val="E5E7EB"/>
+                      </a:solidFill>
+                      <a:prstDash val="solid"/>
+                      <a:round/>
+                      <a:headEnd type="none" w="med" len="med"/>
+                      <a:tailEnd type="none" w="med" len="med"/>
+                    </a:lnT>
+                    <a:lnB w="9525" cap="flat" cmpd="sng" algn="ctr">
+                      <a:solidFill>
+                        <a:srgbClr val="E5E7EB"/>
+                      </a:solidFill>
+                      <a:prstDash val="solid"/>
+                      <a:round/>
+                      <a:headEnd type="none" w="med" len="med"/>
+                      <a:tailEnd type="none" w="med" len="med"/>
+                    </a:lnB>
+                    <a:solidFill>
+                      <a:srgbClr val="FFFFFF"/>
+                    </a:solidFill>
+                  </a:tcPr>
+                </a:tc>
+                <a:tc>
+                  <a:txBody>
+                    <a:bodyPr/>
+                    <a:lstStyle/>
+                    <a:p>
+                      <a:pPr algn="ctr" indent="0" marL="0">
+                        <a:buNone/>
+                      </a:pPr>
+                      <a:r>
+                        <a:rPr lang="en-US" sz="1100" b="1" dirty="0">
+                          <a:solidFill>
+                            <a:srgbClr val="2563EB"/>
+                          </a:solidFill>
+                          <a:latin typeface="Calibri" pitchFamily="34" charset="0"/>
+                          <a:ea typeface="Calibri" pitchFamily="34" charset="-122"/>
+                          <a:cs typeface="Calibri" pitchFamily="34" charset="-120"/>
+                        </a:rPr>
+                        <a:t>In progress</a:t>
+                      </a:r>
+                      <a:endParaRPr lang="en-US" sz="1100" dirty="0">
+                        <a:latin typeface="Calibri" charset="0"/>
+                        <a:ea typeface="Calibri" charset="0"/>
+                        <a:cs typeface="Calibri" charset="0"/>
+                      </a:endParaRPr>
+                    </a:p>
+                  </a:txBody>
+                  <a:tcPr marL="91440" marR="91440" marT="36576" marB="36576" anchor="ctr">
+                    <a:lnL w="9525" cap="flat" cmpd="sng" algn="ctr">
+                      <a:solidFill>
+                        <a:srgbClr val="E5E7EB"/>
+                      </a:solidFill>
+                      <a:prstDash val="solid"/>
+                      <a:round/>
+                      <a:headEnd type="none" w="med" len="med"/>
+                      <a:tailEnd type="none" w="med" len="med"/>
+                    </a:lnL>
+                    <a:lnR w="9525" cap="flat" cmpd="sng" algn="ctr">
+                      <a:solidFill>
+                        <a:srgbClr val="E5E7EB"/>
+                      </a:solidFill>
+                      <a:prstDash val="solid"/>
+                      <a:round/>
+                      <a:headEnd type="none" w="med" len="med"/>
+                      <a:tailEnd type="none" w="med" len="med"/>
+                    </a:lnR>
+                    <a:lnT w="9525" cap="flat" cmpd="sng" algn="ctr">
+                      <a:solidFill>
+                        <a:srgbClr val="E5E7EB"/>
+                      </a:solidFill>
+                      <a:prstDash val="solid"/>
+                      <a:round/>
+                      <a:headEnd type="none" w="med" len="med"/>
+                      <a:tailEnd type="none" w="med" len="med"/>
+                    </a:lnT>
+                    <a:lnB w="9525" cap="flat" cmpd="sng" algn="ctr">
+                      <a:solidFill>
+                        <a:srgbClr val="E5E7EB"/>
+                      </a:solidFill>
+                      <a:prstDash val="solid"/>
+                      <a:round/>
+                      <a:headEnd type="none" w="med" len="med"/>
+                      <a:tailEnd type="none" w="med" len="med"/>
+                    </a:lnB>
+                    <a:solidFill>
+                      <a:srgbClr val="DBEAFE"/>
+                    </a:solidFill>
                   </a:tcPr>
                 </a:tc>
                 <a:tc>
@@ -18470,7 +19807,7 @@
                         <a:buNone/>
                       </a:pPr>
                       <a:r>
-                        <a:rPr lang="en-US" sz="1200" b="1" dirty="0">
+                        <a:rPr lang="en-US" sz="1150" b="1" dirty="0">
                           <a:solidFill>
                             <a:srgbClr val="D97706"/>
                           </a:solidFill>
@@ -18480,7 +19817,7 @@
                         </a:rPr>
                         <a:t>TBC</a:t>
                       </a:r>
-                      <a:endParaRPr lang="en-US" sz="1200" dirty="0">
+                      <a:endParaRPr lang="en-US" sz="1150" dirty="0">
                         <a:latin typeface="Calibri" charset="0"/>
                         <a:ea typeface="Calibri" charset="0"/>
                         <a:cs typeface="Calibri" charset="0"/>
@@ -18524,6 +19861,79 @@
                       <a:headEnd type="none" w="med" len="med"/>
                       <a:tailEnd type="none" w="med" len="med"/>
                     </a:lnB>
+                    <a:solidFill>
+                      <a:srgbClr val="FFFFFF"/>
+                    </a:solidFill>
+                  </a:tcPr>
+                </a:tc>
+              </a:tr>
+              <a:tr h="365760">
+                <a:tc>
+                  <a:txBody>
+                    <a:bodyPr/>
+                    <a:lstStyle/>
+                    <a:p>
+                      <a:pPr algn="ctr" indent="0" marL="0">
+                        <a:buNone/>
+                      </a:pPr>
+                      <a:r>
+                        <a:rPr lang="en-US" sz="1150" dirty="0">
+                          <a:solidFill>
+                            <a:srgbClr val="6B7280"/>
+                          </a:solidFill>
+                          <a:latin typeface="Calibri" pitchFamily="34" charset="0"/>
+                          <a:ea typeface="Calibri" pitchFamily="34" charset="-122"/>
+                          <a:cs typeface="Calibri" pitchFamily="34" charset="-120"/>
+                        </a:rPr>
+                        <a:t>4</a:t>
+                      </a:r>
+                      <a:endParaRPr lang="en-US" sz="1150" dirty="0">
+                        <a:latin typeface="Calibri" charset="0"/>
+                        <a:ea typeface="Calibri" charset="0"/>
+                        <a:cs typeface="Calibri" charset="0"/>
+                      </a:endParaRPr>
+                    </a:p>
+                  </a:txBody>
+                  <a:tcPr marL="91440" marR="91440" marT="36576" marB="36576" anchor="ctr">
+                    <a:lnL w="9525" cap="flat" cmpd="sng" algn="ctr">
+                      <a:solidFill>
+                        <a:srgbClr val="E5E7EB"/>
+                      </a:solidFill>
+                      <a:prstDash val="solid"/>
+                      <a:round/>
+                      <a:headEnd type="none" w="med" len="med"/>
+                      <a:tailEnd type="none" w="med" len="med"/>
+                    </a:lnL>
+                    <a:lnR w="9525" cap="flat" cmpd="sng" algn="ctr">
+                      <a:solidFill>
+                        <a:srgbClr val="E5E7EB"/>
+                      </a:solidFill>
+                      <a:prstDash val="solid"/>
+                      <a:round/>
+                      <a:headEnd type="none" w="med" len="med"/>
+                      <a:tailEnd type="none" w="med" len="med"/>
+                    </a:lnR>
+                    <a:lnT w="9525" cap="flat" cmpd="sng" algn="ctr">
+                      <a:solidFill>
+                        <a:srgbClr val="E5E7EB"/>
+                      </a:solidFill>
+                      <a:prstDash val="solid"/>
+                      <a:round/>
+                      <a:headEnd type="none" w="med" len="med"/>
+                      <a:tailEnd type="none" w="med" len="med"/>
+                    </a:lnT>
+                    <a:lnB w="9525" cap="flat" cmpd="sng" algn="ctr">
+                      <a:solidFill>
+                        <a:srgbClr val="E5E7EB"/>
+                      </a:solidFill>
+                      <a:prstDash val="solid"/>
+                      <a:round/>
+                      <a:headEnd type="none" w="med" len="med"/>
+                      <a:tailEnd type="none" w="med" len="med"/>
+                    </a:lnB>
+                    <a:solidFill>
+                      <a:srgbClr val="F9FAFB"/>
+                    </a:solidFill>
                   </a:tcPr>
                 </a:tc>
                 <a:tc>
@@ -18535,17 +19945,17 @@
                         <a:buNone/>
                       </a:pPr>
                       <a:r>
-                        <a:rPr lang="en-US" sz="1200" b="1" dirty="0">
+                        <a:rPr lang="en-US" sz="1150" dirty="0">
                           <a:solidFill>
-                            <a:srgbClr val="059669"/>
+                            <a:srgbClr val="111827"/>
                           </a:solidFill>
                           <a:latin typeface="Calibri" pitchFamily="34" charset="0"/>
                           <a:ea typeface="Calibri" pitchFamily="34" charset="-122"/>
                           <a:cs typeface="Calibri" pitchFamily="34" charset="-120"/>
                         </a:rPr>
-                        <a:t>Confirmed</a:t>
+                        <a:t>Load securement &amp; decking (ANCRA)</a:t>
                       </a:r>
-                      <a:endParaRPr lang="en-US" sz="1200" dirty="0">
+                      <a:endParaRPr lang="en-US" sz="1150" dirty="0">
                         <a:latin typeface="Calibri" charset="0"/>
                         <a:ea typeface="Calibri" charset="0"/>
                         <a:cs typeface="Calibri" charset="0"/>
@@ -18589,10 +19999,1243 @@
                       <a:headEnd type="none" w="med" len="med"/>
                       <a:tailEnd type="none" w="med" len="med"/>
                     </a:lnB>
+                    <a:solidFill>
+                      <a:srgbClr val="F9FAFB"/>
+                    </a:solidFill>
+                  </a:tcPr>
+                </a:tc>
+                <a:tc>
+                  <a:txBody>
+                    <a:bodyPr/>
+                    <a:lstStyle/>
+                    <a:p>
+                      <a:pPr indent="0" marL="0">
+                        <a:buNone/>
+                      </a:pPr>
+                      <a:r>
+                        <a:rPr lang="en-US" sz="1100" dirty="0">
+                          <a:solidFill>
+                            <a:srgbClr val="6B7280"/>
+                          </a:solidFill>
+                          <a:latin typeface="Calibri" pitchFamily="34" charset="0"/>
+                          <a:ea typeface="Calibri" pitchFamily="34" charset="-122"/>
+                          <a:cs typeface="Calibri" pitchFamily="34" charset="-120"/>
+                        </a:rPr>
+                        <a:t>Linehaul / load factor</a:t>
+                      </a:r>
+                      <a:endParaRPr lang="en-US" sz="1100" dirty="0">
+                        <a:latin typeface="Calibri" charset="0"/>
+                        <a:ea typeface="Calibri" charset="0"/>
+                        <a:cs typeface="Calibri" charset="0"/>
+                      </a:endParaRPr>
+                    </a:p>
+                  </a:txBody>
+                  <a:tcPr marL="91440" marR="91440" marT="36576" marB="36576" anchor="ctr">
+                    <a:lnL w="9525" cap="flat" cmpd="sng" algn="ctr">
+                      <a:solidFill>
+                        <a:srgbClr val="E5E7EB"/>
+                      </a:solidFill>
+                      <a:prstDash val="solid"/>
+                      <a:round/>
+                      <a:headEnd type="none" w="med" len="med"/>
+                      <a:tailEnd type="none" w="med" len="med"/>
+                    </a:lnL>
+                    <a:lnR w="9525" cap="flat" cmpd="sng" algn="ctr">
+                      <a:solidFill>
+                        <a:srgbClr val="E5E7EB"/>
+                      </a:solidFill>
+                      <a:prstDash val="solid"/>
+                      <a:round/>
+                      <a:headEnd type="none" w="med" len="med"/>
+                      <a:tailEnd type="none" w="med" len="med"/>
+                    </a:lnR>
+                    <a:lnT w="9525" cap="flat" cmpd="sng" algn="ctr">
+                      <a:solidFill>
+                        <a:srgbClr val="E5E7EB"/>
+                      </a:solidFill>
+                      <a:prstDash val="solid"/>
+                      <a:round/>
+                      <a:headEnd type="none" w="med" len="med"/>
+                      <a:tailEnd type="none" w="med" len="med"/>
+                    </a:lnT>
+                    <a:lnB w="9525" cap="flat" cmpd="sng" algn="ctr">
+                      <a:solidFill>
+                        <a:srgbClr val="E5E7EB"/>
+                      </a:solidFill>
+                      <a:prstDash val="solid"/>
+                      <a:round/>
+                      <a:headEnd type="none" w="med" len="med"/>
+                      <a:tailEnd type="none" w="med" len="med"/>
+                    </a:lnB>
+                    <a:solidFill>
+                      <a:srgbClr val="F9FAFB"/>
+                    </a:solidFill>
+                  </a:tcPr>
+                </a:tc>
+                <a:tc>
+                  <a:txBody>
+                    <a:bodyPr/>
+                    <a:lstStyle/>
+                    <a:p>
+                      <a:pPr algn="ctr" indent="0" marL="0">
+                        <a:buNone/>
+                      </a:pPr>
+                      <a:r>
+                        <a:rPr lang="en-US" sz="1100" b="1" dirty="0">
+                          <a:solidFill>
+                            <a:srgbClr val="B45309"/>
+                          </a:solidFill>
+                          <a:latin typeface="Calibri" pitchFamily="34" charset="0"/>
+                          <a:ea typeface="Calibri" pitchFamily="34" charset="-122"/>
+                          <a:cs typeface="Calibri" pitchFamily="34" charset="-120"/>
+                        </a:rPr>
+                        <a:t>Planned</a:t>
+                      </a:r>
+                      <a:endParaRPr lang="en-US" sz="1100" dirty="0">
+                        <a:latin typeface="Calibri" charset="0"/>
+                        <a:ea typeface="Calibri" charset="0"/>
+                        <a:cs typeface="Calibri" charset="0"/>
+                      </a:endParaRPr>
+                    </a:p>
+                  </a:txBody>
+                  <a:tcPr marL="91440" marR="91440" marT="36576" marB="36576" anchor="ctr">
+                    <a:lnL w="9525" cap="flat" cmpd="sng" algn="ctr">
+                      <a:solidFill>
+                        <a:srgbClr val="E5E7EB"/>
+                      </a:solidFill>
+                      <a:prstDash val="solid"/>
+                      <a:round/>
+                      <a:headEnd type="none" w="med" len="med"/>
+                      <a:tailEnd type="none" w="med" len="med"/>
+                    </a:lnL>
+                    <a:lnR w="9525" cap="flat" cmpd="sng" algn="ctr">
+                      <a:solidFill>
+                        <a:srgbClr val="E5E7EB"/>
+                      </a:solidFill>
+                      <a:prstDash val="solid"/>
+                      <a:round/>
+                      <a:headEnd type="none" w="med" len="med"/>
+                      <a:tailEnd type="none" w="med" len="med"/>
+                    </a:lnR>
+                    <a:lnT w="9525" cap="flat" cmpd="sng" algn="ctr">
+                      <a:solidFill>
+                        <a:srgbClr val="E5E7EB"/>
+                      </a:solidFill>
+                      <a:prstDash val="solid"/>
+                      <a:round/>
+                      <a:headEnd type="none" w="med" len="med"/>
+                      <a:tailEnd type="none" w="med" len="med"/>
+                    </a:lnT>
+                    <a:lnB w="9525" cap="flat" cmpd="sng" algn="ctr">
+                      <a:solidFill>
+                        <a:srgbClr val="E5E7EB"/>
+                      </a:solidFill>
+                      <a:prstDash val="solid"/>
+                      <a:round/>
+                      <a:headEnd type="none" w="med" len="med"/>
+                      <a:tailEnd type="none" w="med" len="med"/>
+                    </a:lnB>
+                    <a:solidFill>
+                      <a:srgbClr val="FEF3C7"/>
+                    </a:solidFill>
+                  </a:tcPr>
+                </a:tc>
+                <a:tc>
+                  <a:txBody>
+                    <a:bodyPr/>
+                    <a:lstStyle/>
+                    <a:p>
+                      <a:pPr algn="r" indent="0" marL="0">
+                        <a:buNone/>
+                      </a:pPr>
+                      <a:r>
+                        <a:rPr lang="en-US" sz="1150" b="1" dirty="0">
+                          <a:solidFill>
+                            <a:srgbClr val="D97706"/>
+                          </a:solidFill>
+                          <a:latin typeface="Calibri" pitchFamily="34" charset="0"/>
+                          <a:ea typeface="Calibri" pitchFamily="34" charset="-122"/>
+                          <a:cs typeface="Calibri" pitchFamily="34" charset="-120"/>
+                        </a:rPr>
+                        <a:t>TBC</a:t>
+                      </a:r>
+                      <a:endParaRPr lang="en-US" sz="1150" dirty="0">
+                        <a:latin typeface="Calibri" charset="0"/>
+                        <a:ea typeface="Calibri" charset="0"/>
+                        <a:cs typeface="Calibri" charset="0"/>
+                      </a:endParaRPr>
+                    </a:p>
+                  </a:txBody>
+                  <a:tcPr marL="91440" marR="91440" marT="36576" marB="36576" anchor="ctr">
+                    <a:lnL w="9525" cap="flat" cmpd="sng" algn="ctr">
+                      <a:solidFill>
+                        <a:srgbClr val="E5E7EB"/>
+                      </a:solidFill>
+                      <a:prstDash val="solid"/>
+                      <a:round/>
+                      <a:headEnd type="none" w="med" len="med"/>
+                      <a:tailEnd type="none" w="med" len="med"/>
+                    </a:lnL>
+                    <a:lnR w="9525" cap="flat" cmpd="sng" algn="ctr">
+                      <a:solidFill>
+                        <a:srgbClr val="E5E7EB"/>
+                      </a:solidFill>
+                      <a:prstDash val="solid"/>
+                      <a:round/>
+                      <a:headEnd type="none" w="med" len="med"/>
+                      <a:tailEnd type="none" w="med" len="med"/>
+                    </a:lnR>
+                    <a:lnT w="9525" cap="flat" cmpd="sng" algn="ctr">
+                      <a:solidFill>
+                        <a:srgbClr val="E5E7EB"/>
+                      </a:solidFill>
+                      <a:prstDash val="solid"/>
+                      <a:round/>
+                      <a:headEnd type="none" w="med" len="med"/>
+                      <a:tailEnd type="none" w="med" len="med"/>
+                    </a:lnT>
+                    <a:lnB w="9525" cap="flat" cmpd="sng" algn="ctr">
+                      <a:solidFill>
+                        <a:srgbClr val="E5E7EB"/>
+                      </a:solidFill>
+                      <a:prstDash val="solid"/>
+                      <a:round/>
+                      <a:headEnd type="none" w="med" len="med"/>
+                      <a:tailEnd type="none" w="med" len="med"/>
+                    </a:lnB>
+                    <a:solidFill>
+                      <a:srgbClr val="F9FAFB"/>
+                    </a:solidFill>
                   </a:tcPr>
                 </a:tc>
               </a:tr>
-              <a:tr h="502920">
+              <a:tr h="365760">
+                <a:tc>
+                  <a:txBody>
+                    <a:bodyPr/>
+                    <a:lstStyle/>
+                    <a:p>
+                      <a:pPr algn="ctr" indent="0" marL="0">
+                        <a:buNone/>
+                      </a:pPr>
+                      <a:r>
+                        <a:rPr lang="en-US" sz="1150" dirty="0">
+                          <a:solidFill>
+                            <a:srgbClr val="6B7280"/>
+                          </a:solidFill>
+                          <a:latin typeface="Calibri" pitchFamily="34" charset="0"/>
+                          <a:ea typeface="Calibri" pitchFamily="34" charset="-122"/>
+                          <a:cs typeface="Calibri" pitchFamily="34" charset="-120"/>
+                        </a:rPr>
+                        <a:t>5</a:t>
+                      </a:r>
+                      <a:endParaRPr lang="en-US" sz="1150" dirty="0">
+                        <a:latin typeface="Calibri" charset="0"/>
+                        <a:ea typeface="Calibri" charset="0"/>
+                        <a:cs typeface="Calibri" charset="0"/>
+                      </a:endParaRPr>
+                    </a:p>
+                  </a:txBody>
+                  <a:tcPr marL="91440" marR="91440" marT="36576" marB="36576" anchor="ctr">
+                    <a:lnL w="9525" cap="flat" cmpd="sng" algn="ctr">
+                      <a:solidFill>
+                        <a:srgbClr val="E5E7EB"/>
+                      </a:solidFill>
+                      <a:prstDash val="solid"/>
+                      <a:round/>
+                      <a:headEnd type="none" w="med" len="med"/>
+                      <a:tailEnd type="none" w="med" len="med"/>
+                    </a:lnL>
+                    <a:lnR w="9525" cap="flat" cmpd="sng" algn="ctr">
+                      <a:solidFill>
+                        <a:srgbClr val="E5E7EB"/>
+                      </a:solidFill>
+                      <a:prstDash val="solid"/>
+                      <a:round/>
+                      <a:headEnd type="none" w="med" len="med"/>
+                      <a:tailEnd type="none" w="med" len="med"/>
+                    </a:lnR>
+                    <a:lnT w="9525" cap="flat" cmpd="sng" algn="ctr">
+                      <a:solidFill>
+                        <a:srgbClr val="E5E7EB"/>
+                      </a:solidFill>
+                      <a:prstDash val="solid"/>
+                      <a:round/>
+                      <a:headEnd type="none" w="med" len="med"/>
+                      <a:tailEnd type="none" w="med" len="med"/>
+                    </a:lnT>
+                    <a:lnB w="9525" cap="flat" cmpd="sng" algn="ctr">
+                      <a:solidFill>
+                        <a:srgbClr val="E5E7EB"/>
+                      </a:solidFill>
+                      <a:prstDash val="solid"/>
+                      <a:round/>
+                      <a:headEnd type="none" w="med" len="med"/>
+                      <a:tailEnd type="none" w="med" len="med"/>
+                    </a:lnB>
+                    <a:solidFill>
+                      <a:srgbClr val="FFFFFF"/>
+                    </a:solidFill>
+                  </a:tcPr>
+                </a:tc>
+                <a:tc>
+                  <a:txBody>
+                    <a:bodyPr/>
+                    <a:lstStyle/>
+                    <a:p>
+                      <a:pPr indent="0" marL="0">
+                        <a:buNone/>
+                      </a:pPr>
+                      <a:r>
+                        <a:rPr lang="en-US" sz="1150" dirty="0">
+                          <a:solidFill>
+                            <a:srgbClr val="111827"/>
+                          </a:solidFill>
+                          <a:latin typeface="Calibri" pitchFamily="34" charset="0"/>
+                          <a:ea typeface="Calibri" pitchFamily="34" charset="-122"/>
+                          <a:cs typeface="Calibri" pitchFamily="34" charset="-120"/>
+                        </a:rPr>
+                        <a:t>Freight-handling equipment (panel carts)</a:t>
+                      </a:r>
+                      <a:endParaRPr lang="en-US" sz="1150" dirty="0">
+                        <a:latin typeface="Calibri" charset="0"/>
+                        <a:ea typeface="Calibri" charset="0"/>
+                        <a:cs typeface="Calibri" charset="0"/>
+                      </a:endParaRPr>
+                    </a:p>
+                  </a:txBody>
+                  <a:tcPr marL="91440" marR="91440" marT="36576" marB="36576" anchor="ctr">
+                    <a:lnL w="9525" cap="flat" cmpd="sng" algn="ctr">
+                      <a:solidFill>
+                        <a:srgbClr val="E5E7EB"/>
+                      </a:solidFill>
+                      <a:prstDash val="solid"/>
+                      <a:round/>
+                      <a:headEnd type="none" w="med" len="med"/>
+                      <a:tailEnd type="none" w="med" len="med"/>
+                    </a:lnL>
+                    <a:lnR w="9525" cap="flat" cmpd="sng" algn="ctr">
+                      <a:solidFill>
+                        <a:srgbClr val="E5E7EB"/>
+                      </a:solidFill>
+                      <a:prstDash val="solid"/>
+                      <a:round/>
+                      <a:headEnd type="none" w="med" len="med"/>
+                      <a:tailEnd type="none" w="med" len="med"/>
+                    </a:lnR>
+                    <a:lnT w="9525" cap="flat" cmpd="sng" algn="ctr">
+                      <a:solidFill>
+                        <a:srgbClr val="E5E7EB"/>
+                      </a:solidFill>
+                      <a:prstDash val="solid"/>
+                      <a:round/>
+                      <a:headEnd type="none" w="med" len="med"/>
+                      <a:tailEnd type="none" w="med" len="med"/>
+                    </a:lnT>
+                    <a:lnB w="9525" cap="flat" cmpd="sng" algn="ctr">
+                      <a:solidFill>
+                        <a:srgbClr val="E5E7EB"/>
+                      </a:solidFill>
+                      <a:prstDash val="solid"/>
+                      <a:round/>
+                      <a:headEnd type="none" w="med" len="med"/>
+                      <a:tailEnd type="none" w="med" len="med"/>
+                    </a:lnB>
+                    <a:solidFill>
+                      <a:srgbClr val="FFFFFF"/>
+                    </a:solidFill>
+                  </a:tcPr>
+                </a:tc>
+                <a:tc>
+                  <a:txBody>
+                    <a:bodyPr/>
+                    <a:lstStyle/>
+                    <a:p>
+                      <a:pPr indent="0" marL="0">
+                        <a:buNone/>
+                      </a:pPr>
+                      <a:r>
+                        <a:rPr lang="en-US" sz="1100" dirty="0">
+                          <a:solidFill>
+                            <a:srgbClr val="6B7280"/>
+                          </a:solidFill>
+                          <a:latin typeface="Calibri" pitchFamily="34" charset="0"/>
+                          <a:ea typeface="Calibri" pitchFamily="34" charset="-122"/>
+                          <a:cs typeface="Calibri" pitchFamily="34" charset="-120"/>
+                        </a:rPr>
+                        <a:t>Claims &amp; damage</a:t>
+                      </a:r>
+                      <a:endParaRPr lang="en-US" sz="1100" dirty="0">
+                        <a:latin typeface="Calibri" charset="0"/>
+                        <a:ea typeface="Calibri" charset="0"/>
+                        <a:cs typeface="Calibri" charset="0"/>
+                      </a:endParaRPr>
+                    </a:p>
+                  </a:txBody>
+                  <a:tcPr marL="91440" marR="91440" marT="36576" marB="36576" anchor="ctr">
+                    <a:lnL w="9525" cap="flat" cmpd="sng" algn="ctr">
+                      <a:solidFill>
+                        <a:srgbClr val="E5E7EB"/>
+                      </a:solidFill>
+                      <a:prstDash val="solid"/>
+                      <a:round/>
+                      <a:headEnd type="none" w="med" len="med"/>
+                      <a:tailEnd type="none" w="med" len="med"/>
+                    </a:lnL>
+                    <a:lnR w="9525" cap="flat" cmpd="sng" algn="ctr">
+                      <a:solidFill>
+                        <a:srgbClr val="E5E7EB"/>
+                      </a:solidFill>
+                      <a:prstDash val="solid"/>
+                      <a:round/>
+                      <a:headEnd type="none" w="med" len="med"/>
+                      <a:tailEnd type="none" w="med" len="med"/>
+                    </a:lnR>
+                    <a:lnT w="9525" cap="flat" cmpd="sng" algn="ctr">
+                      <a:solidFill>
+                        <a:srgbClr val="E5E7EB"/>
+                      </a:solidFill>
+                      <a:prstDash val="solid"/>
+                      <a:round/>
+                      <a:headEnd type="none" w="med" len="med"/>
+                      <a:tailEnd type="none" w="med" len="med"/>
+                    </a:lnT>
+                    <a:lnB w="9525" cap="flat" cmpd="sng" algn="ctr">
+                      <a:solidFill>
+                        <a:srgbClr val="E5E7EB"/>
+                      </a:solidFill>
+                      <a:prstDash val="solid"/>
+                      <a:round/>
+                      <a:headEnd type="none" w="med" len="med"/>
+                      <a:tailEnd type="none" w="med" len="med"/>
+                    </a:lnB>
+                    <a:solidFill>
+                      <a:srgbClr val="FFFFFF"/>
+                    </a:solidFill>
+                  </a:tcPr>
+                </a:tc>
+                <a:tc>
+                  <a:txBody>
+                    <a:bodyPr/>
+                    <a:lstStyle/>
+                    <a:p>
+                      <a:pPr algn="ctr" indent="0" marL="0">
+                        <a:buNone/>
+                      </a:pPr>
+                      <a:r>
+                        <a:rPr lang="en-US" sz="1100" b="1" dirty="0">
+                          <a:solidFill>
+                            <a:srgbClr val="B45309"/>
+                          </a:solidFill>
+                          <a:latin typeface="Calibri" pitchFamily="34" charset="0"/>
+                          <a:ea typeface="Calibri" pitchFamily="34" charset="-122"/>
+                          <a:cs typeface="Calibri" pitchFamily="34" charset="-120"/>
+                        </a:rPr>
+                        <a:t>Planned</a:t>
+                      </a:r>
+                      <a:endParaRPr lang="en-US" sz="1100" dirty="0">
+                        <a:latin typeface="Calibri" charset="0"/>
+                        <a:ea typeface="Calibri" charset="0"/>
+                        <a:cs typeface="Calibri" charset="0"/>
+                      </a:endParaRPr>
+                    </a:p>
+                  </a:txBody>
+                  <a:tcPr marL="91440" marR="91440" marT="36576" marB="36576" anchor="ctr">
+                    <a:lnL w="9525" cap="flat" cmpd="sng" algn="ctr">
+                      <a:solidFill>
+                        <a:srgbClr val="E5E7EB"/>
+                      </a:solidFill>
+                      <a:prstDash val="solid"/>
+                      <a:round/>
+                      <a:headEnd type="none" w="med" len="med"/>
+                      <a:tailEnd type="none" w="med" len="med"/>
+                    </a:lnL>
+                    <a:lnR w="9525" cap="flat" cmpd="sng" algn="ctr">
+                      <a:solidFill>
+                        <a:srgbClr val="E5E7EB"/>
+                      </a:solidFill>
+                      <a:prstDash val="solid"/>
+                      <a:round/>
+                      <a:headEnd type="none" w="med" len="med"/>
+                      <a:tailEnd type="none" w="med" len="med"/>
+                    </a:lnR>
+                    <a:lnT w="9525" cap="flat" cmpd="sng" algn="ctr">
+                      <a:solidFill>
+                        <a:srgbClr val="E5E7EB"/>
+                      </a:solidFill>
+                      <a:prstDash val="solid"/>
+                      <a:round/>
+                      <a:headEnd type="none" w="med" len="med"/>
+                      <a:tailEnd type="none" w="med" len="med"/>
+                    </a:lnT>
+                    <a:lnB w="9525" cap="flat" cmpd="sng" algn="ctr">
+                      <a:solidFill>
+                        <a:srgbClr val="E5E7EB"/>
+                      </a:solidFill>
+                      <a:prstDash val="solid"/>
+                      <a:round/>
+                      <a:headEnd type="none" w="med" len="med"/>
+                      <a:tailEnd type="none" w="med" len="med"/>
+                    </a:lnB>
+                    <a:solidFill>
+                      <a:srgbClr val="FEF3C7"/>
+                    </a:solidFill>
+                  </a:tcPr>
+                </a:tc>
+                <a:tc>
+                  <a:txBody>
+                    <a:bodyPr/>
+                    <a:lstStyle/>
+                    <a:p>
+                      <a:pPr algn="r" indent="0" marL="0">
+                        <a:buNone/>
+                      </a:pPr>
+                      <a:r>
+                        <a:rPr lang="en-US" sz="1150" b="1" dirty="0">
+                          <a:solidFill>
+                            <a:srgbClr val="D97706"/>
+                          </a:solidFill>
+                          <a:latin typeface="Calibri" pitchFamily="34" charset="0"/>
+                          <a:ea typeface="Calibri" pitchFamily="34" charset="-122"/>
+                          <a:cs typeface="Calibri" pitchFamily="34" charset="-120"/>
+                        </a:rPr>
+                        <a:t>TBC</a:t>
+                      </a:r>
+                      <a:endParaRPr lang="en-US" sz="1150" dirty="0">
+                        <a:latin typeface="Calibri" charset="0"/>
+                        <a:ea typeface="Calibri" charset="0"/>
+                        <a:cs typeface="Calibri" charset="0"/>
+                      </a:endParaRPr>
+                    </a:p>
+                  </a:txBody>
+                  <a:tcPr marL="91440" marR="91440" marT="36576" marB="36576" anchor="ctr">
+                    <a:lnL w="9525" cap="flat" cmpd="sng" algn="ctr">
+                      <a:solidFill>
+                        <a:srgbClr val="E5E7EB"/>
+                      </a:solidFill>
+                      <a:prstDash val="solid"/>
+                      <a:round/>
+                      <a:headEnd type="none" w="med" len="med"/>
+                      <a:tailEnd type="none" w="med" len="med"/>
+                    </a:lnL>
+                    <a:lnR w="9525" cap="flat" cmpd="sng" algn="ctr">
+                      <a:solidFill>
+                        <a:srgbClr val="E5E7EB"/>
+                      </a:solidFill>
+                      <a:prstDash val="solid"/>
+                      <a:round/>
+                      <a:headEnd type="none" w="med" len="med"/>
+                      <a:tailEnd type="none" w="med" len="med"/>
+                    </a:lnR>
+                    <a:lnT w="9525" cap="flat" cmpd="sng" algn="ctr">
+                      <a:solidFill>
+                        <a:srgbClr val="E5E7EB"/>
+                      </a:solidFill>
+                      <a:prstDash val="solid"/>
+                      <a:round/>
+                      <a:headEnd type="none" w="med" len="med"/>
+                      <a:tailEnd type="none" w="med" len="med"/>
+                    </a:lnT>
+                    <a:lnB w="9525" cap="flat" cmpd="sng" algn="ctr">
+                      <a:solidFill>
+                        <a:srgbClr val="E5E7EB"/>
+                      </a:solidFill>
+                      <a:prstDash val="solid"/>
+                      <a:round/>
+                      <a:headEnd type="none" w="med" len="med"/>
+                      <a:tailEnd type="none" w="med" len="med"/>
+                    </a:lnB>
+                    <a:solidFill>
+                      <a:srgbClr val="FFFFFF"/>
+                    </a:solidFill>
+                  </a:tcPr>
+                </a:tc>
+              </a:tr>
+              <a:tr h="365760">
+                <a:tc>
+                  <a:txBody>
+                    <a:bodyPr/>
+                    <a:lstStyle/>
+                    <a:p>
+                      <a:pPr algn="ctr" indent="0" marL="0">
+                        <a:buNone/>
+                      </a:pPr>
+                      <a:r>
+                        <a:rPr lang="en-US" sz="1150" dirty="0">
+                          <a:solidFill>
+                            <a:srgbClr val="6B7280"/>
+                          </a:solidFill>
+                          <a:latin typeface="Calibri" pitchFamily="34" charset="0"/>
+                          <a:ea typeface="Calibri" pitchFamily="34" charset="-122"/>
+                          <a:cs typeface="Calibri" pitchFamily="34" charset="-120"/>
+                        </a:rPr>
+                        <a:t>6</a:t>
+                      </a:r>
+                      <a:endParaRPr lang="en-US" sz="1150" dirty="0">
+                        <a:latin typeface="Calibri" charset="0"/>
+                        <a:ea typeface="Calibri" charset="0"/>
+                        <a:cs typeface="Calibri" charset="0"/>
+                      </a:endParaRPr>
+                    </a:p>
+                  </a:txBody>
+                  <a:tcPr marL="91440" marR="91440" marT="36576" marB="36576" anchor="ctr">
+                    <a:lnL w="9525" cap="flat" cmpd="sng" algn="ctr">
+                      <a:solidFill>
+                        <a:srgbClr val="E5E7EB"/>
+                      </a:solidFill>
+                      <a:prstDash val="solid"/>
+                      <a:round/>
+                      <a:headEnd type="none" w="med" len="med"/>
+                      <a:tailEnd type="none" w="med" len="med"/>
+                    </a:lnL>
+                    <a:lnR w="9525" cap="flat" cmpd="sng" algn="ctr">
+                      <a:solidFill>
+                        <a:srgbClr val="E5E7EB"/>
+                      </a:solidFill>
+                      <a:prstDash val="solid"/>
+                      <a:round/>
+                      <a:headEnd type="none" w="med" len="med"/>
+                      <a:tailEnd type="none" w="med" len="med"/>
+                    </a:lnR>
+                    <a:lnT w="9525" cap="flat" cmpd="sng" algn="ctr">
+                      <a:solidFill>
+                        <a:srgbClr val="E5E7EB"/>
+                      </a:solidFill>
+                      <a:prstDash val="solid"/>
+                      <a:round/>
+                      <a:headEnd type="none" w="med" len="med"/>
+                      <a:tailEnd type="none" w="med" len="med"/>
+                    </a:lnT>
+                    <a:lnB w="9525" cap="flat" cmpd="sng" algn="ctr">
+                      <a:solidFill>
+                        <a:srgbClr val="E5E7EB"/>
+                      </a:solidFill>
+                      <a:prstDash val="solid"/>
+                      <a:round/>
+                      <a:headEnd type="none" w="med" len="med"/>
+                      <a:tailEnd type="none" w="med" len="med"/>
+                    </a:lnB>
+                    <a:solidFill>
+                      <a:srgbClr val="F9FAFB"/>
+                    </a:solidFill>
+                  </a:tcPr>
+                </a:tc>
+                <a:tc>
+                  <a:txBody>
+                    <a:bodyPr/>
+                    <a:lstStyle/>
+                    <a:p>
+                      <a:pPr indent="0" marL="0">
+                        <a:buNone/>
+                      </a:pPr>
+                      <a:r>
+                        <a:rPr lang="en-US" sz="1150" dirty="0">
+                          <a:solidFill>
+                            <a:srgbClr val="111827"/>
+                          </a:solidFill>
+                          <a:latin typeface="Calibri" pitchFamily="34" charset="0"/>
+                          <a:ea typeface="Calibri" pitchFamily="34" charset="-122"/>
+                          <a:cs typeface="Calibri" pitchFamily="34" charset="-120"/>
+                        </a:rPr>
+                        <a:t>Accessorial capture</a:t>
+                      </a:r>
+                      <a:endParaRPr lang="en-US" sz="1150" dirty="0">
+                        <a:latin typeface="Calibri" charset="0"/>
+                        <a:ea typeface="Calibri" charset="0"/>
+                        <a:cs typeface="Calibri" charset="0"/>
+                      </a:endParaRPr>
+                    </a:p>
+                  </a:txBody>
+                  <a:tcPr marL="91440" marR="91440" marT="36576" marB="36576" anchor="ctr">
+                    <a:lnL w="9525" cap="flat" cmpd="sng" algn="ctr">
+                      <a:solidFill>
+                        <a:srgbClr val="E5E7EB"/>
+                      </a:solidFill>
+                      <a:prstDash val="solid"/>
+                      <a:round/>
+                      <a:headEnd type="none" w="med" len="med"/>
+                      <a:tailEnd type="none" w="med" len="med"/>
+                    </a:lnL>
+                    <a:lnR w="9525" cap="flat" cmpd="sng" algn="ctr">
+                      <a:solidFill>
+                        <a:srgbClr val="E5E7EB"/>
+                      </a:solidFill>
+                      <a:prstDash val="solid"/>
+                      <a:round/>
+                      <a:headEnd type="none" w="med" len="med"/>
+                      <a:tailEnd type="none" w="med" len="med"/>
+                    </a:lnR>
+                    <a:lnT w="9525" cap="flat" cmpd="sng" algn="ctr">
+                      <a:solidFill>
+                        <a:srgbClr val="E5E7EB"/>
+                      </a:solidFill>
+                      <a:prstDash val="solid"/>
+                      <a:round/>
+                      <a:headEnd type="none" w="med" len="med"/>
+                      <a:tailEnd type="none" w="med" len="med"/>
+                    </a:lnT>
+                    <a:lnB w="9525" cap="flat" cmpd="sng" algn="ctr">
+                      <a:solidFill>
+                        <a:srgbClr val="E5E7EB"/>
+                      </a:solidFill>
+                      <a:prstDash val="solid"/>
+                      <a:round/>
+                      <a:headEnd type="none" w="med" len="med"/>
+                      <a:tailEnd type="none" w="med" len="med"/>
+                    </a:lnB>
+                    <a:solidFill>
+                      <a:srgbClr val="F9FAFB"/>
+                    </a:solidFill>
+                  </a:tcPr>
+                </a:tc>
+                <a:tc>
+                  <a:txBody>
+                    <a:bodyPr/>
+                    <a:lstStyle/>
+                    <a:p>
+                      <a:pPr indent="0" marL="0">
+                        <a:buNone/>
+                      </a:pPr>
+                      <a:r>
+                        <a:rPr lang="en-US" sz="1100" dirty="0">
+                          <a:solidFill>
+                            <a:srgbClr val="6B7280"/>
+                          </a:solidFill>
+                          <a:latin typeface="Calibri" pitchFamily="34" charset="0"/>
+                          <a:ea typeface="Calibri" pitchFamily="34" charset="-122"/>
+                          <a:cs typeface="Calibri" pitchFamily="34" charset="-120"/>
+                        </a:rPr>
+                        <a:t>Revenue protection</a:t>
+                      </a:r>
+                      <a:endParaRPr lang="en-US" sz="1100" dirty="0">
+                        <a:latin typeface="Calibri" charset="0"/>
+                        <a:ea typeface="Calibri" charset="0"/>
+                        <a:cs typeface="Calibri" charset="0"/>
+                      </a:endParaRPr>
+                    </a:p>
+                  </a:txBody>
+                  <a:tcPr marL="91440" marR="91440" marT="36576" marB="36576" anchor="ctr">
+                    <a:lnL w="9525" cap="flat" cmpd="sng" algn="ctr">
+                      <a:solidFill>
+                        <a:srgbClr val="E5E7EB"/>
+                      </a:solidFill>
+                      <a:prstDash val="solid"/>
+                      <a:round/>
+                      <a:headEnd type="none" w="med" len="med"/>
+                      <a:tailEnd type="none" w="med" len="med"/>
+                    </a:lnL>
+                    <a:lnR w="9525" cap="flat" cmpd="sng" algn="ctr">
+                      <a:solidFill>
+                        <a:srgbClr val="E5E7EB"/>
+                      </a:solidFill>
+                      <a:prstDash val="solid"/>
+                      <a:round/>
+                      <a:headEnd type="none" w="med" len="med"/>
+                      <a:tailEnd type="none" w="med" len="med"/>
+                    </a:lnR>
+                    <a:lnT w="9525" cap="flat" cmpd="sng" algn="ctr">
+                      <a:solidFill>
+                        <a:srgbClr val="E5E7EB"/>
+                      </a:solidFill>
+                      <a:prstDash val="solid"/>
+                      <a:round/>
+                      <a:headEnd type="none" w="med" len="med"/>
+                      <a:tailEnd type="none" w="med" len="med"/>
+                    </a:lnT>
+                    <a:lnB w="9525" cap="flat" cmpd="sng" algn="ctr">
+                      <a:solidFill>
+                        <a:srgbClr val="E5E7EB"/>
+                      </a:solidFill>
+                      <a:prstDash val="solid"/>
+                      <a:round/>
+                      <a:headEnd type="none" w="med" len="med"/>
+                      <a:tailEnd type="none" w="med" len="med"/>
+                    </a:lnB>
+                    <a:solidFill>
+                      <a:srgbClr val="F9FAFB"/>
+                    </a:solidFill>
+                  </a:tcPr>
+                </a:tc>
+                <a:tc>
+                  <a:txBody>
+                    <a:bodyPr/>
+                    <a:lstStyle/>
+                    <a:p>
+                      <a:pPr algn="ctr" indent="0" marL="0">
+                        <a:buNone/>
+                      </a:pPr>
+                      <a:r>
+                        <a:rPr lang="en-US" sz="1100" b="1" dirty="0">
+                          <a:solidFill>
+                            <a:srgbClr val="2563EB"/>
+                          </a:solidFill>
+                          <a:latin typeface="Calibri" pitchFamily="34" charset="0"/>
+                          <a:ea typeface="Calibri" pitchFamily="34" charset="-122"/>
+                          <a:cs typeface="Calibri" pitchFamily="34" charset="-120"/>
+                        </a:rPr>
+                        <a:t>In progress</a:t>
+                      </a:r>
+                      <a:endParaRPr lang="en-US" sz="1100" dirty="0">
+                        <a:latin typeface="Calibri" charset="0"/>
+                        <a:ea typeface="Calibri" charset="0"/>
+                        <a:cs typeface="Calibri" charset="0"/>
+                      </a:endParaRPr>
+                    </a:p>
+                  </a:txBody>
+                  <a:tcPr marL="91440" marR="91440" marT="36576" marB="36576" anchor="ctr">
+                    <a:lnL w="9525" cap="flat" cmpd="sng" algn="ctr">
+                      <a:solidFill>
+                        <a:srgbClr val="E5E7EB"/>
+                      </a:solidFill>
+                      <a:prstDash val="solid"/>
+                      <a:round/>
+                      <a:headEnd type="none" w="med" len="med"/>
+                      <a:tailEnd type="none" w="med" len="med"/>
+                    </a:lnL>
+                    <a:lnR w="9525" cap="flat" cmpd="sng" algn="ctr">
+                      <a:solidFill>
+                        <a:srgbClr val="E5E7EB"/>
+                      </a:solidFill>
+                      <a:prstDash val="solid"/>
+                      <a:round/>
+                      <a:headEnd type="none" w="med" len="med"/>
+                      <a:tailEnd type="none" w="med" len="med"/>
+                    </a:lnR>
+                    <a:lnT w="9525" cap="flat" cmpd="sng" algn="ctr">
+                      <a:solidFill>
+                        <a:srgbClr val="E5E7EB"/>
+                      </a:solidFill>
+                      <a:prstDash val="solid"/>
+                      <a:round/>
+                      <a:headEnd type="none" w="med" len="med"/>
+                      <a:tailEnd type="none" w="med" len="med"/>
+                    </a:lnT>
+                    <a:lnB w="9525" cap="flat" cmpd="sng" algn="ctr">
+                      <a:solidFill>
+                        <a:srgbClr val="E5E7EB"/>
+                      </a:solidFill>
+                      <a:prstDash val="solid"/>
+                      <a:round/>
+                      <a:headEnd type="none" w="med" len="med"/>
+                      <a:tailEnd type="none" w="med" len="med"/>
+                    </a:lnB>
+                    <a:solidFill>
+                      <a:srgbClr val="DBEAFE"/>
+                    </a:solidFill>
+                  </a:tcPr>
+                </a:tc>
+                <a:tc>
+                  <a:txBody>
+                    <a:bodyPr/>
+                    <a:lstStyle/>
+                    <a:p>
+                      <a:pPr algn="r" indent="0" marL="0">
+                        <a:buNone/>
+                      </a:pPr>
+                      <a:r>
+                        <a:rPr lang="en-US" sz="1150" b="1" dirty="0">
+                          <a:solidFill>
+                            <a:srgbClr val="D97706"/>
+                          </a:solidFill>
+                          <a:latin typeface="Calibri" pitchFamily="34" charset="0"/>
+                          <a:ea typeface="Calibri" pitchFamily="34" charset="-122"/>
+                          <a:cs typeface="Calibri" pitchFamily="34" charset="-120"/>
+                        </a:rPr>
+                        <a:t>TBC</a:t>
+                      </a:r>
+                      <a:endParaRPr lang="en-US" sz="1150" dirty="0">
+                        <a:latin typeface="Calibri" charset="0"/>
+                        <a:ea typeface="Calibri" charset="0"/>
+                        <a:cs typeface="Calibri" charset="0"/>
+                      </a:endParaRPr>
+                    </a:p>
+                  </a:txBody>
+                  <a:tcPr marL="91440" marR="91440" marT="36576" marB="36576" anchor="ctr">
+                    <a:lnL w="9525" cap="flat" cmpd="sng" algn="ctr">
+                      <a:solidFill>
+                        <a:srgbClr val="E5E7EB"/>
+                      </a:solidFill>
+                      <a:prstDash val="solid"/>
+                      <a:round/>
+                      <a:headEnd type="none" w="med" len="med"/>
+                      <a:tailEnd type="none" w="med" len="med"/>
+                    </a:lnL>
+                    <a:lnR w="9525" cap="flat" cmpd="sng" algn="ctr">
+                      <a:solidFill>
+                        <a:srgbClr val="E5E7EB"/>
+                      </a:solidFill>
+                      <a:prstDash val="solid"/>
+                      <a:round/>
+                      <a:headEnd type="none" w="med" len="med"/>
+                      <a:tailEnd type="none" w="med" len="med"/>
+                    </a:lnR>
+                    <a:lnT w="9525" cap="flat" cmpd="sng" algn="ctr">
+                      <a:solidFill>
+                        <a:srgbClr val="E5E7EB"/>
+                      </a:solidFill>
+                      <a:prstDash val="solid"/>
+                      <a:round/>
+                      <a:headEnd type="none" w="med" len="med"/>
+                      <a:tailEnd type="none" w="med" len="med"/>
+                    </a:lnT>
+                    <a:lnB w="9525" cap="flat" cmpd="sng" algn="ctr">
+                      <a:solidFill>
+                        <a:srgbClr val="E5E7EB"/>
+                      </a:solidFill>
+                      <a:prstDash val="solid"/>
+                      <a:round/>
+                      <a:headEnd type="none" w="med" len="med"/>
+                      <a:tailEnd type="none" w="med" len="med"/>
+                    </a:lnB>
+                    <a:solidFill>
+                      <a:srgbClr val="F9FAFB"/>
+                    </a:solidFill>
+                  </a:tcPr>
+                </a:tc>
+              </a:tr>
+              <a:tr h="365760">
+                <a:tc>
+                  <a:txBody>
+                    <a:bodyPr/>
+                    <a:lstStyle/>
+                    <a:p>
+                      <a:pPr algn="ctr" indent="0" marL="0">
+                        <a:buNone/>
+                      </a:pPr>
+                      <a:r>
+                        <a:rPr lang="en-US" sz="1150" dirty="0">
+                          <a:solidFill>
+                            <a:srgbClr val="6B7280"/>
+                          </a:solidFill>
+                          <a:latin typeface="Calibri" pitchFamily="34" charset="0"/>
+                          <a:ea typeface="Calibri" pitchFamily="34" charset="-122"/>
+                          <a:cs typeface="Calibri" pitchFamily="34" charset="-120"/>
+                        </a:rPr>
+                        <a:t>7</a:t>
+                      </a:r>
+                      <a:endParaRPr lang="en-US" sz="1150" dirty="0">
+                        <a:latin typeface="Calibri" charset="0"/>
+                        <a:ea typeface="Calibri" charset="0"/>
+                        <a:cs typeface="Calibri" charset="0"/>
+                      </a:endParaRPr>
+                    </a:p>
+                  </a:txBody>
+                  <a:tcPr marL="91440" marR="91440" marT="36576" marB="36576" anchor="ctr">
+                    <a:lnL w="9525" cap="flat" cmpd="sng" algn="ctr">
+                      <a:solidFill>
+                        <a:srgbClr val="E5E7EB"/>
+                      </a:solidFill>
+                      <a:prstDash val="solid"/>
+                      <a:round/>
+                      <a:headEnd type="none" w="med" len="med"/>
+                      <a:tailEnd type="none" w="med" len="med"/>
+                    </a:lnL>
+                    <a:lnR w="9525" cap="flat" cmpd="sng" algn="ctr">
+                      <a:solidFill>
+                        <a:srgbClr val="E5E7EB"/>
+                      </a:solidFill>
+                      <a:prstDash val="solid"/>
+                      <a:round/>
+                      <a:headEnd type="none" w="med" len="med"/>
+                      <a:tailEnd type="none" w="med" len="med"/>
+                    </a:lnR>
+                    <a:lnT w="9525" cap="flat" cmpd="sng" algn="ctr">
+                      <a:solidFill>
+                        <a:srgbClr val="E5E7EB"/>
+                      </a:solidFill>
+                      <a:prstDash val="solid"/>
+                      <a:round/>
+                      <a:headEnd type="none" w="med" len="med"/>
+                      <a:tailEnd type="none" w="med" len="med"/>
+                    </a:lnT>
+                    <a:lnB w="9525" cap="flat" cmpd="sng" algn="ctr">
+                      <a:solidFill>
+                        <a:srgbClr val="E5E7EB"/>
+                      </a:solidFill>
+                      <a:prstDash val="solid"/>
+                      <a:round/>
+                      <a:headEnd type="none" w="med" len="med"/>
+                      <a:tailEnd type="none" w="med" len="med"/>
+                    </a:lnB>
+                    <a:solidFill>
+                      <a:srgbClr val="FFFFFF"/>
+                    </a:solidFill>
+                  </a:tcPr>
+                </a:tc>
+                <a:tc>
+                  <a:txBody>
+                    <a:bodyPr/>
+                    <a:lstStyle/>
+                    <a:p>
+                      <a:pPr indent="0" marL="0">
+                        <a:buNone/>
+                      </a:pPr>
+                      <a:r>
+                        <a:rPr lang="en-US" sz="1150" dirty="0">
+                          <a:solidFill>
+                            <a:srgbClr val="111827"/>
+                          </a:solidFill>
+                          <a:latin typeface="Calibri" pitchFamily="34" charset="0"/>
+                          <a:ea typeface="Calibri" pitchFamily="34" charset="-122"/>
+                          <a:cs typeface="Calibri" pitchFamily="34" charset="-120"/>
+                        </a:rPr>
+                        <a:t>Toyota baseload footage capture</a:t>
+                      </a:r>
+                      <a:endParaRPr lang="en-US" sz="1150" dirty="0">
+                        <a:latin typeface="Calibri" charset="0"/>
+                        <a:ea typeface="Calibri" charset="0"/>
+                        <a:cs typeface="Calibri" charset="0"/>
+                      </a:endParaRPr>
+                    </a:p>
+                  </a:txBody>
+                  <a:tcPr marL="91440" marR="91440" marT="36576" marB="36576" anchor="ctr">
+                    <a:lnL w="9525" cap="flat" cmpd="sng" algn="ctr">
+                      <a:solidFill>
+                        <a:srgbClr val="E5E7EB"/>
+                      </a:solidFill>
+                      <a:prstDash val="solid"/>
+                      <a:round/>
+                      <a:headEnd type="none" w="med" len="med"/>
+                      <a:tailEnd type="none" w="med" len="med"/>
+                    </a:lnL>
+                    <a:lnR w="9525" cap="flat" cmpd="sng" algn="ctr">
+                      <a:solidFill>
+                        <a:srgbClr val="E5E7EB"/>
+                      </a:solidFill>
+                      <a:prstDash val="solid"/>
+                      <a:round/>
+                      <a:headEnd type="none" w="med" len="med"/>
+                      <a:tailEnd type="none" w="med" len="med"/>
+                    </a:lnR>
+                    <a:lnT w="9525" cap="flat" cmpd="sng" algn="ctr">
+                      <a:solidFill>
+                        <a:srgbClr val="E5E7EB"/>
+                      </a:solidFill>
+                      <a:prstDash val="solid"/>
+                      <a:round/>
+                      <a:headEnd type="none" w="med" len="med"/>
+                      <a:tailEnd type="none" w="med" len="med"/>
+                    </a:lnT>
+                    <a:lnB w="9525" cap="flat" cmpd="sng" algn="ctr">
+                      <a:solidFill>
+                        <a:srgbClr val="E5E7EB"/>
+                      </a:solidFill>
+                      <a:prstDash val="solid"/>
+                      <a:round/>
+                      <a:headEnd type="none" w="med" len="med"/>
+                      <a:tailEnd type="none" w="med" len="med"/>
+                    </a:lnB>
+                    <a:solidFill>
+                      <a:srgbClr val="FFFFFF"/>
+                    </a:solidFill>
+                  </a:tcPr>
+                </a:tc>
+                <a:tc>
+                  <a:txBody>
+                    <a:bodyPr/>
+                    <a:lstStyle/>
+                    <a:p>
+                      <a:pPr indent="0" marL="0">
+                        <a:buNone/>
+                      </a:pPr>
+                      <a:r>
+                        <a:rPr lang="en-US" sz="1100" dirty="0">
+                          <a:solidFill>
+                            <a:srgbClr val="6B7280"/>
+                          </a:solidFill>
+                          <a:latin typeface="Calibri" pitchFamily="34" charset="0"/>
+                          <a:ea typeface="Calibri" pitchFamily="34" charset="-122"/>
+                          <a:cs typeface="Calibri" pitchFamily="34" charset="-120"/>
+                        </a:rPr>
+                        <a:t>Revenue / load factor</a:t>
+                      </a:r>
+                      <a:endParaRPr lang="en-US" sz="1100" dirty="0">
+                        <a:latin typeface="Calibri" charset="0"/>
+                        <a:ea typeface="Calibri" charset="0"/>
+                        <a:cs typeface="Calibri" charset="0"/>
+                      </a:endParaRPr>
+                    </a:p>
+                  </a:txBody>
+                  <a:tcPr marL="91440" marR="91440" marT="36576" marB="36576" anchor="ctr">
+                    <a:lnL w="9525" cap="flat" cmpd="sng" algn="ctr">
+                      <a:solidFill>
+                        <a:srgbClr val="E5E7EB"/>
+                      </a:solidFill>
+                      <a:prstDash val="solid"/>
+                      <a:round/>
+                      <a:headEnd type="none" w="med" len="med"/>
+                      <a:tailEnd type="none" w="med" len="med"/>
+                    </a:lnL>
+                    <a:lnR w="9525" cap="flat" cmpd="sng" algn="ctr">
+                      <a:solidFill>
+                        <a:srgbClr val="E5E7EB"/>
+                      </a:solidFill>
+                      <a:prstDash val="solid"/>
+                      <a:round/>
+                      <a:headEnd type="none" w="med" len="med"/>
+                      <a:tailEnd type="none" w="med" len="med"/>
+                    </a:lnR>
+                    <a:lnT w="9525" cap="flat" cmpd="sng" algn="ctr">
+                      <a:solidFill>
+                        <a:srgbClr val="E5E7EB"/>
+                      </a:solidFill>
+                      <a:prstDash val="solid"/>
+                      <a:round/>
+                      <a:headEnd type="none" w="med" len="med"/>
+                      <a:tailEnd type="none" w="med" len="med"/>
+                    </a:lnT>
+                    <a:lnB w="9525" cap="flat" cmpd="sng" algn="ctr">
+                      <a:solidFill>
+                        <a:srgbClr val="E5E7EB"/>
+                      </a:solidFill>
+                      <a:prstDash val="solid"/>
+                      <a:round/>
+                      <a:headEnd type="none" w="med" len="med"/>
+                      <a:tailEnd type="none" w="med" len="med"/>
+                    </a:lnB>
+                    <a:solidFill>
+                      <a:srgbClr val="FFFFFF"/>
+                    </a:solidFill>
+                  </a:tcPr>
+                </a:tc>
+                <a:tc>
+                  <a:txBody>
+                    <a:bodyPr/>
+                    <a:lstStyle/>
+                    <a:p>
+                      <a:pPr algn="ctr" indent="0" marL="0">
+                        <a:buNone/>
+                      </a:pPr>
+                      <a:r>
+                        <a:rPr lang="en-US" sz="1100" b="1" dirty="0">
+                          <a:solidFill>
+                            <a:srgbClr val="2563EB"/>
+                          </a:solidFill>
+                          <a:latin typeface="Calibri" pitchFamily="34" charset="0"/>
+                          <a:ea typeface="Calibri" pitchFamily="34" charset="-122"/>
+                          <a:cs typeface="Calibri" pitchFamily="34" charset="-120"/>
+                        </a:rPr>
+                        <a:t>In progress</a:t>
+                      </a:r>
+                      <a:endParaRPr lang="en-US" sz="1100" dirty="0">
+                        <a:latin typeface="Calibri" charset="0"/>
+                        <a:ea typeface="Calibri" charset="0"/>
+                        <a:cs typeface="Calibri" charset="0"/>
+                      </a:endParaRPr>
+                    </a:p>
+                  </a:txBody>
+                  <a:tcPr marL="91440" marR="91440" marT="36576" marB="36576" anchor="ctr">
+                    <a:lnL w="9525" cap="flat" cmpd="sng" algn="ctr">
+                      <a:solidFill>
+                        <a:srgbClr val="E5E7EB"/>
+                      </a:solidFill>
+                      <a:prstDash val="solid"/>
+                      <a:round/>
+                      <a:headEnd type="none" w="med" len="med"/>
+                      <a:tailEnd type="none" w="med" len="med"/>
+                    </a:lnL>
+                    <a:lnR w="9525" cap="flat" cmpd="sng" algn="ctr">
+                      <a:solidFill>
+                        <a:srgbClr val="E5E7EB"/>
+                      </a:solidFill>
+                      <a:prstDash val="solid"/>
+                      <a:round/>
+                      <a:headEnd type="none" w="med" len="med"/>
+                      <a:tailEnd type="none" w="med" len="med"/>
+                    </a:lnR>
+                    <a:lnT w="9525" cap="flat" cmpd="sng" algn="ctr">
+                      <a:solidFill>
+                        <a:srgbClr val="E5E7EB"/>
+                      </a:solidFill>
+                      <a:prstDash val="solid"/>
+                      <a:round/>
+                      <a:headEnd type="none" w="med" len="med"/>
+                      <a:tailEnd type="none" w="med" len="med"/>
+                    </a:lnT>
+                    <a:lnB w="9525" cap="flat" cmpd="sng" algn="ctr">
+                      <a:solidFill>
+                        <a:srgbClr val="E5E7EB"/>
+                      </a:solidFill>
+                      <a:prstDash val="solid"/>
+                      <a:round/>
+                      <a:headEnd type="none" w="med" len="med"/>
+                      <a:tailEnd type="none" w="med" len="med"/>
+                    </a:lnB>
+                    <a:solidFill>
+                      <a:srgbClr val="DBEAFE"/>
+                    </a:solidFill>
+                  </a:tcPr>
+                </a:tc>
+                <a:tc>
+                  <a:txBody>
+                    <a:bodyPr/>
+                    <a:lstStyle/>
+                    <a:p>
+                      <a:pPr algn="r" indent="0" marL="0">
+                        <a:buNone/>
+                      </a:pPr>
+                      <a:r>
+                        <a:rPr lang="en-US" sz="1150" b="1" dirty="0">
+                          <a:solidFill>
+                            <a:srgbClr val="D97706"/>
+                          </a:solidFill>
+                          <a:latin typeface="Calibri" pitchFamily="34" charset="0"/>
+                          <a:ea typeface="Calibri" pitchFamily="34" charset="-122"/>
+                          <a:cs typeface="Calibri" pitchFamily="34" charset="-120"/>
+                        </a:rPr>
+                        <a:t>TBC</a:t>
+                      </a:r>
+                      <a:endParaRPr lang="en-US" sz="1150" dirty="0">
+                        <a:latin typeface="Calibri" charset="0"/>
+                        <a:ea typeface="Calibri" charset="0"/>
+                        <a:cs typeface="Calibri" charset="0"/>
+                      </a:endParaRPr>
+                    </a:p>
+                  </a:txBody>
+                  <a:tcPr marL="91440" marR="91440" marT="36576" marB="36576" anchor="ctr">
+                    <a:lnL w="9525" cap="flat" cmpd="sng" algn="ctr">
+                      <a:solidFill>
+                        <a:srgbClr val="E5E7EB"/>
+                      </a:solidFill>
+                      <a:prstDash val="solid"/>
+                      <a:round/>
+                      <a:headEnd type="none" w="med" len="med"/>
+                      <a:tailEnd type="none" w="med" len="med"/>
+                    </a:lnL>
+                    <a:lnR w="9525" cap="flat" cmpd="sng" algn="ctr">
+                      <a:solidFill>
+                        <a:srgbClr val="E5E7EB"/>
+                      </a:solidFill>
+                      <a:prstDash val="solid"/>
+                      <a:round/>
+                      <a:headEnd type="none" w="med" len="med"/>
+                      <a:tailEnd type="none" w="med" len="med"/>
+                    </a:lnR>
+                    <a:lnT w="9525" cap="flat" cmpd="sng" algn="ctr">
+                      <a:solidFill>
+                        <a:srgbClr val="E5E7EB"/>
+                      </a:solidFill>
+                      <a:prstDash val="solid"/>
+                      <a:round/>
+                      <a:headEnd type="none" w="med" len="med"/>
+                      <a:tailEnd type="none" w="med" len="med"/>
+                    </a:lnT>
+                    <a:lnB w="9525" cap="flat" cmpd="sng" algn="ctr">
+                      <a:solidFill>
+                        <a:srgbClr val="E5E7EB"/>
+                      </a:solidFill>
+                      <a:prstDash val="solid"/>
+                      <a:round/>
+                      <a:headEnd type="none" w="med" len="med"/>
+                      <a:tailEnd type="none" w="med" len="med"/>
+                    </a:lnB>
+                    <a:solidFill>
+                      <a:srgbClr val="FFFFFF"/>
+                    </a:solidFill>
+                  </a:tcPr>
+                </a:tc>
+              </a:tr>
+              <a:tr h="365760">
                 <a:tc>
                   <a:txBody>
                     <a:bodyPr/>
@@ -18646,11 +21289,11 @@
                       <a:tailEnd type="none" w="med" len="med"/>
                     </a:lnB>
                     <a:solidFill>
-                      <a:srgbClr val="F9FAFB"/>
+                      <a:srgbClr val="EDE9FE"/>
                     </a:solidFill>
                   </a:tcPr>
                 </a:tc>
-                <a:tc>
+                <a:tc gridSpan="3">
                   <a:txBody>
                     <a:bodyPr/>
                     <a:lstStyle/>
@@ -18659,17 +21302,31 @@
                         <a:buNone/>
                       </a:pPr>
                       <a:r>
-                        <a:rPr lang="en-US" sz="1200" i="1" dirty="0">
+                        <a:rPr lang="en-US" sz="1150" b="1" dirty="0">
                           <a:solidFill>
-                            <a:srgbClr val="6B7280"/>
+                            <a:srgbClr val="111827"/>
                           </a:solidFill>
                           <a:latin typeface="Calibri" pitchFamily="34" charset="0"/>
                           <a:ea typeface="Calibri" pitchFamily="34" charset="-122"/>
                           <a:cs typeface="Calibri" pitchFamily="34" charset="-120"/>
                         </a:rPr>
-                        <a:t>Additional initiatives in development</a:t>
+                        <a:t>Total identified $61,000/yr · Target </a:t>
                       </a:r>
-                      <a:endParaRPr lang="en-US" sz="1200" dirty="0">
+                      <a:pPr indent="0" marL="0">
+                        <a:buNone/>
+                      </a:pPr>
+                      <a:r>
+                        <a:rPr lang="en-US" sz="1150" b="1" dirty="0">
+                          <a:solidFill>
+                            <a:srgbClr val="D97706"/>
+                          </a:solidFill>
+                          <a:latin typeface="Calibri" pitchFamily="34" charset="0"/>
+                          <a:ea typeface="Calibri" pitchFamily="34" charset="-122"/>
+                          <a:cs typeface="Calibri" pitchFamily="34" charset="-120"/>
+                        </a:rPr>
+                        <a:t>TBC</a:t>
+                      </a:r>
+                      <a:endParaRPr lang="en-US" sz="1150" dirty="0">
                         <a:latin typeface="Calibri" charset="0"/>
                         <a:ea typeface="Calibri" charset="0"/>
                         <a:cs typeface="Calibri" charset="0"/>
@@ -18714,318 +21371,15 @@
                       <a:tailEnd type="none" w="med" len="med"/>
                     </a:lnB>
                     <a:solidFill>
-                      <a:srgbClr val="F9FAFB"/>
-                    </a:solidFill>
-                  </a:tcPr>
-                </a:tc>
-                <a:tc>
-                  <a:txBody>
-                    <a:bodyPr/>
-                    <a:lstStyle/>
-                    <a:p>
-                      <a:pPr indent="0" marL="0">
-                        <a:buNone/>
-                      </a:pPr>
-                      <a:endParaRPr lang="en-US" sz="1200" dirty="0">
-                        <a:latin typeface="Calibri" charset="0"/>
-                        <a:ea typeface="Calibri" charset="0"/>
-                        <a:cs typeface="Calibri" charset="0"/>
-                      </a:endParaRPr>
-                    </a:p>
-                  </a:txBody>
-                  <a:tcPr marL="91440" marR="91440" marT="36576" marB="36576" anchor="ctr">
-                    <a:lnL w="9525" cap="flat" cmpd="sng" algn="ctr">
-                      <a:solidFill>
-                        <a:srgbClr val="E5E7EB"/>
-                      </a:solidFill>
-                      <a:prstDash val="solid"/>
-                      <a:round/>
-                      <a:headEnd type="none" w="med" len="med"/>
-                      <a:tailEnd type="none" w="med" len="med"/>
-                    </a:lnL>
-                    <a:lnR w="9525" cap="flat" cmpd="sng" algn="ctr">
-                      <a:solidFill>
-                        <a:srgbClr val="E5E7EB"/>
-                      </a:solidFill>
-                      <a:prstDash val="solid"/>
-                      <a:round/>
-                      <a:headEnd type="none" w="med" len="med"/>
-                      <a:tailEnd type="none" w="med" len="med"/>
-                    </a:lnR>
-                    <a:lnT w="9525" cap="flat" cmpd="sng" algn="ctr">
-                      <a:solidFill>
-                        <a:srgbClr val="E5E7EB"/>
-                      </a:solidFill>
-                      <a:prstDash val="solid"/>
-                      <a:round/>
-                      <a:headEnd type="none" w="med" len="med"/>
-                      <a:tailEnd type="none" w="med" len="med"/>
-                    </a:lnT>
-                    <a:lnB w="9525" cap="flat" cmpd="sng" algn="ctr">
-                      <a:solidFill>
-                        <a:srgbClr val="E5E7EB"/>
-                      </a:solidFill>
-                      <a:prstDash val="solid"/>
-                      <a:round/>
-                      <a:headEnd type="none" w="med" len="med"/>
-                      <a:tailEnd type="none" w="med" len="med"/>
-                    </a:lnB>
-                    <a:solidFill>
-                      <a:srgbClr val="F9FAFB"/>
-                    </a:solidFill>
-                  </a:tcPr>
-                </a:tc>
-                <a:tc>
-                  <a:txBody>
-                    <a:bodyPr/>
-                    <a:lstStyle/>
-                    <a:p>
-                      <a:pPr indent="0" marL="0">
-                        <a:buNone/>
-                      </a:pPr>
-                      <a:endParaRPr lang="en-US" sz="1200" dirty="0">
-                        <a:latin typeface="Calibri" charset="0"/>
-                        <a:ea typeface="Calibri" charset="0"/>
-                        <a:cs typeface="Calibri" charset="0"/>
-                      </a:endParaRPr>
-                    </a:p>
-                  </a:txBody>
-                  <a:tcPr marL="91440" marR="91440" marT="36576" marB="36576" anchor="ctr">
-                    <a:lnL w="9525" cap="flat" cmpd="sng" algn="ctr">
-                      <a:solidFill>
-                        <a:srgbClr val="E5E7EB"/>
-                      </a:solidFill>
-                      <a:prstDash val="solid"/>
-                      <a:round/>
-                      <a:headEnd type="none" w="med" len="med"/>
-                      <a:tailEnd type="none" w="med" len="med"/>
-                    </a:lnL>
-                    <a:lnR w="9525" cap="flat" cmpd="sng" algn="ctr">
-                      <a:solidFill>
-                        <a:srgbClr val="E5E7EB"/>
-                      </a:solidFill>
-                      <a:prstDash val="solid"/>
-                      <a:round/>
-                      <a:headEnd type="none" w="med" len="med"/>
-                      <a:tailEnd type="none" w="med" len="med"/>
-                    </a:lnR>
-                    <a:lnT w="9525" cap="flat" cmpd="sng" algn="ctr">
-                      <a:solidFill>
-                        <a:srgbClr val="E5E7EB"/>
-                      </a:solidFill>
-                      <a:prstDash val="solid"/>
-                      <a:round/>
-                      <a:headEnd type="none" w="med" len="med"/>
-                      <a:tailEnd type="none" w="med" len="med"/>
-                    </a:lnT>
-                    <a:lnB w="9525" cap="flat" cmpd="sng" algn="ctr">
-                      <a:solidFill>
-                        <a:srgbClr val="E5E7EB"/>
-                      </a:solidFill>
-                      <a:prstDash val="solid"/>
-                      <a:round/>
-                      <a:headEnd type="none" w="med" len="med"/>
-                      <a:tailEnd type="none" w="med" len="med"/>
-                    </a:lnB>
-                    <a:solidFill>
-                      <a:srgbClr val="F9FAFB"/>
-                    </a:solidFill>
-                  </a:tcPr>
-                </a:tc>
-                <a:tc>
-                  <a:txBody>
-                    <a:bodyPr/>
-                    <a:lstStyle/>
-                    <a:p>
-                      <a:pPr indent="0" marL="0">
-                        <a:buNone/>
-                      </a:pPr>
-                      <a:r>
-                        <a:rPr lang="en-US" sz="1200" dirty="0">
-                          <a:solidFill>
-                            <a:srgbClr val="6B7280"/>
-                          </a:solidFill>
-                          <a:latin typeface="Calibri" pitchFamily="34" charset="0"/>
-                          <a:ea typeface="Calibri" pitchFamily="34" charset="-122"/>
-                          <a:cs typeface="Calibri" pitchFamily="34" charset="-120"/>
-                        </a:rPr>
-                        <a:t>In development</a:t>
-                      </a:r>
-                      <a:endParaRPr lang="en-US" sz="1200" dirty="0">
-                        <a:latin typeface="Calibri" charset="0"/>
-                        <a:ea typeface="Calibri" charset="0"/>
-                        <a:cs typeface="Calibri" charset="0"/>
-                      </a:endParaRPr>
-                    </a:p>
-                  </a:txBody>
-                  <a:tcPr marL="91440" marR="91440" marT="36576" marB="36576" anchor="ctr">
-                    <a:lnL w="9525" cap="flat" cmpd="sng" algn="ctr">
-                      <a:solidFill>
-                        <a:srgbClr val="E5E7EB"/>
-                      </a:solidFill>
-                      <a:prstDash val="solid"/>
-                      <a:round/>
-                      <a:headEnd type="none" w="med" len="med"/>
-                      <a:tailEnd type="none" w="med" len="med"/>
-                    </a:lnL>
-                    <a:lnR w="9525" cap="flat" cmpd="sng" algn="ctr">
-                      <a:solidFill>
-                        <a:srgbClr val="E5E7EB"/>
-                      </a:solidFill>
-                      <a:prstDash val="solid"/>
-                      <a:round/>
-                      <a:headEnd type="none" w="med" len="med"/>
-                      <a:tailEnd type="none" w="med" len="med"/>
-                    </a:lnR>
-                    <a:lnT w="9525" cap="flat" cmpd="sng" algn="ctr">
-                      <a:solidFill>
-                        <a:srgbClr val="E5E7EB"/>
-                      </a:solidFill>
-                      <a:prstDash val="solid"/>
-                      <a:round/>
-                      <a:headEnd type="none" w="med" len="med"/>
-                      <a:tailEnd type="none" w="med" len="med"/>
-                    </a:lnT>
-                    <a:lnB w="9525" cap="flat" cmpd="sng" algn="ctr">
-                      <a:solidFill>
-                        <a:srgbClr val="E5E7EB"/>
-                      </a:solidFill>
-                      <a:prstDash val="solid"/>
-                      <a:round/>
-                      <a:headEnd type="none" w="med" len="med"/>
-                      <a:tailEnd type="none" w="med" len="med"/>
-                    </a:lnB>
-                    <a:solidFill>
-                      <a:srgbClr val="F9FAFB"/>
-                    </a:solidFill>
-                  </a:tcPr>
-                </a:tc>
-              </a:tr>
-              <a:tr h="502920">
-                <a:tc>
-                  <a:txBody>
-                    <a:bodyPr/>
-                    <a:lstStyle/>
-                    <a:p>
-                      <a:pPr indent="0" marL="0">
-                        <a:buNone/>
-                      </a:pPr>
-                      <a:endParaRPr lang="en-US" sz="1200" dirty="0">
-                        <a:latin typeface="Calibri" charset="0"/>
-                        <a:ea typeface="Calibri" charset="0"/>
-                        <a:cs typeface="Calibri" charset="0"/>
-                      </a:endParaRPr>
-                    </a:p>
-                  </a:txBody>
-                  <a:tcPr marL="91440" marR="91440" marT="36576" marB="36576" anchor="ctr">
-                    <a:lnL w="9525" cap="flat" cmpd="sng" algn="ctr">
-                      <a:solidFill>
-                        <a:srgbClr val="E5E7EB"/>
-                      </a:solidFill>
-                      <a:prstDash val="solid"/>
-                      <a:round/>
-                      <a:headEnd type="none" w="med" len="med"/>
-                      <a:tailEnd type="none" w="med" len="med"/>
-                    </a:lnL>
-                    <a:lnR w="9525" cap="flat" cmpd="sng" algn="ctr">
-                      <a:solidFill>
-                        <a:srgbClr val="E5E7EB"/>
-                      </a:solidFill>
-                      <a:prstDash val="solid"/>
-                      <a:round/>
-                      <a:headEnd type="none" w="med" len="med"/>
-                      <a:tailEnd type="none" w="med" len="med"/>
-                    </a:lnR>
-                    <a:lnT w="9525" cap="flat" cmpd="sng" algn="ctr">
-                      <a:solidFill>
-                        <a:srgbClr val="E5E7EB"/>
-                      </a:solidFill>
-                      <a:prstDash val="solid"/>
-                      <a:round/>
-                      <a:headEnd type="none" w="med" len="med"/>
-                      <a:tailEnd type="none" w="med" len="med"/>
-                    </a:lnT>
-                    <a:lnB w="9525" cap="flat" cmpd="sng" algn="ctr">
-                      <a:solidFill>
-                        <a:srgbClr val="E5E7EB"/>
-                      </a:solidFill>
-                      <a:prstDash val="solid"/>
-                      <a:round/>
-                      <a:headEnd type="none" w="med" len="med"/>
-                      <a:tailEnd type="none" w="med" len="med"/>
-                    </a:lnB>
-                    <a:solidFill>
                       <a:srgbClr val="EDE9FE"/>
                     </a:solidFill>
                   </a:tcPr>
                 </a:tc>
-                <a:tc>
-                  <a:txBody>
-                    <a:bodyPr/>
-                    <a:lstStyle/>
-                    <a:p>
-                      <a:pPr indent="0" marL="0">
-                        <a:buNone/>
-                      </a:pPr>
-                      <a:r>
-                        <a:rPr lang="en-US" sz="1200" b="1" dirty="0">
-                          <a:solidFill>
-                            <a:srgbClr val="111827"/>
-                          </a:solidFill>
-                          <a:latin typeface="Calibri" pitchFamily="34" charset="0"/>
-                          <a:ea typeface="Calibri" pitchFamily="34" charset="-122"/>
-                          <a:cs typeface="Calibri" pitchFamily="34" charset="-120"/>
-                        </a:rPr>
-                        <a:t>Identified so far</a:t>
-                      </a:r>
-                      <a:endParaRPr lang="en-US" sz="1200" dirty="0">
-                        <a:latin typeface="Calibri" charset="0"/>
-                        <a:ea typeface="Calibri" charset="0"/>
-                        <a:cs typeface="Calibri" charset="0"/>
-                      </a:endParaRPr>
-                    </a:p>
-                  </a:txBody>
-                  <a:tcPr marL="91440" marR="91440" marT="36576" marB="36576" anchor="ctr">
-                    <a:lnL w="9525" cap="flat" cmpd="sng" algn="ctr">
-                      <a:solidFill>
-                        <a:srgbClr val="E5E7EB"/>
-                      </a:solidFill>
-                      <a:prstDash val="solid"/>
-                      <a:round/>
-                      <a:headEnd type="none" w="med" len="med"/>
-                      <a:tailEnd type="none" w="med" len="med"/>
-                    </a:lnL>
-                    <a:lnR w="9525" cap="flat" cmpd="sng" algn="ctr">
-                      <a:solidFill>
-                        <a:srgbClr val="E5E7EB"/>
-                      </a:solidFill>
-                      <a:prstDash val="solid"/>
-                      <a:round/>
-                      <a:headEnd type="none" w="med" len="med"/>
-                      <a:tailEnd type="none" w="med" len="med"/>
-                    </a:lnR>
-                    <a:lnT w="9525" cap="flat" cmpd="sng" algn="ctr">
-                      <a:solidFill>
-                        <a:srgbClr val="E5E7EB"/>
-                      </a:solidFill>
-                      <a:prstDash val="solid"/>
-                      <a:round/>
-                      <a:headEnd type="none" w="med" len="med"/>
-                      <a:tailEnd type="none" w="med" len="med"/>
-                    </a:lnT>
-                    <a:lnB w="9525" cap="flat" cmpd="sng" algn="ctr">
-                      <a:solidFill>
-                        <a:srgbClr val="E5E7EB"/>
-                      </a:solidFill>
-                      <a:prstDash val="solid"/>
-                      <a:round/>
-                      <a:headEnd type="none" w="med" len="med"/>
-                      <a:tailEnd type="none" w="med" len="med"/>
-                    </a:lnB>
-                    <a:solidFill>
-                      <a:srgbClr val="EDE9FE"/>
-                    </a:solidFill>
-                  </a:tcPr>
+                <a:tc hMerge="1">
+                  <a:tcPr/>
+                </a:tc>
+                <a:tc hMerge="1">
+                  <a:tcPr/>
                 </a:tc>
                 <a:tc>
                   <a:txBody>
@@ -19036,9 +21390,9 @@
                         <a:buNone/>
                       </a:pPr>
                       <a:r>
-                        <a:rPr lang="en-US" sz="1200" b="1" dirty="0">
+                        <a:rPr lang="en-US" sz="1150" b="1" dirty="0">
                           <a:solidFill>
-                            <a:srgbClr val="111827"/>
+                            <a:srgbClr val="059669"/>
                           </a:solidFill>
                           <a:latin typeface="Calibri" pitchFamily="34" charset="0"/>
                           <a:ea typeface="Calibri" pitchFamily="34" charset="-122"/>
@@ -19046,132 +21400,7 @@
                         </a:rPr>
                         <a:t>$61,000</a:t>
                       </a:r>
-                      <a:endParaRPr lang="en-US" sz="1200" dirty="0">
-                        <a:latin typeface="Calibri" charset="0"/>
-                        <a:ea typeface="Calibri" charset="0"/>
-                        <a:cs typeface="Calibri" charset="0"/>
-                      </a:endParaRPr>
-                    </a:p>
-                  </a:txBody>
-                  <a:tcPr marL="91440" marR="91440" marT="36576" marB="36576" anchor="ctr">
-                    <a:lnL w="9525" cap="flat" cmpd="sng" algn="ctr">
-                      <a:solidFill>
-                        <a:srgbClr val="E5E7EB"/>
-                      </a:solidFill>
-                      <a:prstDash val="solid"/>
-                      <a:round/>
-                      <a:headEnd type="none" w="med" len="med"/>
-                      <a:tailEnd type="none" w="med" len="med"/>
-                    </a:lnL>
-                    <a:lnR w="9525" cap="flat" cmpd="sng" algn="ctr">
-                      <a:solidFill>
-                        <a:srgbClr val="E5E7EB"/>
-                      </a:solidFill>
-                      <a:prstDash val="solid"/>
-                      <a:round/>
-                      <a:headEnd type="none" w="med" len="med"/>
-                      <a:tailEnd type="none" w="med" len="med"/>
-                    </a:lnR>
-                    <a:lnT w="9525" cap="flat" cmpd="sng" algn="ctr">
-                      <a:solidFill>
-                        <a:srgbClr val="E5E7EB"/>
-                      </a:solidFill>
-                      <a:prstDash val="solid"/>
-                      <a:round/>
-                      <a:headEnd type="none" w="med" len="med"/>
-                      <a:tailEnd type="none" w="med" len="med"/>
-                    </a:lnT>
-                    <a:lnB w="9525" cap="flat" cmpd="sng" algn="ctr">
-                      <a:solidFill>
-                        <a:srgbClr val="E5E7EB"/>
-                      </a:solidFill>
-                      <a:prstDash val="solid"/>
-                      <a:round/>
-                      <a:headEnd type="none" w="med" len="med"/>
-                      <a:tailEnd type="none" w="med" len="med"/>
-                    </a:lnB>
-                    <a:solidFill>
-                      <a:srgbClr val="EDE9FE"/>
-                    </a:solidFill>
-                  </a:tcPr>
-                </a:tc>
-                <a:tc>
-                  <a:txBody>
-                    <a:bodyPr/>
-                    <a:lstStyle/>
-                    <a:p>
-                      <a:pPr algn="r" indent="0" marL="0">
-                        <a:buNone/>
-                      </a:pPr>
-                      <a:r>
-                        <a:rPr lang="en-US" sz="1200" b="1" dirty="0">
-                          <a:solidFill>
-                            <a:srgbClr val="D97706"/>
-                          </a:solidFill>
-                          <a:latin typeface="Calibri" pitchFamily="34" charset="0"/>
-                          <a:ea typeface="Calibri" pitchFamily="34" charset="-122"/>
-                          <a:cs typeface="Calibri" pitchFamily="34" charset="-120"/>
-                        </a:rPr>
-                        <a:t>TBC</a:t>
-                      </a:r>
-                      <a:endParaRPr lang="en-US" sz="1200" dirty="0">
-                        <a:latin typeface="Calibri" charset="0"/>
-                        <a:ea typeface="Calibri" charset="0"/>
-                        <a:cs typeface="Calibri" charset="0"/>
-                      </a:endParaRPr>
-                    </a:p>
-                  </a:txBody>
-                  <a:tcPr marL="91440" marR="91440" marT="36576" marB="36576" anchor="ctr">
-                    <a:lnL w="9525" cap="flat" cmpd="sng" algn="ctr">
-                      <a:solidFill>
-                        <a:srgbClr val="E5E7EB"/>
-                      </a:solidFill>
-                      <a:prstDash val="solid"/>
-                      <a:round/>
-                      <a:headEnd type="none" w="med" len="med"/>
-                      <a:tailEnd type="none" w="med" len="med"/>
-                    </a:lnL>
-                    <a:lnR w="9525" cap="flat" cmpd="sng" algn="ctr">
-                      <a:solidFill>
-                        <a:srgbClr val="E5E7EB"/>
-                      </a:solidFill>
-                      <a:prstDash val="solid"/>
-                      <a:round/>
-                      <a:headEnd type="none" w="med" len="med"/>
-                      <a:tailEnd type="none" w="med" len="med"/>
-                    </a:lnR>
-                    <a:lnT w="9525" cap="flat" cmpd="sng" algn="ctr">
-                      <a:solidFill>
-                        <a:srgbClr val="E5E7EB"/>
-                      </a:solidFill>
-                      <a:prstDash val="solid"/>
-                      <a:round/>
-                      <a:headEnd type="none" w="med" len="med"/>
-                      <a:tailEnd type="none" w="med" len="med"/>
-                    </a:lnT>
-                    <a:lnB w="9525" cap="flat" cmpd="sng" algn="ctr">
-                      <a:solidFill>
-                        <a:srgbClr val="E5E7EB"/>
-                      </a:solidFill>
-                      <a:prstDash val="solid"/>
-                      <a:round/>
-                      <a:headEnd type="none" w="med" len="med"/>
-                      <a:tailEnd type="none" w="med" len="med"/>
-                    </a:lnB>
-                    <a:solidFill>
-                      <a:srgbClr val="EDE9FE"/>
-                    </a:solidFill>
-                  </a:tcPr>
-                </a:tc>
-                <a:tc>
-                  <a:txBody>
-                    <a:bodyPr/>
-                    <a:lstStyle/>
-                    <a:p>
-                      <a:pPr indent="0" marL="0">
-                        <a:buNone/>
-                      </a:pPr>
-                      <a:endParaRPr lang="en-US" sz="1200" dirty="0">
+                      <a:endParaRPr lang="en-US" sz="1150" dirty="0">
                         <a:latin typeface="Calibri" charset="0"/>
                         <a:ea typeface="Calibri" charset="0"/>
                         <a:cs typeface="Calibri" charset="0"/>
@@ -19227,90 +21456,14 @@
       </p:graphicFrame>
       <p:sp>
         <p:nvSpPr>
-          <p:cNvPr id="5" name="Shape 2"/>
-          <p:cNvSpPr/>
-          <p:nvPr/>
-        </p:nvSpPr>
-        <p:spPr>
-          <a:xfrm>
-            <a:off x="548640" y="3657600"/>
-            <a:ext cx="8229600" cy="1874520"/>
-          </a:xfrm>
-          <a:prstGeom prst="roundRect">
-            <a:avLst>
-              <a:gd name="adj" fmla="val 3902"/>
-            </a:avLst>
-          </a:prstGeom>
-          <a:solidFill>
-            <a:srgbClr val="ECFDF5"/>
-          </a:solidFill>
-          <a:ln w="12700">
-            <a:solidFill>
-              <a:srgbClr val="ECFDF5"/>
-            </a:solidFill>
-            <a:prstDash val="solid"/>
-          </a:ln>
-        </p:spPr>
-      </p:sp>
-      <p:sp>
-        <p:nvSpPr>
-          <p:cNvPr id="6" name="Shape 3"/>
-          <p:cNvSpPr/>
-          <p:nvPr/>
-        </p:nvSpPr>
-        <p:spPr>
-          <a:xfrm>
-            <a:off x="822960" y="3977640"/>
-            <a:ext cx="685800" cy="685800"/>
-          </a:xfrm>
-          <a:prstGeom prst="ellipse">
-            <a:avLst/>
-          </a:prstGeom>
-          <a:solidFill>
-            <a:srgbClr val="059669"/>
-          </a:solidFill>
-          <a:ln w="12700">
-            <a:solidFill>
-              <a:srgbClr val="059669"/>
-            </a:solidFill>
-            <a:prstDash val="solid"/>
-          </a:ln>
-        </p:spPr>
-      </p:sp>
-      <p:pic>
-        <p:nvPicPr>
-          <p:cNvPr id="7" name="Image 0" descr="preencoded.png">    </p:cNvPr>
-          <p:cNvPicPr>
-            <a:picLocks noChangeAspect="1"/>
-          </p:cNvPicPr>
-          <p:nvPr/>
-        </p:nvPicPr>
-        <p:blipFill>
-          <a:blip r:embed="rId1"/>
-          <a:stretch>
-            <a:fillRect/>
-          </a:stretch>
-        </p:blipFill>
-        <p:spPr>
-          <a:xfrm>
-            <a:off x="994410" y="4149090"/>
-            <a:ext cx="342900" cy="342900"/>
-          </a:xfrm>
-          <a:prstGeom prst="rect">
-            <a:avLst/>
-          </a:prstGeom>
-        </p:spPr>
-      </p:pic>
-      <p:sp>
-        <p:nvSpPr>
-          <p:cNvPr id="8" name="Text 4"/>
-          <p:cNvSpPr txBox="1"/>
-          <p:nvPr/>
-        </p:nvSpPr>
-        <p:spPr>
-          <a:xfrm>
-            <a:off x="1737360" y="3840480"/>
-            <a:ext cx="6766560" cy="274320"/>
+          <p:cNvPr id="21" name="Text 18"/>
+          <p:cNvSpPr txBox="1"/>
+          <p:nvPr/>
+        </p:nvSpPr>
+        <p:spPr>
+          <a:xfrm>
+            <a:off x="548640" y="5943600"/>
+            <a:ext cx="11091672" cy="256032"/>
           </a:xfrm>
           <a:prstGeom prst="rect">
             <a:avLst/>
@@ -19326,7 +21479,7 @@
               <a:buNone/>
             </a:pPr>
             <a:r>
-              <a:rPr lang="en-US" sz="1300" b="1" dirty="0">
+              <a:rPr lang="en-US" sz="950" i="1" dirty="0">
                 <a:solidFill>
                   <a:srgbClr val="6B7280"/>
                 </a:solidFill>
@@ -19334,736 +21487,15 @@
                 <a:ea typeface="Calibri" pitchFamily="34" charset="-122"/>
                 <a:cs typeface="Calibri" pitchFamily="34" charset="-120"/>
               </a:rPr>
-              <a:t>Confirmed saving</a:t>
-            </a:r>
-            <a:endParaRPr lang="en-US" sz="1300" dirty="0"/>
-          </a:p>
-        </p:txBody>
-      </p:sp>
-      <p:sp>
-        <p:nvSpPr>
-          <p:cNvPr id="9" name="Text 5"/>
-          <p:cNvSpPr txBox="1"/>
-          <p:nvPr/>
-        </p:nvSpPr>
-        <p:spPr>
-          <a:xfrm>
-            <a:off x="1737360" y="4114800"/>
-            <a:ext cx="6766560" cy="731520"/>
-          </a:xfrm>
-          <a:prstGeom prst="rect">
-            <a:avLst/>
-          </a:prstGeom>
-          <a:noFill/>
-          <a:ln/>
-        </p:spPr>
-        <p:txBody>
-          <a:bodyPr wrap="square" lIns="0" tIns="0" rIns="0" bIns="0" rtlCol="0" anchor="ctr"/>
-          <a:lstStyle/>
-          <a:p>
-            <a:pPr indent="0" marL="0">
-              <a:buNone/>
-            </a:pPr>
-            <a:r>
-              <a:rPr lang="en-US" sz="4000" b="1" dirty="0">
-                <a:solidFill>
-                  <a:srgbClr val="059669"/>
-                </a:solidFill>
-                <a:latin typeface="Calibri" pitchFamily="34" charset="0"/>
-                <a:ea typeface="Calibri" pitchFamily="34" charset="-122"/>
-                <a:cs typeface="Calibri" pitchFamily="34" charset="-120"/>
-              </a:rPr>
-              <a:t>$61,000</a:t>
-            </a:r>
-            <a:pPr indent="0" marL="0">
-              <a:buNone/>
-            </a:pPr>
-            <a:r>
-              <a:rPr lang="en-US" sz="1600" dirty="0">
-                <a:solidFill>
-                  <a:srgbClr val="1F2937"/>
-                </a:solidFill>
-                <a:latin typeface="Calibri" pitchFamily="34" charset="0"/>
-                <a:ea typeface="Calibri" pitchFamily="34" charset="-122"/>
-                <a:cs typeface="Calibri" pitchFamily="34" charset="-120"/>
-              </a:rPr>
-              <a:t>  per year</a:t>
-            </a:r>
-            <a:endParaRPr lang="en-US" sz="4000" dirty="0"/>
-          </a:p>
-        </p:txBody>
-      </p:sp>
-      <p:sp>
-        <p:nvSpPr>
-          <p:cNvPr id="10" name="Text 6"/>
-          <p:cNvSpPr txBox="1"/>
-          <p:nvPr/>
-        </p:nvSpPr>
-        <p:spPr>
-          <a:xfrm>
-            <a:off x="1737360" y="4892040"/>
-            <a:ext cx="6766560" cy="365760"/>
-          </a:xfrm>
-          <a:prstGeom prst="rect">
-            <a:avLst/>
-          </a:prstGeom>
-          <a:noFill/>
-          <a:ln/>
-        </p:spPr>
-        <p:txBody>
-          <a:bodyPr wrap="square" lIns="0" tIns="0" rIns="0" bIns="0" rtlCol="0" anchor="ctr"/>
-          <a:lstStyle/>
-          <a:p>
-            <a:pPr indent="0" marL="0">
-              <a:buNone/>
-            </a:pPr>
-            <a:r>
-              <a:rPr lang="en-US" sz="1500" dirty="0">
-                <a:solidFill>
-                  <a:srgbClr val="1F2937"/>
-                </a:solidFill>
-                <a:latin typeface="Calibri" pitchFamily="34" charset="0"/>
-                <a:ea typeface="Calibri" pitchFamily="34" charset="-122"/>
-                <a:cs typeface="Calibri" pitchFamily="34" charset="-120"/>
-              </a:rPr>
-              <a:t>Dispatcher role eliminated — dispatch centralized.</a:t>
-            </a:r>
-            <a:endParaRPr lang="en-US" sz="1500" dirty="0"/>
-          </a:p>
-        </p:txBody>
-      </p:sp>
-      <p:sp>
-        <p:nvSpPr>
-          <p:cNvPr id="11" name="Text 7"/>
-          <p:cNvSpPr txBox="1"/>
-          <p:nvPr/>
-        </p:nvSpPr>
-        <p:spPr>
-          <a:xfrm>
-            <a:off x="548640" y="5806440"/>
-            <a:ext cx="11091672" cy="274320"/>
-          </a:xfrm>
-          <a:prstGeom prst="rect">
-            <a:avLst/>
-          </a:prstGeom>
-          <a:noFill/>
-          <a:ln/>
-        </p:spPr>
-        <p:txBody>
-          <a:bodyPr wrap="square" lIns="0" tIns="0" rIns="0" bIns="0" rtlCol="0" anchor="ctr"/>
-          <a:lstStyle/>
-          <a:p>
-            <a:pPr indent="0" marL="0">
-              <a:buNone/>
-            </a:pPr>
-            <a:r>
-              <a:rPr lang="en-US" sz="1000" i="1" dirty="0">
-                <a:solidFill>
-                  <a:srgbClr val="6B7280"/>
-                </a:solidFill>
-                <a:latin typeface="Calibri" pitchFamily="34" charset="0"/>
-                <a:ea typeface="Calibri" pitchFamily="34" charset="-122"/>
-                <a:cs typeface="Calibri" pitchFamily="34" charset="-120"/>
-              </a:rPr>
-              <a:t>F27 plan = full-year $; realized = Jul 1, 2026 to date. Cargo claims: Claims report — terminal T-0502 (Mississauga).</a:t>
-            </a:r>
-            <a:endParaRPr lang="en-US" sz="1000" dirty="0"/>
-          </a:p>
-        </p:txBody>
-      </p:sp>
-      <p:sp>
-        <p:nvSpPr>
-          <p:cNvPr id="12" name="Shape 8"/>
-          <p:cNvSpPr/>
-          <p:nvPr/>
-        </p:nvSpPr>
-        <p:spPr>
-          <a:xfrm>
-            <a:off x="9052560" y="1371600"/>
-            <a:ext cx="2587752" cy="1005840"/>
-          </a:xfrm>
-          <a:prstGeom prst="roundRect">
-            <a:avLst>
-              <a:gd name="adj" fmla="val 7273"/>
-            </a:avLst>
-          </a:prstGeom>
-          <a:solidFill>
-            <a:srgbClr val="F5F3FF"/>
-          </a:solidFill>
-          <a:ln w="12700">
-            <a:solidFill>
-              <a:srgbClr val="F5F3FF"/>
-            </a:solidFill>
-            <a:prstDash val="solid"/>
-          </a:ln>
-        </p:spPr>
-      </p:sp>
-      <p:sp>
-        <p:nvSpPr>
-          <p:cNvPr id="13" name="Text 9"/>
-          <p:cNvSpPr txBox="1"/>
-          <p:nvPr/>
-        </p:nvSpPr>
-        <p:spPr>
-          <a:xfrm>
-            <a:off x="9217152" y="1463040"/>
-            <a:ext cx="2286000" cy="237744"/>
-          </a:xfrm>
-          <a:prstGeom prst="rect">
-            <a:avLst/>
-          </a:prstGeom>
-          <a:noFill/>
-          <a:ln/>
-        </p:spPr>
-        <p:txBody>
-          <a:bodyPr wrap="square" lIns="0" tIns="0" rIns="0" bIns="0" rtlCol="0" anchor="ctr"/>
-          <a:lstStyle/>
-          <a:p>
-            <a:pPr indent="0" marL="0">
-              <a:buNone/>
-            </a:pPr>
-            <a:r>
-              <a:rPr lang="en-US" sz="1100" b="1" dirty="0">
-                <a:solidFill>
-                  <a:srgbClr val="6B7280"/>
-                </a:solidFill>
-                <a:latin typeface="Calibri" pitchFamily="34" charset="0"/>
-                <a:ea typeface="Calibri" pitchFamily="34" charset="-122"/>
-                <a:cs typeface="Calibri" pitchFamily="34" charset="-120"/>
-              </a:rPr>
-              <a:t>F27 take-out target</a:t>
-            </a:r>
-            <a:endParaRPr lang="en-US" sz="1100" dirty="0"/>
-          </a:p>
-        </p:txBody>
-      </p:sp>
-      <p:sp>
-        <p:nvSpPr>
-          <p:cNvPr id="14" name="Text 10"/>
-          <p:cNvSpPr txBox="1"/>
-          <p:nvPr/>
-        </p:nvSpPr>
-        <p:spPr>
-          <a:xfrm>
-            <a:off x="9217152" y="1700784"/>
-            <a:ext cx="2286000" cy="384048"/>
-          </a:xfrm>
-          <a:prstGeom prst="rect">
-            <a:avLst/>
-          </a:prstGeom>
-          <a:noFill/>
-          <a:ln/>
-        </p:spPr>
-        <p:txBody>
-          <a:bodyPr wrap="square" lIns="0" tIns="0" rIns="0" bIns="0" rtlCol="0" anchor="ctr"/>
-          <a:lstStyle/>
-          <a:p>
-            <a:pPr indent="0" marL="0">
-              <a:buNone/>
-            </a:pPr>
-            <a:r>
-              <a:rPr lang="en-US" sz="2000" b="1" dirty="0">
-                <a:solidFill>
-                  <a:srgbClr val="D97706"/>
-                </a:solidFill>
-                <a:latin typeface="Calibri" pitchFamily="34" charset="0"/>
-                <a:ea typeface="Calibri" pitchFamily="34" charset="-122"/>
-                <a:cs typeface="Calibri" pitchFamily="34" charset="-120"/>
-              </a:rPr>
-              <a:t>TBC</a:t>
-            </a:r>
-            <a:endParaRPr lang="en-US" sz="2000" dirty="0"/>
-          </a:p>
-        </p:txBody>
-      </p:sp>
-      <p:sp>
-        <p:nvSpPr>
-          <p:cNvPr id="15" name="Text 11"/>
-          <p:cNvSpPr txBox="1"/>
-          <p:nvPr/>
-        </p:nvSpPr>
-        <p:spPr>
-          <a:xfrm>
-            <a:off x="9217152" y="2103120"/>
-            <a:ext cx="2286000" cy="219456"/>
-          </a:xfrm>
-          <a:prstGeom prst="rect">
-            <a:avLst/>
-          </a:prstGeom>
-          <a:noFill/>
-          <a:ln/>
-        </p:spPr>
-        <p:txBody>
-          <a:bodyPr wrap="square" lIns="0" tIns="0" rIns="0" bIns="0" rtlCol="0" anchor="ctr"/>
-          <a:lstStyle/>
-          <a:p>
-            <a:pPr indent="0" marL="0">
-              <a:buNone/>
-            </a:pPr>
-            <a:r>
-              <a:rPr lang="en-US" sz="1000" dirty="0">
-                <a:solidFill>
-                  <a:srgbClr val="6B7280"/>
-                </a:solidFill>
-                <a:latin typeface="Calibri" pitchFamily="34" charset="0"/>
-                <a:ea typeface="Calibri" pitchFamily="34" charset="-122"/>
-                <a:cs typeface="Calibri" pitchFamily="34" charset="-120"/>
-              </a:rPr>
-              <a:t>Full year</a:t>
-            </a:r>
-            <a:endParaRPr lang="en-US" sz="1000" dirty="0"/>
-          </a:p>
-        </p:txBody>
-      </p:sp>
-      <p:sp>
-        <p:nvSpPr>
-          <p:cNvPr id="16" name="Shape 12"/>
-          <p:cNvSpPr/>
-          <p:nvPr/>
-        </p:nvSpPr>
-        <p:spPr>
-          <a:xfrm>
-            <a:off x="9052560" y="2487168"/>
-            <a:ext cx="2587752" cy="1005840"/>
-          </a:xfrm>
-          <a:prstGeom prst="roundRect">
-            <a:avLst>
-              <a:gd name="adj" fmla="val 7273"/>
-            </a:avLst>
-          </a:prstGeom>
-          <a:solidFill>
-            <a:srgbClr val="F3F4F6"/>
-          </a:solidFill>
-          <a:ln w="12700">
-            <a:solidFill>
-              <a:srgbClr val="F3F4F6"/>
-            </a:solidFill>
-            <a:prstDash val="solid"/>
-          </a:ln>
-        </p:spPr>
-      </p:sp>
-      <p:sp>
-        <p:nvSpPr>
-          <p:cNvPr id="17" name="Text 13"/>
-          <p:cNvSpPr txBox="1"/>
-          <p:nvPr/>
-        </p:nvSpPr>
-        <p:spPr>
-          <a:xfrm>
-            <a:off x="9217152" y="2578608"/>
-            <a:ext cx="2286000" cy="237744"/>
-          </a:xfrm>
-          <a:prstGeom prst="rect">
-            <a:avLst/>
-          </a:prstGeom>
-          <a:noFill/>
-          <a:ln/>
-        </p:spPr>
-        <p:txBody>
-          <a:bodyPr wrap="square" lIns="0" tIns="0" rIns="0" bIns="0" rtlCol="0" anchor="ctr"/>
-          <a:lstStyle/>
-          <a:p>
-            <a:pPr indent="0" marL="0">
-              <a:buNone/>
-            </a:pPr>
-            <a:r>
-              <a:rPr lang="en-US" sz="1100" b="1" dirty="0">
-                <a:solidFill>
-                  <a:srgbClr val="6B7280"/>
-                </a:solidFill>
-                <a:latin typeface="Calibri" pitchFamily="34" charset="0"/>
-                <a:ea typeface="Calibri" pitchFamily="34" charset="-122"/>
-                <a:cs typeface="Calibri" pitchFamily="34" charset="-120"/>
-              </a:rPr>
-              <a:t>Identified so far</a:t>
-            </a:r>
-            <a:endParaRPr lang="en-US" sz="1100" dirty="0"/>
-          </a:p>
-        </p:txBody>
-      </p:sp>
-      <p:sp>
-        <p:nvSpPr>
-          <p:cNvPr id="18" name="Text 14"/>
-          <p:cNvSpPr txBox="1"/>
-          <p:nvPr/>
-        </p:nvSpPr>
-        <p:spPr>
-          <a:xfrm>
-            <a:off x="9217152" y="2816352"/>
-            <a:ext cx="2286000" cy="384048"/>
-          </a:xfrm>
-          <a:prstGeom prst="rect">
-            <a:avLst/>
-          </a:prstGeom>
-          <a:noFill/>
-          <a:ln/>
-        </p:spPr>
-        <p:txBody>
-          <a:bodyPr wrap="square" lIns="0" tIns="0" rIns="0" bIns="0" rtlCol="0" anchor="ctr"/>
-          <a:lstStyle/>
-          <a:p>
-            <a:pPr indent="0" marL="0">
-              <a:buNone/>
-            </a:pPr>
-            <a:r>
-              <a:rPr lang="en-US" sz="2000" b="1" dirty="0">
-                <a:solidFill>
-                  <a:srgbClr val="059669"/>
-                </a:solidFill>
-                <a:latin typeface="Calibri" pitchFamily="34" charset="0"/>
-                <a:ea typeface="Calibri" pitchFamily="34" charset="-122"/>
-                <a:cs typeface="Calibri" pitchFamily="34" charset="-120"/>
-              </a:rPr>
-              <a:t>$61,000</a:t>
-            </a:r>
-            <a:endParaRPr lang="en-US" sz="2000" dirty="0"/>
-          </a:p>
-        </p:txBody>
-      </p:sp>
-      <p:sp>
-        <p:nvSpPr>
-          <p:cNvPr id="19" name="Text 15"/>
-          <p:cNvSpPr txBox="1"/>
-          <p:nvPr/>
-        </p:nvSpPr>
-        <p:spPr>
-          <a:xfrm>
-            <a:off x="9217152" y="3218688"/>
-            <a:ext cx="2286000" cy="219456"/>
-          </a:xfrm>
-          <a:prstGeom prst="rect">
-            <a:avLst/>
-          </a:prstGeom>
-          <a:noFill/>
-          <a:ln/>
-        </p:spPr>
-        <p:txBody>
-          <a:bodyPr wrap="square" lIns="0" tIns="0" rIns="0" bIns="0" rtlCol="0" anchor="ctr"/>
-          <a:lstStyle/>
-          <a:p>
-            <a:pPr indent="0" marL="0">
-              <a:buNone/>
-            </a:pPr>
-            <a:r>
-              <a:rPr lang="en-US" sz="1000" dirty="0">
-                <a:solidFill>
-                  <a:srgbClr val="6B7280"/>
-                </a:solidFill>
-                <a:latin typeface="Calibri" pitchFamily="34" charset="0"/>
-                <a:ea typeface="Calibri" pitchFamily="34" charset="-122"/>
-                <a:cs typeface="Calibri" pitchFamily="34" charset="-120"/>
-              </a:rPr>
-              <a:t>% of target: </a:t>
-            </a:r>
-            <a:pPr indent="0" marL="0">
-              <a:buNone/>
-            </a:pPr>
-            <a:r>
-              <a:rPr lang="en-US" sz="1000" b="1" dirty="0">
-                <a:solidFill>
-                  <a:srgbClr val="D97706"/>
-                </a:solidFill>
-                <a:latin typeface="Calibri" pitchFamily="34" charset="0"/>
-                <a:ea typeface="Calibri" pitchFamily="34" charset="-122"/>
-                <a:cs typeface="Calibri" pitchFamily="34" charset="-120"/>
-              </a:rPr>
-              <a:t>TBC</a:t>
-            </a:r>
-            <a:endParaRPr lang="en-US" sz="1000" dirty="0"/>
-          </a:p>
-        </p:txBody>
-      </p:sp>
-      <p:sp>
-        <p:nvSpPr>
-          <p:cNvPr id="20" name="Shape 16"/>
-          <p:cNvSpPr/>
-          <p:nvPr/>
-        </p:nvSpPr>
-        <p:spPr>
-          <a:xfrm>
-            <a:off x="9052560" y="3602736"/>
-            <a:ext cx="2587752" cy="1005840"/>
-          </a:xfrm>
-          <a:prstGeom prst="roundRect">
-            <a:avLst>
-              <a:gd name="adj" fmla="val 7273"/>
-            </a:avLst>
-          </a:prstGeom>
-          <a:solidFill>
-            <a:srgbClr val="F3F4F6"/>
-          </a:solidFill>
-          <a:ln w="12700">
-            <a:solidFill>
-              <a:srgbClr val="F3F4F6"/>
-            </a:solidFill>
-            <a:prstDash val="solid"/>
-          </a:ln>
-        </p:spPr>
-      </p:sp>
-      <p:sp>
-        <p:nvSpPr>
-          <p:cNvPr id="21" name="Text 17"/>
-          <p:cNvSpPr txBox="1"/>
-          <p:nvPr/>
-        </p:nvSpPr>
-        <p:spPr>
-          <a:xfrm>
-            <a:off x="9217152" y="3694176"/>
-            <a:ext cx="2286000" cy="237744"/>
-          </a:xfrm>
-          <a:prstGeom prst="rect">
-            <a:avLst/>
-          </a:prstGeom>
-          <a:noFill/>
-          <a:ln/>
-        </p:spPr>
-        <p:txBody>
-          <a:bodyPr wrap="square" lIns="0" tIns="0" rIns="0" bIns="0" rtlCol="0" anchor="ctr"/>
-          <a:lstStyle/>
-          <a:p>
-            <a:pPr indent="0" marL="0">
-              <a:buNone/>
-            </a:pPr>
-            <a:r>
-              <a:rPr lang="en-US" sz="1100" b="1" dirty="0">
-                <a:solidFill>
-                  <a:srgbClr val="6B7280"/>
-                </a:solidFill>
-                <a:latin typeface="Calibri" pitchFamily="34" charset="0"/>
-                <a:ea typeface="Calibri" pitchFamily="34" charset="-122"/>
-                <a:cs typeface="Calibri" pitchFamily="34" charset="-120"/>
-              </a:rPr>
-              <a:t>Realized YTD</a:t>
-            </a:r>
-            <a:endParaRPr lang="en-US" sz="1100" dirty="0"/>
-          </a:p>
-        </p:txBody>
-      </p:sp>
-      <p:sp>
-        <p:nvSpPr>
-          <p:cNvPr id="22" name="Text 18"/>
-          <p:cNvSpPr txBox="1"/>
-          <p:nvPr/>
-        </p:nvSpPr>
-        <p:spPr>
-          <a:xfrm>
-            <a:off x="9217152" y="3931920"/>
-            <a:ext cx="2286000" cy="384048"/>
-          </a:xfrm>
-          <a:prstGeom prst="rect">
-            <a:avLst/>
-          </a:prstGeom>
-          <a:noFill/>
-          <a:ln/>
-        </p:spPr>
-        <p:txBody>
-          <a:bodyPr wrap="square" lIns="0" tIns="0" rIns="0" bIns="0" rtlCol="0" anchor="ctr"/>
-          <a:lstStyle/>
-          <a:p>
-            <a:pPr indent="0" marL="0">
-              <a:buNone/>
-            </a:pPr>
-            <a:r>
-              <a:rPr lang="en-US" sz="2000" b="1" dirty="0">
-                <a:solidFill>
-                  <a:srgbClr val="D97706"/>
-                </a:solidFill>
-                <a:latin typeface="Calibri" pitchFamily="34" charset="0"/>
-                <a:ea typeface="Calibri" pitchFamily="34" charset="-122"/>
-                <a:cs typeface="Calibri" pitchFamily="34" charset="-120"/>
-              </a:rPr>
-              <a:t>TBC</a:t>
-            </a:r>
-            <a:endParaRPr lang="en-US" sz="2000" dirty="0"/>
-          </a:p>
-        </p:txBody>
-      </p:sp>
-      <p:sp>
-        <p:nvSpPr>
-          <p:cNvPr id="23" name="Text 19"/>
-          <p:cNvSpPr txBox="1"/>
-          <p:nvPr/>
-        </p:nvSpPr>
-        <p:spPr>
-          <a:xfrm>
-            <a:off x="9217152" y="4334256"/>
-            <a:ext cx="2286000" cy="219456"/>
-          </a:xfrm>
-          <a:prstGeom prst="rect">
-            <a:avLst/>
-          </a:prstGeom>
-          <a:noFill/>
-          <a:ln/>
-        </p:spPr>
-        <p:txBody>
-          <a:bodyPr wrap="square" lIns="0" tIns="0" rIns="0" bIns="0" rtlCol="0" anchor="ctr"/>
-          <a:lstStyle/>
-          <a:p>
-            <a:pPr indent="0" marL="0">
-              <a:buNone/>
-            </a:pPr>
-            <a:r>
-              <a:rPr lang="en-US" sz="1000" dirty="0">
-                <a:solidFill>
-                  <a:srgbClr val="6B7280"/>
-                </a:solidFill>
-                <a:latin typeface="Calibri" pitchFamily="34" charset="0"/>
-                <a:ea typeface="Calibri" pitchFamily="34" charset="-122"/>
-                <a:cs typeface="Calibri" pitchFamily="34" charset="-120"/>
-              </a:rPr>
-              <a:t>Jul 1 to date</a:t>
-            </a:r>
-            <a:endParaRPr lang="en-US" sz="1000" dirty="0"/>
-          </a:p>
-        </p:txBody>
-      </p:sp>
-      <p:sp>
-        <p:nvSpPr>
-          <p:cNvPr id="24" name="Shape 20"/>
-          <p:cNvSpPr/>
-          <p:nvPr/>
-        </p:nvSpPr>
-        <p:spPr>
-          <a:xfrm>
-            <a:off x="9052560" y="4718304"/>
-            <a:ext cx="2587752" cy="1005840"/>
-          </a:xfrm>
-          <a:prstGeom prst="roundRect">
-            <a:avLst>
-              <a:gd name="adj" fmla="val 7273"/>
-            </a:avLst>
-          </a:prstGeom>
-          <a:solidFill>
-            <a:srgbClr val="F3F4F6"/>
-          </a:solidFill>
-          <a:ln w="12700">
-            <a:solidFill>
-              <a:srgbClr val="F3F4F6"/>
-            </a:solidFill>
-            <a:prstDash val="solid"/>
-          </a:ln>
-        </p:spPr>
-      </p:sp>
-      <p:sp>
-        <p:nvSpPr>
-          <p:cNvPr id="25" name="Text 21"/>
-          <p:cNvSpPr txBox="1"/>
-          <p:nvPr/>
-        </p:nvSpPr>
-        <p:spPr>
-          <a:xfrm>
-            <a:off x="9217152" y="4809744"/>
-            <a:ext cx="2286000" cy="237744"/>
-          </a:xfrm>
-          <a:prstGeom prst="rect">
-            <a:avLst/>
-          </a:prstGeom>
-          <a:noFill/>
-          <a:ln/>
-        </p:spPr>
-        <p:txBody>
-          <a:bodyPr wrap="square" lIns="0" tIns="0" rIns="0" bIns="0" rtlCol="0" anchor="ctr"/>
-          <a:lstStyle/>
-          <a:p>
-            <a:pPr indent="0" marL="0">
-              <a:buNone/>
-            </a:pPr>
-            <a:r>
-              <a:rPr lang="en-US" sz="1100" b="1" dirty="0">
-                <a:solidFill>
-                  <a:srgbClr val="6B7280"/>
-                </a:solidFill>
-                <a:latin typeface="Calibri" pitchFamily="34" charset="0"/>
-                <a:ea typeface="Calibri" pitchFamily="34" charset="-122"/>
-                <a:cs typeface="Calibri" pitchFamily="34" charset="-120"/>
-              </a:rPr>
-              <a:t>Cargo claims · T-0502</a:t>
-            </a:r>
-            <a:endParaRPr lang="en-US" sz="1100" dirty="0"/>
-          </a:p>
-        </p:txBody>
-      </p:sp>
-      <p:sp>
-        <p:nvSpPr>
-          <p:cNvPr id="26" name="Text 22"/>
-          <p:cNvSpPr txBox="1"/>
-          <p:nvPr/>
-        </p:nvSpPr>
-        <p:spPr>
-          <a:xfrm>
-            <a:off x="9217152" y="5047488"/>
-            <a:ext cx="2286000" cy="384048"/>
-          </a:xfrm>
-          <a:prstGeom prst="rect">
-            <a:avLst/>
-          </a:prstGeom>
-          <a:noFill/>
-          <a:ln/>
-        </p:spPr>
-        <p:txBody>
-          <a:bodyPr wrap="square" lIns="0" tIns="0" rIns="0" bIns="0" rtlCol="0" anchor="ctr"/>
-          <a:lstStyle/>
-          <a:p>
-            <a:pPr indent="0" marL="0">
-              <a:buNone/>
-            </a:pPr>
-            <a:r>
-              <a:rPr lang="en-US" sz="2000" b="1" dirty="0">
-                <a:solidFill>
-                  <a:srgbClr val="111827"/>
-                </a:solidFill>
-                <a:latin typeface="Calibri" pitchFamily="34" charset="0"/>
-                <a:ea typeface="Calibri" pitchFamily="34" charset="-122"/>
-                <a:cs typeface="Calibri" pitchFamily="34" charset="-120"/>
-              </a:rPr>
-              <a:t>$13,432.53</a:t>
-            </a:r>
-            <a:endParaRPr lang="en-US" sz="2000" dirty="0"/>
-          </a:p>
-        </p:txBody>
-      </p:sp>
-      <p:sp>
-        <p:nvSpPr>
-          <p:cNvPr id="27" name="Text 23"/>
-          <p:cNvSpPr txBox="1"/>
-          <p:nvPr/>
-        </p:nvSpPr>
-        <p:spPr>
-          <a:xfrm>
-            <a:off x="9217152" y="5449824"/>
-            <a:ext cx="2286000" cy="219456"/>
-          </a:xfrm>
-          <a:prstGeom prst="rect">
-            <a:avLst/>
-          </a:prstGeom>
-          <a:noFill/>
-          <a:ln/>
-        </p:spPr>
-        <p:txBody>
-          <a:bodyPr wrap="square" lIns="0" tIns="0" rIns="0" bIns="0" rtlCol="0" anchor="ctr"/>
-          <a:lstStyle/>
-          <a:p>
-            <a:pPr indent="0" marL="0">
-              <a:buNone/>
-            </a:pPr>
-            <a:r>
-              <a:rPr lang="en-US" sz="1000" dirty="0">
-                <a:solidFill>
-                  <a:srgbClr val="6B7280"/>
-                </a:solidFill>
-                <a:latin typeface="Calibri" pitchFamily="34" charset="0"/>
-                <a:ea typeface="Calibri" pitchFamily="34" charset="-122"/>
-                <a:cs typeface="Calibri" pitchFamily="34" charset="-120"/>
-              </a:rPr>
-              <a:t>August 2026 (Sept not closed)</a:t>
-            </a:r>
-            <a:endParaRPr lang="en-US" sz="1000" dirty="0"/>
-          </a:p>
-        </p:txBody>
-      </p:sp>
-      <p:sp>
-        <p:nvSpPr>
-          <p:cNvPr id="28" name="Text 24"/>
+              <a:t>$/yr = full-year F27 run-rate. Cargo claims (Claims report, T-0502): $13,432.53 for August 2026 — see also damaged FB on slide 6.</a:t>
+            </a:r>
+            <a:endParaRPr lang="en-US" sz="950" dirty="0"/>
+          </a:p>
+        </p:txBody>
+      </p:sp>
+      <p:sp>
+        <p:nvSpPr>
+          <p:cNvPr id="22" name="Text 19"/>
           <p:cNvSpPr txBox="1"/>
           <p:nvPr/>
         </p:nvSpPr>
@@ -20102,7 +21534,7 @@
       </p:sp>
       <p:sp>
         <p:nvSpPr>
-          <p:cNvPr id="29" name="Text 25"/>
+          <p:cNvPr id="23" name="Text 20"/>
           <p:cNvSpPr txBox="1"/>
           <p:nvPr/>
         </p:nvSpPr>
@@ -28721,7 +30153,7 @@
                 <a:ea typeface="Calibri" pitchFamily="34" charset="-122"/>
                 <a:cs typeface="Calibri" pitchFamily="34" charset="-120"/>
               </a:rPr>
-              <a:t>Cost per PRO, hours, labour, accessorials, savings plan</a:t>
+              <a:t>Cost per PRO, hours, labour, accessorials, savings tracker</a:t>
             </a:r>
             <a:endParaRPr lang="en-US" sz="1300" dirty="0"/>
           </a:p>
@@ -34874,7 +36306,7 @@
                 <a:ea typeface="Calibri" pitchFamily="34" charset="-122"/>
                 <a:cs typeface="Calibri" pitchFamily="34" charset="-120"/>
               </a:rPr>
-              <a:t>Savings: $61,000/yr confirmed (dispatcher role eliminated — dispatch centralized); more in development.</a:t>
+              <a:t>Savings: 7 initiatives tracked; $61K/yr confirmed (dispatcher role eliminated — dispatch centralized).</a:t>
             </a:r>
             <a:endParaRPr lang="en-US" sz="1200" dirty="0"/>
           </a:p>

</xml_diff>

<commit_message>
Deck QA corrections (labels, wording, P&D tiles) and pace reduction shown as 1,637 on site and deck
Co-Authored-By: Claude Opus 5.5 <noreply@anthropic.com>
Claude-Session: https://claude.ai/code/session_01BwRjju3y2wk3wSHFrM9KLe
</commit_message>
<xml_diff>
--- a/presentation/Mississauga_F27_Leadership_Review_Sep29.pptx
+++ b/presentation/Mississauga_F27_Leadership_Review_Sep29.pptx
@@ -4714,7 +4714,7 @@
           <a:p>
             <a:r>
               <a:rPr lang="en-US" dirty="0"/>
-              <a:t>Good morning. This is the Mississauga Terminal F27 review, following the same structure Brampton used yesterday: safety, service, SCA, productivity, and the status of the building. Our September month-to-date headlines: adjusted on-time service is 93.7 percent, we are at 91.1 percent of our SCA hour allowance, cost per unit is down 16.7 percent and units per hour up 26.7 percent on last year, with only 9 overtime hours. Our focus is the gap to the PPH goal.</a:t>
+              <a:t>Good morning. This is the Mississauga Terminal F27 review: safety, service, SCA, productivity, and the status of the building. Our September month-to-date headlines: adjusted on-time service is 93.7 percent, we are at 91.1 percent of our SCA hour allowance, cost per unit is down 16.7 percent and units per hour up 26.7 percent on last year, with only 9 overtime hours. Our focus is the gap to the PPH goal.</a:t>
             </a:r>
             <a:endParaRPr lang="en-US" dirty="0"/>
           </a:p>
@@ -5330,7 +5330,7 @@
           <a:p>
             <a:r>
               <a:rPr lang="en-US" dirty="0"/>
-              <a:t>PPH is 3,327 for September month to date, essentially flat against F26, but 21.9 percent below the F27 goal of 4,258. The freight is lighter per unit, so the better signal is units per hour, which is up 26.7 percent on last year. Closing the PPH gap is tied to the 1,181-hour reduction target for the month.</a:t>
+              <a:t>PPH is 3,327 for September month to date, essentially flat against F26, but 21.9 percent below the F27 goal of 4,258. The freight is lighter per unit, so the better signal is units per hour, which is up 26.7 percent on last year. PPH goal is weight-based; freight got lighter, 218 versus about 275 pounds per unit, while units per hour rose.</a:t>
             </a:r>
             <a:endParaRPr lang="en-US" dirty="0"/>
           </a:p>
@@ -5946,7 +5946,7 @@
           <a:p>
             <a:r>
               <a:rPr lang="en-US" dirty="0"/>
-              <a:t>Mississauga is relocating to a new building by year end, most likely before 2027. Because of that, we are not planning any major repair spend at the current site; our focus is a clean transition for the team and our customers.</a:t>
+              <a:t>Mississauga is moving to a new building, expected before the end of calendar 2026. Because of that, we are not planning any major repair spend at the current site; our focus is a clean transition for the team and our customers.</a:t>
             </a:r>
             <a:endParaRPr lang="en-US" dirty="0"/>
           </a:p>
@@ -6210,7 +6210,7 @@
           <a:p>
             <a:r>
               <a:rPr lang="en-US" dirty="0"/>
-              <a:t>We have had zero recordable incidents in F27 to date, July and August, so our F27 TRIR is 0.00 against 1.21 for F26 and a 12-month average of 1.21, a 100 percent improvement, and it has been 384 days since our last recordable on September 10, 2025. Every shift starts with a tailgate and forklift inspections, and after any incident we run a specific safety moment. Supervisors and managers correct non-compliance on the spot and record it in their STEP observations, and dock conditions are documented and reviewed at JHSC.</a:t>
+              <a:t>We have had zero recordable incidents in F27 to date, July and August, so our F27 TRIR is 0.00 against 1.21 for F26 and a 12-month average of 1.21, and it has been 384 days since our last recordable on September 10, 2025. Every shift starts with a tailgate and forklift inspections, and after any incident we run a specific safety moment. Supervisors and managers correct non-compliance on the spot and record it in their STEP observations, and dock conditions are documented and reviewed at JHSC.</a:t>
             </a:r>
             <a:endParaRPr lang="en-US" dirty="0"/>
           </a:p>
@@ -6474,7 +6474,7 @@
           <a:p>
             <a:r>
               <a:rPr lang="en-US" dirty="0"/>
-              <a:t>Missed pickups are at 4.70 percent across the report period through September 26. Only about 15 percent are true operations issues; about 45 percent are false positives, most coded already serviced, which is a close-out and scanning discipline fix. Excluding those, the rate would be roughly 2.6 percent; the September 7 spike was Labour Day on low volume. Damaged freight bills averaged 1.61 percent over the last seven days, trending down from 3.34 percent on September 22 to 0.31 percent on September 28.</a:t>
+              <a:t>Missed pickups are at 4.70 percent across the report period through September 26. Only about 15 percent are true operations issues; about 45 percent are false positives, most coded already serviced, which is a close-out and scanning discipline fix. Excluding those, the rate would be roughly 2.6 percent; the September 7 spike was Labour Day on low volume. Damaged freight bills averaged 1.61 percent over the last seven days; the latest day was 0.31 percent on September 28.</a:t>
             </a:r>
             <a:endParaRPr lang="en-US" dirty="0"/>
           </a:p>
@@ -6562,7 +6562,7 @@
           <a:p>
             <a:r>
               <a:rPr lang="en-US" dirty="0"/>
-              <a:t>For September 1 to 28, 91.37 percent of freight bills were scanned in and out of the terminal, 90.50 percent were completely scanned, and 90.66 percent of items were scanned. September is in line with fiscal year to date, at 91.4 against 91.6 percent of freight bills scanned, and slightly down on the last period. That still leaves about 4,550 freight bills not scanned this month, and closing that gap also reduces the already-serviced false positives we saw in missed pickups.</a:t>
+              <a:t>For September 1 to 28, 91.37 percent of freight bills were scanned in and out of the terminal, 90.50 percent were completely scanned, and 90.66 percent of items were scanned. September is in line with fiscal year to date: 91.37 percent of freight bills scanned against 91.55 percent fiscal year to date, and slightly down on the last period. That still leaves about 4,550 freight bills not scanned this month, and closing that gap also reduces the already-serviced false positives we saw in missed pickups.</a:t>
             </a:r>
             <a:endParaRPr lang="en-US" dirty="0"/>
           </a:p>
@@ -6650,7 +6650,7 @@
           <a:p>
             <a:r>
               <a:rPr lang="en-US" dirty="0"/>
-              <a:t>On the national SCA report updated September 26, Mississauga is at 6.60 cost per PRO against a 6.85 target: 96.3 percent of target, 25 cents under per PRO. That puts us in the amber watch band, which starts above 95 percent. Across 26,053 freight bills month to date, that is roughly 6.5 thousand dollars below target.</a:t>
+              <a:t>On the national SCA report updated September 26, Mississauga is at 6.60 SCA dock cost per PRO against a 6.85 target: 96.3 percent of target, 25 cents under per PRO. That puts us in the amber watch band, which starts above 95 percent. Across 26,053 freight bills month to date, that is roughly 6.5 thousand dollars below target.</a:t>
             </a:r>
             <a:endParaRPr lang="en-US" dirty="0"/>
           </a:p>
@@ -8290,7 +8290,7 @@
                 <a:ea typeface="Calibri" pitchFamily="34" charset="-122"/>
                 <a:cs typeface="Calibri" pitchFamily="34" charset="-120"/>
               </a:rPr>
-              <a:t>   −$0.44 (−16.7%)</a:t>
+              <a:t>   −16.7%</a:t>
             </a:r>
             <a:endParaRPr lang="en-US" sz="2200" dirty="0"/>
           </a:p>
@@ -8530,6 +8530,23 @@
                 <a:cs typeface="Calibri" pitchFamily="34" charset="-120"/>
               </a:rPr>
               <a:t>−33.1%</a:t>
+            </a:r>
+            <a:endParaRPr lang="en-US" sz="2400" dirty="0"/>
+          </a:p>
+          <a:p>
+            <a:pPr algn="r" indent="0" marL="0">
+              <a:buNone/>
+            </a:pPr>
+            <a:r>
+              <a:rPr lang="en-US" sz="950" b="1" dirty="0">
+                <a:solidFill>
+                  <a:srgbClr val="059669"/>
+                </a:solidFill>
+                <a:latin typeface="Calibri" pitchFamily="34" charset="0"/>
+                <a:ea typeface="Calibri" pitchFamily="34" charset="-122"/>
+                <a:cs typeface="Calibri" pitchFamily="34" charset="-120"/>
+              </a:rPr>
+              <a:t>(MTD vs full month)</a:t>
             </a:r>
             <a:endParaRPr lang="en-US" sz="2400" dirty="0"/>
           </a:p>
@@ -17661,7 +17678,7 @@
                 <a:ea typeface="Calibri" pitchFamily="34" charset="-122"/>
                 <a:cs typeface="Calibri" pitchFamily="34" charset="-120"/>
               </a:rPr>
-              <a:t>Every month since April is above the reweigh target — F27 running 126–144%. Reweighs correct under-declared weights, protecting revenue on every bill.</a:t>
+              <a:t>Every month since April is above the reweigh target — F27 running 126–144%. Reweighs correct under-declared weights, protecting revenue on every reweighed bill.</a:t>
             </a:r>
             <a:endParaRPr lang="en-US" sz="1200" dirty="0"/>
           </a:p>
@@ -22536,7 +22553,7 @@
                 <a:ea typeface="Calibri" pitchFamily="34" charset="-122"/>
                 <a:cs typeface="Calibri" pitchFamily="34" charset="-120"/>
               </a:rPr>
-              <a:t>Gap to PPH goal: −21.9%; hour-reduction target for the month is 1,181 hours.</a:t>
+              <a:t>Gap to PPH goal: −21.9%. PPH goal is weight-based; freight got lighter (218 vs ≈275 lbs/unit) while units per hour rose.</a:t>
             </a:r>
             <a:endParaRPr lang="en-US" sz="1400" dirty="0"/>
           </a:p>
@@ -26760,112 +26777,46 @@
       </p:sp>
       <p:sp>
         <p:nvSpPr>
-          <p:cNvPr id="35" name="Shape 33"/>
-          <p:cNvSpPr/>
+          <p:cNvPr id="35" name="Text 33"/>
+          <p:cNvSpPr txBox="1"/>
           <p:nvPr/>
         </p:nvSpPr>
         <p:spPr>
           <a:xfrm>
             <a:off x="8034528" y="2560320"/>
-            <a:ext cx="1734312" cy="804672"/>
-          </a:xfrm>
-          <a:prstGeom prst="roundRect">
-            <a:avLst>
-              <a:gd name="adj" fmla="val 9091"/>
-            </a:avLst>
-          </a:prstGeom>
-          <a:solidFill>
-            <a:srgbClr val="F3F4F6"/>
-          </a:solidFill>
-          <a:ln w="12700">
-            <a:solidFill>
-              <a:srgbClr val="F3F4F6"/>
-            </a:solidFill>
-            <a:prstDash val="solid"/>
-          </a:ln>
-        </p:spPr>
+            <a:ext cx="3605784" cy="804672"/>
+          </a:xfrm>
+          <a:prstGeom prst="rect">
+            <a:avLst/>
+          </a:prstGeom>
+          <a:noFill/>
+          <a:ln/>
+        </p:spPr>
+        <p:txBody>
+          <a:bodyPr wrap="square" lIns="0" tIns="0" rIns="0" bIns="0" rtlCol="0" anchor="ctr"/>
+          <a:lstStyle/>
+          <a:p>
+            <a:pPr indent="0" marL="0">
+              <a:buNone/>
+            </a:pPr>
+            <a:r>
+              <a:rPr lang="en-US" sz="1050" i="1" dirty="0">
+                <a:solidFill>
+                  <a:srgbClr val="6B7280"/>
+                </a:solidFill>
+                <a:latin typeface="Calibri" pitchFamily="34" charset="0"/>
+                <a:ea typeface="Calibri" pitchFamily="34" charset="-122"/>
+                <a:cs typeface="Calibri" pitchFamily="34" charset="-120"/>
+              </a:rPr>
+              <a:t>Bills 63,738 · Delivery bills 41,725 · Pickup bills 24,401 (counted separately — delivery and pickup bills do not sum to total bills).</a:t>
+            </a:r>
+            <a:endParaRPr lang="en-US" sz="1050" dirty="0"/>
+          </a:p>
+        </p:txBody>
       </p:sp>
       <p:sp>
         <p:nvSpPr>
           <p:cNvPr id="36" name="Text 34"/>
-          <p:cNvSpPr txBox="1"/>
-          <p:nvPr/>
-        </p:nvSpPr>
-        <p:spPr>
-          <a:xfrm>
-            <a:off x="8171688" y="2651760"/>
-            <a:ext cx="1459992" cy="237744"/>
-          </a:xfrm>
-          <a:prstGeom prst="rect">
-            <a:avLst/>
-          </a:prstGeom>
-          <a:noFill/>
-          <a:ln/>
-        </p:spPr>
-        <p:txBody>
-          <a:bodyPr wrap="square" lIns="0" tIns="0" rIns="0" bIns="0" rtlCol="0" anchor="ctr"/>
-          <a:lstStyle/>
-          <a:p>
-            <a:pPr indent="0" marL="0">
-              <a:buNone/>
-            </a:pPr>
-            <a:r>
-              <a:rPr lang="en-US" sz="1050" b="1" dirty="0">
-                <a:solidFill>
-                  <a:srgbClr val="6B7280"/>
-                </a:solidFill>
-                <a:latin typeface="Calibri" pitchFamily="34" charset="0"/>
-                <a:ea typeface="Calibri" pitchFamily="34" charset="-122"/>
-                <a:cs typeface="Calibri" pitchFamily="34" charset="-120"/>
-              </a:rPr>
-              <a:t>Units</a:t>
-            </a:r>
-            <a:endParaRPr lang="en-US" sz="1050" dirty="0"/>
-          </a:p>
-        </p:txBody>
-      </p:sp>
-      <p:sp>
-        <p:nvSpPr>
-          <p:cNvPr id="37" name="Text 35"/>
-          <p:cNvSpPr txBox="1"/>
-          <p:nvPr/>
-        </p:nvSpPr>
-        <p:spPr>
-          <a:xfrm>
-            <a:off x="8171688" y="2907792"/>
-            <a:ext cx="1459992" cy="384048"/>
-          </a:xfrm>
-          <a:prstGeom prst="rect">
-            <a:avLst/>
-          </a:prstGeom>
-          <a:noFill/>
-          <a:ln/>
-        </p:spPr>
-        <p:txBody>
-          <a:bodyPr wrap="square" lIns="0" tIns="0" rIns="0" bIns="0" rtlCol="0" anchor="ctr"/>
-          <a:lstStyle/>
-          <a:p>
-            <a:pPr indent="0" marL="0">
-              <a:buNone/>
-            </a:pPr>
-            <a:r>
-              <a:rPr lang="en-US" sz="1800" b="1" dirty="0">
-                <a:solidFill>
-                  <a:srgbClr val="111827"/>
-                </a:solidFill>
-                <a:latin typeface="Calibri" pitchFamily="34" charset="0"/>
-                <a:ea typeface="Calibri" pitchFamily="34" charset="-122"/>
-                <a:cs typeface="Calibri" pitchFamily="34" charset="-120"/>
-              </a:rPr>
-              <a:t>53</a:t>
-            </a:r>
-            <a:endParaRPr lang="en-US" sz="1800" dirty="0"/>
-          </a:p>
-        </p:txBody>
-      </p:sp>
-      <p:sp>
-        <p:nvSpPr>
-          <p:cNvPr id="38" name="Text 36"/>
           <p:cNvSpPr txBox="1"/>
           <p:nvPr/>
         </p:nvSpPr>
@@ -26904,7 +26855,7 @@
       </p:sp>
       <p:sp>
         <p:nvSpPr>
-          <p:cNvPr id="39" name="Shape 37"/>
+          <p:cNvPr id="37" name="Shape 35"/>
           <p:cNvSpPr/>
           <p:nvPr/>
         </p:nvSpPr>
@@ -26931,7 +26882,7 @@
       </p:sp>
       <p:sp>
         <p:nvSpPr>
-          <p:cNvPr id="40" name="Text 38"/>
+          <p:cNvPr id="38" name="Text 36"/>
           <p:cNvSpPr txBox="1"/>
           <p:nvPr/>
         </p:nvSpPr>
@@ -26970,7 +26921,7 @@
       </p:sp>
       <p:sp>
         <p:nvSpPr>
-          <p:cNvPr id="41" name="Text 39"/>
+          <p:cNvPr id="39" name="Text 37"/>
           <p:cNvSpPr txBox="1"/>
           <p:nvPr/>
         </p:nvSpPr>
@@ -27009,7 +26960,7 @@
       </p:sp>
       <p:sp>
         <p:nvSpPr>
-          <p:cNvPr id="42" name="Shape 40"/>
+          <p:cNvPr id="40" name="Shape 38"/>
           <p:cNvSpPr/>
           <p:nvPr/>
         </p:nvSpPr>
@@ -27036,7 +26987,7 @@
       </p:sp>
       <p:sp>
         <p:nvSpPr>
-          <p:cNvPr id="43" name="Text 41"/>
+          <p:cNvPr id="41" name="Text 39"/>
           <p:cNvSpPr txBox="1"/>
           <p:nvPr/>
         </p:nvSpPr>
@@ -27075,7 +27026,7 @@
       </p:sp>
       <p:sp>
         <p:nvSpPr>
-          <p:cNvPr id="44" name="Text 42"/>
+          <p:cNvPr id="42" name="Text 40"/>
           <p:cNvSpPr txBox="1"/>
           <p:nvPr/>
         </p:nvSpPr>
@@ -27114,7 +27065,7 @@
       </p:sp>
       <p:sp>
         <p:nvSpPr>
-          <p:cNvPr id="45" name="Shape 43"/>
+          <p:cNvPr id="43" name="Shape 41"/>
           <p:cNvSpPr/>
           <p:nvPr/>
         </p:nvSpPr>
@@ -27141,7 +27092,7 @@
       </p:sp>
       <p:sp>
         <p:nvSpPr>
-          <p:cNvPr id="46" name="Text 44"/>
+          <p:cNvPr id="44" name="Text 42"/>
           <p:cNvSpPr txBox="1"/>
           <p:nvPr/>
         </p:nvSpPr>
@@ -27172,7 +27123,7 @@
                 <a:ea typeface="Calibri" pitchFamily="34" charset="-122"/>
                 <a:cs typeface="Calibri" pitchFamily="34" charset="-120"/>
               </a:rPr>
-              <a:t>Miles / trip</a:t>
+              <a:t>Bills / trip</a:t>
             </a:r>
             <a:endParaRPr lang="en-US" sz="1050" dirty="0"/>
           </a:p>
@@ -27180,7 +27131,7 @@
       </p:sp>
       <p:sp>
         <p:nvSpPr>
-          <p:cNvPr id="47" name="Text 45"/>
+          <p:cNvPr id="45" name="Text 43"/>
           <p:cNvSpPr txBox="1"/>
           <p:nvPr/>
         </p:nvSpPr>
@@ -27211,7 +27162,7 @@
                 <a:ea typeface="Calibri" pitchFamily="34" charset="-122"/>
                 <a:cs typeface="Calibri" pitchFamily="34" charset="-120"/>
               </a:rPr>
-              <a:t>109.1</a:t>
+              <a:t>13.83</a:t>
             </a:r>
             <a:endParaRPr lang="en-US" sz="1800" dirty="0"/>
           </a:p>
@@ -27219,7 +27170,7 @@
       </p:sp>
       <p:sp>
         <p:nvSpPr>
-          <p:cNvPr id="48" name="Shape 46"/>
+          <p:cNvPr id="46" name="Shape 44"/>
           <p:cNvSpPr/>
           <p:nvPr/>
         </p:nvSpPr>
@@ -27246,7 +27197,7 @@
       </p:sp>
       <p:sp>
         <p:nvSpPr>
-          <p:cNvPr id="49" name="Text 47"/>
+          <p:cNvPr id="47" name="Text 45"/>
           <p:cNvSpPr txBox="1"/>
           <p:nvPr/>
         </p:nvSpPr>
@@ -27277,7 +27228,7 @@
                 <a:ea typeface="Calibri" pitchFamily="34" charset="-122"/>
                 <a:cs typeface="Calibri" pitchFamily="34" charset="-120"/>
               </a:rPr>
-              <a:t>Bills / trip</a:t>
+              <a:t>Miles / stop</a:t>
             </a:r>
             <a:endParaRPr lang="en-US" sz="1050" dirty="0"/>
           </a:p>
@@ -27285,7 +27236,7 @@
       </p:sp>
       <p:sp>
         <p:nvSpPr>
-          <p:cNvPr id="50" name="Text 48"/>
+          <p:cNvPr id="48" name="Text 46"/>
           <p:cNvSpPr txBox="1"/>
           <p:nvPr/>
         </p:nvSpPr>
@@ -27316,7 +27267,7 @@
                 <a:ea typeface="Calibri" pitchFamily="34" charset="-122"/>
                 <a:cs typeface="Calibri" pitchFamily="34" charset="-120"/>
               </a:rPr>
-              <a:t>13.83</a:t>
+              <a:t>16.82</a:t>
             </a:r>
             <a:endParaRPr lang="en-US" sz="1800" dirty="0"/>
           </a:p>
@@ -27324,7 +27275,7 @@
       </p:sp>
       <p:sp>
         <p:nvSpPr>
-          <p:cNvPr id="51" name="Shape 49"/>
+          <p:cNvPr id="49" name="Shape 47"/>
           <p:cNvSpPr/>
           <p:nvPr/>
         </p:nvSpPr>
@@ -27351,7 +27302,7 @@
       </p:sp>
       <p:sp>
         <p:nvSpPr>
-          <p:cNvPr id="52" name="Text 50"/>
+          <p:cNvPr id="50" name="Text 48"/>
           <p:cNvSpPr txBox="1"/>
           <p:nvPr/>
         </p:nvSpPr>
@@ -27382,7 +27333,7 @@
                 <a:ea typeface="Calibri" pitchFamily="34" charset="-122"/>
                 <a:cs typeface="Calibri" pitchFamily="34" charset="-120"/>
               </a:rPr>
-              <a:t>Delivery bills / trip</a:t>
+              <a:t>Weight / stop</a:t>
             </a:r>
             <a:endParaRPr lang="en-US" sz="1050" dirty="0"/>
           </a:p>
@@ -27390,7 +27341,7 @@
       </p:sp>
       <p:sp>
         <p:nvSpPr>
-          <p:cNvPr id="53" name="Text 51"/>
+          <p:cNvPr id="51" name="Text 49"/>
           <p:cNvSpPr txBox="1"/>
           <p:nvPr/>
         </p:nvSpPr>
@@ -27421,7 +27372,7 @@
                 <a:ea typeface="Calibri" pitchFamily="34" charset="-122"/>
                 <a:cs typeface="Calibri" pitchFamily="34" charset="-120"/>
               </a:rPr>
-              <a:t>9.19</a:t>
+              <a:t>707 lbs</a:t>
             </a:r>
             <a:endParaRPr lang="en-US" sz="1800" dirty="0"/>
           </a:p>
@@ -27429,7 +27380,7 @@
       </p:sp>
       <p:sp>
         <p:nvSpPr>
-          <p:cNvPr id="54" name="Shape 52"/>
+          <p:cNvPr id="52" name="Shape 50"/>
           <p:cNvSpPr/>
           <p:nvPr/>
         </p:nvSpPr>
@@ -27456,7 +27407,7 @@
       </p:sp>
       <p:sp>
         <p:nvSpPr>
-          <p:cNvPr id="55" name="Text 53"/>
+          <p:cNvPr id="53" name="Text 51"/>
           <p:cNvSpPr txBox="1"/>
           <p:nvPr/>
         </p:nvSpPr>
@@ -27487,7 +27438,7 @@
                 <a:ea typeface="Calibri" pitchFamily="34" charset="-122"/>
                 <a:cs typeface="Calibri" pitchFamily="34" charset="-120"/>
               </a:rPr>
-              <a:t>Pickup bills / trip</a:t>
+              <a:t>Weight / bill</a:t>
             </a:r>
             <a:endParaRPr lang="en-US" sz="1050" dirty="0"/>
           </a:p>
@@ -27495,7 +27446,7 @@
       </p:sp>
       <p:sp>
         <p:nvSpPr>
-          <p:cNvPr id="56" name="Text 54"/>
+          <p:cNvPr id="54" name="Text 52"/>
           <p:cNvSpPr txBox="1"/>
           <p:nvPr/>
         </p:nvSpPr>
@@ -27526,7 +27477,7 @@
                 <a:ea typeface="Calibri" pitchFamily="34" charset="-122"/>
                 <a:cs typeface="Calibri" pitchFamily="34" charset="-120"/>
               </a:rPr>
-              <a:t>5.70</a:t>
+              <a:t>507 lbs</a:t>
             </a:r>
             <a:endParaRPr lang="en-US" sz="1800" dirty="0"/>
           </a:p>
@@ -27534,7 +27485,7 @@
       </p:sp>
       <p:sp>
         <p:nvSpPr>
-          <p:cNvPr id="57" name="Shape 55"/>
+          <p:cNvPr id="55" name="Shape 53"/>
           <p:cNvSpPr/>
           <p:nvPr/>
         </p:nvSpPr>
@@ -27561,7 +27512,7 @@
       </p:sp>
       <p:sp>
         <p:nvSpPr>
-          <p:cNvPr id="58" name="Text 56"/>
+          <p:cNvPr id="56" name="Text 54"/>
           <p:cNvSpPr txBox="1"/>
           <p:nvPr/>
         </p:nvSpPr>
@@ -27592,7 +27543,7 @@
                 <a:ea typeface="Calibri" pitchFamily="34" charset="-122"/>
                 <a:cs typeface="Calibri" pitchFamily="34" charset="-120"/>
               </a:rPr>
-              <a:t>Miles / stop</a:t>
+              <a:t>Miles / hour</a:t>
             </a:r>
             <a:endParaRPr lang="en-US" sz="1050" dirty="0"/>
           </a:p>
@@ -27600,7 +27551,7 @@
       </p:sp>
       <p:sp>
         <p:nvSpPr>
-          <p:cNvPr id="59" name="Text 57"/>
+          <p:cNvPr id="57" name="Text 55"/>
           <p:cNvSpPr txBox="1"/>
           <p:nvPr/>
         </p:nvSpPr>
@@ -27631,7 +27582,7 @@
                 <a:ea typeface="Calibri" pitchFamily="34" charset="-122"/>
                 <a:cs typeface="Calibri" pitchFamily="34" charset="-120"/>
               </a:rPr>
-              <a:t>16.82</a:t>
+              <a:t>35.13</a:t>
             </a:r>
             <a:endParaRPr lang="en-US" sz="1800" dirty="0"/>
           </a:p>
@@ -27639,7 +27590,7 @@
       </p:sp>
       <p:sp>
         <p:nvSpPr>
-          <p:cNvPr id="60" name="Shape 58"/>
+          <p:cNvPr id="58" name="Shape 56"/>
           <p:cNvSpPr/>
           <p:nvPr/>
         </p:nvSpPr>
@@ -27666,7 +27617,7 @@
       </p:sp>
       <p:sp>
         <p:nvSpPr>
-          <p:cNvPr id="61" name="Text 59"/>
+          <p:cNvPr id="59" name="Text 57"/>
           <p:cNvSpPr txBox="1"/>
           <p:nvPr/>
         </p:nvSpPr>
@@ -27697,7 +27648,7 @@
                 <a:ea typeface="Calibri" pitchFamily="34" charset="-122"/>
                 <a:cs typeface="Calibri" pitchFamily="34" charset="-120"/>
               </a:rPr>
-              <a:t>Weight / stop</a:t>
+              <a:t>Stops / hour</a:t>
             </a:r>
             <a:endParaRPr lang="en-US" sz="1050" dirty="0"/>
           </a:p>
@@ -27705,7 +27656,7 @@
       </p:sp>
       <p:sp>
         <p:nvSpPr>
-          <p:cNvPr id="62" name="Text 60"/>
+          <p:cNvPr id="60" name="Text 58"/>
           <p:cNvSpPr txBox="1"/>
           <p:nvPr/>
         </p:nvSpPr>
@@ -27736,7 +27687,7 @@
                 <a:ea typeface="Calibri" pitchFamily="34" charset="-122"/>
                 <a:cs typeface="Calibri" pitchFamily="34" charset="-120"/>
               </a:rPr>
-              <a:t>707 lbs</a:t>
+              <a:t>2.09</a:t>
             </a:r>
             <a:endParaRPr lang="en-US" sz="1800" dirty="0"/>
           </a:p>
@@ -27744,7 +27695,7 @@
       </p:sp>
       <p:sp>
         <p:nvSpPr>
-          <p:cNvPr id="63" name="Shape 61"/>
+          <p:cNvPr id="61" name="Shape 59"/>
           <p:cNvSpPr/>
           <p:nvPr/>
         </p:nvSpPr>
@@ -27771,7 +27722,7 @@
       </p:sp>
       <p:sp>
         <p:nvSpPr>
-          <p:cNvPr id="64" name="Text 62"/>
+          <p:cNvPr id="62" name="Text 60"/>
           <p:cNvSpPr txBox="1"/>
           <p:nvPr/>
         </p:nvSpPr>
@@ -27802,7 +27753,7 @@
                 <a:ea typeface="Calibri" pitchFamily="34" charset="-122"/>
                 <a:cs typeface="Calibri" pitchFamily="34" charset="-120"/>
               </a:rPr>
-              <a:t>Weight / bill</a:t>
+              <a:t>Hours / trip</a:t>
             </a:r>
             <a:endParaRPr lang="en-US" sz="1050" dirty="0"/>
           </a:p>
@@ -27810,7 +27761,7 @@
       </p:sp>
       <p:sp>
         <p:nvSpPr>
-          <p:cNvPr id="65" name="Text 63"/>
+          <p:cNvPr id="63" name="Text 61"/>
           <p:cNvSpPr txBox="1"/>
           <p:nvPr/>
         </p:nvSpPr>
@@ -27841,7 +27792,7 @@
                 <a:ea typeface="Calibri" pitchFamily="34" charset="-122"/>
                 <a:cs typeface="Calibri" pitchFamily="34" charset="-120"/>
               </a:rPr>
-              <a:t>507 lbs</a:t>
+              <a:t>4.75</a:t>
             </a:r>
             <a:endParaRPr lang="en-US" sz="1800" dirty="0"/>
           </a:p>
@@ -27849,322 +27800,7 @@
       </p:sp>
       <p:sp>
         <p:nvSpPr>
-          <p:cNvPr id="66" name="Shape 64"/>
-          <p:cNvSpPr/>
-          <p:nvPr/>
-        </p:nvSpPr>
-        <p:spPr>
-          <a:xfrm>
-            <a:off x="6163056" y="4782312"/>
-            <a:ext cx="1734312" cy="804672"/>
-          </a:xfrm>
-          <a:prstGeom prst="roundRect">
-            <a:avLst>
-              <a:gd name="adj" fmla="val 9091"/>
-            </a:avLst>
-          </a:prstGeom>
-          <a:solidFill>
-            <a:srgbClr val="F5F3FF"/>
-          </a:solidFill>
-          <a:ln w="12700">
-            <a:solidFill>
-              <a:srgbClr val="F5F3FF"/>
-            </a:solidFill>
-            <a:prstDash val="solid"/>
-          </a:ln>
-        </p:spPr>
-      </p:sp>
-      <p:sp>
-        <p:nvSpPr>
-          <p:cNvPr id="67" name="Text 65"/>
-          <p:cNvSpPr txBox="1"/>
-          <p:nvPr/>
-        </p:nvSpPr>
-        <p:spPr>
-          <a:xfrm>
-            <a:off x="6300216" y="4873752"/>
-            <a:ext cx="1459992" cy="237744"/>
-          </a:xfrm>
-          <a:prstGeom prst="rect">
-            <a:avLst/>
-          </a:prstGeom>
-          <a:noFill/>
-          <a:ln/>
-        </p:spPr>
-        <p:txBody>
-          <a:bodyPr wrap="square" lIns="0" tIns="0" rIns="0" bIns="0" rtlCol="0" anchor="ctr"/>
-          <a:lstStyle/>
-          <a:p>
-            <a:pPr indent="0" marL="0">
-              <a:buNone/>
-            </a:pPr>
-            <a:r>
-              <a:rPr lang="en-US" sz="1050" b="1" dirty="0">
-                <a:solidFill>
-                  <a:srgbClr val="6B7280"/>
-                </a:solidFill>
-                <a:latin typeface="Calibri" pitchFamily="34" charset="0"/>
-                <a:ea typeface="Calibri" pitchFamily="34" charset="-122"/>
-                <a:cs typeface="Calibri" pitchFamily="34" charset="-120"/>
-              </a:rPr>
-              <a:t>Miles / hour</a:t>
-            </a:r>
-            <a:endParaRPr lang="en-US" sz="1050" dirty="0"/>
-          </a:p>
-        </p:txBody>
-      </p:sp>
-      <p:sp>
-        <p:nvSpPr>
-          <p:cNvPr id="68" name="Text 66"/>
-          <p:cNvSpPr txBox="1"/>
-          <p:nvPr/>
-        </p:nvSpPr>
-        <p:spPr>
-          <a:xfrm>
-            <a:off x="6300216" y="5129784"/>
-            <a:ext cx="1459992" cy="384048"/>
-          </a:xfrm>
-          <a:prstGeom prst="rect">
-            <a:avLst/>
-          </a:prstGeom>
-          <a:noFill/>
-          <a:ln/>
-        </p:spPr>
-        <p:txBody>
-          <a:bodyPr wrap="square" lIns="0" tIns="0" rIns="0" bIns="0" rtlCol="0" anchor="ctr"/>
-          <a:lstStyle/>
-          <a:p>
-            <a:pPr indent="0" marL="0">
-              <a:buNone/>
-            </a:pPr>
-            <a:r>
-              <a:rPr lang="en-US" sz="1800" b="1" dirty="0">
-                <a:solidFill>
-                  <a:srgbClr val="111827"/>
-                </a:solidFill>
-                <a:latin typeface="Calibri" pitchFamily="34" charset="0"/>
-                <a:ea typeface="Calibri" pitchFamily="34" charset="-122"/>
-                <a:cs typeface="Calibri" pitchFamily="34" charset="-120"/>
-              </a:rPr>
-              <a:t>35.13</a:t>
-            </a:r>
-            <a:endParaRPr lang="en-US" sz="1800" dirty="0"/>
-          </a:p>
-        </p:txBody>
-      </p:sp>
-      <p:sp>
-        <p:nvSpPr>
-          <p:cNvPr id="69" name="Shape 67"/>
-          <p:cNvSpPr/>
-          <p:nvPr/>
-        </p:nvSpPr>
-        <p:spPr>
-          <a:xfrm>
-            <a:off x="8034528" y="4782312"/>
-            <a:ext cx="1734312" cy="804672"/>
-          </a:xfrm>
-          <a:prstGeom prst="roundRect">
-            <a:avLst>
-              <a:gd name="adj" fmla="val 9091"/>
-            </a:avLst>
-          </a:prstGeom>
-          <a:solidFill>
-            <a:srgbClr val="F5F3FF"/>
-          </a:solidFill>
-          <a:ln w="12700">
-            <a:solidFill>
-              <a:srgbClr val="F5F3FF"/>
-            </a:solidFill>
-            <a:prstDash val="solid"/>
-          </a:ln>
-        </p:spPr>
-      </p:sp>
-      <p:sp>
-        <p:nvSpPr>
-          <p:cNvPr id="70" name="Text 68"/>
-          <p:cNvSpPr txBox="1"/>
-          <p:nvPr/>
-        </p:nvSpPr>
-        <p:spPr>
-          <a:xfrm>
-            <a:off x="8171688" y="4873752"/>
-            <a:ext cx="1459992" cy="237744"/>
-          </a:xfrm>
-          <a:prstGeom prst="rect">
-            <a:avLst/>
-          </a:prstGeom>
-          <a:noFill/>
-          <a:ln/>
-        </p:spPr>
-        <p:txBody>
-          <a:bodyPr wrap="square" lIns="0" tIns="0" rIns="0" bIns="0" rtlCol="0" anchor="ctr"/>
-          <a:lstStyle/>
-          <a:p>
-            <a:pPr indent="0" marL="0">
-              <a:buNone/>
-            </a:pPr>
-            <a:r>
-              <a:rPr lang="en-US" sz="1050" b="1" dirty="0">
-                <a:solidFill>
-                  <a:srgbClr val="6B7280"/>
-                </a:solidFill>
-                <a:latin typeface="Calibri" pitchFamily="34" charset="0"/>
-                <a:ea typeface="Calibri" pitchFamily="34" charset="-122"/>
-                <a:cs typeface="Calibri" pitchFamily="34" charset="-120"/>
-              </a:rPr>
-              <a:t>Stops / hour</a:t>
-            </a:r>
-            <a:endParaRPr lang="en-US" sz="1050" dirty="0"/>
-          </a:p>
-        </p:txBody>
-      </p:sp>
-      <p:sp>
-        <p:nvSpPr>
-          <p:cNvPr id="71" name="Text 69"/>
-          <p:cNvSpPr txBox="1"/>
-          <p:nvPr/>
-        </p:nvSpPr>
-        <p:spPr>
-          <a:xfrm>
-            <a:off x="8171688" y="5129784"/>
-            <a:ext cx="1459992" cy="384048"/>
-          </a:xfrm>
-          <a:prstGeom prst="rect">
-            <a:avLst/>
-          </a:prstGeom>
-          <a:noFill/>
-          <a:ln/>
-        </p:spPr>
-        <p:txBody>
-          <a:bodyPr wrap="square" lIns="0" tIns="0" rIns="0" bIns="0" rtlCol="0" anchor="ctr"/>
-          <a:lstStyle/>
-          <a:p>
-            <a:pPr indent="0" marL="0">
-              <a:buNone/>
-            </a:pPr>
-            <a:r>
-              <a:rPr lang="en-US" sz="1800" b="1" dirty="0">
-                <a:solidFill>
-                  <a:srgbClr val="111827"/>
-                </a:solidFill>
-                <a:latin typeface="Calibri" pitchFamily="34" charset="0"/>
-                <a:ea typeface="Calibri" pitchFamily="34" charset="-122"/>
-                <a:cs typeface="Calibri" pitchFamily="34" charset="-120"/>
-              </a:rPr>
-              <a:t>2.09</a:t>
-            </a:r>
-            <a:endParaRPr lang="en-US" sz="1800" dirty="0"/>
-          </a:p>
-        </p:txBody>
-      </p:sp>
-      <p:sp>
-        <p:nvSpPr>
-          <p:cNvPr id="72" name="Shape 70"/>
-          <p:cNvSpPr/>
-          <p:nvPr/>
-        </p:nvSpPr>
-        <p:spPr>
-          <a:xfrm>
-            <a:off x="9906000" y="4782312"/>
-            <a:ext cx="1734312" cy="804672"/>
-          </a:xfrm>
-          <a:prstGeom prst="roundRect">
-            <a:avLst>
-              <a:gd name="adj" fmla="val 9091"/>
-            </a:avLst>
-          </a:prstGeom>
-          <a:solidFill>
-            <a:srgbClr val="F5F3FF"/>
-          </a:solidFill>
-          <a:ln w="12700">
-            <a:solidFill>
-              <a:srgbClr val="F5F3FF"/>
-            </a:solidFill>
-            <a:prstDash val="solid"/>
-          </a:ln>
-        </p:spPr>
-      </p:sp>
-      <p:sp>
-        <p:nvSpPr>
-          <p:cNvPr id="73" name="Text 71"/>
-          <p:cNvSpPr txBox="1"/>
-          <p:nvPr/>
-        </p:nvSpPr>
-        <p:spPr>
-          <a:xfrm>
-            <a:off x="10043160" y="4873752"/>
-            <a:ext cx="1459992" cy="237744"/>
-          </a:xfrm>
-          <a:prstGeom prst="rect">
-            <a:avLst/>
-          </a:prstGeom>
-          <a:noFill/>
-          <a:ln/>
-        </p:spPr>
-        <p:txBody>
-          <a:bodyPr wrap="square" lIns="0" tIns="0" rIns="0" bIns="0" rtlCol="0" anchor="ctr"/>
-          <a:lstStyle/>
-          <a:p>
-            <a:pPr indent="0" marL="0">
-              <a:buNone/>
-            </a:pPr>
-            <a:r>
-              <a:rPr lang="en-US" sz="1050" b="1" dirty="0">
-                <a:solidFill>
-                  <a:srgbClr val="6B7280"/>
-                </a:solidFill>
-                <a:latin typeface="Calibri" pitchFamily="34" charset="0"/>
-                <a:ea typeface="Calibri" pitchFamily="34" charset="-122"/>
-                <a:cs typeface="Calibri" pitchFamily="34" charset="-120"/>
-              </a:rPr>
-              <a:t>Hours / trip</a:t>
-            </a:r>
-            <a:endParaRPr lang="en-US" sz="1050" dirty="0"/>
-          </a:p>
-        </p:txBody>
-      </p:sp>
-      <p:sp>
-        <p:nvSpPr>
-          <p:cNvPr id="74" name="Text 72"/>
-          <p:cNvSpPr txBox="1"/>
-          <p:nvPr/>
-        </p:nvSpPr>
-        <p:spPr>
-          <a:xfrm>
-            <a:off x="10043160" y="5129784"/>
-            <a:ext cx="1459992" cy="384048"/>
-          </a:xfrm>
-          <a:prstGeom prst="rect">
-            <a:avLst/>
-          </a:prstGeom>
-          <a:noFill/>
-          <a:ln/>
-        </p:spPr>
-        <p:txBody>
-          <a:bodyPr wrap="square" lIns="0" tIns="0" rIns="0" bIns="0" rtlCol="0" anchor="ctr"/>
-          <a:lstStyle/>
-          <a:p>
-            <a:pPr indent="0" marL="0">
-              <a:buNone/>
-            </a:pPr>
-            <a:r>
-              <a:rPr lang="en-US" sz="1800" b="1" dirty="0">
-                <a:solidFill>
-                  <a:srgbClr val="111827"/>
-                </a:solidFill>
-                <a:latin typeface="Calibri" pitchFamily="34" charset="0"/>
-                <a:ea typeface="Calibri" pitchFamily="34" charset="-122"/>
-                <a:cs typeface="Calibri" pitchFamily="34" charset="-120"/>
-              </a:rPr>
-              <a:t>4.75</a:t>
-            </a:r>
-            <a:endParaRPr lang="en-US" sz="1800" dirty="0"/>
-          </a:p>
-        </p:txBody>
-      </p:sp>
-      <p:sp>
-        <p:nvSpPr>
-          <p:cNvPr id="75" name="Text 73"/>
+          <p:cNvPr id="64" name="Text 62"/>
           <p:cNvSpPr txBox="1"/>
           <p:nvPr/>
         </p:nvSpPr>
@@ -28203,7 +27839,7 @@
       </p:sp>
       <p:sp>
         <p:nvSpPr>
-          <p:cNvPr id="76" name="Text 74"/>
+          <p:cNvPr id="65" name="Text 63"/>
           <p:cNvSpPr txBox="1"/>
           <p:nvPr/>
         </p:nvSpPr>
@@ -28242,7 +27878,7 @@
       </p:sp>
       <p:sp>
         <p:nvSpPr>
-          <p:cNvPr id="77" name="Text 75"/>
+          <p:cNvPr id="66" name="Text 64"/>
           <p:cNvSpPr txBox="1"/>
           <p:nvPr/>
         </p:nvSpPr>
@@ -30535,7 +30171,7 @@
                 <a:ea typeface="Calibri" pitchFamily="34" charset="-122"/>
                 <a:cs typeface="Calibri" pitchFamily="34" charset="-120"/>
               </a:rPr>
-              <a:t>Relocation to a new building by year end</a:t>
+              <a:t>Moving to a new building — expected before end of calendar 2026.</a:t>
             </a:r>
             <a:endParaRPr lang="en-US" sz="1300" dirty="0"/>
           </a:p>
@@ -34626,7 +34262,7 @@
                 <a:ea typeface="Calibri" pitchFamily="34" charset="-122"/>
                 <a:cs typeface="Calibri" pitchFamily="34" charset="-120"/>
               </a:rPr>
-              <a:t>Moving to a new building by year end</a:t>
+              <a:t>Moving to a new building</a:t>
             </a:r>
             <a:endParaRPr lang="en-US" sz="3200" dirty="0"/>
           </a:p>
@@ -34665,7 +34301,7 @@
                 <a:ea typeface="Calibri" pitchFamily="34" charset="-122"/>
                 <a:cs typeface="Calibri" pitchFamily="34" charset="-120"/>
               </a:rPr>
-              <a:t>Most likely before 2027</a:t>
+              <a:t>Expected before end of calendar 2026.</a:t>
             </a:r>
             <a:endParaRPr lang="en-US" sz="1800" dirty="0"/>
           </a:p>
@@ -36243,7 +35879,7 @@
                 <a:ea typeface="Calibri" pitchFamily="34" charset="-122"/>
                 <a:cs typeface="Calibri" pitchFamily="34" charset="-120"/>
               </a:rPr>
-              <a:t>Cost per PRO $6.60 vs $6.85 target (96.3%, watch).</a:t>
+              <a:t>SCA dock cost per PRO $6.60 vs $6.85 target (96.3%, watch).</a:t>
             </a:r>
             <a:endParaRPr lang="en-US" sz="1200" dirty="0"/>
           </a:p>
@@ -36673,7 +36309,7 @@
                 <a:ea typeface="Calibri" pitchFamily="34" charset="-122"/>
                 <a:cs typeface="Calibri" pitchFamily="34" charset="-120"/>
               </a:rPr>
-              <a:t>Sept SCA target 5,122 dock hrs (F26 Sept 6,303 − 1,181-hr reduction target) · 244 hrs per working day · cost per PRO target $6.85.</a:t>
+              <a:t>Sept SCA target 5,122 dock hrs (F26 Sept 6,303 − 1,181-hr reduction target) · 244 hrs per working day · SCA dock cost per PRO target $6.85.</a:t>
             </a:r>
             <a:endParaRPr lang="en-US" sz="1000" dirty="0"/>
           </a:p>
@@ -36778,7 +36414,7 @@
                 <a:ea typeface="Calibri" pitchFamily="34" charset="-122"/>
                 <a:cs typeface="Calibri" pitchFamily="34" charset="-120"/>
               </a:rPr>
-              <a:t>3,999 hrs used vs 4,390 allowed MTD = 91.1% (391 hrs under ≈ $13.1K) · pace ≈4,666 hrs vs 5,122 target = 139% of reduction target · cost per PRO $6.60 = 96.3% of target (amber).</a:t>
+              <a:t>3,999 hrs used vs 4,390 allowed MTD = 91.1% (391 hrs under ≈ $13.1K) · pace ≈4,666 hrs vs 5,122 target = 139% of reduction target · SCA dock cost per PRO $6.60 = 96.3% of target (amber).</a:t>
             </a:r>
             <a:endParaRPr lang="en-US" sz="1000" dirty="0"/>
           </a:p>
@@ -38620,7 +38256,7 @@
                 <a:ea typeface="Calibri" pitchFamily="34" charset="-122"/>
                 <a:cs typeface="Calibri" pitchFamily="34" charset="-120"/>
               </a:rPr>
-              <a:t>Zero recordable incidents in F27 to date (Jul–Aug) — 100% improvement vs F26 TRIR of 1.21.</a:t>
+              <a:t>0 recordables Jul–Aug; TRIR 0.00 vs 1.21 F26.</a:t>
             </a:r>
             <a:endParaRPr lang="en-US" sz="1400" dirty="0"/>
           </a:p>
@@ -44666,7 +44302,7 @@
                 <a:ea typeface="Calibri" pitchFamily="34" charset="-122"/>
                 <a:cs typeface="Calibri" pitchFamily="34" charset="-120"/>
               </a:rPr>
-              <a:t>Trending down: 3.34% (Sep 22) → 0.31% (Sep 28)</a:t>
+              <a:t>7-day avg 1.61%; latest day 0.31% (Sep 28)</a:t>
             </a:r>
             <a:endParaRPr lang="en-US" sz="950" dirty="0"/>
           </a:p>
@@ -46256,7 +45892,7 @@
                 <a:ea typeface="Calibri" pitchFamily="34" charset="-122"/>
                 <a:cs typeface="Calibri" pitchFamily="34" charset="-120"/>
               </a:rPr>
-              <a:t>September is in line with fiscal YTD (91.4% vs 91.6% of freight bills scanned). ≈4.55K freight bills were not scanned in/out Sep 1–28 — closing that gap also cuts 'already serviced' missed-PU false positives.</a:t>
+              <a:t>September is in line with fiscal YTD: freight bills scanned 91.37% (FYTD 91.55%). ≈4.55K freight bills were not scanned in/out Sep 1–28 — closing that gap also cuts 'already serviced' missed-PU false positives.</a:t>
             </a:r>
             <a:endParaRPr lang="en-US" sz="1350" dirty="0"/>
           </a:p>
@@ -46500,7 +46136,7 @@
                 <a:ea typeface="Calibri" pitchFamily="34" charset="-122"/>
                 <a:cs typeface="Calibri" pitchFamily="34" charset="-120"/>
               </a:rPr>
-              <a:t>SCA — Cost per PRO (Sept MTD)</a:t>
+              <a:t>SCA dock cost per PRO (Sept MTD)</a:t>
             </a:r>
             <a:endParaRPr lang="en-US" sz="3000" dirty="0"/>
           </a:p>
@@ -46566,7 +46202,7 @@
                 <a:ea typeface="Calibri" pitchFamily="34" charset="-122"/>
                 <a:cs typeface="Calibri" pitchFamily="34" charset="-120"/>
               </a:rPr>
-              <a:t>Cost per PRO · MTD</a:t>
+              <a:t>SCA dock cost per PRO · MTD</a:t>
             </a:r>
             <a:endParaRPr lang="en-US" sz="1500" dirty="0"/>
           </a:p>

</xml_diff>

<commit_message>
Deck: driver safety reps and route ride-alongs on safety slide
Co-Authored-By: Claude Opus 5.5 <noreply@anthropic.com>
Claude-Session: https://claude.ai/code/session_01BwRjju3y2wk3wSHFrM9KLe
</commit_message>
<xml_diff>
--- a/presentation/Mississauga_F27_Leadership_Review_Sep29.pptx
+++ b/presentation/Mississauga_F27_Leadership_Review_Sep29.pptx
@@ -6387,7 +6387,7 @@
           <a:p>
             <a:r>
               <a:rPr lang="en-US" dirty="0"/>
-              <a:t>Here is where our safety work stands. Completed: the roofing work zones are barricaded with N95 masks available, and the new shunt pre-trip checklist is used every shift. Our ongoing practices include incident reporting: incidents are reported promptly and supervisors work directly with OHS on WSIB forms and a safe return to work; we document detailed descriptions, identify root cause with OHS, and follow up corrective actions so controls prevent recurrence; and forklift and TDG training is completed before expiry. Planned are load securement and decking with ANCRA decks and divider deck-board kits, and freight-handling equipment such as panel trucks and racks for windows, panels and car parts to improve handling and cut damages, and the ideas list is where we go next, including agency onboarding and a safety plan for the new building.</a:t>
+              <a:t>Here is where our safety work stands. Completed: the roofing work zones are barricaded with N95 masks available, and the new shunt pre-trip checklist is used every shift. Our ongoing practices include incident reporting: incidents are reported promptly and supervisors work directly with OHS on WSIB forms and a safe return to work; we document detailed descriptions, identify root cause with OHS, and follow up corrective actions so controls prevent recurrence; and forklift and TDG training is completed before expiry. Planned are load securement and decking with ANCRA decks and divider deck-board kits, and freight-handling equipment such as panel trucks and racks for windows, panels and car parts to improve handling and cut damages, and two driver-led initiatives we will take to Safety: driver safety reps — our top safety-score drivers join the monthly safety meeting and speak for drivers, because drivers follow respected peers, people protect standards they help set, and drivers raise concerns with a peer they would not raise with a manager — and manager and supervisor route ride-alongs with a quarterly quota that ramps up to every driver once a year, so leaders see road challenges first-hand. The ideas list is where we go next, including agency onboarding and a safety plan for the new building.</a:t>
             </a:r>
             <a:endParaRPr lang="en-US" dirty="0"/>
           </a:p>
@@ -41798,7 +41798,7 @@
                 <a:ea typeface="Calibri" pitchFamily="34" charset="-122"/>
                 <a:cs typeface="Calibri" pitchFamily="34" charset="-120"/>
               </a:rPr>
-              <a:t>0 recordables F27, TRIR 0.00 vs 1.21 F26 · 384 days since last recordable · Initiatives: 3 completed · 7 active · 2 planned (load securement &amp; decking; freight-handling equipment).</a:t>
+              <a:t>0 recordables F27, TRIR 0.00 vs 1.21 F26 · 384 days since last recordable · Initiatives: 3 completed · 7 active · 4 planned (driver safety reps; route ride-alongs; load securement &amp; decking; freight-handling equipment).</a:t>
             </a:r>
             <a:endParaRPr lang="en-US" sz="1000" dirty="0"/>
           </a:p>
@@ -44128,7 +44128,7 @@
                 <a:ea typeface="Calibri" pitchFamily="34" charset="-122"/>
                 <a:cs typeface="Calibri" pitchFamily="34" charset="-120"/>
               </a:rPr>
-              <a:t>2 planned</a:t>
+              <a:t>4 planned</a:t>
             </a:r>
             <a:endParaRPr lang="en-US" sz="1050" dirty="0"/>
           </a:p>
@@ -44159,7 +44159,7 @@
               <a:buNone/>
             </a:pPr>
             <a:r>
-              <a:rPr lang="en-US" sz="1100" b="1" dirty="0">
+              <a:rPr lang="en-US" sz="1000" b="1" dirty="0">
                 <a:solidFill>
                   <a:srgbClr val="111827"/>
                 </a:solidFill>
@@ -44167,13 +44167,75 @@
                 <a:ea typeface="Calibri" pitchFamily="34" charset="-122"/>
                 <a:cs typeface="Calibri" pitchFamily="34" charset="-120"/>
               </a:rPr>
+              <a:t>Driver safety reps: </a:t>
+            </a:r>
+            <a:pPr indent="0" marL="0">
+              <a:buNone/>
+            </a:pPr>
+            <a:r>
+              <a:rPr lang="en-US" sz="1000" dirty="0">
+                <a:solidFill>
+                  <a:srgbClr val="1F2937"/>
+                </a:solidFill>
+                <a:latin typeface="Calibri" pitchFamily="34" charset="0"/>
+                <a:ea typeface="Calibri" pitchFamily="34" charset="-122"/>
+                <a:cs typeface="Calibri" pitchFamily="34" charset="-120"/>
+              </a:rPr>
+              <a:t>top safety-score drivers join the monthly safety meeting and speak for drivers.</a:t>
+            </a:r>
+            <a:endParaRPr lang="en-US" sz="1000" dirty="0"/>
+          </a:p>
+          <a:p>
+            <a:pPr indent="0" marL="0">
+              <a:buNone/>
+            </a:pPr>
+            <a:r>
+              <a:rPr lang="en-US" sz="1000" b="1" dirty="0">
+                <a:solidFill>
+                  <a:srgbClr val="111827"/>
+                </a:solidFill>
+                <a:latin typeface="Calibri" pitchFamily="34" charset="0"/>
+                <a:ea typeface="Calibri" pitchFamily="34" charset="-122"/>
+                <a:cs typeface="Calibri" pitchFamily="34" charset="-120"/>
+              </a:rPr>
+              <a:t>Route ride-alongs: </a:t>
+            </a:r>
+            <a:pPr indent="0" marL="0">
+              <a:buNone/>
+            </a:pPr>
+            <a:r>
+              <a:rPr lang="en-US" sz="1000" dirty="0">
+                <a:solidFill>
+                  <a:srgbClr val="1F2937"/>
+                </a:solidFill>
+                <a:latin typeface="Calibri" pitchFamily="34" charset="0"/>
+                <a:ea typeface="Calibri" pitchFamily="34" charset="-122"/>
+                <a:cs typeface="Calibri" pitchFamily="34" charset="-120"/>
+              </a:rPr>
+              <a:t>managers &amp; supervisors, quarterly quota ramping to every driver yearly.</a:t>
+            </a:r>
+            <a:endParaRPr lang="en-US" sz="1000" dirty="0"/>
+          </a:p>
+          <a:p>
+            <a:pPr indent="0" marL="0">
+              <a:buNone/>
+            </a:pPr>
+            <a:r>
+              <a:rPr lang="en-US" sz="1000" b="1" dirty="0">
+                <a:solidFill>
+                  <a:srgbClr val="111827"/>
+                </a:solidFill>
+                <a:latin typeface="Calibri" pitchFamily="34" charset="0"/>
+                <a:ea typeface="Calibri" pitchFamily="34" charset="-122"/>
+                <a:cs typeface="Calibri" pitchFamily="34" charset="-120"/>
+              </a:rPr>
               <a:t>Load securement &amp; decking </a:t>
             </a:r>
             <a:pPr indent="0" marL="0">
               <a:buNone/>
             </a:pPr>
             <a:r>
-              <a:rPr lang="en-US" sz="1100" dirty="0">
+              <a:rPr lang="en-US" sz="1000" dirty="0">
                 <a:solidFill>
                   <a:srgbClr val="1F2937"/>
                 </a:solidFill>
@@ -44181,16 +44243,16 @@
                 <a:ea typeface="Calibri" pitchFamily="34" charset="-122"/>
                 <a:cs typeface="Calibri" pitchFamily="34" charset="-120"/>
               </a:rPr>
-              <a:t>(ANCRA decks, divider deck-board kits).</a:t>
-            </a:r>
-            <a:endParaRPr lang="en-US" sz="1100" dirty="0"/>
-          </a:p>
-          <a:p>
-            <a:pPr indent="0" marL="0">
-              <a:buNone/>
-            </a:pPr>
-            <a:r>
-              <a:rPr lang="en-US" sz="1100" b="1" dirty="0">
+              <a:t>(ANCRA decks, divider kits).</a:t>
+            </a:r>
+            <a:endParaRPr lang="en-US" sz="1000" dirty="0"/>
+          </a:p>
+          <a:p>
+            <a:pPr indent="0" marL="0">
+              <a:buNone/>
+            </a:pPr>
+            <a:r>
+              <a:rPr lang="en-US" sz="1000" b="1" dirty="0">
                 <a:solidFill>
                   <a:srgbClr val="111827"/>
                 </a:solidFill>
@@ -44204,7 +44266,7 @@
               <a:buNone/>
             </a:pPr>
             <a:r>
-              <a:rPr lang="en-US" sz="1100" dirty="0">
+              <a:rPr lang="en-US" sz="1000" dirty="0">
                 <a:solidFill>
                   <a:srgbClr val="1F2937"/>
                 </a:solidFill>
@@ -44212,26 +44274,9 @@
                 <a:ea typeface="Calibri" pitchFamily="34" charset="-122"/>
                 <a:cs typeface="Calibri" pitchFamily="34" charset="-120"/>
               </a:rPr>
-              <a:t>panel trucks &amp; reconfigurable racks for windows, panels and car parts (Sawtrax, Rack and Shelf, Grainger vertical panel truck 1,800 lb, Uline carpeted panel truck).</a:t>
-            </a:r>
-            <a:endParaRPr lang="en-US" sz="1100" dirty="0"/>
-          </a:p>
-          <a:p>
-            <a:pPr indent="0" marL="0">
-              <a:buNone/>
-            </a:pPr>
-            <a:r>
-              <a:rPr lang="en-US" sz="1100" b="1" dirty="0">
-                <a:solidFill>
-                  <a:srgbClr val="059669"/>
-                </a:solidFill>
-                <a:latin typeface="Calibri" pitchFamily="34" charset="0"/>
-                <a:ea typeface="Calibri" pitchFamily="34" charset="-122"/>
-                <a:cs typeface="Calibri" pitchFamily="34" charset="-120"/>
-              </a:rPr>
-              <a:t>→ Safer handling, better load quality, fewer damages (damaged FB 1.61%, 7-day avg).</a:t>
-            </a:r>
-            <a:endParaRPr lang="en-US" sz="1100" dirty="0"/>
+              <a:t>panel trucks &amp; racks for windows, panels, car parts.</a:t>
+            </a:r>
+            <a:endParaRPr lang="en-US" sz="1000" dirty="0"/>
           </a:p>
         </p:txBody>
       </p:sp>

</xml_diff>

<commit_message>
Collapsible load tables: photos and network-benefit story on site and new deck slide 22
Co-Authored-By: Claude Opus 5.5 <noreply@anthropic.com>
Claude-Session: https://claude.ai/code/session_01BwRjju3y2wk3wSHFrM9KLe
</commit_message>
<xml_diff>
--- a/presentation/Mississauga_F27_Leadership_Review_Sep29.pptx
+++ b/presentation/Mississauga_F27_Leadership_Review_Sep29.pptx
@@ -30,9 +30,10 @@
     <p:sldId id="278" r:id="rId24"/>
     <p:sldId id="279" r:id="rId25"/>
     <p:sldId id="280" r:id="rId26"/>
+    <p:sldId id="281" r:id="rId27"/>
   </p:sldIdLst>
   <p:notesMasterIdLst>
-    <p:notesMasterId r:id="rId27"/>
+    <p:notesMasterId r:id="rId28"/>
   </p:notesMasterIdLst>
   <p:sldSz cx="12192000" cy="6858000"/>
   <p:notesSz cx="6858000" cy="12192000"/>
@@ -5947,7 +5948,7 @@
           <a:p>
             <a:r>
               <a:rPr lang="en-US" dirty="0"/>
-              <a:t>Clock-in and clock-out discipline turns late starts, missed lunches and early releases into hours we do not pay for. Weekly hours saved are being confirmed; once entered, dollars are calculated at the September month-to-date rate of 33.43 per hour from the productivity dashboard.</a:t>
+              <a:t>These are collapsible load tables. Extended, they build a second tier in the trailer; folded, a forklift lifts them; when empty they stack in a small footprint. Today our load tables are big fixed metal tables that take up dock space, and most terminals are much smaller than ours and could not store them. The benefit goes beyond Mississauga: we send outbound trailers to terminals across the country, and well-loaded trailers with collapsible tables and bin carts are faster and safer for them to unload and stage for final mile or transfer, and the same applies to inbound trailers to us. Less handling, fewer damages and claims, and safer unloading.</a:t>
             </a:r>
             <a:endParaRPr lang="en-US" dirty="0"/>
           </a:p>
@@ -6035,7 +6036,7 @@
           <a:p>
             <a:r>
               <a:rPr lang="en-US" dirty="0"/>
-              <a:t>Mississauga is moving to a new building, expected before the end of calendar 2026. Because of that, we are not planning any major repair spend at the current site; our focus is a clean transition for the team and our customers.</a:t>
+              <a:t>Clock-in and clock-out discipline turns late starts, missed lunches and early releases into hours we do not pay for. Weekly hours saved are being confirmed; once entered, dollars are calculated at the September month-to-date rate of 33.43 per hour from the productivity dashboard.</a:t>
             </a:r>
             <a:endParaRPr lang="en-US" dirty="0"/>
           </a:p>
@@ -6123,7 +6124,7 @@
           <a:p>
             <a:r>
               <a:rPr lang="en-US" dirty="0"/>
-              <a:t>To close: in F26 we set out to take 386,589 dollars out against the F25 baseline and identified 427,001 dollars of savings, 110 percent of the requirement; the F26 actuals will be added once the year is closed. In F27 September we are under our SCA hour allowance and cost per unit is down on last year, and our focus is closing the gap to the PPH goal. Happy to take questions.</a:t>
+              <a:t>Mississauga is moving to a new building, expected before the end of calendar 2026. Because of that, we are not planning any major repair spend at the current site; our focus is a clean transition for the team and our customers.</a:t>
             </a:r>
             <a:endParaRPr lang="en-US" dirty="0"/>
           </a:p>
@@ -6211,7 +6212,7 @@
           <a:p>
             <a:r>
               <a:rPr lang="en-US" dirty="0"/>
-              <a:t>Backup — use only if asked.</a:t>
+              <a:t>To close: in F26 we set out to take 386,589 dollars out against the F25 baseline and identified 427,001 dollars of savings, 110 percent of the requirement; the F26 actuals will be added once the year is closed. In F27 September we are under our SCA hour allowance and cost per unit is down on last year, and our focus is closing the gap to the PPH goal. Happy to take questions.</a:t>
             </a:r>
             <a:endParaRPr lang="en-US" dirty="0"/>
           </a:p>
@@ -6235,6 +6236,94 @@
             <a:fld id="{F7021451-1387-4CA6-816F-3879F97B5CBC}" type="slidenum">
               <a:rPr lang="en-US"/>
               <a:t>25</a:t>
+            </a:fld>
+            <a:endParaRPr lang="en-US"/>
+          </a:p>
+        </p:txBody>
+      </p:sp>
+    </p:spTree>
+    <p:extLst>
+      <p:ext uri="{BB962C8B-B14F-4D97-AF65-F5344CB8AC3E}">
+        <p14:creationId xmlns:p14="http://schemas.microsoft.com/office/powerpoint/2010/main" val="1024086991"/>
+      </p:ext>
+    </p:extLst>
+  </p:cSld>
+  <p:clrMapOvr>
+    <a:masterClrMapping/>
+  </p:clrMapOvr>
+</p:notes>
+</file>
+
+<file path=ppt/notesSlides/notesSlide26.xml><?xml version="1.0" encoding="utf-8"?>
+<p:notes xmlns:a="http://schemas.openxmlformats.org/drawingml/2006/main" xmlns:r="http://schemas.openxmlformats.org/officeDocument/2006/relationships" xmlns:p="http://schemas.openxmlformats.org/presentationml/2006/main">
+  <p:cSld>
+    <p:spTree>
+      <p:nvGrpSpPr>
+        <p:cNvPr id="1" name=""/>
+        <p:cNvGrpSpPr/>
+        <p:nvPr/>
+      </p:nvGrpSpPr>
+      <p:grpSpPr>
+        <a:xfrm>
+          <a:off x="0" y="0"/>
+          <a:ext cx="0" cy="0"/>
+          <a:chOff x="0" y="0"/>
+          <a:chExt cx="0" cy="0"/>
+        </a:xfrm>
+      </p:grpSpPr>
+      <p:sp>
+        <p:nvSpPr>
+          <p:cNvPr id="2" name="Slide Image Placeholder 1"/>
+          <p:cNvSpPr>
+            <a:spLocks noGrp="1" noRot="1" noChangeAspect="1"/>
+          </p:cNvSpPr>
+          <p:nvPr>
+            <p:ph type="sldImg"/>
+          </p:nvPr>
+        </p:nvSpPr>
+        <p:spPr/>
+      </p:sp>
+      <p:sp>
+        <p:nvSpPr>
+          <p:cNvPr id="3" name="Notes Placeholder 2"/>
+          <p:cNvSpPr>
+            <a:spLocks noGrp="1"/>
+          </p:cNvSpPr>
+          <p:nvPr>
+            <p:ph type="body" idx="1"/>
+          </p:nvPr>
+        </p:nvSpPr>
+        <p:spPr/>
+        <p:txBody>
+          <a:bodyPr/>
+          <a:lstStyle/>
+          <a:p>
+            <a:r>
+              <a:rPr lang="en-US" dirty="0"/>
+              <a:t>Backup — use only if asked.</a:t>
+            </a:r>
+            <a:endParaRPr lang="en-US" dirty="0"/>
+          </a:p>
+        </p:txBody>
+      </p:sp>
+      <p:sp>
+        <p:nvSpPr>
+          <p:cNvPr id="4" name="Slide Number Placeholder 3"/>
+          <p:cNvSpPr>
+            <a:spLocks noGrp="1"/>
+          </p:cNvSpPr>
+          <p:nvPr>
+            <p:ph type="sldNum" sz="quarter" idx="10"/>
+          </p:nvPr>
+        </p:nvSpPr>
+        <p:spPr/>
+        <p:txBody>
+          <a:bodyPr/>
+          <a:lstStyle/>
+          <a:p>
+            <a:fld id="{F7021451-1387-4CA6-816F-3879F97B5CBC}" type="slidenum">
+              <a:rPr lang="en-US"/>
+              <a:t>26</a:t>
             </a:fld>
             <a:endParaRPr lang="en-US"/>
           </a:p>
@@ -9235,7 +9324,7 @@
                 <a:ea typeface="Calibri" pitchFamily="34" charset="-122"/>
                 <a:cs typeface="Calibri" pitchFamily="34" charset="-120"/>
               </a:rPr>
-              <a:t>10 / 25</a:t>
+              <a:t>10 / 26</a:t>
             </a:r>
             <a:endParaRPr lang="en-US" sz="900" dirty="0"/>
           </a:p>
@@ -13728,7 +13817,7 @@
                 <a:ea typeface="Calibri" pitchFamily="34" charset="-122"/>
                 <a:cs typeface="Calibri" pitchFamily="34" charset="-120"/>
               </a:rPr>
-              <a:t>11 / 25</a:t>
+              <a:t>11 / 26</a:t>
             </a:r>
             <a:endParaRPr lang="en-US" sz="900" dirty="0"/>
           </a:p>
@@ -15564,7 +15653,7 @@
                 <a:ea typeface="Calibri" pitchFamily="34" charset="-122"/>
                 <a:cs typeface="Calibri" pitchFamily="34" charset="-120"/>
               </a:rPr>
-              <a:t>12 / 25</a:t>
+              <a:t>12 / 26</a:t>
             </a:r>
             <a:endParaRPr lang="en-US" sz="900" dirty="0"/>
           </a:p>
@@ -16201,7 +16290,7 @@
                 <a:ea typeface="Calibri" pitchFamily="34" charset="-122"/>
                 <a:cs typeface="Calibri" pitchFamily="34" charset="-120"/>
               </a:rPr>
-              <a:t>13 / 25</a:t>
+              <a:t>13 / 26</a:t>
             </a:r>
             <a:endParaRPr lang="en-US" sz="900" dirty="0"/>
           </a:p>
@@ -17708,7 +17797,7 @@
                 <a:ea typeface="Calibri" pitchFamily="34" charset="-122"/>
                 <a:cs typeface="Calibri" pitchFamily="34" charset="-120"/>
               </a:rPr>
-              <a:t>14 / 25</a:t>
+              <a:t>14 / 26</a:t>
             </a:r>
             <a:endParaRPr lang="en-US" sz="900" dirty="0"/>
           </a:p>
@@ -21495,7 +21584,7 @@
                 <a:ea typeface="Calibri" pitchFamily="34" charset="-122"/>
                 <a:cs typeface="Calibri" pitchFamily="34" charset="-120"/>
               </a:rPr>
-              <a:t>15 / 25</a:t>
+              <a:t>15 / 26</a:t>
             </a:r>
             <a:endParaRPr lang="en-US" sz="900" dirty="0"/>
           </a:p>
@@ -26098,7 +26187,7 @@
                 <a:ea typeface="Calibri" pitchFamily="34" charset="-122"/>
                 <a:cs typeface="Calibri" pitchFamily="34" charset="-120"/>
               </a:rPr>
-              <a:t>16 / 25</a:t>
+              <a:t>16 / 26</a:t>
             </a:r>
             <a:endParaRPr lang="en-US" sz="900" dirty="0"/>
           </a:p>
@@ -27186,7 +27275,7 @@
                 <a:ea typeface="Calibri" pitchFamily="34" charset="-122"/>
                 <a:cs typeface="Calibri" pitchFamily="34" charset="-120"/>
               </a:rPr>
-              <a:t>17 / 25</a:t>
+              <a:t>17 / 26</a:t>
             </a:r>
             <a:endParaRPr lang="en-US" sz="900" dirty="0"/>
           </a:p>
@@ -30086,7 +30175,7 @@
                 <a:ea typeface="Calibri" pitchFamily="34" charset="-122"/>
                 <a:cs typeface="Calibri" pitchFamily="34" charset="-120"/>
               </a:rPr>
-              <a:t>18 / 25</a:t>
+              <a:t>18 / 26</a:t>
             </a:r>
             <a:endParaRPr lang="en-US" sz="900" dirty="0"/>
           </a:p>
@@ -32425,7 +32514,7 @@
                 <a:ea typeface="Calibri" pitchFamily="34" charset="-122"/>
                 <a:cs typeface="Calibri" pitchFamily="34" charset="-120"/>
               </a:rPr>
-              <a:t>19 / 25</a:t>
+              <a:t>19 / 26</a:t>
             </a:r>
             <a:endParaRPr lang="en-US" sz="900" dirty="0"/>
           </a:p>
@@ -33821,7 +33910,7 @@
                 <a:ea typeface="Calibri" pitchFamily="34" charset="-122"/>
                 <a:cs typeface="Calibri" pitchFamily="34" charset="-120"/>
               </a:rPr>
-              <a:t>2 / 25</a:t>
+              <a:t>2 / 26</a:t>
             </a:r>
             <a:endParaRPr lang="en-US" sz="900" dirty="0"/>
           </a:p>
@@ -35018,7 +35107,7 @@
                 <a:ea typeface="Calibri" pitchFamily="34" charset="-122"/>
                 <a:cs typeface="Calibri" pitchFamily="34" charset="-120"/>
               </a:rPr>
-              <a:t>20 / 25</a:t>
+              <a:t>20 / 26</a:t>
             </a:r>
             <a:endParaRPr lang="en-US" sz="900" dirty="0"/>
           </a:p>
@@ -36307,7 +36396,7 @@
                 <a:ea typeface="Calibri" pitchFamily="34" charset="-122"/>
                 <a:cs typeface="Calibri" pitchFamily="34" charset="-120"/>
               </a:rPr>
-              <a:t>21 / 25</a:t>
+              <a:t>21 / 26</a:t>
             </a:r>
             <a:endParaRPr lang="en-US" sz="900" dirty="0"/>
           </a:p>
@@ -36417,6 +36506,900 @@
                 <a:ea typeface="Calibri" pitchFamily="34" charset="-122"/>
                 <a:cs typeface="Calibri" pitchFamily="34" charset="-120"/>
               </a:rPr>
+              <a:t>Collapsible load tables — network benefit</a:t>
+            </a:r>
+            <a:endParaRPr lang="en-US" sz="3000" dirty="0"/>
+          </a:p>
+        </p:txBody>
+      </p:sp>
+      <p:sp>
+        <p:nvSpPr>
+          <p:cNvPr id="4" name="Shape 2"/>
+          <p:cNvSpPr/>
+          <p:nvPr/>
+        </p:nvSpPr>
+        <p:spPr>
+          <a:xfrm>
+            <a:off x="548640" y="1371600"/>
+            <a:ext cx="2194560" cy="292608"/>
+          </a:xfrm>
+          <a:prstGeom prst="roundRect">
+            <a:avLst>
+              <a:gd name="adj" fmla="val 25000"/>
+            </a:avLst>
+          </a:prstGeom>
+          <a:solidFill>
+            <a:srgbClr val="EDE9FE"/>
+          </a:solidFill>
+          <a:ln w="12700">
+            <a:solidFill>
+              <a:srgbClr val="EDE9FE"/>
+            </a:solidFill>
+            <a:prstDash val="solid"/>
+          </a:ln>
+        </p:spPr>
+      </p:sp>
+      <p:sp>
+        <p:nvSpPr>
+          <p:cNvPr id="5" name="Text 3"/>
+          <p:cNvSpPr txBox="1"/>
+          <p:nvPr/>
+        </p:nvSpPr>
+        <p:spPr>
+          <a:xfrm>
+            <a:off x="548640" y="1371600"/>
+            <a:ext cx="2194560" cy="292608"/>
+          </a:xfrm>
+          <a:prstGeom prst="rect">
+            <a:avLst/>
+          </a:prstGeom>
+          <a:noFill/>
+          <a:ln/>
+        </p:spPr>
+        <p:txBody>
+          <a:bodyPr wrap="square" lIns="0" tIns="0" rIns="0" bIns="0" rtlCol="0" anchor="ctr"/>
+          <a:lstStyle/>
+          <a:p>
+            <a:pPr algn="ctr" indent="0" marL="0">
+              <a:buNone/>
+            </a:pPr>
+            <a:r>
+              <a:rPr lang="en-US" sz="1100" b="1" spc="100" kern="0" dirty="0">
+                <a:solidFill>
+                  <a:srgbClr val="7C3AED"/>
+                </a:solidFill>
+                <a:latin typeface="Calibri" pitchFamily="34" charset="0"/>
+                <a:ea typeface="Calibri" pitchFamily="34" charset="-122"/>
+                <a:cs typeface="Calibri" pitchFamily="34" charset="-120"/>
+              </a:rPr>
+              <a:t>EXTENDED</a:t>
+            </a:r>
+            <a:endParaRPr lang="en-US" sz="1100" dirty="0"/>
+          </a:p>
+        </p:txBody>
+      </p:sp>
+      <p:pic>
+        <p:nvPicPr>
+          <p:cNvPr id="6" name="Image 0" descr="Second tier in the trailer">    </p:cNvPr>
+          <p:cNvPicPr>
+            <a:picLocks noChangeAspect="1"/>
+          </p:cNvPicPr>
+          <p:nvPr/>
+        </p:nvPicPr>
+        <p:blipFill>
+          <a:blip r:embed="rId1"/>
+          <a:srcRect l="0" r="0" t="0" b="0"/>
+          <a:stretch/>
+        </p:blipFill>
+        <p:spPr>
+          <a:xfrm>
+            <a:off x="548640" y="1737360"/>
+            <a:ext cx="2194560" cy="2392070"/>
+          </a:xfrm>
+          <a:prstGeom prst="rect">
+            <a:avLst/>
+          </a:prstGeom>
+        </p:spPr>
+      </p:pic>
+      <p:sp>
+        <p:nvSpPr>
+          <p:cNvPr id="7" name="Text 4"/>
+          <p:cNvSpPr txBox="1"/>
+          <p:nvPr/>
+        </p:nvSpPr>
+        <p:spPr>
+          <a:xfrm>
+            <a:off x="548640" y="4175150"/>
+            <a:ext cx="2194560" cy="320040"/>
+          </a:xfrm>
+          <a:prstGeom prst="rect">
+            <a:avLst/>
+          </a:prstGeom>
+          <a:noFill/>
+          <a:ln/>
+        </p:spPr>
+        <p:txBody>
+          <a:bodyPr wrap="square" lIns="0" tIns="0" rIns="0" bIns="0" rtlCol="0" anchor="t"/>
+          <a:lstStyle/>
+          <a:p>
+            <a:pPr indent="0" marL="0">
+              <a:buNone/>
+            </a:pPr>
+            <a:r>
+              <a:rPr lang="en-US" sz="1100" dirty="0">
+                <a:solidFill>
+                  <a:srgbClr val="1F2937"/>
+                </a:solidFill>
+                <a:latin typeface="Calibri" pitchFamily="34" charset="0"/>
+                <a:ea typeface="Calibri" pitchFamily="34" charset="-122"/>
+                <a:cs typeface="Calibri" pitchFamily="34" charset="-120"/>
+              </a:rPr>
+              <a:t>Second tier in the trailer</a:t>
+            </a:r>
+            <a:endParaRPr lang="en-US" sz="1100" dirty="0"/>
+          </a:p>
+        </p:txBody>
+      </p:sp>
+      <p:sp>
+        <p:nvSpPr>
+          <p:cNvPr id="8" name="Shape 5"/>
+          <p:cNvSpPr/>
+          <p:nvPr/>
+        </p:nvSpPr>
+        <p:spPr>
+          <a:xfrm>
+            <a:off x="2926080" y="1371600"/>
+            <a:ext cx="2194560" cy="292608"/>
+          </a:xfrm>
+          <a:prstGeom prst="roundRect">
+            <a:avLst>
+              <a:gd name="adj" fmla="val 25000"/>
+            </a:avLst>
+          </a:prstGeom>
+          <a:solidFill>
+            <a:srgbClr val="EDE9FE"/>
+          </a:solidFill>
+          <a:ln w="12700">
+            <a:solidFill>
+              <a:srgbClr val="EDE9FE"/>
+            </a:solidFill>
+            <a:prstDash val="solid"/>
+          </a:ln>
+        </p:spPr>
+      </p:sp>
+      <p:sp>
+        <p:nvSpPr>
+          <p:cNvPr id="9" name="Text 6"/>
+          <p:cNvSpPr txBox="1"/>
+          <p:nvPr/>
+        </p:nvSpPr>
+        <p:spPr>
+          <a:xfrm>
+            <a:off x="2926080" y="1371600"/>
+            <a:ext cx="2194560" cy="292608"/>
+          </a:xfrm>
+          <a:prstGeom prst="rect">
+            <a:avLst/>
+          </a:prstGeom>
+          <a:noFill/>
+          <a:ln/>
+        </p:spPr>
+        <p:txBody>
+          <a:bodyPr wrap="square" lIns="0" tIns="0" rIns="0" bIns="0" rtlCol="0" anchor="ctr"/>
+          <a:lstStyle/>
+          <a:p>
+            <a:pPr algn="ctr" indent="0" marL="0">
+              <a:buNone/>
+            </a:pPr>
+            <a:r>
+              <a:rPr lang="en-US" sz="1100" b="1" spc="100" kern="0" dirty="0">
+                <a:solidFill>
+                  <a:srgbClr val="7C3AED"/>
+                </a:solidFill>
+                <a:latin typeface="Calibri" pitchFamily="34" charset="0"/>
+                <a:ea typeface="Calibri" pitchFamily="34" charset="-122"/>
+                <a:cs typeface="Calibri" pitchFamily="34" charset="-120"/>
+              </a:rPr>
+              <a:t>FOLDED</a:t>
+            </a:r>
+            <a:endParaRPr lang="en-US" sz="1100" dirty="0"/>
+          </a:p>
+        </p:txBody>
+      </p:sp>
+      <p:pic>
+        <p:nvPicPr>
+          <p:cNvPr id="10" name="Image 1" descr="Lifted by forklift">    </p:cNvPr>
+          <p:cNvPicPr>
+            <a:picLocks noChangeAspect="1"/>
+          </p:cNvPicPr>
+          <p:nvPr/>
+        </p:nvPicPr>
+        <p:blipFill>
+          <a:blip r:embed="rId2"/>
+          <a:srcRect l="0" r="0" t="0" b="0"/>
+          <a:stretch/>
+        </p:blipFill>
+        <p:spPr>
+          <a:xfrm>
+            <a:off x="2926080" y="1737360"/>
+            <a:ext cx="2194560" cy="2392070"/>
+          </a:xfrm>
+          <a:prstGeom prst="rect">
+            <a:avLst/>
+          </a:prstGeom>
+        </p:spPr>
+      </p:pic>
+      <p:sp>
+        <p:nvSpPr>
+          <p:cNvPr id="11" name="Text 7"/>
+          <p:cNvSpPr txBox="1"/>
+          <p:nvPr/>
+        </p:nvSpPr>
+        <p:spPr>
+          <a:xfrm>
+            <a:off x="2926080" y="4175150"/>
+            <a:ext cx="2194560" cy="320040"/>
+          </a:xfrm>
+          <a:prstGeom prst="rect">
+            <a:avLst/>
+          </a:prstGeom>
+          <a:noFill/>
+          <a:ln/>
+        </p:spPr>
+        <p:txBody>
+          <a:bodyPr wrap="square" lIns="0" tIns="0" rIns="0" bIns="0" rtlCol="0" anchor="t"/>
+          <a:lstStyle/>
+          <a:p>
+            <a:pPr indent="0" marL="0">
+              <a:buNone/>
+            </a:pPr>
+            <a:r>
+              <a:rPr lang="en-US" sz="1100" dirty="0">
+                <a:solidFill>
+                  <a:srgbClr val="1F2937"/>
+                </a:solidFill>
+                <a:latin typeface="Calibri" pitchFamily="34" charset="0"/>
+                <a:ea typeface="Calibri" pitchFamily="34" charset="-122"/>
+                <a:cs typeface="Calibri" pitchFamily="34" charset="-120"/>
+              </a:rPr>
+              <a:t>Lifted by forklift</a:t>
+            </a:r>
+            <a:endParaRPr lang="en-US" sz="1100" dirty="0"/>
+          </a:p>
+        </p:txBody>
+      </p:sp>
+      <p:sp>
+        <p:nvSpPr>
+          <p:cNvPr id="12" name="Shape 8"/>
+          <p:cNvSpPr/>
+          <p:nvPr/>
+        </p:nvSpPr>
+        <p:spPr>
+          <a:xfrm>
+            <a:off x="5303520" y="1371600"/>
+            <a:ext cx="2194560" cy="292608"/>
+          </a:xfrm>
+          <a:prstGeom prst="roundRect">
+            <a:avLst>
+              <a:gd name="adj" fmla="val 25000"/>
+            </a:avLst>
+          </a:prstGeom>
+          <a:solidFill>
+            <a:srgbClr val="EDE9FE"/>
+          </a:solidFill>
+          <a:ln w="12700">
+            <a:solidFill>
+              <a:srgbClr val="EDE9FE"/>
+            </a:solidFill>
+            <a:prstDash val="solid"/>
+          </a:ln>
+        </p:spPr>
+      </p:sp>
+      <p:sp>
+        <p:nvSpPr>
+          <p:cNvPr id="13" name="Text 9"/>
+          <p:cNvSpPr txBox="1"/>
+          <p:nvPr/>
+        </p:nvSpPr>
+        <p:spPr>
+          <a:xfrm>
+            <a:off x="5303520" y="1371600"/>
+            <a:ext cx="2194560" cy="292608"/>
+          </a:xfrm>
+          <a:prstGeom prst="rect">
+            <a:avLst/>
+          </a:prstGeom>
+          <a:noFill/>
+          <a:ln/>
+        </p:spPr>
+        <p:txBody>
+          <a:bodyPr wrap="square" lIns="0" tIns="0" rIns="0" bIns="0" rtlCol="0" anchor="ctr"/>
+          <a:lstStyle/>
+          <a:p>
+            <a:pPr algn="ctr" indent="0" marL="0">
+              <a:buNone/>
+            </a:pPr>
+            <a:r>
+              <a:rPr lang="en-US" sz="1100" b="1" spc="100" kern="0" dirty="0">
+                <a:solidFill>
+                  <a:srgbClr val="7C3AED"/>
+                </a:solidFill>
+                <a:latin typeface="Calibri" pitchFamily="34" charset="0"/>
+                <a:ea typeface="Calibri" pitchFamily="34" charset="-122"/>
+                <a:cs typeface="Calibri" pitchFamily="34" charset="-120"/>
+              </a:rPr>
+              <a:t>STACKED</a:t>
+            </a:r>
+            <a:endParaRPr lang="en-US" sz="1100" dirty="0"/>
+          </a:p>
+        </p:txBody>
+      </p:sp>
+      <p:pic>
+        <p:nvPicPr>
+          <p:cNvPr id="14" name="Image 2" descr="Small footprint when not in use">    </p:cNvPr>
+          <p:cNvPicPr>
+            <a:picLocks noChangeAspect="1"/>
+          </p:cNvPicPr>
+          <p:nvPr/>
+        </p:nvPicPr>
+        <p:blipFill>
+          <a:blip r:embed="rId3"/>
+          <a:srcRect l="0" r="0" t="0" b="0"/>
+          <a:stretch/>
+        </p:blipFill>
+        <p:spPr>
+          <a:xfrm>
+            <a:off x="5303520" y="1737360"/>
+            <a:ext cx="2194560" cy="2392070"/>
+          </a:xfrm>
+          <a:prstGeom prst="rect">
+            <a:avLst/>
+          </a:prstGeom>
+        </p:spPr>
+      </p:pic>
+      <p:sp>
+        <p:nvSpPr>
+          <p:cNvPr id="15" name="Text 10"/>
+          <p:cNvSpPr txBox="1"/>
+          <p:nvPr/>
+        </p:nvSpPr>
+        <p:spPr>
+          <a:xfrm>
+            <a:off x="5303520" y="4175150"/>
+            <a:ext cx="2194560" cy="320040"/>
+          </a:xfrm>
+          <a:prstGeom prst="rect">
+            <a:avLst/>
+          </a:prstGeom>
+          <a:noFill/>
+          <a:ln/>
+        </p:spPr>
+        <p:txBody>
+          <a:bodyPr wrap="square" lIns="0" tIns="0" rIns="0" bIns="0" rtlCol="0" anchor="t"/>
+          <a:lstStyle/>
+          <a:p>
+            <a:pPr indent="0" marL="0">
+              <a:buNone/>
+            </a:pPr>
+            <a:r>
+              <a:rPr lang="en-US" sz="1100" dirty="0">
+                <a:solidFill>
+                  <a:srgbClr val="1F2937"/>
+                </a:solidFill>
+                <a:latin typeface="Calibri" pitchFamily="34" charset="0"/>
+                <a:ea typeface="Calibri" pitchFamily="34" charset="-122"/>
+                <a:cs typeface="Calibri" pitchFamily="34" charset="-120"/>
+              </a:rPr>
+              <a:t>Small footprint when not in use</a:t>
+            </a:r>
+            <a:endParaRPr lang="en-US" sz="1100" dirty="0"/>
+          </a:p>
+        </p:txBody>
+      </p:sp>
+      <p:sp>
+        <p:nvSpPr>
+          <p:cNvPr id="16" name="Shape 11"/>
+          <p:cNvSpPr/>
+          <p:nvPr/>
+        </p:nvSpPr>
+        <p:spPr>
+          <a:xfrm>
+            <a:off x="548640" y="4754880"/>
+            <a:ext cx="6949440" cy="1280160"/>
+          </a:xfrm>
+          <a:prstGeom prst="roundRect">
+            <a:avLst>
+              <a:gd name="adj" fmla="val 5714"/>
+            </a:avLst>
+          </a:prstGeom>
+          <a:solidFill>
+            <a:srgbClr val="FFFBEB"/>
+          </a:solidFill>
+          <a:ln w="12700">
+            <a:solidFill>
+              <a:srgbClr val="FFFBEB"/>
+            </a:solidFill>
+            <a:prstDash val="solid"/>
+          </a:ln>
+        </p:spPr>
+      </p:sp>
+      <p:sp>
+        <p:nvSpPr>
+          <p:cNvPr id="17" name="Text 12"/>
+          <p:cNvSpPr txBox="1"/>
+          <p:nvPr/>
+        </p:nvSpPr>
+        <p:spPr>
+          <a:xfrm>
+            <a:off x="731520" y="4800600"/>
+            <a:ext cx="6583680" cy="1188720"/>
+          </a:xfrm>
+          <a:prstGeom prst="rect">
+            <a:avLst/>
+          </a:prstGeom>
+          <a:noFill/>
+          <a:ln/>
+        </p:spPr>
+        <p:txBody>
+          <a:bodyPr wrap="square" lIns="0" tIns="0" rIns="0" bIns="0" rtlCol="0" anchor="ctr"/>
+          <a:lstStyle/>
+          <a:p>
+            <a:pPr indent="0" marL="0">
+              <a:buNone/>
+            </a:pPr>
+            <a:r>
+              <a:rPr lang="en-US" sz="1250" b="1" dirty="0">
+                <a:solidFill>
+                  <a:srgbClr val="B45309"/>
+                </a:solidFill>
+                <a:latin typeface="Calibri" pitchFamily="34" charset="0"/>
+                <a:ea typeface="Calibri" pitchFamily="34" charset="-122"/>
+                <a:cs typeface="Calibri" pitchFamily="34" charset="-120"/>
+              </a:rPr>
+              <a:t>Today: </a:t>
+            </a:r>
+            <a:pPr indent="0" marL="0">
+              <a:buNone/>
+            </a:pPr>
+            <a:r>
+              <a:rPr lang="en-US" sz="1250" dirty="0">
+                <a:solidFill>
+                  <a:srgbClr val="1F2937"/>
+                </a:solidFill>
+                <a:latin typeface="Calibri" pitchFamily="34" charset="0"/>
+                <a:ea typeface="Calibri" pitchFamily="34" charset="-122"/>
+                <a:cs typeface="Calibri" pitchFamily="34" charset="-120"/>
+              </a:rPr>
+              <a:t>large fixed metal load tables take up dock space when not in use. Most terminals are much smaller than ours and could not store them.</a:t>
+            </a:r>
+            <a:endParaRPr lang="en-US" sz="1250" dirty="0"/>
+          </a:p>
+        </p:txBody>
+      </p:sp>
+      <p:sp>
+        <p:nvSpPr>
+          <p:cNvPr id="18" name="Shape 13"/>
+          <p:cNvSpPr/>
+          <p:nvPr/>
+        </p:nvSpPr>
+        <p:spPr>
+          <a:xfrm>
+            <a:off x="7772400" y="1371600"/>
+            <a:ext cx="3867912" cy="4663440"/>
+          </a:xfrm>
+          <a:prstGeom prst="roundRect">
+            <a:avLst>
+              <a:gd name="adj" fmla="val 1891"/>
+            </a:avLst>
+          </a:prstGeom>
+          <a:solidFill>
+            <a:srgbClr val="F3F4F6"/>
+          </a:solidFill>
+          <a:ln w="12700">
+            <a:solidFill>
+              <a:srgbClr val="F3F4F6"/>
+            </a:solidFill>
+            <a:prstDash val="solid"/>
+          </a:ln>
+        </p:spPr>
+      </p:sp>
+      <p:sp>
+        <p:nvSpPr>
+          <p:cNvPr id="19" name="Shape 14"/>
+          <p:cNvSpPr/>
+          <p:nvPr/>
+        </p:nvSpPr>
+        <p:spPr>
+          <a:xfrm>
+            <a:off x="8001000" y="1572768"/>
+            <a:ext cx="502920" cy="502920"/>
+          </a:xfrm>
+          <a:prstGeom prst="ellipse">
+            <a:avLst/>
+          </a:prstGeom>
+          <a:solidFill>
+            <a:srgbClr val="7C3AED"/>
+          </a:solidFill>
+          <a:ln w="12700">
+            <a:solidFill>
+              <a:srgbClr val="7C3AED"/>
+            </a:solidFill>
+            <a:prstDash val="solid"/>
+          </a:ln>
+        </p:spPr>
+      </p:sp>
+      <p:pic>
+        <p:nvPicPr>
+          <p:cNvPr id="20" name="Image 3" descr="preencoded.png">    </p:cNvPr>
+          <p:cNvPicPr>
+            <a:picLocks noChangeAspect="1"/>
+          </p:cNvPicPr>
+          <p:nvPr/>
+        </p:nvPicPr>
+        <p:blipFill>
+          <a:blip r:embed="rId4"/>
+          <a:stretch>
+            <a:fillRect/>
+          </a:stretch>
+        </p:blipFill>
+        <p:spPr>
+          <a:xfrm>
+            <a:off x="8126730" y="1698498"/>
+            <a:ext cx="251460" cy="251460"/>
+          </a:xfrm>
+          <a:prstGeom prst="rect">
+            <a:avLst/>
+          </a:prstGeom>
+        </p:spPr>
+      </p:pic>
+      <p:sp>
+        <p:nvSpPr>
+          <p:cNvPr id="21" name="Text 15"/>
+          <p:cNvSpPr txBox="1"/>
+          <p:nvPr/>
+        </p:nvSpPr>
+        <p:spPr>
+          <a:xfrm>
+            <a:off x="8641080" y="1572768"/>
+            <a:ext cx="2834640" cy="502920"/>
+          </a:xfrm>
+          <a:prstGeom prst="rect">
+            <a:avLst/>
+          </a:prstGeom>
+          <a:noFill/>
+          <a:ln/>
+        </p:spPr>
+        <p:txBody>
+          <a:bodyPr wrap="square" lIns="0" tIns="0" rIns="0" bIns="0" rtlCol="0" anchor="ctr"/>
+          <a:lstStyle/>
+          <a:p>
+            <a:pPr indent="0" marL="0">
+              <a:buNone/>
+            </a:pPr>
+            <a:r>
+              <a:rPr lang="en-US" sz="1700" b="1" dirty="0">
+                <a:solidFill>
+                  <a:srgbClr val="111827"/>
+                </a:solidFill>
+                <a:latin typeface="Calibri" pitchFamily="34" charset="0"/>
+                <a:ea typeface="Calibri" pitchFamily="34" charset="-122"/>
+                <a:cs typeface="Calibri" pitchFamily="34" charset="-120"/>
+              </a:rPr>
+              <a:t>Why it matters</a:t>
+            </a:r>
+            <a:endParaRPr lang="en-US" sz="1700" dirty="0"/>
+          </a:p>
+        </p:txBody>
+      </p:sp>
+      <p:sp>
+        <p:nvSpPr>
+          <p:cNvPr id="22" name="Text 16"/>
+          <p:cNvSpPr txBox="1"/>
+          <p:nvPr/>
+        </p:nvSpPr>
+        <p:spPr>
+          <a:xfrm>
+            <a:off x="8001000" y="2240280"/>
+            <a:ext cx="3474720" cy="3657600"/>
+          </a:xfrm>
+          <a:prstGeom prst="rect">
+            <a:avLst/>
+          </a:prstGeom>
+          <a:noFill/>
+          <a:ln/>
+        </p:spPr>
+        <p:txBody>
+          <a:bodyPr wrap="square" lIns="0" tIns="0" rIns="0" bIns="0" rtlCol="0" anchor="t"/>
+          <a:lstStyle/>
+          <a:p>
+            <a:pPr marL="203200" indent="-203200">
+              <a:spcAft>
+                <a:spcPts val="800"/>
+              </a:spcAft>
+              <a:buSzPct val="100000"/>
+              <a:buChar char="•"/>
+            </a:pPr>
+            <a:r>
+              <a:rPr lang="en-US" sz="1250" dirty="0">
+                <a:solidFill>
+                  <a:srgbClr val="1F2937"/>
+                </a:solidFill>
+                <a:latin typeface="Calibri" pitchFamily="34" charset="0"/>
+                <a:ea typeface="Calibri" pitchFamily="34" charset="-122"/>
+                <a:cs typeface="Calibri" pitchFamily="34" charset="-120"/>
+              </a:rPr>
+              <a:t>Fold flat and stack when empty — frees dock space</a:t>
+            </a:r>
+            <a:endParaRPr lang="en-US" sz="1250" dirty="0"/>
+          </a:p>
+          <a:p>
+            <a:pPr marL="203200" indent="-203200">
+              <a:spcAft>
+                <a:spcPts val="800"/>
+              </a:spcAft>
+              <a:buSzPct val="100000"/>
+              <a:buChar char="•"/>
+            </a:pPr>
+            <a:r>
+              <a:rPr lang="en-US" sz="1250" dirty="0">
+                <a:solidFill>
+                  <a:srgbClr val="1F2937"/>
+                </a:solidFill>
+                <a:latin typeface="Calibri" pitchFamily="34" charset="0"/>
+                <a:ea typeface="Calibri" pitchFamily="34" charset="-122"/>
+                <a:cs typeface="Calibri" pitchFamily="34" charset="-120"/>
+              </a:rPr>
+              <a:t>Forklift picks them up — less manual handling, faster unload</a:t>
+            </a:r>
+            <a:endParaRPr lang="en-US" sz="1250" dirty="0"/>
+          </a:p>
+          <a:p>
+            <a:pPr marL="203200" indent="-203200">
+              <a:spcAft>
+                <a:spcPts val="800"/>
+              </a:spcAft>
+              <a:buSzPct val="100000"/>
+              <a:buChar char="•"/>
+            </a:pPr>
+            <a:r>
+              <a:rPr lang="en-US" sz="1250" dirty="0">
+                <a:solidFill>
+                  <a:srgbClr val="1F2937"/>
+                </a:solidFill>
+                <a:latin typeface="Calibri" pitchFamily="34" charset="0"/>
+                <a:ea typeface="Calibri" pitchFamily="34" charset="-122"/>
+                <a:cs typeface="Calibri" pitchFamily="34" charset="-120"/>
+              </a:rPr>
+              <a:t>Receiving terminals across the country unload our trailers faster and cleaner — and theirs to us</a:t>
+            </a:r>
+            <a:endParaRPr lang="en-US" sz="1250" dirty="0"/>
+          </a:p>
+          <a:p>
+            <a:pPr marL="203200" indent="-203200">
+              <a:spcAft>
+                <a:spcPts val="800"/>
+              </a:spcAft>
+              <a:buSzPct val="100000"/>
+              <a:buChar char="•"/>
+            </a:pPr>
+            <a:r>
+              <a:rPr lang="en-US" sz="1250" dirty="0">
+                <a:solidFill>
+                  <a:srgbClr val="1F2937"/>
+                </a:solidFill>
+                <a:latin typeface="Calibri" pitchFamily="34" charset="0"/>
+                <a:ea typeface="Calibri" pitchFamily="34" charset="-122"/>
+                <a:cs typeface="Calibri" pitchFamily="34" charset="-120"/>
+              </a:rPr>
+              <a:t>With yellow / grey bin carts, freight rolls out and is staged for final mile or transfer</a:t>
+            </a:r>
+            <a:endParaRPr lang="en-US" sz="1250" dirty="0"/>
+          </a:p>
+          <a:p>
+            <a:pPr marL="203200" indent="-203200">
+              <a:spcAft>
+                <a:spcPts val="800"/>
+              </a:spcAft>
+              <a:buSzPct val="100000"/>
+              <a:buChar char="•"/>
+            </a:pPr>
+            <a:r>
+              <a:rPr lang="en-US" sz="1250" dirty="0">
+                <a:solidFill>
+                  <a:srgbClr val="1F2937"/>
+                </a:solidFill>
+                <a:latin typeface="Calibri" pitchFamily="34" charset="0"/>
+                <a:ea typeface="Calibri" pitchFamily="34" charset="-122"/>
+                <a:cs typeface="Calibri" pitchFamily="34" charset="-120"/>
+              </a:rPr>
+              <a:t>Fewer damages and claims; safer unloading</a:t>
+            </a:r>
+            <a:endParaRPr lang="en-US" sz="1250" dirty="0"/>
+          </a:p>
+        </p:txBody>
+      </p:sp>
+      <p:sp>
+        <p:nvSpPr>
+          <p:cNvPr id="23" name="Text 17"/>
+          <p:cNvSpPr txBox="1"/>
+          <p:nvPr/>
+        </p:nvSpPr>
+        <p:spPr>
+          <a:xfrm>
+            <a:off x="548640" y="6473952"/>
+            <a:ext cx="7315200" cy="228600"/>
+          </a:xfrm>
+          <a:prstGeom prst="rect">
+            <a:avLst/>
+          </a:prstGeom>
+          <a:noFill/>
+          <a:ln/>
+        </p:spPr>
+        <p:txBody>
+          <a:bodyPr wrap="square" lIns="0" tIns="0" rIns="0" bIns="0" rtlCol="0" anchor="ctr"/>
+          <a:lstStyle/>
+          <a:p>
+            <a:pPr indent="0" marL="0">
+              <a:buNone/>
+            </a:pPr>
+            <a:r>
+              <a:rPr lang="en-US" sz="900" dirty="0">
+                <a:solidFill>
+                  <a:srgbClr val="9CA3AF"/>
+                </a:solidFill>
+                <a:latin typeface="Calibri" pitchFamily="34" charset="0"/>
+                <a:ea typeface="Calibri" pitchFamily="34" charset="-122"/>
+                <a:cs typeface="Calibri" pitchFamily="34" charset="-120"/>
+              </a:rPr>
+              <a:t>Mississauga Terminal · F27 Senior Leadership Review · Sep 29, 2026</a:t>
+            </a:r>
+            <a:endParaRPr lang="en-US" sz="900" dirty="0"/>
+          </a:p>
+        </p:txBody>
+      </p:sp>
+      <p:sp>
+        <p:nvSpPr>
+          <p:cNvPr id="24" name="Text 18"/>
+          <p:cNvSpPr txBox="1"/>
+          <p:nvPr/>
+        </p:nvSpPr>
+        <p:spPr>
+          <a:xfrm>
+            <a:off x="10725912" y="6473952"/>
+            <a:ext cx="914400" cy="228600"/>
+          </a:xfrm>
+          <a:prstGeom prst="rect">
+            <a:avLst/>
+          </a:prstGeom>
+          <a:noFill/>
+          <a:ln/>
+        </p:spPr>
+        <p:txBody>
+          <a:bodyPr wrap="square" lIns="0" tIns="0" rIns="0" bIns="0" rtlCol="0" anchor="ctr"/>
+          <a:lstStyle/>
+          <a:p>
+            <a:pPr algn="r" indent="0" marL="0">
+              <a:buNone/>
+            </a:pPr>
+            <a:r>
+              <a:rPr lang="en-US" sz="900" dirty="0">
+                <a:solidFill>
+                  <a:srgbClr val="9CA3AF"/>
+                </a:solidFill>
+                <a:latin typeface="Calibri" pitchFamily="34" charset="0"/>
+                <a:ea typeface="Calibri" pitchFamily="34" charset="-122"/>
+                <a:cs typeface="Calibri" pitchFamily="34" charset="-120"/>
+              </a:rPr>
+              <a:t>22 / 26</a:t>
+            </a:r>
+            <a:endParaRPr lang="en-US" sz="900" dirty="0"/>
+          </a:p>
+        </p:txBody>
+      </p:sp>
+    </p:spTree>
+  </p:cSld>
+  <p:clrMapOvr>
+    <a:masterClrMapping/>
+  </p:clrMapOvr>
+</p:sld>
+</file>
+
+<file path=ppt/slides/slide23.xml><?xml version="1.0" encoding="utf-8"?>
+<p:sld xmlns:a="http://schemas.openxmlformats.org/drawingml/2006/main" xmlns:r="http://schemas.openxmlformats.org/officeDocument/2006/relationships" xmlns:p="http://schemas.openxmlformats.org/presentationml/2006/main">
+  <p:cSld name="Slide 23">
+    <p:bg>
+      <p:bgPr>
+        <a:solidFill>
+          <a:srgbClr val="FFFFFF"/>
+        </a:solidFill>
+      </p:bgPr>
+    </p:bg>
+    <p:spTree>
+      <p:nvGrpSpPr>
+        <p:cNvPr id="1" name=""/>
+        <p:cNvGrpSpPr/>
+        <p:nvPr/>
+      </p:nvGrpSpPr>
+      <p:grpSpPr>
+        <a:xfrm>
+          <a:off x="0" y="0"/>
+          <a:ext cx="0" cy="0"/>
+          <a:chOff x="0" y="0"/>
+          <a:chExt cx="0" cy="0"/>
+        </a:xfrm>
+      </p:grpSpPr>
+      <p:sp>
+        <p:nvSpPr>
+          <p:cNvPr id="2" name="Text 0"/>
+          <p:cNvSpPr txBox="1"/>
+          <p:nvPr/>
+        </p:nvSpPr>
+        <p:spPr>
+          <a:xfrm>
+            <a:off x="548640" y="320040"/>
+            <a:ext cx="9144000" cy="274320"/>
+          </a:xfrm>
+          <a:prstGeom prst="rect">
+            <a:avLst/>
+          </a:prstGeom>
+          <a:noFill/>
+          <a:ln/>
+        </p:spPr>
+        <p:txBody>
+          <a:bodyPr wrap="square" lIns="0" tIns="0" rIns="0" bIns="0" rtlCol="0" anchor="ctr"/>
+          <a:lstStyle/>
+          <a:p>
+            <a:pPr indent="0" marL="0">
+              <a:buNone/>
+            </a:pPr>
+            <a:r>
+              <a:rPr lang="en-US" sz="1200" b="1" spc="300" kern="0" dirty="0">
+                <a:solidFill>
+                  <a:srgbClr val="7C3AED"/>
+                </a:solidFill>
+                <a:latin typeface="Calibri" pitchFamily="34" charset="0"/>
+                <a:ea typeface="Calibri" pitchFamily="34" charset="-122"/>
+                <a:cs typeface="Calibri" pitchFamily="34" charset="-120"/>
+              </a:rPr>
+              <a:t>PRODUCTIVITY</a:t>
+            </a:r>
+            <a:endParaRPr lang="en-US" sz="1200" dirty="0"/>
+          </a:p>
+        </p:txBody>
+      </p:sp>
+      <p:sp>
+        <p:nvSpPr>
+          <p:cNvPr id="3" name="Text 1"/>
+          <p:cNvSpPr txBox="1"/>
+          <p:nvPr/>
+        </p:nvSpPr>
+        <p:spPr>
+          <a:xfrm>
+            <a:off x="548640" y="603504"/>
+            <a:ext cx="11091672" cy="603504"/>
+          </a:xfrm>
+          <a:prstGeom prst="rect">
+            <a:avLst/>
+          </a:prstGeom>
+          <a:noFill/>
+          <a:ln/>
+        </p:spPr>
+        <p:txBody>
+          <a:bodyPr wrap="square" lIns="0" tIns="0" rIns="0" bIns="0" rtlCol="0" anchor="t"/>
+          <a:lstStyle/>
+          <a:p>
+            <a:pPr indent="0" marL="0">
+              <a:buNone/>
+            </a:pPr>
+            <a:r>
+              <a:rPr lang="en-US" sz="3000" b="1" dirty="0">
+                <a:solidFill>
+                  <a:srgbClr val="111827"/>
+                </a:solidFill>
+                <a:latin typeface="Calibri" pitchFamily="34" charset="0"/>
+                <a:ea typeface="Calibri" pitchFamily="34" charset="-122"/>
+                <a:cs typeface="Calibri" pitchFamily="34" charset="-120"/>
+              </a:rPr>
               <a:t>CICO — hours saved</a:t>
             </a:r>
             <a:endParaRPr lang="en-US" sz="3000" dirty="0"/>
@@ -36425,7 +37408,7 @@
       </p:sp>
       <p:graphicFrame>
         <p:nvGraphicFramePr>
-          <p:cNvPr id="23" name="Table 0"/>
+          <p:cNvPr id="24" name="Table 0"/>
           <p:cNvGraphicFramePr>
             <a:graphicFrameLocks noGrp="1"/>
           </p:cNvGraphicFramePr>
@@ -38514,7 +39497,7 @@
                 <a:ea typeface="Calibri" pitchFamily="34" charset="-122"/>
                 <a:cs typeface="Calibri" pitchFamily="34" charset="-120"/>
               </a:rPr>
-              <a:t>22 / 25</a:t>
+              <a:t>23 / 26</a:t>
             </a:r>
             <a:endParaRPr lang="en-US" sz="900" dirty="0"/>
           </a:p>
@@ -38528,9 +39511,9 @@
 </p:sld>
 </file>
 
-<file path=ppt/slides/slide23.xml><?xml version="1.0" encoding="utf-8"?>
+<file path=ppt/slides/slide24.xml><?xml version="1.0" encoding="utf-8"?>
 <p:sld xmlns:a="http://schemas.openxmlformats.org/drawingml/2006/main" xmlns:r="http://schemas.openxmlformats.org/officeDocument/2006/relationships" xmlns:p="http://schemas.openxmlformats.org/presentationml/2006/main">
-  <p:cSld name="Slide 23">
+  <p:cSld name="Slide 24">
     <p:bg>
       <p:bgPr>
         <a:solidFill>
@@ -39203,7 +40186,7 @@
                 <a:ea typeface="Calibri" pitchFamily="34" charset="-122"/>
                 <a:cs typeface="Calibri" pitchFamily="34" charset="-120"/>
               </a:rPr>
-              <a:t>23 / 25</a:t>
+              <a:t>24 / 26</a:t>
             </a:r>
             <a:endParaRPr lang="en-US" sz="900" dirty="0"/>
           </a:p>
@@ -39217,9 +40200,9 @@
 </p:sld>
 </file>
 
-<file path=ppt/slides/slide24.xml><?xml version="1.0" encoding="utf-8"?>
+<file path=ppt/slides/slide25.xml><?xml version="1.0" encoding="utf-8"?>
 <p:sld xmlns:a="http://schemas.openxmlformats.org/drawingml/2006/main" xmlns:r="http://schemas.openxmlformats.org/officeDocument/2006/relationships" xmlns:p="http://schemas.openxmlformats.org/presentationml/2006/main">
-  <p:cSld name="Slide 24">
+  <p:cSld name="Slide 25">
     <p:bg>
       <p:bgPr>
         <a:solidFill>
@@ -40571,7 +41554,7 @@
                 <a:ea typeface="Calibri" pitchFamily="34" charset="-122"/>
                 <a:cs typeface="Calibri" pitchFamily="34" charset="-120"/>
               </a:rPr>
-              <a:t>24 / 25</a:t>
+              <a:t>25 / 26</a:t>
             </a:r>
             <a:endParaRPr lang="en-US" sz="900" dirty="0"/>
           </a:p>
@@ -40585,9 +41568,9 @@
 </p:sld>
 </file>
 
-<file path=ppt/slides/slide25.xml><?xml version="1.0" encoding="utf-8"?>
+<file path=ppt/slides/slide26.xml><?xml version="1.0" encoding="utf-8"?>
 <p:sld xmlns:a="http://schemas.openxmlformats.org/drawingml/2006/main" xmlns:r="http://schemas.openxmlformats.org/officeDocument/2006/relationships" xmlns:p="http://schemas.openxmlformats.org/presentationml/2006/main">
-  <p:cSld name="Slide 25">
+  <p:cSld name="Slide 26">
     <p:bg>
       <p:bgPr>
         <a:solidFill>
@@ -41876,7 +42859,7 @@
                 <a:ea typeface="Calibri" pitchFamily="34" charset="-122"/>
                 <a:cs typeface="Calibri" pitchFamily="34" charset="-120"/>
               </a:rPr>
-              <a:t>25 / 25</a:t>
+              <a:t>26 / 26</a:t>
             </a:r>
             <a:endParaRPr lang="en-US" sz="900" dirty="0"/>
           </a:p>
@@ -43368,7 +44351,7 @@
                 <a:ea typeface="Calibri" pitchFamily="34" charset="-122"/>
                 <a:cs typeface="Calibri" pitchFamily="34" charset="-120"/>
               </a:rPr>
-              <a:t>3 / 25</a:t>
+              <a:t>3 / 26</a:t>
             </a:r>
             <a:endParaRPr lang="en-US" sz="900" dirty="0"/>
           </a:p>
@@ -44593,7 +45576,7 @@
                 <a:ea typeface="Calibri" pitchFamily="34" charset="-122"/>
                 <a:cs typeface="Calibri" pitchFamily="34" charset="-120"/>
               </a:rPr>
-              <a:t>4 / 25</a:t>
+              <a:t>4 / 26</a:t>
             </a:r>
             <a:endParaRPr lang="en-US" sz="900" dirty="0"/>
           </a:p>
@@ -45998,7 +46981,7 @@
                 <a:ea typeface="Calibri" pitchFamily="34" charset="-122"/>
                 <a:cs typeface="Calibri" pitchFamily="34" charset="-120"/>
               </a:rPr>
-              <a:t>5 / 25</a:t>
+              <a:t>5 / 26</a:t>
             </a:r>
             <a:endParaRPr lang="en-US" sz="900" dirty="0"/>
           </a:p>
@@ -48980,7 +49963,7 @@
                 <a:ea typeface="Calibri" pitchFamily="34" charset="-122"/>
                 <a:cs typeface="Calibri" pitchFamily="34" charset="-120"/>
               </a:rPr>
-              <a:t>6 / 25</a:t>
+              <a:t>6 / 26</a:t>
             </a:r>
             <a:endParaRPr lang="en-US" sz="900" dirty="0"/>
           </a:p>
@@ -50587,7 +51570,7 @@
                 <a:ea typeface="Calibri" pitchFamily="34" charset="-122"/>
                 <a:cs typeface="Calibri" pitchFamily="34" charset="-120"/>
               </a:rPr>
-              <a:t>7 / 25</a:t>
+              <a:t>7 / 26</a:t>
             </a:r>
             <a:endParaRPr lang="en-US" sz="900" dirty="0"/>
           </a:p>
@@ -51930,7 +52913,7 @@
                 <a:ea typeface="Calibri" pitchFamily="34" charset="-122"/>
                 <a:cs typeface="Calibri" pitchFamily="34" charset="-120"/>
               </a:rPr>
-              <a:t>8 / 25</a:t>
+              <a:t>8 / 26</a:t>
             </a:r>
             <a:endParaRPr lang="en-US" sz="900" dirty="0"/>
           </a:p>
@@ -53035,7 +54018,7 @@
                 <a:ea typeface="Calibri" pitchFamily="34" charset="-122"/>
                 <a:cs typeface="Calibri" pitchFamily="34" charset="-120"/>
               </a:rPr>
-              <a:t>9 / 25</a:t>
+              <a:t>9 / 26</a:t>
             </a:r>
             <a:endParaRPr lang="en-US" sz="900" dirty="0"/>
           </a:p>

</xml_diff>